<commit_message>
Day 2: re-pull the claude.ai-built decks' data from Qlik and rebuild them in the Day 1 style
Closed RO (set identifier 1, selections ignored): customer pay m5.json, warranty +
internal wi.json, Jul-Sep CP ELR elr_q3.json, opcodes all.json. P&L: absorption
abs.json, service/parts net to gross ntgs/ntgp.json. Every pull reconciles store
rows to the group and matches the verified figures (CP ROs 279,300/279,756, CP ELR
$158.86/$162.42, labor GP 80.9/80.8, parts GP 39.4/40.7, opcodes 13.2/8.3/9.2/5.8,
absorption 76.0/78.1, net to gross 18.9/21.8 and 37.1/36.7).
Door rates and the work-type shares are recovered from the v1 slides' speaker
notes (raw inputs did not survive the move); Jul-Sep ELR in those notes matches
today's pull for all 33 stores. Gross, Opcodes and the metric blocks now open with
the Day 1 group chart.

Co-Authored-By: Claude Opus 5.5 <noreply@anthropic.com>
Claude-Session: https://claude.ai/code/session_01Xa4nFVxuQGXmHARGph9WhS
</commit_message>
<xml_diff>
--- a/day2-deck/decks/CP Hours & RO a Day - Review.pptx
+++ b/day2-deck/decks/CP Hours & RO a Day - Review.pptx
@@ -7336,20 +7336,6 @@
               <a:buNone/>
             </a:pPr>
             <a:r>
-              <a:rPr lang="en-US" sz="1400" spc="90" kern="0" dirty="0">
-                <a:solidFill>
-                  <a:srgbClr val="595959"/>
-                </a:solidFill>
-                <a:latin typeface="Inter" pitchFamily="34" charset="0"/>
-                <a:ea typeface="Inter" pitchFamily="34" charset="-122"/>
-                <a:cs typeface="Inter" pitchFamily="34" charset="-120"/>
-              </a:rPr>
-              <a:t>2026 VS 2025 YTD · </a:t>
-            </a:r>
-            <a:pPr indent="0" marL="0">
-              <a:buNone/>
-            </a:pPr>
-            <a:r>
               <a:rPr lang="en-US" sz="1400" b="1" spc="90" kern="0" dirty="0">
                 <a:solidFill>
                   <a:srgbClr val="0B2C4A"/>

</xml_diff>

<commit_message>
Line charts for totals; draft warranty audit slides lead section 06
- groupYoy: gross, CP ROs, CP hours sold and warranty ROs charted as lines (no bars)
- warranty-deck.mjs: What Gets Claims Debited, Keep the Claim Paid (from Jan 2026 GM slides 13-14, stores not named)
- Section 06 order: compliance, audit slides, warranty ELR, warranty ROs, internal ELR

Co-Authored-By: Claude Opus 5.5 <noreply@anthropic.com>
Claude-Session: https://claude.ai/code/session_01Xa4nFVxuQGXmHARGph9WhS
</commit_message>
<xml_diff>
--- a/day2-deck/decks/CP Hours & RO a Day - Review.pptx
+++ b/day2-deck/decks/CP Hours & RO a Day - Review.pptx
@@ -118,9 +118,7 @@
     <c:autoTitleDeleted val="1"/>
     <c:plotArea>
       <c:layout/>
-      <c:barChart>
-        <c:barDir val="col"/>
-        <c:grouping val="clustered"/>
+      <c:lineChart>
         <c:varyColors val="0"/>
         <c:ser>
           <c:idx val="0"/>
@@ -131,15 +129,22 @@
               <c:strCache>
                 <c:ptCount val="1"/>
                 <c:pt idx="0">
-                  <c:v>2025</c:v>
+                  <c:v>2026</c:v>
                 </c:pt>
               </c:strCache>
             </c:strRef>
           </c:tx>
           <c:spPr>
             <a:solidFill>
-              <a:srgbClr val="9AA3AD"/>
+              <a:srgbClr val="2587C5"/>
             </a:solidFill>
+            <a:ln w="38100" cap="flat">
+              <a:solidFill>
+                <a:srgbClr val="2587C5"/>
+              </a:solidFill>
+              <a:prstDash val="solid"/>
+              <a:round/>
+            </a:ln>
             <a:effectLst/>
           </c:spPr>
           <c:invertIfNegative val="0"/>
@@ -160,6 +165,289 @@
               </a:p>
             </c:txPr>
             <c:showLegendKey val="0"/>
+            <c:showVal val="0"/>
+            <c:showCatName val="0"/>
+            <c:showSerName val="0"/>
+            <c:showPercent val="0"/>
+            <c:showBubbleSize val="0"/>
+            <c:showLeaderLines val="0"/>
+          </c:dLbls>
+          <c:marker>
+            <c:symbol val="circle"/>
+            <c:size val="8"/>
+            <c:spPr>
+              <a:solidFill>
+                <a:srgbClr val="2587C5"/>
+              </a:solidFill>
+              <a:ln w="9525" cap="flat">
+                <a:solidFill>
+                  <a:srgbClr val="2587C5"/>
+                </a:solidFill>
+                <a:prstDash val="solid"/>
+                <a:round/>
+              </a:ln>
+              <a:effectLst/>
+            </c:spPr>
+          </c:marker>
+          <c:cat>
+            <c:multiLvlStrRef>
+              <c:f>Sheet1!$A$2:$A$10</c:f>
+              <c:multiLvlStrCache>
+                <c:ptCount val="9"/>
+                <c:lvl>
+                  <c:pt idx="0">
+                    <c:v>Jan</c:v>
+                  </c:pt>
+                  <c:pt idx="1">
+                    <c:v>Feb</c:v>
+                  </c:pt>
+                  <c:pt idx="2">
+                    <c:v>Mar</c:v>
+                  </c:pt>
+                  <c:pt idx="3">
+                    <c:v>Apr</c:v>
+                  </c:pt>
+                  <c:pt idx="4">
+                    <c:v>May</c:v>
+                  </c:pt>
+                  <c:pt idx="5">
+                    <c:v>Jun</c:v>
+                  </c:pt>
+                  <c:pt idx="6">
+                    <c:v>Jul</c:v>
+                  </c:pt>
+                  <c:pt idx="7">
+                    <c:v>Aug</c:v>
+                  </c:pt>
+                  <c:pt idx="8">
+                    <c:v>Sep</c:v>
+                  </c:pt>
+                </c:lvl>
+              </c:multiLvlStrCache>
+            </c:multiLvlStrRef>
+          </c:cat>
+          <c:val>
+            <c:numRef>
+              <c:f>Sheet1!$B$2:$B$10</c:f>
+              <c:numCache>
+                <c:formatCode>General</c:formatCode>
+                <c:ptCount val="9"/>
+                <c:pt idx="0">
+                  <c:v>55578.46</c:v>
+                </c:pt>
+                <c:pt idx="1">
+                  <c:v>52000.56</c:v>
+                </c:pt>
+                <c:pt idx="2">
+                  <c:v>60175.93</c:v>
+                </c:pt>
+                <c:pt idx="3">
+                  <c:v>59745.97</c:v>
+                </c:pt>
+                <c:pt idx="4">
+                  <c:v>57788.84</c:v>
+                </c:pt>
+                <c:pt idx="5">
+                  <c:v>60916.67</c:v>
+                </c:pt>
+                <c:pt idx="6">
+                  <c:v>61860.58</c:v>
+                </c:pt>
+                <c:pt idx="7">
+                  <c:v>59618.54</c:v>
+                </c:pt>
+                <c:pt idx="8">
+                  <c:v>55456.31</c:v>
+                </c:pt>
+              </c:numCache>
+            </c:numRef>
+          </c:val>
+          <c:smooth val="0"/>
+        </c:ser>
+        <c:dLbls>
+          <c:numFmt formatCode="#,##0.0,&quot;K&quot;" sourceLinked="0"/>
+          <c:txPr>
+            <a:bodyPr/>
+            <a:lstStyle/>
+            <a:p>
+              <a:pPr>
+                <a:defRPr b="0" i="0" strike="noStrike" sz="1400" u="none">
+                  <a:solidFill>
+                    <a:srgbClr val="1A1A1A"/>
+                  </a:solidFill>
+                  <a:latin typeface="+mn-lt"/>
+                </a:defRPr>
+              </a:pPr>
+            </a:p>
+          </c:txPr>
+          <c:showLegendKey val="0"/>
+          <c:showVal val="0"/>
+          <c:showCatName val="0"/>
+          <c:showSerName val="0"/>
+          <c:showPercent val="0"/>
+          <c:showBubbleSize val="0"/>
+          <c:showLeaderLines val="0"/>
+        </c:dLbls>
+        <c:marker val="1"/>
+        <c:axId val="2094734554"/>
+        <c:axId val="2094734552"/>
+        <c:axId val="2094734556"/>
+      </c:lineChart>
+      <c:catAx>
+        <c:axId val="2094734554"/>
+        <c:scaling>
+          <c:orientation val="minMax"/>
+        </c:scaling>
+        <c:delete val="0"/>
+        <c:axPos val="b"/>
+        <c:numFmt formatCode="General" sourceLinked="1"/>
+        <c:majorTickMark val="out"/>
+        <c:minorTickMark val="none"/>
+        <c:tickLblPos val="low"/>
+        <c:spPr>
+          <a:ln w="12700" cap="flat">
+            <a:noFill/>
+            <a:prstDash val="solid"/>
+            <a:round/>
+          </a:ln>
+        </c:spPr>
+        <c:txPr>
+          <a:bodyPr/>
+          <a:lstStyle/>
+          <a:p>
+            <a:pPr>
+              <a:defRPr sz="1400" b="0" i="0" u="none" strike="noStrike">
+                <a:solidFill>
+                  <a:srgbClr val="FFFFFF"/>
+                </a:solidFill>
+                <a:latin typeface="+mn-lt"/>
+              </a:defRPr>
+            </a:pPr>
+            <a:endParaRPr lang="en-US"/>
+          </a:p>
+        </c:txPr>
+        <c:crossAx val="2094734552"/>
+        <c:crosses val="min"/>
+        <c:auto val="1"/>
+        <c:lblAlgn val="ctr"/>
+        <c:noMultiLvlLbl val="1"/>
+      </c:catAx>
+      <c:valAx>
+        <c:axId val="2094734552"/>
+        <c:scaling>
+          <c:orientation val="minMax"/>
+          <c:max val="70000"/>
+          <c:min val="45000"/>
+        </c:scaling>
+        <c:delete val="0"/>
+        <c:axPos val="l"/>
+        <c:numFmt formatCode="#,##0" sourceLinked="0"/>
+        <c:majorTickMark val="out"/>
+        <c:minorTickMark val="none"/>
+        <c:tickLblPos val="nextTo"/>
+        <c:spPr>
+          <a:ln w="12700" cap="flat">
+            <a:noFill/>
+            <a:prstDash val="solid"/>
+            <a:round/>
+          </a:ln>
+        </c:spPr>
+        <c:txPr>
+          <a:bodyPr/>
+          <a:lstStyle/>
+          <a:p>
+            <a:pPr>
+              <a:defRPr sz="1400" b="0" i="0" u="none" strike="noStrike">
+                <a:solidFill>
+                  <a:srgbClr val="FFFFFF"/>
+                </a:solidFill>
+                <a:latin typeface="+mn-lt"/>
+              </a:defRPr>
+            </a:pPr>
+            <a:endParaRPr lang="en-US"/>
+          </a:p>
+        </c:txPr>
+        <c:crossAx val="2094734554"/>
+        <c:crosses val="autoZero"/>
+        <c:crossBetween val="between"/>
+        <c:majorUnit val="5000"/>
+      </c:valAx>
+      <c:spPr>
+        <a:noFill/>
+        <a:ln>
+          <a:noFill/>
+        </a:ln>
+        <a:effectLst/>
+      </c:spPr>
+    </c:plotArea>
+    <c:plotVisOnly val="1"/>
+    <c:dispBlanksAs val="span"/>
+  </c:chart>
+  <c:spPr>
+    <a:noFill/>
+    <a:ln>
+      <a:noFill/>
+    </a:ln>
+    <a:effectLst/>
+  </c:spPr>
+  <c:externalData r:id="rId1">
+    <c:autoUpdate val="0"/>
+  </c:externalData>
+</c:chartSpace>
+</file>
+
+<file path=ppt/charts/chart2.xml><?xml version="1.0" encoding="utf-8"?>
+<c:chartSpace xmlns:c="http://schemas.openxmlformats.org/drawingml/2006/chart" xmlns:a="http://schemas.openxmlformats.org/drawingml/2006/main" xmlns:r="http://schemas.openxmlformats.org/officeDocument/2006/relationships">
+  <c:date1904 val="0"/>
+  <c:roundedCorners val="1"/>
+  <c:chart>
+    <c:autoTitleDeleted val="1"/>
+    <c:plotArea>
+      <c:layout/>
+      <c:lineChart>
+        <c:varyColors val="0"/>
+        <c:ser>
+          <c:idx val="0"/>
+          <c:order val="0"/>
+          <c:tx>
+            <c:strRef>
+              <c:f>Sheet1!$B$1</c:f>
+              <c:strCache>
+                <c:ptCount val="1"/>
+                <c:pt idx="0">
+                  <c:v>2026</c:v>
+                </c:pt>
+              </c:strCache>
+            </c:strRef>
+          </c:tx>
+          <c:spPr>
+            <a:solidFill>
+              <a:srgbClr val="2587C5"/>
+            </a:solidFill>
+            <a:ln>
+              <a:noFill/>
+            </a:ln>
+            <a:effectLst/>
+          </c:spPr>
+          <c:invertIfNegative val="0"/>
+          <c:dLbls>
+            <c:numFmt formatCode="#,##0.0,&quot;K&quot;" sourceLinked="0"/>
+            <c:txPr>
+              <a:bodyPr/>
+              <a:lstStyle/>
+              <a:p>
+                <a:pPr>
+                  <a:defRPr b="0" i="0" strike="noStrike" sz="1400" u="none">
+                    <a:solidFill>
+                      <a:srgbClr val="1A1A1A"/>
+                    </a:solidFill>
+                    <a:latin typeface="+mn-lt"/>
+                  </a:defRPr>
+                </a:pPr>
+              </a:p>
+            </c:txPr>
+            <c:dLblPos val="t"/>
+            <c:showLegendKey val="0"/>
             <c:showVal val="1"/>
             <c:showCatName val="0"/>
             <c:showSerName val="0"/>
@@ -167,6 +455,1194 @@
             <c:showBubbleSize val="0"/>
             <c:showLeaderLines val="0"/>
           </c:dLbls>
+          <c:marker>
+            <c:symbol val="none"/>
+            <c:size val="8"/>
+            <c:spPr>
+              <a:solidFill>
+                <a:srgbClr val="2587C5"/>
+              </a:solidFill>
+              <a:ln w="9525" cap="flat">
+                <a:solidFill>
+                  <a:srgbClr val="2587C5"/>
+                </a:solidFill>
+                <a:prstDash val="solid"/>
+                <a:round/>
+              </a:ln>
+              <a:effectLst/>
+            </c:spPr>
+          </c:marker>
+          <c:cat>
+            <c:multiLvlStrRef>
+              <c:f>Sheet1!$A$2:$A$10</c:f>
+              <c:multiLvlStrCache>
+                <c:ptCount val="9"/>
+                <c:lvl>
+                  <c:pt idx="0">
+                    <c:v>Jan</c:v>
+                  </c:pt>
+                  <c:pt idx="1">
+                    <c:v>Feb</c:v>
+                  </c:pt>
+                  <c:pt idx="2">
+                    <c:v>Mar</c:v>
+                  </c:pt>
+                  <c:pt idx="3">
+                    <c:v>Apr</c:v>
+                  </c:pt>
+                  <c:pt idx="4">
+                    <c:v>May</c:v>
+                  </c:pt>
+                  <c:pt idx="5">
+                    <c:v>Jun</c:v>
+                  </c:pt>
+                  <c:pt idx="6">
+                    <c:v>Jul</c:v>
+                  </c:pt>
+                  <c:pt idx="7">
+                    <c:v>Aug</c:v>
+                  </c:pt>
+                  <c:pt idx="8">
+                    <c:v>Sep</c:v>
+                  </c:pt>
+                </c:lvl>
+              </c:multiLvlStrCache>
+            </c:multiLvlStrRef>
+          </c:cat>
+          <c:val>
+            <c:numRef>
+              <c:f>Sheet1!$B$2:$B$10</c:f>
+              <c:numCache>
+                <c:formatCode>General</c:formatCode>
+                <c:ptCount val="9"/>
+                <c:pt idx="0">
+                  <c:v>55578.46</c:v>
+                </c:pt>
+                <c:pt idx="1">
+                  <c:v>52000.56</c:v>
+                </c:pt>
+                <c:pt idx="2">
+                  <c:v>60175.93</c:v>
+                </c:pt>
+                <c:pt idx="3">
+                  <c:v>59745.97</c:v>
+                </c:pt>
+                <c:pt idx="4">
+                  <c:v/>
+                </c:pt>
+                <c:pt idx="5">
+                  <c:v>60916.67</c:v>
+                </c:pt>
+                <c:pt idx="6">
+                  <c:v>61860.58</c:v>
+                </c:pt>
+                <c:pt idx="7">
+                  <c:v>59618.54</c:v>
+                </c:pt>
+                <c:pt idx="8">
+                  <c:v>55456.31</c:v>
+                </c:pt>
+              </c:numCache>
+            </c:numRef>
+          </c:val>
+          <c:smooth val="0"/>
+        </c:ser>
+        <c:dLbls>
+          <c:numFmt formatCode="#,##0.0,&quot;K&quot;" sourceLinked="0"/>
+          <c:txPr>
+            <a:bodyPr/>
+            <a:lstStyle/>
+            <a:p>
+              <a:pPr>
+                <a:defRPr b="0" i="0" strike="noStrike" sz="1400" u="none">
+                  <a:solidFill>
+                    <a:srgbClr val="1A1A1A"/>
+                  </a:solidFill>
+                  <a:latin typeface="+mn-lt"/>
+                </a:defRPr>
+              </a:pPr>
+            </a:p>
+          </c:txPr>
+          <c:dLblPos val="t"/>
+          <c:showLegendKey val="0"/>
+          <c:showVal val="1"/>
+          <c:showCatName val="0"/>
+          <c:showSerName val="0"/>
+          <c:showPercent val="0"/>
+          <c:showBubbleSize val="0"/>
+          <c:showLeaderLines val="0"/>
+        </c:dLbls>
+        <c:marker val="1"/>
+        <c:axId val="2094734554"/>
+        <c:axId val="2094734552"/>
+        <c:axId val="2094734556"/>
+      </c:lineChart>
+      <c:catAx>
+        <c:axId val="2094734554"/>
+        <c:scaling>
+          <c:orientation val="minMax"/>
+        </c:scaling>
+        <c:delete val="0"/>
+        <c:axPos val="b"/>
+        <c:numFmt formatCode="General" sourceLinked="1"/>
+        <c:majorTickMark val="out"/>
+        <c:minorTickMark val="none"/>
+        <c:tickLblPos val="low"/>
+        <c:spPr>
+          <a:ln w="12700" cap="flat">
+            <a:noFill/>
+            <a:prstDash val="solid"/>
+            <a:round/>
+          </a:ln>
+        </c:spPr>
+        <c:txPr>
+          <a:bodyPr/>
+          <a:lstStyle/>
+          <a:p>
+            <a:pPr>
+              <a:defRPr sz="1400" b="0" i="0" u="none" strike="noStrike">
+                <a:solidFill>
+                  <a:srgbClr val="FFFFFF"/>
+                </a:solidFill>
+                <a:latin typeface="+mn-lt"/>
+              </a:defRPr>
+            </a:pPr>
+            <a:endParaRPr lang="en-US"/>
+          </a:p>
+        </c:txPr>
+        <c:crossAx val="2094734552"/>
+        <c:crosses val="min"/>
+        <c:auto val="1"/>
+        <c:lblAlgn val="ctr"/>
+        <c:noMultiLvlLbl val="1"/>
+      </c:catAx>
+      <c:valAx>
+        <c:axId val="2094734552"/>
+        <c:scaling>
+          <c:orientation val="minMax"/>
+          <c:max val="70000"/>
+          <c:min val="45000"/>
+        </c:scaling>
+        <c:delete val="0"/>
+        <c:axPos val="l"/>
+        <c:numFmt formatCode="#,##0" sourceLinked="0"/>
+        <c:majorTickMark val="out"/>
+        <c:minorTickMark val="none"/>
+        <c:tickLblPos val="nextTo"/>
+        <c:spPr>
+          <a:ln w="12700" cap="flat">
+            <a:noFill/>
+            <a:prstDash val="solid"/>
+            <a:round/>
+          </a:ln>
+        </c:spPr>
+        <c:txPr>
+          <a:bodyPr/>
+          <a:lstStyle/>
+          <a:p>
+            <a:pPr>
+              <a:defRPr sz="1400" b="0" i="0" u="none" strike="noStrike">
+                <a:solidFill>
+                  <a:srgbClr val="FFFFFF"/>
+                </a:solidFill>
+                <a:latin typeface="+mn-lt"/>
+              </a:defRPr>
+            </a:pPr>
+            <a:endParaRPr lang="en-US"/>
+          </a:p>
+        </c:txPr>
+        <c:crossAx val="2094734554"/>
+        <c:crosses val="autoZero"/>
+        <c:crossBetween val="between"/>
+        <c:majorUnit val="5000"/>
+      </c:valAx>
+      <c:spPr>
+        <a:solidFill>
+          <a:srgbClr val="FFFFFF">
+            <a:alpha val="0"/>
+          </a:srgbClr>
+        </a:solidFill>
+        <a:ln>
+          <a:noFill/>
+        </a:ln>
+        <a:effectLst/>
+      </c:spPr>
+    </c:plotArea>
+    <c:plotVisOnly val="1"/>
+    <c:dispBlanksAs val="span"/>
+  </c:chart>
+  <c:spPr>
+    <a:solidFill>
+      <a:srgbClr val="FFFFFF">
+        <a:alpha val="0"/>
+      </a:srgbClr>
+    </a:solidFill>
+    <a:ln>
+      <a:noFill/>
+    </a:ln>
+    <a:effectLst/>
+  </c:spPr>
+  <c:externalData r:id="rId1">
+    <c:autoUpdate val="0"/>
+  </c:externalData>
+</c:chartSpace>
+</file>
+
+<file path=ppt/charts/chart3.xml><?xml version="1.0" encoding="utf-8"?>
+<c:chartSpace xmlns:c="http://schemas.openxmlformats.org/drawingml/2006/chart" xmlns:a="http://schemas.openxmlformats.org/drawingml/2006/main" xmlns:r="http://schemas.openxmlformats.org/officeDocument/2006/relationships">
+  <c:date1904 val="0"/>
+  <c:roundedCorners val="1"/>
+  <c:chart>
+    <c:autoTitleDeleted val="1"/>
+    <c:plotArea>
+      <c:layout/>
+      <c:lineChart>
+        <c:varyColors val="0"/>
+        <c:ser>
+          <c:idx val="0"/>
+          <c:order val="0"/>
+          <c:tx>
+            <c:strRef>
+              <c:f>Sheet1!$B$1</c:f>
+              <c:strCache>
+                <c:ptCount val="1"/>
+                <c:pt idx="0">
+                  <c:v>2026</c:v>
+                </c:pt>
+              </c:strCache>
+            </c:strRef>
+          </c:tx>
+          <c:spPr>
+            <a:solidFill>
+              <a:srgbClr val="2587C5"/>
+            </a:solidFill>
+            <a:ln>
+              <a:noFill/>
+            </a:ln>
+            <a:effectLst/>
+          </c:spPr>
+          <c:invertIfNegative val="0"/>
+          <c:dLbls>
+            <c:numFmt formatCode="#,##0.0,&quot;K&quot;" sourceLinked="0"/>
+            <c:txPr>
+              <a:bodyPr/>
+              <a:lstStyle/>
+              <a:p>
+                <a:pPr>
+                  <a:defRPr b="0" i="0" strike="noStrike" sz="1400" u="none">
+                    <a:solidFill>
+                      <a:srgbClr val="1A1A1A"/>
+                    </a:solidFill>
+                    <a:latin typeface="+mn-lt"/>
+                  </a:defRPr>
+                </a:pPr>
+              </a:p>
+            </c:txPr>
+            <c:dLblPos val="b"/>
+            <c:showLegendKey val="0"/>
+            <c:showVal val="1"/>
+            <c:showCatName val="0"/>
+            <c:showSerName val="0"/>
+            <c:showPercent val="0"/>
+            <c:showBubbleSize val="0"/>
+            <c:showLeaderLines val="0"/>
+          </c:dLbls>
+          <c:marker>
+            <c:symbol val="none"/>
+            <c:size val="8"/>
+            <c:spPr>
+              <a:solidFill>
+                <a:srgbClr val="2587C5"/>
+              </a:solidFill>
+              <a:ln w="9525" cap="flat">
+                <a:solidFill>
+                  <a:srgbClr val="2587C5"/>
+                </a:solidFill>
+                <a:prstDash val="solid"/>
+                <a:round/>
+              </a:ln>
+              <a:effectLst/>
+            </c:spPr>
+          </c:marker>
+          <c:cat>
+            <c:multiLvlStrRef>
+              <c:f>Sheet1!$A$2:$A$10</c:f>
+              <c:multiLvlStrCache>
+                <c:ptCount val="9"/>
+                <c:lvl>
+                  <c:pt idx="0">
+                    <c:v>Jan</c:v>
+                  </c:pt>
+                  <c:pt idx="1">
+                    <c:v>Feb</c:v>
+                  </c:pt>
+                  <c:pt idx="2">
+                    <c:v>Mar</c:v>
+                  </c:pt>
+                  <c:pt idx="3">
+                    <c:v>Apr</c:v>
+                  </c:pt>
+                  <c:pt idx="4">
+                    <c:v>May</c:v>
+                  </c:pt>
+                  <c:pt idx="5">
+                    <c:v>Jun</c:v>
+                  </c:pt>
+                  <c:pt idx="6">
+                    <c:v>Jul</c:v>
+                  </c:pt>
+                  <c:pt idx="7">
+                    <c:v>Aug</c:v>
+                  </c:pt>
+                  <c:pt idx="8">
+                    <c:v>Sep</c:v>
+                  </c:pt>
+                </c:lvl>
+              </c:multiLvlStrCache>
+            </c:multiLvlStrRef>
+          </c:cat>
+          <c:val>
+            <c:numRef>
+              <c:f>Sheet1!$B$2:$B$10</c:f>
+              <c:numCache>
+                <c:formatCode>General</c:formatCode>
+                <c:ptCount val="9"/>
+                <c:pt idx="0">
+                  <c:v/>
+                </c:pt>
+                <c:pt idx="1">
+                  <c:v/>
+                </c:pt>
+                <c:pt idx="2">
+                  <c:v/>
+                </c:pt>
+                <c:pt idx="3">
+                  <c:v/>
+                </c:pt>
+                <c:pt idx="4">
+                  <c:v>57788.84</c:v>
+                </c:pt>
+                <c:pt idx="5">
+                  <c:v/>
+                </c:pt>
+                <c:pt idx="6">
+                  <c:v/>
+                </c:pt>
+                <c:pt idx="7">
+                  <c:v/>
+                </c:pt>
+                <c:pt idx="8">
+                  <c:v/>
+                </c:pt>
+              </c:numCache>
+            </c:numRef>
+          </c:val>
+          <c:smooth val="0"/>
+        </c:ser>
+        <c:dLbls>
+          <c:numFmt formatCode="#,##0.0,&quot;K&quot;" sourceLinked="0"/>
+          <c:txPr>
+            <a:bodyPr/>
+            <a:lstStyle/>
+            <a:p>
+              <a:pPr>
+                <a:defRPr b="0" i="0" strike="noStrike" sz="1400" u="none">
+                  <a:solidFill>
+                    <a:srgbClr val="1A1A1A"/>
+                  </a:solidFill>
+                  <a:latin typeface="+mn-lt"/>
+                </a:defRPr>
+              </a:pPr>
+            </a:p>
+          </c:txPr>
+          <c:dLblPos val="b"/>
+          <c:showLegendKey val="0"/>
+          <c:showVal val="1"/>
+          <c:showCatName val="0"/>
+          <c:showSerName val="0"/>
+          <c:showPercent val="0"/>
+          <c:showBubbleSize val="0"/>
+          <c:showLeaderLines val="0"/>
+        </c:dLbls>
+        <c:marker val="1"/>
+        <c:axId val="2094734554"/>
+        <c:axId val="2094734552"/>
+        <c:axId val="2094734556"/>
+      </c:lineChart>
+      <c:catAx>
+        <c:axId val="2094734554"/>
+        <c:scaling>
+          <c:orientation val="minMax"/>
+        </c:scaling>
+        <c:delete val="0"/>
+        <c:axPos val="b"/>
+        <c:numFmt formatCode="General" sourceLinked="1"/>
+        <c:majorTickMark val="out"/>
+        <c:minorTickMark val="none"/>
+        <c:tickLblPos val="low"/>
+        <c:spPr>
+          <a:ln w="12700" cap="flat">
+            <a:noFill/>
+            <a:prstDash val="solid"/>
+            <a:round/>
+          </a:ln>
+        </c:spPr>
+        <c:txPr>
+          <a:bodyPr/>
+          <a:lstStyle/>
+          <a:p>
+            <a:pPr>
+              <a:defRPr sz="1400" b="0" i="0" u="none" strike="noStrike">
+                <a:solidFill>
+                  <a:srgbClr val="FFFFFF"/>
+                </a:solidFill>
+                <a:latin typeface="+mn-lt"/>
+              </a:defRPr>
+            </a:pPr>
+            <a:endParaRPr lang="en-US"/>
+          </a:p>
+        </c:txPr>
+        <c:crossAx val="2094734552"/>
+        <c:crosses val="min"/>
+        <c:auto val="1"/>
+        <c:lblAlgn val="ctr"/>
+        <c:noMultiLvlLbl val="1"/>
+      </c:catAx>
+      <c:valAx>
+        <c:axId val="2094734552"/>
+        <c:scaling>
+          <c:orientation val="minMax"/>
+          <c:max val="70000"/>
+          <c:min val="45000"/>
+        </c:scaling>
+        <c:delete val="0"/>
+        <c:axPos val="l"/>
+        <c:numFmt formatCode="#,##0" sourceLinked="0"/>
+        <c:majorTickMark val="out"/>
+        <c:minorTickMark val="none"/>
+        <c:tickLblPos val="nextTo"/>
+        <c:spPr>
+          <a:ln w="12700" cap="flat">
+            <a:noFill/>
+            <a:prstDash val="solid"/>
+            <a:round/>
+          </a:ln>
+        </c:spPr>
+        <c:txPr>
+          <a:bodyPr/>
+          <a:lstStyle/>
+          <a:p>
+            <a:pPr>
+              <a:defRPr sz="1400" b="0" i="0" u="none" strike="noStrike">
+                <a:solidFill>
+                  <a:srgbClr val="FFFFFF"/>
+                </a:solidFill>
+                <a:latin typeface="+mn-lt"/>
+              </a:defRPr>
+            </a:pPr>
+            <a:endParaRPr lang="en-US"/>
+          </a:p>
+        </c:txPr>
+        <c:crossAx val="2094734554"/>
+        <c:crosses val="autoZero"/>
+        <c:crossBetween val="between"/>
+        <c:majorUnit val="5000"/>
+      </c:valAx>
+      <c:spPr>
+        <a:solidFill>
+          <a:srgbClr val="FFFFFF">
+            <a:alpha val="0"/>
+          </a:srgbClr>
+        </a:solidFill>
+        <a:ln>
+          <a:noFill/>
+        </a:ln>
+        <a:effectLst/>
+      </c:spPr>
+    </c:plotArea>
+    <c:plotVisOnly val="1"/>
+    <c:dispBlanksAs val="span"/>
+  </c:chart>
+  <c:spPr>
+    <a:solidFill>
+      <a:srgbClr val="FFFFFF">
+        <a:alpha val="0"/>
+      </a:srgbClr>
+    </a:solidFill>
+    <a:ln>
+      <a:noFill/>
+    </a:ln>
+    <a:effectLst/>
+  </c:spPr>
+  <c:externalData r:id="rId1">
+    <c:autoUpdate val="0"/>
+  </c:externalData>
+</c:chartSpace>
+</file>
+
+<file path=ppt/charts/chart4.xml><?xml version="1.0" encoding="utf-8"?>
+<c:chartSpace xmlns:c="http://schemas.openxmlformats.org/drawingml/2006/chart" xmlns:a="http://schemas.openxmlformats.org/drawingml/2006/main" xmlns:r="http://schemas.openxmlformats.org/officeDocument/2006/relationships">
+  <c:date1904 val="0"/>
+  <c:roundedCorners val="1"/>
+  <c:chart>
+    <c:autoTitleDeleted val="1"/>
+    <c:plotArea>
+      <c:layout/>
+      <c:lineChart>
+        <c:varyColors val="0"/>
+        <c:ser>
+          <c:idx val="0"/>
+          <c:order val="0"/>
+          <c:tx>
+            <c:strRef>
+              <c:f>Sheet1!$B$1</c:f>
+              <c:strCache>
+                <c:ptCount val="1"/>
+                <c:pt idx="0">
+                  <c:v>2025</c:v>
+                </c:pt>
+              </c:strCache>
+            </c:strRef>
+          </c:tx>
+          <c:spPr>
+            <a:solidFill>
+              <a:srgbClr val="9AA3AD"/>
+            </a:solidFill>
+            <a:ln>
+              <a:noFill/>
+            </a:ln>
+            <a:effectLst/>
+          </c:spPr>
+          <c:invertIfNegative val="0"/>
+          <c:dLbls>
+            <c:numFmt formatCode="#,##0.0,&quot;K&quot;" sourceLinked="0"/>
+            <c:txPr>
+              <a:bodyPr/>
+              <a:lstStyle/>
+              <a:p>
+                <a:pPr>
+                  <a:defRPr b="0" i="0" strike="noStrike" sz="1400" u="none">
+                    <a:solidFill>
+                      <a:srgbClr val="1A1A1A"/>
+                    </a:solidFill>
+                    <a:latin typeface="+mn-lt"/>
+                  </a:defRPr>
+                </a:pPr>
+              </a:p>
+            </c:txPr>
+            <c:dLblPos val="t"/>
+            <c:showLegendKey val="0"/>
+            <c:showVal val="1"/>
+            <c:showCatName val="0"/>
+            <c:showSerName val="0"/>
+            <c:showPercent val="0"/>
+            <c:showBubbleSize val="0"/>
+            <c:showLeaderLines val="0"/>
+          </c:dLbls>
+          <c:marker>
+            <c:symbol val="none"/>
+            <c:size val="8"/>
+            <c:spPr>
+              <a:solidFill>
+                <a:srgbClr val="9AA3AD"/>
+              </a:solidFill>
+              <a:ln w="9525" cap="flat">
+                <a:solidFill>
+                  <a:srgbClr val="9AA3AD"/>
+                </a:solidFill>
+                <a:prstDash val="solid"/>
+                <a:round/>
+              </a:ln>
+              <a:effectLst/>
+            </c:spPr>
+          </c:marker>
+          <c:cat>
+            <c:multiLvlStrRef>
+              <c:f>Sheet1!$A$2:$A$10</c:f>
+              <c:multiLvlStrCache>
+                <c:ptCount val="9"/>
+                <c:lvl>
+                  <c:pt idx="0">
+                    <c:v>Jan</c:v>
+                  </c:pt>
+                  <c:pt idx="1">
+                    <c:v>Feb</c:v>
+                  </c:pt>
+                  <c:pt idx="2">
+                    <c:v>Mar</c:v>
+                  </c:pt>
+                  <c:pt idx="3">
+                    <c:v>Apr</c:v>
+                  </c:pt>
+                  <c:pt idx="4">
+                    <c:v>May</c:v>
+                  </c:pt>
+                  <c:pt idx="5">
+                    <c:v>Jun</c:v>
+                  </c:pt>
+                  <c:pt idx="6">
+                    <c:v>Jul</c:v>
+                  </c:pt>
+                  <c:pt idx="7">
+                    <c:v>Aug</c:v>
+                  </c:pt>
+                  <c:pt idx="8">
+                    <c:v>Sep</c:v>
+                  </c:pt>
+                </c:lvl>
+              </c:multiLvlStrCache>
+            </c:multiLvlStrRef>
+          </c:cat>
+          <c:val>
+            <c:numRef>
+              <c:f>Sheet1!$B$2:$B$10</c:f>
+              <c:numCache>
+                <c:formatCode>General</c:formatCode>
+                <c:ptCount val="9"/>
+                <c:pt idx="0">
+                  <c:v/>
+                </c:pt>
+                <c:pt idx="1">
+                  <c:v/>
+                </c:pt>
+                <c:pt idx="2">
+                  <c:v/>
+                </c:pt>
+                <c:pt idx="3">
+                  <c:v/>
+                </c:pt>
+                <c:pt idx="4">
+                  <c:v>57794.35</c:v>
+                </c:pt>
+                <c:pt idx="5">
+                  <c:v/>
+                </c:pt>
+                <c:pt idx="6">
+                  <c:v/>
+                </c:pt>
+                <c:pt idx="7">
+                  <c:v/>
+                </c:pt>
+                <c:pt idx="8">
+                  <c:v/>
+                </c:pt>
+              </c:numCache>
+            </c:numRef>
+          </c:val>
+          <c:smooth val="0"/>
+        </c:ser>
+        <c:dLbls>
+          <c:numFmt formatCode="#,##0.0,&quot;K&quot;" sourceLinked="0"/>
+          <c:txPr>
+            <a:bodyPr/>
+            <a:lstStyle/>
+            <a:p>
+              <a:pPr>
+                <a:defRPr b="0" i="0" strike="noStrike" sz="1400" u="none">
+                  <a:solidFill>
+                    <a:srgbClr val="1A1A1A"/>
+                  </a:solidFill>
+                  <a:latin typeface="+mn-lt"/>
+                </a:defRPr>
+              </a:pPr>
+            </a:p>
+          </c:txPr>
+          <c:dLblPos val="t"/>
+          <c:showLegendKey val="0"/>
+          <c:showVal val="1"/>
+          <c:showCatName val="0"/>
+          <c:showSerName val="0"/>
+          <c:showPercent val="0"/>
+          <c:showBubbleSize val="0"/>
+          <c:showLeaderLines val="0"/>
+        </c:dLbls>
+        <c:marker val="1"/>
+        <c:axId val="2094734554"/>
+        <c:axId val="2094734552"/>
+        <c:axId val="2094734556"/>
+      </c:lineChart>
+      <c:catAx>
+        <c:axId val="2094734554"/>
+        <c:scaling>
+          <c:orientation val="minMax"/>
+        </c:scaling>
+        <c:delete val="0"/>
+        <c:axPos val="b"/>
+        <c:numFmt formatCode="General" sourceLinked="1"/>
+        <c:majorTickMark val="out"/>
+        <c:minorTickMark val="none"/>
+        <c:tickLblPos val="low"/>
+        <c:spPr>
+          <a:ln w="12700" cap="flat">
+            <a:noFill/>
+            <a:prstDash val="solid"/>
+            <a:round/>
+          </a:ln>
+        </c:spPr>
+        <c:txPr>
+          <a:bodyPr/>
+          <a:lstStyle/>
+          <a:p>
+            <a:pPr>
+              <a:defRPr sz="1400" b="0" i="0" u="none" strike="noStrike">
+                <a:solidFill>
+                  <a:srgbClr val="FFFFFF"/>
+                </a:solidFill>
+                <a:latin typeface="+mn-lt"/>
+              </a:defRPr>
+            </a:pPr>
+            <a:endParaRPr lang="en-US"/>
+          </a:p>
+        </c:txPr>
+        <c:crossAx val="2094734552"/>
+        <c:crosses val="min"/>
+        <c:auto val="1"/>
+        <c:lblAlgn val="ctr"/>
+        <c:noMultiLvlLbl val="1"/>
+      </c:catAx>
+      <c:valAx>
+        <c:axId val="2094734552"/>
+        <c:scaling>
+          <c:orientation val="minMax"/>
+          <c:max val="70000"/>
+          <c:min val="45000"/>
+        </c:scaling>
+        <c:delete val="0"/>
+        <c:axPos val="l"/>
+        <c:numFmt formatCode="#,##0" sourceLinked="0"/>
+        <c:majorTickMark val="out"/>
+        <c:minorTickMark val="none"/>
+        <c:tickLblPos val="nextTo"/>
+        <c:spPr>
+          <a:ln w="12700" cap="flat">
+            <a:noFill/>
+            <a:prstDash val="solid"/>
+            <a:round/>
+          </a:ln>
+        </c:spPr>
+        <c:txPr>
+          <a:bodyPr/>
+          <a:lstStyle/>
+          <a:p>
+            <a:pPr>
+              <a:defRPr sz="1400" b="0" i="0" u="none" strike="noStrike">
+                <a:solidFill>
+                  <a:srgbClr val="FFFFFF"/>
+                </a:solidFill>
+                <a:latin typeface="+mn-lt"/>
+              </a:defRPr>
+            </a:pPr>
+            <a:endParaRPr lang="en-US"/>
+          </a:p>
+        </c:txPr>
+        <c:crossAx val="2094734554"/>
+        <c:crosses val="autoZero"/>
+        <c:crossBetween val="between"/>
+        <c:majorUnit val="5000"/>
+      </c:valAx>
+      <c:spPr>
+        <a:solidFill>
+          <a:srgbClr val="FFFFFF">
+            <a:alpha val="0"/>
+          </a:srgbClr>
+        </a:solidFill>
+        <a:ln>
+          <a:noFill/>
+        </a:ln>
+        <a:effectLst/>
+      </c:spPr>
+    </c:plotArea>
+    <c:plotVisOnly val="1"/>
+    <c:dispBlanksAs val="span"/>
+  </c:chart>
+  <c:spPr>
+    <a:solidFill>
+      <a:srgbClr val="FFFFFF">
+        <a:alpha val="0"/>
+      </a:srgbClr>
+    </a:solidFill>
+    <a:ln>
+      <a:noFill/>
+    </a:ln>
+    <a:effectLst/>
+  </c:spPr>
+  <c:externalData r:id="rId1">
+    <c:autoUpdate val="0"/>
+  </c:externalData>
+</c:chartSpace>
+</file>
+
+<file path=ppt/charts/chart5.xml><?xml version="1.0" encoding="utf-8"?>
+<c:chartSpace xmlns:c="http://schemas.openxmlformats.org/drawingml/2006/chart" xmlns:a="http://schemas.openxmlformats.org/drawingml/2006/main" xmlns:r="http://schemas.openxmlformats.org/officeDocument/2006/relationships">
+  <c:date1904 val="0"/>
+  <c:roundedCorners val="1"/>
+  <c:chart>
+    <c:autoTitleDeleted val="1"/>
+    <c:plotArea>
+      <c:layout/>
+      <c:lineChart>
+        <c:varyColors val="0"/>
+        <c:ser>
+          <c:idx val="0"/>
+          <c:order val="0"/>
+          <c:tx>
+            <c:strRef>
+              <c:f>Sheet1!$B$1</c:f>
+              <c:strCache>
+                <c:ptCount val="1"/>
+                <c:pt idx="0">
+                  <c:v>2025</c:v>
+                </c:pt>
+              </c:strCache>
+            </c:strRef>
+          </c:tx>
+          <c:spPr>
+            <a:solidFill>
+              <a:srgbClr val="9AA3AD"/>
+            </a:solidFill>
+            <a:ln>
+              <a:noFill/>
+            </a:ln>
+            <a:effectLst/>
+          </c:spPr>
+          <c:invertIfNegative val="0"/>
+          <c:dLbls>
+            <c:numFmt formatCode="#,##0.0,&quot;K&quot;" sourceLinked="0"/>
+            <c:txPr>
+              <a:bodyPr/>
+              <a:lstStyle/>
+              <a:p>
+                <a:pPr>
+                  <a:defRPr b="0" i="0" strike="noStrike" sz="1400" u="none">
+                    <a:solidFill>
+                      <a:srgbClr val="1A1A1A"/>
+                    </a:solidFill>
+                    <a:latin typeface="+mn-lt"/>
+                  </a:defRPr>
+                </a:pPr>
+              </a:p>
+            </c:txPr>
+            <c:dLblPos val="b"/>
+            <c:showLegendKey val="0"/>
+            <c:showVal val="1"/>
+            <c:showCatName val="0"/>
+            <c:showSerName val="0"/>
+            <c:showPercent val="0"/>
+            <c:showBubbleSize val="0"/>
+            <c:showLeaderLines val="0"/>
+          </c:dLbls>
+          <c:marker>
+            <c:symbol val="none"/>
+            <c:size val="8"/>
+            <c:spPr>
+              <a:solidFill>
+                <a:srgbClr val="9AA3AD"/>
+              </a:solidFill>
+              <a:ln w="9525" cap="flat">
+                <a:solidFill>
+                  <a:srgbClr val="9AA3AD"/>
+                </a:solidFill>
+                <a:prstDash val="solid"/>
+                <a:round/>
+              </a:ln>
+              <a:effectLst/>
+            </c:spPr>
+          </c:marker>
+          <c:cat>
+            <c:multiLvlStrRef>
+              <c:f>Sheet1!$A$2:$A$10</c:f>
+              <c:multiLvlStrCache>
+                <c:ptCount val="9"/>
+                <c:lvl>
+                  <c:pt idx="0">
+                    <c:v>Jan</c:v>
+                  </c:pt>
+                  <c:pt idx="1">
+                    <c:v>Feb</c:v>
+                  </c:pt>
+                  <c:pt idx="2">
+                    <c:v>Mar</c:v>
+                  </c:pt>
+                  <c:pt idx="3">
+                    <c:v>Apr</c:v>
+                  </c:pt>
+                  <c:pt idx="4">
+                    <c:v>May</c:v>
+                  </c:pt>
+                  <c:pt idx="5">
+                    <c:v>Jun</c:v>
+                  </c:pt>
+                  <c:pt idx="6">
+                    <c:v>Jul</c:v>
+                  </c:pt>
+                  <c:pt idx="7">
+                    <c:v>Aug</c:v>
+                  </c:pt>
+                  <c:pt idx="8">
+                    <c:v>Sep</c:v>
+                  </c:pt>
+                </c:lvl>
+              </c:multiLvlStrCache>
+            </c:multiLvlStrRef>
+          </c:cat>
+          <c:val>
+            <c:numRef>
+              <c:f>Sheet1!$B$2:$B$10</c:f>
+              <c:numCache>
+                <c:formatCode>General</c:formatCode>
+                <c:ptCount val="9"/>
+                <c:pt idx="0">
+                  <c:v>55120.88</c:v>
+                </c:pt>
+                <c:pt idx="1">
+                  <c:v>51212.03</c:v>
+                </c:pt>
+                <c:pt idx="2">
+                  <c:v>57205.56</c:v>
+                </c:pt>
+                <c:pt idx="3">
+                  <c:v>58170.14</c:v>
+                </c:pt>
+                <c:pt idx="4">
+                  <c:v/>
+                </c:pt>
+                <c:pt idx="5">
+                  <c:v>56468.18</c:v>
+                </c:pt>
+                <c:pt idx="6">
+                  <c:v>57717.31</c:v>
+                </c:pt>
+                <c:pt idx="7">
+                  <c:v>57021.2</c:v>
+                </c:pt>
+                <c:pt idx="8">
+                  <c:v>53309.32</c:v>
+                </c:pt>
+              </c:numCache>
+            </c:numRef>
+          </c:val>
+          <c:smooth val="0"/>
+        </c:ser>
+        <c:dLbls>
+          <c:numFmt formatCode="#,##0.0,&quot;K&quot;" sourceLinked="0"/>
+          <c:txPr>
+            <a:bodyPr/>
+            <a:lstStyle/>
+            <a:p>
+              <a:pPr>
+                <a:defRPr b="0" i="0" strike="noStrike" sz="1400" u="none">
+                  <a:solidFill>
+                    <a:srgbClr val="1A1A1A"/>
+                  </a:solidFill>
+                  <a:latin typeface="+mn-lt"/>
+                </a:defRPr>
+              </a:pPr>
+            </a:p>
+          </c:txPr>
+          <c:dLblPos val="b"/>
+          <c:showLegendKey val="0"/>
+          <c:showVal val="1"/>
+          <c:showCatName val="0"/>
+          <c:showSerName val="0"/>
+          <c:showPercent val="0"/>
+          <c:showBubbleSize val="0"/>
+          <c:showLeaderLines val="0"/>
+        </c:dLbls>
+        <c:marker val="1"/>
+        <c:axId val="2094734554"/>
+        <c:axId val="2094734552"/>
+        <c:axId val="2094734556"/>
+      </c:lineChart>
+      <c:catAx>
+        <c:axId val="2094734554"/>
+        <c:scaling>
+          <c:orientation val="minMax"/>
+        </c:scaling>
+        <c:delete val="0"/>
+        <c:axPos val="b"/>
+        <c:numFmt formatCode="General" sourceLinked="1"/>
+        <c:majorTickMark val="out"/>
+        <c:minorTickMark val="none"/>
+        <c:tickLblPos val="low"/>
+        <c:spPr>
+          <a:ln w="12700" cap="flat">
+            <a:noFill/>
+            <a:prstDash val="solid"/>
+            <a:round/>
+          </a:ln>
+        </c:spPr>
+        <c:txPr>
+          <a:bodyPr/>
+          <a:lstStyle/>
+          <a:p>
+            <a:pPr>
+              <a:defRPr sz="1400" b="0" i="0" u="none" strike="noStrike">
+                <a:solidFill>
+                  <a:srgbClr val="FFFFFF"/>
+                </a:solidFill>
+                <a:latin typeface="+mn-lt"/>
+              </a:defRPr>
+            </a:pPr>
+            <a:endParaRPr lang="en-US"/>
+          </a:p>
+        </c:txPr>
+        <c:crossAx val="2094734552"/>
+        <c:crosses val="min"/>
+        <c:auto val="1"/>
+        <c:lblAlgn val="ctr"/>
+        <c:noMultiLvlLbl val="1"/>
+      </c:catAx>
+      <c:valAx>
+        <c:axId val="2094734552"/>
+        <c:scaling>
+          <c:orientation val="minMax"/>
+          <c:max val="70000"/>
+          <c:min val="45000"/>
+        </c:scaling>
+        <c:delete val="0"/>
+        <c:axPos val="l"/>
+        <c:numFmt formatCode="#,##0" sourceLinked="0"/>
+        <c:majorTickMark val="out"/>
+        <c:minorTickMark val="none"/>
+        <c:tickLblPos val="nextTo"/>
+        <c:spPr>
+          <a:ln w="12700" cap="flat">
+            <a:noFill/>
+            <a:prstDash val="solid"/>
+            <a:round/>
+          </a:ln>
+        </c:spPr>
+        <c:txPr>
+          <a:bodyPr/>
+          <a:lstStyle/>
+          <a:p>
+            <a:pPr>
+              <a:defRPr sz="1400" b="0" i="0" u="none" strike="noStrike">
+                <a:solidFill>
+                  <a:srgbClr val="FFFFFF"/>
+                </a:solidFill>
+                <a:latin typeface="+mn-lt"/>
+              </a:defRPr>
+            </a:pPr>
+            <a:endParaRPr lang="en-US"/>
+          </a:p>
+        </c:txPr>
+        <c:crossAx val="2094734554"/>
+        <c:crosses val="autoZero"/>
+        <c:crossBetween val="between"/>
+        <c:majorUnit val="5000"/>
+      </c:valAx>
+      <c:spPr>
+        <a:solidFill>
+          <a:srgbClr val="FFFFFF">
+            <a:alpha val="0"/>
+          </a:srgbClr>
+        </a:solidFill>
+        <a:ln>
+          <a:noFill/>
+        </a:ln>
+        <a:effectLst/>
+      </c:spPr>
+    </c:plotArea>
+    <c:plotVisOnly val="1"/>
+    <c:dispBlanksAs val="span"/>
+  </c:chart>
+  <c:spPr>
+    <a:solidFill>
+      <a:srgbClr val="FFFFFF">
+        <a:alpha val="0"/>
+      </a:srgbClr>
+    </a:solidFill>
+    <a:ln>
+      <a:noFill/>
+    </a:ln>
+    <a:effectLst/>
+  </c:spPr>
+  <c:externalData r:id="rId1">
+    <c:autoUpdate val="0"/>
+  </c:externalData>
+</c:chartSpace>
+</file>
+
+<file path=ppt/charts/chart6.xml><?xml version="1.0" encoding="utf-8"?>
+<c:chartSpace xmlns:c="http://schemas.openxmlformats.org/drawingml/2006/chart" xmlns:a="http://schemas.openxmlformats.org/drawingml/2006/main" xmlns:r="http://schemas.openxmlformats.org/officeDocument/2006/relationships">
+  <c:date1904 val="0"/>
+  <c:roundedCorners val="1"/>
+  <c:chart>
+    <c:autoTitleDeleted val="1"/>
+    <c:plotArea>
+      <c:layout/>
+      <c:lineChart>
+        <c:varyColors val="0"/>
+        <c:ser>
+          <c:idx val="0"/>
+          <c:order val="0"/>
+          <c:tx>
+            <c:strRef>
+              <c:f>Sheet1!$B$1</c:f>
+              <c:strCache>
+                <c:ptCount val="1"/>
+                <c:pt idx="0">
+                  <c:v>2025</c:v>
+                </c:pt>
+              </c:strCache>
+            </c:strRef>
+          </c:tx>
+          <c:spPr>
+            <a:solidFill>
+              <a:srgbClr val="9AA3AD"/>
+            </a:solidFill>
+            <a:ln w="38100" cap="flat">
+              <a:solidFill>
+                <a:srgbClr val="9AA3AD"/>
+              </a:solidFill>
+              <a:prstDash val="solid"/>
+              <a:round/>
+            </a:ln>
+            <a:effectLst/>
+          </c:spPr>
+          <c:invertIfNegative val="0"/>
+          <c:dLbls>
+            <c:numFmt formatCode="#,##0.0,&quot;K&quot;" sourceLinked="0"/>
+            <c:txPr>
+              <a:bodyPr/>
+              <a:lstStyle/>
+              <a:p>
+                <a:pPr>
+                  <a:defRPr b="0" i="0" strike="noStrike" sz="1400" u="none">
+                    <a:solidFill>
+                      <a:srgbClr val="1A1A1A"/>
+                    </a:solidFill>
+                    <a:latin typeface="+mn-lt"/>
+                  </a:defRPr>
+                </a:pPr>
+              </a:p>
+            </c:txPr>
+            <c:showLegendKey val="0"/>
+            <c:showVal val="0"/>
+            <c:showCatName val="0"/>
+            <c:showSerName val="0"/>
+            <c:showPercent val="0"/>
+            <c:showBubbleSize val="0"/>
+            <c:showLeaderLines val="0"/>
+          </c:dLbls>
+          <c:marker>
+            <c:symbol val="circle"/>
+            <c:size val="8"/>
+            <c:spPr>
+              <a:solidFill>
+                <a:srgbClr val="9AA3AD"/>
+              </a:solidFill>
+              <a:ln w="9525" cap="flat">
+                <a:solidFill>
+                  <a:srgbClr val="9AA3AD"/>
+                </a:solidFill>
+                <a:prstDash val="solid"/>
+                <a:round/>
+              </a:ln>
+              <a:effectLst/>
+            </c:spPr>
+          </c:marker>
           <c:cat>
             <c:multiLvlStrRef>
               <c:f>Sheet1!$A$2:$A$10</c:f>
@@ -240,125 +1716,7 @@
               </c:numCache>
             </c:numRef>
           </c:val>
-        </c:ser>
-        <c:ser>
-          <c:idx val="1"/>
-          <c:order val="1"/>
-          <c:tx>
-            <c:strRef>
-              <c:f>Sheet1!$C$1</c:f>
-              <c:strCache>
-                <c:ptCount val="1"/>
-                <c:pt idx="0">
-                  <c:v>2026</c:v>
-                </c:pt>
-              </c:strCache>
-            </c:strRef>
-          </c:tx>
-          <c:spPr>
-            <a:solidFill>
-              <a:srgbClr val="2587C5"/>
-            </a:solidFill>
-            <a:effectLst/>
-          </c:spPr>
-          <c:invertIfNegative val="0"/>
-          <c:dLbls>
-            <c:numFmt formatCode="#,##0.0,&quot;K&quot;" sourceLinked="0"/>
-            <c:txPr>
-              <a:bodyPr/>
-              <a:lstStyle/>
-              <a:p>
-                <a:pPr>
-                  <a:defRPr b="0" i="0" strike="noStrike" sz="1400" u="none">
-                    <a:solidFill>
-                      <a:srgbClr val="1A1A1A"/>
-                    </a:solidFill>
-                    <a:latin typeface="+mn-lt"/>
-                  </a:defRPr>
-                </a:pPr>
-              </a:p>
-            </c:txPr>
-            <c:showLegendKey val="0"/>
-            <c:showVal val="1"/>
-            <c:showCatName val="0"/>
-            <c:showSerName val="0"/>
-            <c:showPercent val="0"/>
-            <c:showBubbleSize val="0"/>
-            <c:showLeaderLines val="0"/>
-          </c:dLbls>
-          <c:cat>
-            <c:multiLvlStrRef>
-              <c:f>Sheet1!$A$2:$A$10</c:f>
-              <c:multiLvlStrCache>
-                <c:ptCount val="9"/>
-                <c:lvl>
-                  <c:pt idx="0">
-                    <c:v>Jan</c:v>
-                  </c:pt>
-                  <c:pt idx="1">
-                    <c:v>Feb</c:v>
-                  </c:pt>
-                  <c:pt idx="2">
-                    <c:v>Mar</c:v>
-                  </c:pt>
-                  <c:pt idx="3">
-                    <c:v>Apr</c:v>
-                  </c:pt>
-                  <c:pt idx="4">
-                    <c:v>May</c:v>
-                  </c:pt>
-                  <c:pt idx="5">
-                    <c:v>Jun</c:v>
-                  </c:pt>
-                  <c:pt idx="6">
-                    <c:v>Jul</c:v>
-                  </c:pt>
-                  <c:pt idx="7">
-                    <c:v>Aug</c:v>
-                  </c:pt>
-                  <c:pt idx="8">
-                    <c:v>Sep</c:v>
-                  </c:pt>
-                </c:lvl>
-              </c:multiLvlStrCache>
-            </c:multiLvlStrRef>
-          </c:cat>
-          <c:val>
-            <c:numRef>
-              <c:f>Sheet1!$C$2:$C$10</c:f>
-              <c:numCache>
-                <c:formatCode>General</c:formatCode>
-                <c:ptCount val="9"/>
-                <c:pt idx="0">
-                  <c:v>55578.46</c:v>
-                </c:pt>
-                <c:pt idx="1">
-                  <c:v>52000.56</c:v>
-                </c:pt>
-                <c:pt idx="2">
-                  <c:v>60175.93</c:v>
-                </c:pt>
-                <c:pt idx="3">
-                  <c:v>59745.97</c:v>
-                </c:pt>
-                <c:pt idx="4">
-                  <c:v>57788.84</c:v>
-                </c:pt>
-                <c:pt idx="5">
-                  <c:v>60916.67</c:v>
-                </c:pt>
-                <c:pt idx="6">
-                  <c:v>61860.58</c:v>
-                </c:pt>
-                <c:pt idx="7">
-                  <c:v>59618.54</c:v>
-                </c:pt>
-                <c:pt idx="8">
-                  <c:v>55456.31</c:v>
-                </c:pt>
-              </c:numCache>
-            </c:numRef>
-          </c:val>
+          <c:smooth val="0"/>
         </c:ser>
         <c:dLbls>
           <c:numFmt formatCode="#,##0.0,&quot;K&quot;" sourceLinked="0"/>
@@ -377,19 +1735,18 @@
             </a:p>
           </c:txPr>
           <c:showLegendKey val="0"/>
-          <c:showVal val="1"/>
+          <c:showVal val="0"/>
           <c:showCatName val="0"/>
           <c:showSerName val="0"/>
           <c:showPercent val="0"/>
           <c:showBubbleSize val="0"/>
           <c:showLeaderLines val="0"/>
         </c:dLbls>
-        <c:gapWidth val="35"/>
-        <c:overlap val="-35"/>
+        <c:marker val="1"/>
         <c:axId val="2094734554"/>
         <c:axId val="2094734552"/>
         <c:axId val="2094734556"/>
-      </c:barChart>
+      </c:lineChart>
       <c:catAx>
         <c:axId val="2094734554"/>
         <c:scaling>
@@ -435,8 +1792,8 @@
         <c:axId val="2094734552"/>
         <c:scaling>
           <c:orientation val="minMax"/>
-          <c:max val="80000"/>
-          <c:min val="0"/>
+          <c:max val="70000"/>
+          <c:min val="45000"/>
         </c:scaling>
         <c:delete val="0"/>
         <c:axPos val="l"/>
@@ -480,41 +1837,29 @@
         <c:crossAx val="2094734554"/>
         <c:crosses val="autoZero"/>
         <c:crossBetween val="between"/>
-        <c:majorUnit val="20000"/>
+        <c:majorUnit val="5000"/>
       </c:valAx>
       <c:spPr>
-        <a:noFill/>
+        <a:solidFill>
+          <a:srgbClr val="FFFFFF">
+            <a:alpha val="0"/>
+          </a:srgbClr>
+        </a:solidFill>
         <a:ln>
           <a:noFill/>
         </a:ln>
         <a:effectLst/>
       </c:spPr>
     </c:plotArea>
-    <c:legend>
-      <c:legendPos val="t"/>
-      <c:overlay val="0"/>
-      <c:txPr>
-        <a:bodyPr/>
-        <a:lstStyle/>
-        <a:p>
-          <a:pPr>
-            <a:defRPr sz="1400">
-              <a:solidFill>
-                <a:srgbClr val="1A1A1A"/>
-              </a:solidFill>
-              <a:latin typeface="+mn-lt"/>
-              <a:cs typeface="+mn-lt"/>
-            </a:defRPr>
-          </a:pPr>
-          <a:endParaRPr lang="en-US"/>
-        </a:p>
-      </c:txPr>
-    </c:legend>
     <c:plotVisOnly val="1"/>
     <c:dispBlanksAs val="span"/>
   </c:chart>
   <c:spPr>
-    <a:noFill/>
+    <a:solidFill>
+      <a:srgbClr val="FFFFFF">
+        <a:alpha val="0"/>
+      </a:srgbClr>
+    </a:solidFill>
     <a:ln>
       <a:noFill/>
     </a:ln>
@@ -2107,8 +3452,8 @@
           <p:nvPr/>
         </p:nvGraphicFramePr>
         <p:xfrm>
-          <a:off x="621792" y="2889504"/>
-          <a:ext cx="10945368" cy="3008376"/>
+          <a:off x="621792" y="3218688"/>
+          <a:ext cx="10945368" cy="2679192"/>
         </p:xfrm>
         <a:graphic xmlns:a="http://schemas.openxmlformats.org/drawingml/2006/main">
           <a:graphicData uri="http://schemas.openxmlformats.org/drawingml/2006/chart">
@@ -2116,9 +3461,247 @@
           </a:graphicData>
         </a:graphic>
       </p:graphicFrame>
-      <p:sp>
-        <p:nvSpPr>
-          <p:cNvPr id="18" name="Shape 15"/>
+      <p:graphicFrame>
+        <p:nvGraphicFramePr>
+          <p:cNvPr id="18" name="Chart 1" descr=""/>
+          <p:cNvGraphicFramePr/>
+          <p:nvPr/>
+        </p:nvGraphicFramePr>
+        <p:xfrm>
+          <a:off x="621792" y="3218688"/>
+          <a:ext cx="10945368" cy="2679192"/>
+        </p:xfrm>
+        <a:graphic xmlns:a="http://schemas.openxmlformats.org/drawingml/2006/main">
+          <a:graphicData uri="http://schemas.openxmlformats.org/drawingml/2006/chart">
+            <c:chart xmlns:c="http://schemas.openxmlformats.org/drawingml/2006/chart" r:id="rId2"/>
+          </a:graphicData>
+        </a:graphic>
+      </p:graphicFrame>
+      <p:graphicFrame>
+        <p:nvGraphicFramePr>
+          <p:cNvPr id="19" name="Chart 2" descr=""/>
+          <p:cNvGraphicFramePr/>
+          <p:nvPr/>
+        </p:nvGraphicFramePr>
+        <p:xfrm>
+          <a:off x="621792" y="3218688"/>
+          <a:ext cx="10945368" cy="2679192"/>
+        </p:xfrm>
+        <a:graphic xmlns:a="http://schemas.openxmlformats.org/drawingml/2006/main">
+          <a:graphicData uri="http://schemas.openxmlformats.org/drawingml/2006/chart">
+            <c:chart xmlns:c="http://schemas.openxmlformats.org/drawingml/2006/chart" r:id="rId3"/>
+          </a:graphicData>
+        </a:graphic>
+      </p:graphicFrame>
+      <p:graphicFrame>
+        <p:nvGraphicFramePr>
+          <p:cNvPr id="20" name="Chart 3" descr=""/>
+          <p:cNvGraphicFramePr/>
+          <p:nvPr/>
+        </p:nvGraphicFramePr>
+        <p:xfrm>
+          <a:off x="621792" y="3218688"/>
+          <a:ext cx="10945368" cy="2679192"/>
+        </p:xfrm>
+        <a:graphic xmlns:a="http://schemas.openxmlformats.org/drawingml/2006/main">
+          <a:graphicData uri="http://schemas.openxmlformats.org/drawingml/2006/chart">
+            <c:chart xmlns:c="http://schemas.openxmlformats.org/drawingml/2006/chart" r:id="rId4"/>
+          </a:graphicData>
+        </a:graphic>
+      </p:graphicFrame>
+      <p:graphicFrame>
+        <p:nvGraphicFramePr>
+          <p:cNvPr id="21" name="Chart 4" descr=""/>
+          <p:cNvGraphicFramePr/>
+          <p:nvPr/>
+        </p:nvGraphicFramePr>
+        <p:xfrm>
+          <a:off x="621792" y="3218688"/>
+          <a:ext cx="10945368" cy="2679192"/>
+        </p:xfrm>
+        <a:graphic xmlns:a="http://schemas.openxmlformats.org/drawingml/2006/main">
+          <a:graphicData uri="http://schemas.openxmlformats.org/drawingml/2006/chart">
+            <c:chart xmlns:c="http://schemas.openxmlformats.org/drawingml/2006/chart" r:id="rId5"/>
+          </a:graphicData>
+        </a:graphic>
+      </p:graphicFrame>
+      <p:graphicFrame>
+        <p:nvGraphicFramePr>
+          <p:cNvPr id="22" name="Chart 5" descr=""/>
+          <p:cNvGraphicFramePr/>
+          <p:nvPr/>
+        </p:nvGraphicFramePr>
+        <p:xfrm>
+          <a:off x="621792" y="3218688"/>
+          <a:ext cx="10945368" cy="2679192"/>
+        </p:xfrm>
+        <a:graphic xmlns:a="http://schemas.openxmlformats.org/drawingml/2006/main">
+          <a:graphicData uri="http://schemas.openxmlformats.org/drawingml/2006/chart">
+            <c:chart xmlns:c="http://schemas.openxmlformats.org/drawingml/2006/chart" r:id="rId6"/>
+          </a:graphicData>
+        </a:graphic>
+      </p:graphicFrame>
+      <p:sp>
+        <p:nvSpPr>
+          <p:cNvPr id="23" name="Shape 15"/>
+          <p:cNvSpPr/>
+          <p:nvPr/>
+        </p:nvSpPr>
+        <p:spPr>
+          <a:xfrm>
+            <a:off x="4951476" y="3049524"/>
+            <a:ext cx="310896" cy="45720"/>
+          </a:xfrm>
+          <a:prstGeom prst="rect">
+            <a:avLst/>
+          </a:prstGeom>
+          <a:solidFill>
+            <a:srgbClr val="9AA3AD"/>
+          </a:solidFill>
+          <a:ln/>
+        </p:spPr>
+      </p:sp>
+      <p:sp>
+        <p:nvSpPr>
+          <p:cNvPr id="24" name="Shape 16"/>
+          <p:cNvSpPr/>
+          <p:nvPr/>
+        </p:nvSpPr>
+        <p:spPr>
+          <a:xfrm>
+            <a:off x="5052060" y="3017520"/>
+            <a:ext cx="109728" cy="109728"/>
+          </a:xfrm>
+          <a:prstGeom prst="ellipse">
+            <a:avLst/>
+          </a:prstGeom>
+          <a:solidFill>
+            <a:srgbClr val="9AA3AD"/>
+          </a:solidFill>
+          <a:ln/>
+        </p:spPr>
+      </p:sp>
+      <p:sp>
+        <p:nvSpPr>
+          <p:cNvPr id="25" name="Text 17"/>
+          <p:cNvSpPr txBox="1"/>
+          <p:nvPr/>
+        </p:nvSpPr>
+        <p:spPr>
+          <a:xfrm>
+            <a:off x="5335524" y="2926080"/>
+            <a:ext cx="777240" cy="292608"/>
+          </a:xfrm>
+          <a:prstGeom prst="rect">
+            <a:avLst/>
+          </a:prstGeom>
+          <a:noFill/>
+          <a:ln/>
+        </p:spPr>
+        <p:txBody>
+          <a:bodyPr wrap="square" lIns="0" tIns="0" rIns="0" bIns="0" rtlCol="0" anchor="ctr"/>
+          <a:lstStyle/>
+          <a:p>
+            <a:pPr indent="0" marL="0">
+              <a:buNone/>
+            </a:pPr>
+            <a:r>
+              <a:rPr lang="en-US" sz="1400" dirty="0">
+                <a:solidFill>
+                  <a:srgbClr val="1A1A1A"/>
+                </a:solidFill>
+                <a:latin typeface="Inter" pitchFamily="34" charset="0"/>
+                <a:ea typeface="Inter" pitchFamily="34" charset="-122"/>
+                <a:cs typeface="Inter" pitchFamily="34" charset="-120"/>
+              </a:rPr>
+              <a:t>2025</a:t>
+            </a:r>
+            <a:endParaRPr lang="en-US" sz="1400" dirty="0"/>
+          </a:p>
+        </p:txBody>
+      </p:sp>
+      <p:sp>
+        <p:nvSpPr>
+          <p:cNvPr id="26" name="Shape 18"/>
+          <p:cNvSpPr/>
+          <p:nvPr/>
+        </p:nvSpPr>
+        <p:spPr>
+          <a:xfrm>
+            <a:off x="6185916" y="3049524"/>
+            <a:ext cx="310896" cy="45720"/>
+          </a:xfrm>
+          <a:prstGeom prst="rect">
+            <a:avLst/>
+          </a:prstGeom>
+          <a:solidFill>
+            <a:srgbClr val="2587C5"/>
+          </a:solidFill>
+          <a:ln/>
+        </p:spPr>
+      </p:sp>
+      <p:sp>
+        <p:nvSpPr>
+          <p:cNvPr id="27" name="Shape 19"/>
+          <p:cNvSpPr/>
+          <p:nvPr/>
+        </p:nvSpPr>
+        <p:spPr>
+          <a:xfrm>
+            <a:off x="6286500" y="3017520"/>
+            <a:ext cx="109728" cy="109728"/>
+          </a:xfrm>
+          <a:prstGeom prst="ellipse">
+            <a:avLst/>
+          </a:prstGeom>
+          <a:solidFill>
+            <a:srgbClr val="2587C5"/>
+          </a:solidFill>
+          <a:ln/>
+        </p:spPr>
+      </p:sp>
+      <p:sp>
+        <p:nvSpPr>
+          <p:cNvPr id="28" name="Text 20"/>
+          <p:cNvSpPr txBox="1"/>
+          <p:nvPr/>
+        </p:nvSpPr>
+        <p:spPr>
+          <a:xfrm>
+            <a:off x="6569964" y="2926080"/>
+            <a:ext cx="777240" cy="292608"/>
+          </a:xfrm>
+          <a:prstGeom prst="rect">
+            <a:avLst/>
+          </a:prstGeom>
+          <a:noFill/>
+          <a:ln/>
+        </p:spPr>
+        <p:txBody>
+          <a:bodyPr wrap="square" lIns="0" tIns="0" rIns="0" bIns="0" rtlCol="0" anchor="ctr"/>
+          <a:lstStyle/>
+          <a:p>
+            <a:pPr indent="0" marL="0">
+              <a:buNone/>
+            </a:pPr>
+            <a:r>
+              <a:rPr lang="en-US" sz="1400" dirty="0">
+                <a:solidFill>
+                  <a:srgbClr val="1A1A1A"/>
+                </a:solidFill>
+                <a:latin typeface="Inter" pitchFamily="34" charset="0"/>
+                <a:ea typeface="Inter" pitchFamily="34" charset="-122"/>
+                <a:cs typeface="Inter" pitchFamily="34" charset="-120"/>
+              </a:rPr>
+              <a:t>2026</a:t>
+            </a:r>
+            <a:endParaRPr lang="en-US" sz="1400" dirty="0"/>
+          </a:p>
+        </p:txBody>
+      </p:sp>
+      <p:sp>
+        <p:nvSpPr>
+          <p:cNvPr id="29" name="Shape 21"/>
           <p:cNvSpPr/>
           <p:nvPr/>
         </p:nvSpPr>
@@ -2138,7 +3721,7 @@
       </p:sp>
       <p:sp>
         <p:nvSpPr>
-          <p:cNvPr id="19" name="Text 16"/>
+          <p:cNvPr id="30" name="Text 22"/>
           <p:cNvSpPr txBox="1"/>
           <p:nvPr/>
         </p:nvSpPr>

</xml_diff>

<commit_message>
2025 through December on every YOY chart; Warranty Parts GP % slide
- Qlik pull (Oct 22): 2025 Oct-Dec group months for CP, warranty, internal, opcodes,
  CP&W ROs and P&L lines; Jan/Sep re-pulled alongside and match the existing files
- Each data file carries the months as q4 (chart only; YTD and rankers stay Jan-Sep)
- Gross charts back to 2025 Jan-Dec
- New Warranty Parts Gross Profit % chart after Warranty ELR (42.6% -> 44.7%)

Co-Authored-By: Claude Opus 5.5 <noreply@anthropic.com>
Claude-Session: https://claude.ai/code/session_01Xa4nFVxuQGXmHARGph9WhS
</commit_message>
<xml_diff>
--- a/day2-deck/decks/CP Hours & RO a Day - Review.pptx
+++ b/day2-deck/decks/CP Hours & RO a Day - Review.pptx
@@ -191,9 +191,9 @@
           </c:marker>
           <c:cat>
             <c:multiLvlStrRef>
-              <c:f>Sheet1!$A$2:$A$10</c:f>
+              <c:f>Sheet1!$A$2:$A$13</c:f>
               <c:multiLvlStrCache>
-                <c:ptCount val="9"/>
+                <c:ptCount val="12"/>
                 <c:lvl>
                   <c:pt idx="0">
                     <c:v>Jan</c:v>
@@ -222,16 +222,25 @@
                   <c:pt idx="8">
                     <c:v>Sep</c:v>
                   </c:pt>
+                  <c:pt idx="9">
+                    <c:v>Oct</c:v>
+                  </c:pt>
+                  <c:pt idx="10">
+                    <c:v>Nov</c:v>
+                  </c:pt>
+                  <c:pt idx="11">
+                    <c:v>Dec</c:v>
+                  </c:pt>
                 </c:lvl>
               </c:multiLvlStrCache>
             </c:multiLvlStrRef>
           </c:cat>
           <c:val>
             <c:numRef>
-              <c:f>Sheet1!$B$2:$B$10</c:f>
+              <c:f>Sheet1!$B$2:$B$13</c:f>
               <c:numCache>
                 <c:formatCode>General</c:formatCode>
-                <c:ptCount val="9"/>
+                <c:ptCount val="12"/>
                 <c:pt idx="0">
                   <c:v>55578.46</c:v>
                 </c:pt>
@@ -258,6 +267,15 @@
                 </c:pt>
                 <c:pt idx="8">
                   <c:v>55456.31</c:v>
+                </c:pt>
+                <c:pt idx="9">
+                  <c:v/>
+                </c:pt>
+                <c:pt idx="10">
+                  <c:v/>
+                </c:pt>
+                <c:pt idx="11">
+                  <c:v/>
                 </c:pt>
               </c:numCache>
             </c:numRef>
@@ -474,9 +492,9 @@
           </c:marker>
           <c:cat>
             <c:multiLvlStrRef>
-              <c:f>Sheet1!$A$2:$A$10</c:f>
+              <c:f>Sheet1!$A$2:$A$13</c:f>
               <c:multiLvlStrCache>
-                <c:ptCount val="9"/>
+                <c:ptCount val="12"/>
                 <c:lvl>
                   <c:pt idx="0">
                     <c:v>Jan</c:v>
@@ -505,16 +523,25 @@
                   <c:pt idx="8">
                     <c:v>Sep</c:v>
                   </c:pt>
+                  <c:pt idx="9">
+                    <c:v>Oct</c:v>
+                  </c:pt>
+                  <c:pt idx="10">
+                    <c:v>Nov</c:v>
+                  </c:pt>
+                  <c:pt idx="11">
+                    <c:v>Dec</c:v>
+                  </c:pt>
                 </c:lvl>
               </c:multiLvlStrCache>
             </c:multiLvlStrRef>
           </c:cat>
           <c:val>
             <c:numRef>
-              <c:f>Sheet1!$B$2:$B$10</c:f>
+              <c:f>Sheet1!$B$2:$B$13</c:f>
               <c:numCache>
                 <c:formatCode>General</c:formatCode>
-                <c:ptCount val="9"/>
+                <c:ptCount val="12"/>
                 <c:pt idx="0">
                   <c:v>55578.46</c:v>
                 </c:pt>
@@ -541,6 +568,15 @@
                 </c:pt>
                 <c:pt idx="8">
                   <c:v>55456.31</c:v>
+                </c:pt>
+                <c:pt idx="9">
+                  <c:v/>
+                </c:pt>
+                <c:pt idx="10">
+                  <c:v/>
+                </c:pt>
+                <c:pt idx="11">
+                  <c:v/>
                 </c:pt>
               </c:numCache>
             </c:numRef>
@@ -766,9 +802,9 @@
           </c:marker>
           <c:cat>
             <c:multiLvlStrRef>
-              <c:f>Sheet1!$A$2:$A$10</c:f>
+              <c:f>Sheet1!$A$2:$A$13</c:f>
               <c:multiLvlStrCache>
-                <c:ptCount val="9"/>
+                <c:ptCount val="12"/>
                 <c:lvl>
                   <c:pt idx="0">
                     <c:v>Jan</c:v>
@@ -797,16 +833,25 @@
                   <c:pt idx="8">
                     <c:v>Sep</c:v>
                   </c:pt>
+                  <c:pt idx="9">
+                    <c:v>Oct</c:v>
+                  </c:pt>
+                  <c:pt idx="10">
+                    <c:v>Nov</c:v>
+                  </c:pt>
+                  <c:pt idx="11">
+                    <c:v>Dec</c:v>
+                  </c:pt>
                 </c:lvl>
               </c:multiLvlStrCache>
             </c:multiLvlStrRef>
           </c:cat>
           <c:val>
             <c:numRef>
-              <c:f>Sheet1!$B$2:$B$10</c:f>
+              <c:f>Sheet1!$B$2:$B$13</c:f>
               <c:numCache>
                 <c:formatCode>General</c:formatCode>
-                <c:ptCount val="9"/>
+                <c:ptCount val="12"/>
                 <c:pt idx="0">
                   <c:v/>
                 </c:pt>
@@ -832,6 +877,15 @@
                   <c:v/>
                 </c:pt>
                 <c:pt idx="8">
+                  <c:v/>
+                </c:pt>
+                <c:pt idx="9">
+                  <c:v/>
+                </c:pt>
+                <c:pt idx="10">
+                  <c:v/>
+                </c:pt>
+                <c:pt idx="11">
                   <c:v/>
                 </c:pt>
               </c:numCache>
@@ -1058,9 +1112,9 @@
           </c:marker>
           <c:cat>
             <c:multiLvlStrRef>
-              <c:f>Sheet1!$A$2:$A$10</c:f>
+              <c:f>Sheet1!$A$2:$A$13</c:f>
               <c:multiLvlStrCache>
-                <c:ptCount val="9"/>
+                <c:ptCount val="12"/>
                 <c:lvl>
                   <c:pt idx="0">
                     <c:v>Jan</c:v>
@@ -1089,16 +1143,25 @@
                   <c:pt idx="8">
                     <c:v>Sep</c:v>
                   </c:pt>
+                  <c:pt idx="9">
+                    <c:v>Oct</c:v>
+                  </c:pt>
+                  <c:pt idx="10">
+                    <c:v>Nov</c:v>
+                  </c:pt>
+                  <c:pt idx="11">
+                    <c:v>Dec</c:v>
+                  </c:pt>
                 </c:lvl>
               </c:multiLvlStrCache>
             </c:multiLvlStrRef>
           </c:cat>
           <c:val>
             <c:numRef>
-              <c:f>Sheet1!$B$2:$B$10</c:f>
+              <c:f>Sheet1!$B$2:$B$13</c:f>
               <c:numCache>
                 <c:formatCode>General</c:formatCode>
-                <c:ptCount val="9"/>
+                <c:ptCount val="12"/>
                 <c:pt idx="0">
                   <c:v/>
                 </c:pt>
@@ -1124,6 +1187,15 @@
                   <c:v/>
                 </c:pt>
                 <c:pt idx="8">
+                  <c:v/>
+                </c:pt>
+                <c:pt idx="9">
+                  <c:v/>
+                </c:pt>
+                <c:pt idx="10">
+                  <c:v/>
+                </c:pt>
+                <c:pt idx="11">
                   <c:v/>
                 </c:pt>
               </c:numCache>
@@ -1350,9 +1422,9 @@
           </c:marker>
           <c:cat>
             <c:multiLvlStrRef>
-              <c:f>Sheet1!$A$2:$A$10</c:f>
+              <c:f>Sheet1!$A$2:$A$13</c:f>
               <c:multiLvlStrCache>
-                <c:ptCount val="9"/>
+                <c:ptCount val="12"/>
                 <c:lvl>
                   <c:pt idx="0">
                     <c:v>Jan</c:v>
@@ -1381,16 +1453,25 @@
                   <c:pt idx="8">
                     <c:v>Sep</c:v>
                   </c:pt>
+                  <c:pt idx="9">
+                    <c:v>Oct</c:v>
+                  </c:pt>
+                  <c:pt idx="10">
+                    <c:v>Nov</c:v>
+                  </c:pt>
+                  <c:pt idx="11">
+                    <c:v>Dec</c:v>
+                  </c:pt>
                 </c:lvl>
               </c:multiLvlStrCache>
             </c:multiLvlStrRef>
           </c:cat>
           <c:val>
             <c:numRef>
-              <c:f>Sheet1!$B$2:$B$10</c:f>
+              <c:f>Sheet1!$B$2:$B$13</c:f>
               <c:numCache>
                 <c:formatCode>General</c:formatCode>
-                <c:ptCount val="9"/>
+                <c:ptCount val="12"/>
                 <c:pt idx="0">
                   <c:v>55120.88</c:v>
                 </c:pt>
@@ -1417,6 +1498,15 @@
                 </c:pt>
                 <c:pt idx="8">
                   <c:v>53309.32</c:v>
+                </c:pt>
+                <c:pt idx="9">
+                  <c:v>58023.59000000028</c:v>
+                </c:pt>
+                <c:pt idx="10">
+                  <c:v>51202.50000000025</c:v>
+                </c:pt>
+                <c:pt idx="11">
+                  <c:v>52701.39000000027</c:v>
                 </c:pt>
               </c:numCache>
             </c:numRef>
@@ -1645,9 +1735,9 @@
           </c:marker>
           <c:cat>
             <c:multiLvlStrRef>
-              <c:f>Sheet1!$A$2:$A$10</c:f>
+              <c:f>Sheet1!$A$2:$A$13</c:f>
               <c:multiLvlStrCache>
-                <c:ptCount val="9"/>
+                <c:ptCount val="12"/>
                 <c:lvl>
                   <c:pt idx="0">
                     <c:v>Jan</c:v>
@@ -1676,16 +1766,25 @@
                   <c:pt idx="8">
                     <c:v>Sep</c:v>
                   </c:pt>
+                  <c:pt idx="9">
+                    <c:v>Oct</c:v>
+                  </c:pt>
+                  <c:pt idx="10">
+                    <c:v>Nov</c:v>
+                  </c:pt>
+                  <c:pt idx="11">
+                    <c:v>Dec</c:v>
+                  </c:pt>
                 </c:lvl>
               </c:multiLvlStrCache>
             </c:multiLvlStrRef>
           </c:cat>
           <c:val>
             <c:numRef>
-              <c:f>Sheet1!$B$2:$B$10</c:f>
+              <c:f>Sheet1!$B$2:$B$13</c:f>
               <c:numCache>
                 <c:formatCode>General</c:formatCode>
-                <c:ptCount val="9"/>
+                <c:ptCount val="12"/>
                 <c:pt idx="0">
                   <c:v>55120.88</c:v>
                 </c:pt>
@@ -1712,6 +1811,15 @@
                 </c:pt>
                 <c:pt idx="8">
                   <c:v>53309.32</c:v>
+                </c:pt>
+                <c:pt idx="9">
+                  <c:v>58023.59000000028</c:v>
+                </c:pt>
+                <c:pt idx="10">
+                  <c:v>51202.50000000025</c:v>
+                </c:pt>
+                <c:pt idx="11">
+                  <c:v>52701.39000000027</c:v>
                 </c:pt>
               </c:numCache>
             </c:numRef>
@@ -2266,7 +2374,7 @@
           <a:p>
             <a:r>
               <a:rPr lang="en-US" dirty="0"/>
-              <a:t>Source: Qlik - Closed Repair Orders. Customer pay, Jan-Sep by close date. Same-store, INEOS excluded (opened 2026). GMC Prescott body shop labor types excluded. Total customer-pay labor hours sold, all CP ROs. YTD from YTD totals, not the mean of months. Store rows reconcile to the group on every input, both years.</a:t>
+              <a:t>Source: Qlik - Closed Repair Orders. Customer pay, Jan-Sep by close date. Same-store, INEOS excluded (opened 2026). GMC Prescott body shop labor types excluded. Total customer-pay labor hours sold, all CP ROs. YTD from YTD totals, not the mean of months. Store rows reconcile to the group on every input, both years. 2025 shown January-December; October-December pulled Oct 22 on the same basis (chart only).</a:t>
             </a:r>
             <a:endParaRPr lang="en-US" dirty="0"/>
           </a:p>

</xml_diff>

<commit_message>
One More CP RO a Day and the Missed Opportunity slides in $K; amounts under $1K stay exact
Co-Authored-By: Claude Opus 5.5 <noreply@anthropic.com>
Claude-Session: https://claude.ai/code/session_01Xa4nFVxuQGXmHARGph9WhS
</commit_message>
<xml_diff>
--- a/day2-deck/decks/CP Hours & RO a Day - Review.pptx
+++ b/day2-deck/decks/CP Hours & RO a Day - Review.pptx
@@ -13878,8 +13878,8 @@
         </p:nvSpPr>
         <p:spPr>
           <a:xfrm>
-            <a:off x="3456432" y="1316736"/>
-            <a:ext cx="896112" cy="329184"/>
+            <a:off x="3529584" y="1316736"/>
+            <a:ext cx="822960" cy="329184"/>
           </a:xfrm>
           <a:prstGeom prst="rect">
             <a:avLst/>
@@ -13995,8 +13995,8 @@
         </p:nvSpPr>
         <p:spPr>
           <a:xfrm>
-            <a:off x="9006840" y="1316736"/>
-            <a:ext cx="896112" cy="329184"/>
+            <a:off x="9079992" y="1316736"/>
+            <a:ext cx="822960" cy="329184"/>
           </a:xfrm>
           <a:prstGeom prst="rect">
             <a:avLst/>
@@ -14152,7 +14152,7 @@
         <p:spPr>
           <a:xfrm>
             <a:off x="2670048" y="1756697"/>
-            <a:ext cx="731520" cy="136676"/>
+            <a:ext cx="804672" cy="136676"/>
           </a:xfrm>
           <a:prstGeom prst="rect">
             <a:avLst/>
@@ -14171,8 +14171,8 @@
         </p:nvSpPr>
         <p:spPr>
           <a:xfrm>
-            <a:off x="3456432" y="1700784"/>
-            <a:ext cx="896112" cy="248502"/>
+            <a:off x="3529584" y="1700784"/>
+            <a:ext cx="822960" cy="248502"/>
           </a:xfrm>
           <a:prstGeom prst="rect">
             <a:avLst/>
@@ -14196,7 +14196,7 @@
                 <a:ea typeface="Inter" pitchFamily="34" charset="-122"/>
                 <a:cs typeface="Inter" pitchFamily="34" charset="-120"/>
               </a:rPr>
-              <a:t>$358,484</a:t>
+              <a:t>$358K</a:t>
             </a:r>
             <a:endParaRPr lang="en-US" sz="1300" dirty="0"/>
           </a:p>
@@ -14328,7 +14328,7 @@
         <p:spPr>
           <a:xfrm>
             <a:off x="2670048" y="2005199"/>
-            <a:ext cx="715403" cy="136676"/>
+            <a:ext cx="786943" cy="136676"/>
           </a:xfrm>
           <a:prstGeom prst="rect">
             <a:avLst/>
@@ -14347,8 +14347,8 @@
         </p:nvSpPr>
         <p:spPr>
           <a:xfrm>
-            <a:off x="3456432" y="1949286"/>
-            <a:ext cx="896112" cy="248502"/>
+            <a:off x="3529584" y="1949286"/>
+            <a:ext cx="822960" cy="248502"/>
           </a:xfrm>
           <a:prstGeom prst="rect">
             <a:avLst/>
@@ -14372,7 +14372,7 @@
                 <a:ea typeface="Inter" pitchFamily="34" charset="-122"/>
                 <a:cs typeface="Inter" pitchFamily="34" charset="-120"/>
               </a:rPr>
-              <a:t>$350,585</a:t>
+              <a:t>$351K</a:t>
             </a:r>
             <a:endParaRPr lang="en-US" sz="1300" dirty="0"/>
           </a:p>
@@ -14504,7 +14504,7 @@
         <p:spPr>
           <a:xfrm>
             <a:off x="2670048" y="2253700"/>
-            <a:ext cx="659351" cy="136676"/>
+            <a:ext cx="725286" cy="136676"/>
           </a:xfrm>
           <a:prstGeom prst="rect">
             <a:avLst/>
@@ -14523,8 +14523,8 @@
         </p:nvSpPr>
         <p:spPr>
           <a:xfrm>
-            <a:off x="3456432" y="2197787"/>
-            <a:ext cx="896112" cy="248502"/>
+            <a:off x="3529584" y="2197787"/>
+            <a:ext cx="822960" cy="248502"/>
           </a:xfrm>
           <a:prstGeom prst="rect">
             <a:avLst/>
@@ -14548,7 +14548,7 @@
                 <a:ea typeface="Inter" pitchFamily="34" charset="-122"/>
                 <a:cs typeface="Inter" pitchFamily="34" charset="-120"/>
               </a:rPr>
-              <a:t>$323,117</a:t>
+              <a:t>$323K</a:t>
             </a:r>
             <a:endParaRPr lang="en-US" sz="1300" dirty="0"/>
           </a:p>
@@ -14680,7 +14680,7 @@
         <p:spPr>
           <a:xfrm>
             <a:off x="2670048" y="2502202"/>
-            <a:ext cx="645107" cy="136676"/>
+            <a:ext cx="709617" cy="136676"/>
           </a:xfrm>
           <a:prstGeom prst="rect">
             <a:avLst/>
@@ -14699,8 +14699,8 @@
         </p:nvSpPr>
         <p:spPr>
           <a:xfrm>
-            <a:off x="3456432" y="2446289"/>
-            <a:ext cx="896112" cy="248502"/>
+            <a:off x="3529584" y="2446289"/>
+            <a:ext cx="822960" cy="248502"/>
           </a:xfrm>
           <a:prstGeom prst="rect">
             <a:avLst/>
@@ -14724,7 +14724,7 @@
                 <a:ea typeface="Inter" pitchFamily="34" charset="-122"/>
                 <a:cs typeface="Inter" pitchFamily="34" charset="-120"/>
               </a:rPr>
-              <a:t>$316,136</a:t>
+              <a:t>$316K</a:t>
             </a:r>
             <a:endParaRPr lang="en-US" sz="1300" dirty="0"/>
           </a:p>
@@ -14856,7 +14856,7 @@
         <p:spPr>
           <a:xfrm>
             <a:off x="2670048" y="2750703"/>
-            <a:ext cx="463821" cy="136676"/>
+            <a:ext cx="510203" cy="136676"/>
           </a:xfrm>
           <a:prstGeom prst="rect">
             <a:avLst/>
@@ -14875,8 +14875,8 @@
         </p:nvSpPr>
         <p:spPr>
           <a:xfrm>
-            <a:off x="3456432" y="2694791"/>
-            <a:ext cx="896112" cy="248502"/>
+            <a:off x="3529584" y="2694791"/>
+            <a:ext cx="822960" cy="248502"/>
           </a:xfrm>
           <a:prstGeom prst="rect">
             <a:avLst/>
@@ -14900,7 +14900,7 @@
                 <a:ea typeface="Inter" pitchFamily="34" charset="-122"/>
                 <a:cs typeface="Inter" pitchFamily="34" charset="-120"/>
               </a:rPr>
-              <a:t>$227,297</a:t>
+              <a:t>$227K</a:t>
             </a:r>
             <a:endParaRPr lang="en-US" sz="1300" dirty="0"/>
           </a:p>
@@ -15032,7 +15032,7 @@
         <p:spPr>
           <a:xfrm>
             <a:off x="2670048" y="2999205"/>
-            <a:ext cx="414980" cy="136676"/>
+            <a:ext cx="456478" cy="136676"/>
           </a:xfrm>
           <a:prstGeom prst="rect">
             <a:avLst/>
@@ -15051,8 +15051,8 @@
         </p:nvSpPr>
         <p:spPr>
           <a:xfrm>
-            <a:off x="3456432" y="2943292"/>
-            <a:ext cx="896112" cy="248502"/>
+            <a:off x="3529584" y="2943292"/>
+            <a:ext cx="822960" cy="248502"/>
           </a:xfrm>
           <a:prstGeom prst="rect">
             <a:avLst/>
@@ -15076,7 +15076,7 @@
                 <a:ea typeface="Inter" pitchFamily="34" charset="-122"/>
                 <a:cs typeface="Inter" pitchFamily="34" charset="-120"/>
               </a:rPr>
-              <a:t>$203,362</a:t>
+              <a:t>$203K</a:t>
             </a:r>
             <a:endParaRPr lang="en-US" sz="1300" dirty="0"/>
           </a:p>
@@ -15208,7 +15208,7 @@
         <p:spPr>
           <a:xfrm>
             <a:off x="2670048" y="3247707"/>
-            <a:ext cx="318618" cy="136676"/>
+            <a:ext cx="350480" cy="136676"/>
           </a:xfrm>
           <a:prstGeom prst="rect">
             <a:avLst/>
@@ -15227,8 +15227,8 @@
         </p:nvSpPr>
         <p:spPr>
           <a:xfrm>
-            <a:off x="3456432" y="3191794"/>
-            <a:ext cx="896112" cy="248502"/>
+            <a:off x="3529584" y="3191794"/>
+            <a:ext cx="822960" cy="248502"/>
           </a:xfrm>
           <a:prstGeom prst="rect">
             <a:avLst/>
@@ -15252,7 +15252,7 @@
                 <a:ea typeface="Inter" pitchFamily="34" charset="-122"/>
                 <a:cs typeface="Inter" pitchFamily="34" charset="-120"/>
               </a:rPr>
-              <a:t>$156,140</a:t>
+              <a:t>$156K</a:t>
             </a:r>
             <a:endParaRPr lang="en-US" sz="1300" dirty="0"/>
           </a:p>
@@ -15384,7 +15384,7 @@
         <p:spPr>
           <a:xfrm>
             <a:off x="2670048" y="3496208"/>
-            <a:ext cx="301001" cy="136676"/>
+            <a:ext cx="331101" cy="136676"/>
           </a:xfrm>
           <a:prstGeom prst="rect">
             <a:avLst/>
@@ -15403,8 +15403,8 @@
         </p:nvSpPr>
         <p:spPr>
           <a:xfrm>
-            <a:off x="3456432" y="3440296"/>
-            <a:ext cx="896112" cy="248502"/>
+            <a:off x="3529584" y="3440296"/>
+            <a:ext cx="822960" cy="248502"/>
           </a:xfrm>
           <a:prstGeom prst="rect">
             <a:avLst/>
@@ -15428,7 +15428,7 @@
                 <a:ea typeface="Inter" pitchFamily="34" charset="-122"/>
                 <a:cs typeface="Inter" pitchFamily="34" charset="-120"/>
               </a:rPr>
-              <a:t>$147,507</a:t>
+              <a:t>$148K</a:t>
             </a:r>
             <a:endParaRPr lang="en-US" sz="1300" dirty="0"/>
           </a:p>
@@ -15560,7 +15560,7 @@
         <p:spPr>
           <a:xfrm>
             <a:off x="2670048" y="3744710"/>
-            <a:ext cx="288095" cy="136676"/>
+            <a:ext cx="316904" cy="136676"/>
           </a:xfrm>
           <a:prstGeom prst="rect">
             <a:avLst/>
@@ -15579,8 +15579,8 @@
         </p:nvSpPr>
         <p:spPr>
           <a:xfrm>
-            <a:off x="3456432" y="3688797"/>
-            <a:ext cx="896112" cy="248502"/>
+            <a:off x="3529584" y="3688797"/>
+            <a:ext cx="822960" cy="248502"/>
           </a:xfrm>
           <a:prstGeom prst="rect">
             <a:avLst/>
@@ -15604,7 +15604,7 @@
                 <a:ea typeface="Inter" pitchFamily="34" charset="-122"/>
                 <a:cs typeface="Inter" pitchFamily="34" charset="-120"/>
               </a:rPr>
-              <a:t>$141,182</a:t>
+              <a:t>$141K</a:t>
             </a:r>
             <a:endParaRPr lang="en-US" sz="1300" dirty="0"/>
           </a:p>
@@ -15736,7 +15736,7 @@
         <p:spPr>
           <a:xfrm>
             <a:off x="2670048" y="3993212"/>
-            <a:ext cx="268462" cy="136676"/>
+            <a:ext cx="295308" cy="136676"/>
           </a:xfrm>
           <a:prstGeom prst="rect">
             <a:avLst/>
@@ -15755,8 +15755,8 @@
         </p:nvSpPr>
         <p:spPr>
           <a:xfrm>
-            <a:off x="3456432" y="3937299"/>
-            <a:ext cx="896112" cy="248502"/>
+            <a:off x="3529584" y="3937299"/>
+            <a:ext cx="822960" cy="248502"/>
           </a:xfrm>
           <a:prstGeom prst="rect">
             <a:avLst/>
@@ -15780,7 +15780,7 @@
                 <a:ea typeface="Inter" pitchFamily="34" charset="-122"/>
                 <a:cs typeface="Inter" pitchFamily="34" charset="-120"/>
               </a:rPr>
-              <a:t>$131,560</a:t>
+              <a:t>$132K</a:t>
             </a:r>
             <a:endParaRPr lang="en-US" sz="1300" dirty="0"/>
           </a:p>
@@ -15912,7 +15912,7 @@
         <p:spPr>
           <a:xfrm>
             <a:off x="2670048" y="4241713"/>
-            <a:ext cx="254519" cy="136676"/>
+            <a:ext cx="279971" cy="136676"/>
           </a:xfrm>
           <a:prstGeom prst="rect">
             <a:avLst/>
@@ -15931,8 +15931,8 @@
         </p:nvSpPr>
         <p:spPr>
           <a:xfrm>
-            <a:off x="3456432" y="4185800"/>
-            <a:ext cx="896112" cy="248502"/>
+            <a:off x="3529584" y="4185800"/>
+            <a:ext cx="822960" cy="248502"/>
           </a:xfrm>
           <a:prstGeom prst="rect">
             <a:avLst/>
@@ -15956,7 +15956,7 @@
                 <a:ea typeface="Inter" pitchFamily="34" charset="-122"/>
                 <a:cs typeface="Inter" pitchFamily="34" charset="-120"/>
               </a:rPr>
-              <a:t>$124,728</a:t>
+              <a:t>$125K</a:t>
             </a:r>
             <a:endParaRPr lang="en-US" sz="1300" dirty="0"/>
           </a:p>
@@ -16088,7 +16088,7 @@
         <p:spPr>
           <a:xfrm>
             <a:off x="2670048" y="4490215"/>
-            <a:ext cx="250231" cy="136676"/>
+            <a:ext cx="275254" cy="136676"/>
           </a:xfrm>
           <a:prstGeom prst="rect">
             <a:avLst/>
@@ -16107,8 +16107,8 @@
         </p:nvSpPr>
         <p:spPr>
           <a:xfrm>
-            <a:off x="3456432" y="4434302"/>
-            <a:ext cx="896112" cy="248502"/>
+            <a:off x="3529584" y="4434302"/>
+            <a:ext cx="822960" cy="248502"/>
           </a:xfrm>
           <a:prstGeom prst="rect">
             <a:avLst/>
@@ -16132,7 +16132,7 @@
                 <a:ea typeface="Inter" pitchFamily="34" charset="-122"/>
                 <a:cs typeface="Inter" pitchFamily="34" charset="-120"/>
               </a:rPr>
-              <a:t>$122,626</a:t>
+              <a:t>$123K</a:t>
             </a:r>
             <a:endParaRPr lang="en-US" sz="1300" dirty="0"/>
           </a:p>
@@ -16264,7 +16264,7 @@
         <p:spPr>
           <a:xfrm>
             <a:off x="2670048" y="4738717"/>
-            <a:ext cx="227064" cy="136676"/>
+            <a:ext cx="249770" cy="136676"/>
           </a:xfrm>
           <a:prstGeom prst="rect">
             <a:avLst/>
@@ -16283,8 +16283,8 @@
         </p:nvSpPr>
         <p:spPr>
           <a:xfrm>
-            <a:off x="3456432" y="4682804"/>
-            <a:ext cx="896112" cy="248502"/>
+            <a:off x="3529584" y="4682804"/>
+            <a:ext cx="822960" cy="248502"/>
           </a:xfrm>
           <a:prstGeom prst="rect">
             <a:avLst/>
@@ -16308,7 +16308,7 @@
                 <a:ea typeface="Inter" pitchFamily="34" charset="-122"/>
                 <a:cs typeface="Inter" pitchFamily="34" charset="-120"/>
               </a:rPr>
-              <a:t>$111,273</a:t>
+              <a:t>$111K</a:t>
             </a:r>
             <a:endParaRPr lang="en-US" sz="1300" dirty="0"/>
           </a:p>
@@ -16440,7 +16440,7 @@
         <p:spPr>
           <a:xfrm>
             <a:off x="2670048" y="4987218"/>
-            <a:ext cx="223838" cy="136676"/>
+            <a:ext cx="246222" cy="136676"/>
           </a:xfrm>
           <a:prstGeom prst="rect">
             <a:avLst/>
@@ -16459,8 +16459,8 @@
         </p:nvSpPr>
         <p:spPr>
           <a:xfrm>
-            <a:off x="3456432" y="4931305"/>
-            <a:ext cx="896112" cy="248502"/>
+            <a:off x="3529584" y="4931305"/>
+            <a:ext cx="822960" cy="248502"/>
           </a:xfrm>
           <a:prstGeom prst="rect">
             <a:avLst/>
@@ -16484,7 +16484,7 @@
                 <a:ea typeface="Inter" pitchFamily="34" charset="-122"/>
                 <a:cs typeface="Inter" pitchFamily="34" charset="-120"/>
               </a:rPr>
-              <a:t>$109,693</a:t>
+              <a:t>$110K</a:t>
             </a:r>
             <a:endParaRPr lang="en-US" sz="1300" dirty="0"/>
           </a:p>
@@ -16616,7 +16616,7 @@
         <p:spPr>
           <a:xfrm>
             <a:off x="2670048" y="5235720"/>
-            <a:ext cx="222732" cy="136676"/>
+            <a:ext cx="245006" cy="136676"/>
           </a:xfrm>
           <a:prstGeom prst="rect">
             <a:avLst/>
@@ -16635,8 +16635,8 @@
         </p:nvSpPr>
         <p:spPr>
           <a:xfrm>
-            <a:off x="3456432" y="5179807"/>
-            <a:ext cx="896112" cy="248502"/>
+            <a:off x="3529584" y="5179807"/>
+            <a:ext cx="822960" cy="248502"/>
           </a:xfrm>
           <a:prstGeom prst="rect">
             <a:avLst/>
@@ -16660,7 +16660,7 @@
                 <a:ea typeface="Inter" pitchFamily="34" charset="-122"/>
                 <a:cs typeface="Inter" pitchFamily="34" charset="-120"/>
               </a:rPr>
-              <a:t>$109,151</a:t>
+              <a:t>$109K</a:t>
             </a:r>
             <a:endParaRPr lang="en-US" sz="1300" dirty="0"/>
           </a:p>
@@ -16792,7 +16792,7 @@
         <p:spPr>
           <a:xfrm>
             <a:off x="2670048" y="5484222"/>
-            <a:ext cx="221786" cy="136676"/>
+            <a:ext cx="243965" cy="136676"/>
           </a:xfrm>
           <a:prstGeom prst="rect">
             <a:avLst/>
@@ -16811,8 +16811,8 @@
         </p:nvSpPr>
         <p:spPr>
           <a:xfrm>
-            <a:off x="3456432" y="5428309"/>
-            <a:ext cx="896112" cy="248502"/>
+            <a:off x="3529584" y="5428309"/>
+            <a:ext cx="822960" cy="248502"/>
           </a:xfrm>
           <a:prstGeom prst="rect">
             <a:avLst/>
@@ -16836,7 +16836,7 @@
                 <a:ea typeface="Inter" pitchFamily="34" charset="-122"/>
                 <a:cs typeface="Inter" pitchFamily="34" charset="-120"/>
               </a:rPr>
-              <a:t>$108,687</a:t>
+              <a:t>$109K</a:t>
             </a:r>
             <a:endParaRPr lang="en-US" sz="1300" dirty="0"/>
           </a:p>
@@ -16968,7 +16968,7 @@
         <p:spPr>
           <a:xfrm>
             <a:off x="2670048" y="5732723"/>
-            <a:ext cx="211558" cy="136676"/>
+            <a:ext cx="232714" cy="136676"/>
           </a:xfrm>
           <a:prstGeom prst="rect">
             <a:avLst/>
@@ -16987,8 +16987,8 @@
         </p:nvSpPr>
         <p:spPr>
           <a:xfrm>
-            <a:off x="3456432" y="5676810"/>
-            <a:ext cx="896112" cy="248502"/>
+            <a:off x="3529584" y="5676810"/>
+            <a:ext cx="822960" cy="248502"/>
           </a:xfrm>
           <a:prstGeom prst="rect">
             <a:avLst/>
@@ -17012,7 +17012,7 @@
                 <a:ea typeface="Inter" pitchFamily="34" charset="-122"/>
                 <a:cs typeface="Inter" pitchFamily="34" charset="-120"/>
               </a:rPr>
-              <a:t>$103,675</a:t>
+              <a:t>$104K</a:t>
             </a:r>
             <a:endParaRPr lang="en-US" sz="1300" dirty="0"/>
           </a:p>
@@ -17144,7 +17144,7 @@
         <p:spPr>
           <a:xfrm>
             <a:off x="8220456" y="1756697"/>
-            <a:ext cx="210961" cy="136676"/>
+            <a:ext cx="232057" cy="136676"/>
           </a:xfrm>
           <a:prstGeom prst="rect">
             <a:avLst/>
@@ -17163,8 +17163,8 @@
         </p:nvSpPr>
         <p:spPr>
           <a:xfrm>
-            <a:off x="9006840" y="1700784"/>
-            <a:ext cx="896112" cy="248502"/>
+            <a:off x="9079992" y="1700784"/>
+            <a:ext cx="822960" cy="248502"/>
           </a:xfrm>
           <a:prstGeom prst="rect">
             <a:avLst/>
@@ -17188,7 +17188,7 @@
                 <a:ea typeface="Inter" pitchFamily="34" charset="-122"/>
                 <a:cs typeface="Inter" pitchFamily="34" charset="-120"/>
               </a:rPr>
-              <a:t>$103,382</a:t>
+              <a:t>$103K</a:t>
             </a:r>
             <a:endParaRPr lang="en-US" sz="1300" dirty="0"/>
           </a:p>
@@ -17320,7 +17320,7 @@
         <p:spPr>
           <a:xfrm>
             <a:off x="8220456" y="2005199"/>
-            <a:ext cx="207153" cy="136676"/>
+            <a:ext cx="227868" cy="136676"/>
           </a:xfrm>
           <a:prstGeom prst="rect">
             <a:avLst/>
@@ -17339,8 +17339,8 @@
         </p:nvSpPr>
         <p:spPr>
           <a:xfrm>
-            <a:off x="9006840" y="1949286"/>
-            <a:ext cx="896112" cy="248502"/>
+            <a:off x="9079992" y="1949286"/>
+            <a:ext cx="822960" cy="248502"/>
           </a:xfrm>
           <a:prstGeom prst="rect">
             <a:avLst/>
@@ -17364,7 +17364,7 @@
                 <a:ea typeface="Inter" pitchFamily="34" charset="-122"/>
                 <a:cs typeface="Inter" pitchFamily="34" charset="-120"/>
               </a:rPr>
-              <a:t>$101,516</a:t>
+              <a:t>$102K</a:t>
             </a:r>
             <a:endParaRPr lang="en-US" sz="1300" dirty="0"/>
           </a:p>
@@ -17496,7 +17496,7 @@
         <p:spPr>
           <a:xfrm>
             <a:off x="8220456" y="2253700"/>
-            <a:ext cx="197009" cy="136676"/>
+            <a:ext cx="216710" cy="136676"/>
           </a:xfrm>
           <a:prstGeom prst="rect">
             <a:avLst/>
@@ -17515,8 +17515,8 @@
         </p:nvSpPr>
         <p:spPr>
           <a:xfrm>
-            <a:off x="9006840" y="2197787"/>
-            <a:ext cx="896112" cy="248502"/>
+            <a:off x="9079992" y="2197787"/>
+            <a:ext cx="822960" cy="248502"/>
           </a:xfrm>
           <a:prstGeom prst="rect">
             <a:avLst/>
@@ -17540,7 +17540,7 @@
                 <a:ea typeface="Inter" pitchFamily="34" charset="-122"/>
                 <a:cs typeface="Inter" pitchFamily="34" charset="-120"/>
               </a:rPr>
-              <a:t>$96,545</a:t>
+              <a:t>$97K</a:t>
             </a:r>
             <a:endParaRPr lang="en-US" sz="1300" dirty="0"/>
           </a:p>
@@ -17672,7 +17672,7 @@
         <p:spPr>
           <a:xfrm>
             <a:off x="8220456" y="2502202"/>
-            <a:ext cx="193959" cy="136676"/>
+            <a:ext cx="213355" cy="136676"/>
           </a:xfrm>
           <a:prstGeom prst="rect">
             <a:avLst/>
@@ -17691,8 +17691,8 @@
         </p:nvSpPr>
         <p:spPr>
           <a:xfrm>
-            <a:off x="9006840" y="2446289"/>
-            <a:ext cx="896112" cy="248502"/>
+            <a:off x="9079992" y="2446289"/>
+            <a:ext cx="822960" cy="248502"/>
           </a:xfrm>
           <a:prstGeom prst="rect">
             <a:avLst/>
@@ -17716,7 +17716,7 @@
                 <a:ea typeface="Inter" pitchFamily="34" charset="-122"/>
                 <a:cs typeface="Inter" pitchFamily="34" charset="-120"/>
               </a:rPr>
-              <a:t>$95,050</a:t>
+              <a:t>$95K</a:t>
             </a:r>
             <a:endParaRPr lang="en-US" sz="1300" dirty="0"/>
           </a:p>
@@ -17848,7 +17848,7 @@
         <p:spPr>
           <a:xfrm>
             <a:off x="8220456" y="2750703"/>
-            <a:ext cx="192175" cy="136676"/>
+            <a:ext cx="211393" cy="136676"/>
           </a:xfrm>
           <a:prstGeom prst="rect">
             <a:avLst/>
@@ -17867,8 +17867,8 @@
         </p:nvSpPr>
         <p:spPr>
           <a:xfrm>
-            <a:off x="9006840" y="2694791"/>
-            <a:ext cx="896112" cy="248502"/>
+            <a:off x="9079992" y="2694791"/>
+            <a:ext cx="822960" cy="248502"/>
           </a:xfrm>
           <a:prstGeom prst="rect">
             <a:avLst/>
@@ -17892,7 +17892,7 @@
                 <a:ea typeface="Inter" pitchFamily="34" charset="-122"/>
                 <a:cs typeface="Inter" pitchFamily="34" charset="-120"/>
               </a:rPr>
-              <a:t>$94,176</a:t>
+              <a:t>$94K</a:t>
             </a:r>
             <a:endParaRPr lang="en-US" sz="1300" dirty="0"/>
           </a:p>
@@ -18024,7 +18024,7 @@
         <p:spPr>
           <a:xfrm>
             <a:off x="8220456" y="2999205"/>
-            <a:ext cx="182910" cy="136676"/>
+            <a:ext cx="201201" cy="136676"/>
           </a:xfrm>
           <a:prstGeom prst="rect">
             <a:avLst/>
@@ -18043,8 +18043,8 @@
         </p:nvSpPr>
         <p:spPr>
           <a:xfrm>
-            <a:off x="9006840" y="2943292"/>
-            <a:ext cx="896112" cy="248502"/>
+            <a:off x="9079992" y="2943292"/>
+            <a:ext cx="822960" cy="248502"/>
           </a:xfrm>
           <a:prstGeom prst="rect">
             <a:avLst/>
@@ -18068,7 +18068,7 @@
                 <a:ea typeface="Inter" pitchFamily="34" charset="-122"/>
                 <a:cs typeface="Inter" pitchFamily="34" charset="-120"/>
               </a:rPr>
-              <a:t>$89,636</a:t>
+              <a:t>$90K</a:t>
             </a:r>
             <a:endParaRPr lang="en-US" sz="1300" dirty="0"/>
           </a:p>
@@ -18200,7 +18200,7 @@
         <p:spPr>
           <a:xfrm>
             <a:off x="8220456" y="3247707"/>
-            <a:ext cx="177501" cy="136676"/>
+            <a:ext cx="195251" cy="136676"/>
           </a:xfrm>
           <a:prstGeom prst="rect">
             <a:avLst/>
@@ -18219,8 +18219,8 @@
         </p:nvSpPr>
         <p:spPr>
           <a:xfrm>
-            <a:off x="9006840" y="3191794"/>
-            <a:ext cx="896112" cy="248502"/>
+            <a:off x="9079992" y="3191794"/>
+            <a:ext cx="822960" cy="248502"/>
           </a:xfrm>
           <a:prstGeom prst="rect">
             <a:avLst/>
@@ -18244,7 +18244,7 @@
                 <a:ea typeface="Inter" pitchFamily="34" charset="-122"/>
                 <a:cs typeface="Inter" pitchFamily="34" charset="-120"/>
               </a:rPr>
-              <a:t>$86,985</a:t>
+              <a:t>$87K</a:t>
             </a:r>
             <a:endParaRPr lang="en-US" sz="1300" dirty="0"/>
           </a:p>
@@ -18376,7 +18376,7 @@
         <p:spPr>
           <a:xfrm>
             <a:off x="8220456" y="3496208"/>
-            <a:ext cx="175512" cy="136676"/>
+            <a:ext cx="193063" cy="136676"/>
           </a:xfrm>
           <a:prstGeom prst="rect">
             <a:avLst/>
@@ -18395,8 +18395,8 @@
         </p:nvSpPr>
         <p:spPr>
           <a:xfrm>
-            <a:off x="9006840" y="3440296"/>
-            <a:ext cx="896112" cy="248502"/>
+            <a:off x="9079992" y="3440296"/>
+            <a:ext cx="822960" cy="248502"/>
           </a:xfrm>
           <a:prstGeom prst="rect">
             <a:avLst/>
@@ -18420,7 +18420,7 @@
                 <a:ea typeface="Inter" pitchFamily="34" charset="-122"/>
                 <a:cs typeface="Inter" pitchFamily="34" charset="-120"/>
               </a:rPr>
-              <a:t>$86,010</a:t>
+              <a:t>$86K</a:t>
             </a:r>
             <a:endParaRPr lang="en-US" sz="1300" dirty="0"/>
           </a:p>
@@ -18552,7 +18552,7 @@
         <p:spPr>
           <a:xfrm>
             <a:off x="8220456" y="3744710"/>
-            <a:ext cx="167969" cy="136676"/>
+            <a:ext cx="184766" cy="136676"/>
           </a:xfrm>
           <a:prstGeom prst="rect">
             <a:avLst/>
@@ -18571,8 +18571,8 @@
         </p:nvSpPr>
         <p:spPr>
           <a:xfrm>
-            <a:off x="9006840" y="3688797"/>
-            <a:ext cx="896112" cy="248502"/>
+            <a:off x="9079992" y="3688797"/>
+            <a:ext cx="822960" cy="248502"/>
           </a:xfrm>
           <a:prstGeom prst="rect">
             <a:avLst/>
@@ -18596,7 +18596,7 @@
                 <a:ea typeface="Inter" pitchFamily="34" charset="-122"/>
                 <a:cs typeface="Inter" pitchFamily="34" charset="-120"/>
               </a:rPr>
-              <a:t>$82,314</a:t>
+              <a:t>$82K</a:t>
             </a:r>
             <a:endParaRPr lang="en-US" sz="1300" dirty="0"/>
           </a:p>
@@ -18728,7 +18728,7 @@
         <p:spPr>
           <a:xfrm>
             <a:off x="8220456" y="3993212"/>
-            <a:ext cx="151665" cy="136676"/>
+            <a:ext cx="166831" cy="136676"/>
           </a:xfrm>
           <a:prstGeom prst="rect">
             <a:avLst/>
@@ -18747,8 +18747,8 @@
         </p:nvSpPr>
         <p:spPr>
           <a:xfrm>
-            <a:off x="9006840" y="3937299"/>
-            <a:ext cx="896112" cy="248502"/>
+            <a:off x="9079992" y="3937299"/>
+            <a:ext cx="822960" cy="248502"/>
           </a:xfrm>
           <a:prstGeom prst="rect">
             <a:avLst/>
@@ -18772,7 +18772,7 @@
                 <a:ea typeface="Inter" pitchFamily="34" charset="-122"/>
                 <a:cs typeface="Inter" pitchFamily="34" charset="-120"/>
               </a:rPr>
-              <a:t>$74,324</a:t>
+              <a:t>$74K</a:t>
             </a:r>
             <a:endParaRPr lang="en-US" sz="1300" dirty="0"/>
           </a:p>
@@ -18904,7 +18904,7 @@
         <p:spPr>
           <a:xfrm>
             <a:off x="8220456" y="4241713"/>
-            <a:ext cx="148544" cy="136676"/>
+            <a:ext cx="163399" cy="136676"/>
           </a:xfrm>
           <a:prstGeom prst="rect">
             <a:avLst/>
@@ -18923,8 +18923,8 @@
         </p:nvSpPr>
         <p:spPr>
           <a:xfrm>
-            <a:off x="9006840" y="4185800"/>
-            <a:ext cx="896112" cy="248502"/>
+            <a:off x="9079992" y="4185800"/>
+            <a:ext cx="822960" cy="248502"/>
           </a:xfrm>
           <a:prstGeom prst="rect">
             <a:avLst/>
@@ -18948,7 +18948,7 @@
                 <a:ea typeface="Inter" pitchFamily="34" charset="-122"/>
                 <a:cs typeface="Inter" pitchFamily="34" charset="-120"/>
               </a:rPr>
-              <a:t>$72,795</a:t>
+              <a:t>$73K</a:t>
             </a:r>
             <a:endParaRPr lang="en-US" sz="1300" dirty="0"/>
           </a:p>
@@ -19080,7 +19080,7 @@
         <p:spPr>
           <a:xfrm>
             <a:off x="8220456" y="4490215"/>
-            <a:ext cx="148506" cy="136676"/>
+            <a:ext cx="163357" cy="136676"/>
           </a:xfrm>
           <a:prstGeom prst="rect">
             <a:avLst/>
@@ -19099,8 +19099,8 @@
         </p:nvSpPr>
         <p:spPr>
           <a:xfrm>
-            <a:off x="9006840" y="4434302"/>
-            <a:ext cx="896112" cy="248502"/>
+            <a:off x="9079992" y="4434302"/>
+            <a:ext cx="822960" cy="248502"/>
           </a:xfrm>
           <a:prstGeom prst="rect">
             <a:avLst/>
@@ -19124,7 +19124,7 @@
                 <a:ea typeface="Inter" pitchFamily="34" charset="-122"/>
                 <a:cs typeface="Inter" pitchFamily="34" charset="-120"/>
               </a:rPr>
-              <a:t>$72,776</a:t>
+              <a:t>$73K</a:t>
             </a:r>
             <a:endParaRPr lang="en-US" sz="1300" dirty="0"/>
           </a:p>
@@ -19256,7 +19256,7 @@
         <p:spPr>
           <a:xfrm>
             <a:off x="8220456" y="4738717"/>
-            <a:ext cx="148438" cy="136676"/>
+            <a:ext cx="163282" cy="136676"/>
           </a:xfrm>
           <a:prstGeom prst="rect">
             <a:avLst/>
@@ -19275,8 +19275,8 @@
         </p:nvSpPr>
         <p:spPr>
           <a:xfrm>
-            <a:off x="9006840" y="4682804"/>
-            <a:ext cx="896112" cy="248502"/>
+            <a:off x="9079992" y="4682804"/>
+            <a:ext cx="822960" cy="248502"/>
           </a:xfrm>
           <a:prstGeom prst="rect">
             <a:avLst/>
@@ -19300,7 +19300,7 @@
                 <a:ea typeface="Inter" pitchFamily="34" charset="-122"/>
                 <a:cs typeface="Inter" pitchFamily="34" charset="-120"/>
               </a:rPr>
-              <a:t>$72,743</a:t>
+              <a:t>$73K</a:t>
             </a:r>
             <a:endParaRPr lang="en-US" sz="1300" dirty="0"/>
           </a:p>
@@ -19432,7 +19432,7 @@
         <p:spPr>
           <a:xfrm>
             <a:off x="8220456" y="4987218"/>
-            <a:ext cx="137973" cy="136676"/>
+            <a:ext cx="151770" cy="136676"/>
           </a:xfrm>
           <a:prstGeom prst="rect">
             <a:avLst/>
@@ -19451,8 +19451,8 @@
         </p:nvSpPr>
         <p:spPr>
           <a:xfrm>
-            <a:off x="9006840" y="4931305"/>
-            <a:ext cx="896112" cy="248502"/>
+            <a:off x="9079992" y="4931305"/>
+            <a:ext cx="822960" cy="248502"/>
           </a:xfrm>
           <a:prstGeom prst="rect">
             <a:avLst/>
@@ -19476,7 +19476,7 @@
                 <a:ea typeface="Inter" pitchFamily="34" charset="-122"/>
                 <a:cs typeface="Inter" pitchFamily="34" charset="-120"/>
               </a:rPr>
-              <a:t>$67,614</a:t>
+              <a:t>$68K</a:t>
             </a:r>
             <a:endParaRPr lang="en-US" sz="1300" dirty="0"/>
           </a:p>
@@ -19608,7 +19608,7 @@
         <p:spPr>
           <a:xfrm>
             <a:off x="8220456" y="5235720"/>
-            <a:ext cx="135948" cy="136676"/>
+            <a:ext cx="149543" cy="136676"/>
           </a:xfrm>
           <a:prstGeom prst="rect">
             <a:avLst/>
@@ -19627,8 +19627,8 @@
         </p:nvSpPr>
         <p:spPr>
           <a:xfrm>
-            <a:off x="9006840" y="5179807"/>
-            <a:ext cx="896112" cy="248502"/>
+            <a:off x="9079992" y="5179807"/>
+            <a:ext cx="822960" cy="248502"/>
           </a:xfrm>
           <a:prstGeom prst="rect">
             <a:avLst/>
@@ -19652,7 +19652,7 @@
                 <a:ea typeface="Inter" pitchFamily="34" charset="-122"/>
                 <a:cs typeface="Inter" pitchFamily="34" charset="-120"/>
               </a:rPr>
-              <a:t>$66,622</a:t>
+              <a:t>$67K</a:t>
             </a:r>
             <a:endParaRPr lang="en-US" sz="1300" dirty="0"/>
           </a:p>
@@ -19784,7 +19784,7 @@
         <p:spPr>
           <a:xfrm>
             <a:off x="8220456" y="5484222"/>
-            <a:ext cx="133856" cy="136676"/>
+            <a:ext cx="147241" cy="136676"/>
           </a:xfrm>
           <a:prstGeom prst="rect">
             <a:avLst/>
@@ -19803,8 +19803,8 @@
         </p:nvSpPr>
         <p:spPr>
           <a:xfrm>
-            <a:off x="9006840" y="5428309"/>
-            <a:ext cx="896112" cy="248502"/>
+            <a:off x="9079992" y="5428309"/>
+            <a:ext cx="822960" cy="248502"/>
           </a:xfrm>
           <a:prstGeom prst="rect">
             <a:avLst/>
@@ -19828,7 +19828,7 @@
                 <a:ea typeface="Inter" pitchFamily="34" charset="-122"/>
                 <a:cs typeface="Inter" pitchFamily="34" charset="-120"/>
               </a:rPr>
-              <a:t>$65,596</a:t>
+              <a:t>$66K</a:t>
             </a:r>
             <a:endParaRPr lang="en-US" sz="1300" dirty="0"/>
           </a:p>

</xml_diff>

<commit_message>
Customer Pay section rename, wording fixes, top/bottom-five movers slide for every metric, drop Unclassified CP Labor
Co-Authored-By: Claude Opus 5.5 <noreply@anthropic.com>
Claude-Session: https://claude.ai/code/session_01Xa4nFVxuQGXmHARGph9WhS
</commit_message>
<xml_diff>
--- a/day2-deck/decks/CP Hours & RO a Day - Review.pptx
+++ b/day2-deck/decks/CP Hours & RO a Day - Review.pptx
@@ -9,9 +9,10 @@
     <p:sldId id="257" r:id="rId3"/>
     <p:sldId id="258" r:id="rId4"/>
     <p:sldId id="259" r:id="rId5"/>
+    <p:sldId id="260" r:id="rId6"/>
   </p:sldIdLst>
   <p:notesMasterIdLst>
-    <p:notesMasterId r:id="rId6"/>
+    <p:notesMasterId r:id="rId7"/>
   </p:notesMasterIdLst>
   <p:sldSz cx="12192000" cy="6858000"/>
   <p:notesSz cx="6858000" cy="12192000"/>
@@ -2638,6 +2639,94 @@
           <a:p>
             <a:r>
               <a:rPr lang="en-US" dirty="0"/>
+              <a:t>Source: Qlik - Closed Repair Orders. Customer pay, Jan-Sep by close date. Same-store, INEOS excluded (opened 2026). GMC Prescott body shop labor types excluded. Total customer-pay labor hours sold, all CP ROs. Top and bottom five stores by change in customer-pay hours sold (percent, so store size does not drive the ranking), Jan-Sep 2026 vs 2025.Conversation starter: each top store says one thing they started doing; each bottom store says what got in the way and what they would try. The room trades ideas.</a:t>
+            </a:r>
+            <a:endParaRPr lang="en-US" dirty="0"/>
+          </a:p>
+        </p:txBody>
+      </p:sp>
+      <p:sp>
+        <p:nvSpPr>
+          <p:cNvPr id="4" name="Slide Number Placeholder 3"/>
+          <p:cNvSpPr>
+            <a:spLocks noGrp="1"/>
+          </p:cNvSpPr>
+          <p:nvPr>
+            <p:ph type="sldNum" sz="quarter" idx="10"/>
+          </p:nvPr>
+        </p:nvSpPr>
+        <p:spPr/>
+        <p:txBody>
+          <a:bodyPr/>
+          <a:lstStyle/>
+          <a:p>
+            <a:fld id="{F7021451-1387-4CA6-816F-3879F97B5CBC}" type="slidenum">
+              <a:rPr lang="en-US"/>
+              <a:t>4</a:t>
+            </a:fld>
+            <a:endParaRPr lang="en-US"/>
+          </a:p>
+        </p:txBody>
+      </p:sp>
+    </p:spTree>
+    <p:extLst>
+      <p:ext uri="{BB962C8B-B14F-4D97-AF65-F5344CB8AC3E}">
+        <p14:creationId xmlns:p14="http://schemas.microsoft.com/office/powerpoint/2010/main" val="1024086991"/>
+      </p:ext>
+    </p:extLst>
+  </p:cSld>
+  <p:clrMapOvr>
+    <a:masterClrMapping/>
+  </p:clrMapOvr>
+</p:notes>
+</file>
+
+<file path=ppt/notesSlides/notesSlide5.xml><?xml version="1.0" encoding="utf-8"?>
+<p:notes xmlns:a="http://schemas.openxmlformats.org/drawingml/2006/main" xmlns:r="http://schemas.openxmlformats.org/officeDocument/2006/relationships" xmlns:p="http://schemas.openxmlformats.org/presentationml/2006/main">
+  <p:cSld>
+    <p:spTree>
+      <p:nvGrpSpPr>
+        <p:cNvPr id="1" name=""/>
+        <p:cNvGrpSpPr/>
+        <p:nvPr/>
+      </p:nvGrpSpPr>
+      <p:grpSpPr>
+        <a:xfrm>
+          <a:off x="0" y="0"/>
+          <a:ext cx="0" cy="0"/>
+          <a:chOff x="0" y="0"/>
+          <a:chExt cx="0" cy="0"/>
+        </a:xfrm>
+      </p:grpSpPr>
+      <p:sp>
+        <p:nvSpPr>
+          <p:cNvPr id="2" name="Slide Image Placeholder 1"/>
+          <p:cNvSpPr>
+            <a:spLocks noGrp="1" noRot="1" noChangeAspect="1"/>
+          </p:cNvSpPr>
+          <p:nvPr>
+            <p:ph type="sldImg"/>
+          </p:nvPr>
+        </p:nvSpPr>
+        <p:spPr/>
+      </p:sp>
+      <p:sp>
+        <p:nvSpPr>
+          <p:cNvPr id="3" name="Notes Placeholder 2"/>
+          <p:cNvSpPr>
+            <a:spLocks noGrp="1"/>
+          </p:cNvSpPr>
+          <p:nvPr>
+            <p:ph type="body" idx="1"/>
+          </p:nvPr>
+        </p:nvSpPr>
+        <p:spPr/>
+        <p:txBody>
+          <a:bodyPr/>
+          <a:lstStyle/>
+          <a:p>
+            <a:r>
+              <a:rPr lang="en-US" dirty="0"/>
               <a:t>Source: Qlik - Closed Repair Orders. Customer pay, Jan-Sep by close date. Same-store, INEOS excluded (opened 2026). GMC Prescott body shop labor types excluded. Per RO = the store's customer-pay labor gross + parts gross / its CP RO count, Jan-Sep 2026. Days open a year: 307 for every store (open 6 days a week, 2026 calendar, less the 6 service holidays: New Year's, Memorial Day, Independence Day, Labor Day, Thanksgiving, Christmas). ROs/day = Jan-Sep 2026 CP ROs at a yearly pace / days open. Assumes the added RO is an average one.Talk track: one more customer a day - one more answered call, one appointment kept, one 'close to losing' customer brought back. Retention, phones and the scheduler are the levers.
 LR HENDERSON: $1,168 gross per RO x 307 days open a year = $358,484; 6.8 CP ROs a day today
 LR LV: $1,142 gross per RO x 307 days open a year = $350,585; 15.2 CP ROs a day today
@@ -2694,7 +2783,7 @@
           <a:p>
             <a:fld id="{F7021451-1387-4CA6-816F-3879F97B5CBC}" type="slidenum">
               <a:rPr lang="en-US"/>
-              <a:t>4</a:t>
+              <a:t>5</a:t>
             </a:fld>
             <a:endParaRPr lang="en-US"/>
           </a:p>
@@ -3097,7 +3186,7 @@
                 <a:ea typeface="Inter" pitchFamily="34" charset="-122"/>
                 <a:cs typeface="Inter" pitchFamily="34" charset="-120"/>
               </a:rPr>
-              <a:t>THE CP ENGINE</a:t>
+              <a:t>CUSTOMER PAY</a:t>
             </a:r>
             <a:endParaRPr lang="en-US" sz="1400" dirty="0"/>
           </a:p>
@@ -3951,7 +4040,7 @@
                 <a:ea typeface="Inter" pitchFamily="34" charset="-122"/>
                 <a:cs typeface="Inter" pitchFamily="34" charset="-120"/>
               </a:rPr>
-              <a:t>THE CP ENGINE</a:t>
+              <a:t>CUSTOMER PAY</a:t>
             </a:r>
             <a:endParaRPr lang="en-US" sz="1400" dirty="0"/>
           </a:p>
@@ -8858,7 +8947,7 @@
                 <a:ea typeface="Inter" pitchFamily="34" charset="-122"/>
                 <a:cs typeface="Inter" pitchFamily="34" charset="-120"/>
               </a:rPr>
-              <a:t>THE CP ENGINE</a:t>
+              <a:t>CUSTOMER PAY</a:t>
             </a:r>
             <a:endParaRPr lang="en-US" sz="1400" dirty="0"/>
           </a:p>
@@ -13805,7 +13894,2489 @@
                 <a:ea typeface="Inter" pitchFamily="34" charset="-122"/>
                 <a:cs typeface="Inter" pitchFamily="34" charset="-120"/>
               </a:rPr>
-              <a:t>THE CP ENGINE</a:t>
+              <a:t>CUSTOMER PAY</a:t>
+            </a:r>
+            <a:endParaRPr lang="en-US" sz="1400" dirty="0"/>
+          </a:p>
+        </p:txBody>
+      </p:sp>
+      <p:sp>
+        <p:nvSpPr>
+          <p:cNvPr id="4" name="Text 2"/>
+          <p:cNvSpPr txBox="1"/>
+          <p:nvPr/>
+        </p:nvSpPr>
+        <p:spPr>
+          <a:xfrm>
+            <a:off x="457200" y="640080"/>
+            <a:ext cx="11338560" cy="502920"/>
+          </a:xfrm>
+          <a:prstGeom prst="rect">
+            <a:avLst/>
+          </a:prstGeom>
+          <a:noFill/>
+          <a:ln/>
+        </p:spPr>
+        <p:txBody>
+          <a:bodyPr wrap="square" lIns="0" tIns="0" rIns="0" bIns="0" rtlCol="0" anchor="ctr"/>
+          <a:lstStyle/>
+          <a:p>
+            <a:pPr indent="0" marL="0">
+              <a:buNone/>
+            </a:pPr>
+            <a:r>
+              <a:rPr lang="en-US" sz="2800" dirty="0">
+                <a:solidFill>
+                  <a:srgbClr val="1A1A1A"/>
+                </a:solidFill>
+                <a:latin typeface="Inter" pitchFamily="34" charset="0"/>
+                <a:ea typeface="Inter" pitchFamily="34" charset="-122"/>
+                <a:cs typeface="Inter" pitchFamily="34" charset="-120"/>
+              </a:rPr>
+              <a:t>Customer Pay Hours Sold</a:t>
+            </a:r>
+            <a:endParaRPr lang="en-US" sz="2800" dirty="0"/>
+          </a:p>
+        </p:txBody>
+      </p:sp>
+      <p:sp>
+        <p:nvSpPr>
+          <p:cNvPr id="5" name="Shape 3"/>
+          <p:cNvSpPr/>
+          <p:nvPr/>
+        </p:nvSpPr>
+        <p:spPr>
+          <a:xfrm>
+            <a:off x="457200" y="1207008"/>
+            <a:ext cx="11274552" cy="4782312"/>
+          </a:xfrm>
+          <a:prstGeom prst="rect">
+            <a:avLst/>
+          </a:prstGeom>
+          <a:solidFill>
+            <a:srgbClr val="FFFFFF"/>
+          </a:solidFill>
+          <a:ln/>
+        </p:spPr>
+      </p:sp>
+      <p:sp>
+        <p:nvSpPr>
+          <p:cNvPr id="6" name="Text 4"/>
+          <p:cNvSpPr txBox="1"/>
+          <p:nvPr/>
+        </p:nvSpPr>
+        <p:spPr>
+          <a:xfrm>
+            <a:off x="713232" y="1298448"/>
+            <a:ext cx="10762488" cy="310896"/>
+          </a:xfrm>
+          <a:prstGeom prst="rect">
+            <a:avLst/>
+          </a:prstGeom>
+          <a:noFill/>
+          <a:ln/>
+        </p:spPr>
+        <p:txBody>
+          <a:bodyPr wrap="square" lIns="0" tIns="0" rIns="0" bIns="0" rtlCol="0" anchor="ctr"/>
+          <a:lstStyle/>
+          <a:p>
+            <a:pPr indent="0" marL="0">
+              <a:buNone/>
+            </a:pPr>
+            <a:r>
+              <a:rPr lang="en-US" sz="1400" dirty="0">
+                <a:solidFill>
+                  <a:srgbClr val="595959"/>
+                </a:solidFill>
+                <a:latin typeface="Inter" pitchFamily="34" charset="0"/>
+                <a:ea typeface="Inter" pitchFamily="34" charset="-122"/>
+                <a:cs typeface="Inter" pitchFamily="34" charset="-120"/>
+              </a:rPr>
+              <a:t>Jan–Sep 2026 against Jan–Sep 2025. Group 504,019 → 523,142 (+3.8%). Ranked by percent change.</a:t>
+            </a:r>
+            <a:endParaRPr lang="en-US" sz="1400" dirty="0"/>
+          </a:p>
+        </p:txBody>
+      </p:sp>
+      <p:sp>
+        <p:nvSpPr>
+          <p:cNvPr id="7" name="Shape 5"/>
+          <p:cNvSpPr/>
+          <p:nvPr/>
+        </p:nvSpPr>
+        <p:spPr>
+          <a:xfrm>
+            <a:off x="658368" y="1737360"/>
+            <a:ext cx="5321808" cy="45720"/>
+          </a:xfrm>
+          <a:prstGeom prst="rect">
+            <a:avLst/>
+          </a:prstGeom>
+          <a:solidFill>
+            <a:srgbClr val="12A566"/>
+          </a:solidFill>
+          <a:ln/>
+        </p:spPr>
+      </p:sp>
+      <p:sp>
+        <p:nvSpPr>
+          <p:cNvPr id="8" name="Text 6"/>
+          <p:cNvSpPr txBox="1"/>
+          <p:nvPr/>
+        </p:nvSpPr>
+        <p:spPr>
+          <a:xfrm>
+            <a:off x="749808" y="1810512"/>
+            <a:ext cx="1828800" cy="274320"/>
+          </a:xfrm>
+          <a:prstGeom prst="rect">
+            <a:avLst/>
+          </a:prstGeom>
+          <a:noFill/>
+          <a:ln/>
+        </p:spPr>
+        <p:txBody>
+          <a:bodyPr wrap="square" lIns="0" tIns="0" rIns="0" bIns="0" rtlCol="0" anchor="ctr"/>
+          <a:lstStyle/>
+          <a:p>
+            <a:pPr indent="0" marL="0">
+              <a:buNone/>
+            </a:pPr>
+            <a:r>
+              <a:rPr lang="en-US" sz="1400" b="1" spc="100" kern="0" dirty="0">
+                <a:solidFill>
+                  <a:srgbClr val="0B7A4A"/>
+                </a:solidFill>
+                <a:latin typeface="Inter" pitchFamily="34" charset="0"/>
+                <a:ea typeface="Inter" pitchFamily="34" charset="-122"/>
+                <a:cs typeface="Inter" pitchFamily="34" charset="-120"/>
+              </a:rPr>
+              <a:t>TOP 5</a:t>
+            </a:r>
+            <a:endParaRPr lang="en-US" sz="1400" dirty="0"/>
+          </a:p>
+        </p:txBody>
+      </p:sp>
+      <p:sp>
+        <p:nvSpPr>
+          <p:cNvPr id="9" name="Text 7"/>
+          <p:cNvSpPr txBox="1"/>
+          <p:nvPr/>
+        </p:nvSpPr>
+        <p:spPr>
+          <a:xfrm>
+            <a:off x="2898648" y="1810512"/>
+            <a:ext cx="1828800" cy="274320"/>
+          </a:xfrm>
+          <a:prstGeom prst="rect">
+            <a:avLst/>
+          </a:prstGeom>
+          <a:noFill/>
+          <a:ln/>
+        </p:spPr>
+        <p:txBody>
+          <a:bodyPr wrap="square" lIns="0" tIns="0" rIns="0" bIns="0" rtlCol="0" anchor="ctr"/>
+          <a:lstStyle/>
+          <a:p>
+            <a:pPr indent="0" marL="0">
+              <a:buNone/>
+            </a:pPr>
+            <a:r>
+              <a:rPr lang="en-US" sz="1400" b="1" dirty="0">
+                <a:solidFill>
+                  <a:srgbClr val="595959"/>
+                </a:solidFill>
+                <a:latin typeface="Inter" pitchFamily="34" charset="0"/>
+                <a:ea typeface="Inter" pitchFamily="34" charset="-122"/>
+                <a:cs typeface="Inter" pitchFamily="34" charset="-120"/>
+              </a:rPr>
+              <a:t>2025 → 2026</a:t>
+            </a:r>
+            <a:endParaRPr lang="en-US" sz="1400" dirty="0"/>
+          </a:p>
+        </p:txBody>
+      </p:sp>
+      <p:sp>
+        <p:nvSpPr>
+          <p:cNvPr id="10" name="Text 8"/>
+          <p:cNvSpPr txBox="1"/>
+          <p:nvPr/>
+        </p:nvSpPr>
+        <p:spPr>
+          <a:xfrm>
+            <a:off x="4864608" y="1810512"/>
+            <a:ext cx="1051560" cy="274320"/>
+          </a:xfrm>
+          <a:prstGeom prst="rect">
+            <a:avLst/>
+          </a:prstGeom>
+          <a:noFill/>
+          <a:ln/>
+        </p:spPr>
+        <p:txBody>
+          <a:bodyPr wrap="square" lIns="0" tIns="0" rIns="0" bIns="0" rtlCol="0" anchor="ctr"/>
+          <a:lstStyle/>
+          <a:p>
+            <a:pPr algn="r" indent="0" marL="0">
+              <a:buNone/>
+            </a:pPr>
+            <a:r>
+              <a:rPr lang="en-US" sz="1400" b="1" dirty="0">
+                <a:solidFill>
+                  <a:srgbClr val="595959"/>
+                </a:solidFill>
+                <a:latin typeface="Inter" pitchFamily="34" charset="0"/>
+                <a:ea typeface="Inter" pitchFamily="34" charset="-122"/>
+                <a:cs typeface="Inter" pitchFamily="34" charset="-120"/>
+              </a:rPr>
+              <a:t>Change</a:t>
+            </a:r>
+            <a:endParaRPr lang="en-US" sz="1400" dirty="0"/>
+          </a:p>
+        </p:txBody>
+      </p:sp>
+      <p:sp>
+        <p:nvSpPr>
+          <p:cNvPr id="11" name="Shape 9"/>
+          <p:cNvSpPr/>
+          <p:nvPr/>
+        </p:nvSpPr>
+        <p:spPr>
+          <a:xfrm>
+            <a:off x="658368" y="2121408"/>
+            <a:ext cx="5321808" cy="751637"/>
+          </a:xfrm>
+          <a:prstGeom prst="rect">
+            <a:avLst/>
+          </a:prstGeom>
+          <a:solidFill>
+            <a:srgbClr val="F7F7F7"/>
+          </a:solidFill>
+          <a:ln/>
+        </p:spPr>
+      </p:sp>
+      <p:sp>
+        <p:nvSpPr>
+          <p:cNvPr id="12" name="Text 10"/>
+          <p:cNvSpPr txBox="1"/>
+          <p:nvPr/>
+        </p:nvSpPr>
+        <p:spPr>
+          <a:xfrm>
+            <a:off x="749808" y="2121408"/>
+            <a:ext cx="320040" cy="751637"/>
+          </a:xfrm>
+          <a:prstGeom prst="rect">
+            <a:avLst/>
+          </a:prstGeom>
+          <a:noFill/>
+          <a:ln/>
+        </p:spPr>
+        <p:txBody>
+          <a:bodyPr wrap="square" lIns="0" tIns="0" rIns="0" bIns="0" rtlCol="0" anchor="ctr"/>
+          <a:lstStyle/>
+          <a:p>
+            <a:pPr indent="0" marL="0">
+              <a:buNone/>
+            </a:pPr>
+            <a:r>
+              <a:rPr lang="en-US" sz="1500" b="1" dirty="0">
+                <a:solidFill>
+                  <a:srgbClr val="0B2C4A"/>
+                </a:solidFill>
+                <a:latin typeface="Inter" pitchFamily="34" charset="0"/>
+                <a:ea typeface="Inter" pitchFamily="34" charset="-122"/>
+                <a:cs typeface="Inter" pitchFamily="34" charset="-120"/>
+              </a:rPr>
+              <a:t>1</a:t>
+            </a:r>
+            <a:endParaRPr lang="en-US" sz="1500" dirty="0"/>
+          </a:p>
+        </p:txBody>
+      </p:sp>
+      <p:sp>
+        <p:nvSpPr>
+          <p:cNvPr id="13" name="Text 11"/>
+          <p:cNvSpPr txBox="1"/>
+          <p:nvPr/>
+        </p:nvSpPr>
+        <p:spPr>
+          <a:xfrm>
+            <a:off x="1115568" y="2121408"/>
+            <a:ext cx="1737360" cy="751637"/>
+          </a:xfrm>
+          <a:prstGeom prst="rect">
+            <a:avLst/>
+          </a:prstGeom>
+          <a:noFill/>
+          <a:ln/>
+        </p:spPr>
+        <p:txBody>
+          <a:bodyPr wrap="square" lIns="0" tIns="0" rIns="0" bIns="0" rtlCol="0" anchor="ctr"/>
+          <a:lstStyle/>
+          <a:p>
+            <a:pPr indent="0" marL="0">
+              <a:buNone/>
+            </a:pPr>
+            <a:r>
+              <a:rPr lang="en-US" sz="1400" b="1" dirty="0">
+                <a:solidFill>
+                  <a:srgbClr val="1A1A1A"/>
+                </a:solidFill>
+                <a:latin typeface="Inter" pitchFamily="34" charset="0"/>
+                <a:ea typeface="Inter" pitchFamily="34" charset="-122"/>
+                <a:cs typeface="Inter" pitchFamily="34" charset="-120"/>
+              </a:rPr>
+              <a:t>Subaru St George</a:t>
+            </a:r>
+            <a:endParaRPr lang="en-US" sz="1400" dirty="0"/>
+          </a:p>
+        </p:txBody>
+      </p:sp>
+      <p:sp>
+        <p:nvSpPr>
+          <p:cNvPr id="14" name="Text 12"/>
+          <p:cNvSpPr txBox="1"/>
+          <p:nvPr/>
+        </p:nvSpPr>
+        <p:spPr>
+          <a:xfrm>
+            <a:off x="2898648" y="2121408"/>
+            <a:ext cx="1920240" cy="751637"/>
+          </a:xfrm>
+          <a:prstGeom prst="rect">
+            <a:avLst/>
+          </a:prstGeom>
+          <a:noFill/>
+          <a:ln/>
+        </p:spPr>
+        <p:txBody>
+          <a:bodyPr wrap="square" lIns="0" tIns="0" rIns="0" bIns="0" rtlCol="0" anchor="ctr"/>
+          <a:lstStyle/>
+          <a:p>
+            <a:pPr indent="0" marL="0">
+              <a:buNone/>
+            </a:pPr>
+            <a:r>
+              <a:rPr lang="en-US" sz="1400" dirty="0">
+                <a:solidFill>
+                  <a:srgbClr val="595959"/>
+                </a:solidFill>
+                <a:latin typeface="Inter" pitchFamily="34" charset="0"/>
+                <a:ea typeface="Inter" pitchFamily="34" charset="-122"/>
+                <a:cs typeface="Inter" pitchFamily="34" charset="-120"/>
+              </a:rPr>
+              <a:t>8,827  </a:t>
+            </a:r>
+            <a:pPr indent="0" marL="0">
+              <a:buNone/>
+            </a:pPr>
+            <a:r>
+              <a:rPr lang="en-US" sz="1400" b="1" dirty="0">
+                <a:solidFill>
+                  <a:srgbClr val="0B7A4A"/>
+                </a:solidFill>
+                <a:latin typeface="Inter" pitchFamily="34" charset="0"/>
+                <a:ea typeface="Inter" pitchFamily="34" charset="-122"/>
+                <a:cs typeface="Inter" pitchFamily="34" charset="-120"/>
+              </a:rPr>
+              <a:t>→  </a:t>
+            </a:r>
+            <a:pPr indent="0" marL="0">
+              <a:buNone/>
+            </a:pPr>
+            <a:r>
+              <a:rPr lang="en-US" sz="1400" b="1" dirty="0">
+                <a:solidFill>
+                  <a:srgbClr val="0B7A4A"/>
+                </a:solidFill>
+                <a:latin typeface="Inter" pitchFamily="34" charset="0"/>
+                <a:ea typeface="Inter" pitchFamily="34" charset="-122"/>
+                <a:cs typeface="Inter" pitchFamily="34" charset="-120"/>
+              </a:rPr>
+              <a:t>12,766</a:t>
+            </a:r>
+            <a:endParaRPr lang="en-US" sz="1400" dirty="0"/>
+          </a:p>
+        </p:txBody>
+      </p:sp>
+      <p:sp>
+        <p:nvSpPr>
+          <p:cNvPr id="15" name="Text 13"/>
+          <p:cNvSpPr txBox="1"/>
+          <p:nvPr/>
+        </p:nvSpPr>
+        <p:spPr>
+          <a:xfrm>
+            <a:off x="4864608" y="2121408"/>
+            <a:ext cx="1051560" cy="751637"/>
+          </a:xfrm>
+          <a:prstGeom prst="rect">
+            <a:avLst/>
+          </a:prstGeom>
+          <a:noFill/>
+          <a:ln/>
+        </p:spPr>
+        <p:txBody>
+          <a:bodyPr wrap="square" lIns="0" tIns="0" rIns="0" bIns="0" rtlCol="0" anchor="ctr"/>
+          <a:lstStyle/>
+          <a:p>
+            <a:pPr algn="r" indent="0" marL="0">
+              <a:buNone/>
+            </a:pPr>
+            <a:r>
+              <a:rPr lang="en-US" sz="1600" b="1" dirty="0">
+                <a:solidFill>
+                  <a:srgbClr val="0B7A4A"/>
+                </a:solidFill>
+                <a:latin typeface="Inter" pitchFamily="34" charset="0"/>
+                <a:ea typeface="Inter" pitchFamily="34" charset="-122"/>
+                <a:cs typeface="Inter" pitchFamily="34" charset="-120"/>
+              </a:rPr>
+              <a:t>+44.6%</a:t>
+            </a:r>
+            <a:endParaRPr lang="en-US" sz="1600" dirty="0"/>
+          </a:p>
+        </p:txBody>
+      </p:sp>
+      <p:sp>
+        <p:nvSpPr>
+          <p:cNvPr id="16" name="Text 14"/>
+          <p:cNvSpPr txBox="1"/>
+          <p:nvPr/>
+        </p:nvSpPr>
+        <p:spPr>
+          <a:xfrm>
+            <a:off x="749808" y="2873045"/>
+            <a:ext cx="320040" cy="751637"/>
+          </a:xfrm>
+          <a:prstGeom prst="rect">
+            <a:avLst/>
+          </a:prstGeom>
+          <a:noFill/>
+          <a:ln/>
+        </p:spPr>
+        <p:txBody>
+          <a:bodyPr wrap="square" lIns="0" tIns="0" rIns="0" bIns="0" rtlCol="0" anchor="ctr"/>
+          <a:lstStyle/>
+          <a:p>
+            <a:pPr indent="0" marL="0">
+              <a:buNone/>
+            </a:pPr>
+            <a:r>
+              <a:rPr lang="en-US" sz="1500" b="1" dirty="0">
+                <a:solidFill>
+                  <a:srgbClr val="0B2C4A"/>
+                </a:solidFill>
+                <a:latin typeface="Inter" pitchFamily="34" charset="0"/>
+                <a:ea typeface="Inter" pitchFamily="34" charset="-122"/>
+                <a:cs typeface="Inter" pitchFamily="34" charset="-120"/>
+              </a:rPr>
+              <a:t>2</a:t>
+            </a:r>
+            <a:endParaRPr lang="en-US" sz="1500" dirty="0"/>
+          </a:p>
+        </p:txBody>
+      </p:sp>
+      <p:sp>
+        <p:nvSpPr>
+          <p:cNvPr id="17" name="Text 15"/>
+          <p:cNvSpPr txBox="1"/>
+          <p:nvPr/>
+        </p:nvSpPr>
+        <p:spPr>
+          <a:xfrm>
+            <a:off x="1115568" y="2873045"/>
+            <a:ext cx="1737360" cy="751637"/>
+          </a:xfrm>
+          <a:prstGeom prst="rect">
+            <a:avLst/>
+          </a:prstGeom>
+          <a:noFill/>
+          <a:ln/>
+        </p:spPr>
+        <p:txBody>
+          <a:bodyPr wrap="square" lIns="0" tIns="0" rIns="0" bIns="0" rtlCol="0" anchor="ctr"/>
+          <a:lstStyle/>
+          <a:p>
+            <a:pPr indent="0" marL="0">
+              <a:buNone/>
+            </a:pPr>
+            <a:r>
+              <a:rPr lang="en-US" sz="1400" b="1" dirty="0">
+                <a:solidFill>
+                  <a:srgbClr val="1A1A1A"/>
+                </a:solidFill>
+                <a:latin typeface="Inter" pitchFamily="34" charset="0"/>
+                <a:ea typeface="Inter" pitchFamily="34" charset="-122"/>
+                <a:cs typeface="Inter" pitchFamily="34" charset="-120"/>
+              </a:rPr>
+              <a:t>Kia LV</a:t>
+            </a:r>
+            <a:endParaRPr lang="en-US" sz="1400" dirty="0"/>
+          </a:p>
+        </p:txBody>
+      </p:sp>
+      <p:sp>
+        <p:nvSpPr>
+          <p:cNvPr id="18" name="Text 16"/>
+          <p:cNvSpPr txBox="1"/>
+          <p:nvPr/>
+        </p:nvSpPr>
+        <p:spPr>
+          <a:xfrm>
+            <a:off x="2898648" y="2873045"/>
+            <a:ext cx="1920240" cy="751637"/>
+          </a:xfrm>
+          <a:prstGeom prst="rect">
+            <a:avLst/>
+          </a:prstGeom>
+          <a:noFill/>
+          <a:ln/>
+        </p:spPr>
+        <p:txBody>
+          <a:bodyPr wrap="square" lIns="0" tIns="0" rIns="0" bIns="0" rtlCol="0" anchor="ctr"/>
+          <a:lstStyle/>
+          <a:p>
+            <a:pPr indent="0" marL="0">
+              <a:buNone/>
+            </a:pPr>
+            <a:r>
+              <a:rPr lang="en-US" sz="1400" dirty="0">
+                <a:solidFill>
+                  <a:srgbClr val="595959"/>
+                </a:solidFill>
+                <a:latin typeface="Inter" pitchFamily="34" charset="0"/>
+                <a:ea typeface="Inter" pitchFamily="34" charset="-122"/>
+                <a:cs typeface="Inter" pitchFamily="34" charset="-120"/>
+              </a:rPr>
+              <a:t>9,453  </a:t>
+            </a:r>
+            <a:pPr indent="0" marL="0">
+              <a:buNone/>
+            </a:pPr>
+            <a:r>
+              <a:rPr lang="en-US" sz="1400" b="1" dirty="0">
+                <a:solidFill>
+                  <a:srgbClr val="0B7A4A"/>
+                </a:solidFill>
+                <a:latin typeface="Inter" pitchFamily="34" charset="0"/>
+                <a:ea typeface="Inter" pitchFamily="34" charset="-122"/>
+                <a:cs typeface="Inter" pitchFamily="34" charset="-120"/>
+              </a:rPr>
+              <a:t>→  </a:t>
+            </a:r>
+            <a:pPr indent="0" marL="0">
+              <a:buNone/>
+            </a:pPr>
+            <a:r>
+              <a:rPr lang="en-US" sz="1400" b="1" dirty="0">
+                <a:solidFill>
+                  <a:srgbClr val="0B7A4A"/>
+                </a:solidFill>
+                <a:latin typeface="Inter" pitchFamily="34" charset="0"/>
+                <a:ea typeface="Inter" pitchFamily="34" charset="-122"/>
+                <a:cs typeface="Inter" pitchFamily="34" charset="-120"/>
+              </a:rPr>
+              <a:t>12,757</a:t>
+            </a:r>
+            <a:endParaRPr lang="en-US" sz="1400" dirty="0"/>
+          </a:p>
+        </p:txBody>
+      </p:sp>
+      <p:sp>
+        <p:nvSpPr>
+          <p:cNvPr id="19" name="Text 17"/>
+          <p:cNvSpPr txBox="1"/>
+          <p:nvPr/>
+        </p:nvSpPr>
+        <p:spPr>
+          <a:xfrm>
+            <a:off x="4864608" y="2873045"/>
+            <a:ext cx="1051560" cy="751637"/>
+          </a:xfrm>
+          <a:prstGeom prst="rect">
+            <a:avLst/>
+          </a:prstGeom>
+          <a:noFill/>
+          <a:ln/>
+        </p:spPr>
+        <p:txBody>
+          <a:bodyPr wrap="square" lIns="0" tIns="0" rIns="0" bIns="0" rtlCol="0" anchor="ctr"/>
+          <a:lstStyle/>
+          <a:p>
+            <a:pPr algn="r" indent="0" marL="0">
+              <a:buNone/>
+            </a:pPr>
+            <a:r>
+              <a:rPr lang="en-US" sz="1600" b="1" dirty="0">
+                <a:solidFill>
+                  <a:srgbClr val="0B7A4A"/>
+                </a:solidFill>
+                <a:latin typeface="Inter" pitchFamily="34" charset="0"/>
+                <a:ea typeface="Inter" pitchFamily="34" charset="-122"/>
+                <a:cs typeface="Inter" pitchFamily="34" charset="-120"/>
+              </a:rPr>
+              <a:t>+35.0%</a:t>
+            </a:r>
+            <a:endParaRPr lang="en-US" sz="1600" dirty="0"/>
+          </a:p>
+        </p:txBody>
+      </p:sp>
+      <p:sp>
+        <p:nvSpPr>
+          <p:cNvPr id="20" name="Shape 18"/>
+          <p:cNvSpPr/>
+          <p:nvPr/>
+        </p:nvSpPr>
+        <p:spPr>
+          <a:xfrm>
+            <a:off x="658368" y="3624682"/>
+            <a:ext cx="5321808" cy="751637"/>
+          </a:xfrm>
+          <a:prstGeom prst="rect">
+            <a:avLst/>
+          </a:prstGeom>
+          <a:solidFill>
+            <a:srgbClr val="F7F7F7"/>
+          </a:solidFill>
+          <a:ln/>
+        </p:spPr>
+      </p:sp>
+      <p:sp>
+        <p:nvSpPr>
+          <p:cNvPr id="21" name="Text 19"/>
+          <p:cNvSpPr txBox="1"/>
+          <p:nvPr/>
+        </p:nvSpPr>
+        <p:spPr>
+          <a:xfrm>
+            <a:off x="749808" y="3624682"/>
+            <a:ext cx="320040" cy="751637"/>
+          </a:xfrm>
+          <a:prstGeom prst="rect">
+            <a:avLst/>
+          </a:prstGeom>
+          <a:noFill/>
+          <a:ln/>
+        </p:spPr>
+        <p:txBody>
+          <a:bodyPr wrap="square" lIns="0" tIns="0" rIns="0" bIns="0" rtlCol="0" anchor="ctr"/>
+          <a:lstStyle/>
+          <a:p>
+            <a:pPr indent="0" marL="0">
+              <a:buNone/>
+            </a:pPr>
+            <a:r>
+              <a:rPr lang="en-US" sz="1500" b="1" dirty="0">
+                <a:solidFill>
+                  <a:srgbClr val="0B2C4A"/>
+                </a:solidFill>
+                <a:latin typeface="Inter" pitchFamily="34" charset="0"/>
+                <a:ea typeface="Inter" pitchFamily="34" charset="-122"/>
+                <a:cs typeface="Inter" pitchFamily="34" charset="-120"/>
+              </a:rPr>
+              <a:t>3</a:t>
+            </a:r>
+            <a:endParaRPr lang="en-US" sz="1500" dirty="0"/>
+          </a:p>
+        </p:txBody>
+      </p:sp>
+      <p:sp>
+        <p:nvSpPr>
+          <p:cNvPr id="22" name="Text 20"/>
+          <p:cNvSpPr txBox="1"/>
+          <p:nvPr/>
+        </p:nvSpPr>
+        <p:spPr>
+          <a:xfrm>
+            <a:off x="1115568" y="3624682"/>
+            <a:ext cx="1737360" cy="751637"/>
+          </a:xfrm>
+          <a:prstGeom prst="rect">
+            <a:avLst/>
+          </a:prstGeom>
+          <a:noFill/>
+          <a:ln/>
+        </p:spPr>
+        <p:txBody>
+          <a:bodyPr wrap="square" lIns="0" tIns="0" rIns="0" bIns="0" rtlCol="0" anchor="ctr"/>
+          <a:lstStyle/>
+          <a:p>
+            <a:pPr indent="0" marL="0">
+              <a:buNone/>
+            </a:pPr>
+            <a:r>
+              <a:rPr lang="en-US" sz="1400" b="1" dirty="0">
+                <a:solidFill>
+                  <a:srgbClr val="1A1A1A"/>
+                </a:solidFill>
+                <a:latin typeface="Inter" pitchFamily="34" charset="0"/>
+                <a:ea typeface="Inter" pitchFamily="34" charset="-122"/>
+                <a:cs typeface="Inter" pitchFamily="34" charset="-120"/>
+              </a:rPr>
+              <a:t>Kia St George</a:t>
+            </a:r>
+            <a:endParaRPr lang="en-US" sz="1400" dirty="0"/>
+          </a:p>
+        </p:txBody>
+      </p:sp>
+      <p:sp>
+        <p:nvSpPr>
+          <p:cNvPr id="23" name="Text 21"/>
+          <p:cNvSpPr txBox="1"/>
+          <p:nvPr/>
+        </p:nvSpPr>
+        <p:spPr>
+          <a:xfrm>
+            <a:off x="2898648" y="3624682"/>
+            <a:ext cx="1920240" cy="751637"/>
+          </a:xfrm>
+          <a:prstGeom prst="rect">
+            <a:avLst/>
+          </a:prstGeom>
+          <a:noFill/>
+          <a:ln/>
+        </p:spPr>
+        <p:txBody>
+          <a:bodyPr wrap="square" lIns="0" tIns="0" rIns="0" bIns="0" rtlCol="0" anchor="ctr"/>
+          <a:lstStyle/>
+          <a:p>
+            <a:pPr indent="0" marL="0">
+              <a:buNone/>
+            </a:pPr>
+            <a:r>
+              <a:rPr lang="en-US" sz="1400" dirty="0">
+                <a:solidFill>
+                  <a:srgbClr val="595959"/>
+                </a:solidFill>
+                <a:latin typeface="Inter" pitchFamily="34" charset="0"/>
+                <a:ea typeface="Inter" pitchFamily="34" charset="-122"/>
+                <a:cs typeface="Inter" pitchFamily="34" charset="-120"/>
+              </a:rPr>
+              <a:t>3,768  </a:t>
+            </a:r>
+            <a:pPr indent="0" marL="0">
+              <a:buNone/>
+            </a:pPr>
+            <a:r>
+              <a:rPr lang="en-US" sz="1400" b="1" dirty="0">
+                <a:solidFill>
+                  <a:srgbClr val="0B7A4A"/>
+                </a:solidFill>
+                <a:latin typeface="Inter" pitchFamily="34" charset="0"/>
+                <a:ea typeface="Inter" pitchFamily="34" charset="-122"/>
+                <a:cs typeface="Inter" pitchFamily="34" charset="-120"/>
+              </a:rPr>
+              <a:t>→  </a:t>
+            </a:r>
+            <a:pPr indent="0" marL="0">
+              <a:buNone/>
+            </a:pPr>
+            <a:r>
+              <a:rPr lang="en-US" sz="1400" b="1" dirty="0">
+                <a:solidFill>
+                  <a:srgbClr val="0B7A4A"/>
+                </a:solidFill>
+                <a:latin typeface="Inter" pitchFamily="34" charset="0"/>
+                <a:ea typeface="Inter" pitchFamily="34" charset="-122"/>
+                <a:cs typeface="Inter" pitchFamily="34" charset="-120"/>
+              </a:rPr>
+              <a:t>5,045</a:t>
+            </a:r>
+            <a:endParaRPr lang="en-US" sz="1400" dirty="0"/>
+          </a:p>
+        </p:txBody>
+      </p:sp>
+      <p:sp>
+        <p:nvSpPr>
+          <p:cNvPr id="24" name="Text 22"/>
+          <p:cNvSpPr txBox="1"/>
+          <p:nvPr/>
+        </p:nvSpPr>
+        <p:spPr>
+          <a:xfrm>
+            <a:off x="4864608" y="3624682"/>
+            <a:ext cx="1051560" cy="751637"/>
+          </a:xfrm>
+          <a:prstGeom prst="rect">
+            <a:avLst/>
+          </a:prstGeom>
+          <a:noFill/>
+          <a:ln/>
+        </p:spPr>
+        <p:txBody>
+          <a:bodyPr wrap="square" lIns="0" tIns="0" rIns="0" bIns="0" rtlCol="0" anchor="ctr"/>
+          <a:lstStyle/>
+          <a:p>
+            <a:pPr algn="r" indent="0" marL="0">
+              <a:buNone/>
+            </a:pPr>
+            <a:r>
+              <a:rPr lang="en-US" sz="1600" b="1" dirty="0">
+                <a:solidFill>
+                  <a:srgbClr val="0B7A4A"/>
+                </a:solidFill>
+                <a:latin typeface="Inter" pitchFamily="34" charset="0"/>
+                <a:ea typeface="Inter" pitchFamily="34" charset="-122"/>
+                <a:cs typeface="Inter" pitchFamily="34" charset="-120"/>
+              </a:rPr>
+              <a:t>+33.9%</a:t>
+            </a:r>
+            <a:endParaRPr lang="en-US" sz="1600" dirty="0"/>
+          </a:p>
+        </p:txBody>
+      </p:sp>
+      <p:sp>
+        <p:nvSpPr>
+          <p:cNvPr id="25" name="Text 23"/>
+          <p:cNvSpPr txBox="1"/>
+          <p:nvPr/>
+        </p:nvSpPr>
+        <p:spPr>
+          <a:xfrm>
+            <a:off x="749808" y="4376318"/>
+            <a:ext cx="320040" cy="751637"/>
+          </a:xfrm>
+          <a:prstGeom prst="rect">
+            <a:avLst/>
+          </a:prstGeom>
+          <a:noFill/>
+          <a:ln/>
+        </p:spPr>
+        <p:txBody>
+          <a:bodyPr wrap="square" lIns="0" tIns="0" rIns="0" bIns="0" rtlCol="0" anchor="ctr"/>
+          <a:lstStyle/>
+          <a:p>
+            <a:pPr indent="0" marL="0">
+              <a:buNone/>
+            </a:pPr>
+            <a:r>
+              <a:rPr lang="en-US" sz="1500" b="1" dirty="0">
+                <a:solidFill>
+                  <a:srgbClr val="0B2C4A"/>
+                </a:solidFill>
+                <a:latin typeface="Inter" pitchFamily="34" charset="0"/>
+                <a:ea typeface="Inter" pitchFamily="34" charset="-122"/>
+                <a:cs typeface="Inter" pitchFamily="34" charset="-120"/>
+              </a:rPr>
+              <a:t>4</a:t>
+            </a:r>
+            <a:endParaRPr lang="en-US" sz="1500" dirty="0"/>
+          </a:p>
+        </p:txBody>
+      </p:sp>
+      <p:sp>
+        <p:nvSpPr>
+          <p:cNvPr id="26" name="Text 24"/>
+          <p:cNvSpPr txBox="1"/>
+          <p:nvPr/>
+        </p:nvSpPr>
+        <p:spPr>
+          <a:xfrm>
+            <a:off x="1115568" y="4376318"/>
+            <a:ext cx="1737360" cy="751637"/>
+          </a:xfrm>
+          <a:prstGeom prst="rect">
+            <a:avLst/>
+          </a:prstGeom>
+          <a:noFill/>
+          <a:ln/>
+        </p:spPr>
+        <p:txBody>
+          <a:bodyPr wrap="square" lIns="0" tIns="0" rIns="0" bIns="0" rtlCol="0" anchor="ctr"/>
+          <a:lstStyle/>
+          <a:p>
+            <a:pPr indent="0" marL="0">
+              <a:buNone/>
+            </a:pPr>
+            <a:r>
+              <a:rPr lang="en-US" sz="1400" b="1" dirty="0">
+                <a:solidFill>
+                  <a:srgbClr val="1A1A1A"/>
+                </a:solidFill>
+                <a:latin typeface="Inter" pitchFamily="34" charset="0"/>
+                <a:ea typeface="Inter" pitchFamily="34" charset="-122"/>
+                <a:cs typeface="Inter" pitchFamily="34" charset="-120"/>
+              </a:rPr>
+              <a:t>Subaru Prescott</a:t>
+            </a:r>
+            <a:endParaRPr lang="en-US" sz="1400" dirty="0"/>
+          </a:p>
+        </p:txBody>
+      </p:sp>
+      <p:sp>
+        <p:nvSpPr>
+          <p:cNvPr id="27" name="Text 25"/>
+          <p:cNvSpPr txBox="1"/>
+          <p:nvPr/>
+        </p:nvSpPr>
+        <p:spPr>
+          <a:xfrm>
+            <a:off x="2898648" y="4376318"/>
+            <a:ext cx="1920240" cy="751637"/>
+          </a:xfrm>
+          <a:prstGeom prst="rect">
+            <a:avLst/>
+          </a:prstGeom>
+          <a:noFill/>
+          <a:ln/>
+        </p:spPr>
+        <p:txBody>
+          <a:bodyPr wrap="square" lIns="0" tIns="0" rIns="0" bIns="0" rtlCol="0" anchor="ctr"/>
+          <a:lstStyle/>
+          <a:p>
+            <a:pPr indent="0" marL="0">
+              <a:buNone/>
+            </a:pPr>
+            <a:r>
+              <a:rPr lang="en-US" sz="1400" dirty="0">
+                <a:solidFill>
+                  <a:srgbClr val="595959"/>
+                </a:solidFill>
+                <a:latin typeface="Inter" pitchFamily="34" charset="0"/>
+                <a:ea typeface="Inter" pitchFamily="34" charset="-122"/>
+                <a:cs typeface="Inter" pitchFamily="34" charset="-120"/>
+              </a:rPr>
+              <a:t>6,328  </a:t>
+            </a:r>
+            <a:pPr indent="0" marL="0">
+              <a:buNone/>
+            </a:pPr>
+            <a:r>
+              <a:rPr lang="en-US" sz="1400" b="1" dirty="0">
+                <a:solidFill>
+                  <a:srgbClr val="0B7A4A"/>
+                </a:solidFill>
+                <a:latin typeface="Inter" pitchFamily="34" charset="0"/>
+                <a:ea typeface="Inter" pitchFamily="34" charset="-122"/>
+                <a:cs typeface="Inter" pitchFamily="34" charset="-120"/>
+              </a:rPr>
+              <a:t>→  </a:t>
+            </a:r>
+            <a:pPr indent="0" marL="0">
+              <a:buNone/>
+            </a:pPr>
+            <a:r>
+              <a:rPr lang="en-US" sz="1400" b="1" dirty="0">
+                <a:solidFill>
+                  <a:srgbClr val="0B7A4A"/>
+                </a:solidFill>
+                <a:latin typeface="Inter" pitchFamily="34" charset="0"/>
+                <a:ea typeface="Inter" pitchFamily="34" charset="-122"/>
+                <a:cs typeface="Inter" pitchFamily="34" charset="-120"/>
+              </a:rPr>
+              <a:t>8,154</a:t>
+            </a:r>
+            <a:endParaRPr lang="en-US" sz="1400" dirty="0"/>
+          </a:p>
+        </p:txBody>
+      </p:sp>
+      <p:sp>
+        <p:nvSpPr>
+          <p:cNvPr id="28" name="Text 26"/>
+          <p:cNvSpPr txBox="1"/>
+          <p:nvPr/>
+        </p:nvSpPr>
+        <p:spPr>
+          <a:xfrm>
+            <a:off x="4864608" y="4376318"/>
+            <a:ext cx="1051560" cy="751637"/>
+          </a:xfrm>
+          <a:prstGeom prst="rect">
+            <a:avLst/>
+          </a:prstGeom>
+          <a:noFill/>
+          <a:ln/>
+        </p:spPr>
+        <p:txBody>
+          <a:bodyPr wrap="square" lIns="0" tIns="0" rIns="0" bIns="0" rtlCol="0" anchor="ctr"/>
+          <a:lstStyle/>
+          <a:p>
+            <a:pPr algn="r" indent="0" marL="0">
+              <a:buNone/>
+            </a:pPr>
+            <a:r>
+              <a:rPr lang="en-US" sz="1600" b="1" dirty="0">
+                <a:solidFill>
+                  <a:srgbClr val="0B7A4A"/>
+                </a:solidFill>
+                <a:latin typeface="Inter" pitchFamily="34" charset="0"/>
+                <a:ea typeface="Inter" pitchFamily="34" charset="-122"/>
+                <a:cs typeface="Inter" pitchFamily="34" charset="-120"/>
+              </a:rPr>
+              <a:t>+28.9%</a:t>
+            </a:r>
+            <a:endParaRPr lang="en-US" sz="1600" dirty="0"/>
+          </a:p>
+        </p:txBody>
+      </p:sp>
+      <p:sp>
+        <p:nvSpPr>
+          <p:cNvPr id="29" name="Shape 27"/>
+          <p:cNvSpPr/>
+          <p:nvPr/>
+        </p:nvSpPr>
+        <p:spPr>
+          <a:xfrm>
+            <a:off x="658368" y="5127955"/>
+            <a:ext cx="5321808" cy="751637"/>
+          </a:xfrm>
+          <a:prstGeom prst="rect">
+            <a:avLst/>
+          </a:prstGeom>
+          <a:solidFill>
+            <a:srgbClr val="F7F7F7"/>
+          </a:solidFill>
+          <a:ln/>
+        </p:spPr>
+      </p:sp>
+      <p:sp>
+        <p:nvSpPr>
+          <p:cNvPr id="30" name="Text 28"/>
+          <p:cNvSpPr txBox="1"/>
+          <p:nvPr/>
+        </p:nvSpPr>
+        <p:spPr>
+          <a:xfrm>
+            <a:off x="749808" y="5127955"/>
+            <a:ext cx="320040" cy="751637"/>
+          </a:xfrm>
+          <a:prstGeom prst="rect">
+            <a:avLst/>
+          </a:prstGeom>
+          <a:noFill/>
+          <a:ln/>
+        </p:spPr>
+        <p:txBody>
+          <a:bodyPr wrap="square" lIns="0" tIns="0" rIns="0" bIns="0" rtlCol="0" anchor="ctr"/>
+          <a:lstStyle/>
+          <a:p>
+            <a:pPr indent="0" marL="0">
+              <a:buNone/>
+            </a:pPr>
+            <a:r>
+              <a:rPr lang="en-US" sz="1500" b="1" dirty="0">
+                <a:solidFill>
+                  <a:srgbClr val="0B2C4A"/>
+                </a:solidFill>
+                <a:latin typeface="Inter" pitchFamily="34" charset="0"/>
+                <a:ea typeface="Inter" pitchFamily="34" charset="-122"/>
+                <a:cs typeface="Inter" pitchFamily="34" charset="-120"/>
+              </a:rPr>
+              <a:t>5</a:t>
+            </a:r>
+            <a:endParaRPr lang="en-US" sz="1500" dirty="0"/>
+          </a:p>
+        </p:txBody>
+      </p:sp>
+      <p:sp>
+        <p:nvSpPr>
+          <p:cNvPr id="31" name="Text 29"/>
+          <p:cNvSpPr txBox="1"/>
+          <p:nvPr/>
+        </p:nvSpPr>
+        <p:spPr>
+          <a:xfrm>
+            <a:off x="1115568" y="5127955"/>
+            <a:ext cx="1737360" cy="751637"/>
+          </a:xfrm>
+          <a:prstGeom prst="rect">
+            <a:avLst/>
+          </a:prstGeom>
+          <a:noFill/>
+          <a:ln/>
+        </p:spPr>
+        <p:txBody>
+          <a:bodyPr wrap="square" lIns="0" tIns="0" rIns="0" bIns="0" rtlCol="0" anchor="ctr"/>
+          <a:lstStyle/>
+          <a:p>
+            <a:pPr indent="0" marL="0">
+              <a:buNone/>
+            </a:pPr>
+            <a:r>
+              <a:rPr lang="en-US" sz="1400" b="1" dirty="0">
+                <a:solidFill>
+                  <a:srgbClr val="1A1A1A"/>
+                </a:solidFill>
+                <a:latin typeface="Inter" pitchFamily="34" charset="0"/>
+                <a:ea typeface="Inter" pitchFamily="34" charset="-122"/>
+                <a:cs typeface="Inter" pitchFamily="34" charset="-120"/>
+              </a:rPr>
+              <a:t>Hyundai Prescott</a:t>
+            </a:r>
+            <a:endParaRPr lang="en-US" sz="1400" dirty="0"/>
+          </a:p>
+        </p:txBody>
+      </p:sp>
+      <p:sp>
+        <p:nvSpPr>
+          <p:cNvPr id="32" name="Text 30"/>
+          <p:cNvSpPr txBox="1"/>
+          <p:nvPr/>
+        </p:nvSpPr>
+        <p:spPr>
+          <a:xfrm>
+            <a:off x="2898648" y="5127955"/>
+            <a:ext cx="1920240" cy="751637"/>
+          </a:xfrm>
+          <a:prstGeom prst="rect">
+            <a:avLst/>
+          </a:prstGeom>
+          <a:noFill/>
+          <a:ln/>
+        </p:spPr>
+        <p:txBody>
+          <a:bodyPr wrap="square" lIns="0" tIns="0" rIns="0" bIns="0" rtlCol="0" anchor="ctr"/>
+          <a:lstStyle/>
+          <a:p>
+            <a:pPr indent="0" marL="0">
+              <a:buNone/>
+            </a:pPr>
+            <a:r>
+              <a:rPr lang="en-US" sz="1400" dirty="0">
+                <a:solidFill>
+                  <a:srgbClr val="595959"/>
+                </a:solidFill>
+                <a:latin typeface="Inter" pitchFamily="34" charset="0"/>
+                <a:ea typeface="Inter" pitchFamily="34" charset="-122"/>
+                <a:cs typeface="Inter" pitchFamily="34" charset="-120"/>
+              </a:rPr>
+              <a:t>2,566  </a:t>
+            </a:r>
+            <a:pPr indent="0" marL="0">
+              <a:buNone/>
+            </a:pPr>
+            <a:r>
+              <a:rPr lang="en-US" sz="1400" b="1" dirty="0">
+                <a:solidFill>
+                  <a:srgbClr val="0B7A4A"/>
+                </a:solidFill>
+                <a:latin typeface="Inter" pitchFamily="34" charset="0"/>
+                <a:ea typeface="Inter" pitchFamily="34" charset="-122"/>
+                <a:cs typeface="Inter" pitchFamily="34" charset="-120"/>
+              </a:rPr>
+              <a:t>→  </a:t>
+            </a:r>
+            <a:pPr indent="0" marL="0">
+              <a:buNone/>
+            </a:pPr>
+            <a:r>
+              <a:rPr lang="en-US" sz="1400" b="1" dirty="0">
+                <a:solidFill>
+                  <a:srgbClr val="0B7A4A"/>
+                </a:solidFill>
+                <a:latin typeface="Inter" pitchFamily="34" charset="0"/>
+                <a:ea typeface="Inter" pitchFamily="34" charset="-122"/>
+                <a:cs typeface="Inter" pitchFamily="34" charset="-120"/>
+              </a:rPr>
+              <a:t>3,287</a:t>
+            </a:r>
+            <a:endParaRPr lang="en-US" sz="1400" dirty="0"/>
+          </a:p>
+        </p:txBody>
+      </p:sp>
+      <p:sp>
+        <p:nvSpPr>
+          <p:cNvPr id="33" name="Text 31"/>
+          <p:cNvSpPr txBox="1"/>
+          <p:nvPr/>
+        </p:nvSpPr>
+        <p:spPr>
+          <a:xfrm>
+            <a:off x="4864608" y="5127955"/>
+            <a:ext cx="1051560" cy="751637"/>
+          </a:xfrm>
+          <a:prstGeom prst="rect">
+            <a:avLst/>
+          </a:prstGeom>
+          <a:noFill/>
+          <a:ln/>
+        </p:spPr>
+        <p:txBody>
+          <a:bodyPr wrap="square" lIns="0" tIns="0" rIns="0" bIns="0" rtlCol="0" anchor="ctr"/>
+          <a:lstStyle/>
+          <a:p>
+            <a:pPr algn="r" indent="0" marL="0">
+              <a:buNone/>
+            </a:pPr>
+            <a:r>
+              <a:rPr lang="en-US" sz="1600" b="1" dirty="0">
+                <a:solidFill>
+                  <a:srgbClr val="0B7A4A"/>
+                </a:solidFill>
+                <a:latin typeface="Inter" pitchFamily="34" charset="0"/>
+                <a:ea typeface="Inter" pitchFamily="34" charset="-122"/>
+                <a:cs typeface="Inter" pitchFamily="34" charset="-120"/>
+              </a:rPr>
+              <a:t>+28.1%</a:t>
+            </a:r>
+            <a:endParaRPr lang="en-US" sz="1600" dirty="0"/>
+          </a:p>
+        </p:txBody>
+      </p:sp>
+      <p:sp>
+        <p:nvSpPr>
+          <p:cNvPr id="34" name="Shape 32"/>
+          <p:cNvSpPr/>
+          <p:nvPr/>
+        </p:nvSpPr>
+        <p:spPr>
+          <a:xfrm>
+            <a:off x="6208776" y="1737360"/>
+            <a:ext cx="5321808" cy="45720"/>
+          </a:xfrm>
+          <a:prstGeom prst="rect">
+            <a:avLst/>
+          </a:prstGeom>
+          <a:solidFill>
+            <a:srgbClr val="C2352F"/>
+          </a:solidFill>
+          <a:ln/>
+        </p:spPr>
+      </p:sp>
+      <p:sp>
+        <p:nvSpPr>
+          <p:cNvPr id="35" name="Text 33"/>
+          <p:cNvSpPr txBox="1"/>
+          <p:nvPr/>
+        </p:nvSpPr>
+        <p:spPr>
+          <a:xfrm>
+            <a:off x="6300216" y="1810512"/>
+            <a:ext cx="1828800" cy="274320"/>
+          </a:xfrm>
+          <a:prstGeom prst="rect">
+            <a:avLst/>
+          </a:prstGeom>
+          <a:noFill/>
+          <a:ln/>
+        </p:spPr>
+        <p:txBody>
+          <a:bodyPr wrap="square" lIns="0" tIns="0" rIns="0" bIns="0" rtlCol="0" anchor="ctr"/>
+          <a:lstStyle/>
+          <a:p>
+            <a:pPr indent="0" marL="0">
+              <a:buNone/>
+            </a:pPr>
+            <a:r>
+              <a:rPr lang="en-US" sz="1400" b="1" spc="100" kern="0" dirty="0">
+                <a:solidFill>
+                  <a:srgbClr val="A82B26"/>
+                </a:solidFill>
+                <a:latin typeface="Inter" pitchFamily="34" charset="0"/>
+                <a:ea typeface="Inter" pitchFamily="34" charset="-122"/>
+                <a:cs typeface="Inter" pitchFamily="34" charset="-120"/>
+              </a:rPr>
+              <a:t>BOTTOM 5</a:t>
+            </a:r>
+            <a:endParaRPr lang="en-US" sz="1400" dirty="0"/>
+          </a:p>
+        </p:txBody>
+      </p:sp>
+      <p:sp>
+        <p:nvSpPr>
+          <p:cNvPr id="36" name="Text 34"/>
+          <p:cNvSpPr txBox="1"/>
+          <p:nvPr/>
+        </p:nvSpPr>
+        <p:spPr>
+          <a:xfrm>
+            <a:off x="8449056" y="1810512"/>
+            <a:ext cx="1828800" cy="274320"/>
+          </a:xfrm>
+          <a:prstGeom prst="rect">
+            <a:avLst/>
+          </a:prstGeom>
+          <a:noFill/>
+          <a:ln/>
+        </p:spPr>
+        <p:txBody>
+          <a:bodyPr wrap="square" lIns="0" tIns="0" rIns="0" bIns="0" rtlCol="0" anchor="ctr"/>
+          <a:lstStyle/>
+          <a:p>
+            <a:pPr indent="0" marL="0">
+              <a:buNone/>
+            </a:pPr>
+            <a:r>
+              <a:rPr lang="en-US" sz="1400" b="1" dirty="0">
+                <a:solidFill>
+                  <a:srgbClr val="595959"/>
+                </a:solidFill>
+                <a:latin typeface="Inter" pitchFamily="34" charset="0"/>
+                <a:ea typeface="Inter" pitchFamily="34" charset="-122"/>
+                <a:cs typeface="Inter" pitchFamily="34" charset="-120"/>
+              </a:rPr>
+              <a:t>2025 → 2026</a:t>
+            </a:r>
+            <a:endParaRPr lang="en-US" sz="1400" dirty="0"/>
+          </a:p>
+        </p:txBody>
+      </p:sp>
+      <p:sp>
+        <p:nvSpPr>
+          <p:cNvPr id="37" name="Text 35"/>
+          <p:cNvSpPr txBox="1"/>
+          <p:nvPr/>
+        </p:nvSpPr>
+        <p:spPr>
+          <a:xfrm>
+            <a:off x="10415016" y="1810512"/>
+            <a:ext cx="1051560" cy="274320"/>
+          </a:xfrm>
+          <a:prstGeom prst="rect">
+            <a:avLst/>
+          </a:prstGeom>
+          <a:noFill/>
+          <a:ln/>
+        </p:spPr>
+        <p:txBody>
+          <a:bodyPr wrap="square" lIns="0" tIns="0" rIns="0" bIns="0" rtlCol="0" anchor="ctr"/>
+          <a:lstStyle/>
+          <a:p>
+            <a:pPr algn="r" indent="0" marL="0">
+              <a:buNone/>
+            </a:pPr>
+            <a:r>
+              <a:rPr lang="en-US" sz="1400" b="1" dirty="0">
+                <a:solidFill>
+                  <a:srgbClr val="595959"/>
+                </a:solidFill>
+                <a:latin typeface="Inter" pitchFamily="34" charset="0"/>
+                <a:ea typeface="Inter" pitchFamily="34" charset="-122"/>
+                <a:cs typeface="Inter" pitchFamily="34" charset="-120"/>
+              </a:rPr>
+              <a:t>Change</a:t>
+            </a:r>
+            <a:endParaRPr lang="en-US" sz="1400" dirty="0"/>
+          </a:p>
+        </p:txBody>
+      </p:sp>
+      <p:sp>
+        <p:nvSpPr>
+          <p:cNvPr id="38" name="Shape 36"/>
+          <p:cNvSpPr/>
+          <p:nvPr/>
+        </p:nvSpPr>
+        <p:spPr>
+          <a:xfrm>
+            <a:off x="6208776" y="2121408"/>
+            <a:ext cx="5321808" cy="751637"/>
+          </a:xfrm>
+          <a:prstGeom prst="rect">
+            <a:avLst/>
+          </a:prstGeom>
+          <a:solidFill>
+            <a:srgbClr val="F7F7F7"/>
+          </a:solidFill>
+          <a:ln/>
+        </p:spPr>
+      </p:sp>
+      <p:sp>
+        <p:nvSpPr>
+          <p:cNvPr id="39" name="Text 37"/>
+          <p:cNvSpPr txBox="1"/>
+          <p:nvPr/>
+        </p:nvSpPr>
+        <p:spPr>
+          <a:xfrm>
+            <a:off x="6300216" y="2121408"/>
+            <a:ext cx="320040" cy="751637"/>
+          </a:xfrm>
+          <a:prstGeom prst="rect">
+            <a:avLst/>
+          </a:prstGeom>
+          <a:noFill/>
+          <a:ln/>
+        </p:spPr>
+        <p:txBody>
+          <a:bodyPr wrap="square" lIns="0" tIns="0" rIns="0" bIns="0" rtlCol="0" anchor="ctr"/>
+          <a:lstStyle/>
+          <a:p>
+            <a:pPr indent="0" marL="0">
+              <a:buNone/>
+            </a:pPr>
+            <a:r>
+              <a:rPr lang="en-US" sz="1500" b="1" dirty="0">
+                <a:solidFill>
+                  <a:srgbClr val="0B2C4A"/>
+                </a:solidFill>
+                <a:latin typeface="Inter" pitchFamily="34" charset="0"/>
+                <a:ea typeface="Inter" pitchFamily="34" charset="-122"/>
+                <a:cs typeface="Inter" pitchFamily="34" charset="-120"/>
+              </a:rPr>
+              <a:t>33</a:t>
+            </a:r>
+            <a:endParaRPr lang="en-US" sz="1500" dirty="0"/>
+          </a:p>
+        </p:txBody>
+      </p:sp>
+      <p:sp>
+        <p:nvSpPr>
+          <p:cNvPr id="40" name="Text 38"/>
+          <p:cNvSpPr txBox="1"/>
+          <p:nvPr/>
+        </p:nvSpPr>
+        <p:spPr>
+          <a:xfrm>
+            <a:off x="6665976" y="2121408"/>
+            <a:ext cx="1737360" cy="751637"/>
+          </a:xfrm>
+          <a:prstGeom prst="rect">
+            <a:avLst/>
+          </a:prstGeom>
+          <a:noFill/>
+          <a:ln/>
+        </p:spPr>
+        <p:txBody>
+          <a:bodyPr wrap="square" lIns="0" tIns="0" rIns="0" bIns="0" rtlCol="0" anchor="ctr"/>
+          <a:lstStyle/>
+          <a:p>
+            <a:pPr indent="0" marL="0">
+              <a:buNone/>
+            </a:pPr>
+            <a:r>
+              <a:rPr lang="en-US" sz="1400" b="1" dirty="0">
+                <a:solidFill>
+                  <a:srgbClr val="1A1A1A"/>
+                </a:solidFill>
+                <a:latin typeface="Inter" pitchFamily="34" charset="0"/>
+                <a:ea typeface="Inter" pitchFamily="34" charset="-122"/>
+                <a:cs typeface="Inter" pitchFamily="34" charset="-120"/>
+              </a:rPr>
+              <a:t>VW St George</a:t>
+            </a:r>
+            <a:endParaRPr lang="en-US" sz="1400" dirty="0"/>
+          </a:p>
+        </p:txBody>
+      </p:sp>
+      <p:sp>
+        <p:nvSpPr>
+          <p:cNvPr id="41" name="Text 39"/>
+          <p:cNvSpPr txBox="1"/>
+          <p:nvPr/>
+        </p:nvSpPr>
+        <p:spPr>
+          <a:xfrm>
+            <a:off x="8449056" y="2121408"/>
+            <a:ext cx="1920240" cy="751637"/>
+          </a:xfrm>
+          <a:prstGeom prst="rect">
+            <a:avLst/>
+          </a:prstGeom>
+          <a:noFill/>
+          <a:ln/>
+        </p:spPr>
+        <p:txBody>
+          <a:bodyPr wrap="square" lIns="0" tIns="0" rIns="0" bIns="0" rtlCol="0" anchor="ctr"/>
+          <a:lstStyle/>
+          <a:p>
+            <a:pPr indent="0" marL="0">
+              <a:buNone/>
+            </a:pPr>
+            <a:r>
+              <a:rPr lang="en-US" sz="1400" dirty="0">
+                <a:solidFill>
+                  <a:srgbClr val="595959"/>
+                </a:solidFill>
+                <a:latin typeface="Inter" pitchFamily="34" charset="0"/>
+                <a:ea typeface="Inter" pitchFamily="34" charset="-122"/>
+                <a:cs typeface="Inter" pitchFamily="34" charset="-120"/>
+              </a:rPr>
+              <a:t>4,394  </a:t>
+            </a:r>
+            <a:pPr indent="0" marL="0">
+              <a:buNone/>
+            </a:pPr>
+            <a:r>
+              <a:rPr lang="en-US" sz="1400" b="1" dirty="0">
+                <a:solidFill>
+                  <a:srgbClr val="A82B26"/>
+                </a:solidFill>
+                <a:latin typeface="Inter" pitchFamily="34" charset="0"/>
+                <a:ea typeface="Inter" pitchFamily="34" charset="-122"/>
+                <a:cs typeface="Inter" pitchFamily="34" charset="-120"/>
+              </a:rPr>
+              <a:t>→  </a:t>
+            </a:r>
+            <a:pPr indent="0" marL="0">
+              <a:buNone/>
+            </a:pPr>
+            <a:r>
+              <a:rPr lang="en-US" sz="1400" b="1" dirty="0">
+                <a:solidFill>
+                  <a:srgbClr val="A82B26"/>
+                </a:solidFill>
+                <a:latin typeface="Inter" pitchFamily="34" charset="0"/>
+                <a:ea typeface="Inter" pitchFamily="34" charset="-122"/>
+                <a:cs typeface="Inter" pitchFamily="34" charset="-120"/>
+              </a:rPr>
+              <a:t>3,276</a:t>
+            </a:r>
+            <a:endParaRPr lang="en-US" sz="1400" dirty="0"/>
+          </a:p>
+        </p:txBody>
+      </p:sp>
+      <p:sp>
+        <p:nvSpPr>
+          <p:cNvPr id="42" name="Text 40"/>
+          <p:cNvSpPr txBox="1"/>
+          <p:nvPr/>
+        </p:nvSpPr>
+        <p:spPr>
+          <a:xfrm>
+            <a:off x="10415016" y="2121408"/>
+            <a:ext cx="1051560" cy="751637"/>
+          </a:xfrm>
+          <a:prstGeom prst="rect">
+            <a:avLst/>
+          </a:prstGeom>
+          <a:noFill/>
+          <a:ln/>
+        </p:spPr>
+        <p:txBody>
+          <a:bodyPr wrap="square" lIns="0" tIns="0" rIns="0" bIns="0" rtlCol="0" anchor="ctr"/>
+          <a:lstStyle/>
+          <a:p>
+            <a:pPr algn="r" indent="0" marL="0">
+              <a:buNone/>
+            </a:pPr>
+            <a:r>
+              <a:rPr lang="en-US" sz="1600" b="1" dirty="0">
+                <a:solidFill>
+                  <a:srgbClr val="A82B26"/>
+                </a:solidFill>
+                <a:latin typeface="Inter" pitchFamily="34" charset="0"/>
+                <a:ea typeface="Inter" pitchFamily="34" charset="-122"/>
+                <a:cs typeface="Inter" pitchFamily="34" charset="-120"/>
+              </a:rPr>
+              <a:t>−25.4%</a:t>
+            </a:r>
+            <a:endParaRPr lang="en-US" sz="1600" dirty="0"/>
+          </a:p>
+        </p:txBody>
+      </p:sp>
+      <p:sp>
+        <p:nvSpPr>
+          <p:cNvPr id="43" name="Text 41"/>
+          <p:cNvSpPr txBox="1"/>
+          <p:nvPr/>
+        </p:nvSpPr>
+        <p:spPr>
+          <a:xfrm>
+            <a:off x="6300216" y="2873045"/>
+            <a:ext cx="320040" cy="751637"/>
+          </a:xfrm>
+          <a:prstGeom prst="rect">
+            <a:avLst/>
+          </a:prstGeom>
+          <a:noFill/>
+          <a:ln/>
+        </p:spPr>
+        <p:txBody>
+          <a:bodyPr wrap="square" lIns="0" tIns="0" rIns="0" bIns="0" rtlCol="0" anchor="ctr"/>
+          <a:lstStyle/>
+          <a:p>
+            <a:pPr indent="0" marL="0">
+              <a:buNone/>
+            </a:pPr>
+            <a:r>
+              <a:rPr lang="en-US" sz="1500" b="1" dirty="0">
+                <a:solidFill>
+                  <a:srgbClr val="0B2C4A"/>
+                </a:solidFill>
+                <a:latin typeface="Inter" pitchFamily="34" charset="0"/>
+                <a:ea typeface="Inter" pitchFamily="34" charset="-122"/>
+                <a:cs typeface="Inter" pitchFamily="34" charset="-120"/>
+              </a:rPr>
+              <a:t>32</a:t>
+            </a:r>
+            <a:endParaRPr lang="en-US" sz="1500" dirty="0"/>
+          </a:p>
+        </p:txBody>
+      </p:sp>
+      <p:sp>
+        <p:nvSpPr>
+          <p:cNvPr id="44" name="Text 42"/>
+          <p:cNvSpPr txBox="1"/>
+          <p:nvPr/>
+        </p:nvSpPr>
+        <p:spPr>
+          <a:xfrm>
+            <a:off x="6665976" y="2873045"/>
+            <a:ext cx="1737360" cy="751637"/>
+          </a:xfrm>
+          <a:prstGeom prst="rect">
+            <a:avLst/>
+          </a:prstGeom>
+          <a:noFill/>
+          <a:ln/>
+        </p:spPr>
+        <p:txBody>
+          <a:bodyPr wrap="square" lIns="0" tIns="0" rIns="0" bIns="0" rtlCol="0" anchor="ctr"/>
+          <a:lstStyle/>
+          <a:p>
+            <a:pPr indent="0" marL="0">
+              <a:buNone/>
+            </a:pPr>
+            <a:r>
+              <a:rPr lang="en-US" sz="1400" b="1" dirty="0">
+                <a:solidFill>
+                  <a:srgbClr val="1A1A1A"/>
+                </a:solidFill>
+                <a:latin typeface="Inter" pitchFamily="34" charset="0"/>
+                <a:ea typeface="Inter" pitchFamily="34" charset="-122"/>
+                <a:cs typeface="Inter" pitchFamily="34" charset="-120"/>
+              </a:rPr>
+              <a:t>Audi Reno</a:t>
+            </a:r>
+            <a:endParaRPr lang="en-US" sz="1400" dirty="0"/>
+          </a:p>
+        </p:txBody>
+      </p:sp>
+      <p:sp>
+        <p:nvSpPr>
+          <p:cNvPr id="45" name="Text 43"/>
+          <p:cNvSpPr txBox="1"/>
+          <p:nvPr/>
+        </p:nvSpPr>
+        <p:spPr>
+          <a:xfrm>
+            <a:off x="8449056" y="2873045"/>
+            <a:ext cx="1920240" cy="751637"/>
+          </a:xfrm>
+          <a:prstGeom prst="rect">
+            <a:avLst/>
+          </a:prstGeom>
+          <a:noFill/>
+          <a:ln/>
+        </p:spPr>
+        <p:txBody>
+          <a:bodyPr wrap="square" lIns="0" tIns="0" rIns="0" bIns="0" rtlCol="0" anchor="ctr"/>
+          <a:lstStyle/>
+          <a:p>
+            <a:pPr indent="0" marL="0">
+              <a:buNone/>
+            </a:pPr>
+            <a:r>
+              <a:rPr lang="en-US" sz="1400" dirty="0">
+                <a:solidFill>
+                  <a:srgbClr val="595959"/>
+                </a:solidFill>
+                <a:latin typeface="Inter" pitchFamily="34" charset="0"/>
+                <a:ea typeface="Inter" pitchFamily="34" charset="-122"/>
+                <a:cs typeface="Inter" pitchFamily="34" charset="-120"/>
+              </a:rPr>
+              <a:t>12,611  </a:t>
+            </a:r>
+            <a:pPr indent="0" marL="0">
+              <a:buNone/>
+            </a:pPr>
+            <a:r>
+              <a:rPr lang="en-US" sz="1400" b="1" dirty="0">
+                <a:solidFill>
+                  <a:srgbClr val="A82B26"/>
+                </a:solidFill>
+                <a:latin typeface="Inter" pitchFamily="34" charset="0"/>
+                <a:ea typeface="Inter" pitchFamily="34" charset="-122"/>
+                <a:cs typeface="Inter" pitchFamily="34" charset="-120"/>
+              </a:rPr>
+              <a:t>→  </a:t>
+            </a:r>
+            <a:pPr indent="0" marL="0">
+              <a:buNone/>
+            </a:pPr>
+            <a:r>
+              <a:rPr lang="en-US" sz="1400" b="1" dirty="0">
+                <a:solidFill>
+                  <a:srgbClr val="A82B26"/>
+                </a:solidFill>
+                <a:latin typeface="Inter" pitchFamily="34" charset="0"/>
+                <a:ea typeface="Inter" pitchFamily="34" charset="-122"/>
+                <a:cs typeface="Inter" pitchFamily="34" charset="-120"/>
+              </a:rPr>
+              <a:t>10,684</a:t>
+            </a:r>
+            <a:endParaRPr lang="en-US" sz="1400" dirty="0"/>
+          </a:p>
+        </p:txBody>
+      </p:sp>
+      <p:sp>
+        <p:nvSpPr>
+          <p:cNvPr id="46" name="Text 44"/>
+          <p:cNvSpPr txBox="1"/>
+          <p:nvPr/>
+        </p:nvSpPr>
+        <p:spPr>
+          <a:xfrm>
+            <a:off x="10415016" y="2873045"/>
+            <a:ext cx="1051560" cy="751637"/>
+          </a:xfrm>
+          <a:prstGeom prst="rect">
+            <a:avLst/>
+          </a:prstGeom>
+          <a:noFill/>
+          <a:ln/>
+        </p:spPr>
+        <p:txBody>
+          <a:bodyPr wrap="square" lIns="0" tIns="0" rIns="0" bIns="0" rtlCol="0" anchor="ctr"/>
+          <a:lstStyle/>
+          <a:p>
+            <a:pPr algn="r" indent="0" marL="0">
+              <a:buNone/>
+            </a:pPr>
+            <a:r>
+              <a:rPr lang="en-US" sz="1600" b="1" dirty="0">
+                <a:solidFill>
+                  <a:srgbClr val="A82B26"/>
+                </a:solidFill>
+                <a:latin typeface="Inter" pitchFamily="34" charset="0"/>
+                <a:ea typeface="Inter" pitchFamily="34" charset="-122"/>
+                <a:cs typeface="Inter" pitchFamily="34" charset="-120"/>
+              </a:rPr>
+              <a:t>−15.3%</a:t>
+            </a:r>
+            <a:endParaRPr lang="en-US" sz="1600" dirty="0"/>
+          </a:p>
+        </p:txBody>
+      </p:sp>
+      <p:sp>
+        <p:nvSpPr>
+          <p:cNvPr id="47" name="Shape 45"/>
+          <p:cNvSpPr/>
+          <p:nvPr/>
+        </p:nvSpPr>
+        <p:spPr>
+          <a:xfrm>
+            <a:off x="6208776" y="3624682"/>
+            <a:ext cx="5321808" cy="751637"/>
+          </a:xfrm>
+          <a:prstGeom prst="rect">
+            <a:avLst/>
+          </a:prstGeom>
+          <a:solidFill>
+            <a:srgbClr val="F7F7F7"/>
+          </a:solidFill>
+          <a:ln/>
+        </p:spPr>
+      </p:sp>
+      <p:sp>
+        <p:nvSpPr>
+          <p:cNvPr id="48" name="Text 46"/>
+          <p:cNvSpPr txBox="1"/>
+          <p:nvPr/>
+        </p:nvSpPr>
+        <p:spPr>
+          <a:xfrm>
+            <a:off x="6300216" y="3624682"/>
+            <a:ext cx="320040" cy="751637"/>
+          </a:xfrm>
+          <a:prstGeom prst="rect">
+            <a:avLst/>
+          </a:prstGeom>
+          <a:noFill/>
+          <a:ln/>
+        </p:spPr>
+        <p:txBody>
+          <a:bodyPr wrap="square" lIns="0" tIns="0" rIns="0" bIns="0" rtlCol="0" anchor="ctr"/>
+          <a:lstStyle/>
+          <a:p>
+            <a:pPr indent="0" marL="0">
+              <a:buNone/>
+            </a:pPr>
+            <a:r>
+              <a:rPr lang="en-US" sz="1500" b="1" dirty="0">
+                <a:solidFill>
+                  <a:srgbClr val="0B2C4A"/>
+                </a:solidFill>
+                <a:latin typeface="Inter" pitchFamily="34" charset="0"/>
+                <a:ea typeface="Inter" pitchFamily="34" charset="-122"/>
+                <a:cs typeface="Inter" pitchFamily="34" charset="-120"/>
+              </a:rPr>
+              <a:t>31</a:t>
+            </a:r>
+            <a:endParaRPr lang="en-US" sz="1500" dirty="0"/>
+          </a:p>
+        </p:txBody>
+      </p:sp>
+      <p:sp>
+        <p:nvSpPr>
+          <p:cNvPr id="49" name="Text 47"/>
+          <p:cNvSpPr txBox="1"/>
+          <p:nvPr/>
+        </p:nvSpPr>
+        <p:spPr>
+          <a:xfrm>
+            <a:off x="6665976" y="3624682"/>
+            <a:ext cx="1737360" cy="751637"/>
+          </a:xfrm>
+          <a:prstGeom prst="rect">
+            <a:avLst/>
+          </a:prstGeom>
+          <a:noFill/>
+          <a:ln/>
+        </p:spPr>
+        <p:txBody>
+          <a:bodyPr wrap="square" lIns="0" tIns="0" rIns="0" bIns="0" rtlCol="0" anchor="ctr"/>
+          <a:lstStyle/>
+          <a:p>
+            <a:pPr indent="0" marL="0">
+              <a:buNone/>
+            </a:pPr>
+            <a:r>
+              <a:rPr lang="en-US" sz="1400" b="1" dirty="0">
+                <a:solidFill>
+                  <a:srgbClr val="1A1A1A"/>
+                </a:solidFill>
+                <a:latin typeface="Inter" pitchFamily="34" charset="0"/>
+                <a:ea typeface="Inter" pitchFamily="34" charset="-122"/>
+                <a:cs typeface="Inter" pitchFamily="34" charset="-120"/>
+              </a:rPr>
+              <a:t>Volvo</a:t>
+            </a:r>
+            <a:endParaRPr lang="en-US" sz="1400" dirty="0"/>
+          </a:p>
+        </p:txBody>
+      </p:sp>
+      <p:sp>
+        <p:nvSpPr>
+          <p:cNvPr id="50" name="Text 48"/>
+          <p:cNvSpPr txBox="1"/>
+          <p:nvPr/>
+        </p:nvSpPr>
+        <p:spPr>
+          <a:xfrm>
+            <a:off x="8449056" y="3624682"/>
+            <a:ext cx="1920240" cy="751637"/>
+          </a:xfrm>
+          <a:prstGeom prst="rect">
+            <a:avLst/>
+          </a:prstGeom>
+          <a:noFill/>
+          <a:ln/>
+        </p:spPr>
+        <p:txBody>
+          <a:bodyPr wrap="square" lIns="0" tIns="0" rIns="0" bIns="0" rtlCol="0" anchor="ctr"/>
+          <a:lstStyle/>
+          <a:p>
+            <a:pPr indent="0" marL="0">
+              <a:buNone/>
+            </a:pPr>
+            <a:r>
+              <a:rPr lang="en-US" sz="1400" dirty="0">
+                <a:solidFill>
+                  <a:srgbClr val="595959"/>
+                </a:solidFill>
+                <a:latin typeface="Inter" pitchFamily="34" charset="0"/>
+                <a:ea typeface="Inter" pitchFamily="34" charset="-122"/>
+                <a:cs typeface="Inter" pitchFamily="34" charset="-120"/>
+              </a:rPr>
+              <a:t>8,659  </a:t>
+            </a:r>
+            <a:pPr indent="0" marL="0">
+              <a:buNone/>
+            </a:pPr>
+            <a:r>
+              <a:rPr lang="en-US" sz="1400" b="1" dirty="0">
+                <a:solidFill>
+                  <a:srgbClr val="A82B26"/>
+                </a:solidFill>
+                <a:latin typeface="Inter" pitchFamily="34" charset="0"/>
+                <a:ea typeface="Inter" pitchFamily="34" charset="-122"/>
+                <a:cs typeface="Inter" pitchFamily="34" charset="-120"/>
+              </a:rPr>
+              <a:t>→  </a:t>
+            </a:r>
+            <a:pPr indent="0" marL="0">
+              <a:buNone/>
+            </a:pPr>
+            <a:r>
+              <a:rPr lang="en-US" sz="1400" b="1" dirty="0">
+                <a:solidFill>
+                  <a:srgbClr val="A82B26"/>
+                </a:solidFill>
+                <a:latin typeface="Inter" pitchFamily="34" charset="0"/>
+                <a:ea typeface="Inter" pitchFamily="34" charset="-122"/>
+                <a:cs typeface="Inter" pitchFamily="34" charset="-120"/>
+              </a:rPr>
+              <a:t>7,749</a:t>
+            </a:r>
+            <a:endParaRPr lang="en-US" sz="1400" dirty="0"/>
+          </a:p>
+        </p:txBody>
+      </p:sp>
+      <p:sp>
+        <p:nvSpPr>
+          <p:cNvPr id="51" name="Text 49"/>
+          <p:cNvSpPr txBox="1"/>
+          <p:nvPr/>
+        </p:nvSpPr>
+        <p:spPr>
+          <a:xfrm>
+            <a:off x="10415016" y="3624682"/>
+            <a:ext cx="1051560" cy="751637"/>
+          </a:xfrm>
+          <a:prstGeom prst="rect">
+            <a:avLst/>
+          </a:prstGeom>
+          <a:noFill/>
+          <a:ln/>
+        </p:spPr>
+        <p:txBody>
+          <a:bodyPr wrap="square" lIns="0" tIns="0" rIns="0" bIns="0" rtlCol="0" anchor="ctr"/>
+          <a:lstStyle/>
+          <a:p>
+            <a:pPr algn="r" indent="0" marL="0">
+              <a:buNone/>
+            </a:pPr>
+            <a:r>
+              <a:rPr lang="en-US" sz="1600" b="1" dirty="0">
+                <a:solidFill>
+                  <a:srgbClr val="A82B26"/>
+                </a:solidFill>
+                <a:latin typeface="Inter" pitchFamily="34" charset="0"/>
+                <a:ea typeface="Inter" pitchFamily="34" charset="-122"/>
+                <a:cs typeface="Inter" pitchFamily="34" charset="-120"/>
+              </a:rPr>
+              <a:t>−10.5%</a:t>
+            </a:r>
+            <a:endParaRPr lang="en-US" sz="1600" dirty="0"/>
+          </a:p>
+        </p:txBody>
+      </p:sp>
+      <p:sp>
+        <p:nvSpPr>
+          <p:cNvPr id="52" name="Text 50"/>
+          <p:cNvSpPr txBox="1"/>
+          <p:nvPr/>
+        </p:nvSpPr>
+        <p:spPr>
+          <a:xfrm>
+            <a:off x="6300216" y="4376318"/>
+            <a:ext cx="320040" cy="751637"/>
+          </a:xfrm>
+          <a:prstGeom prst="rect">
+            <a:avLst/>
+          </a:prstGeom>
+          <a:noFill/>
+          <a:ln/>
+        </p:spPr>
+        <p:txBody>
+          <a:bodyPr wrap="square" lIns="0" tIns="0" rIns="0" bIns="0" rtlCol="0" anchor="ctr"/>
+          <a:lstStyle/>
+          <a:p>
+            <a:pPr indent="0" marL="0">
+              <a:buNone/>
+            </a:pPr>
+            <a:r>
+              <a:rPr lang="en-US" sz="1500" b="1" dirty="0">
+                <a:solidFill>
+                  <a:srgbClr val="0B2C4A"/>
+                </a:solidFill>
+                <a:latin typeface="Inter" pitchFamily="34" charset="0"/>
+                <a:ea typeface="Inter" pitchFamily="34" charset="-122"/>
+                <a:cs typeface="Inter" pitchFamily="34" charset="-120"/>
+              </a:rPr>
+              <a:t>30</a:t>
+            </a:r>
+            <a:endParaRPr lang="en-US" sz="1500" dirty="0"/>
+          </a:p>
+        </p:txBody>
+      </p:sp>
+      <p:sp>
+        <p:nvSpPr>
+          <p:cNvPr id="53" name="Text 51"/>
+          <p:cNvSpPr txBox="1"/>
+          <p:nvPr/>
+        </p:nvSpPr>
+        <p:spPr>
+          <a:xfrm>
+            <a:off x="6665976" y="4376318"/>
+            <a:ext cx="1737360" cy="751637"/>
+          </a:xfrm>
+          <a:prstGeom prst="rect">
+            <a:avLst/>
+          </a:prstGeom>
+          <a:noFill/>
+          <a:ln/>
+        </p:spPr>
+        <p:txBody>
+          <a:bodyPr wrap="square" lIns="0" tIns="0" rIns="0" bIns="0" rtlCol="0" anchor="ctr"/>
+          <a:lstStyle/>
+          <a:p>
+            <a:pPr indent="0" marL="0">
+              <a:buNone/>
+            </a:pPr>
+            <a:r>
+              <a:rPr lang="en-US" sz="1400" b="1" dirty="0">
+                <a:solidFill>
+                  <a:srgbClr val="1A1A1A"/>
+                </a:solidFill>
+                <a:latin typeface="Inter" pitchFamily="34" charset="0"/>
+                <a:ea typeface="Inter" pitchFamily="34" charset="-122"/>
+                <a:cs typeface="Inter" pitchFamily="34" charset="-120"/>
+              </a:rPr>
+              <a:t>Honda Spokane</a:t>
+            </a:r>
+            <a:endParaRPr lang="en-US" sz="1400" dirty="0"/>
+          </a:p>
+        </p:txBody>
+      </p:sp>
+      <p:sp>
+        <p:nvSpPr>
+          <p:cNvPr id="54" name="Text 52"/>
+          <p:cNvSpPr txBox="1"/>
+          <p:nvPr/>
+        </p:nvSpPr>
+        <p:spPr>
+          <a:xfrm>
+            <a:off x="8449056" y="4376318"/>
+            <a:ext cx="1920240" cy="751637"/>
+          </a:xfrm>
+          <a:prstGeom prst="rect">
+            <a:avLst/>
+          </a:prstGeom>
+          <a:noFill/>
+          <a:ln/>
+        </p:spPr>
+        <p:txBody>
+          <a:bodyPr wrap="square" lIns="0" tIns="0" rIns="0" bIns="0" rtlCol="0" anchor="ctr"/>
+          <a:lstStyle/>
+          <a:p>
+            <a:pPr indent="0" marL="0">
+              <a:buNone/>
+            </a:pPr>
+            <a:r>
+              <a:rPr lang="en-US" sz="1400" dirty="0">
+                <a:solidFill>
+                  <a:srgbClr val="595959"/>
+                </a:solidFill>
+                <a:latin typeface="Inter" pitchFamily="34" charset="0"/>
+                <a:ea typeface="Inter" pitchFamily="34" charset="-122"/>
+                <a:cs typeface="Inter" pitchFamily="34" charset="-120"/>
+              </a:rPr>
+              <a:t>19,520  </a:t>
+            </a:r>
+            <a:pPr indent="0" marL="0">
+              <a:buNone/>
+            </a:pPr>
+            <a:r>
+              <a:rPr lang="en-US" sz="1400" b="1" dirty="0">
+                <a:solidFill>
+                  <a:srgbClr val="A82B26"/>
+                </a:solidFill>
+                <a:latin typeface="Inter" pitchFamily="34" charset="0"/>
+                <a:ea typeface="Inter" pitchFamily="34" charset="-122"/>
+                <a:cs typeface="Inter" pitchFamily="34" charset="-120"/>
+              </a:rPr>
+              <a:t>→  </a:t>
+            </a:r>
+            <a:pPr indent="0" marL="0">
+              <a:buNone/>
+            </a:pPr>
+            <a:r>
+              <a:rPr lang="en-US" sz="1400" b="1" dirty="0">
+                <a:solidFill>
+                  <a:srgbClr val="A82B26"/>
+                </a:solidFill>
+                <a:latin typeface="Inter" pitchFamily="34" charset="0"/>
+                <a:ea typeface="Inter" pitchFamily="34" charset="-122"/>
+                <a:cs typeface="Inter" pitchFamily="34" charset="-120"/>
+              </a:rPr>
+              <a:t>17,926</a:t>
+            </a:r>
+            <a:endParaRPr lang="en-US" sz="1400" dirty="0"/>
+          </a:p>
+        </p:txBody>
+      </p:sp>
+      <p:sp>
+        <p:nvSpPr>
+          <p:cNvPr id="55" name="Text 53"/>
+          <p:cNvSpPr txBox="1"/>
+          <p:nvPr/>
+        </p:nvSpPr>
+        <p:spPr>
+          <a:xfrm>
+            <a:off x="10415016" y="4376318"/>
+            <a:ext cx="1051560" cy="751637"/>
+          </a:xfrm>
+          <a:prstGeom prst="rect">
+            <a:avLst/>
+          </a:prstGeom>
+          <a:noFill/>
+          <a:ln/>
+        </p:spPr>
+        <p:txBody>
+          <a:bodyPr wrap="square" lIns="0" tIns="0" rIns="0" bIns="0" rtlCol="0" anchor="ctr"/>
+          <a:lstStyle/>
+          <a:p>
+            <a:pPr algn="r" indent="0" marL="0">
+              <a:buNone/>
+            </a:pPr>
+            <a:r>
+              <a:rPr lang="en-US" sz="1600" b="1" dirty="0">
+                <a:solidFill>
+                  <a:srgbClr val="A82B26"/>
+                </a:solidFill>
+                <a:latin typeface="Inter" pitchFamily="34" charset="0"/>
+                <a:ea typeface="Inter" pitchFamily="34" charset="-122"/>
+                <a:cs typeface="Inter" pitchFamily="34" charset="-120"/>
+              </a:rPr>
+              <a:t>−8.2%</a:t>
+            </a:r>
+            <a:endParaRPr lang="en-US" sz="1600" dirty="0"/>
+          </a:p>
+        </p:txBody>
+      </p:sp>
+      <p:sp>
+        <p:nvSpPr>
+          <p:cNvPr id="56" name="Shape 54"/>
+          <p:cNvSpPr/>
+          <p:nvPr/>
+        </p:nvSpPr>
+        <p:spPr>
+          <a:xfrm>
+            <a:off x="6208776" y="5127955"/>
+            <a:ext cx="5321808" cy="751637"/>
+          </a:xfrm>
+          <a:prstGeom prst="rect">
+            <a:avLst/>
+          </a:prstGeom>
+          <a:solidFill>
+            <a:srgbClr val="F7F7F7"/>
+          </a:solidFill>
+          <a:ln/>
+        </p:spPr>
+      </p:sp>
+      <p:sp>
+        <p:nvSpPr>
+          <p:cNvPr id="57" name="Text 55"/>
+          <p:cNvSpPr txBox="1"/>
+          <p:nvPr/>
+        </p:nvSpPr>
+        <p:spPr>
+          <a:xfrm>
+            <a:off x="6300216" y="5127955"/>
+            <a:ext cx="320040" cy="751637"/>
+          </a:xfrm>
+          <a:prstGeom prst="rect">
+            <a:avLst/>
+          </a:prstGeom>
+          <a:noFill/>
+          <a:ln/>
+        </p:spPr>
+        <p:txBody>
+          <a:bodyPr wrap="square" lIns="0" tIns="0" rIns="0" bIns="0" rtlCol="0" anchor="ctr"/>
+          <a:lstStyle/>
+          <a:p>
+            <a:pPr indent="0" marL="0">
+              <a:buNone/>
+            </a:pPr>
+            <a:r>
+              <a:rPr lang="en-US" sz="1500" b="1" dirty="0">
+                <a:solidFill>
+                  <a:srgbClr val="0B2C4A"/>
+                </a:solidFill>
+                <a:latin typeface="Inter" pitchFamily="34" charset="0"/>
+                <a:ea typeface="Inter" pitchFamily="34" charset="-122"/>
+                <a:cs typeface="Inter" pitchFamily="34" charset="-120"/>
+              </a:rPr>
+              <a:t>29</a:t>
+            </a:r>
+            <a:endParaRPr lang="en-US" sz="1500" dirty="0"/>
+          </a:p>
+        </p:txBody>
+      </p:sp>
+      <p:sp>
+        <p:nvSpPr>
+          <p:cNvPr id="58" name="Text 56"/>
+          <p:cNvSpPr txBox="1"/>
+          <p:nvPr/>
+        </p:nvSpPr>
+        <p:spPr>
+          <a:xfrm>
+            <a:off x="6665976" y="5127955"/>
+            <a:ext cx="1737360" cy="751637"/>
+          </a:xfrm>
+          <a:prstGeom prst="rect">
+            <a:avLst/>
+          </a:prstGeom>
+          <a:noFill/>
+          <a:ln/>
+        </p:spPr>
+        <p:txBody>
+          <a:bodyPr wrap="square" lIns="0" tIns="0" rIns="0" bIns="0" rtlCol="0" anchor="ctr"/>
+          <a:lstStyle/>
+          <a:p>
+            <a:pPr indent="0" marL="0">
+              <a:buNone/>
+            </a:pPr>
+            <a:r>
+              <a:rPr lang="en-US" sz="1400" b="1" dirty="0">
+                <a:solidFill>
+                  <a:srgbClr val="1A1A1A"/>
+                </a:solidFill>
+                <a:latin typeface="Inter" pitchFamily="34" charset="0"/>
+                <a:ea typeface="Inter" pitchFamily="34" charset="-122"/>
+                <a:cs typeface="Inter" pitchFamily="34" charset="-120"/>
+              </a:rPr>
+              <a:t>Chevy LV</a:t>
+            </a:r>
+            <a:endParaRPr lang="en-US" sz="1400" dirty="0"/>
+          </a:p>
+        </p:txBody>
+      </p:sp>
+      <p:sp>
+        <p:nvSpPr>
+          <p:cNvPr id="59" name="Text 57"/>
+          <p:cNvSpPr txBox="1"/>
+          <p:nvPr/>
+        </p:nvSpPr>
+        <p:spPr>
+          <a:xfrm>
+            <a:off x="8449056" y="5127955"/>
+            <a:ext cx="1920240" cy="751637"/>
+          </a:xfrm>
+          <a:prstGeom prst="rect">
+            <a:avLst/>
+          </a:prstGeom>
+          <a:noFill/>
+          <a:ln/>
+        </p:spPr>
+        <p:txBody>
+          <a:bodyPr wrap="square" lIns="0" tIns="0" rIns="0" bIns="0" rtlCol="0" anchor="ctr"/>
+          <a:lstStyle/>
+          <a:p>
+            <a:pPr indent="0" marL="0">
+              <a:buNone/>
+            </a:pPr>
+            <a:r>
+              <a:rPr lang="en-US" sz="1400" dirty="0">
+                <a:solidFill>
+                  <a:srgbClr val="595959"/>
+                </a:solidFill>
+                <a:latin typeface="Inter" pitchFamily="34" charset="0"/>
+                <a:ea typeface="Inter" pitchFamily="34" charset="-122"/>
+                <a:cs typeface="Inter" pitchFamily="34" charset="-120"/>
+              </a:rPr>
+              <a:t>48,486  </a:t>
+            </a:r>
+            <a:pPr indent="0" marL="0">
+              <a:buNone/>
+            </a:pPr>
+            <a:r>
+              <a:rPr lang="en-US" sz="1400" b="1" dirty="0">
+                <a:solidFill>
+                  <a:srgbClr val="A82B26"/>
+                </a:solidFill>
+                <a:latin typeface="Inter" pitchFamily="34" charset="0"/>
+                <a:ea typeface="Inter" pitchFamily="34" charset="-122"/>
+                <a:cs typeface="Inter" pitchFamily="34" charset="-120"/>
+              </a:rPr>
+              <a:t>→  </a:t>
+            </a:r>
+            <a:pPr indent="0" marL="0">
+              <a:buNone/>
+            </a:pPr>
+            <a:r>
+              <a:rPr lang="en-US" sz="1400" b="1" dirty="0">
+                <a:solidFill>
+                  <a:srgbClr val="A82B26"/>
+                </a:solidFill>
+                <a:latin typeface="Inter" pitchFamily="34" charset="0"/>
+                <a:ea typeface="Inter" pitchFamily="34" charset="-122"/>
+                <a:cs typeface="Inter" pitchFamily="34" charset="-120"/>
+              </a:rPr>
+              <a:t>44,883</a:t>
+            </a:r>
+            <a:endParaRPr lang="en-US" sz="1400" dirty="0"/>
+          </a:p>
+        </p:txBody>
+      </p:sp>
+      <p:sp>
+        <p:nvSpPr>
+          <p:cNvPr id="60" name="Text 58"/>
+          <p:cNvSpPr txBox="1"/>
+          <p:nvPr/>
+        </p:nvSpPr>
+        <p:spPr>
+          <a:xfrm>
+            <a:off x="10415016" y="5127955"/>
+            <a:ext cx="1051560" cy="751637"/>
+          </a:xfrm>
+          <a:prstGeom prst="rect">
+            <a:avLst/>
+          </a:prstGeom>
+          <a:noFill/>
+          <a:ln/>
+        </p:spPr>
+        <p:txBody>
+          <a:bodyPr wrap="square" lIns="0" tIns="0" rIns="0" bIns="0" rtlCol="0" anchor="ctr"/>
+          <a:lstStyle/>
+          <a:p>
+            <a:pPr algn="r" indent="0" marL="0">
+              <a:buNone/>
+            </a:pPr>
+            <a:r>
+              <a:rPr lang="en-US" sz="1600" b="1" dirty="0">
+                <a:solidFill>
+                  <a:srgbClr val="A82B26"/>
+                </a:solidFill>
+                <a:latin typeface="Inter" pitchFamily="34" charset="0"/>
+                <a:ea typeface="Inter" pitchFamily="34" charset="-122"/>
+                <a:cs typeface="Inter" pitchFamily="34" charset="-120"/>
+              </a:rPr>
+              <a:t>−7.4%</a:t>
+            </a:r>
+            <a:endParaRPr lang="en-US" sz="1600" dirty="0"/>
+          </a:p>
+        </p:txBody>
+      </p:sp>
+      <p:sp>
+        <p:nvSpPr>
+          <p:cNvPr id="61" name="Shape 59"/>
+          <p:cNvSpPr/>
+          <p:nvPr/>
+        </p:nvSpPr>
+        <p:spPr>
+          <a:xfrm>
+            <a:off x="457200" y="6126480"/>
+            <a:ext cx="11274552" cy="615696"/>
+          </a:xfrm>
+          <a:prstGeom prst="rect">
+            <a:avLst/>
+          </a:prstGeom>
+          <a:solidFill>
+            <a:srgbClr val="EDF4FA"/>
+          </a:solidFill>
+          <a:ln/>
+        </p:spPr>
+      </p:sp>
+      <p:sp>
+        <p:nvSpPr>
+          <p:cNvPr id="62" name="Text 60"/>
+          <p:cNvSpPr txBox="1"/>
+          <p:nvPr/>
+        </p:nvSpPr>
+        <p:spPr>
+          <a:xfrm>
+            <a:off x="658368" y="6144768"/>
+            <a:ext cx="10927080" cy="579120"/>
+          </a:xfrm>
+          <a:prstGeom prst="rect">
+            <a:avLst/>
+          </a:prstGeom>
+          <a:noFill/>
+          <a:ln/>
+        </p:spPr>
+        <p:txBody>
+          <a:bodyPr wrap="square" lIns="0" tIns="0" rIns="0" bIns="0" rtlCol="0" anchor="ctr"/>
+          <a:lstStyle/>
+          <a:p>
+            <a:pPr indent="0" marL="0">
+              <a:buNone/>
+            </a:pPr>
+            <a:r>
+              <a:rPr lang="en-US" sz="1600" b="1" dirty="0">
+                <a:solidFill>
+                  <a:srgbClr val="0B2C4A"/>
+                </a:solidFill>
+                <a:latin typeface="Inter" pitchFamily="34" charset="0"/>
+                <a:ea typeface="Inter" pitchFamily="34" charset="-122"/>
+                <a:cs typeface="Inter" pitchFamily="34" charset="-120"/>
+              </a:rPr>
+              <a:t>Ask Subaru St George, Kia LV and Kia St George what changed. Ask VW St George, Audi Reno and Volvo what got in the way.</a:t>
+            </a:r>
+            <a:endParaRPr lang="en-US" sz="1600" dirty="0"/>
+          </a:p>
+        </p:txBody>
+      </p:sp>
+    </p:spTree>
+  </p:cSld>
+  <p:clrMapOvr>
+    <a:masterClrMapping/>
+  </p:clrMapOvr>
+</p:sld>
+</file>
+
+<file path=ppt/slides/slide5.xml><?xml version="1.0" encoding="utf-8"?>
+<p:sld xmlns:a="http://schemas.openxmlformats.org/drawingml/2006/main" xmlns:r="http://schemas.openxmlformats.org/officeDocument/2006/relationships" xmlns:p="http://schemas.openxmlformats.org/presentationml/2006/main">
+  <p:cSld name="Slide 5">
+    <p:bg>
+      <p:bgPr>
+        <a:solidFill>
+          <a:srgbClr val="EDEDED"/>
+        </a:solidFill>
+      </p:bgPr>
+    </p:bg>
+    <p:spTree>
+      <p:nvGrpSpPr>
+        <p:cNvPr id="1" name=""/>
+        <p:cNvGrpSpPr/>
+        <p:nvPr/>
+      </p:nvGrpSpPr>
+      <p:grpSpPr>
+        <a:xfrm>
+          <a:off x="0" y="0"/>
+          <a:ext cx="0" cy="0"/>
+          <a:chOff x="0" y="0"/>
+          <a:chExt cx="0" cy="0"/>
+        </a:xfrm>
+      </p:grpSpPr>
+      <p:sp>
+        <p:nvSpPr>
+          <p:cNvPr id="2" name="Shape 0"/>
+          <p:cNvSpPr/>
+          <p:nvPr/>
+        </p:nvSpPr>
+        <p:spPr>
+          <a:xfrm>
+            <a:off x="457200" y="402336"/>
+            <a:ext cx="50292" cy="192024"/>
+          </a:xfrm>
+          <a:prstGeom prst="rect">
+            <a:avLst/>
+          </a:prstGeom>
+          <a:solidFill>
+            <a:srgbClr val="2587C5"/>
+          </a:solidFill>
+          <a:ln/>
+        </p:spPr>
+      </p:sp>
+      <p:sp>
+        <p:nvSpPr>
+          <p:cNvPr id="3" name="Text 1"/>
+          <p:cNvSpPr txBox="1"/>
+          <p:nvPr/>
+        </p:nvSpPr>
+        <p:spPr>
+          <a:xfrm>
+            <a:off x="621792" y="338328"/>
+            <a:ext cx="8229600" cy="274320"/>
+          </a:xfrm>
+          <a:prstGeom prst="rect">
+            <a:avLst/>
+          </a:prstGeom>
+          <a:noFill/>
+          <a:ln/>
+        </p:spPr>
+        <p:txBody>
+          <a:bodyPr wrap="square" lIns="0" tIns="0" rIns="0" bIns="0" rtlCol="0" anchor="ctr"/>
+          <a:lstStyle/>
+          <a:p>
+            <a:pPr indent="0" marL="0">
+              <a:buNone/>
+            </a:pPr>
+            <a:r>
+              <a:rPr lang="en-US" sz="1400" b="1" spc="110" kern="0" dirty="0">
+                <a:solidFill>
+                  <a:srgbClr val="595959"/>
+                </a:solidFill>
+                <a:latin typeface="Inter" pitchFamily="34" charset="0"/>
+                <a:ea typeface="Inter" pitchFamily="34" charset="-122"/>
+                <a:cs typeface="Inter" pitchFamily="34" charset="-120"/>
+              </a:rPr>
+              <a:t>CUSTOMER PAY</a:t>
             </a:r>
             <a:endParaRPr lang="en-US" sz="1400" dirty="0"/>
           </a:p>

</xml_diff>

<commit_message>
Blue bars on display-only store totals and warranty rate increases; green/red only for comparisons
Co-Authored-By: Claude Opus 5.5 <noreply@anthropic.com>
Claude-Session: https://claude.ai/code/session_01Xa4nFVxuQGXmHARGph9WhS
</commit_message>
<xml_diff>
--- a/day2-deck/decks/CP Hours & RO a Day - Review.pptx
+++ b/day2-deck/decks/CP Hours & RO a Day - Review.pptx
@@ -4355,7 +4355,7 @@
             <a:avLst/>
           </a:prstGeom>
           <a:solidFill>
-            <a:srgbClr val="12A566"/>
+            <a:srgbClr val="2587C5"/>
           </a:solidFill>
           <a:ln/>
         </p:spPr>
@@ -4492,7 +4492,7 @@
             <a:avLst/>
           </a:prstGeom>
           <a:solidFill>
-            <a:srgbClr val="12A566"/>
+            <a:srgbClr val="2587C5"/>
           </a:solidFill>
           <a:ln/>
         </p:spPr>
@@ -4629,7 +4629,7 @@
             <a:avLst/>
           </a:prstGeom>
           <a:solidFill>
-            <a:srgbClr val="12A566"/>
+            <a:srgbClr val="2587C5"/>
           </a:solidFill>
           <a:ln/>
         </p:spPr>
@@ -4766,7 +4766,7 @@
             <a:avLst/>
           </a:prstGeom>
           <a:solidFill>
-            <a:srgbClr val="12A566"/>
+            <a:srgbClr val="2587C5"/>
           </a:solidFill>
           <a:ln/>
         </p:spPr>
@@ -4903,7 +4903,7 @@
             <a:avLst/>
           </a:prstGeom>
           <a:solidFill>
-            <a:srgbClr val="12A566"/>
+            <a:srgbClr val="2587C5"/>
           </a:solidFill>
           <a:ln/>
         </p:spPr>
@@ -5040,7 +5040,7 @@
             <a:avLst/>
           </a:prstGeom>
           <a:solidFill>
-            <a:srgbClr val="12A566"/>
+            <a:srgbClr val="2587C5"/>
           </a:solidFill>
           <a:ln/>
         </p:spPr>
@@ -5177,7 +5177,7 @@
             <a:avLst/>
           </a:prstGeom>
           <a:solidFill>
-            <a:srgbClr val="12A566"/>
+            <a:srgbClr val="2587C5"/>
           </a:solidFill>
           <a:ln/>
         </p:spPr>
@@ -5314,7 +5314,7 @@
             <a:avLst/>
           </a:prstGeom>
           <a:solidFill>
-            <a:srgbClr val="12A566"/>
+            <a:srgbClr val="2587C5"/>
           </a:solidFill>
           <a:ln/>
         </p:spPr>
@@ -5451,7 +5451,7 @@
             <a:avLst/>
           </a:prstGeom>
           <a:solidFill>
-            <a:srgbClr val="12A566"/>
+            <a:srgbClr val="2587C5"/>
           </a:solidFill>
           <a:ln/>
         </p:spPr>
@@ -5588,7 +5588,7 @@
             <a:avLst/>
           </a:prstGeom>
           <a:solidFill>
-            <a:srgbClr val="12A566"/>
+            <a:srgbClr val="2587C5"/>
           </a:solidFill>
           <a:ln/>
         </p:spPr>
@@ -5725,7 +5725,7 @@
             <a:avLst/>
           </a:prstGeom>
           <a:solidFill>
-            <a:srgbClr val="12A566"/>
+            <a:srgbClr val="2587C5"/>
           </a:solidFill>
           <a:ln/>
         </p:spPr>
@@ -5862,7 +5862,7 @@
             <a:avLst/>
           </a:prstGeom>
           <a:solidFill>
-            <a:srgbClr val="12A566"/>
+            <a:srgbClr val="2587C5"/>
           </a:solidFill>
           <a:ln/>
         </p:spPr>
@@ -5999,7 +5999,7 @@
             <a:avLst/>
           </a:prstGeom>
           <a:solidFill>
-            <a:srgbClr val="12A566"/>
+            <a:srgbClr val="2587C5"/>
           </a:solidFill>
           <a:ln/>
         </p:spPr>
@@ -6136,7 +6136,7 @@
             <a:avLst/>
           </a:prstGeom>
           <a:solidFill>
-            <a:srgbClr val="12A566"/>
+            <a:srgbClr val="2587C5"/>
           </a:solidFill>
           <a:ln/>
         </p:spPr>
@@ -6273,7 +6273,7 @@
             <a:avLst/>
           </a:prstGeom>
           <a:solidFill>
-            <a:srgbClr val="12A566"/>
+            <a:srgbClr val="2587C5"/>
           </a:solidFill>
           <a:ln/>
         </p:spPr>
@@ -6410,7 +6410,7 @@
             <a:avLst/>
           </a:prstGeom>
           <a:solidFill>
-            <a:srgbClr val="12A566"/>
+            <a:srgbClr val="2587C5"/>
           </a:solidFill>
           <a:ln/>
         </p:spPr>
@@ -6547,7 +6547,7 @@
             <a:avLst/>
           </a:prstGeom>
           <a:solidFill>
-            <a:srgbClr val="12A566"/>
+            <a:srgbClr val="2587C5"/>
           </a:solidFill>
           <a:ln/>
         </p:spPr>
@@ -6684,7 +6684,7 @@
             <a:avLst/>
           </a:prstGeom>
           <a:solidFill>
-            <a:srgbClr val="12A566"/>
+            <a:srgbClr val="2587C5"/>
           </a:solidFill>
           <a:ln/>
         </p:spPr>
@@ -6821,7 +6821,7 @@
             <a:avLst/>
           </a:prstGeom>
           <a:solidFill>
-            <a:srgbClr val="12A566"/>
+            <a:srgbClr val="2587C5"/>
           </a:solidFill>
           <a:ln/>
         </p:spPr>
@@ -6958,7 +6958,7 @@
             <a:avLst/>
           </a:prstGeom>
           <a:solidFill>
-            <a:srgbClr val="12A566"/>
+            <a:srgbClr val="2587C5"/>
           </a:solidFill>
           <a:ln/>
         </p:spPr>
@@ -7095,7 +7095,7 @@
             <a:avLst/>
           </a:prstGeom>
           <a:solidFill>
-            <a:srgbClr val="12A566"/>
+            <a:srgbClr val="2587C5"/>
           </a:solidFill>
           <a:ln/>
         </p:spPr>
@@ -7232,7 +7232,7 @@
             <a:avLst/>
           </a:prstGeom>
           <a:solidFill>
-            <a:srgbClr val="12A566"/>
+            <a:srgbClr val="2587C5"/>
           </a:solidFill>
           <a:ln/>
         </p:spPr>
@@ -7369,7 +7369,7 @@
             <a:avLst/>
           </a:prstGeom>
           <a:solidFill>
-            <a:srgbClr val="12A566"/>
+            <a:srgbClr val="2587C5"/>
           </a:solidFill>
           <a:ln/>
         </p:spPr>
@@ -7506,7 +7506,7 @@
             <a:avLst/>
           </a:prstGeom>
           <a:solidFill>
-            <a:srgbClr val="12A566"/>
+            <a:srgbClr val="2587C5"/>
           </a:solidFill>
           <a:ln/>
         </p:spPr>
@@ -7643,7 +7643,7 @@
             <a:avLst/>
           </a:prstGeom>
           <a:solidFill>
-            <a:srgbClr val="12A566"/>
+            <a:srgbClr val="2587C5"/>
           </a:solidFill>
           <a:ln/>
         </p:spPr>
@@ -7780,7 +7780,7 @@
             <a:avLst/>
           </a:prstGeom>
           <a:solidFill>
-            <a:srgbClr val="12A566"/>
+            <a:srgbClr val="2587C5"/>
           </a:solidFill>
           <a:ln/>
         </p:spPr>
@@ -7917,7 +7917,7 @@
             <a:avLst/>
           </a:prstGeom>
           <a:solidFill>
-            <a:srgbClr val="12A566"/>
+            <a:srgbClr val="2587C5"/>
           </a:solidFill>
           <a:ln/>
         </p:spPr>
@@ -8054,7 +8054,7 @@
             <a:avLst/>
           </a:prstGeom>
           <a:solidFill>
-            <a:srgbClr val="12A566"/>
+            <a:srgbClr val="2587C5"/>
           </a:solidFill>
           <a:ln/>
         </p:spPr>
@@ -8191,7 +8191,7 @@
             <a:avLst/>
           </a:prstGeom>
           <a:solidFill>
-            <a:srgbClr val="12A566"/>
+            <a:srgbClr val="2587C5"/>
           </a:solidFill>
           <a:ln/>
         </p:spPr>
@@ -8328,7 +8328,7 @@
             <a:avLst/>
           </a:prstGeom>
           <a:solidFill>
-            <a:srgbClr val="12A566"/>
+            <a:srgbClr val="2587C5"/>
           </a:solidFill>
           <a:ln/>
         </p:spPr>
@@ -8465,7 +8465,7 @@
             <a:avLst/>
           </a:prstGeom>
           <a:solidFill>
-            <a:srgbClr val="12A566"/>
+            <a:srgbClr val="2587C5"/>
           </a:solidFill>
           <a:ln/>
         </p:spPr>
@@ -8602,7 +8602,7 @@
             <a:avLst/>
           </a:prstGeom>
           <a:solidFill>
-            <a:srgbClr val="12A566"/>
+            <a:srgbClr val="2587C5"/>
           </a:solidFill>
           <a:ln/>
         </p:spPr>
@@ -8739,7 +8739,7 @@
             <a:avLst/>
           </a:prstGeom>
           <a:solidFill>
-            <a:srgbClr val="12A566"/>
+            <a:srgbClr val="2587C5"/>
           </a:solidFill>
           <a:ln/>
         </p:spPr>

</xml_diff>

<commit_message>
Every top/bottom slide: top 5 and bottom 5 vs last year plus top 5 moving now (Jul-Sep vs Jan-Mar 2026)
Q1/Q3 2026 store inputs pulled from Qlik on each slide's original basis and
reconciled to every data file's 2026 months (pulls/mn). Productivity from build_prod.py.

Co-Authored-By: Claude Opus 5.5 <noreply@anthropic.com>
Claude-Session: https://claude.ai/code/session_01Xa4nFVxuQGXmHARGph9WhS
</commit_message>
<xml_diff>
--- a/day2-deck/decks/CP Hours & RO a Day - Review.pptx
+++ b/day2-deck/decks/CP Hours & RO a Day - Review.pptx
@@ -2639,7 +2639,7 @@
           <a:p>
             <a:r>
               <a:rPr lang="en-US" dirty="0"/>
-              <a:t>Source: Qlik - Closed Repair Orders. Customer pay, Jan-Sep by close date. Same-store, INEOS excluded (opened 2026). GMC Prescott body shop labor types excluded. Total customer-pay labor hours sold, all CP ROs. Top and bottom five stores by change in customer-pay hours sold (percent, so store size does not drive the ranking), Jan-Sep 2026 vs 2025.Conversation starter: each top store says one thing they started doing; each bottom store says what got in the way and what they would try. The room trades ideas.</a:t>
+              <a:t>Source: Qlik - Closed Repair Orders. Customer pay, Jan-Sep by close date. Same-store, INEOS excluded (opened 2026). GMC Prescott body shop labor types excluded. Total customer-pay labor hours sold, all CP ROs. Top and bottom five stores by change in customer-pay hours sold (percent, so store size does not drive the ranking), Jan-Sep 2026 vs 2025. Moving now: Jul-Sep 2026 vs Jan-Mar 2026, each store against itself (monthly averages); the group moved +5.5% on the same basis, so part of every store's change is seasonal.Conversation starter: each top store says one thing they started doing; each bottom store says what got in the way and what they would try. The room trades ideas. Moving now: ask the top three what they started this year.</a:t>
             </a:r>
             <a:endParaRPr lang="en-US" dirty="0"/>
           </a:p>
@@ -13961,53 +13961,14 @@
       </p:sp>
       <p:sp>
         <p:nvSpPr>
-          <p:cNvPr id="6" name="Text 4"/>
-          <p:cNvSpPr txBox="1"/>
-          <p:nvPr/>
-        </p:nvSpPr>
-        <p:spPr>
-          <a:xfrm>
-            <a:off x="713232" y="1298448"/>
-            <a:ext cx="10762488" cy="310896"/>
-          </a:xfrm>
-          <a:prstGeom prst="rect">
-            <a:avLst/>
-          </a:prstGeom>
-          <a:noFill/>
-          <a:ln/>
-        </p:spPr>
-        <p:txBody>
-          <a:bodyPr wrap="square" lIns="0" tIns="0" rIns="0" bIns="0" rtlCol="0" anchor="ctr"/>
-          <a:lstStyle/>
-          <a:p>
-            <a:pPr indent="0" marL="0">
-              <a:buNone/>
-            </a:pPr>
-            <a:r>
-              <a:rPr lang="en-US" sz="1400" dirty="0">
-                <a:solidFill>
-                  <a:srgbClr val="595959"/>
-                </a:solidFill>
-                <a:latin typeface="Inter" pitchFamily="34" charset="0"/>
-                <a:ea typeface="Inter" pitchFamily="34" charset="-122"/>
-                <a:cs typeface="Inter" pitchFamily="34" charset="-120"/>
-              </a:rPr>
-              <a:t>Jan–Sep 2026 against Jan–Sep 2025. Group 504,019 → 523,142 (+3.8%). Ranked by percent change.</a:t>
-            </a:r>
-            <a:endParaRPr lang="en-US" sz="1400" dirty="0"/>
-          </a:p>
-        </p:txBody>
-      </p:sp>
-      <p:sp>
-        <p:nvSpPr>
-          <p:cNvPr id="7" name="Shape 5"/>
+          <p:cNvPr id="6" name="Shape 4"/>
           <p:cNvSpPr/>
           <p:nvPr/>
         </p:nvSpPr>
         <p:spPr>
           <a:xfrm>
-            <a:off x="658368" y="1737360"/>
-            <a:ext cx="5321808" cy="45720"/>
+            <a:off x="658368" y="1371600"/>
+            <a:ext cx="3489960" cy="45720"/>
           </a:xfrm>
           <a:prstGeom prst="rect">
             <a:avLst/>
@@ -14020,14 +13981,53 @@
       </p:sp>
       <p:sp>
         <p:nvSpPr>
+          <p:cNvPr id="7" name="Text 5"/>
+          <p:cNvSpPr txBox="1"/>
+          <p:nvPr/>
+        </p:nvSpPr>
+        <p:spPr>
+          <a:xfrm>
+            <a:off x="749808" y="1444752"/>
+            <a:ext cx="3307080" cy="274320"/>
+          </a:xfrm>
+          <a:prstGeom prst="rect">
+            <a:avLst/>
+          </a:prstGeom>
+          <a:noFill/>
+          <a:ln/>
+        </p:spPr>
+        <p:txBody>
+          <a:bodyPr wrap="square" lIns="0" tIns="0" rIns="0" bIns="0" rtlCol="0" anchor="ctr"/>
+          <a:lstStyle/>
+          <a:p>
+            <a:pPr indent="0" marL="0">
+              <a:buNone/>
+            </a:pPr>
+            <a:r>
+              <a:rPr lang="en-US" sz="1500" b="1" spc="100" kern="0" dirty="0">
+                <a:solidFill>
+                  <a:srgbClr val="0B7A4A"/>
+                </a:solidFill>
+                <a:latin typeface="Inter" pitchFamily="34" charset="0"/>
+                <a:ea typeface="Inter" pitchFamily="34" charset="-122"/>
+                <a:cs typeface="Inter" pitchFamily="34" charset="-120"/>
+              </a:rPr>
+              <a:t>TOP 5 VS LAST YEAR</a:t>
+            </a:r>
+            <a:endParaRPr lang="en-US" sz="1500" dirty="0"/>
+          </a:p>
+        </p:txBody>
+      </p:sp>
+      <p:sp>
+        <p:nvSpPr>
           <p:cNvPr id="8" name="Text 6"/>
           <p:cNvSpPr txBox="1"/>
           <p:nvPr/>
         </p:nvSpPr>
         <p:spPr>
           <a:xfrm>
-            <a:off x="749808" y="1810512"/>
-            <a:ext cx="1828800" cy="274320"/>
+            <a:off x="749808" y="1737360"/>
+            <a:ext cx="3307080" cy="274320"/>
           </a:xfrm>
           <a:prstGeom prst="rect">
             <a:avLst/>
@@ -14043,46 +14043,7 @@
               <a:buNone/>
             </a:pPr>
             <a:r>
-              <a:rPr lang="en-US" sz="1400" b="1" spc="100" kern="0" dirty="0">
-                <a:solidFill>
-                  <a:srgbClr val="0B7A4A"/>
-                </a:solidFill>
-                <a:latin typeface="Inter" pitchFamily="34" charset="0"/>
-                <a:ea typeface="Inter" pitchFamily="34" charset="-122"/>
-                <a:cs typeface="Inter" pitchFamily="34" charset="-120"/>
-              </a:rPr>
-              <a:t>TOP 5</a:t>
-            </a:r>
-            <a:endParaRPr lang="en-US" sz="1400" dirty="0"/>
-          </a:p>
-        </p:txBody>
-      </p:sp>
-      <p:sp>
-        <p:nvSpPr>
-          <p:cNvPr id="9" name="Text 7"/>
-          <p:cNvSpPr txBox="1"/>
-          <p:nvPr/>
-        </p:nvSpPr>
-        <p:spPr>
-          <a:xfrm>
-            <a:off x="2898648" y="1810512"/>
-            <a:ext cx="1828800" cy="274320"/>
-          </a:xfrm>
-          <a:prstGeom prst="rect">
-            <a:avLst/>
-          </a:prstGeom>
-          <a:noFill/>
-          <a:ln/>
-        </p:spPr>
-        <p:txBody>
-          <a:bodyPr wrap="square" lIns="0" tIns="0" rIns="0" bIns="0" rtlCol="0" anchor="ctr"/>
-          <a:lstStyle/>
-          <a:p>
-            <a:pPr indent="0" marL="0">
-              <a:buNone/>
-            </a:pPr>
-            <a:r>
-              <a:rPr lang="en-US" sz="1400" b="1" dirty="0">
+              <a:rPr lang="en-US" sz="1200" dirty="0">
                 <a:solidFill>
                   <a:srgbClr val="595959"/>
                 </a:solidFill>
@@ -14090,61 +14051,22 @@
                 <a:ea typeface="Inter" pitchFamily="34" charset="-122"/>
                 <a:cs typeface="Inter" pitchFamily="34" charset="-120"/>
               </a:rPr>
-              <a:t>2025 → 2026</a:t>
-            </a:r>
-            <a:endParaRPr lang="en-US" sz="1400" dirty="0"/>
-          </a:p>
-        </p:txBody>
-      </p:sp>
-      <p:sp>
-        <p:nvSpPr>
-          <p:cNvPr id="10" name="Text 8"/>
-          <p:cNvSpPr txBox="1"/>
-          <p:nvPr/>
-        </p:nvSpPr>
-        <p:spPr>
-          <a:xfrm>
-            <a:off x="4864608" y="1810512"/>
-            <a:ext cx="1051560" cy="274320"/>
-          </a:xfrm>
-          <a:prstGeom prst="rect">
-            <a:avLst/>
-          </a:prstGeom>
-          <a:noFill/>
-          <a:ln/>
-        </p:spPr>
-        <p:txBody>
-          <a:bodyPr wrap="square" lIns="0" tIns="0" rIns="0" bIns="0" rtlCol="0" anchor="ctr"/>
-          <a:lstStyle/>
-          <a:p>
-            <a:pPr algn="r" indent="0" marL="0">
-              <a:buNone/>
-            </a:pPr>
-            <a:r>
-              <a:rPr lang="en-US" sz="1400" b="1" dirty="0">
-                <a:solidFill>
-                  <a:srgbClr val="595959"/>
-                </a:solidFill>
-                <a:latin typeface="Inter" pitchFamily="34" charset="0"/>
-                <a:ea typeface="Inter" pitchFamily="34" charset="-122"/>
-                <a:cs typeface="Inter" pitchFamily="34" charset="-120"/>
-              </a:rPr>
-              <a:t>Change</a:t>
-            </a:r>
-            <a:endParaRPr lang="en-US" sz="1400" dirty="0"/>
-          </a:p>
-        </p:txBody>
-      </p:sp>
-      <p:sp>
-        <p:nvSpPr>
-          <p:cNvPr id="11" name="Shape 9"/>
+              <a:t>Jan–Sep 2026 vs Jan–Sep 2025</a:t>
+            </a:r>
+            <a:endParaRPr lang="en-US" sz="1200" dirty="0"/>
+          </a:p>
+        </p:txBody>
+      </p:sp>
+      <p:sp>
+        <p:nvSpPr>
+          <p:cNvPr id="9" name="Shape 7"/>
           <p:cNvSpPr/>
           <p:nvPr/>
         </p:nvSpPr>
         <p:spPr>
           <a:xfrm>
-            <a:off x="658368" y="2121408"/>
-            <a:ext cx="5321808" cy="751637"/>
+            <a:off x="658368" y="2103120"/>
+            <a:ext cx="3489960" cy="755294"/>
           </a:xfrm>
           <a:prstGeom prst="rect">
             <a:avLst/>
@@ -14157,14 +14079,171 @@
       </p:sp>
       <p:sp>
         <p:nvSpPr>
+          <p:cNvPr id="10" name="Text 8"/>
+          <p:cNvSpPr txBox="1"/>
+          <p:nvPr/>
+        </p:nvSpPr>
+        <p:spPr>
+          <a:xfrm>
+            <a:off x="749808" y="2103120"/>
+            <a:ext cx="365760" cy="755294"/>
+          </a:xfrm>
+          <a:prstGeom prst="rect">
+            <a:avLst/>
+          </a:prstGeom>
+          <a:noFill/>
+          <a:ln/>
+        </p:spPr>
+        <p:txBody>
+          <a:bodyPr wrap="square" lIns="0" tIns="0" rIns="0" bIns="0" rtlCol="0" anchor="ctr"/>
+          <a:lstStyle/>
+          <a:p>
+            <a:pPr indent="0" marL="0">
+              <a:buNone/>
+            </a:pPr>
+            <a:r>
+              <a:rPr lang="en-US" sz="1500" b="1" dirty="0">
+                <a:solidFill>
+                  <a:srgbClr val="0B2C4A"/>
+                </a:solidFill>
+                <a:latin typeface="Inter" pitchFamily="34" charset="0"/>
+                <a:ea typeface="Inter" pitchFamily="34" charset="-122"/>
+                <a:cs typeface="Inter" pitchFamily="34" charset="-120"/>
+              </a:rPr>
+              <a:t>1</a:t>
+            </a:r>
+            <a:endParaRPr lang="en-US" sz="1500" dirty="0"/>
+          </a:p>
+        </p:txBody>
+      </p:sp>
+      <p:sp>
+        <p:nvSpPr>
+          <p:cNvPr id="11" name="Text 9"/>
+          <p:cNvSpPr txBox="1"/>
+          <p:nvPr/>
+        </p:nvSpPr>
+        <p:spPr>
+          <a:xfrm>
+            <a:off x="1097280" y="2103120"/>
+            <a:ext cx="1825752" cy="755294"/>
+          </a:xfrm>
+          <a:prstGeom prst="rect">
+            <a:avLst/>
+          </a:prstGeom>
+          <a:noFill/>
+          <a:ln/>
+        </p:spPr>
+        <p:txBody>
+          <a:bodyPr wrap="square" lIns="0" tIns="0" rIns="0" bIns="0" rtlCol="0" anchor="ctr"/>
+          <a:lstStyle/>
+          <a:p>
+            <a:pPr indent="0" marL="0">
+              <a:spcAft>
+                <a:spcPts val="200"/>
+              </a:spcAft>
+              <a:buNone/>
+            </a:pPr>
+            <a:r>
+              <a:rPr lang="en-US" sz="1400" b="1" dirty="0">
+                <a:solidFill>
+                  <a:srgbClr val="1A1A1A"/>
+                </a:solidFill>
+                <a:latin typeface="Inter" pitchFamily="34" charset="0"/>
+                <a:ea typeface="Inter" pitchFamily="34" charset="-122"/>
+                <a:cs typeface="Inter" pitchFamily="34" charset="-120"/>
+              </a:rPr>
+              <a:t>Subaru St George</a:t>
+            </a:r>
+            <a:endParaRPr lang="en-US" sz="1400" dirty="0"/>
+          </a:p>
+          <a:p>
+            <a:pPr indent="0" marL="0">
+              <a:spcAft>
+                <a:spcPts val="200"/>
+              </a:spcAft>
+              <a:buNone/>
+            </a:pPr>
+            <a:r>
+              <a:rPr lang="en-US" sz="1200" dirty="0">
+                <a:solidFill>
+                  <a:srgbClr val="595959"/>
+                </a:solidFill>
+                <a:latin typeface="Inter" pitchFamily="34" charset="0"/>
+                <a:ea typeface="Inter" pitchFamily="34" charset="-122"/>
+                <a:cs typeface="Inter" pitchFamily="34" charset="-120"/>
+              </a:rPr>
+              <a:t>8,827  →  </a:t>
+            </a:r>
+            <a:pPr indent="0" marL="0">
+              <a:spcAft>
+                <a:spcPts val="200"/>
+              </a:spcAft>
+              <a:buNone/>
+            </a:pPr>
+            <a:r>
+              <a:rPr lang="en-US" sz="1200" b="1" dirty="0">
+                <a:solidFill>
+                  <a:srgbClr val="0B7A4A"/>
+                </a:solidFill>
+                <a:latin typeface="Inter" pitchFamily="34" charset="0"/>
+                <a:ea typeface="Inter" pitchFamily="34" charset="-122"/>
+                <a:cs typeface="Inter" pitchFamily="34" charset="-120"/>
+              </a:rPr>
+              <a:t>12,766</a:t>
+            </a:r>
+            <a:endParaRPr lang="en-US" sz="1400" dirty="0"/>
+          </a:p>
+        </p:txBody>
+      </p:sp>
+      <p:sp>
+        <p:nvSpPr>
           <p:cNvPr id="12" name="Text 10"/>
           <p:cNvSpPr txBox="1"/>
           <p:nvPr/>
         </p:nvSpPr>
         <p:spPr>
           <a:xfrm>
-            <a:off x="749808" y="2121408"/>
-            <a:ext cx="320040" cy="751637"/>
+            <a:off x="2941320" y="2103120"/>
+            <a:ext cx="1115568" cy="755294"/>
+          </a:xfrm>
+          <a:prstGeom prst="rect">
+            <a:avLst/>
+          </a:prstGeom>
+          <a:noFill/>
+          <a:ln/>
+        </p:spPr>
+        <p:txBody>
+          <a:bodyPr wrap="square" lIns="0" tIns="0" rIns="0" bIns="0" rtlCol="0" anchor="ctr"/>
+          <a:lstStyle/>
+          <a:p>
+            <a:pPr algn="r" indent="0" marL="0">
+              <a:buNone/>
+            </a:pPr>
+            <a:r>
+              <a:rPr lang="en-US" sz="1600" b="1" dirty="0">
+                <a:solidFill>
+                  <a:srgbClr val="0B7A4A"/>
+                </a:solidFill>
+                <a:latin typeface="Inter" pitchFamily="34" charset="0"/>
+                <a:ea typeface="Inter" pitchFamily="34" charset="-122"/>
+                <a:cs typeface="Inter" pitchFamily="34" charset="-120"/>
+              </a:rPr>
+              <a:t>+44.6%</a:t>
+            </a:r>
+            <a:endParaRPr lang="en-US" sz="1600" dirty="0"/>
+          </a:p>
+        </p:txBody>
+      </p:sp>
+      <p:sp>
+        <p:nvSpPr>
+          <p:cNvPr id="13" name="Text 11"/>
+          <p:cNvSpPr txBox="1"/>
+          <p:nvPr/>
+        </p:nvSpPr>
+        <p:spPr>
+          <a:xfrm>
+            <a:off x="749808" y="2858414"/>
+            <a:ext cx="365760" cy="755294"/>
           </a:xfrm>
           <a:prstGeom prst="rect">
             <a:avLst/>
@@ -14188,7 +14267,7 @@
                 <a:ea typeface="Inter" pitchFamily="34" charset="-122"/>
                 <a:cs typeface="Inter" pitchFamily="34" charset="-120"/>
               </a:rPr>
-              <a:t>1</a:t>
+              <a:t>2</a:t>
             </a:r>
             <a:endParaRPr lang="en-US" sz="1500" dirty="0"/>
           </a:p>
@@ -14196,14 +14275,14 @@
       </p:sp>
       <p:sp>
         <p:nvSpPr>
-          <p:cNvPr id="13" name="Text 11"/>
-          <p:cNvSpPr txBox="1"/>
-          <p:nvPr/>
-        </p:nvSpPr>
-        <p:spPr>
-          <a:xfrm>
-            <a:off x="1115568" y="2121408"/>
-            <a:ext cx="1737360" cy="751637"/>
+          <p:cNvPr id="14" name="Text 12"/>
+          <p:cNvSpPr txBox="1"/>
+          <p:nvPr/>
+        </p:nvSpPr>
+        <p:spPr>
+          <a:xfrm>
+            <a:off x="1097280" y="2858414"/>
+            <a:ext cx="1825752" cy="755294"/>
           </a:xfrm>
           <a:prstGeom prst="rect">
             <a:avLst/>
@@ -14216,6 +14295,9 @@
           <a:lstStyle/>
           <a:p>
             <a:pPr indent="0" marL="0">
+              <a:spcAft>
+                <a:spcPts val="200"/>
+              </a:spcAft>
               <a:buNone/>
             </a:pPr>
             <a:r>
@@ -14227,38 +14309,19 @@
                 <a:ea typeface="Inter" pitchFamily="34" charset="-122"/>
                 <a:cs typeface="Inter" pitchFamily="34" charset="-120"/>
               </a:rPr>
-              <a:t>Subaru St George</a:t>
+              <a:t>Kia LV</a:t>
             </a:r>
             <a:endParaRPr lang="en-US" sz="1400" dirty="0"/>
           </a:p>
-        </p:txBody>
-      </p:sp>
-      <p:sp>
-        <p:nvSpPr>
-          <p:cNvPr id="14" name="Text 12"/>
-          <p:cNvSpPr txBox="1"/>
-          <p:nvPr/>
-        </p:nvSpPr>
-        <p:spPr>
-          <a:xfrm>
-            <a:off x="2898648" y="2121408"/>
-            <a:ext cx="1920240" cy="751637"/>
-          </a:xfrm>
-          <a:prstGeom prst="rect">
-            <a:avLst/>
-          </a:prstGeom>
-          <a:noFill/>
-          <a:ln/>
-        </p:spPr>
-        <p:txBody>
-          <a:bodyPr wrap="square" lIns="0" tIns="0" rIns="0" bIns="0" rtlCol="0" anchor="ctr"/>
-          <a:lstStyle/>
           <a:p>
             <a:pPr indent="0" marL="0">
-              <a:buNone/>
-            </a:pPr>
-            <a:r>
-              <a:rPr lang="en-US" sz="1400" dirty="0">
+              <a:spcAft>
+                <a:spcPts val="200"/>
+              </a:spcAft>
+              <a:buNone/>
+            </a:pPr>
+            <a:r>
+              <a:rPr lang="en-US" sz="1200" dirty="0">
                 <a:solidFill>
                   <a:srgbClr val="595959"/>
                 </a:solidFill>
@@ -14266,13 +14329,16 @@
                 <a:ea typeface="Inter" pitchFamily="34" charset="-122"/>
                 <a:cs typeface="Inter" pitchFamily="34" charset="-120"/>
               </a:rPr>
-              <a:t>8,827  </a:t>
+              <a:t>9,453  →  </a:t>
             </a:r>
             <a:pPr indent="0" marL="0">
-              <a:buNone/>
-            </a:pPr>
-            <a:r>
-              <a:rPr lang="en-US" sz="1400" b="1" dirty="0">
+              <a:spcAft>
+                <a:spcPts val="200"/>
+              </a:spcAft>
+              <a:buNone/>
+            </a:pPr>
+            <a:r>
+              <a:rPr lang="en-US" sz="1200" b="1" dirty="0">
                 <a:solidFill>
                   <a:srgbClr val="0B7A4A"/>
                 </a:solidFill>
@@ -14280,13 +14346,38 @@
                 <a:ea typeface="Inter" pitchFamily="34" charset="-122"/>
                 <a:cs typeface="Inter" pitchFamily="34" charset="-120"/>
               </a:rPr>
-              <a:t>→  </a:t>
-            </a:r>
-            <a:pPr indent="0" marL="0">
-              <a:buNone/>
-            </a:pPr>
-            <a:r>
-              <a:rPr lang="en-US" sz="1400" b="1" dirty="0">
+              <a:t>12,757</a:t>
+            </a:r>
+            <a:endParaRPr lang="en-US" sz="1400" dirty="0"/>
+          </a:p>
+        </p:txBody>
+      </p:sp>
+      <p:sp>
+        <p:nvSpPr>
+          <p:cNvPr id="15" name="Text 13"/>
+          <p:cNvSpPr txBox="1"/>
+          <p:nvPr/>
+        </p:nvSpPr>
+        <p:spPr>
+          <a:xfrm>
+            <a:off x="2941320" y="2858414"/>
+            <a:ext cx="1115568" cy="755294"/>
+          </a:xfrm>
+          <a:prstGeom prst="rect">
+            <a:avLst/>
+          </a:prstGeom>
+          <a:noFill/>
+          <a:ln/>
+        </p:spPr>
+        <p:txBody>
+          <a:bodyPr wrap="square" lIns="0" tIns="0" rIns="0" bIns="0" rtlCol="0" anchor="ctr"/>
+          <a:lstStyle/>
+          <a:p>
+            <a:pPr algn="r" indent="0" marL="0">
+              <a:buNone/>
+            </a:pPr>
+            <a:r>
+              <a:rPr lang="en-US" sz="1600" b="1" dirty="0">
                 <a:solidFill>
                   <a:srgbClr val="0B7A4A"/>
                 </a:solidFill>
@@ -14294,46 +14385,7 @@
                 <a:ea typeface="Inter" pitchFamily="34" charset="-122"/>
                 <a:cs typeface="Inter" pitchFamily="34" charset="-120"/>
               </a:rPr>
-              <a:t>12,766</a:t>
-            </a:r>
-            <a:endParaRPr lang="en-US" sz="1400" dirty="0"/>
-          </a:p>
-        </p:txBody>
-      </p:sp>
-      <p:sp>
-        <p:nvSpPr>
-          <p:cNvPr id="15" name="Text 13"/>
-          <p:cNvSpPr txBox="1"/>
-          <p:nvPr/>
-        </p:nvSpPr>
-        <p:spPr>
-          <a:xfrm>
-            <a:off x="4864608" y="2121408"/>
-            <a:ext cx="1051560" cy="751637"/>
-          </a:xfrm>
-          <a:prstGeom prst="rect">
-            <a:avLst/>
-          </a:prstGeom>
-          <a:noFill/>
-          <a:ln/>
-        </p:spPr>
-        <p:txBody>
-          <a:bodyPr wrap="square" lIns="0" tIns="0" rIns="0" bIns="0" rtlCol="0" anchor="ctr"/>
-          <a:lstStyle/>
-          <a:p>
-            <a:pPr algn="r" indent="0" marL="0">
-              <a:buNone/>
-            </a:pPr>
-            <a:r>
-              <a:rPr lang="en-US" sz="1600" b="1" dirty="0">
-                <a:solidFill>
-                  <a:srgbClr val="0B7A4A"/>
-                </a:solidFill>
-                <a:latin typeface="Inter" pitchFamily="34" charset="0"/>
-                <a:ea typeface="Inter" pitchFamily="34" charset="-122"/>
-                <a:cs typeface="Inter" pitchFamily="34" charset="-120"/>
-              </a:rPr>
-              <a:t>+44.6%</a:t>
+              <a:t>+35.0%</a:t>
             </a:r>
             <a:endParaRPr lang="en-US" sz="1600" dirty="0"/>
           </a:p>
@@ -14341,198 +14393,14 @@
       </p:sp>
       <p:sp>
         <p:nvSpPr>
-          <p:cNvPr id="16" name="Text 14"/>
-          <p:cNvSpPr txBox="1"/>
-          <p:nvPr/>
-        </p:nvSpPr>
-        <p:spPr>
-          <a:xfrm>
-            <a:off x="749808" y="2873045"/>
-            <a:ext cx="320040" cy="751637"/>
-          </a:xfrm>
-          <a:prstGeom prst="rect">
-            <a:avLst/>
-          </a:prstGeom>
-          <a:noFill/>
-          <a:ln/>
-        </p:spPr>
-        <p:txBody>
-          <a:bodyPr wrap="square" lIns="0" tIns="0" rIns="0" bIns="0" rtlCol="0" anchor="ctr"/>
-          <a:lstStyle/>
-          <a:p>
-            <a:pPr indent="0" marL="0">
-              <a:buNone/>
-            </a:pPr>
-            <a:r>
-              <a:rPr lang="en-US" sz="1500" b="1" dirty="0">
-                <a:solidFill>
-                  <a:srgbClr val="0B2C4A"/>
-                </a:solidFill>
-                <a:latin typeface="Inter" pitchFamily="34" charset="0"/>
-                <a:ea typeface="Inter" pitchFamily="34" charset="-122"/>
-                <a:cs typeface="Inter" pitchFamily="34" charset="-120"/>
-              </a:rPr>
-              <a:t>2</a:t>
-            </a:r>
-            <a:endParaRPr lang="en-US" sz="1500" dirty="0"/>
-          </a:p>
-        </p:txBody>
-      </p:sp>
-      <p:sp>
-        <p:nvSpPr>
-          <p:cNvPr id="17" name="Text 15"/>
-          <p:cNvSpPr txBox="1"/>
-          <p:nvPr/>
-        </p:nvSpPr>
-        <p:spPr>
-          <a:xfrm>
-            <a:off x="1115568" y="2873045"/>
-            <a:ext cx="1737360" cy="751637"/>
-          </a:xfrm>
-          <a:prstGeom prst="rect">
-            <a:avLst/>
-          </a:prstGeom>
-          <a:noFill/>
-          <a:ln/>
-        </p:spPr>
-        <p:txBody>
-          <a:bodyPr wrap="square" lIns="0" tIns="0" rIns="0" bIns="0" rtlCol="0" anchor="ctr"/>
-          <a:lstStyle/>
-          <a:p>
-            <a:pPr indent="0" marL="0">
-              <a:buNone/>
-            </a:pPr>
-            <a:r>
-              <a:rPr lang="en-US" sz="1400" b="1" dirty="0">
-                <a:solidFill>
-                  <a:srgbClr val="1A1A1A"/>
-                </a:solidFill>
-                <a:latin typeface="Inter" pitchFamily="34" charset="0"/>
-                <a:ea typeface="Inter" pitchFamily="34" charset="-122"/>
-                <a:cs typeface="Inter" pitchFamily="34" charset="-120"/>
-              </a:rPr>
-              <a:t>Kia LV</a:t>
-            </a:r>
-            <a:endParaRPr lang="en-US" sz="1400" dirty="0"/>
-          </a:p>
-        </p:txBody>
-      </p:sp>
-      <p:sp>
-        <p:nvSpPr>
-          <p:cNvPr id="18" name="Text 16"/>
-          <p:cNvSpPr txBox="1"/>
-          <p:nvPr/>
-        </p:nvSpPr>
-        <p:spPr>
-          <a:xfrm>
-            <a:off x="2898648" y="2873045"/>
-            <a:ext cx="1920240" cy="751637"/>
-          </a:xfrm>
-          <a:prstGeom prst="rect">
-            <a:avLst/>
-          </a:prstGeom>
-          <a:noFill/>
-          <a:ln/>
-        </p:spPr>
-        <p:txBody>
-          <a:bodyPr wrap="square" lIns="0" tIns="0" rIns="0" bIns="0" rtlCol="0" anchor="ctr"/>
-          <a:lstStyle/>
-          <a:p>
-            <a:pPr indent="0" marL="0">
-              <a:buNone/>
-            </a:pPr>
-            <a:r>
-              <a:rPr lang="en-US" sz="1400" dirty="0">
-                <a:solidFill>
-                  <a:srgbClr val="595959"/>
-                </a:solidFill>
-                <a:latin typeface="Inter" pitchFamily="34" charset="0"/>
-                <a:ea typeface="Inter" pitchFamily="34" charset="-122"/>
-                <a:cs typeface="Inter" pitchFamily="34" charset="-120"/>
-              </a:rPr>
-              <a:t>9,453  </a:t>
-            </a:r>
-            <a:pPr indent="0" marL="0">
-              <a:buNone/>
-            </a:pPr>
-            <a:r>
-              <a:rPr lang="en-US" sz="1400" b="1" dirty="0">
-                <a:solidFill>
-                  <a:srgbClr val="0B7A4A"/>
-                </a:solidFill>
-                <a:latin typeface="Inter" pitchFamily="34" charset="0"/>
-                <a:ea typeface="Inter" pitchFamily="34" charset="-122"/>
-                <a:cs typeface="Inter" pitchFamily="34" charset="-120"/>
-              </a:rPr>
-              <a:t>→  </a:t>
-            </a:r>
-            <a:pPr indent="0" marL="0">
-              <a:buNone/>
-            </a:pPr>
-            <a:r>
-              <a:rPr lang="en-US" sz="1400" b="1" dirty="0">
-                <a:solidFill>
-                  <a:srgbClr val="0B7A4A"/>
-                </a:solidFill>
-                <a:latin typeface="Inter" pitchFamily="34" charset="0"/>
-                <a:ea typeface="Inter" pitchFamily="34" charset="-122"/>
-                <a:cs typeface="Inter" pitchFamily="34" charset="-120"/>
-              </a:rPr>
-              <a:t>12,757</a:t>
-            </a:r>
-            <a:endParaRPr lang="en-US" sz="1400" dirty="0"/>
-          </a:p>
-        </p:txBody>
-      </p:sp>
-      <p:sp>
-        <p:nvSpPr>
-          <p:cNvPr id="19" name="Text 17"/>
-          <p:cNvSpPr txBox="1"/>
-          <p:nvPr/>
-        </p:nvSpPr>
-        <p:spPr>
-          <a:xfrm>
-            <a:off x="4864608" y="2873045"/>
-            <a:ext cx="1051560" cy="751637"/>
-          </a:xfrm>
-          <a:prstGeom prst="rect">
-            <a:avLst/>
-          </a:prstGeom>
-          <a:noFill/>
-          <a:ln/>
-        </p:spPr>
-        <p:txBody>
-          <a:bodyPr wrap="square" lIns="0" tIns="0" rIns="0" bIns="0" rtlCol="0" anchor="ctr"/>
-          <a:lstStyle/>
-          <a:p>
-            <a:pPr algn="r" indent="0" marL="0">
-              <a:buNone/>
-            </a:pPr>
-            <a:r>
-              <a:rPr lang="en-US" sz="1600" b="1" dirty="0">
-                <a:solidFill>
-                  <a:srgbClr val="0B7A4A"/>
-                </a:solidFill>
-                <a:latin typeface="Inter" pitchFamily="34" charset="0"/>
-                <a:ea typeface="Inter" pitchFamily="34" charset="-122"/>
-                <a:cs typeface="Inter" pitchFamily="34" charset="-120"/>
-              </a:rPr>
-              <a:t>+35.0%</a:t>
-            </a:r>
-            <a:endParaRPr lang="en-US" sz="1600" dirty="0"/>
-          </a:p>
-        </p:txBody>
-      </p:sp>
-      <p:sp>
-        <p:nvSpPr>
-          <p:cNvPr id="20" name="Shape 18"/>
+          <p:cNvPr id="16" name="Shape 14"/>
           <p:cNvSpPr/>
           <p:nvPr/>
         </p:nvSpPr>
         <p:spPr>
           <a:xfrm>
-            <a:off x="658368" y="3624682"/>
-            <a:ext cx="5321808" cy="751637"/>
+            <a:off x="658368" y="3613709"/>
+            <a:ext cx="3489960" cy="755294"/>
           </a:xfrm>
           <a:prstGeom prst="rect">
             <a:avLst/>
@@ -14545,14 +14413,210 @@
       </p:sp>
       <p:sp>
         <p:nvSpPr>
+          <p:cNvPr id="17" name="Text 15"/>
+          <p:cNvSpPr txBox="1"/>
+          <p:nvPr/>
+        </p:nvSpPr>
+        <p:spPr>
+          <a:xfrm>
+            <a:off x="749808" y="3613709"/>
+            <a:ext cx="365760" cy="755294"/>
+          </a:xfrm>
+          <a:prstGeom prst="rect">
+            <a:avLst/>
+          </a:prstGeom>
+          <a:noFill/>
+          <a:ln/>
+        </p:spPr>
+        <p:txBody>
+          <a:bodyPr wrap="square" lIns="0" tIns="0" rIns="0" bIns="0" rtlCol="0" anchor="ctr"/>
+          <a:lstStyle/>
+          <a:p>
+            <a:pPr indent="0" marL="0">
+              <a:buNone/>
+            </a:pPr>
+            <a:r>
+              <a:rPr lang="en-US" sz="1500" b="1" dirty="0">
+                <a:solidFill>
+                  <a:srgbClr val="0B2C4A"/>
+                </a:solidFill>
+                <a:latin typeface="Inter" pitchFamily="34" charset="0"/>
+                <a:ea typeface="Inter" pitchFamily="34" charset="-122"/>
+                <a:cs typeface="Inter" pitchFamily="34" charset="-120"/>
+              </a:rPr>
+              <a:t>3</a:t>
+            </a:r>
+            <a:endParaRPr lang="en-US" sz="1500" dirty="0"/>
+          </a:p>
+        </p:txBody>
+      </p:sp>
+      <p:sp>
+        <p:nvSpPr>
+          <p:cNvPr id="18" name="Text 16"/>
+          <p:cNvSpPr txBox="1"/>
+          <p:nvPr/>
+        </p:nvSpPr>
+        <p:spPr>
+          <a:xfrm>
+            <a:off x="1097280" y="3613709"/>
+            <a:ext cx="1825752" cy="755294"/>
+          </a:xfrm>
+          <a:prstGeom prst="rect">
+            <a:avLst/>
+          </a:prstGeom>
+          <a:noFill/>
+          <a:ln/>
+        </p:spPr>
+        <p:txBody>
+          <a:bodyPr wrap="square" lIns="0" tIns="0" rIns="0" bIns="0" rtlCol="0" anchor="ctr"/>
+          <a:lstStyle/>
+          <a:p>
+            <a:pPr indent="0" marL="0">
+              <a:spcAft>
+                <a:spcPts val="200"/>
+              </a:spcAft>
+              <a:buNone/>
+            </a:pPr>
+            <a:r>
+              <a:rPr lang="en-US" sz="1400" b="1" dirty="0">
+                <a:solidFill>
+                  <a:srgbClr val="1A1A1A"/>
+                </a:solidFill>
+                <a:latin typeface="Inter" pitchFamily="34" charset="0"/>
+                <a:ea typeface="Inter" pitchFamily="34" charset="-122"/>
+                <a:cs typeface="Inter" pitchFamily="34" charset="-120"/>
+              </a:rPr>
+              <a:t>Kia St George</a:t>
+            </a:r>
+            <a:endParaRPr lang="en-US" sz="1400" dirty="0"/>
+          </a:p>
+          <a:p>
+            <a:pPr indent="0" marL="0">
+              <a:spcAft>
+                <a:spcPts val="200"/>
+              </a:spcAft>
+              <a:buNone/>
+            </a:pPr>
+            <a:r>
+              <a:rPr lang="en-US" sz="1200" dirty="0">
+                <a:solidFill>
+                  <a:srgbClr val="595959"/>
+                </a:solidFill>
+                <a:latin typeface="Inter" pitchFamily="34" charset="0"/>
+                <a:ea typeface="Inter" pitchFamily="34" charset="-122"/>
+                <a:cs typeface="Inter" pitchFamily="34" charset="-120"/>
+              </a:rPr>
+              <a:t>3,768  →  </a:t>
+            </a:r>
+            <a:pPr indent="0" marL="0">
+              <a:spcAft>
+                <a:spcPts val="200"/>
+              </a:spcAft>
+              <a:buNone/>
+            </a:pPr>
+            <a:r>
+              <a:rPr lang="en-US" sz="1200" b="1" dirty="0">
+                <a:solidFill>
+                  <a:srgbClr val="0B7A4A"/>
+                </a:solidFill>
+                <a:latin typeface="Inter" pitchFamily="34" charset="0"/>
+                <a:ea typeface="Inter" pitchFamily="34" charset="-122"/>
+                <a:cs typeface="Inter" pitchFamily="34" charset="-120"/>
+              </a:rPr>
+              <a:t>5,045</a:t>
+            </a:r>
+            <a:endParaRPr lang="en-US" sz="1400" dirty="0"/>
+          </a:p>
+        </p:txBody>
+      </p:sp>
+      <p:sp>
+        <p:nvSpPr>
+          <p:cNvPr id="19" name="Text 17"/>
+          <p:cNvSpPr txBox="1"/>
+          <p:nvPr/>
+        </p:nvSpPr>
+        <p:spPr>
+          <a:xfrm>
+            <a:off x="2941320" y="3613709"/>
+            <a:ext cx="1115568" cy="755294"/>
+          </a:xfrm>
+          <a:prstGeom prst="rect">
+            <a:avLst/>
+          </a:prstGeom>
+          <a:noFill/>
+          <a:ln/>
+        </p:spPr>
+        <p:txBody>
+          <a:bodyPr wrap="square" lIns="0" tIns="0" rIns="0" bIns="0" rtlCol="0" anchor="ctr"/>
+          <a:lstStyle/>
+          <a:p>
+            <a:pPr algn="r" indent="0" marL="0">
+              <a:buNone/>
+            </a:pPr>
+            <a:r>
+              <a:rPr lang="en-US" sz="1600" b="1" dirty="0">
+                <a:solidFill>
+                  <a:srgbClr val="0B7A4A"/>
+                </a:solidFill>
+                <a:latin typeface="Inter" pitchFamily="34" charset="0"/>
+                <a:ea typeface="Inter" pitchFamily="34" charset="-122"/>
+                <a:cs typeface="Inter" pitchFamily="34" charset="-120"/>
+              </a:rPr>
+              <a:t>+33.9%</a:t>
+            </a:r>
+            <a:endParaRPr lang="en-US" sz="1600" dirty="0"/>
+          </a:p>
+        </p:txBody>
+      </p:sp>
+      <p:sp>
+        <p:nvSpPr>
+          <p:cNvPr id="20" name="Text 18"/>
+          <p:cNvSpPr txBox="1"/>
+          <p:nvPr/>
+        </p:nvSpPr>
+        <p:spPr>
+          <a:xfrm>
+            <a:off x="749808" y="4369003"/>
+            <a:ext cx="365760" cy="755294"/>
+          </a:xfrm>
+          <a:prstGeom prst="rect">
+            <a:avLst/>
+          </a:prstGeom>
+          <a:noFill/>
+          <a:ln/>
+        </p:spPr>
+        <p:txBody>
+          <a:bodyPr wrap="square" lIns="0" tIns="0" rIns="0" bIns="0" rtlCol="0" anchor="ctr"/>
+          <a:lstStyle/>
+          <a:p>
+            <a:pPr indent="0" marL="0">
+              <a:buNone/>
+            </a:pPr>
+            <a:r>
+              <a:rPr lang="en-US" sz="1500" b="1" dirty="0">
+                <a:solidFill>
+                  <a:srgbClr val="0B2C4A"/>
+                </a:solidFill>
+                <a:latin typeface="Inter" pitchFamily="34" charset="0"/>
+                <a:ea typeface="Inter" pitchFamily="34" charset="-122"/>
+                <a:cs typeface="Inter" pitchFamily="34" charset="-120"/>
+              </a:rPr>
+              <a:t>4</a:t>
+            </a:r>
+            <a:endParaRPr lang="en-US" sz="1500" dirty="0"/>
+          </a:p>
+        </p:txBody>
+      </p:sp>
+      <p:sp>
+        <p:nvSpPr>
           <p:cNvPr id="21" name="Text 19"/>
           <p:cNvSpPr txBox="1"/>
           <p:nvPr/>
         </p:nvSpPr>
         <p:spPr>
           <a:xfrm>
-            <a:off x="749808" y="3624682"/>
-            <a:ext cx="320040" cy="751637"/>
+            <a:off x="1097280" y="4369003"/>
+            <a:ext cx="1825752" cy="755294"/>
           </a:xfrm>
           <a:prstGeom prst="rect">
             <a:avLst/>
@@ -14565,20 +14629,60 @@
           <a:lstStyle/>
           <a:p>
             <a:pPr indent="0" marL="0">
-              <a:buNone/>
-            </a:pPr>
-            <a:r>
-              <a:rPr lang="en-US" sz="1500" b="1" dirty="0">
-                <a:solidFill>
-                  <a:srgbClr val="0B2C4A"/>
-                </a:solidFill>
-                <a:latin typeface="Inter" pitchFamily="34" charset="0"/>
-                <a:ea typeface="Inter" pitchFamily="34" charset="-122"/>
-                <a:cs typeface="Inter" pitchFamily="34" charset="-120"/>
-              </a:rPr>
-              <a:t>3</a:t>
-            </a:r>
-            <a:endParaRPr lang="en-US" sz="1500" dirty="0"/>
+              <a:spcAft>
+                <a:spcPts val="200"/>
+              </a:spcAft>
+              <a:buNone/>
+            </a:pPr>
+            <a:r>
+              <a:rPr lang="en-US" sz="1400" b="1" dirty="0">
+                <a:solidFill>
+                  <a:srgbClr val="1A1A1A"/>
+                </a:solidFill>
+                <a:latin typeface="Inter" pitchFamily="34" charset="0"/>
+                <a:ea typeface="Inter" pitchFamily="34" charset="-122"/>
+                <a:cs typeface="Inter" pitchFamily="34" charset="-120"/>
+              </a:rPr>
+              <a:t>Subaru Prescott</a:t>
+            </a:r>
+            <a:endParaRPr lang="en-US" sz="1400" dirty="0"/>
+          </a:p>
+          <a:p>
+            <a:pPr indent="0" marL="0">
+              <a:spcAft>
+                <a:spcPts val="200"/>
+              </a:spcAft>
+              <a:buNone/>
+            </a:pPr>
+            <a:r>
+              <a:rPr lang="en-US" sz="1200" dirty="0">
+                <a:solidFill>
+                  <a:srgbClr val="595959"/>
+                </a:solidFill>
+                <a:latin typeface="Inter" pitchFamily="34" charset="0"/>
+                <a:ea typeface="Inter" pitchFamily="34" charset="-122"/>
+                <a:cs typeface="Inter" pitchFamily="34" charset="-120"/>
+              </a:rPr>
+              <a:t>6,328  →  </a:t>
+            </a:r>
+            <a:pPr indent="0" marL="0">
+              <a:spcAft>
+                <a:spcPts val="200"/>
+              </a:spcAft>
+              <a:buNone/>
+            </a:pPr>
+            <a:r>
+              <a:rPr lang="en-US" sz="1200" b="1" dirty="0">
+                <a:solidFill>
+                  <a:srgbClr val="0B7A4A"/>
+                </a:solidFill>
+                <a:latin typeface="Inter" pitchFamily="34" charset="0"/>
+                <a:ea typeface="Inter" pitchFamily="34" charset="-122"/>
+                <a:cs typeface="Inter" pitchFamily="34" charset="-120"/>
+              </a:rPr>
+              <a:t>8,154</a:t>
+            </a:r>
+            <a:endParaRPr lang="en-US" sz="1400" dirty="0"/>
           </a:p>
         </p:txBody>
       </p:sp>
@@ -14590,77 +14694,24 @@
         </p:nvSpPr>
         <p:spPr>
           <a:xfrm>
-            <a:off x="1115568" y="3624682"/>
-            <a:ext cx="1737360" cy="751637"/>
-          </a:xfrm>
-          <a:prstGeom prst="rect">
-            <a:avLst/>
-          </a:prstGeom>
-          <a:noFill/>
-          <a:ln/>
-        </p:spPr>
-        <p:txBody>
-          <a:bodyPr wrap="square" lIns="0" tIns="0" rIns="0" bIns="0" rtlCol="0" anchor="ctr"/>
-          <a:lstStyle/>
-          <a:p>
-            <a:pPr indent="0" marL="0">
-              <a:buNone/>
-            </a:pPr>
-            <a:r>
-              <a:rPr lang="en-US" sz="1400" b="1" dirty="0">
-                <a:solidFill>
-                  <a:srgbClr val="1A1A1A"/>
-                </a:solidFill>
-                <a:latin typeface="Inter" pitchFamily="34" charset="0"/>
-                <a:ea typeface="Inter" pitchFamily="34" charset="-122"/>
-                <a:cs typeface="Inter" pitchFamily="34" charset="-120"/>
-              </a:rPr>
-              <a:t>Kia St George</a:t>
-            </a:r>
-            <a:endParaRPr lang="en-US" sz="1400" dirty="0"/>
-          </a:p>
-        </p:txBody>
-      </p:sp>
-      <p:sp>
-        <p:nvSpPr>
-          <p:cNvPr id="23" name="Text 21"/>
-          <p:cNvSpPr txBox="1"/>
-          <p:nvPr/>
-        </p:nvSpPr>
-        <p:spPr>
-          <a:xfrm>
-            <a:off x="2898648" y="3624682"/>
-            <a:ext cx="1920240" cy="751637"/>
-          </a:xfrm>
-          <a:prstGeom prst="rect">
-            <a:avLst/>
-          </a:prstGeom>
-          <a:noFill/>
-          <a:ln/>
-        </p:spPr>
-        <p:txBody>
-          <a:bodyPr wrap="square" lIns="0" tIns="0" rIns="0" bIns="0" rtlCol="0" anchor="ctr"/>
-          <a:lstStyle/>
-          <a:p>
-            <a:pPr indent="0" marL="0">
-              <a:buNone/>
-            </a:pPr>
-            <a:r>
-              <a:rPr lang="en-US" sz="1400" dirty="0">
-                <a:solidFill>
-                  <a:srgbClr val="595959"/>
-                </a:solidFill>
-                <a:latin typeface="Inter" pitchFamily="34" charset="0"/>
-                <a:ea typeface="Inter" pitchFamily="34" charset="-122"/>
-                <a:cs typeface="Inter" pitchFamily="34" charset="-120"/>
-              </a:rPr>
-              <a:t>3,768  </a:t>
-            </a:r>
-            <a:pPr indent="0" marL="0">
-              <a:buNone/>
-            </a:pPr>
-            <a:r>
-              <a:rPr lang="en-US" sz="1400" b="1" dirty="0">
+            <a:off x="2941320" y="4369003"/>
+            <a:ext cx="1115568" cy="755294"/>
+          </a:xfrm>
+          <a:prstGeom prst="rect">
+            <a:avLst/>
+          </a:prstGeom>
+          <a:noFill/>
+          <a:ln/>
+        </p:spPr>
+        <p:txBody>
+          <a:bodyPr wrap="square" lIns="0" tIns="0" rIns="0" bIns="0" rtlCol="0" anchor="ctr"/>
+          <a:lstStyle/>
+          <a:p>
+            <a:pPr algn="r" indent="0" marL="0">
+              <a:buNone/>
+            </a:pPr>
+            <a:r>
+              <a:rPr lang="en-US" sz="1600" b="1" dirty="0">
                 <a:solidFill>
                   <a:srgbClr val="0B7A4A"/>
                 </a:solidFill>
@@ -14668,60 +14719,7 @@
                 <a:ea typeface="Inter" pitchFamily="34" charset="-122"/>
                 <a:cs typeface="Inter" pitchFamily="34" charset="-120"/>
               </a:rPr>
-              <a:t>→  </a:t>
-            </a:r>
-            <a:pPr indent="0" marL="0">
-              <a:buNone/>
-            </a:pPr>
-            <a:r>
-              <a:rPr lang="en-US" sz="1400" b="1" dirty="0">
-                <a:solidFill>
-                  <a:srgbClr val="0B7A4A"/>
-                </a:solidFill>
-                <a:latin typeface="Inter" pitchFamily="34" charset="0"/>
-                <a:ea typeface="Inter" pitchFamily="34" charset="-122"/>
-                <a:cs typeface="Inter" pitchFamily="34" charset="-120"/>
-              </a:rPr>
-              <a:t>5,045</a:t>
-            </a:r>
-            <a:endParaRPr lang="en-US" sz="1400" dirty="0"/>
-          </a:p>
-        </p:txBody>
-      </p:sp>
-      <p:sp>
-        <p:nvSpPr>
-          <p:cNvPr id="24" name="Text 22"/>
-          <p:cNvSpPr txBox="1"/>
-          <p:nvPr/>
-        </p:nvSpPr>
-        <p:spPr>
-          <a:xfrm>
-            <a:off x="4864608" y="3624682"/>
-            <a:ext cx="1051560" cy="751637"/>
-          </a:xfrm>
-          <a:prstGeom prst="rect">
-            <a:avLst/>
-          </a:prstGeom>
-          <a:noFill/>
-          <a:ln/>
-        </p:spPr>
-        <p:txBody>
-          <a:bodyPr wrap="square" lIns="0" tIns="0" rIns="0" bIns="0" rtlCol="0" anchor="ctr"/>
-          <a:lstStyle/>
-          <a:p>
-            <a:pPr algn="r" indent="0" marL="0">
-              <a:buNone/>
-            </a:pPr>
-            <a:r>
-              <a:rPr lang="en-US" sz="1600" b="1" dirty="0">
-                <a:solidFill>
-                  <a:srgbClr val="0B7A4A"/>
-                </a:solidFill>
-                <a:latin typeface="Inter" pitchFamily="34" charset="0"/>
-                <a:ea typeface="Inter" pitchFamily="34" charset="-122"/>
-                <a:cs typeface="Inter" pitchFamily="34" charset="-120"/>
-              </a:rPr>
-              <a:t>+33.9%</a:t>
+              <a:t>+28.9%</a:t>
             </a:r>
             <a:endParaRPr lang="en-US" sz="1600" dirty="0"/>
           </a:p>
@@ -14729,198 +14727,14 @@
       </p:sp>
       <p:sp>
         <p:nvSpPr>
-          <p:cNvPr id="25" name="Text 23"/>
-          <p:cNvSpPr txBox="1"/>
-          <p:nvPr/>
-        </p:nvSpPr>
-        <p:spPr>
-          <a:xfrm>
-            <a:off x="749808" y="4376318"/>
-            <a:ext cx="320040" cy="751637"/>
-          </a:xfrm>
-          <a:prstGeom prst="rect">
-            <a:avLst/>
-          </a:prstGeom>
-          <a:noFill/>
-          <a:ln/>
-        </p:spPr>
-        <p:txBody>
-          <a:bodyPr wrap="square" lIns="0" tIns="0" rIns="0" bIns="0" rtlCol="0" anchor="ctr"/>
-          <a:lstStyle/>
-          <a:p>
-            <a:pPr indent="0" marL="0">
-              <a:buNone/>
-            </a:pPr>
-            <a:r>
-              <a:rPr lang="en-US" sz="1500" b="1" dirty="0">
-                <a:solidFill>
-                  <a:srgbClr val="0B2C4A"/>
-                </a:solidFill>
-                <a:latin typeface="Inter" pitchFamily="34" charset="0"/>
-                <a:ea typeface="Inter" pitchFamily="34" charset="-122"/>
-                <a:cs typeface="Inter" pitchFamily="34" charset="-120"/>
-              </a:rPr>
-              <a:t>4</a:t>
-            </a:r>
-            <a:endParaRPr lang="en-US" sz="1500" dirty="0"/>
-          </a:p>
-        </p:txBody>
-      </p:sp>
-      <p:sp>
-        <p:nvSpPr>
-          <p:cNvPr id="26" name="Text 24"/>
-          <p:cNvSpPr txBox="1"/>
-          <p:nvPr/>
-        </p:nvSpPr>
-        <p:spPr>
-          <a:xfrm>
-            <a:off x="1115568" y="4376318"/>
-            <a:ext cx="1737360" cy="751637"/>
-          </a:xfrm>
-          <a:prstGeom prst="rect">
-            <a:avLst/>
-          </a:prstGeom>
-          <a:noFill/>
-          <a:ln/>
-        </p:spPr>
-        <p:txBody>
-          <a:bodyPr wrap="square" lIns="0" tIns="0" rIns="0" bIns="0" rtlCol="0" anchor="ctr"/>
-          <a:lstStyle/>
-          <a:p>
-            <a:pPr indent="0" marL="0">
-              <a:buNone/>
-            </a:pPr>
-            <a:r>
-              <a:rPr lang="en-US" sz="1400" b="1" dirty="0">
-                <a:solidFill>
-                  <a:srgbClr val="1A1A1A"/>
-                </a:solidFill>
-                <a:latin typeface="Inter" pitchFamily="34" charset="0"/>
-                <a:ea typeface="Inter" pitchFamily="34" charset="-122"/>
-                <a:cs typeface="Inter" pitchFamily="34" charset="-120"/>
-              </a:rPr>
-              <a:t>Subaru Prescott</a:t>
-            </a:r>
-            <a:endParaRPr lang="en-US" sz="1400" dirty="0"/>
-          </a:p>
-        </p:txBody>
-      </p:sp>
-      <p:sp>
-        <p:nvSpPr>
-          <p:cNvPr id="27" name="Text 25"/>
-          <p:cNvSpPr txBox="1"/>
-          <p:nvPr/>
-        </p:nvSpPr>
-        <p:spPr>
-          <a:xfrm>
-            <a:off x="2898648" y="4376318"/>
-            <a:ext cx="1920240" cy="751637"/>
-          </a:xfrm>
-          <a:prstGeom prst="rect">
-            <a:avLst/>
-          </a:prstGeom>
-          <a:noFill/>
-          <a:ln/>
-        </p:spPr>
-        <p:txBody>
-          <a:bodyPr wrap="square" lIns="0" tIns="0" rIns="0" bIns="0" rtlCol="0" anchor="ctr"/>
-          <a:lstStyle/>
-          <a:p>
-            <a:pPr indent="0" marL="0">
-              <a:buNone/>
-            </a:pPr>
-            <a:r>
-              <a:rPr lang="en-US" sz="1400" dirty="0">
-                <a:solidFill>
-                  <a:srgbClr val="595959"/>
-                </a:solidFill>
-                <a:latin typeface="Inter" pitchFamily="34" charset="0"/>
-                <a:ea typeface="Inter" pitchFamily="34" charset="-122"/>
-                <a:cs typeface="Inter" pitchFamily="34" charset="-120"/>
-              </a:rPr>
-              <a:t>6,328  </a:t>
-            </a:r>
-            <a:pPr indent="0" marL="0">
-              <a:buNone/>
-            </a:pPr>
-            <a:r>
-              <a:rPr lang="en-US" sz="1400" b="1" dirty="0">
-                <a:solidFill>
-                  <a:srgbClr val="0B7A4A"/>
-                </a:solidFill>
-                <a:latin typeface="Inter" pitchFamily="34" charset="0"/>
-                <a:ea typeface="Inter" pitchFamily="34" charset="-122"/>
-                <a:cs typeface="Inter" pitchFamily="34" charset="-120"/>
-              </a:rPr>
-              <a:t>→  </a:t>
-            </a:r>
-            <a:pPr indent="0" marL="0">
-              <a:buNone/>
-            </a:pPr>
-            <a:r>
-              <a:rPr lang="en-US" sz="1400" b="1" dirty="0">
-                <a:solidFill>
-                  <a:srgbClr val="0B7A4A"/>
-                </a:solidFill>
-                <a:latin typeface="Inter" pitchFamily="34" charset="0"/>
-                <a:ea typeface="Inter" pitchFamily="34" charset="-122"/>
-                <a:cs typeface="Inter" pitchFamily="34" charset="-120"/>
-              </a:rPr>
-              <a:t>8,154</a:t>
-            </a:r>
-            <a:endParaRPr lang="en-US" sz="1400" dirty="0"/>
-          </a:p>
-        </p:txBody>
-      </p:sp>
-      <p:sp>
-        <p:nvSpPr>
-          <p:cNvPr id="28" name="Text 26"/>
-          <p:cNvSpPr txBox="1"/>
-          <p:nvPr/>
-        </p:nvSpPr>
-        <p:spPr>
-          <a:xfrm>
-            <a:off x="4864608" y="4376318"/>
-            <a:ext cx="1051560" cy="751637"/>
-          </a:xfrm>
-          <a:prstGeom prst="rect">
-            <a:avLst/>
-          </a:prstGeom>
-          <a:noFill/>
-          <a:ln/>
-        </p:spPr>
-        <p:txBody>
-          <a:bodyPr wrap="square" lIns="0" tIns="0" rIns="0" bIns="0" rtlCol="0" anchor="ctr"/>
-          <a:lstStyle/>
-          <a:p>
-            <a:pPr algn="r" indent="0" marL="0">
-              <a:buNone/>
-            </a:pPr>
-            <a:r>
-              <a:rPr lang="en-US" sz="1600" b="1" dirty="0">
-                <a:solidFill>
-                  <a:srgbClr val="0B7A4A"/>
-                </a:solidFill>
-                <a:latin typeface="Inter" pitchFamily="34" charset="0"/>
-                <a:ea typeface="Inter" pitchFamily="34" charset="-122"/>
-                <a:cs typeface="Inter" pitchFamily="34" charset="-120"/>
-              </a:rPr>
-              <a:t>+28.9%</a:t>
-            </a:r>
-            <a:endParaRPr lang="en-US" sz="1600" dirty="0"/>
-          </a:p>
-        </p:txBody>
-      </p:sp>
-      <p:sp>
-        <p:nvSpPr>
-          <p:cNvPr id="29" name="Shape 27"/>
+          <p:cNvPr id="23" name="Shape 21"/>
           <p:cNvSpPr/>
           <p:nvPr/>
         </p:nvSpPr>
         <p:spPr>
           <a:xfrm>
-            <a:off x="658368" y="5127955"/>
-            <a:ext cx="5321808" cy="751637"/>
+            <a:off x="658368" y="5124298"/>
+            <a:ext cx="3489960" cy="755294"/>
           </a:xfrm>
           <a:prstGeom prst="rect">
             <a:avLst/>
@@ -14933,14 +14747,14 @@
       </p:sp>
       <p:sp>
         <p:nvSpPr>
-          <p:cNvPr id="30" name="Text 28"/>
-          <p:cNvSpPr txBox="1"/>
-          <p:nvPr/>
-        </p:nvSpPr>
-        <p:spPr>
-          <a:xfrm>
-            <a:off x="749808" y="5127955"/>
-            <a:ext cx="320040" cy="751637"/>
+          <p:cNvPr id="24" name="Text 22"/>
+          <p:cNvSpPr txBox="1"/>
+          <p:nvPr/>
+        </p:nvSpPr>
+        <p:spPr>
+          <a:xfrm>
+            <a:off x="749808" y="5124298"/>
+            <a:ext cx="365760" cy="755294"/>
           </a:xfrm>
           <a:prstGeom prst="rect">
             <a:avLst/>
@@ -14972,14 +14786,14 @@
       </p:sp>
       <p:sp>
         <p:nvSpPr>
-          <p:cNvPr id="31" name="Text 29"/>
-          <p:cNvSpPr txBox="1"/>
-          <p:nvPr/>
-        </p:nvSpPr>
-        <p:spPr>
-          <a:xfrm>
-            <a:off x="1115568" y="5127955"/>
-            <a:ext cx="1737360" cy="751637"/>
+          <p:cNvPr id="25" name="Text 23"/>
+          <p:cNvSpPr txBox="1"/>
+          <p:nvPr/>
+        </p:nvSpPr>
+        <p:spPr>
+          <a:xfrm>
+            <a:off x="1097280" y="5124298"/>
+            <a:ext cx="1825752" cy="755294"/>
           </a:xfrm>
           <a:prstGeom prst="rect">
             <a:avLst/>
@@ -14992,6 +14806,9 @@
           <a:lstStyle/>
           <a:p>
             <a:pPr indent="0" marL="0">
+              <a:spcAft>
+                <a:spcPts val="200"/>
+              </a:spcAft>
               <a:buNone/>
             </a:pPr>
             <a:r>
@@ -15007,34 +14824,15 @@
             </a:r>
             <a:endParaRPr lang="en-US" sz="1400" dirty="0"/>
           </a:p>
-        </p:txBody>
-      </p:sp>
-      <p:sp>
-        <p:nvSpPr>
-          <p:cNvPr id="32" name="Text 30"/>
-          <p:cNvSpPr txBox="1"/>
-          <p:nvPr/>
-        </p:nvSpPr>
-        <p:spPr>
-          <a:xfrm>
-            <a:off x="2898648" y="5127955"/>
-            <a:ext cx="1920240" cy="751637"/>
-          </a:xfrm>
-          <a:prstGeom prst="rect">
-            <a:avLst/>
-          </a:prstGeom>
-          <a:noFill/>
-          <a:ln/>
-        </p:spPr>
-        <p:txBody>
-          <a:bodyPr wrap="square" lIns="0" tIns="0" rIns="0" bIns="0" rtlCol="0" anchor="ctr"/>
-          <a:lstStyle/>
           <a:p>
             <a:pPr indent="0" marL="0">
-              <a:buNone/>
-            </a:pPr>
-            <a:r>
-              <a:rPr lang="en-US" sz="1400" dirty="0">
+              <a:spcAft>
+                <a:spcPts val="200"/>
+              </a:spcAft>
+              <a:buNone/>
+            </a:pPr>
+            <a:r>
+              <a:rPr lang="en-US" sz="1200" dirty="0">
                 <a:solidFill>
                   <a:srgbClr val="595959"/>
                 </a:solidFill>
@@ -15042,13 +14840,16 @@
                 <a:ea typeface="Inter" pitchFamily="34" charset="-122"/>
                 <a:cs typeface="Inter" pitchFamily="34" charset="-120"/>
               </a:rPr>
-              <a:t>2,566  </a:t>
+              <a:t>2,566  →  </a:t>
             </a:r>
             <a:pPr indent="0" marL="0">
-              <a:buNone/>
-            </a:pPr>
-            <a:r>
-              <a:rPr lang="en-US" sz="1400" b="1" dirty="0">
+              <a:spcAft>
+                <a:spcPts val="200"/>
+              </a:spcAft>
+              <a:buNone/>
+            </a:pPr>
+            <a:r>
+              <a:rPr lang="en-US" sz="1200" b="1" dirty="0">
                 <a:solidFill>
                   <a:srgbClr val="0B7A4A"/>
                 </a:solidFill>
@@ -15056,13 +14857,38 @@
                 <a:ea typeface="Inter" pitchFamily="34" charset="-122"/>
                 <a:cs typeface="Inter" pitchFamily="34" charset="-120"/>
               </a:rPr>
-              <a:t>→  </a:t>
-            </a:r>
-            <a:pPr indent="0" marL="0">
-              <a:buNone/>
-            </a:pPr>
-            <a:r>
-              <a:rPr lang="en-US" sz="1400" b="1" dirty="0">
+              <a:t>3,287</a:t>
+            </a:r>
+            <a:endParaRPr lang="en-US" sz="1400" dirty="0"/>
+          </a:p>
+        </p:txBody>
+      </p:sp>
+      <p:sp>
+        <p:nvSpPr>
+          <p:cNvPr id="26" name="Text 24"/>
+          <p:cNvSpPr txBox="1"/>
+          <p:nvPr/>
+        </p:nvSpPr>
+        <p:spPr>
+          <a:xfrm>
+            <a:off x="2941320" y="5124298"/>
+            <a:ext cx="1115568" cy="755294"/>
+          </a:xfrm>
+          <a:prstGeom prst="rect">
+            <a:avLst/>
+          </a:prstGeom>
+          <a:noFill/>
+          <a:ln/>
+        </p:spPr>
+        <p:txBody>
+          <a:bodyPr wrap="square" lIns="0" tIns="0" rIns="0" bIns="0" rtlCol="0" anchor="ctr"/>
+          <a:lstStyle/>
+          <a:p>
+            <a:pPr algn="r" indent="0" marL="0">
+              <a:buNone/>
+            </a:pPr>
+            <a:r>
+              <a:rPr lang="en-US" sz="1600" b="1" dirty="0">
                 <a:solidFill>
                   <a:srgbClr val="0B7A4A"/>
                 </a:solidFill>
@@ -15070,45 +14896,6 @@
                 <a:ea typeface="Inter" pitchFamily="34" charset="-122"/>
                 <a:cs typeface="Inter" pitchFamily="34" charset="-120"/>
               </a:rPr>
-              <a:t>3,287</a:t>
-            </a:r>
-            <a:endParaRPr lang="en-US" sz="1400" dirty="0"/>
-          </a:p>
-        </p:txBody>
-      </p:sp>
-      <p:sp>
-        <p:nvSpPr>
-          <p:cNvPr id="33" name="Text 31"/>
-          <p:cNvSpPr txBox="1"/>
-          <p:nvPr/>
-        </p:nvSpPr>
-        <p:spPr>
-          <a:xfrm>
-            <a:off x="4864608" y="5127955"/>
-            <a:ext cx="1051560" cy="751637"/>
-          </a:xfrm>
-          <a:prstGeom prst="rect">
-            <a:avLst/>
-          </a:prstGeom>
-          <a:noFill/>
-          <a:ln/>
-        </p:spPr>
-        <p:txBody>
-          <a:bodyPr wrap="square" lIns="0" tIns="0" rIns="0" bIns="0" rtlCol="0" anchor="ctr"/>
-          <a:lstStyle/>
-          <a:p>
-            <a:pPr algn="r" indent="0" marL="0">
-              <a:buNone/>
-            </a:pPr>
-            <a:r>
-              <a:rPr lang="en-US" sz="1600" b="1" dirty="0">
-                <a:solidFill>
-                  <a:srgbClr val="0B7A4A"/>
-                </a:solidFill>
-                <a:latin typeface="Inter" pitchFamily="34" charset="0"/>
-                <a:ea typeface="Inter" pitchFamily="34" charset="-122"/>
-                <a:cs typeface="Inter" pitchFamily="34" charset="-120"/>
-              </a:rPr>
               <a:t>+28.1%</a:t>
             </a:r>
             <a:endParaRPr lang="en-US" sz="1600" dirty="0"/>
@@ -15117,14 +14904,14 @@
       </p:sp>
       <p:sp>
         <p:nvSpPr>
-          <p:cNvPr id="34" name="Shape 32"/>
+          <p:cNvPr id="27" name="Shape 25"/>
           <p:cNvSpPr/>
           <p:nvPr/>
         </p:nvSpPr>
         <p:spPr>
           <a:xfrm>
-            <a:off x="6208776" y="1737360"/>
-            <a:ext cx="5321808" cy="45720"/>
+            <a:off x="4349496" y="1371600"/>
+            <a:ext cx="3489960" cy="45720"/>
           </a:xfrm>
           <a:prstGeom prst="rect">
             <a:avLst/>
@@ -15137,14 +14924,14 @@
       </p:sp>
       <p:sp>
         <p:nvSpPr>
-          <p:cNvPr id="35" name="Text 33"/>
-          <p:cNvSpPr txBox="1"/>
-          <p:nvPr/>
-        </p:nvSpPr>
-        <p:spPr>
-          <a:xfrm>
-            <a:off x="6300216" y="1810512"/>
-            <a:ext cx="1828800" cy="274320"/>
+          <p:cNvPr id="28" name="Text 26"/>
+          <p:cNvSpPr txBox="1"/>
+          <p:nvPr/>
+        </p:nvSpPr>
+        <p:spPr>
+          <a:xfrm>
+            <a:off x="4440936" y="1444752"/>
+            <a:ext cx="3307080" cy="274320"/>
           </a:xfrm>
           <a:prstGeom prst="rect">
             <a:avLst/>
@@ -15160,7 +14947,7 @@
               <a:buNone/>
             </a:pPr>
             <a:r>
-              <a:rPr lang="en-US" sz="1400" b="1" spc="100" kern="0" dirty="0">
+              <a:rPr lang="en-US" sz="1500" b="1" spc="100" kern="0" dirty="0">
                 <a:solidFill>
                   <a:srgbClr val="A82B26"/>
                 </a:solidFill>
@@ -15168,22 +14955,22 @@
                 <a:ea typeface="Inter" pitchFamily="34" charset="-122"/>
                 <a:cs typeface="Inter" pitchFamily="34" charset="-120"/>
               </a:rPr>
-              <a:t>BOTTOM 5</a:t>
-            </a:r>
-            <a:endParaRPr lang="en-US" sz="1400" dirty="0"/>
-          </a:p>
-        </p:txBody>
-      </p:sp>
-      <p:sp>
-        <p:nvSpPr>
-          <p:cNvPr id="36" name="Text 34"/>
-          <p:cNvSpPr txBox="1"/>
-          <p:nvPr/>
-        </p:nvSpPr>
-        <p:spPr>
-          <a:xfrm>
-            <a:off x="8449056" y="1810512"/>
-            <a:ext cx="1828800" cy="274320"/>
+              <a:t>BOTTOM 5 VS LAST YEAR</a:t>
+            </a:r>
+            <a:endParaRPr lang="en-US" sz="1500" dirty="0"/>
+          </a:p>
+        </p:txBody>
+      </p:sp>
+      <p:sp>
+        <p:nvSpPr>
+          <p:cNvPr id="29" name="Text 27"/>
+          <p:cNvSpPr txBox="1"/>
+          <p:nvPr/>
+        </p:nvSpPr>
+        <p:spPr>
+          <a:xfrm>
+            <a:off x="4440936" y="1737360"/>
+            <a:ext cx="3307080" cy="274320"/>
           </a:xfrm>
           <a:prstGeom prst="rect">
             <a:avLst/>
@@ -15199,7 +14986,7 @@
               <a:buNone/>
             </a:pPr>
             <a:r>
-              <a:rPr lang="en-US" sz="1400" b="1" dirty="0">
+              <a:rPr lang="en-US" sz="1200" dirty="0">
                 <a:solidFill>
                   <a:srgbClr val="595959"/>
                 </a:solidFill>
@@ -15207,61 +14994,22 @@
                 <a:ea typeface="Inter" pitchFamily="34" charset="-122"/>
                 <a:cs typeface="Inter" pitchFamily="34" charset="-120"/>
               </a:rPr>
-              <a:t>2025 → 2026</a:t>
-            </a:r>
-            <a:endParaRPr lang="en-US" sz="1400" dirty="0"/>
-          </a:p>
-        </p:txBody>
-      </p:sp>
-      <p:sp>
-        <p:nvSpPr>
-          <p:cNvPr id="37" name="Text 35"/>
-          <p:cNvSpPr txBox="1"/>
-          <p:nvPr/>
-        </p:nvSpPr>
-        <p:spPr>
-          <a:xfrm>
-            <a:off x="10415016" y="1810512"/>
-            <a:ext cx="1051560" cy="274320"/>
-          </a:xfrm>
-          <a:prstGeom prst="rect">
-            <a:avLst/>
-          </a:prstGeom>
-          <a:noFill/>
-          <a:ln/>
-        </p:spPr>
-        <p:txBody>
-          <a:bodyPr wrap="square" lIns="0" tIns="0" rIns="0" bIns="0" rtlCol="0" anchor="ctr"/>
-          <a:lstStyle/>
-          <a:p>
-            <a:pPr algn="r" indent="0" marL="0">
-              <a:buNone/>
-            </a:pPr>
-            <a:r>
-              <a:rPr lang="en-US" sz="1400" b="1" dirty="0">
-                <a:solidFill>
-                  <a:srgbClr val="595959"/>
-                </a:solidFill>
-                <a:latin typeface="Inter" pitchFamily="34" charset="0"/>
-                <a:ea typeface="Inter" pitchFamily="34" charset="-122"/>
-                <a:cs typeface="Inter" pitchFamily="34" charset="-120"/>
-              </a:rPr>
-              <a:t>Change</a:t>
-            </a:r>
-            <a:endParaRPr lang="en-US" sz="1400" dirty="0"/>
-          </a:p>
-        </p:txBody>
-      </p:sp>
-      <p:sp>
-        <p:nvSpPr>
-          <p:cNvPr id="38" name="Shape 36"/>
+              <a:t>Jan–Sep 2026 vs Jan–Sep 2025</a:t>
+            </a:r>
+            <a:endParaRPr lang="en-US" sz="1200" dirty="0"/>
+          </a:p>
+        </p:txBody>
+      </p:sp>
+      <p:sp>
+        <p:nvSpPr>
+          <p:cNvPr id="30" name="Shape 28"/>
           <p:cNvSpPr/>
           <p:nvPr/>
         </p:nvSpPr>
         <p:spPr>
           <a:xfrm>
-            <a:off x="6208776" y="2121408"/>
-            <a:ext cx="5321808" cy="751637"/>
+            <a:off x="4349496" y="2103120"/>
+            <a:ext cx="3489960" cy="755294"/>
           </a:xfrm>
           <a:prstGeom prst="rect">
             <a:avLst/>
@@ -15274,14 +15022,14 @@
       </p:sp>
       <p:sp>
         <p:nvSpPr>
-          <p:cNvPr id="39" name="Text 37"/>
-          <p:cNvSpPr txBox="1"/>
-          <p:nvPr/>
-        </p:nvSpPr>
-        <p:spPr>
-          <a:xfrm>
-            <a:off x="6300216" y="2121408"/>
-            <a:ext cx="320040" cy="751637"/>
+          <p:cNvPr id="31" name="Text 29"/>
+          <p:cNvSpPr txBox="1"/>
+          <p:nvPr/>
+        </p:nvSpPr>
+        <p:spPr>
+          <a:xfrm>
+            <a:off x="4440936" y="2103120"/>
+            <a:ext cx="365760" cy="755294"/>
           </a:xfrm>
           <a:prstGeom prst="rect">
             <a:avLst/>
@@ -15313,14 +15061,14 @@
       </p:sp>
       <p:sp>
         <p:nvSpPr>
-          <p:cNvPr id="40" name="Text 38"/>
-          <p:cNvSpPr txBox="1"/>
-          <p:nvPr/>
-        </p:nvSpPr>
-        <p:spPr>
-          <a:xfrm>
-            <a:off x="6665976" y="2121408"/>
-            <a:ext cx="1737360" cy="751637"/>
+          <p:cNvPr id="32" name="Text 30"/>
+          <p:cNvSpPr txBox="1"/>
+          <p:nvPr/>
+        </p:nvSpPr>
+        <p:spPr>
+          <a:xfrm>
+            <a:off x="4788408" y="2103120"/>
+            <a:ext cx="1825752" cy="755294"/>
           </a:xfrm>
           <a:prstGeom prst="rect">
             <a:avLst/>
@@ -15333,6 +15081,9 @@
           <a:lstStyle/>
           <a:p>
             <a:pPr indent="0" marL="0">
+              <a:spcAft>
+                <a:spcPts val="200"/>
+              </a:spcAft>
               <a:buNone/>
             </a:pPr>
             <a:r>
@@ -15348,34 +15099,15 @@
             </a:r>
             <a:endParaRPr lang="en-US" sz="1400" dirty="0"/>
           </a:p>
-        </p:txBody>
-      </p:sp>
-      <p:sp>
-        <p:nvSpPr>
-          <p:cNvPr id="41" name="Text 39"/>
-          <p:cNvSpPr txBox="1"/>
-          <p:nvPr/>
-        </p:nvSpPr>
-        <p:spPr>
-          <a:xfrm>
-            <a:off x="8449056" y="2121408"/>
-            <a:ext cx="1920240" cy="751637"/>
-          </a:xfrm>
-          <a:prstGeom prst="rect">
-            <a:avLst/>
-          </a:prstGeom>
-          <a:noFill/>
-          <a:ln/>
-        </p:spPr>
-        <p:txBody>
-          <a:bodyPr wrap="square" lIns="0" tIns="0" rIns="0" bIns="0" rtlCol="0" anchor="ctr"/>
-          <a:lstStyle/>
           <a:p>
             <a:pPr indent="0" marL="0">
-              <a:buNone/>
-            </a:pPr>
-            <a:r>
-              <a:rPr lang="en-US" sz="1400" dirty="0">
+              <a:spcAft>
+                <a:spcPts val="200"/>
+              </a:spcAft>
+              <a:buNone/>
+            </a:pPr>
+            <a:r>
+              <a:rPr lang="en-US" sz="1200" dirty="0">
                 <a:solidFill>
                   <a:srgbClr val="595959"/>
                 </a:solidFill>
@@ -15383,27 +15115,212 @@
                 <a:ea typeface="Inter" pitchFamily="34" charset="-122"/>
                 <a:cs typeface="Inter" pitchFamily="34" charset="-120"/>
               </a:rPr>
-              <a:t>4,394  </a:t>
+              <a:t>4,394  →  </a:t>
             </a:r>
             <a:pPr indent="0" marL="0">
+              <a:spcAft>
+                <a:spcPts val="200"/>
+              </a:spcAft>
+              <a:buNone/>
+            </a:pPr>
+            <a:r>
+              <a:rPr lang="en-US" sz="1200" b="1" dirty="0">
+                <a:solidFill>
+                  <a:srgbClr val="A82B26"/>
+                </a:solidFill>
+                <a:latin typeface="Inter" pitchFamily="34" charset="0"/>
+                <a:ea typeface="Inter" pitchFamily="34" charset="-122"/>
+                <a:cs typeface="Inter" pitchFamily="34" charset="-120"/>
+              </a:rPr>
+              <a:t>3,276</a:t>
+            </a:r>
+            <a:endParaRPr lang="en-US" sz="1400" dirty="0"/>
+          </a:p>
+        </p:txBody>
+      </p:sp>
+      <p:sp>
+        <p:nvSpPr>
+          <p:cNvPr id="33" name="Text 31"/>
+          <p:cNvSpPr txBox="1"/>
+          <p:nvPr/>
+        </p:nvSpPr>
+        <p:spPr>
+          <a:xfrm>
+            <a:off x="6632448" y="2103120"/>
+            <a:ext cx="1115568" cy="755294"/>
+          </a:xfrm>
+          <a:prstGeom prst="rect">
+            <a:avLst/>
+          </a:prstGeom>
+          <a:noFill/>
+          <a:ln/>
+        </p:spPr>
+        <p:txBody>
+          <a:bodyPr wrap="square" lIns="0" tIns="0" rIns="0" bIns="0" rtlCol="0" anchor="ctr"/>
+          <a:lstStyle/>
+          <a:p>
+            <a:pPr algn="r" indent="0" marL="0">
+              <a:buNone/>
+            </a:pPr>
+            <a:r>
+              <a:rPr lang="en-US" sz="1600" b="1" dirty="0">
+                <a:solidFill>
+                  <a:srgbClr val="A82B26"/>
+                </a:solidFill>
+                <a:latin typeface="Inter" pitchFamily="34" charset="0"/>
+                <a:ea typeface="Inter" pitchFamily="34" charset="-122"/>
+                <a:cs typeface="Inter" pitchFamily="34" charset="-120"/>
+              </a:rPr>
+              <a:t>−25.4%</a:t>
+            </a:r>
+            <a:endParaRPr lang="en-US" sz="1600" dirty="0"/>
+          </a:p>
+        </p:txBody>
+      </p:sp>
+      <p:sp>
+        <p:nvSpPr>
+          <p:cNvPr id="34" name="Text 32"/>
+          <p:cNvSpPr txBox="1"/>
+          <p:nvPr/>
+        </p:nvSpPr>
+        <p:spPr>
+          <a:xfrm>
+            <a:off x="4440936" y="2858414"/>
+            <a:ext cx="365760" cy="755294"/>
+          </a:xfrm>
+          <a:prstGeom prst="rect">
+            <a:avLst/>
+          </a:prstGeom>
+          <a:noFill/>
+          <a:ln/>
+        </p:spPr>
+        <p:txBody>
+          <a:bodyPr wrap="square" lIns="0" tIns="0" rIns="0" bIns="0" rtlCol="0" anchor="ctr"/>
+          <a:lstStyle/>
+          <a:p>
+            <a:pPr indent="0" marL="0">
+              <a:buNone/>
+            </a:pPr>
+            <a:r>
+              <a:rPr lang="en-US" sz="1500" b="1" dirty="0">
+                <a:solidFill>
+                  <a:srgbClr val="0B2C4A"/>
+                </a:solidFill>
+                <a:latin typeface="Inter" pitchFamily="34" charset="0"/>
+                <a:ea typeface="Inter" pitchFamily="34" charset="-122"/>
+                <a:cs typeface="Inter" pitchFamily="34" charset="-120"/>
+              </a:rPr>
+              <a:t>32</a:t>
+            </a:r>
+            <a:endParaRPr lang="en-US" sz="1500" dirty="0"/>
+          </a:p>
+        </p:txBody>
+      </p:sp>
+      <p:sp>
+        <p:nvSpPr>
+          <p:cNvPr id="35" name="Text 33"/>
+          <p:cNvSpPr txBox="1"/>
+          <p:nvPr/>
+        </p:nvSpPr>
+        <p:spPr>
+          <a:xfrm>
+            <a:off x="4788408" y="2858414"/>
+            <a:ext cx="1825752" cy="755294"/>
+          </a:xfrm>
+          <a:prstGeom prst="rect">
+            <a:avLst/>
+          </a:prstGeom>
+          <a:noFill/>
+          <a:ln/>
+        </p:spPr>
+        <p:txBody>
+          <a:bodyPr wrap="square" lIns="0" tIns="0" rIns="0" bIns="0" rtlCol="0" anchor="ctr"/>
+          <a:lstStyle/>
+          <a:p>
+            <a:pPr indent="0" marL="0">
+              <a:spcAft>
+                <a:spcPts val="200"/>
+              </a:spcAft>
               <a:buNone/>
             </a:pPr>
             <a:r>
               <a:rPr lang="en-US" sz="1400" b="1" dirty="0">
                 <a:solidFill>
+                  <a:srgbClr val="1A1A1A"/>
+                </a:solidFill>
+                <a:latin typeface="Inter" pitchFamily="34" charset="0"/>
+                <a:ea typeface="Inter" pitchFamily="34" charset="-122"/>
+                <a:cs typeface="Inter" pitchFamily="34" charset="-120"/>
+              </a:rPr>
+              <a:t>Audi Reno</a:t>
+            </a:r>
+            <a:endParaRPr lang="en-US" sz="1400" dirty="0"/>
+          </a:p>
+          <a:p>
+            <a:pPr indent="0" marL="0">
+              <a:spcAft>
+                <a:spcPts val="200"/>
+              </a:spcAft>
+              <a:buNone/>
+            </a:pPr>
+            <a:r>
+              <a:rPr lang="en-US" sz="1200" dirty="0">
+                <a:solidFill>
+                  <a:srgbClr val="595959"/>
+                </a:solidFill>
+                <a:latin typeface="Inter" pitchFamily="34" charset="0"/>
+                <a:ea typeface="Inter" pitchFamily="34" charset="-122"/>
+                <a:cs typeface="Inter" pitchFamily="34" charset="-120"/>
+              </a:rPr>
+              <a:t>12,611  →  </a:t>
+            </a:r>
+            <a:pPr indent="0" marL="0">
+              <a:spcAft>
+                <a:spcPts val="200"/>
+              </a:spcAft>
+              <a:buNone/>
+            </a:pPr>
+            <a:r>
+              <a:rPr lang="en-US" sz="1200" b="1" dirty="0">
+                <a:solidFill>
                   <a:srgbClr val="A82B26"/>
                 </a:solidFill>
                 <a:latin typeface="Inter" pitchFamily="34" charset="0"/>
                 <a:ea typeface="Inter" pitchFamily="34" charset="-122"/>
                 <a:cs typeface="Inter" pitchFamily="34" charset="-120"/>
               </a:rPr>
-              <a:t>→  </a:t>
-            </a:r>
-            <a:pPr indent="0" marL="0">
-              <a:buNone/>
-            </a:pPr>
-            <a:r>
-              <a:rPr lang="en-US" sz="1400" b="1" dirty="0">
+              <a:t>10,684</a:t>
+            </a:r>
+            <a:endParaRPr lang="en-US" sz="1400" dirty="0"/>
+          </a:p>
+        </p:txBody>
+      </p:sp>
+      <p:sp>
+        <p:nvSpPr>
+          <p:cNvPr id="36" name="Text 34"/>
+          <p:cNvSpPr txBox="1"/>
+          <p:nvPr/>
+        </p:nvSpPr>
+        <p:spPr>
+          <a:xfrm>
+            <a:off x="6632448" y="2858414"/>
+            <a:ext cx="1115568" cy="755294"/>
+          </a:xfrm>
+          <a:prstGeom prst="rect">
+            <a:avLst/>
+          </a:prstGeom>
+          <a:noFill/>
+          <a:ln/>
+        </p:spPr>
+        <p:txBody>
+          <a:bodyPr wrap="square" lIns="0" tIns="0" rIns="0" bIns="0" rtlCol="0" anchor="ctr"/>
+          <a:lstStyle/>
+          <a:p>
+            <a:pPr algn="r" indent="0" marL="0">
+              <a:buNone/>
+            </a:pPr>
+            <a:r>
+              <a:rPr lang="en-US" sz="1600" b="1" dirty="0">
                 <a:solidFill>
                   <a:srgbClr val="A82B26"/>
                 </a:solidFill>
@@ -15411,46 +15328,7 @@
                 <a:ea typeface="Inter" pitchFamily="34" charset="-122"/>
                 <a:cs typeface="Inter" pitchFamily="34" charset="-120"/>
               </a:rPr>
-              <a:t>3,276</a:t>
-            </a:r>
-            <a:endParaRPr lang="en-US" sz="1400" dirty="0"/>
-          </a:p>
-        </p:txBody>
-      </p:sp>
-      <p:sp>
-        <p:nvSpPr>
-          <p:cNvPr id="42" name="Text 40"/>
-          <p:cNvSpPr txBox="1"/>
-          <p:nvPr/>
-        </p:nvSpPr>
-        <p:spPr>
-          <a:xfrm>
-            <a:off x="10415016" y="2121408"/>
-            <a:ext cx="1051560" cy="751637"/>
-          </a:xfrm>
-          <a:prstGeom prst="rect">
-            <a:avLst/>
-          </a:prstGeom>
-          <a:noFill/>
-          <a:ln/>
-        </p:spPr>
-        <p:txBody>
-          <a:bodyPr wrap="square" lIns="0" tIns="0" rIns="0" bIns="0" rtlCol="0" anchor="ctr"/>
-          <a:lstStyle/>
-          <a:p>
-            <a:pPr algn="r" indent="0" marL="0">
-              <a:buNone/>
-            </a:pPr>
-            <a:r>
-              <a:rPr lang="en-US" sz="1600" b="1" dirty="0">
-                <a:solidFill>
-                  <a:srgbClr val="A82B26"/>
-                </a:solidFill>
-                <a:latin typeface="Inter" pitchFamily="34" charset="0"/>
-                <a:ea typeface="Inter" pitchFamily="34" charset="-122"/>
-                <a:cs typeface="Inter" pitchFamily="34" charset="-120"/>
-              </a:rPr>
-              <a:t>−25.4%</a:t>
+              <a:t>−15.3%</a:t>
             </a:r>
             <a:endParaRPr lang="en-US" sz="1600" dirty="0"/>
           </a:p>
@@ -15458,198 +15336,14 @@
       </p:sp>
       <p:sp>
         <p:nvSpPr>
-          <p:cNvPr id="43" name="Text 41"/>
-          <p:cNvSpPr txBox="1"/>
-          <p:nvPr/>
-        </p:nvSpPr>
-        <p:spPr>
-          <a:xfrm>
-            <a:off x="6300216" y="2873045"/>
-            <a:ext cx="320040" cy="751637"/>
-          </a:xfrm>
-          <a:prstGeom prst="rect">
-            <a:avLst/>
-          </a:prstGeom>
-          <a:noFill/>
-          <a:ln/>
-        </p:spPr>
-        <p:txBody>
-          <a:bodyPr wrap="square" lIns="0" tIns="0" rIns="0" bIns="0" rtlCol="0" anchor="ctr"/>
-          <a:lstStyle/>
-          <a:p>
-            <a:pPr indent="0" marL="0">
-              <a:buNone/>
-            </a:pPr>
-            <a:r>
-              <a:rPr lang="en-US" sz="1500" b="1" dirty="0">
-                <a:solidFill>
-                  <a:srgbClr val="0B2C4A"/>
-                </a:solidFill>
-                <a:latin typeface="Inter" pitchFamily="34" charset="0"/>
-                <a:ea typeface="Inter" pitchFamily="34" charset="-122"/>
-                <a:cs typeface="Inter" pitchFamily="34" charset="-120"/>
-              </a:rPr>
-              <a:t>32</a:t>
-            </a:r>
-            <a:endParaRPr lang="en-US" sz="1500" dirty="0"/>
-          </a:p>
-        </p:txBody>
-      </p:sp>
-      <p:sp>
-        <p:nvSpPr>
-          <p:cNvPr id="44" name="Text 42"/>
-          <p:cNvSpPr txBox="1"/>
-          <p:nvPr/>
-        </p:nvSpPr>
-        <p:spPr>
-          <a:xfrm>
-            <a:off x="6665976" y="2873045"/>
-            <a:ext cx="1737360" cy="751637"/>
-          </a:xfrm>
-          <a:prstGeom prst="rect">
-            <a:avLst/>
-          </a:prstGeom>
-          <a:noFill/>
-          <a:ln/>
-        </p:spPr>
-        <p:txBody>
-          <a:bodyPr wrap="square" lIns="0" tIns="0" rIns="0" bIns="0" rtlCol="0" anchor="ctr"/>
-          <a:lstStyle/>
-          <a:p>
-            <a:pPr indent="0" marL="0">
-              <a:buNone/>
-            </a:pPr>
-            <a:r>
-              <a:rPr lang="en-US" sz="1400" b="1" dirty="0">
-                <a:solidFill>
-                  <a:srgbClr val="1A1A1A"/>
-                </a:solidFill>
-                <a:latin typeface="Inter" pitchFamily="34" charset="0"/>
-                <a:ea typeface="Inter" pitchFamily="34" charset="-122"/>
-                <a:cs typeface="Inter" pitchFamily="34" charset="-120"/>
-              </a:rPr>
-              <a:t>Audi Reno</a:t>
-            </a:r>
-            <a:endParaRPr lang="en-US" sz="1400" dirty="0"/>
-          </a:p>
-        </p:txBody>
-      </p:sp>
-      <p:sp>
-        <p:nvSpPr>
-          <p:cNvPr id="45" name="Text 43"/>
-          <p:cNvSpPr txBox="1"/>
-          <p:nvPr/>
-        </p:nvSpPr>
-        <p:spPr>
-          <a:xfrm>
-            <a:off x="8449056" y="2873045"/>
-            <a:ext cx="1920240" cy="751637"/>
-          </a:xfrm>
-          <a:prstGeom prst="rect">
-            <a:avLst/>
-          </a:prstGeom>
-          <a:noFill/>
-          <a:ln/>
-        </p:spPr>
-        <p:txBody>
-          <a:bodyPr wrap="square" lIns="0" tIns="0" rIns="0" bIns="0" rtlCol="0" anchor="ctr"/>
-          <a:lstStyle/>
-          <a:p>
-            <a:pPr indent="0" marL="0">
-              <a:buNone/>
-            </a:pPr>
-            <a:r>
-              <a:rPr lang="en-US" sz="1400" dirty="0">
-                <a:solidFill>
-                  <a:srgbClr val="595959"/>
-                </a:solidFill>
-                <a:latin typeface="Inter" pitchFamily="34" charset="0"/>
-                <a:ea typeface="Inter" pitchFamily="34" charset="-122"/>
-                <a:cs typeface="Inter" pitchFamily="34" charset="-120"/>
-              </a:rPr>
-              <a:t>12,611  </a:t>
-            </a:r>
-            <a:pPr indent="0" marL="0">
-              <a:buNone/>
-            </a:pPr>
-            <a:r>
-              <a:rPr lang="en-US" sz="1400" b="1" dirty="0">
-                <a:solidFill>
-                  <a:srgbClr val="A82B26"/>
-                </a:solidFill>
-                <a:latin typeface="Inter" pitchFamily="34" charset="0"/>
-                <a:ea typeface="Inter" pitchFamily="34" charset="-122"/>
-                <a:cs typeface="Inter" pitchFamily="34" charset="-120"/>
-              </a:rPr>
-              <a:t>→  </a:t>
-            </a:r>
-            <a:pPr indent="0" marL="0">
-              <a:buNone/>
-            </a:pPr>
-            <a:r>
-              <a:rPr lang="en-US" sz="1400" b="1" dirty="0">
-                <a:solidFill>
-                  <a:srgbClr val="A82B26"/>
-                </a:solidFill>
-                <a:latin typeface="Inter" pitchFamily="34" charset="0"/>
-                <a:ea typeface="Inter" pitchFamily="34" charset="-122"/>
-                <a:cs typeface="Inter" pitchFamily="34" charset="-120"/>
-              </a:rPr>
-              <a:t>10,684</a:t>
-            </a:r>
-            <a:endParaRPr lang="en-US" sz="1400" dirty="0"/>
-          </a:p>
-        </p:txBody>
-      </p:sp>
-      <p:sp>
-        <p:nvSpPr>
-          <p:cNvPr id="46" name="Text 44"/>
-          <p:cNvSpPr txBox="1"/>
-          <p:nvPr/>
-        </p:nvSpPr>
-        <p:spPr>
-          <a:xfrm>
-            <a:off x="10415016" y="2873045"/>
-            <a:ext cx="1051560" cy="751637"/>
-          </a:xfrm>
-          <a:prstGeom prst="rect">
-            <a:avLst/>
-          </a:prstGeom>
-          <a:noFill/>
-          <a:ln/>
-        </p:spPr>
-        <p:txBody>
-          <a:bodyPr wrap="square" lIns="0" tIns="0" rIns="0" bIns="0" rtlCol="0" anchor="ctr"/>
-          <a:lstStyle/>
-          <a:p>
-            <a:pPr algn="r" indent="0" marL="0">
-              <a:buNone/>
-            </a:pPr>
-            <a:r>
-              <a:rPr lang="en-US" sz="1600" b="1" dirty="0">
-                <a:solidFill>
-                  <a:srgbClr val="A82B26"/>
-                </a:solidFill>
-                <a:latin typeface="Inter" pitchFamily="34" charset="0"/>
-                <a:ea typeface="Inter" pitchFamily="34" charset="-122"/>
-                <a:cs typeface="Inter" pitchFamily="34" charset="-120"/>
-              </a:rPr>
-              <a:t>−15.3%</a:t>
-            </a:r>
-            <a:endParaRPr lang="en-US" sz="1600" dirty="0"/>
-          </a:p>
-        </p:txBody>
-      </p:sp>
-      <p:sp>
-        <p:nvSpPr>
-          <p:cNvPr id="47" name="Shape 45"/>
+          <p:cNvPr id="37" name="Shape 35"/>
           <p:cNvSpPr/>
           <p:nvPr/>
         </p:nvSpPr>
         <p:spPr>
           <a:xfrm>
-            <a:off x="6208776" y="3624682"/>
-            <a:ext cx="5321808" cy="751637"/>
+            <a:off x="4349496" y="3613709"/>
+            <a:ext cx="3489960" cy="755294"/>
           </a:xfrm>
           <a:prstGeom prst="rect">
             <a:avLst/>
@@ -15662,14 +15356,14 @@
       </p:sp>
       <p:sp>
         <p:nvSpPr>
-          <p:cNvPr id="48" name="Text 46"/>
-          <p:cNvSpPr txBox="1"/>
-          <p:nvPr/>
-        </p:nvSpPr>
-        <p:spPr>
-          <a:xfrm>
-            <a:off x="6300216" y="3624682"/>
-            <a:ext cx="320040" cy="751637"/>
+          <p:cNvPr id="38" name="Text 36"/>
+          <p:cNvSpPr txBox="1"/>
+          <p:nvPr/>
+        </p:nvSpPr>
+        <p:spPr>
+          <a:xfrm>
+            <a:off x="4440936" y="3613709"/>
+            <a:ext cx="365760" cy="755294"/>
           </a:xfrm>
           <a:prstGeom prst="rect">
             <a:avLst/>
@@ -15701,14 +15395,14 @@
       </p:sp>
       <p:sp>
         <p:nvSpPr>
-          <p:cNvPr id="49" name="Text 47"/>
-          <p:cNvSpPr txBox="1"/>
-          <p:nvPr/>
-        </p:nvSpPr>
-        <p:spPr>
-          <a:xfrm>
-            <a:off x="6665976" y="3624682"/>
-            <a:ext cx="1737360" cy="751637"/>
+          <p:cNvPr id="39" name="Text 37"/>
+          <p:cNvSpPr txBox="1"/>
+          <p:nvPr/>
+        </p:nvSpPr>
+        <p:spPr>
+          <a:xfrm>
+            <a:off x="4788408" y="3613709"/>
+            <a:ext cx="1825752" cy="755294"/>
           </a:xfrm>
           <a:prstGeom prst="rect">
             <a:avLst/>
@@ -15721,6 +15415,9 @@
           <a:lstStyle/>
           <a:p>
             <a:pPr indent="0" marL="0">
+              <a:spcAft>
+                <a:spcPts val="200"/>
+              </a:spcAft>
               <a:buNone/>
             </a:pPr>
             <a:r>
@@ -15736,34 +15433,15 @@
             </a:r>
             <a:endParaRPr lang="en-US" sz="1400" dirty="0"/>
           </a:p>
-        </p:txBody>
-      </p:sp>
-      <p:sp>
-        <p:nvSpPr>
-          <p:cNvPr id="50" name="Text 48"/>
-          <p:cNvSpPr txBox="1"/>
-          <p:nvPr/>
-        </p:nvSpPr>
-        <p:spPr>
-          <a:xfrm>
-            <a:off x="8449056" y="3624682"/>
-            <a:ext cx="1920240" cy="751637"/>
-          </a:xfrm>
-          <a:prstGeom prst="rect">
-            <a:avLst/>
-          </a:prstGeom>
-          <a:noFill/>
-          <a:ln/>
-        </p:spPr>
-        <p:txBody>
-          <a:bodyPr wrap="square" lIns="0" tIns="0" rIns="0" bIns="0" rtlCol="0" anchor="ctr"/>
-          <a:lstStyle/>
           <a:p>
             <a:pPr indent="0" marL="0">
-              <a:buNone/>
-            </a:pPr>
-            <a:r>
-              <a:rPr lang="en-US" sz="1400" dirty="0">
+              <a:spcAft>
+                <a:spcPts val="200"/>
+              </a:spcAft>
+              <a:buNone/>
+            </a:pPr>
+            <a:r>
+              <a:rPr lang="en-US" sz="1200" dirty="0">
                 <a:solidFill>
                   <a:srgbClr val="595959"/>
                 </a:solidFill>
@@ -15771,27 +15449,212 @@
                 <a:ea typeface="Inter" pitchFamily="34" charset="-122"/>
                 <a:cs typeface="Inter" pitchFamily="34" charset="-120"/>
               </a:rPr>
-              <a:t>8,659  </a:t>
+              <a:t>8,659  →  </a:t>
             </a:r>
             <a:pPr indent="0" marL="0">
+              <a:spcAft>
+                <a:spcPts val="200"/>
+              </a:spcAft>
+              <a:buNone/>
+            </a:pPr>
+            <a:r>
+              <a:rPr lang="en-US" sz="1200" b="1" dirty="0">
+                <a:solidFill>
+                  <a:srgbClr val="A82B26"/>
+                </a:solidFill>
+                <a:latin typeface="Inter" pitchFamily="34" charset="0"/>
+                <a:ea typeface="Inter" pitchFamily="34" charset="-122"/>
+                <a:cs typeface="Inter" pitchFamily="34" charset="-120"/>
+              </a:rPr>
+              <a:t>7,749</a:t>
+            </a:r>
+            <a:endParaRPr lang="en-US" sz="1400" dirty="0"/>
+          </a:p>
+        </p:txBody>
+      </p:sp>
+      <p:sp>
+        <p:nvSpPr>
+          <p:cNvPr id="40" name="Text 38"/>
+          <p:cNvSpPr txBox="1"/>
+          <p:nvPr/>
+        </p:nvSpPr>
+        <p:spPr>
+          <a:xfrm>
+            <a:off x="6632448" y="3613709"/>
+            <a:ext cx="1115568" cy="755294"/>
+          </a:xfrm>
+          <a:prstGeom prst="rect">
+            <a:avLst/>
+          </a:prstGeom>
+          <a:noFill/>
+          <a:ln/>
+        </p:spPr>
+        <p:txBody>
+          <a:bodyPr wrap="square" lIns="0" tIns="0" rIns="0" bIns="0" rtlCol="0" anchor="ctr"/>
+          <a:lstStyle/>
+          <a:p>
+            <a:pPr algn="r" indent="0" marL="0">
+              <a:buNone/>
+            </a:pPr>
+            <a:r>
+              <a:rPr lang="en-US" sz="1600" b="1" dirty="0">
+                <a:solidFill>
+                  <a:srgbClr val="A82B26"/>
+                </a:solidFill>
+                <a:latin typeface="Inter" pitchFamily="34" charset="0"/>
+                <a:ea typeface="Inter" pitchFamily="34" charset="-122"/>
+                <a:cs typeface="Inter" pitchFamily="34" charset="-120"/>
+              </a:rPr>
+              <a:t>−10.5%</a:t>
+            </a:r>
+            <a:endParaRPr lang="en-US" sz="1600" dirty="0"/>
+          </a:p>
+        </p:txBody>
+      </p:sp>
+      <p:sp>
+        <p:nvSpPr>
+          <p:cNvPr id="41" name="Text 39"/>
+          <p:cNvSpPr txBox="1"/>
+          <p:nvPr/>
+        </p:nvSpPr>
+        <p:spPr>
+          <a:xfrm>
+            <a:off x="4440936" y="4369003"/>
+            <a:ext cx="365760" cy="755294"/>
+          </a:xfrm>
+          <a:prstGeom prst="rect">
+            <a:avLst/>
+          </a:prstGeom>
+          <a:noFill/>
+          <a:ln/>
+        </p:spPr>
+        <p:txBody>
+          <a:bodyPr wrap="square" lIns="0" tIns="0" rIns="0" bIns="0" rtlCol="0" anchor="ctr"/>
+          <a:lstStyle/>
+          <a:p>
+            <a:pPr indent="0" marL="0">
+              <a:buNone/>
+            </a:pPr>
+            <a:r>
+              <a:rPr lang="en-US" sz="1500" b="1" dirty="0">
+                <a:solidFill>
+                  <a:srgbClr val="0B2C4A"/>
+                </a:solidFill>
+                <a:latin typeface="Inter" pitchFamily="34" charset="0"/>
+                <a:ea typeface="Inter" pitchFamily="34" charset="-122"/>
+                <a:cs typeface="Inter" pitchFamily="34" charset="-120"/>
+              </a:rPr>
+              <a:t>30</a:t>
+            </a:r>
+            <a:endParaRPr lang="en-US" sz="1500" dirty="0"/>
+          </a:p>
+        </p:txBody>
+      </p:sp>
+      <p:sp>
+        <p:nvSpPr>
+          <p:cNvPr id="42" name="Text 40"/>
+          <p:cNvSpPr txBox="1"/>
+          <p:nvPr/>
+        </p:nvSpPr>
+        <p:spPr>
+          <a:xfrm>
+            <a:off x="4788408" y="4369003"/>
+            <a:ext cx="1825752" cy="755294"/>
+          </a:xfrm>
+          <a:prstGeom prst="rect">
+            <a:avLst/>
+          </a:prstGeom>
+          <a:noFill/>
+          <a:ln/>
+        </p:spPr>
+        <p:txBody>
+          <a:bodyPr wrap="square" lIns="0" tIns="0" rIns="0" bIns="0" rtlCol="0" anchor="ctr"/>
+          <a:lstStyle/>
+          <a:p>
+            <a:pPr indent="0" marL="0">
+              <a:spcAft>
+                <a:spcPts val="200"/>
+              </a:spcAft>
               <a:buNone/>
             </a:pPr>
             <a:r>
               <a:rPr lang="en-US" sz="1400" b="1" dirty="0">
                 <a:solidFill>
+                  <a:srgbClr val="1A1A1A"/>
+                </a:solidFill>
+                <a:latin typeface="Inter" pitchFamily="34" charset="0"/>
+                <a:ea typeface="Inter" pitchFamily="34" charset="-122"/>
+                <a:cs typeface="Inter" pitchFamily="34" charset="-120"/>
+              </a:rPr>
+              <a:t>Honda Spokane</a:t>
+            </a:r>
+            <a:endParaRPr lang="en-US" sz="1400" dirty="0"/>
+          </a:p>
+          <a:p>
+            <a:pPr indent="0" marL="0">
+              <a:spcAft>
+                <a:spcPts val="200"/>
+              </a:spcAft>
+              <a:buNone/>
+            </a:pPr>
+            <a:r>
+              <a:rPr lang="en-US" sz="1200" dirty="0">
+                <a:solidFill>
+                  <a:srgbClr val="595959"/>
+                </a:solidFill>
+                <a:latin typeface="Inter" pitchFamily="34" charset="0"/>
+                <a:ea typeface="Inter" pitchFamily="34" charset="-122"/>
+                <a:cs typeface="Inter" pitchFamily="34" charset="-120"/>
+              </a:rPr>
+              <a:t>19,520  →  </a:t>
+            </a:r>
+            <a:pPr indent="0" marL="0">
+              <a:spcAft>
+                <a:spcPts val="200"/>
+              </a:spcAft>
+              <a:buNone/>
+            </a:pPr>
+            <a:r>
+              <a:rPr lang="en-US" sz="1200" b="1" dirty="0">
+                <a:solidFill>
                   <a:srgbClr val="A82B26"/>
                 </a:solidFill>
                 <a:latin typeface="Inter" pitchFamily="34" charset="0"/>
                 <a:ea typeface="Inter" pitchFamily="34" charset="-122"/>
                 <a:cs typeface="Inter" pitchFamily="34" charset="-120"/>
               </a:rPr>
-              <a:t>→  </a:t>
-            </a:r>
-            <a:pPr indent="0" marL="0">
-              <a:buNone/>
-            </a:pPr>
-            <a:r>
-              <a:rPr lang="en-US" sz="1400" b="1" dirty="0">
+              <a:t>17,926</a:t>
+            </a:r>
+            <a:endParaRPr lang="en-US" sz="1400" dirty="0"/>
+          </a:p>
+        </p:txBody>
+      </p:sp>
+      <p:sp>
+        <p:nvSpPr>
+          <p:cNvPr id="43" name="Text 41"/>
+          <p:cNvSpPr txBox="1"/>
+          <p:nvPr/>
+        </p:nvSpPr>
+        <p:spPr>
+          <a:xfrm>
+            <a:off x="6632448" y="4369003"/>
+            <a:ext cx="1115568" cy="755294"/>
+          </a:xfrm>
+          <a:prstGeom prst="rect">
+            <a:avLst/>
+          </a:prstGeom>
+          <a:noFill/>
+          <a:ln/>
+        </p:spPr>
+        <p:txBody>
+          <a:bodyPr wrap="square" lIns="0" tIns="0" rIns="0" bIns="0" rtlCol="0" anchor="ctr"/>
+          <a:lstStyle/>
+          <a:p>
+            <a:pPr algn="r" indent="0" marL="0">
+              <a:buNone/>
+            </a:pPr>
+            <a:r>
+              <a:rPr lang="en-US" sz="1600" b="1" dirty="0">
                 <a:solidFill>
                   <a:srgbClr val="A82B26"/>
                 </a:solidFill>
@@ -15799,46 +15662,7 @@
                 <a:ea typeface="Inter" pitchFamily="34" charset="-122"/>
                 <a:cs typeface="Inter" pitchFamily="34" charset="-120"/>
               </a:rPr>
-              <a:t>7,749</a:t>
-            </a:r>
-            <a:endParaRPr lang="en-US" sz="1400" dirty="0"/>
-          </a:p>
-        </p:txBody>
-      </p:sp>
-      <p:sp>
-        <p:nvSpPr>
-          <p:cNvPr id="51" name="Text 49"/>
-          <p:cNvSpPr txBox="1"/>
-          <p:nvPr/>
-        </p:nvSpPr>
-        <p:spPr>
-          <a:xfrm>
-            <a:off x="10415016" y="3624682"/>
-            <a:ext cx="1051560" cy="751637"/>
-          </a:xfrm>
-          <a:prstGeom prst="rect">
-            <a:avLst/>
-          </a:prstGeom>
-          <a:noFill/>
-          <a:ln/>
-        </p:spPr>
-        <p:txBody>
-          <a:bodyPr wrap="square" lIns="0" tIns="0" rIns="0" bIns="0" rtlCol="0" anchor="ctr"/>
-          <a:lstStyle/>
-          <a:p>
-            <a:pPr algn="r" indent="0" marL="0">
-              <a:buNone/>
-            </a:pPr>
-            <a:r>
-              <a:rPr lang="en-US" sz="1600" b="1" dirty="0">
-                <a:solidFill>
-                  <a:srgbClr val="A82B26"/>
-                </a:solidFill>
-                <a:latin typeface="Inter" pitchFamily="34" charset="0"/>
-                <a:ea typeface="Inter" pitchFamily="34" charset="-122"/>
-                <a:cs typeface="Inter" pitchFamily="34" charset="-120"/>
-              </a:rPr>
-              <a:t>−10.5%</a:t>
+              <a:t>−8.2%</a:t>
             </a:r>
             <a:endParaRPr lang="en-US" sz="1600" dirty="0"/>
           </a:p>
@@ -15846,198 +15670,14 @@
       </p:sp>
       <p:sp>
         <p:nvSpPr>
-          <p:cNvPr id="52" name="Text 50"/>
-          <p:cNvSpPr txBox="1"/>
-          <p:nvPr/>
-        </p:nvSpPr>
-        <p:spPr>
-          <a:xfrm>
-            <a:off x="6300216" y="4376318"/>
-            <a:ext cx="320040" cy="751637"/>
-          </a:xfrm>
-          <a:prstGeom prst="rect">
-            <a:avLst/>
-          </a:prstGeom>
-          <a:noFill/>
-          <a:ln/>
-        </p:spPr>
-        <p:txBody>
-          <a:bodyPr wrap="square" lIns="0" tIns="0" rIns="0" bIns="0" rtlCol="0" anchor="ctr"/>
-          <a:lstStyle/>
-          <a:p>
-            <a:pPr indent="0" marL="0">
-              <a:buNone/>
-            </a:pPr>
-            <a:r>
-              <a:rPr lang="en-US" sz="1500" b="1" dirty="0">
-                <a:solidFill>
-                  <a:srgbClr val="0B2C4A"/>
-                </a:solidFill>
-                <a:latin typeface="Inter" pitchFamily="34" charset="0"/>
-                <a:ea typeface="Inter" pitchFamily="34" charset="-122"/>
-                <a:cs typeface="Inter" pitchFamily="34" charset="-120"/>
-              </a:rPr>
-              <a:t>30</a:t>
-            </a:r>
-            <a:endParaRPr lang="en-US" sz="1500" dirty="0"/>
-          </a:p>
-        </p:txBody>
-      </p:sp>
-      <p:sp>
-        <p:nvSpPr>
-          <p:cNvPr id="53" name="Text 51"/>
-          <p:cNvSpPr txBox="1"/>
-          <p:nvPr/>
-        </p:nvSpPr>
-        <p:spPr>
-          <a:xfrm>
-            <a:off x="6665976" y="4376318"/>
-            <a:ext cx="1737360" cy="751637"/>
-          </a:xfrm>
-          <a:prstGeom prst="rect">
-            <a:avLst/>
-          </a:prstGeom>
-          <a:noFill/>
-          <a:ln/>
-        </p:spPr>
-        <p:txBody>
-          <a:bodyPr wrap="square" lIns="0" tIns="0" rIns="0" bIns="0" rtlCol="0" anchor="ctr"/>
-          <a:lstStyle/>
-          <a:p>
-            <a:pPr indent="0" marL="0">
-              <a:buNone/>
-            </a:pPr>
-            <a:r>
-              <a:rPr lang="en-US" sz="1400" b="1" dirty="0">
-                <a:solidFill>
-                  <a:srgbClr val="1A1A1A"/>
-                </a:solidFill>
-                <a:latin typeface="Inter" pitchFamily="34" charset="0"/>
-                <a:ea typeface="Inter" pitchFamily="34" charset="-122"/>
-                <a:cs typeface="Inter" pitchFamily="34" charset="-120"/>
-              </a:rPr>
-              <a:t>Honda Spokane</a:t>
-            </a:r>
-            <a:endParaRPr lang="en-US" sz="1400" dirty="0"/>
-          </a:p>
-        </p:txBody>
-      </p:sp>
-      <p:sp>
-        <p:nvSpPr>
-          <p:cNvPr id="54" name="Text 52"/>
-          <p:cNvSpPr txBox="1"/>
-          <p:nvPr/>
-        </p:nvSpPr>
-        <p:spPr>
-          <a:xfrm>
-            <a:off x="8449056" y="4376318"/>
-            <a:ext cx="1920240" cy="751637"/>
-          </a:xfrm>
-          <a:prstGeom prst="rect">
-            <a:avLst/>
-          </a:prstGeom>
-          <a:noFill/>
-          <a:ln/>
-        </p:spPr>
-        <p:txBody>
-          <a:bodyPr wrap="square" lIns="0" tIns="0" rIns="0" bIns="0" rtlCol="0" anchor="ctr"/>
-          <a:lstStyle/>
-          <a:p>
-            <a:pPr indent="0" marL="0">
-              <a:buNone/>
-            </a:pPr>
-            <a:r>
-              <a:rPr lang="en-US" sz="1400" dirty="0">
-                <a:solidFill>
-                  <a:srgbClr val="595959"/>
-                </a:solidFill>
-                <a:latin typeface="Inter" pitchFamily="34" charset="0"/>
-                <a:ea typeface="Inter" pitchFamily="34" charset="-122"/>
-                <a:cs typeface="Inter" pitchFamily="34" charset="-120"/>
-              </a:rPr>
-              <a:t>19,520  </a:t>
-            </a:r>
-            <a:pPr indent="0" marL="0">
-              <a:buNone/>
-            </a:pPr>
-            <a:r>
-              <a:rPr lang="en-US" sz="1400" b="1" dirty="0">
-                <a:solidFill>
-                  <a:srgbClr val="A82B26"/>
-                </a:solidFill>
-                <a:latin typeface="Inter" pitchFamily="34" charset="0"/>
-                <a:ea typeface="Inter" pitchFamily="34" charset="-122"/>
-                <a:cs typeface="Inter" pitchFamily="34" charset="-120"/>
-              </a:rPr>
-              <a:t>→  </a:t>
-            </a:r>
-            <a:pPr indent="0" marL="0">
-              <a:buNone/>
-            </a:pPr>
-            <a:r>
-              <a:rPr lang="en-US" sz="1400" b="1" dirty="0">
-                <a:solidFill>
-                  <a:srgbClr val="A82B26"/>
-                </a:solidFill>
-                <a:latin typeface="Inter" pitchFamily="34" charset="0"/>
-                <a:ea typeface="Inter" pitchFamily="34" charset="-122"/>
-                <a:cs typeface="Inter" pitchFamily="34" charset="-120"/>
-              </a:rPr>
-              <a:t>17,926</a:t>
-            </a:r>
-            <a:endParaRPr lang="en-US" sz="1400" dirty="0"/>
-          </a:p>
-        </p:txBody>
-      </p:sp>
-      <p:sp>
-        <p:nvSpPr>
-          <p:cNvPr id="55" name="Text 53"/>
-          <p:cNvSpPr txBox="1"/>
-          <p:nvPr/>
-        </p:nvSpPr>
-        <p:spPr>
-          <a:xfrm>
-            <a:off x="10415016" y="4376318"/>
-            <a:ext cx="1051560" cy="751637"/>
-          </a:xfrm>
-          <a:prstGeom prst="rect">
-            <a:avLst/>
-          </a:prstGeom>
-          <a:noFill/>
-          <a:ln/>
-        </p:spPr>
-        <p:txBody>
-          <a:bodyPr wrap="square" lIns="0" tIns="0" rIns="0" bIns="0" rtlCol="0" anchor="ctr"/>
-          <a:lstStyle/>
-          <a:p>
-            <a:pPr algn="r" indent="0" marL="0">
-              <a:buNone/>
-            </a:pPr>
-            <a:r>
-              <a:rPr lang="en-US" sz="1600" b="1" dirty="0">
-                <a:solidFill>
-                  <a:srgbClr val="A82B26"/>
-                </a:solidFill>
-                <a:latin typeface="Inter" pitchFamily="34" charset="0"/>
-                <a:ea typeface="Inter" pitchFamily="34" charset="-122"/>
-                <a:cs typeface="Inter" pitchFamily="34" charset="-120"/>
-              </a:rPr>
-              <a:t>−8.2%</a:t>
-            </a:r>
-            <a:endParaRPr lang="en-US" sz="1600" dirty="0"/>
-          </a:p>
-        </p:txBody>
-      </p:sp>
-      <p:sp>
-        <p:nvSpPr>
-          <p:cNvPr id="56" name="Shape 54"/>
+          <p:cNvPr id="44" name="Shape 42"/>
           <p:cNvSpPr/>
           <p:nvPr/>
         </p:nvSpPr>
         <p:spPr>
           <a:xfrm>
-            <a:off x="6208776" y="5127955"/>
-            <a:ext cx="5321808" cy="751637"/>
+            <a:off x="4349496" y="5124298"/>
+            <a:ext cx="3489960" cy="755294"/>
           </a:xfrm>
           <a:prstGeom prst="rect">
             <a:avLst/>
@@ -16050,14 +15690,623 @@
       </p:sp>
       <p:sp>
         <p:nvSpPr>
+          <p:cNvPr id="45" name="Text 43"/>
+          <p:cNvSpPr txBox="1"/>
+          <p:nvPr/>
+        </p:nvSpPr>
+        <p:spPr>
+          <a:xfrm>
+            <a:off x="4440936" y="5124298"/>
+            <a:ext cx="365760" cy="755294"/>
+          </a:xfrm>
+          <a:prstGeom prst="rect">
+            <a:avLst/>
+          </a:prstGeom>
+          <a:noFill/>
+          <a:ln/>
+        </p:spPr>
+        <p:txBody>
+          <a:bodyPr wrap="square" lIns="0" tIns="0" rIns="0" bIns="0" rtlCol="0" anchor="ctr"/>
+          <a:lstStyle/>
+          <a:p>
+            <a:pPr indent="0" marL="0">
+              <a:buNone/>
+            </a:pPr>
+            <a:r>
+              <a:rPr lang="en-US" sz="1500" b="1" dirty="0">
+                <a:solidFill>
+                  <a:srgbClr val="0B2C4A"/>
+                </a:solidFill>
+                <a:latin typeface="Inter" pitchFamily="34" charset="0"/>
+                <a:ea typeface="Inter" pitchFamily="34" charset="-122"/>
+                <a:cs typeface="Inter" pitchFamily="34" charset="-120"/>
+              </a:rPr>
+              <a:t>29</a:t>
+            </a:r>
+            <a:endParaRPr lang="en-US" sz="1500" dirty="0"/>
+          </a:p>
+        </p:txBody>
+      </p:sp>
+      <p:sp>
+        <p:nvSpPr>
+          <p:cNvPr id="46" name="Text 44"/>
+          <p:cNvSpPr txBox="1"/>
+          <p:nvPr/>
+        </p:nvSpPr>
+        <p:spPr>
+          <a:xfrm>
+            <a:off x="4788408" y="5124298"/>
+            <a:ext cx="1825752" cy="755294"/>
+          </a:xfrm>
+          <a:prstGeom prst="rect">
+            <a:avLst/>
+          </a:prstGeom>
+          <a:noFill/>
+          <a:ln/>
+        </p:spPr>
+        <p:txBody>
+          <a:bodyPr wrap="square" lIns="0" tIns="0" rIns="0" bIns="0" rtlCol="0" anchor="ctr"/>
+          <a:lstStyle/>
+          <a:p>
+            <a:pPr indent="0" marL="0">
+              <a:spcAft>
+                <a:spcPts val="200"/>
+              </a:spcAft>
+              <a:buNone/>
+            </a:pPr>
+            <a:r>
+              <a:rPr lang="en-US" sz="1400" b="1" dirty="0">
+                <a:solidFill>
+                  <a:srgbClr val="1A1A1A"/>
+                </a:solidFill>
+                <a:latin typeface="Inter" pitchFamily="34" charset="0"/>
+                <a:ea typeface="Inter" pitchFamily="34" charset="-122"/>
+                <a:cs typeface="Inter" pitchFamily="34" charset="-120"/>
+              </a:rPr>
+              <a:t>Chevy LV</a:t>
+            </a:r>
+            <a:endParaRPr lang="en-US" sz="1400" dirty="0"/>
+          </a:p>
+          <a:p>
+            <a:pPr indent="0" marL="0">
+              <a:spcAft>
+                <a:spcPts val="200"/>
+              </a:spcAft>
+              <a:buNone/>
+            </a:pPr>
+            <a:r>
+              <a:rPr lang="en-US" sz="1200" dirty="0">
+                <a:solidFill>
+                  <a:srgbClr val="595959"/>
+                </a:solidFill>
+                <a:latin typeface="Inter" pitchFamily="34" charset="0"/>
+                <a:ea typeface="Inter" pitchFamily="34" charset="-122"/>
+                <a:cs typeface="Inter" pitchFamily="34" charset="-120"/>
+              </a:rPr>
+              <a:t>48,486  →  </a:t>
+            </a:r>
+            <a:pPr indent="0" marL="0">
+              <a:spcAft>
+                <a:spcPts val="200"/>
+              </a:spcAft>
+              <a:buNone/>
+            </a:pPr>
+            <a:r>
+              <a:rPr lang="en-US" sz="1200" b="1" dirty="0">
+                <a:solidFill>
+                  <a:srgbClr val="A82B26"/>
+                </a:solidFill>
+                <a:latin typeface="Inter" pitchFamily="34" charset="0"/>
+                <a:ea typeface="Inter" pitchFamily="34" charset="-122"/>
+                <a:cs typeface="Inter" pitchFamily="34" charset="-120"/>
+              </a:rPr>
+              <a:t>44,883</a:t>
+            </a:r>
+            <a:endParaRPr lang="en-US" sz="1400" dirty="0"/>
+          </a:p>
+        </p:txBody>
+      </p:sp>
+      <p:sp>
+        <p:nvSpPr>
+          <p:cNvPr id="47" name="Text 45"/>
+          <p:cNvSpPr txBox="1"/>
+          <p:nvPr/>
+        </p:nvSpPr>
+        <p:spPr>
+          <a:xfrm>
+            <a:off x="6632448" y="5124298"/>
+            <a:ext cx="1115568" cy="755294"/>
+          </a:xfrm>
+          <a:prstGeom prst="rect">
+            <a:avLst/>
+          </a:prstGeom>
+          <a:noFill/>
+          <a:ln/>
+        </p:spPr>
+        <p:txBody>
+          <a:bodyPr wrap="square" lIns="0" tIns="0" rIns="0" bIns="0" rtlCol="0" anchor="ctr"/>
+          <a:lstStyle/>
+          <a:p>
+            <a:pPr algn="r" indent="0" marL="0">
+              <a:buNone/>
+            </a:pPr>
+            <a:r>
+              <a:rPr lang="en-US" sz="1600" b="1" dirty="0">
+                <a:solidFill>
+                  <a:srgbClr val="A82B26"/>
+                </a:solidFill>
+                <a:latin typeface="Inter" pitchFamily="34" charset="0"/>
+                <a:ea typeface="Inter" pitchFamily="34" charset="-122"/>
+                <a:cs typeface="Inter" pitchFamily="34" charset="-120"/>
+              </a:rPr>
+              <a:t>−7.4%</a:t>
+            </a:r>
+            <a:endParaRPr lang="en-US" sz="1600" dirty="0"/>
+          </a:p>
+        </p:txBody>
+      </p:sp>
+      <p:sp>
+        <p:nvSpPr>
+          <p:cNvPr id="48" name="Shape 46"/>
+          <p:cNvSpPr/>
+          <p:nvPr/>
+        </p:nvSpPr>
+        <p:spPr>
+          <a:xfrm>
+            <a:off x="8040624" y="1371600"/>
+            <a:ext cx="3489960" cy="45720"/>
+          </a:xfrm>
+          <a:prstGeom prst="rect">
+            <a:avLst/>
+          </a:prstGeom>
+          <a:solidFill>
+            <a:srgbClr val="2587C5"/>
+          </a:solidFill>
+          <a:ln/>
+        </p:spPr>
+      </p:sp>
+      <p:sp>
+        <p:nvSpPr>
+          <p:cNvPr id="49" name="Text 47"/>
+          <p:cNvSpPr txBox="1"/>
+          <p:nvPr/>
+        </p:nvSpPr>
+        <p:spPr>
+          <a:xfrm>
+            <a:off x="8132064" y="1444752"/>
+            <a:ext cx="3307080" cy="274320"/>
+          </a:xfrm>
+          <a:prstGeom prst="rect">
+            <a:avLst/>
+          </a:prstGeom>
+          <a:noFill/>
+          <a:ln/>
+        </p:spPr>
+        <p:txBody>
+          <a:bodyPr wrap="square" lIns="0" tIns="0" rIns="0" bIns="0" rtlCol="0" anchor="ctr"/>
+          <a:lstStyle/>
+          <a:p>
+            <a:pPr indent="0" marL="0">
+              <a:buNone/>
+            </a:pPr>
+            <a:r>
+              <a:rPr lang="en-US" sz="1500" b="1" spc="100" kern="0" dirty="0">
+                <a:solidFill>
+                  <a:srgbClr val="0B2C4A"/>
+                </a:solidFill>
+                <a:latin typeface="Inter" pitchFamily="34" charset="0"/>
+                <a:ea typeface="Inter" pitchFamily="34" charset="-122"/>
+                <a:cs typeface="Inter" pitchFamily="34" charset="-120"/>
+              </a:rPr>
+              <a:t>TOP 5 MOVING NOW</a:t>
+            </a:r>
+            <a:endParaRPr lang="en-US" sz="1500" dirty="0"/>
+          </a:p>
+        </p:txBody>
+      </p:sp>
+      <p:sp>
+        <p:nvSpPr>
+          <p:cNvPr id="50" name="Text 48"/>
+          <p:cNvSpPr txBox="1"/>
+          <p:nvPr/>
+        </p:nvSpPr>
+        <p:spPr>
+          <a:xfrm>
+            <a:off x="8132064" y="1737360"/>
+            <a:ext cx="3307080" cy="274320"/>
+          </a:xfrm>
+          <a:prstGeom prst="rect">
+            <a:avLst/>
+          </a:prstGeom>
+          <a:noFill/>
+          <a:ln/>
+        </p:spPr>
+        <p:txBody>
+          <a:bodyPr wrap="square" lIns="0" tIns="0" rIns="0" bIns="0" rtlCol="0" anchor="ctr"/>
+          <a:lstStyle/>
+          <a:p>
+            <a:pPr indent="0" marL="0">
+              <a:buNone/>
+            </a:pPr>
+            <a:r>
+              <a:rPr lang="en-US" sz="1200" dirty="0">
+                <a:solidFill>
+                  <a:srgbClr val="595959"/>
+                </a:solidFill>
+                <a:latin typeface="Inter" pitchFamily="34" charset="0"/>
+                <a:ea typeface="Inter" pitchFamily="34" charset="-122"/>
+                <a:cs typeface="Inter" pitchFamily="34" charset="-120"/>
+              </a:rPr>
+              <a:t>Jul–Sep vs Jan–Mar 2026, per month</a:t>
+            </a:r>
+            <a:endParaRPr lang="en-US" sz="1200" dirty="0"/>
+          </a:p>
+        </p:txBody>
+      </p:sp>
+      <p:sp>
+        <p:nvSpPr>
+          <p:cNvPr id="51" name="Shape 49"/>
+          <p:cNvSpPr/>
+          <p:nvPr/>
+        </p:nvSpPr>
+        <p:spPr>
+          <a:xfrm>
+            <a:off x="8040624" y="2103120"/>
+            <a:ext cx="3489960" cy="755294"/>
+          </a:xfrm>
+          <a:prstGeom prst="rect">
+            <a:avLst/>
+          </a:prstGeom>
+          <a:solidFill>
+            <a:srgbClr val="F7F7F7"/>
+          </a:solidFill>
+          <a:ln/>
+        </p:spPr>
+      </p:sp>
+      <p:sp>
+        <p:nvSpPr>
+          <p:cNvPr id="52" name="Text 50"/>
+          <p:cNvSpPr txBox="1"/>
+          <p:nvPr/>
+        </p:nvSpPr>
+        <p:spPr>
+          <a:xfrm>
+            <a:off x="8132064" y="2103120"/>
+            <a:ext cx="365760" cy="755294"/>
+          </a:xfrm>
+          <a:prstGeom prst="rect">
+            <a:avLst/>
+          </a:prstGeom>
+          <a:noFill/>
+          <a:ln/>
+        </p:spPr>
+        <p:txBody>
+          <a:bodyPr wrap="square" lIns="0" tIns="0" rIns="0" bIns="0" rtlCol="0" anchor="ctr"/>
+          <a:lstStyle/>
+          <a:p>
+            <a:pPr indent="0" marL="0">
+              <a:buNone/>
+            </a:pPr>
+            <a:r>
+              <a:rPr lang="en-US" sz="1500" b="1" dirty="0">
+                <a:solidFill>
+                  <a:srgbClr val="0B2C4A"/>
+                </a:solidFill>
+                <a:latin typeface="Inter" pitchFamily="34" charset="0"/>
+                <a:ea typeface="Inter" pitchFamily="34" charset="-122"/>
+                <a:cs typeface="Inter" pitchFamily="34" charset="-120"/>
+              </a:rPr>
+              <a:t>1</a:t>
+            </a:r>
+            <a:endParaRPr lang="en-US" sz="1500" dirty="0"/>
+          </a:p>
+        </p:txBody>
+      </p:sp>
+      <p:sp>
+        <p:nvSpPr>
+          <p:cNvPr id="53" name="Text 51"/>
+          <p:cNvSpPr txBox="1"/>
+          <p:nvPr/>
+        </p:nvSpPr>
+        <p:spPr>
+          <a:xfrm>
+            <a:off x="8479536" y="2103120"/>
+            <a:ext cx="1825752" cy="755294"/>
+          </a:xfrm>
+          <a:prstGeom prst="rect">
+            <a:avLst/>
+          </a:prstGeom>
+          <a:noFill/>
+          <a:ln/>
+        </p:spPr>
+        <p:txBody>
+          <a:bodyPr wrap="square" lIns="0" tIns="0" rIns="0" bIns="0" rtlCol="0" anchor="ctr"/>
+          <a:lstStyle/>
+          <a:p>
+            <a:pPr indent="0" marL="0">
+              <a:spcAft>
+                <a:spcPts val="200"/>
+              </a:spcAft>
+              <a:buNone/>
+            </a:pPr>
+            <a:r>
+              <a:rPr lang="en-US" sz="1400" b="1" dirty="0">
+                <a:solidFill>
+                  <a:srgbClr val="1A1A1A"/>
+                </a:solidFill>
+                <a:latin typeface="Inter" pitchFamily="34" charset="0"/>
+                <a:ea typeface="Inter" pitchFamily="34" charset="-122"/>
+                <a:cs typeface="Inter" pitchFamily="34" charset="-120"/>
+              </a:rPr>
+              <a:t>Mazda</a:t>
+            </a:r>
+            <a:endParaRPr lang="en-US" sz="1400" dirty="0"/>
+          </a:p>
+          <a:p>
+            <a:pPr indent="0" marL="0">
+              <a:spcAft>
+                <a:spcPts val="200"/>
+              </a:spcAft>
+              <a:buNone/>
+            </a:pPr>
+            <a:r>
+              <a:rPr lang="en-US" sz="1200" dirty="0">
+                <a:solidFill>
+                  <a:srgbClr val="595959"/>
+                </a:solidFill>
+                <a:latin typeface="Inter" pitchFamily="34" charset="0"/>
+                <a:ea typeface="Inter" pitchFamily="34" charset="-122"/>
+                <a:cs typeface="Inter" pitchFamily="34" charset="-120"/>
+              </a:rPr>
+              <a:t>779  →  </a:t>
+            </a:r>
+            <a:pPr indent="0" marL="0">
+              <a:spcAft>
+                <a:spcPts val="200"/>
+              </a:spcAft>
+              <a:buNone/>
+            </a:pPr>
+            <a:r>
+              <a:rPr lang="en-US" sz="1200" b="1" dirty="0">
+                <a:solidFill>
+                  <a:srgbClr val="0B7A4A"/>
+                </a:solidFill>
+                <a:latin typeface="Inter" pitchFamily="34" charset="0"/>
+                <a:ea typeface="Inter" pitchFamily="34" charset="-122"/>
+                <a:cs typeface="Inter" pitchFamily="34" charset="-120"/>
+              </a:rPr>
+              <a:t>1,102</a:t>
+            </a:r>
+            <a:endParaRPr lang="en-US" sz="1400" dirty="0"/>
+          </a:p>
+        </p:txBody>
+      </p:sp>
+      <p:sp>
+        <p:nvSpPr>
+          <p:cNvPr id="54" name="Text 52"/>
+          <p:cNvSpPr txBox="1"/>
+          <p:nvPr/>
+        </p:nvSpPr>
+        <p:spPr>
+          <a:xfrm>
+            <a:off x="10323576" y="2103120"/>
+            <a:ext cx="1115568" cy="755294"/>
+          </a:xfrm>
+          <a:prstGeom prst="rect">
+            <a:avLst/>
+          </a:prstGeom>
+          <a:noFill/>
+          <a:ln/>
+        </p:spPr>
+        <p:txBody>
+          <a:bodyPr wrap="square" lIns="0" tIns="0" rIns="0" bIns="0" rtlCol="0" anchor="ctr"/>
+          <a:lstStyle/>
+          <a:p>
+            <a:pPr algn="r" indent="0" marL="0">
+              <a:buNone/>
+            </a:pPr>
+            <a:r>
+              <a:rPr lang="en-US" sz="1600" b="1" dirty="0">
+                <a:solidFill>
+                  <a:srgbClr val="0B7A4A"/>
+                </a:solidFill>
+                <a:latin typeface="Inter" pitchFamily="34" charset="0"/>
+                <a:ea typeface="Inter" pitchFamily="34" charset="-122"/>
+                <a:cs typeface="Inter" pitchFamily="34" charset="-120"/>
+              </a:rPr>
+              <a:t>+41.5%</a:t>
+            </a:r>
+            <a:endParaRPr lang="en-US" sz="1600" dirty="0"/>
+          </a:p>
+        </p:txBody>
+      </p:sp>
+      <p:sp>
+        <p:nvSpPr>
+          <p:cNvPr id="55" name="Text 53"/>
+          <p:cNvSpPr txBox="1"/>
+          <p:nvPr/>
+        </p:nvSpPr>
+        <p:spPr>
+          <a:xfrm>
+            <a:off x="8132064" y="2858414"/>
+            <a:ext cx="365760" cy="755294"/>
+          </a:xfrm>
+          <a:prstGeom prst="rect">
+            <a:avLst/>
+          </a:prstGeom>
+          <a:noFill/>
+          <a:ln/>
+        </p:spPr>
+        <p:txBody>
+          <a:bodyPr wrap="square" lIns="0" tIns="0" rIns="0" bIns="0" rtlCol="0" anchor="ctr"/>
+          <a:lstStyle/>
+          <a:p>
+            <a:pPr indent="0" marL="0">
+              <a:buNone/>
+            </a:pPr>
+            <a:r>
+              <a:rPr lang="en-US" sz="1500" b="1" dirty="0">
+                <a:solidFill>
+                  <a:srgbClr val="0B2C4A"/>
+                </a:solidFill>
+                <a:latin typeface="Inter" pitchFamily="34" charset="0"/>
+                <a:ea typeface="Inter" pitchFamily="34" charset="-122"/>
+                <a:cs typeface="Inter" pitchFamily="34" charset="-120"/>
+              </a:rPr>
+              <a:t>2</a:t>
+            </a:r>
+            <a:endParaRPr lang="en-US" sz="1500" dirty="0"/>
+          </a:p>
+        </p:txBody>
+      </p:sp>
+      <p:sp>
+        <p:nvSpPr>
+          <p:cNvPr id="56" name="Text 54"/>
+          <p:cNvSpPr txBox="1"/>
+          <p:nvPr/>
+        </p:nvSpPr>
+        <p:spPr>
+          <a:xfrm>
+            <a:off x="8479536" y="2858414"/>
+            <a:ext cx="1825752" cy="755294"/>
+          </a:xfrm>
+          <a:prstGeom prst="rect">
+            <a:avLst/>
+          </a:prstGeom>
+          <a:noFill/>
+          <a:ln/>
+        </p:spPr>
+        <p:txBody>
+          <a:bodyPr wrap="square" lIns="0" tIns="0" rIns="0" bIns="0" rtlCol="0" anchor="ctr"/>
+          <a:lstStyle/>
+          <a:p>
+            <a:pPr indent="0" marL="0">
+              <a:spcAft>
+                <a:spcPts val="200"/>
+              </a:spcAft>
+              <a:buNone/>
+            </a:pPr>
+            <a:r>
+              <a:rPr lang="en-US" sz="1400" b="1" dirty="0">
+                <a:solidFill>
+                  <a:srgbClr val="1A1A1A"/>
+                </a:solidFill>
+                <a:latin typeface="Inter" pitchFamily="34" charset="0"/>
+                <a:ea typeface="Inter" pitchFamily="34" charset="-122"/>
+                <a:cs typeface="Inter" pitchFamily="34" charset="-120"/>
+              </a:rPr>
+              <a:t>CDJR Post Falls</a:t>
+            </a:r>
+            <a:endParaRPr lang="en-US" sz="1400" dirty="0"/>
+          </a:p>
+          <a:p>
+            <a:pPr indent="0" marL="0">
+              <a:spcAft>
+                <a:spcPts val="200"/>
+              </a:spcAft>
+              <a:buNone/>
+            </a:pPr>
+            <a:r>
+              <a:rPr lang="en-US" sz="1200" dirty="0">
+                <a:solidFill>
+                  <a:srgbClr val="595959"/>
+                </a:solidFill>
+                <a:latin typeface="Inter" pitchFamily="34" charset="0"/>
+                <a:ea typeface="Inter" pitchFamily="34" charset="-122"/>
+                <a:cs typeface="Inter" pitchFamily="34" charset="-120"/>
+              </a:rPr>
+              <a:t>1,193  →  </a:t>
+            </a:r>
+            <a:pPr indent="0" marL="0">
+              <a:spcAft>
+                <a:spcPts val="200"/>
+              </a:spcAft>
+              <a:buNone/>
+            </a:pPr>
+            <a:r>
+              <a:rPr lang="en-US" sz="1200" b="1" dirty="0">
+                <a:solidFill>
+                  <a:srgbClr val="0B7A4A"/>
+                </a:solidFill>
+                <a:latin typeface="Inter" pitchFamily="34" charset="0"/>
+                <a:ea typeface="Inter" pitchFamily="34" charset="-122"/>
+                <a:cs typeface="Inter" pitchFamily="34" charset="-120"/>
+              </a:rPr>
+              <a:t>1,537</a:t>
+            </a:r>
+            <a:endParaRPr lang="en-US" sz="1400" dirty="0"/>
+          </a:p>
+        </p:txBody>
+      </p:sp>
+      <p:sp>
+        <p:nvSpPr>
           <p:cNvPr id="57" name="Text 55"/>
           <p:cNvSpPr txBox="1"/>
           <p:nvPr/>
         </p:nvSpPr>
         <p:spPr>
           <a:xfrm>
-            <a:off x="6300216" y="5127955"/>
-            <a:ext cx="320040" cy="751637"/>
+            <a:off x="10323576" y="2858414"/>
+            <a:ext cx="1115568" cy="755294"/>
+          </a:xfrm>
+          <a:prstGeom prst="rect">
+            <a:avLst/>
+          </a:prstGeom>
+          <a:noFill/>
+          <a:ln/>
+        </p:spPr>
+        <p:txBody>
+          <a:bodyPr wrap="square" lIns="0" tIns="0" rIns="0" bIns="0" rtlCol="0" anchor="ctr"/>
+          <a:lstStyle/>
+          <a:p>
+            <a:pPr algn="r" indent="0" marL="0">
+              <a:buNone/>
+            </a:pPr>
+            <a:r>
+              <a:rPr lang="en-US" sz="1600" b="1" dirty="0">
+                <a:solidFill>
+                  <a:srgbClr val="0B7A4A"/>
+                </a:solidFill>
+                <a:latin typeface="Inter" pitchFamily="34" charset="0"/>
+                <a:ea typeface="Inter" pitchFamily="34" charset="-122"/>
+                <a:cs typeface="Inter" pitchFamily="34" charset="-120"/>
+              </a:rPr>
+              <a:t>+28.8%</a:t>
+            </a:r>
+            <a:endParaRPr lang="en-US" sz="1600" dirty="0"/>
+          </a:p>
+        </p:txBody>
+      </p:sp>
+      <p:sp>
+        <p:nvSpPr>
+          <p:cNvPr id="58" name="Shape 56"/>
+          <p:cNvSpPr/>
+          <p:nvPr/>
+        </p:nvSpPr>
+        <p:spPr>
+          <a:xfrm>
+            <a:off x="8040624" y="3613709"/>
+            <a:ext cx="3489960" cy="755294"/>
+          </a:xfrm>
+          <a:prstGeom prst="rect">
+            <a:avLst/>
+          </a:prstGeom>
+          <a:solidFill>
+            <a:srgbClr val="F7F7F7"/>
+          </a:solidFill>
+          <a:ln/>
+        </p:spPr>
+      </p:sp>
+      <p:sp>
+        <p:nvSpPr>
+          <p:cNvPr id="59" name="Text 57"/>
+          <p:cNvSpPr txBox="1"/>
+          <p:nvPr/>
+        </p:nvSpPr>
+        <p:spPr>
+          <a:xfrm>
+            <a:off x="8132064" y="3613709"/>
+            <a:ext cx="365760" cy="755294"/>
           </a:xfrm>
           <a:prstGeom prst="rect">
             <a:avLst/>
@@ -16081,7 +16330,7 @@
                 <a:ea typeface="Inter" pitchFamily="34" charset="-122"/>
                 <a:cs typeface="Inter" pitchFamily="34" charset="-120"/>
               </a:rPr>
-              <a:t>29</a:t>
+              <a:t>3</a:t>
             </a:r>
             <a:endParaRPr lang="en-US" sz="1500" dirty="0"/>
           </a:p>
@@ -16089,14 +16338,14 @@
       </p:sp>
       <p:sp>
         <p:nvSpPr>
-          <p:cNvPr id="58" name="Text 56"/>
-          <p:cNvSpPr txBox="1"/>
-          <p:nvPr/>
-        </p:nvSpPr>
-        <p:spPr>
-          <a:xfrm>
-            <a:off x="6665976" y="5127955"/>
-            <a:ext cx="1737360" cy="751637"/>
+          <p:cNvPr id="60" name="Text 58"/>
+          <p:cNvSpPr txBox="1"/>
+          <p:nvPr/>
+        </p:nvSpPr>
+        <p:spPr>
+          <a:xfrm>
+            <a:off x="8479536" y="3613709"/>
+            <a:ext cx="1825752" cy="755294"/>
           </a:xfrm>
           <a:prstGeom prst="rect">
             <a:avLst/>
@@ -16109,6 +16358,9 @@
           <a:lstStyle/>
           <a:p>
             <a:pPr indent="0" marL="0">
+              <a:spcAft>
+                <a:spcPts val="200"/>
+              </a:spcAft>
               <a:buNone/>
             </a:pPr>
             <a:r>
@@ -16120,38 +16372,19 @@
                 <a:ea typeface="Inter" pitchFamily="34" charset="-122"/>
                 <a:cs typeface="Inter" pitchFamily="34" charset="-120"/>
               </a:rPr>
-              <a:t>Chevy LV</a:t>
+              <a:t>Lexus</a:t>
             </a:r>
             <a:endParaRPr lang="en-US" sz="1400" dirty="0"/>
           </a:p>
-        </p:txBody>
-      </p:sp>
-      <p:sp>
-        <p:nvSpPr>
-          <p:cNvPr id="59" name="Text 57"/>
-          <p:cNvSpPr txBox="1"/>
-          <p:nvPr/>
-        </p:nvSpPr>
-        <p:spPr>
-          <a:xfrm>
-            <a:off x="8449056" y="5127955"/>
-            <a:ext cx="1920240" cy="751637"/>
-          </a:xfrm>
-          <a:prstGeom prst="rect">
-            <a:avLst/>
-          </a:prstGeom>
-          <a:noFill/>
-          <a:ln/>
-        </p:spPr>
-        <p:txBody>
-          <a:bodyPr wrap="square" lIns="0" tIns="0" rIns="0" bIns="0" rtlCol="0" anchor="ctr"/>
-          <a:lstStyle/>
           <a:p>
             <a:pPr indent="0" marL="0">
-              <a:buNone/>
-            </a:pPr>
-            <a:r>
-              <a:rPr lang="en-US" sz="1400" dirty="0">
+              <a:spcAft>
+                <a:spcPts val="200"/>
+              </a:spcAft>
+              <a:buNone/>
+            </a:pPr>
+            <a:r>
+              <a:rPr lang="en-US" sz="1200" dirty="0">
                 <a:solidFill>
                   <a:srgbClr val="595959"/>
                 </a:solidFill>
@@ -16159,50 +16392,373 @@
                 <a:ea typeface="Inter" pitchFamily="34" charset="-122"/>
                 <a:cs typeface="Inter" pitchFamily="34" charset="-120"/>
               </a:rPr>
-              <a:t>48,486  </a:t>
+              <a:t>922  →  </a:t>
             </a:r>
             <a:pPr indent="0" marL="0">
+              <a:spcAft>
+                <a:spcPts val="200"/>
+              </a:spcAft>
+              <a:buNone/>
+            </a:pPr>
+            <a:r>
+              <a:rPr lang="en-US" sz="1200" b="1" dirty="0">
+                <a:solidFill>
+                  <a:srgbClr val="0B7A4A"/>
+                </a:solidFill>
+                <a:latin typeface="Inter" pitchFamily="34" charset="0"/>
+                <a:ea typeface="Inter" pitchFamily="34" charset="-122"/>
+                <a:cs typeface="Inter" pitchFamily="34" charset="-120"/>
+              </a:rPr>
+              <a:t>1,146</a:t>
+            </a:r>
+            <a:endParaRPr lang="en-US" sz="1400" dirty="0"/>
+          </a:p>
+        </p:txBody>
+      </p:sp>
+      <p:sp>
+        <p:nvSpPr>
+          <p:cNvPr id="61" name="Text 59"/>
+          <p:cNvSpPr txBox="1"/>
+          <p:nvPr/>
+        </p:nvSpPr>
+        <p:spPr>
+          <a:xfrm>
+            <a:off x="10323576" y="3613709"/>
+            <a:ext cx="1115568" cy="755294"/>
+          </a:xfrm>
+          <a:prstGeom prst="rect">
+            <a:avLst/>
+          </a:prstGeom>
+          <a:noFill/>
+          <a:ln/>
+        </p:spPr>
+        <p:txBody>
+          <a:bodyPr wrap="square" lIns="0" tIns="0" rIns="0" bIns="0" rtlCol="0" anchor="ctr"/>
+          <a:lstStyle/>
+          <a:p>
+            <a:pPr algn="r" indent="0" marL="0">
+              <a:buNone/>
+            </a:pPr>
+            <a:r>
+              <a:rPr lang="en-US" sz="1600" b="1" dirty="0">
+                <a:solidFill>
+                  <a:srgbClr val="0B7A4A"/>
+                </a:solidFill>
+                <a:latin typeface="Inter" pitchFamily="34" charset="0"/>
+                <a:ea typeface="Inter" pitchFamily="34" charset="-122"/>
+                <a:cs typeface="Inter" pitchFamily="34" charset="-120"/>
+              </a:rPr>
+              <a:t>+24.3%</a:t>
+            </a:r>
+            <a:endParaRPr lang="en-US" sz="1600" dirty="0"/>
+          </a:p>
+        </p:txBody>
+      </p:sp>
+      <p:sp>
+        <p:nvSpPr>
+          <p:cNvPr id="62" name="Text 60"/>
+          <p:cNvSpPr txBox="1"/>
+          <p:nvPr/>
+        </p:nvSpPr>
+        <p:spPr>
+          <a:xfrm>
+            <a:off x="8132064" y="4369003"/>
+            <a:ext cx="365760" cy="755294"/>
+          </a:xfrm>
+          <a:prstGeom prst="rect">
+            <a:avLst/>
+          </a:prstGeom>
+          <a:noFill/>
+          <a:ln/>
+        </p:spPr>
+        <p:txBody>
+          <a:bodyPr wrap="square" lIns="0" tIns="0" rIns="0" bIns="0" rtlCol="0" anchor="ctr"/>
+          <a:lstStyle/>
+          <a:p>
+            <a:pPr indent="0" marL="0">
+              <a:buNone/>
+            </a:pPr>
+            <a:r>
+              <a:rPr lang="en-US" sz="1500" b="1" dirty="0">
+                <a:solidFill>
+                  <a:srgbClr val="0B2C4A"/>
+                </a:solidFill>
+                <a:latin typeface="Inter" pitchFamily="34" charset="0"/>
+                <a:ea typeface="Inter" pitchFamily="34" charset="-122"/>
+                <a:cs typeface="Inter" pitchFamily="34" charset="-120"/>
+              </a:rPr>
+              <a:t>4</a:t>
+            </a:r>
+            <a:endParaRPr lang="en-US" sz="1500" dirty="0"/>
+          </a:p>
+        </p:txBody>
+      </p:sp>
+      <p:sp>
+        <p:nvSpPr>
+          <p:cNvPr id="63" name="Text 61"/>
+          <p:cNvSpPr txBox="1"/>
+          <p:nvPr/>
+        </p:nvSpPr>
+        <p:spPr>
+          <a:xfrm>
+            <a:off x="8479536" y="4369003"/>
+            <a:ext cx="1825752" cy="755294"/>
+          </a:xfrm>
+          <a:prstGeom prst="rect">
+            <a:avLst/>
+          </a:prstGeom>
+          <a:noFill/>
+          <a:ln/>
+        </p:spPr>
+        <p:txBody>
+          <a:bodyPr wrap="square" lIns="0" tIns="0" rIns="0" bIns="0" rtlCol="0" anchor="ctr"/>
+          <a:lstStyle/>
+          <a:p>
+            <a:pPr indent="0" marL="0">
+              <a:spcAft>
+                <a:spcPts val="200"/>
+              </a:spcAft>
               <a:buNone/>
             </a:pPr>
             <a:r>
               <a:rPr lang="en-US" sz="1400" b="1" dirty="0">
                 <a:solidFill>
-                  <a:srgbClr val="A82B26"/>
-                </a:solidFill>
-                <a:latin typeface="Inter" pitchFamily="34" charset="0"/>
-                <a:ea typeface="Inter" pitchFamily="34" charset="-122"/>
-                <a:cs typeface="Inter" pitchFamily="34" charset="-120"/>
-              </a:rPr>
-              <a:t>→  </a:t>
-            </a:r>
+                  <a:srgbClr val="1A1A1A"/>
+                </a:solidFill>
+                <a:latin typeface="Inter" pitchFamily="34" charset="0"/>
+                <a:ea typeface="Inter" pitchFamily="34" charset="-122"/>
+                <a:cs typeface="Inter" pitchFamily="34" charset="-120"/>
+              </a:rPr>
+              <a:t>LR LV</a:t>
+            </a:r>
+            <a:endParaRPr lang="en-US" sz="1400" dirty="0"/>
+          </a:p>
+          <a:p>
             <a:pPr indent="0" marL="0">
+              <a:spcAft>
+                <a:spcPts val="200"/>
+              </a:spcAft>
+              <a:buNone/>
+            </a:pPr>
+            <a:r>
+              <a:rPr lang="en-US" sz="1200" dirty="0">
+                <a:solidFill>
+                  <a:srgbClr val="595959"/>
+                </a:solidFill>
+                <a:latin typeface="Inter" pitchFamily="34" charset="0"/>
+                <a:ea typeface="Inter" pitchFamily="34" charset="-122"/>
+                <a:cs typeface="Inter" pitchFamily="34" charset="-120"/>
+              </a:rPr>
+              <a:t>1,367  →  </a:t>
+            </a:r>
+            <a:pPr indent="0" marL="0">
+              <a:spcAft>
+                <a:spcPts val="200"/>
+              </a:spcAft>
+              <a:buNone/>
+            </a:pPr>
+            <a:r>
+              <a:rPr lang="en-US" sz="1200" b="1" dirty="0">
+                <a:solidFill>
+                  <a:srgbClr val="0B7A4A"/>
+                </a:solidFill>
+                <a:latin typeface="Inter" pitchFamily="34" charset="0"/>
+                <a:ea typeface="Inter" pitchFamily="34" charset="-122"/>
+                <a:cs typeface="Inter" pitchFamily="34" charset="-120"/>
+              </a:rPr>
+              <a:t>1,692</a:t>
+            </a:r>
+            <a:endParaRPr lang="en-US" sz="1400" dirty="0"/>
+          </a:p>
+        </p:txBody>
+      </p:sp>
+      <p:sp>
+        <p:nvSpPr>
+          <p:cNvPr id="64" name="Text 62"/>
+          <p:cNvSpPr txBox="1"/>
+          <p:nvPr/>
+        </p:nvSpPr>
+        <p:spPr>
+          <a:xfrm>
+            <a:off x="10323576" y="4369003"/>
+            <a:ext cx="1115568" cy="755294"/>
+          </a:xfrm>
+          <a:prstGeom prst="rect">
+            <a:avLst/>
+          </a:prstGeom>
+          <a:noFill/>
+          <a:ln/>
+        </p:spPr>
+        <p:txBody>
+          <a:bodyPr wrap="square" lIns="0" tIns="0" rIns="0" bIns="0" rtlCol="0" anchor="ctr"/>
+          <a:lstStyle/>
+          <a:p>
+            <a:pPr algn="r" indent="0" marL="0">
+              <a:buNone/>
+            </a:pPr>
+            <a:r>
+              <a:rPr lang="en-US" sz="1600" b="1" dirty="0">
+                <a:solidFill>
+                  <a:srgbClr val="0B7A4A"/>
+                </a:solidFill>
+                <a:latin typeface="Inter" pitchFamily="34" charset="0"/>
+                <a:ea typeface="Inter" pitchFamily="34" charset="-122"/>
+                <a:cs typeface="Inter" pitchFamily="34" charset="-120"/>
+              </a:rPr>
+              <a:t>+23.8%</a:t>
+            </a:r>
+            <a:endParaRPr lang="en-US" sz="1600" dirty="0"/>
+          </a:p>
+        </p:txBody>
+      </p:sp>
+      <p:sp>
+        <p:nvSpPr>
+          <p:cNvPr id="65" name="Shape 63"/>
+          <p:cNvSpPr/>
+          <p:nvPr/>
+        </p:nvSpPr>
+        <p:spPr>
+          <a:xfrm>
+            <a:off x="8040624" y="5124298"/>
+            <a:ext cx="3489960" cy="755294"/>
+          </a:xfrm>
+          <a:prstGeom prst="rect">
+            <a:avLst/>
+          </a:prstGeom>
+          <a:solidFill>
+            <a:srgbClr val="F7F7F7"/>
+          </a:solidFill>
+          <a:ln/>
+        </p:spPr>
+      </p:sp>
+      <p:sp>
+        <p:nvSpPr>
+          <p:cNvPr id="66" name="Text 64"/>
+          <p:cNvSpPr txBox="1"/>
+          <p:nvPr/>
+        </p:nvSpPr>
+        <p:spPr>
+          <a:xfrm>
+            <a:off x="8132064" y="5124298"/>
+            <a:ext cx="365760" cy="755294"/>
+          </a:xfrm>
+          <a:prstGeom prst="rect">
+            <a:avLst/>
+          </a:prstGeom>
+          <a:noFill/>
+          <a:ln/>
+        </p:spPr>
+        <p:txBody>
+          <a:bodyPr wrap="square" lIns="0" tIns="0" rIns="0" bIns="0" rtlCol="0" anchor="ctr"/>
+          <a:lstStyle/>
+          <a:p>
+            <a:pPr indent="0" marL="0">
+              <a:buNone/>
+            </a:pPr>
+            <a:r>
+              <a:rPr lang="en-US" sz="1500" b="1" dirty="0">
+                <a:solidFill>
+                  <a:srgbClr val="0B2C4A"/>
+                </a:solidFill>
+                <a:latin typeface="Inter" pitchFamily="34" charset="0"/>
+                <a:ea typeface="Inter" pitchFamily="34" charset="-122"/>
+                <a:cs typeface="Inter" pitchFamily="34" charset="-120"/>
+              </a:rPr>
+              <a:t>5</a:t>
+            </a:r>
+            <a:endParaRPr lang="en-US" sz="1500" dirty="0"/>
+          </a:p>
+        </p:txBody>
+      </p:sp>
+      <p:sp>
+        <p:nvSpPr>
+          <p:cNvPr id="67" name="Text 65"/>
+          <p:cNvSpPr txBox="1"/>
+          <p:nvPr/>
+        </p:nvSpPr>
+        <p:spPr>
+          <a:xfrm>
+            <a:off x="8479536" y="5124298"/>
+            <a:ext cx="1825752" cy="755294"/>
+          </a:xfrm>
+          <a:prstGeom prst="rect">
+            <a:avLst/>
+          </a:prstGeom>
+          <a:noFill/>
+          <a:ln/>
+        </p:spPr>
+        <p:txBody>
+          <a:bodyPr wrap="square" lIns="0" tIns="0" rIns="0" bIns="0" rtlCol="0" anchor="ctr"/>
+          <a:lstStyle/>
+          <a:p>
+            <a:pPr indent="0" marL="0">
+              <a:spcAft>
+                <a:spcPts val="200"/>
+              </a:spcAft>
               <a:buNone/>
             </a:pPr>
             <a:r>
               <a:rPr lang="en-US" sz="1400" b="1" dirty="0">
                 <a:solidFill>
-                  <a:srgbClr val="A82B26"/>
-                </a:solidFill>
-                <a:latin typeface="Inter" pitchFamily="34" charset="0"/>
-                <a:ea typeface="Inter" pitchFamily="34" charset="-122"/>
-                <a:cs typeface="Inter" pitchFamily="34" charset="-120"/>
-              </a:rPr>
-              <a:t>44,883</a:t>
+                  <a:srgbClr val="1A1A1A"/>
+                </a:solidFill>
+                <a:latin typeface="Inter" pitchFamily="34" charset="0"/>
+                <a:ea typeface="Inter" pitchFamily="34" charset="-122"/>
+                <a:cs typeface="Inter" pitchFamily="34" charset="-120"/>
+              </a:rPr>
+              <a:t>Kia St George</a:t>
             </a:r>
             <a:endParaRPr lang="en-US" sz="1400" dirty="0"/>
           </a:p>
-        </p:txBody>
-      </p:sp>
-      <p:sp>
-        <p:nvSpPr>
-          <p:cNvPr id="60" name="Text 58"/>
-          <p:cNvSpPr txBox="1"/>
-          <p:nvPr/>
-        </p:nvSpPr>
-        <p:spPr>
-          <a:xfrm>
-            <a:off x="10415016" y="5127955"/>
-            <a:ext cx="1051560" cy="751637"/>
+          <a:p>
+            <a:pPr indent="0" marL="0">
+              <a:spcAft>
+                <a:spcPts val="200"/>
+              </a:spcAft>
+              <a:buNone/>
+            </a:pPr>
+            <a:r>
+              <a:rPr lang="en-US" sz="1200" dirty="0">
+                <a:solidFill>
+                  <a:srgbClr val="595959"/>
+                </a:solidFill>
+                <a:latin typeface="Inter" pitchFamily="34" charset="0"/>
+                <a:ea typeface="Inter" pitchFamily="34" charset="-122"/>
+                <a:cs typeface="Inter" pitchFamily="34" charset="-120"/>
+              </a:rPr>
+              <a:t>515  →  </a:t>
+            </a:r>
+            <a:pPr indent="0" marL="0">
+              <a:spcAft>
+                <a:spcPts val="200"/>
+              </a:spcAft>
+              <a:buNone/>
+            </a:pPr>
+            <a:r>
+              <a:rPr lang="en-US" sz="1200" b="1" dirty="0">
+                <a:solidFill>
+                  <a:srgbClr val="0B7A4A"/>
+                </a:solidFill>
+                <a:latin typeface="Inter" pitchFamily="34" charset="0"/>
+                <a:ea typeface="Inter" pitchFamily="34" charset="-122"/>
+                <a:cs typeface="Inter" pitchFamily="34" charset="-120"/>
+              </a:rPr>
+              <a:t>634</a:t>
+            </a:r>
+            <a:endParaRPr lang="en-US" sz="1400" dirty="0"/>
+          </a:p>
+        </p:txBody>
+      </p:sp>
+      <p:sp>
+        <p:nvSpPr>
+          <p:cNvPr id="68" name="Text 66"/>
+          <p:cNvSpPr txBox="1"/>
+          <p:nvPr/>
+        </p:nvSpPr>
+        <p:spPr>
+          <a:xfrm>
+            <a:off x="10323576" y="5124298"/>
+            <a:ext cx="1115568" cy="755294"/>
           </a:xfrm>
           <a:prstGeom prst="rect">
             <a:avLst/>
@@ -16220,13 +16776,13 @@
             <a:r>
               <a:rPr lang="en-US" sz="1600" b="1" dirty="0">
                 <a:solidFill>
-                  <a:srgbClr val="A82B26"/>
-                </a:solidFill>
-                <a:latin typeface="Inter" pitchFamily="34" charset="0"/>
-                <a:ea typeface="Inter" pitchFamily="34" charset="-122"/>
-                <a:cs typeface="Inter" pitchFamily="34" charset="-120"/>
-              </a:rPr>
-              <a:t>−7.4%</a:t>
+                  <a:srgbClr val="0B7A4A"/>
+                </a:solidFill>
+                <a:latin typeface="Inter" pitchFamily="34" charset="0"/>
+                <a:ea typeface="Inter" pitchFamily="34" charset="-122"/>
+                <a:cs typeface="Inter" pitchFamily="34" charset="-120"/>
+              </a:rPr>
+              <a:t>+23.1%</a:t>
             </a:r>
             <a:endParaRPr lang="en-US" sz="1600" dirty="0"/>
           </a:p>
@@ -16234,7 +16790,7 @@
       </p:sp>
       <p:sp>
         <p:nvSpPr>
-          <p:cNvPr id="61" name="Shape 59"/>
+          <p:cNvPr id="69" name="Shape 67"/>
           <p:cNvSpPr/>
           <p:nvPr/>
         </p:nvSpPr>
@@ -16254,7 +16810,7 @@
       </p:sp>
       <p:sp>
         <p:nvSpPr>
-          <p:cNvPr id="62" name="Text 60"/>
+          <p:cNvPr id="70" name="Text 68"/>
           <p:cNvSpPr txBox="1"/>
           <p:nvPr/>
         </p:nvSpPr>
@@ -16285,7 +16841,7 @@
                 <a:ea typeface="Inter" pitchFamily="34" charset="-122"/>
                 <a:cs typeface="Inter" pitchFamily="34" charset="-120"/>
               </a:rPr>
-              <a:t>Ask Subaru St George, Kia LV and Kia St George what changed. Ask VW St George, Audi Reno and Volvo what got in the way.</a:t>
+              <a:t>Ask Subaru St George, Kia LV and Kia St George what changed. Ask VW St George, Audi Reno and Volvo what got in the way. Ask Mazda, CDJR Post Falls and Lexus what they started this year.</a:t>
             </a:r>
             <a:endParaRPr lang="en-US" sz="1600" dirty="0"/>
           </a:p>

</xml_diff>

<commit_message>
Oct 24 round: % ranking with unit change, whole-dollar ELR, ranked amount slides, missed opportunity vs benchmark for every store, benchmark lines, chart label fix, warranty rates slide, moves to Open Decisions; luxury slide preview
Co-Authored-By: Claude Opus 5.5 <noreply@anthropic.com>
Claude-Session: https://claude.ai/code/session_01Xa4nFVxuQGXmHARGph9WhS
</commit_message>
<xml_diff>
--- a/day2-deck/decks/CP Hours & RO a Day - Review.pptx
+++ b/day2-deck/decks/CP Hours & RO a Day - Review.pptx
@@ -360,6 +360,17 @@
         </c:scaling>
         <c:delete val="0"/>
         <c:axPos val="l"/>
+        <c:majorGridlines>
+          <c:spPr>
+            <a:ln w="9525" cap="flat">
+              <a:solidFill>
+                <a:srgbClr val="D9D9D9"/>
+              </a:solidFill>
+              <a:prstDash val="solid"/>
+              <a:round/>
+            </a:ln>
+          </c:spPr>
+        </c:majorGridlines>
         <c:numFmt formatCode="#,##0" sourceLinked="0"/>
         <c:majorTickMark val="out"/>
         <c:minorTickMark val="none"/>
@@ -1191,13 +1202,13 @@
                   <c:v/>
                 </c:pt>
                 <c:pt idx="9">
-                  <c:v/>
+                  <c:v>58023.59000000028</c:v>
                 </c:pt>
                 <c:pt idx="10">
                   <c:v/>
                 </c:pt>
                 <c:pt idx="11">
-                  <c:v/>
+                  <c:v>52701.39000000027</c:v>
                 </c:pt>
               </c:numCache>
             </c:numRef>
@@ -1501,13 +1512,13 @@
                   <c:v>53309.32</c:v>
                 </c:pt>
                 <c:pt idx="9">
-                  <c:v>58023.59000000028</c:v>
+                  <c:v/>
                 </c:pt>
                 <c:pt idx="10">
                   <c:v>51202.50000000025</c:v>
                 </c:pt>
                 <c:pt idx="11">
-                  <c:v>52701.39000000027</c:v>
+                  <c:v/>
                 </c:pt>
               </c:numCache>
             </c:numRef>
@@ -1906,17 +1917,6 @@
         </c:scaling>
         <c:delete val="0"/>
         <c:axPos val="l"/>
-        <c:majorGridlines>
-          <c:spPr>
-            <a:ln w="9525" cap="flat">
-              <a:solidFill>
-                <a:srgbClr val="D9D9D9"/>
-              </a:solidFill>
-              <a:prstDash val="solid"/>
-              <a:round/>
-            </a:ln>
-          </c:spPr>
-        </c:majorGridlines>
         <c:numFmt formatCode="#,##0" sourceLinked="0"/>
         <c:majorTickMark val="out"/>
         <c:minorTickMark val="none"/>
@@ -17005,7 +17005,7 @@
         </p:nvSpPr>
         <p:spPr>
           <a:xfrm>
-            <a:off x="3529584" y="1316736"/>
+            <a:off x="3575304" y="1316736"/>
             <a:ext cx="822960" cy="329184"/>
           </a:xfrm>
           <a:prstGeom prst="rect">
@@ -17044,7 +17044,7 @@
         </p:nvSpPr>
         <p:spPr>
           <a:xfrm>
-            <a:off x="4352544" y="1316736"/>
+            <a:off x="4398264" y="1316736"/>
             <a:ext cx="786384" cy="329184"/>
           </a:xfrm>
           <a:prstGeom prst="rect">
@@ -17083,7 +17083,7 @@
         </p:nvSpPr>
         <p:spPr>
           <a:xfrm>
-            <a:off x="5138928" y="1316736"/>
+            <a:off x="5184648" y="1316736"/>
             <a:ext cx="731520" cy="329184"/>
           </a:xfrm>
           <a:prstGeom prst="rect">
@@ -17122,7 +17122,7 @@
         </p:nvSpPr>
         <p:spPr>
           <a:xfrm>
-            <a:off x="9079992" y="1316736"/>
+            <a:off x="9125712" y="1316736"/>
             <a:ext cx="822960" cy="329184"/>
           </a:xfrm>
           <a:prstGeom prst="rect">
@@ -17161,7 +17161,7 @@
         </p:nvSpPr>
         <p:spPr>
           <a:xfrm>
-            <a:off x="9902952" y="1316736"/>
+            <a:off x="9948672" y="1316736"/>
             <a:ext cx="786384" cy="329184"/>
           </a:xfrm>
           <a:prstGeom prst="rect">
@@ -17200,7 +17200,7 @@
         </p:nvSpPr>
         <p:spPr>
           <a:xfrm>
-            <a:off x="10689336" y="1316736"/>
+            <a:off x="10735056" y="1316736"/>
             <a:ext cx="731520" cy="329184"/>
           </a:xfrm>
           <a:prstGeom prst="rect">
@@ -17240,7 +17240,46 @@
         <p:spPr>
           <a:xfrm>
             <a:off x="658368" y="1700784"/>
-            <a:ext cx="1938528" cy="248502"/>
+            <a:ext cx="310896" cy="248502"/>
+          </a:xfrm>
+          <a:prstGeom prst="rect">
+            <a:avLst/>
+          </a:prstGeom>
+          <a:noFill/>
+          <a:ln/>
+        </p:spPr>
+        <p:txBody>
+          <a:bodyPr wrap="square" lIns="0" tIns="0" rIns="0" bIns="0" rtlCol="0" anchor="ctr"/>
+          <a:lstStyle/>
+          <a:p>
+            <a:pPr algn="r" indent="0" marL="0">
+              <a:buNone/>
+            </a:pPr>
+            <a:r>
+              <a:rPr lang="en-US" sz="1200" dirty="0">
+                <a:solidFill>
+                  <a:srgbClr val="9AA3AD"/>
+                </a:solidFill>
+                <a:latin typeface="Inter" pitchFamily="34" charset="0"/>
+                <a:ea typeface="Inter" pitchFamily="34" charset="-122"/>
+                <a:cs typeface="Inter" pitchFamily="34" charset="-120"/>
+              </a:rPr>
+              <a:t>1</a:t>
+            </a:r>
+            <a:endParaRPr lang="en-US" sz="1200" dirty="0"/>
+          </a:p>
+        </p:txBody>
+      </p:sp>
+      <p:sp>
+        <p:nvSpPr>
+          <p:cNvPr id="13" name="Text 11"/>
+          <p:cNvSpPr txBox="1"/>
+          <p:nvPr/>
+        </p:nvSpPr>
+        <p:spPr>
+          <a:xfrm>
+            <a:off x="1014984" y="1700784"/>
+            <a:ext cx="1783080" cy="248502"/>
           </a:xfrm>
           <a:prstGeom prst="rect">
             <a:avLst/>
@@ -17272,14 +17311,14 @@
       </p:sp>
       <p:sp>
         <p:nvSpPr>
-          <p:cNvPr id="13" name="Shape 11"/>
+          <p:cNvPr id="14" name="Shape 12"/>
           <p:cNvSpPr/>
           <p:nvPr/>
         </p:nvSpPr>
         <p:spPr>
           <a:xfrm>
-            <a:off x="2670048" y="1756697"/>
-            <a:ext cx="804672" cy="136676"/>
+            <a:off x="2871216" y="1756697"/>
+            <a:ext cx="649224" cy="136676"/>
           </a:xfrm>
           <a:prstGeom prst="rect">
             <a:avLst/>
@@ -17292,13 +17331,13 @@
       </p:sp>
       <p:sp>
         <p:nvSpPr>
-          <p:cNvPr id="14" name="Text 12"/>
-          <p:cNvSpPr txBox="1"/>
-          <p:nvPr/>
-        </p:nvSpPr>
-        <p:spPr>
-          <a:xfrm>
-            <a:off x="3529584" y="1700784"/>
+          <p:cNvPr id="15" name="Text 13"/>
+          <p:cNvSpPr txBox="1"/>
+          <p:nvPr/>
+        </p:nvSpPr>
+        <p:spPr>
+          <a:xfrm>
+            <a:off x="3575304" y="1700784"/>
             <a:ext cx="822960" cy="248502"/>
           </a:xfrm>
           <a:prstGeom prst="rect">
@@ -17331,13 +17370,13 @@
       </p:sp>
       <p:sp>
         <p:nvSpPr>
-          <p:cNvPr id="15" name="Text 13"/>
-          <p:cNvSpPr txBox="1"/>
-          <p:nvPr/>
-        </p:nvSpPr>
-        <p:spPr>
-          <a:xfrm>
-            <a:off x="4352544" y="1700784"/>
+          <p:cNvPr id="16" name="Text 14"/>
+          <p:cNvSpPr txBox="1"/>
+          <p:nvPr/>
+        </p:nvSpPr>
+        <p:spPr>
+          <a:xfrm>
+            <a:off x="4398264" y="1700784"/>
             <a:ext cx="786384" cy="248502"/>
           </a:xfrm>
           <a:prstGeom prst="rect">
@@ -17370,13 +17409,13 @@
       </p:sp>
       <p:sp>
         <p:nvSpPr>
-          <p:cNvPr id="16" name="Text 14"/>
-          <p:cNvSpPr txBox="1"/>
-          <p:nvPr/>
-        </p:nvSpPr>
-        <p:spPr>
-          <a:xfrm>
-            <a:off x="5138928" y="1700784"/>
+          <p:cNvPr id="17" name="Text 15"/>
+          <p:cNvSpPr txBox="1"/>
+          <p:nvPr/>
+        </p:nvSpPr>
+        <p:spPr>
+          <a:xfrm>
+            <a:off x="5184648" y="1700784"/>
             <a:ext cx="731520" cy="248502"/>
           </a:xfrm>
           <a:prstGeom prst="rect">
@@ -17409,14 +17448,53 @@
       </p:sp>
       <p:sp>
         <p:nvSpPr>
-          <p:cNvPr id="17" name="Text 15"/>
+          <p:cNvPr id="18" name="Text 16"/>
           <p:cNvSpPr txBox="1"/>
           <p:nvPr/>
         </p:nvSpPr>
         <p:spPr>
           <a:xfrm>
             <a:off x="658368" y="1949286"/>
-            <a:ext cx="1938528" cy="248502"/>
+            <a:ext cx="310896" cy="248502"/>
+          </a:xfrm>
+          <a:prstGeom prst="rect">
+            <a:avLst/>
+          </a:prstGeom>
+          <a:noFill/>
+          <a:ln/>
+        </p:spPr>
+        <p:txBody>
+          <a:bodyPr wrap="square" lIns="0" tIns="0" rIns="0" bIns="0" rtlCol="0" anchor="ctr"/>
+          <a:lstStyle/>
+          <a:p>
+            <a:pPr algn="r" indent="0" marL="0">
+              <a:buNone/>
+            </a:pPr>
+            <a:r>
+              <a:rPr lang="en-US" sz="1200" dirty="0">
+                <a:solidFill>
+                  <a:srgbClr val="9AA3AD"/>
+                </a:solidFill>
+                <a:latin typeface="Inter" pitchFamily="34" charset="0"/>
+                <a:ea typeface="Inter" pitchFamily="34" charset="-122"/>
+                <a:cs typeface="Inter" pitchFamily="34" charset="-120"/>
+              </a:rPr>
+              <a:t>2</a:t>
+            </a:r>
+            <a:endParaRPr lang="en-US" sz="1200" dirty="0"/>
+          </a:p>
+        </p:txBody>
+      </p:sp>
+      <p:sp>
+        <p:nvSpPr>
+          <p:cNvPr id="19" name="Text 17"/>
+          <p:cNvSpPr txBox="1"/>
+          <p:nvPr/>
+        </p:nvSpPr>
+        <p:spPr>
+          <a:xfrm>
+            <a:off x="1014984" y="1949286"/>
+            <a:ext cx="1783080" cy="248502"/>
           </a:xfrm>
           <a:prstGeom prst="rect">
             <a:avLst/>
@@ -17448,14 +17526,14 @@
       </p:sp>
       <p:sp>
         <p:nvSpPr>
-          <p:cNvPr id="18" name="Shape 16"/>
+          <p:cNvPr id="20" name="Shape 18"/>
           <p:cNvSpPr/>
           <p:nvPr/>
         </p:nvSpPr>
         <p:spPr>
           <a:xfrm>
-            <a:off x="2670048" y="2005199"/>
-            <a:ext cx="786943" cy="136676"/>
+            <a:off x="2871216" y="2005199"/>
+            <a:ext cx="634920" cy="136676"/>
           </a:xfrm>
           <a:prstGeom prst="rect">
             <a:avLst/>
@@ -17468,13 +17546,13 @@
       </p:sp>
       <p:sp>
         <p:nvSpPr>
-          <p:cNvPr id="19" name="Text 17"/>
-          <p:cNvSpPr txBox="1"/>
-          <p:nvPr/>
-        </p:nvSpPr>
-        <p:spPr>
-          <a:xfrm>
-            <a:off x="3529584" y="1949286"/>
+          <p:cNvPr id="21" name="Text 19"/>
+          <p:cNvSpPr txBox="1"/>
+          <p:nvPr/>
+        </p:nvSpPr>
+        <p:spPr>
+          <a:xfrm>
+            <a:off x="3575304" y="1949286"/>
             <a:ext cx="822960" cy="248502"/>
           </a:xfrm>
           <a:prstGeom prst="rect">
@@ -17507,13 +17585,13 @@
       </p:sp>
       <p:sp>
         <p:nvSpPr>
-          <p:cNvPr id="20" name="Text 18"/>
-          <p:cNvSpPr txBox="1"/>
-          <p:nvPr/>
-        </p:nvSpPr>
-        <p:spPr>
-          <a:xfrm>
-            <a:off x="4352544" y="1949286"/>
+          <p:cNvPr id="22" name="Text 20"/>
+          <p:cNvSpPr txBox="1"/>
+          <p:nvPr/>
+        </p:nvSpPr>
+        <p:spPr>
+          <a:xfrm>
+            <a:off x="4398264" y="1949286"/>
             <a:ext cx="786384" cy="248502"/>
           </a:xfrm>
           <a:prstGeom prst="rect">
@@ -17546,13 +17624,13 @@
       </p:sp>
       <p:sp>
         <p:nvSpPr>
-          <p:cNvPr id="21" name="Text 19"/>
-          <p:cNvSpPr txBox="1"/>
-          <p:nvPr/>
-        </p:nvSpPr>
-        <p:spPr>
-          <a:xfrm>
-            <a:off x="5138928" y="1949286"/>
+          <p:cNvPr id="23" name="Text 21"/>
+          <p:cNvSpPr txBox="1"/>
+          <p:nvPr/>
+        </p:nvSpPr>
+        <p:spPr>
+          <a:xfrm>
+            <a:off x="5184648" y="1949286"/>
             <a:ext cx="731520" cy="248502"/>
           </a:xfrm>
           <a:prstGeom prst="rect">
@@ -17585,14 +17663,53 @@
       </p:sp>
       <p:sp>
         <p:nvSpPr>
-          <p:cNvPr id="22" name="Text 20"/>
+          <p:cNvPr id="24" name="Text 22"/>
           <p:cNvSpPr txBox="1"/>
           <p:nvPr/>
         </p:nvSpPr>
         <p:spPr>
           <a:xfrm>
             <a:off x="658368" y="2197787"/>
-            <a:ext cx="1938528" cy="248502"/>
+            <a:ext cx="310896" cy="248502"/>
+          </a:xfrm>
+          <a:prstGeom prst="rect">
+            <a:avLst/>
+          </a:prstGeom>
+          <a:noFill/>
+          <a:ln/>
+        </p:spPr>
+        <p:txBody>
+          <a:bodyPr wrap="square" lIns="0" tIns="0" rIns="0" bIns="0" rtlCol="0" anchor="ctr"/>
+          <a:lstStyle/>
+          <a:p>
+            <a:pPr algn="r" indent="0" marL="0">
+              <a:buNone/>
+            </a:pPr>
+            <a:r>
+              <a:rPr lang="en-US" sz="1200" dirty="0">
+                <a:solidFill>
+                  <a:srgbClr val="9AA3AD"/>
+                </a:solidFill>
+                <a:latin typeface="Inter" pitchFamily="34" charset="0"/>
+                <a:ea typeface="Inter" pitchFamily="34" charset="-122"/>
+                <a:cs typeface="Inter" pitchFamily="34" charset="-120"/>
+              </a:rPr>
+              <a:t>3</a:t>
+            </a:r>
+            <a:endParaRPr lang="en-US" sz="1200" dirty="0"/>
+          </a:p>
+        </p:txBody>
+      </p:sp>
+      <p:sp>
+        <p:nvSpPr>
+          <p:cNvPr id="25" name="Text 23"/>
+          <p:cNvSpPr txBox="1"/>
+          <p:nvPr/>
+        </p:nvSpPr>
+        <p:spPr>
+          <a:xfrm>
+            <a:off x="1014984" y="2197787"/>
+            <a:ext cx="1783080" cy="248502"/>
           </a:xfrm>
           <a:prstGeom prst="rect">
             <a:avLst/>
@@ -17624,14 +17741,14 @@
       </p:sp>
       <p:sp>
         <p:nvSpPr>
-          <p:cNvPr id="23" name="Shape 21"/>
+          <p:cNvPr id="26" name="Shape 24"/>
           <p:cNvSpPr/>
           <p:nvPr/>
         </p:nvSpPr>
         <p:spPr>
           <a:xfrm>
-            <a:off x="2670048" y="2253700"/>
-            <a:ext cx="725286" cy="136676"/>
+            <a:off x="2871216" y="2253700"/>
+            <a:ext cx="585174" cy="136676"/>
           </a:xfrm>
           <a:prstGeom prst="rect">
             <a:avLst/>
@@ -17644,13 +17761,13 @@
       </p:sp>
       <p:sp>
         <p:nvSpPr>
-          <p:cNvPr id="24" name="Text 22"/>
-          <p:cNvSpPr txBox="1"/>
-          <p:nvPr/>
-        </p:nvSpPr>
-        <p:spPr>
-          <a:xfrm>
-            <a:off x="3529584" y="2197787"/>
+          <p:cNvPr id="27" name="Text 25"/>
+          <p:cNvSpPr txBox="1"/>
+          <p:nvPr/>
+        </p:nvSpPr>
+        <p:spPr>
+          <a:xfrm>
+            <a:off x="3575304" y="2197787"/>
             <a:ext cx="822960" cy="248502"/>
           </a:xfrm>
           <a:prstGeom prst="rect">
@@ -17683,13 +17800,13 @@
       </p:sp>
       <p:sp>
         <p:nvSpPr>
-          <p:cNvPr id="25" name="Text 23"/>
-          <p:cNvSpPr txBox="1"/>
-          <p:nvPr/>
-        </p:nvSpPr>
-        <p:spPr>
-          <a:xfrm>
-            <a:off x="4352544" y="2197787"/>
+          <p:cNvPr id="28" name="Text 26"/>
+          <p:cNvSpPr txBox="1"/>
+          <p:nvPr/>
+        </p:nvSpPr>
+        <p:spPr>
+          <a:xfrm>
+            <a:off x="4398264" y="2197787"/>
             <a:ext cx="786384" cy="248502"/>
           </a:xfrm>
           <a:prstGeom prst="rect">
@@ -17722,13 +17839,13 @@
       </p:sp>
       <p:sp>
         <p:nvSpPr>
-          <p:cNvPr id="26" name="Text 24"/>
-          <p:cNvSpPr txBox="1"/>
-          <p:nvPr/>
-        </p:nvSpPr>
-        <p:spPr>
-          <a:xfrm>
-            <a:off x="5138928" y="2197787"/>
+          <p:cNvPr id="29" name="Text 27"/>
+          <p:cNvSpPr txBox="1"/>
+          <p:nvPr/>
+        </p:nvSpPr>
+        <p:spPr>
+          <a:xfrm>
+            <a:off x="5184648" y="2197787"/>
             <a:ext cx="731520" cy="248502"/>
           </a:xfrm>
           <a:prstGeom prst="rect">
@@ -17761,14 +17878,53 @@
       </p:sp>
       <p:sp>
         <p:nvSpPr>
-          <p:cNvPr id="27" name="Text 25"/>
+          <p:cNvPr id="30" name="Text 28"/>
           <p:cNvSpPr txBox="1"/>
           <p:nvPr/>
         </p:nvSpPr>
         <p:spPr>
           <a:xfrm>
             <a:off x="658368" y="2446289"/>
-            <a:ext cx="1938528" cy="248502"/>
+            <a:ext cx="310896" cy="248502"/>
+          </a:xfrm>
+          <a:prstGeom prst="rect">
+            <a:avLst/>
+          </a:prstGeom>
+          <a:noFill/>
+          <a:ln/>
+        </p:spPr>
+        <p:txBody>
+          <a:bodyPr wrap="square" lIns="0" tIns="0" rIns="0" bIns="0" rtlCol="0" anchor="ctr"/>
+          <a:lstStyle/>
+          <a:p>
+            <a:pPr algn="r" indent="0" marL="0">
+              <a:buNone/>
+            </a:pPr>
+            <a:r>
+              <a:rPr lang="en-US" sz="1200" dirty="0">
+                <a:solidFill>
+                  <a:srgbClr val="9AA3AD"/>
+                </a:solidFill>
+                <a:latin typeface="Inter" pitchFamily="34" charset="0"/>
+                <a:ea typeface="Inter" pitchFamily="34" charset="-122"/>
+                <a:cs typeface="Inter" pitchFamily="34" charset="-120"/>
+              </a:rPr>
+              <a:t>4</a:t>
+            </a:r>
+            <a:endParaRPr lang="en-US" sz="1200" dirty="0"/>
+          </a:p>
+        </p:txBody>
+      </p:sp>
+      <p:sp>
+        <p:nvSpPr>
+          <p:cNvPr id="31" name="Text 29"/>
+          <p:cNvSpPr txBox="1"/>
+          <p:nvPr/>
+        </p:nvSpPr>
+        <p:spPr>
+          <a:xfrm>
+            <a:off x="1014984" y="2446289"/>
+            <a:ext cx="1783080" cy="248502"/>
           </a:xfrm>
           <a:prstGeom prst="rect">
             <a:avLst/>
@@ -17800,14 +17956,14 @@
       </p:sp>
       <p:sp>
         <p:nvSpPr>
-          <p:cNvPr id="28" name="Shape 26"/>
+          <p:cNvPr id="32" name="Shape 30"/>
           <p:cNvSpPr/>
           <p:nvPr/>
         </p:nvSpPr>
         <p:spPr>
           <a:xfrm>
-            <a:off x="2670048" y="2502202"/>
-            <a:ext cx="709617" cy="136676"/>
+            <a:off x="2871216" y="2502202"/>
+            <a:ext cx="572532" cy="136676"/>
           </a:xfrm>
           <a:prstGeom prst="rect">
             <a:avLst/>
@@ -17820,13 +17976,13 @@
       </p:sp>
       <p:sp>
         <p:nvSpPr>
-          <p:cNvPr id="29" name="Text 27"/>
-          <p:cNvSpPr txBox="1"/>
-          <p:nvPr/>
-        </p:nvSpPr>
-        <p:spPr>
-          <a:xfrm>
-            <a:off x="3529584" y="2446289"/>
+          <p:cNvPr id="33" name="Text 31"/>
+          <p:cNvSpPr txBox="1"/>
+          <p:nvPr/>
+        </p:nvSpPr>
+        <p:spPr>
+          <a:xfrm>
+            <a:off x="3575304" y="2446289"/>
             <a:ext cx="822960" cy="248502"/>
           </a:xfrm>
           <a:prstGeom prst="rect">
@@ -17859,13 +18015,13 @@
       </p:sp>
       <p:sp>
         <p:nvSpPr>
-          <p:cNvPr id="30" name="Text 28"/>
-          <p:cNvSpPr txBox="1"/>
-          <p:nvPr/>
-        </p:nvSpPr>
-        <p:spPr>
-          <a:xfrm>
-            <a:off x="4352544" y="2446289"/>
+          <p:cNvPr id="34" name="Text 32"/>
+          <p:cNvSpPr txBox="1"/>
+          <p:nvPr/>
+        </p:nvSpPr>
+        <p:spPr>
+          <a:xfrm>
+            <a:off x="4398264" y="2446289"/>
             <a:ext cx="786384" cy="248502"/>
           </a:xfrm>
           <a:prstGeom prst="rect">
@@ -17898,13 +18054,13 @@
       </p:sp>
       <p:sp>
         <p:nvSpPr>
-          <p:cNvPr id="31" name="Text 29"/>
-          <p:cNvSpPr txBox="1"/>
-          <p:nvPr/>
-        </p:nvSpPr>
-        <p:spPr>
-          <a:xfrm>
-            <a:off x="5138928" y="2446289"/>
+          <p:cNvPr id="35" name="Text 33"/>
+          <p:cNvSpPr txBox="1"/>
+          <p:nvPr/>
+        </p:nvSpPr>
+        <p:spPr>
+          <a:xfrm>
+            <a:off x="5184648" y="2446289"/>
             <a:ext cx="731520" cy="248502"/>
           </a:xfrm>
           <a:prstGeom prst="rect">
@@ -17937,14 +18093,53 @@
       </p:sp>
       <p:sp>
         <p:nvSpPr>
-          <p:cNvPr id="32" name="Text 30"/>
+          <p:cNvPr id="36" name="Text 34"/>
           <p:cNvSpPr txBox="1"/>
           <p:nvPr/>
         </p:nvSpPr>
         <p:spPr>
           <a:xfrm>
             <a:off x="658368" y="2694791"/>
-            <a:ext cx="1938528" cy="248502"/>
+            <a:ext cx="310896" cy="248502"/>
+          </a:xfrm>
+          <a:prstGeom prst="rect">
+            <a:avLst/>
+          </a:prstGeom>
+          <a:noFill/>
+          <a:ln/>
+        </p:spPr>
+        <p:txBody>
+          <a:bodyPr wrap="square" lIns="0" tIns="0" rIns="0" bIns="0" rtlCol="0" anchor="ctr"/>
+          <a:lstStyle/>
+          <a:p>
+            <a:pPr algn="r" indent="0" marL="0">
+              <a:buNone/>
+            </a:pPr>
+            <a:r>
+              <a:rPr lang="en-US" sz="1200" dirty="0">
+                <a:solidFill>
+                  <a:srgbClr val="9AA3AD"/>
+                </a:solidFill>
+                <a:latin typeface="Inter" pitchFamily="34" charset="0"/>
+                <a:ea typeface="Inter" pitchFamily="34" charset="-122"/>
+                <a:cs typeface="Inter" pitchFamily="34" charset="-120"/>
+              </a:rPr>
+              <a:t>5</a:t>
+            </a:r>
+            <a:endParaRPr lang="en-US" sz="1200" dirty="0"/>
+          </a:p>
+        </p:txBody>
+      </p:sp>
+      <p:sp>
+        <p:nvSpPr>
+          <p:cNvPr id="37" name="Text 35"/>
+          <p:cNvSpPr txBox="1"/>
+          <p:nvPr/>
+        </p:nvSpPr>
+        <p:spPr>
+          <a:xfrm>
+            <a:off x="1014984" y="2694791"/>
+            <a:ext cx="1783080" cy="248502"/>
           </a:xfrm>
           <a:prstGeom prst="rect">
             <a:avLst/>
@@ -17976,14 +18171,14 @@
       </p:sp>
       <p:sp>
         <p:nvSpPr>
-          <p:cNvPr id="33" name="Shape 31"/>
+          <p:cNvPr id="38" name="Shape 36"/>
           <p:cNvSpPr/>
           <p:nvPr/>
         </p:nvSpPr>
         <p:spPr>
           <a:xfrm>
-            <a:off x="2670048" y="2750703"/>
-            <a:ext cx="510203" cy="136676"/>
+            <a:off x="2871216" y="2750703"/>
+            <a:ext cx="411641" cy="136676"/>
           </a:xfrm>
           <a:prstGeom prst="rect">
             <a:avLst/>
@@ -17996,13 +18191,13 @@
       </p:sp>
       <p:sp>
         <p:nvSpPr>
-          <p:cNvPr id="34" name="Text 32"/>
-          <p:cNvSpPr txBox="1"/>
-          <p:nvPr/>
-        </p:nvSpPr>
-        <p:spPr>
-          <a:xfrm>
-            <a:off x="3529584" y="2694791"/>
+          <p:cNvPr id="39" name="Text 37"/>
+          <p:cNvSpPr txBox="1"/>
+          <p:nvPr/>
+        </p:nvSpPr>
+        <p:spPr>
+          <a:xfrm>
+            <a:off x="3575304" y="2694791"/>
             <a:ext cx="822960" cy="248502"/>
           </a:xfrm>
           <a:prstGeom prst="rect">
@@ -18035,13 +18230,13 @@
       </p:sp>
       <p:sp>
         <p:nvSpPr>
-          <p:cNvPr id="35" name="Text 33"/>
-          <p:cNvSpPr txBox="1"/>
-          <p:nvPr/>
-        </p:nvSpPr>
-        <p:spPr>
-          <a:xfrm>
-            <a:off x="4352544" y="2694791"/>
+          <p:cNvPr id="40" name="Text 38"/>
+          <p:cNvSpPr txBox="1"/>
+          <p:nvPr/>
+        </p:nvSpPr>
+        <p:spPr>
+          <a:xfrm>
+            <a:off x="4398264" y="2694791"/>
             <a:ext cx="786384" cy="248502"/>
           </a:xfrm>
           <a:prstGeom prst="rect">
@@ -18074,13 +18269,13 @@
       </p:sp>
       <p:sp>
         <p:nvSpPr>
-          <p:cNvPr id="36" name="Text 34"/>
-          <p:cNvSpPr txBox="1"/>
-          <p:nvPr/>
-        </p:nvSpPr>
-        <p:spPr>
-          <a:xfrm>
-            <a:off x="5138928" y="2694791"/>
+          <p:cNvPr id="41" name="Text 39"/>
+          <p:cNvSpPr txBox="1"/>
+          <p:nvPr/>
+        </p:nvSpPr>
+        <p:spPr>
+          <a:xfrm>
+            <a:off x="5184648" y="2694791"/>
             <a:ext cx="731520" cy="248502"/>
           </a:xfrm>
           <a:prstGeom prst="rect">
@@ -18113,14 +18308,53 @@
       </p:sp>
       <p:sp>
         <p:nvSpPr>
-          <p:cNvPr id="37" name="Text 35"/>
+          <p:cNvPr id="42" name="Text 40"/>
           <p:cNvSpPr txBox="1"/>
           <p:nvPr/>
         </p:nvSpPr>
         <p:spPr>
           <a:xfrm>
             <a:off x="658368" y="2943292"/>
-            <a:ext cx="1938528" cy="248502"/>
+            <a:ext cx="310896" cy="248502"/>
+          </a:xfrm>
+          <a:prstGeom prst="rect">
+            <a:avLst/>
+          </a:prstGeom>
+          <a:noFill/>
+          <a:ln/>
+        </p:spPr>
+        <p:txBody>
+          <a:bodyPr wrap="square" lIns="0" tIns="0" rIns="0" bIns="0" rtlCol="0" anchor="ctr"/>
+          <a:lstStyle/>
+          <a:p>
+            <a:pPr algn="r" indent="0" marL="0">
+              <a:buNone/>
+            </a:pPr>
+            <a:r>
+              <a:rPr lang="en-US" sz="1200" dirty="0">
+                <a:solidFill>
+                  <a:srgbClr val="9AA3AD"/>
+                </a:solidFill>
+                <a:latin typeface="Inter" pitchFamily="34" charset="0"/>
+                <a:ea typeface="Inter" pitchFamily="34" charset="-122"/>
+                <a:cs typeface="Inter" pitchFamily="34" charset="-120"/>
+              </a:rPr>
+              <a:t>6</a:t>
+            </a:r>
+            <a:endParaRPr lang="en-US" sz="1200" dirty="0"/>
+          </a:p>
+        </p:txBody>
+      </p:sp>
+      <p:sp>
+        <p:nvSpPr>
+          <p:cNvPr id="43" name="Text 41"/>
+          <p:cNvSpPr txBox="1"/>
+          <p:nvPr/>
+        </p:nvSpPr>
+        <p:spPr>
+          <a:xfrm>
+            <a:off x="1014984" y="2943292"/>
+            <a:ext cx="1783080" cy="248502"/>
           </a:xfrm>
           <a:prstGeom prst="rect">
             <a:avLst/>
@@ -18152,14 +18386,14 @@
       </p:sp>
       <p:sp>
         <p:nvSpPr>
-          <p:cNvPr id="38" name="Shape 36"/>
+          <p:cNvPr id="44" name="Shape 42"/>
           <p:cNvSpPr/>
           <p:nvPr/>
         </p:nvSpPr>
         <p:spPr>
           <a:xfrm>
-            <a:off x="2670048" y="2999205"/>
-            <a:ext cx="456478" cy="136676"/>
+            <a:off x="2871216" y="2999205"/>
+            <a:ext cx="368295" cy="136676"/>
           </a:xfrm>
           <a:prstGeom prst="rect">
             <a:avLst/>
@@ -18172,13 +18406,13 @@
       </p:sp>
       <p:sp>
         <p:nvSpPr>
-          <p:cNvPr id="39" name="Text 37"/>
-          <p:cNvSpPr txBox="1"/>
-          <p:nvPr/>
-        </p:nvSpPr>
-        <p:spPr>
-          <a:xfrm>
-            <a:off x="3529584" y="2943292"/>
+          <p:cNvPr id="45" name="Text 43"/>
+          <p:cNvSpPr txBox="1"/>
+          <p:nvPr/>
+        </p:nvSpPr>
+        <p:spPr>
+          <a:xfrm>
+            <a:off x="3575304" y="2943292"/>
             <a:ext cx="822960" cy="248502"/>
           </a:xfrm>
           <a:prstGeom prst="rect">
@@ -18211,13 +18445,13 @@
       </p:sp>
       <p:sp>
         <p:nvSpPr>
-          <p:cNvPr id="40" name="Text 38"/>
-          <p:cNvSpPr txBox="1"/>
-          <p:nvPr/>
-        </p:nvSpPr>
-        <p:spPr>
-          <a:xfrm>
-            <a:off x="4352544" y="2943292"/>
+          <p:cNvPr id="46" name="Text 44"/>
+          <p:cNvSpPr txBox="1"/>
+          <p:nvPr/>
+        </p:nvSpPr>
+        <p:spPr>
+          <a:xfrm>
+            <a:off x="4398264" y="2943292"/>
             <a:ext cx="786384" cy="248502"/>
           </a:xfrm>
           <a:prstGeom prst="rect">
@@ -18250,13 +18484,13 @@
       </p:sp>
       <p:sp>
         <p:nvSpPr>
-          <p:cNvPr id="41" name="Text 39"/>
-          <p:cNvSpPr txBox="1"/>
-          <p:nvPr/>
-        </p:nvSpPr>
-        <p:spPr>
-          <a:xfrm>
-            <a:off x="5138928" y="2943292"/>
+          <p:cNvPr id="47" name="Text 45"/>
+          <p:cNvSpPr txBox="1"/>
+          <p:nvPr/>
+        </p:nvSpPr>
+        <p:spPr>
+          <a:xfrm>
+            <a:off x="5184648" y="2943292"/>
             <a:ext cx="731520" cy="248502"/>
           </a:xfrm>
           <a:prstGeom prst="rect">
@@ -18289,14 +18523,53 @@
       </p:sp>
       <p:sp>
         <p:nvSpPr>
-          <p:cNvPr id="42" name="Text 40"/>
+          <p:cNvPr id="48" name="Text 46"/>
           <p:cNvSpPr txBox="1"/>
           <p:nvPr/>
         </p:nvSpPr>
         <p:spPr>
           <a:xfrm>
             <a:off x="658368" y="3191794"/>
-            <a:ext cx="1938528" cy="248502"/>
+            <a:ext cx="310896" cy="248502"/>
+          </a:xfrm>
+          <a:prstGeom prst="rect">
+            <a:avLst/>
+          </a:prstGeom>
+          <a:noFill/>
+          <a:ln/>
+        </p:spPr>
+        <p:txBody>
+          <a:bodyPr wrap="square" lIns="0" tIns="0" rIns="0" bIns="0" rtlCol="0" anchor="ctr"/>
+          <a:lstStyle/>
+          <a:p>
+            <a:pPr algn="r" indent="0" marL="0">
+              <a:buNone/>
+            </a:pPr>
+            <a:r>
+              <a:rPr lang="en-US" sz="1200" dirty="0">
+                <a:solidFill>
+                  <a:srgbClr val="9AA3AD"/>
+                </a:solidFill>
+                <a:latin typeface="Inter" pitchFamily="34" charset="0"/>
+                <a:ea typeface="Inter" pitchFamily="34" charset="-122"/>
+                <a:cs typeface="Inter" pitchFamily="34" charset="-120"/>
+              </a:rPr>
+              <a:t>7</a:t>
+            </a:r>
+            <a:endParaRPr lang="en-US" sz="1200" dirty="0"/>
+          </a:p>
+        </p:txBody>
+      </p:sp>
+      <p:sp>
+        <p:nvSpPr>
+          <p:cNvPr id="49" name="Text 47"/>
+          <p:cNvSpPr txBox="1"/>
+          <p:nvPr/>
+        </p:nvSpPr>
+        <p:spPr>
+          <a:xfrm>
+            <a:off x="1014984" y="3191794"/>
+            <a:ext cx="1783080" cy="248502"/>
           </a:xfrm>
           <a:prstGeom prst="rect">
             <a:avLst/>
@@ -18328,14 +18601,14 @@
       </p:sp>
       <p:sp>
         <p:nvSpPr>
-          <p:cNvPr id="43" name="Shape 41"/>
+          <p:cNvPr id="50" name="Shape 48"/>
           <p:cNvSpPr/>
           <p:nvPr/>
         </p:nvSpPr>
         <p:spPr>
           <a:xfrm>
-            <a:off x="2670048" y="3247707"/>
-            <a:ext cx="350480" cy="136676"/>
+            <a:off x="2871216" y="3247707"/>
+            <a:ext cx="282773" cy="136676"/>
           </a:xfrm>
           <a:prstGeom prst="rect">
             <a:avLst/>
@@ -18348,13 +18621,13 @@
       </p:sp>
       <p:sp>
         <p:nvSpPr>
-          <p:cNvPr id="44" name="Text 42"/>
-          <p:cNvSpPr txBox="1"/>
-          <p:nvPr/>
-        </p:nvSpPr>
-        <p:spPr>
-          <a:xfrm>
-            <a:off x="3529584" y="3191794"/>
+          <p:cNvPr id="51" name="Text 49"/>
+          <p:cNvSpPr txBox="1"/>
+          <p:nvPr/>
+        </p:nvSpPr>
+        <p:spPr>
+          <a:xfrm>
+            <a:off x="3575304" y="3191794"/>
             <a:ext cx="822960" cy="248502"/>
           </a:xfrm>
           <a:prstGeom prst="rect">
@@ -18387,13 +18660,13 @@
       </p:sp>
       <p:sp>
         <p:nvSpPr>
-          <p:cNvPr id="45" name="Text 43"/>
-          <p:cNvSpPr txBox="1"/>
-          <p:nvPr/>
-        </p:nvSpPr>
-        <p:spPr>
-          <a:xfrm>
-            <a:off x="4352544" y="3191794"/>
+          <p:cNvPr id="52" name="Text 50"/>
+          <p:cNvSpPr txBox="1"/>
+          <p:nvPr/>
+        </p:nvSpPr>
+        <p:spPr>
+          <a:xfrm>
+            <a:off x="4398264" y="3191794"/>
             <a:ext cx="786384" cy="248502"/>
           </a:xfrm>
           <a:prstGeom prst="rect">
@@ -18426,13 +18699,13 @@
       </p:sp>
       <p:sp>
         <p:nvSpPr>
-          <p:cNvPr id="46" name="Text 44"/>
-          <p:cNvSpPr txBox="1"/>
-          <p:nvPr/>
-        </p:nvSpPr>
-        <p:spPr>
-          <a:xfrm>
-            <a:off x="5138928" y="3191794"/>
+          <p:cNvPr id="53" name="Text 51"/>
+          <p:cNvSpPr txBox="1"/>
+          <p:nvPr/>
+        </p:nvSpPr>
+        <p:spPr>
+          <a:xfrm>
+            <a:off x="5184648" y="3191794"/>
             <a:ext cx="731520" cy="248502"/>
           </a:xfrm>
           <a:prstGeom prst="rect">
@@ -18465,14 +18738,53 @@
       </p:sp>
       <p:sp>
         <p:nvSpPr>
-          <p:cNvPr id="47" name="Text 45"/>
+          <p:cNvPr id="54" name="Text 52"/>
           <p:cNvSpPr txBox="1"/>
           <p:nvPr/>
         </p:nvSpPr>
         <p:spPr>
           <a:xfrm>
             <a:off x="658368" y="3440296"/>
-            <a:ext cx="1938528" cy="248502"/>
+            <a:ext cx="310896" cy="248502"/>
+          </a:xfrm>
+          <a:prstGeom prst="rect">
+            <a:avLst/>
+          </a:prstGeom>
+          <a:noFill/>
+          <a:ln/>
+        </p:spPr>
+        <p:txBody>
+          <a:bodyPr wrap="square" lIns="0" tIns="0" rIns="0" bIns="0" rtlCol="0" anchor="ctr"/>
+          <a:lstStyle/>
+          <a:p>
+            <a:pPr algn="r" indent="0" marL="0">
+              <a:buNone/>
+            </a:pPr>
+            <a:r>
+              <a:rPr lang="en-US" sz="1200" dirty="0">
+                <a:solidFill>
+                  <a:srgbClr val="9AA3AD"/>
+                </a:solidFill>
+                <a:latin typeface="Inter" pitchFamily="34" charset="0"/>
+                <a:ea typeface="Inter" pitchFamily="34" charset="-122"/>
+                <a:cs typeface="Inter" pitchFamily="34" charset="-120"/>
+              </a:rPr>
+              <a:t>8</a:t>
+            </a:r>
+            <a:endParaRPr lang="en-US" sz="1200" dirty="0"/>
+          </a:p>
+        </p:txBody>
+      </p:sp>
+      <p:sp>
+        <p:nvSpPr>
+          <p:cNvPr id="55" name="Text 53"/>
+          <p:cNvSpPr txBox="1"/>
+          <p:nvPr/>
+        </p:nvSpPr>
+        <p:spPr>
+          <a:xfrm>
+            <a:off x="1014984" y="3440296"/>
+            <a:ext cx="1783080" cy="248502"/>
           </a:xfrm>
           <a:prstGeom prst="rect">
             <a:avLst/>
@@ -18504,14 +18816,14 @@
       </p:sp>
       <p:sp>
         <p:nvSpPr>
-          <p:cNvPr id="48" name="Shape 46"/>
+          <p:cNvPr id="56" name="Shape 54"/>
           <p:cNvSpPr/>
           <p:nvPr/>
         </p:nvSpPr>
         <p:spPr>
           <a:xfrm>
-            <a:off x="2670048" y="3496208"/>
-            <a:ext cx="331101" cy="136676"/>
+            <a:off x="2871216" y="3496208"/>
+            <a:ext cx="267139" cy="136676"/>
           </a:xfrm>
           <a:prstGeom prst="rect">
             <a:avLst/>
@@ -18524,13 +18836,13 @@
       </p:sp>
       <p:sp>
         <p:nvSpPr>
-          <p:cNvPr id="49" name="Text 47"/>
-          <p:cNvSpPr txBox="1"/>
-          <p:nvPr/>
-        </p:nvSpPr>
-        <p:spPr>
-          <a:xfrm>
-            <a:off x="3529584" y="3440296"/>
+          <p:cNvPr id="57" name="Text 55"/>
+          <p:cNvSpPr txBox="1"/>
+          <p:nvPr/>
+        </p:nvSpPr>
+        <p:spPr>
+          <a:xfrm>
+            <a:off x="3575304" y="3440296"/>
             <a:ext cx="822960" cy="248502"/>
           </a:xfrm>
           <a:prstGeom prst="rect">
@@ -18563,13 +18875,13 @@
       </p:sp>
       <p:sp>
         <p:nvSpPr>
-          <p:cNvPr id="50" name="Text 48"/>
-          <p:cNvSpPr txBox="1"/>
-          <p:nvPr/>
-        </p:nvSpPr>
-        <p:spPr>
-          <a:xfrm>
-            <a:off x="4352544" y="3440296"/>
+          <p:cNvPr id="58" name="Text 56"/>
+          <p:cNvSpPr txBox="1"/>
+          <p:nvPr/>
+        </p:nvSpPr>
+        <p:spPr>
+          <a:xfrm>
+            <a:off x="4398264" y="3440296"/>
             <a:ext cx="786384" cy="248502"/>
           </a:xfrm>
           <a:prstGeom prst="rect">
@@ -18602,13 +18914,13 @@
       </p:sp>
       <p:sp>
         <p:nvSpPr>
-          <p:cNvPr id="51" name="Text 49"/>
-          <p:cNvSpPr txBox="1"/>
-          <p:nvPr/>
-        </p:nvSpPr>
-        <p:spPr>
-          <a:xfrm>
-            <a:off x="5138928" y="3440296"/>
+          <p:cNvPr id="59" name="Text 57"/>
+          <p:cNvSpPr txBox="1"/>
+          <p:nvPr/>
+        </p:nvSpPr>
+        <p:spPr>
+          <a:xfrm>
+            <a:off x="5184648" y="3440296"/>
             <a:ext cx="731520" cy="248502"/>
           </a:xfrm>
           <a:prstGeom prst="rect">
@@ -18641,14 +18953,53 @@
       </p:sp>
       <p:sp>
         <p:nvSpPr>
-          <p:cNvPr id="52" name="Text 50"/>
+          <p:cNvPr id="60" name="Text 58"/>
           <p:cNvSpPr txBox="1"/>
           <p:nvPr/>
         </p:nvSpPr>
         <p:spPr>
           <a:xfrm>
             <a:off x="658368" y="3688797"/>
-            <a:ext cx="1938528" cy="248502"/>
+            <a:ext cx="310896" cy="248502"/>
+          </a:xfrm>
+          <a:prstGeom prst="rect">
+            <a:avLst/>
+          </a:prstGeom>
+          <a:noFill/>
+          <a:ln/>
+        </p:spPr>
+        <p:txBody>
+          <a:bodyPr wrap="square" lIns="0" tIns="0" rIns="0" bIns="0" rtlCol="0" anchor="ctr"/>
+          <a:lstStyle/>
+          <a:p>
+            <a:pPr algn="r" indent="0" marL="0">
+              <a:buNone/>
+            </a:pPr>
+            <a:r>
+              <a:rPr lang="en-US" sz="1200" dirty="0">
+                <a:solidFill>
+                  <a:srgbClr val="9AA3AD"/>
+                </a:solidFill>
+                <a:latin typeface="Inter" pitchFamily="34" charset="0"/>
+                <a:ea typeface="Inter" pitchFamily="34" charset="-122"/>
+                <a:cs typeface="Inter" pitchFamily="34" charset="-120"/>
+              </a:rPr>
+              <a:t>9</a:t>
+            </a:r>
+            <a:endParaRPr lang="en-US" sz="1200" dirty="0"/>
+          </a:p>
+        </p:txBody>
+      </p:sp>
+      <p:sp>
+        <p:nvSpPr>
+          <p:cNvPr id="61" name="Text 59"/>
+          <p:cNvSpPr txBox="1"/>
+          <p:nvPr/>
+        </p:nvSpPr>
+        <p:spPr>
+          <a:xfrm>
+            <a:off x="1014984" y="3688797"/>
+            <a:ext cx="1783080" cy="248502"/>
           </a:xfrm>
           <a:prstGeom prst="rect">
             <a:avLst/>
@@ -18680,14 +19031,14 @@
       </p:sp>
       <p:sp>
         <p:nvSpPr>
-          <p:cNvPr id="53" name="Shape 51"/>
+          <p:cNvPr id="62" name="Shape 60"/>
           <p:cNvSpPr/>
           <p:nvPr/>
         </p:nvSpPr>
         <p:spPr>
           <a:xfrm>
-            <a:off x="2670048" y="3744710"/>
-            <a:ext cx="316904" cy="136676"/>
+            <a:off x="2871216" y="3744710"/>
+            <a:ext cx="255684" cy="136676"/>
           </a:xfrm>
           <a:prstGeom prst="rect">
             <a:avLst/>
@@ -18700,13 +19051,13 @@
       </p:sp>
       <p:sp>
         <p:nvSpPr>
-          <p:cNvPr id="54" name="Text 52"/>
-          <p:cNvSpPr txBox="1"/>
-          <p:nvPr/>
-        </p:nvSpPr>
-        <p:spPr>
-          <a:xfrm>
-            <a:off x="3529584" y="3688797"/>
+          <p:cNvPr id="63" name="Text 61"/>
+          <p:cNvSpPr txBox="1"/>
+          <p:nvPr/>
+        </p:nvSpPr>
+        <p:spPr>
+          <a:xfrm>
+            <a:off x="3575304" y="3688797"/>
             <a:ext cx="822960" cy="248502"/>
           </a:xfrm>
           <a:prstGeom prst="rect">
@@ -18739,13 +19090,13 @@
       </p:sp>
       <p:sp>
         <p:nvSpPr>
-          <p:cNvPr id="55" name="Text 53"/>
-          <p:cNvSpPr txBox="1"/>
-          <p:nvPr/>
-        </p:nvSpPr>
-        <p:spPr>
-          <a:xfrm>
-            <a:off x="4352544" y="3688797"/>
+          <p:cNvPr id="64" name="Text 62"/>
+          <p:cNvSpPr txBox="1"/>
+          <p:nvPr/>
+        </p:nvSpPr>
+        <p:spPr>
+          <a:xfrm>
+            <a:off x="4398264" y="3688797"/>
             <a:ext cx="786384" cy="248502"/>
           </a:xfrm>
           <a:prstGeom prst="rect">
@@ -18778,13 +19129,13 @@
       </p:sp>
       <p:sp>
         <p:nvSpPr>
-          <p:cNvPr id="56" name="Text 54"/>
-          <p:cNvSpPr txBox="1"/>
-          <p:nvPr/>
-        </p:nvSpPr>
-        <p:spPr>
-          <a:xfrm>
-            <a:off x="5138928" y="3688797"/>
+          <p:cNvPr id="65" name="Text 63"/>
+          <p:cNvSpPr txBox="1"/>
+          <p:nvPr/>
+        </p:nvSpPr>
+        <p:spPr>
+          <a:xfrm>
+            <a:off x="5184648" y="3688797"/>
             <a:ext cx="731520" cy="248502"/>
           </a:xfrm>
           <a:prstGeom prst="rect">
@@ -18817,14 +19168,53 @@
       </p:sp>
       <p:sp>
         <p:nvSpPr>
-          <p:cNvPr id="57" name="Text 55"/>
+          <p:cNvPr id="66" name="Text 64"/>
           <p:cNvSpPr txBox="1"/>
           <p:nvPr/>
         </p:nvSpPr>
         <p:spPr>
           <a:xfrm>
             <a:off x="658368" y="3937299"/>
-            <a:ext cx="1938528" cy="248502"/>
+            <a:ext cx="310896" cy="248502"/>
+          </a:xfrm>
+          <a:prstGeom prst="rect">
+            <a:avLst/>
+          </a:prstGeom>
+          <a:noFill/>
+          <a:ln/>
+        </p:spPr>
+        <p:txBody>
+          <a:bodyPr wrap="square" lIns="0" tIns="0" rIns="0" bIns="0" rtlCol="0" anchor="ctr"/>
+          <a:lstStyle/>
+          <a:p>
+            <a:pPr algn="r" indent="0" marL="0">
+              <a:buNone/>
+            </a:pPr>
+            <a:r>
+              <a:rPr lang="en-US" sz="1200" dirty="0">
+                <a:solidFill>
+                  <a:srgbClr val="9AA3AD"/>
+                </a:solidFill>
+                <a:latin typeface="Inter" pitchFamily="34" charset="0"/>
+                <a:ea typeface="Inter" pitchFamily="34" charset="-122"/>
+                <a:cs typeface="Inter" pitchFamily="34" charset="-120"/>
+              </a:rPr>
+              <a:t>10</a:t>
+            </a:r>
+            <a:endParaRPr lang="en-US" sz="1200" dirty="0"/>
+          </a:p>
+        </p:txBody>
+      </p:sp>
+      <p:sp>
+        <p:nvSpPr>
+          <p:cNvPr id="67" name="Text 65"/>
+          <p:cNvSpPr txBox="1"/>
+          <p:nvPr/>
+        </p:nvSpPr>
+        <p:spPr>
+          <a:xfrm>
+            <a:off x="1014984" y="3937299"/>
+            <a:ext cx="1783080" cy="248502"/>
           </a:xfrm>
           <a:prstGeom prst="rect">
             <a:avLst/>
@@ -18856,14 +19246,14 @@
       </p:sp>
       <p:sp>
         <p:nvSpPr>
-          <p:cNvPr id="58" name="Shape 56"/>
+          <p:cNvPr id="68" name="Shape 66"/>
           <p:cNvSpPr/>
           <p:nvPr/>
         </p:nvSpPr>
         <p:spPr>
           <a:xfrm>
-            <a:off x="2670048" y="3993212"/>
-            <a:ext cx="295308" cy="136676"/>
+            <a:off x="2871216" y="3993212"/>
+            <a:ext cx="238260" cy="136676"/>
           </a:xfrm>
           <a:prstGeom prst="rect">
             <a:avLst/>
@@ -18876,13 +19266,13 @@
       </p:sp>
       <p:sp>
         <p:nvSpPr>
-          <p:cNvPr id="59" name="Text 57"/>
-          <p:cNvSpPr txBox="1"/>
-          <p:nvPr/>
-        </p:nvSpPr>
-        <p:spPr>
-          <a:xfrm>
-            <a:off x="3529584" y="3937299"/>
+          <p:cNvPr id="69" name="Text 67"/>
+          <p:cNvSpPr txBox="1"/>
+          <p:nvPr/>
+        </p:nvSpPr>
+        <p:spPr>
+          <a:xfrm>
+            <a:off x="3575304" y="3937299"/>
             <a:ext cx="822960" cy="248502"/>
           </a:xfrm>
           <a:prstGeom prst="rect">
@@ -18915,13 +19305,13 @@
       </p:sp>
       <p:sp>
         <p:nvSpPr>
-          <p:cNvPr id="60" name="Text 58"/>
-          <p:cNvSpPr txBox="1"/>
-          <p:nvPr/>
-        </p:nvSpPr>
-        <p:spPr>
-          <a:xfrm>
-            <a:off x="4352544" y="3937299"/>
+          <p:cNvPr id="70" name="Text 68"/>
+          <p:cNvSpPr txBox="1"/>
+          <p:nvPr/>
+        </p:nvSpPr>
+        <p:spPr>
+          <a:xfrm>
+            <a:off x="4398264" y="3937299"/>
             <a:ext cx="786384" cy="248502"/>
           </a:xfrm>
           <a:prstGeom prst="rect">
@@ -18954,13 +19344,13 @@
       </p:sp>
       <p:sp>
         <p:nvSpPr>
-          <p:cNvPr id="61" name="Text 59"/>
-          <p:cNvSpPr txBox="1"/>
-          <p:nvPr/>
-        </p:nvSpPr>
-        <p:spPr>
-          <a:xfrm>
-            <a:off x="5138928" y="3937299"/>
+          <p:cNvPr id="71" name="Text 69"/>
+          <p:cNvSpPr txBox="1"/>
+          <p:nvPr/>
+        </p:nvSpPr>
+        <p:spPr>
+          <a:xfrm>
+            <a:off x="5184648" y="3937299"/>
             <a:ext cx="731520" cy="248502"/>
           </a:xfrm>
           <a:prstGeom prst="rect">
@@ -18993,14 +19383,53 @@
       </p:sp>
       <p:sp>
         <p:nvSpPr>
-          <p:cNvPr id="62" name="Text 60"/>
+          <p:cNvPr id="72" name="Text 70"/>
           <p:cNvSpPr txBox="1"/>
           <p:nvPr/>
         </p:nvSpPr>
         <p:spPr>
           <a:xfrm>
             <a:off x="658368" y="4185800"/>
-            <a:ext cx="1938528" cy="248502"/>
+            <a:ext cx="310896" cy="248502"/>
+          </a:xfrm>
+          <a:prstGeom prst="rect">
+            <a:avLst/>
+          </a:prstGeom>
+          <a:noFill/>
+          <a:ln/>
+        </p:spPr>
+        <p:txBody>
+          <a:bodyPr wrap="square" lIns="0" tIns="0" rIns="0" bIns="0" rtlCol="0" anchor="ctr"/>
+          <a:lstStyle/>
+          <a:p>
+            <a:pPr algn="r" indent="0" marL="0">
+              <a:buNone/>
+            </a:pPr>
+            <a:r>
+              <a:rPr lang="en-US" sz="1200" dirty="0">
+                <a:solidFill>
+                  <a:srgbClr val="9AA3AD"/>
+                </a:solidFill>
+                <a:latin typeface="Inter" pitchFamily="34" charset="0"/>
+                <a:ea typeface="Inter" pitchFamily="34" charset="-122"/>
+                <a:cs typeface="Inter" pitchFamily="34" charset="-120"/>
+              </a:rPr>
+              <a:t>11</a:t>
+            </a:r>
+            <a:endParaRPr lang="en-US" sz="1200" dirty="0"/>
+          </a:p>
+        </p:txBody>
+      </p:sp>
+      <p:sp>
+        <p:nvSpPr>
+          <p:cNvPr id="73" name="Text 71"/>
+          <p:cNvSpPr txBox="1"/>
+          <p:nvPr/>
+        </p:nvSpPr>
+        <p:spPr>
+          <a:xfrm>
+            <a:off x="1014984" y="4185800"/>
+            <a:ext cx="1783080" cy="248502"/>
           </a:xfrm>
           <a:prstGeom prst="rect">
             <a:avLst/>
@@ -19032,14 +19461,14 @@
       </p:sp>
       <p:sp>
         <p:nvSpPr>
-          <p:cNvPr id="63" name="Shape 61"/>
+          <p:cNvPr id="74" name="Shape 72"/>
           <p:cNvSpPr/>
           <p:nvPr/>
         </p:nvSpPr>
         <p:spPr>
           <a:xfrm>
-            <a:off x="2670048" y="4241713"/>
-            <a:ext cx="279971" cy="136676"/>
+            <a:off x="2871216" y="4241713"/>
+            <a:ext cx="225886" cy="136676"/>
           </a:xfrm>
           <a:prstGeom prst="rect">
             <a:avLst/>
@@ -19052,13 +19481,13 @@
       </p:sp>
       <p:sp>
         <p:nvSpPr>
-          <p:cNvPr id="64" name="Text 62"/>
-          <p:cNvSpPr txBox="1"/>
-          <p:nvPr/>
-        </p:nvSpPr>
-        <p:spPr>
-          <a:xfrm>
-            <a:off x="3529584" y="4185800"/>
+          <p:cNvPr id="75" name="Text 73"/>
+          <p:cNvSpPr txBox="1"/>
+          <p:nvPr/>
+        </p:nvSpPr>
+        <p:spPr>
+          <a:xfrm>
+            <a:off x="3575304" y="4185800"/>
             <a:ext cx="822960" cy="248502"/>
           </a:xfrm>
           <a:prstGeom prst="rect">
@@ -19091,13 +19520,13 @@
       </p:sp>
       <p:sp>
         <p:nvSpPr>
-          <p:cNvPr id="65" name="Text 63"/>
-          <p:cNvSpPr txBox="1"/>
-          <p:nvPr/>
-        </p:nvSpPr>
-        <p:spPr>
-          <a:xfrm>
-            <a:off x="4352544" y="4185800"/>
+          <p:cNvPr id="76" name="Text 74"/>
+          <p:cNvSpPr txBox="1"/>
+          <p:nvPr/>
+        </p:nvSpPr>
+        <p:spPr>
+          <a:xfrm>
+            <a:off x="4398264" y="4185800"/>
             <a:ext cx="786384" cy="248502"/>
           </a:xfrm>
           <a:prstGeom prst="rect">
@@ -19130,13 +19559,13 @@
       </p:sp>
       <p:sp>
         <p:nvSpPr>
-          <p:cNvPr id="66" name="Text 64"/>
-          <p:cNvSpPr txBox="1"/>
-          <p:nvPr/>
-        </p:nvSpPr>
-        <p:spPr>
-          <a:xfrm>
-            <a:off x="5138928" y="4185800"/>
+          <p:cNvPr id="77" name="Text 75"/>
+          <p:cNvSpPr txBox="1"/>
+          <p:nvPr/>
+        </p:nvSpPr>
+        <p:spPr>
+          <a:xfrm>
+            <a:off x="5184648" y="4185800"/>
             <a:ext cx="731520" cy="248502"/>
           </a:xfrm>
           <a:prstGeom prst="rect">
@@ -19169,14 +19598,53 @@
       </p:sp>
       <p:sp>
         <p:nvSpPr>
-          <p:cNvPr id="67" name="Text 65"/>
+          <p:cNvPr id="78" name="Text 76"/>
           <p:cNvSpPr txBox="1"/>
           <p:nvPr/>
         </p:nvSpPr>
         <p:spPr>
           <a:xfrm>
             <a:off x="658368" y="4434302"/>
-            <a:ext cx="1938528" cy="248502"/>
+            <a:ext cx="310896" cy="248502"/>
+          </a:xfrm>
+          <a:prstGeom prst="rect">
+            <a:avLst/>
+          </a:prstGeom>
+          <a:noFill/>
+          <a:ln/>
+        </p:spPr>
+        <p:txBody>
+          <a:bodyPr wrap="square" lIns="0" tIns="0" rIns="0" bIns="0" rtlCol="0" anchor="ctr"/>
+          <a:lstStyle/>
+          <a:p>
+            <a:pPr algn="r" indent="0" marL="0">
+              <a:buNone/>
+            </a:pPr>
+            <a:r>
+              <a:rPr lang="en-US" sz="1200" dirty="0">
+                <a:solidFill>
+                  <a:srgbClr val="9AA3AD"/>
+                </a:solidFill>
+                <a:latin typeface="Inter" pitchFamily="34" charset="0"/>
+                <a:ea typeface="Inter" pitchFamily="34" charset="-122"/>
+                <a:cs typeface="Inter" pitchFamily="34" charset="-120"/>
+              </a:rPr>
+              <a:t>12</a:t>
+            </a:r>
+            <a:endParaRPr lang="en-US" sz="1200" dirty="0"/>
+          </a:p>
+        </p:txBody>
+      </p:sp>
+      <p:sp>
+        <p:nvSpPr>
+          <p:cNvPr id="79" name="Text 77"/>
+          <p:cNvSpPr txBox="1"/>
+          <p:nvPr/>
+        </p:nvSpPr>
+        <p:spPr>
+          <a:xfrm>
+            <a:off x="1014984" y="4434302"/>
+            <a:ext cx="1783080" cy="248502"/>
           </a:xfrm>
           <a:prstGeom prst="rect">
             <a:avLst/>
@@ -19208,14 +19676,14 @@
       </p:sp>
       <p:sp>
         <p:nvSpPr>
-          <p:cNvPr id="68" name="Shape 66"/>
+          <p:cNvPr id="80" name="Shape 78"/>
           <p:cNvSpPr/>
           <p:nvPr/>
         </p:nvSpPr>
         <p:spPr>
           <a:xfrm>
-            <a:off x="2670048" y="4490215"/>
-            <a:ext cx="275254" cy="136676"/>
+            <a:off x="2871216" y="4490215"/>
+            <a:ext cx="222080" cy="136676"/>
           </a:xfrm>
           <a:prstGeom prst="rect">
             <a:avLst/>
@@ -19228,13 +19696,13 @@
       </p:sp>
       <p:sp>
         <p:nvSpPr>
-          <p:cNvPr id="69" name="Text 67"/>
-          <p:cNvSpPr txBox="1"/>
-          <p:nvPr/>
-        </p:nvSpPr>
-        <p:spPr>
-          <a:xfrm>
-            <a:off x="3529584" y="4434302"/>
+          <p:cNvPr id="81" name="Text 79"/>
+          <p:cNvSpPr txBox="1"/>
+          <p:nvPr/>
+        </p:nvSpPr>
+        <p:spPr>
+          <a:xfrm>
+            <a:off x="3575304" y="4434302"/>
             <a:ext cx="822960" cy="248502"/>
           </a:xfrm>
           <a:prstGeom prst="rect">
@@ -19267,13 +19735,13 @@
       </p:sp>
       <p:sp>
         <p:nvSpPr>
-          <p:cNvPr id="70" name="Text 68"/>
-          <p:cNvSpPr txBox="1"/>
-          <p:nvPr/>
-        </p:nvSpPr>
-        <p:spPr>
-          <a:xfrm>
-            <a:off x="4352544" y="4434302"/>
+          <p:cNvPr id="82" name="Text 80"/>
+          <p:cNvSpPr txBox="1"/>
+          <p:nvPr/>
+        </p:nvSpPr>
+        <p:spPr>
+          <a:xfrm>
+            <a:off x="4398264" y="4434302"/>
             <a:ext cx="786384" cy="248502"/>
           </a:xfrm>
           <a:prstGeom prst="rect">
@@ -19306,13 +19774,13 @@
       </p:sp>
       <p:sp>
         <p:nvSpPr>
-          <p:cNvPr id="71" name="Text 69"/>
-          <p:cNvSpPr txBox="1"/>
-          <p:nvPr/>
-        </p:nvSpPr>
-        <p:spPr>
-          <a:xfrm>
-            <a:off x="5138928" y="4434302"/>
+          <p:cNvPr id="83" name="Text 81"/>
+          <p:cNvSpPr txBox="1"/>
+          <p:nvPr/>
+        </p:nvSpPr>
+        <p:spPr>
+          <a:xfrm>
+            <a:off x="5184648" y="4434302"/>
             <a:ext cx="731520" cy="248502"/>
           </a:xfrm>
           <a:prstGeom prst="rect">
@@ -19345,14 +19813,53 @@
       </p:sp>
       <p:sp>
         <p:nvSpPr>
-          <p:cNvPr id="72" name="Text 70"/>
+          <p:cNvPr id="84" name="Text 82"/>
           <p:cNvSpPr txBox="1"/>
           <p:nvPr/>
         </p:nvSpPr>
         <p:spPr>
           <a:xfrm>
             <a:off x="658368" y="4682804"/>
-            <a:ext cx="1938528" cy="248502"/>
+            <a:ext cx="310896" cy="248502"/>
+          </a:xfrm>
+          <a:prstGeom prst="rect">
+            <a:avLst/>
+          </a:prstGeom>
+          <a:noFill/>
+          <a:ln/>
+        </p:spPr>
+        <p:txBody>
+          <a:bodyPr wrap="square" lIns="0" tIns="0" rIns="0" bIns="0" rtlCol="0" anchor="ctr"/>
+          <a:lstStyle/>
+          <a:p>
+            <a:pPr algn="r" indent="0" marL="0">
+              <a:buNone/>
+            </a:pPr>
+            <a:r>
+              <a:rPr lang="en-US" sz="1200" dirty="0">
+                <a:solidFill>
+                  <a:srgbClr val="9AA3AD"/>
+                </a:solidFill>
+                <a:latin typeface="Inter" pitchFamily="34" charset="0"/>
+                <a:ea typeface="Inter" pitchFamily="34" charset="-122"/>
+                <a:cs typeface="Inter" pitchFamily="34" charset="-120"/>
+              </a:rPr>
+              <a:t>13</a:t>
+            </a:r>
+            <a:endParaRPr lang="en-US" sz="1200" dirty="0"/>
+          </a:p>
+        </p:txBody>
+      </p:sp>
+      <p:sp>
+        <p:nvSpPr>
+          <p:cNvPr id="85" name="Text 83"/>
+          <p:cNvSpPr txBox="1"/>
+          <p:nvPr/>
+        </p:nvSpPr>
+        <p:spPr>
+          <a:xfrm>
+            <a:off x="1014984" y="4682804"/>
+            <a:ext cx="1783080" cy="248502"/>
           </a:xfrm>
           <a:prstGeom prst="rect">
             <a:avLst/>
@@ -19384,14 +19891,14 @@
       </p:sp>
       <p:sp>
         <p:nvSpPr>
-          <p:cNvPr id="73" name="Shape 71"/>
+          <p:cNvPr id="86" name="Shape 84"/>
           <p:cNvSpPr/>
           <p:nvPr/>
         </p:nvSpPr>
         <p:spPr>
           <a:xfrm>
-            <a:off x="2670048" y="4738717"/>
-            <a:ext cx="249770" cy="136676"/>
+            <a:off x="2871216" y="4738717"/>
+            <a:ext cx="201519" cy="136676"/>
           </a:xfrm>
           <a:prstGeom prst="rect">
             <a:avLst/>
@@ -19404,13 +19911,13 @@
       </p:sp>
       <p:sp>
         <p:nvSpPr>
-          <p:cNvPr id="74" name="Text 72"/>
-          <p:cNvSpPr txBox="1"/>
-          <p:nvPr/>
-        </p:nvSpPr>
-        <p:spPr>
-          <a:xfrm>
-            <a:off x="3529584" y="4682804"/>
+          <p:cNvPr id="87" name="Text 85"/>
+          <p:cNvSpPr txBox="1"/>
+          <p:nvPr/>
+        </p:nvSpPr>
+        <p:spPr>
+          <a:xfrm>
+            <a:off x="3575304" y="4682804"/>
             <a:ext cx="822960" cy="248502"/>
           </a:xfrm>
           <a:prstGeom prst="rect">
@@ -19443,13 +19950,13 @@
       </p:sp>
       <p:sp>
         <p:nvSpPr>
-          <p:cNvPr id="75" name="Text 73"/>
-          <p:cNvSpPr txBox="1"/>
-          <p:nvPr/>
-        </p:nvSpPr>
-        <p:spPr>
-          <a:xfrm>
-            <a:off x="4352544" y="4682804"/>
+          <p:cNvPr id="88" name="Text 86"/>
+          <p:cNvSpPr txBox="1"/>
+          <p:nvPr/>
+        </p:nvSpPr>
+        <p:spPr>
+          <a:xfrm>
+            <a:off x="4398264" y="4682804"/>
             <a:ext cx="786384" cy="248502"/>
           </a:xfrm>
           <a:prstGeom prst="rect">
@@ -19482,13 +19989,13 @@
       </p:sp>
       <p:sp>
         <p:nvSpPr>
-          <p:cNvPr id="76" name="Text 74"/>
-          <p:cNvSpPr txBox="1"/>
-          <p:nvPr/>
-        </p:nvSpPr>
-        <p:spPr>
-          <a:xfrm>
-            <a:off x="5138928" y="4682804"/>
+          <p:cNvPr id="89" name="Text 87"/>
+          <p:cNvSpPr txBox="1"/>
+          <p:nvPr/>
+        </p:nvSpPr>
+        <p:spPr>
+          <a:xfrm>
+            <a:off x="5184648" y="4682804"/>
             <a:ext cx="731520" cy="248502"/>
           </a:xfrm>
           <a:prstGeom prst="rect">
@@ -19521,14 +20028,53 @@
       </p:sp>
       <p:sp>
         <p:nvSpPr>
-          <p:cNvPr id="77" name="Text 75"/>
+          <p:cNvPr id="90" name="Text 88"/>
           <p:cNvSpPr txBox="1"/>
           <p:nvPr/>
         </p:nvSpPr>
         <p:spPr>
           <a:xfrm>
             <a:off x="658368" y="4931305"/>
-            <a:ext cx="1938528" cy="248502"/>
+            <a:ext cx="310896" cy="248502"/>
+          </a:xfrm>
+          <a:prstGeom prst="rect">
+            <a:avLst/>
+          </a:prstGeom>
+          <a:noFill/>
+          <a:ln/>
+        </p:spPr>
+        <p:txBody>
+          <a:bodyPr wrap="square" lIns="0" tIns="0" rIns="0" bIns="0" rtlCol="0" anchor="ctr"/>
+          <a:lstStyle/>
+          <a:p>
+            <a:pPr algn="r" indent="0" marL="0">
+              <a:buNone/>
+            </a:pPr>
+            <a:r>
+              <a:rPr lang="en-US" sz="1200" dirty="0">
+                <a:solidFill>
+                  <a:srgbClr val="9AA3AD"/>
+                </a:solidFill>
+                <a:latin typeface="Inter" pitchFamily="34" charset="0"/>
+                <a:ea typeface="Inter" pitchFamily="34" charset="-122"/>
+                <a:cs typeface="Inter" pitchFamily="34" charset="-120"/>
+              </a:rPr>
+              <a:t>14</a:t>
+            </a:r>
+            <a:endParaRPr lang="en-US" sz="1200" dirty="0"/>
+          </a:p>
+        </p:txBody>
+      </p:sp>
+      <p:sp>
+        <p:nvSpPr>
+          <p:cNvPr id="91" name="Text 89"/>
+          <p:cNvSpPr txBox="1"/>
+          <p:nvPr/>
+        </p:nvSpPr>
+        <p:spPr>
+          <a:xfrm>
+            <a:off x="1014984" y="4931305"/>
+            <a:ext cx="1783080" cy="248502"/>
           </a:xfrm>
           <a:prstGeom prst="rect">
             <a:avLst/>
@@ -19560,14 +20106,14 @@
       </p:sp>
       <p:sp>
         <p:nvSpPr>
-          <p:cNvPr id="78" name="Shape 76"/>
+          <p:cNvPr id="92" name="Shape 90"/>
           <p:cNvSpPr/>
           <p:nvPr/>
         </p:nvSpPr>
         <p:spPr>
           <a:xfrm>
-            <a:off x="2670048" y="4987218"/>
-            <a:ext cx="246222" cy="136676"/>
+            <a:off x="2871216" y="4987218"/>
+            <a:ext cx="198656" cy="136676"/>
           </a:xfrm>
           <a:prstGeom prst="rect">
             <a:avLst/>
@@ -19580,13 +20126,13 @@
       </p:sp>
       <p:sp>
         <p:nvSpPr>
-          <p:cNvPr id="79" name="Text 77"/>
-          <p:cNvSpPr txBox="1"/>
-          <p:nvPr/>
-        </p:nvSpPr>
-        <p:spPr>
-          <a:xfrm>
-            <a:off x="3529584" y="4931305"/>
+          <p:cNvPr id="93" name="Text 91"/>
+          <p:cNvSpPr txBox="1"/>
+          <p:nvPr/>
+        </p:nvSpPr>
+        <p:spPr>
+          <a:xfrm>
+            <a:off x="3575304" y="4931305"/>
             <a:ext cx="822960" cy="248502"/>
           </a:xfrm>
           <a:prstGeom prst="rect">
@@ -19619,13 +20165,13 @@
       </p:sp>
       <p:sp>
         <p:nvSpPr>
-          <p:cNvPr id="80" name="Text 78"/>
-          <p:cNvSpPr txBox="1"/>
-          <p:nvPr/>
-        </p:nvSpPr>
-        <p:spPr>
-          <a:xfrm>
-            <a:off x="4352544" y="4931305"/>
+          <p:cNvPr id="94" name="Text 92"/>
+          <p:cNvSpPr txBox="1"/>
+          <p:nvPr/>
+        </p:nvSpPr>
+        <p:spPr>
+          <a:xfrm>
+            <a:off x="4398264" y="4931305"/>
             <a:ext cx="786384" cy="248502"/>
           </a:xfrm>
           <a:prstGeom prst="rect">
@@ -19658,13 +20204,13 @@
       </p:sp>
       <p:sp>
         <p:nvSpPr>
-          <p:cNvPr id="81" name="Text 79"/>
-          <p:cNvSpPr txBox="1"/>
-          <p:nvPr/>
-        </p:nvSpPr>
-        <p:spPr>
-          <a:xfrm>
-            <a:off x="5138928" y="4931305"/>
+          <p:cNvPr id="95" name="Text 93"/>
+          <p:cNvSpPr txBox="1"/>
+          <p:nvPr/>
+        </p:nvSpPr>
+        <p:spPr>
+          <a:xfrm>
+            <a:off x="5184648" y="4931305"/>
             <a:ext cx="731520" cy="248502"/>
           </a:xfrm>
           <a:prstGeom prst="rect">
@@ -19697,14 +20243,53 @@
       </p:sp>
       <p:sp>
         <p:nvSpPr>
-          <p:cNvPr id="82" name="Text 80"/>
+          <p:cNvPr id="96" name="Text 94"/>
           <p:cNvSpPr txBox="1"/>
           <p:nvPr/>
         </p:nvSpPr>
         <p:spPr>
           <a:xfrm>
             <a:off x="658368" y="5179807"/>
-            <a:ext cx="1938528" cy="248502"/>
+            <a:ext cx="310896" cy="248502"/>
+          </a:xfrm>
+          <a:prstGeom prst="rect">
+            <a:avLst/>
+          </a:prstGeom>
+          <a:noFill/>
+          <a:ln/>
+        </p:spPr>
+        <p:txBody>
+          <a:bodyPr wrap="square" lIns="0" tIns="0" rIns="0" bIns="0" rtlCol="0" anchor="ctr"/>
+          <a:lstStyle/>
+          <a:p>
+            <a:pPr algn="r" indent="0" marL="0">
+              <a:buNone/>
+            </a:pPr>
+            <a:r>
+              <a:rPr lang="en-US" sz="1200" dirty="0">
+                <a:solidFill>
+                  <a:srgbClr val="9AA3AD"/>
+                </a:solidFill>
+                <a:latin typeface="Inter" pitchFamily="34" charset="0"/>
+                <a:ea typeface="Inter" pitchFamily="34" charset="-122"/>
+                <a:cs typeface="Inter" pitchFamily="34" charset="-120"/>
+              </a:rPr>
+              <a:t>15</a:t>
+            </a:r>
+            <a:endParaRPr lang="en-US" sz="1200" dirty="0"/>
+          </a:p>
+        </p:txBody>
+      </p:sp>
+      <p:sp>
+        <p:nvSpPr>
+          <p:cNvPr id="97" name="Text 95"/>
+          <p:cNvSpPr txBox="1"/>
+          <p:nvPr/>
+        </p:nvSpPr>
+        <p:spPr>
+          <a:xfrm>
+            <a:off x="1014984" y="5179807"/>
+            <a:ext cx="1783080" cy="248502"/>
           </a:xfrm>
           <a:prstGeom prst="rect">
             <a:avLst/>
@@ -19736,14 +20321,14 @@
       </p:sp>
       <p:sp>
         <p:nvSpPr>
-          <p:cNvPr id="83" name="Shape 81"/>
+          <p:cNvPr id="98" name="Shape 96"/>
           <p:cNvSpPr/>
           <p:nvPr/>
         </p:nvSpPr>
         <p:spPr>
           <a:xfrm>
-            <a:off x="2670048" y="5235720"/>
-            <a:ext cx="245006" cy="136676"/>
+            <a:off x="2871216" y="5235720"/>
+            <a:ext cx="197675" cy="136676"/>
           </a:xfrm>
           <a:prstGeom prst="rect">
             <a:avLst/>
@@ -19756,13 +20341,13 @@
       </p:sp>
       <p:sp>
         <p:nvSpPr>
-          <p:cNvPr id="84" name="Text 82"/>
-          <p:cNvSpPr txBox="1"/>
-          <p:nvPr/>
-        </p:nvSpPr>
-        <p:spPr>
-          <a:xfrm>
-            <a:off x="3529584" y="5179807"/>
+          <p:cNvPr id="99" name="Text 97"/>
+          <p:cNvSpPr txBox="1"/>
+          <p:nvPr/>
+        </p:nvSpPr>
+        <p:spPr>
+          <a:xfrm>
+            <a:off x="3575304" y="5179807"/>
             <a:ext cx="822960" cy="248502"/>
           </a:xfrm>
           <a:prstGeom prst="rect">
@@ -19795,13 +20380,13 @@
       </p:sp>
       <p:sp>
         <p:nvSpPr>
-          <p:cNvPr id="85" name="Text 83"/>
-          <p:cNvSpPr txBox="1"/>
-          <p:nvPr/>
-        </p:nvSpPr>
-        <p:spPr>
-          <a:xfrm>
-            <a:off x="4352544" y="5179807"/>
+          <p:cNvPr id="100" name="Text 98"/>
+          <p:cNvSpPr txBox="1"/>
+          <p:nvPr/>
+        </p:nvSpPr>
+        <p:spPr>
+          <a:xfrm>
+            <a:off x="4398264" y="5179807"/>
             <a:ext cx="786384" cy="248502"/>
           </a:xfrm>
           <a:prstGeom prst="rect">
@@ -19834,13 +20419,13 @@
       </p:sp>
       <p:sp>
         <p:nvSpPr>
-          <p:cNvPr id="86" name="Text 84"/>
-          <p:cNvSpPr txBox="1"/>
-          <p:nvPr/>
-        </p:nvSpPr>
-        <p:spPr>
-          <a:xfrm>
-            <a:off x="5138928" y="5179807"/>
+          <p:cNvPr id="101" name="Text 99"/>
+          <p:cNvSpPr txBox="1"/>
+          <p:nvPr/>
+        </p:nvSpPr>
+        <p:spPr>
+          <a:xfrm>
+            <a:off x="5184648" y="5179807"/>
             <a:ext cx="731520" cy="248502"/>
           </a:xfrm>
           <a:prstGeom prst="rect">
@@ -19873,14 +20458,53 @@
       </p:sp>
       <p:sp>
         <p:nvSpPr>
-          <p:cNvPr id="87" name="Text 85"/>
+          <p:cNvPr id="102" name="Text 100"/>
           <p:cNvSpPr txBox="1"/>
           <p:nvPr/>
         </p:nvSpPr>
         <p:spPr>
           <a:xfrm>
             <a:off x="658368" y="5428309"/>
-            <a:ext cx="1938528" cy="248502"/>
+            <a:ext cx="310896" cy="248502"/>
+          </a:xfrm>
+          <a:prstGeom prst="rect">
+            <a:avLst/>
+          </a:prstGeom>
+          <a:noFill/>
+          <a:ln/>
+        </p:spPr>
+        <p:txBody>
+          <a:bodyPr wrap="square" lIns="0" tIns="0" rIns="0" bIns="0" rtlCol="0" anchor="ctr"/>
+          <a:lstStyle/>
+          <a:p>
+            <a:pPr algn="r" indent="0" marL="0">
+              <a:buNone/>
+            </a:pPr>
+            <a:r>
+              <a:rPr lang="en-US" sz="1200" dirty="0">
+                <a:solidFill>
+                  <a:srgbClr val="9AA3AD"/>
+                </a:solidFill>
+                <a:latin typeface="Inter" pitchFamily="34" charset="0"/>
+                <a:ea typeface="Inter" pitchFamily="34" charset="-122"/>
+                <a:cs typeface="Inter" pitchFamily="34" charset="-120"/>
+              </a:rPr>
+              <a:t>16</a:t>
+            </a:r>
+            <a:endParaRPr lang="en-US" sz="1200" dirty="0"/>
+          </a:p>
+        </p:txBody>
+      </p:sp>
+      <p:sp>
+        <p:nvSpPr>
+          <p:cNvPr id="103" name="Text 101"/>
+          <p:cNvSpPr txBox="1"/>
+          <p:nvPr/>
+        </p:nvSpPr>
+        <p:spPr>
+          <a:xfrm>
+            <a:off x="1014984" y="5428309"/>
+            <a:ext cx="1783080" cy="248502"/>
           </a:xfrm>
           <a:prstGeom prst="rect">
             <a:avLst/>
@@ -19912,14 +20536,14 @@
       </p:sp>
       <p:sp>
         <p:nvSpPr>
-          <p:cNvPr id="88" name="Shape 86"/>
+          <p:cNvPr id="104" name="Shape 102"/>
           <p:cNvSpPr/>
           <p:nvPr/>
         </p:nvSpPr>
         <p:spPr>
           <a:xfrm>
-            <a:off x="2670048" y="5484222"/>
-            <a:ext cx="243965" cy="136676"/>
+            <a:off x="2871216" y="5484222"/>
+            <a:ext cx="196835" cy="136676"/>
           </a:xfrm>
           <a:prstGeom prst="rect">
             <a:avLst/>
@@ -19932,13 +20556,13 @@
       </p:sp>
       <p:sp>
         <p:nvSpPr>
-          <p:cNvPr id="89" name="Text 87"/>
-          <p:cNvSpPr txBox="1"/>
-          <p:nvPr/>
-        </p:nvSpPr>
-        <p:spPr>
-          <a:xfrm>
-            <a:off x="3529584" y="5428309"/>
+          <p:cNvPr id="105" name="Text 103"/>
+          <p:cNvSpPr txBox="1"/>
+          <p:nvPr/>
+        </p:nvSpPr>
+        <p:spPr>
+          <a:xfrm>
+            <a:off x="3575304" y="5428309"/>
             <a:ext cx="822960" cy="248502"/>
           </a:xfrm>
           <a:prstGeom prst="rect">
@@ -19971,13 +20595,13 @@
       </p:sp>
       <p:sp>
         <p:nvSpPr>
-          <p:cNvPr id="90" name="Text 88"/>
-          <p:cNvSpPr txBox="1"/>
-          <p:nvPr/>
-        </p:nvSpPr>
-        <p:spPr>
-          <a:xfrm>
-            <a:off x="4352544" y="5428309"/>
+          <p:cNvPr id="106" name="Text 104"/>
+          <p:cNvSpPr txBox="1"/>
+          <p:nvPr/>
+        </p:nvSpPr>
+        <p:spPr>
+          <a:xfrm>
+            <a:off x="4398264" y="5428309"/>
             <a:ext cx="786384" cy="248502"/>
           </a:xfrm>
           <a:prstGeom prst="rect">
@@ -20010,13 +20634,13 @@
       </p:sp>
       <p:sp>
         <p:nvSpPr>
-          <p:cNvPr id="91" name="Text 89"/>
-          <p:cNvSpPr txBox="1"/>
-          <p:nvPr/>
-        </p:nvSpPr>
-        <p:spPr>
-          <a:xfrm>
-            <a:off x="5138928" y="5428309"/>
+          <p:cNvPr id="107" name="Text 105"/>
+          <p:cNvSpPr txBox="1"/>
+          <p:nvPr/>
+        </p:nvSpPr>
+        <p:spPr>
+          <a:xfrm>
+            <a:off x="5184648" y="5428309"/>
             <a:ext cx="731520" cy="248502"/>
           </a:xfrm>
           <a:prstGeom prst="rect">
@@ -20049,14 +20673,53 @@
       </p:sp>
       <p:sp>
         <p:nvSpPr>
-          <p:cNvPr id="92" name="Text 90"/>
+          <p:cNvPr id="108" name="Text 106"/>
           <p:cNvSpPr txBox="1"/>
           <p:nvPr/>
         </p:nvSpPr>
         <p:spPr>
           <a:xfrm>
             <a:off x="658368" y="5676810"/>
-            <a:ext cx="1938528" cy="248502"/>
+            <a:ext cx="310896" cy="248502"/>
+          </a:xfrm>
+          <a:prstGeom prst="rect">
+            <a:avLst/>
+          </a:prstGeom>
+          <a:noFill/>
+          <a:ln/>
+        </p:spPr>
+        <p:txBody>
+          <a:bodyPr wrap="square" lIns="0" tIns="0" rIns="0" bIns="0" rtlCol="0" anchor="ctr"/>
+          <a:lstStyle/>
+          <a:p>
+            <a:pPr algn="r" indent="0" marL="0">
+              <a:buNone/>
+            </a:pPr>
+            <a:r>
+              <a:rPr lang="en-US" sz="1200" dirty="0">
+                <a:solidFill>
+                  <a:srgbClr val="9AA3AD"/>
+                </a:solidFill>
+                <a:latin typeface="Inter" pitchFamily="34" charset="0"/>
+                <a:ea typeface="Inter" pitchFamily="34" charset="-122"/>
+                <a:cs typeface="Inter" pitchFamily="34" charset="-120"/>
+              </a:rPr>
+              <a:t>17</a:t>
+            </a:r>
+            <a:endParaRPr lang="en-US" sz="1200" dirty="0"/>
+          </a:p>
+        </p:txBody>
+      </p:sp>
+      <p:sp>
+        <p:nvSpPr>
+          <p:cNvPr id="109" name="Text 107"/>
+          <p:cNvSpPr txBox="1"/>
+          <p:nvPr/>
+        </p:nvSpPr>
+        <p:spPr>
+          <a:xfrm>
+            <a:off x="1014984" y="5676810"/>
+            <a:ext cx="1783080" cy="248502"/>
           </a:xfrm>
           <a:prstGeom prst="rect">
             <a:avLst/>
@@ -20088,14 +20751,14 @@
       </p:sp>
       <p:sp>
         <p:nvSpPr>
-          <p:cNvPr id="93" name="Shape 91"/>
+          <p:cNvPr id="110" name="Shape 108"/>
           <p:cNvSpPr/>
           <p:nvPr/>
         </p:nvSpPr>
         <p:spPr>
           <a:xfrm>
-            <a:off x="2670048" y="5732723"/>
-            <a:ext cx="232714" cy="136676"/>
+            <a:off x="2871216" y="5732723"/>
+            <a:ext cx="187758" cy="136676"/>
           </a:xfrm>
           <a:prstGeom prst="rect">
             <a:avLst/>
@@ -20108,13 +20771,13 @@
       </p:sp>
       <p:sp>
         <p:nvSpPr>
-          <p:cNvPr id="94" name="Text 92"/>
-          <p:cNvSpPr txBox="1"/>
-          <p:nvPr/>
-        </p:nvSpPr>
-        <p:spPr>
-          <a:xfrm>
-            <a:off x="3529584" y="5676810"/>
+          <p:cNvPr id="111" name="Text 109"/>
+          <p:cNvSpPr txBox="1"/>
+          <p:nvPr/>
+        </p:nvSpPr>
+        <p:spPr>
+          <a:xfrm>
+            <a:off x="3575304" y="5676810"/>
             <a:ext cx="822960" cy="248502"/>
           </a:xfrm>
           <a:prstGeom prst="rect">
@@ -20147,13 +20810,13 @@
       </p:sp>
       <p:sp>
         <p:nvSpPr>
-          <p:cNvPr id="95" name="Text 93"/>
-          <p:cNvSpPr txBox="1"/>
-          <p:nvPr/>
-        </p:nvSpPr>
-        <p:spPr>
-          <a:xfrm>
-            <a:off x="4352544" y="5676810"/>
+          <p:cNvPr id="112" name="Text 110"/>
+          <p:cNvSpPr txBox="1"/>
+          <p:nvPr/>
+        </p:nvSpPr>
+        <p:spPr>
+          <a:xfrm>
+            <a:off x="4398264" y="5676810"/>
             <a:ext cx="786384" cy="248502"/>
           </a:xfrm>
           <a:prstGeom prst="rect">
@@ -20186,13 +20849,13 @@
       </p:sp>
       <p:sp>
         <p:nvSpPr>
-          <p:cNvPr id="96" name="Text 94"/>
-          <p:cNvSpPr txBox="1"/>
-          <p:nvPr/>
-        </p:nvSpPr>
-        <p:spPr>
-          <a:xfrm>
-            <a:off x="5138928" y="5676810"/>
+          <p:cNvPr id="113" name="Text 111"/>
+          <p:cNvSpPr txBox="1"/>
+          <p:nvPr/>
+        </p:nvSpPr>
+        <p:spPr>
+          <a:xfrm>
+            <a:off x="5184648" y="5676810"/>
             <a:ext cx="731520" cy="248502"/>
           </a:xfrm>
           <a:prstGeom prst="rect">
@@ -20225,14 +20888,53 @@
       </p:sp>
       <p:sp>
         <p:nvSpPr>
-          <p:cNvPr id="97" name="Text 95"/>
+          <p:cNvPr id="114" name="Text 112"/>
           <p:cNvSpPr txBox="1"/>
           <p:nvPr/>
         </p:nvSpPr>
         <p:spPr>
           <a:xfrm>
             <a:off x="6208776" y="1700784"/>
-            <a:ext cx="1938528" cy="248502"/>
+            <a:ext cx="310896" cy="248502"/>
+          </a:xfrm>
+          <a:prstGeom prst="rect">
+            <a:avLst/>
+          </a:prstGeom>
+          <a:noFill/>
+          <a:ln/>
+        </p:spPr>
+        <p:txBody>
+          <a:bodyPr wrap="square" lIns="0" tIns="0" rIns="0" bIns="0" rtlCol="0" anchor="ctr"/>
+          <a:lstStyle/>
+          <a:p>
+            <a:pPr algn="r" indent="0" marL="0">
+              <a:buNone/>
+            </a:pPr>
+            <a:r>
+              <a:rPr lang="en-US" sz="1200" dirty="0">
+                <a:solidFill>
+                  <a:srgbClr val="9AA3AD"/>
+                </a:solidFill>
+                <a:latin typeface="Inter" pitchFamily="34" charset="0"/>
+                <a:ea typeface="Inter" pitchFamily="34" charset="-122"/>
+                <a:cs typeface="Inter" pitchFamily="34" charset="-120"/>
+              </a:rPr>
+              <a:t>18</a:t>
+            </a:r>
+            <a:endParaRPr lang="en-US" sz="1200" dirty="0"/>
+          </a:p>
+        </p:txBody>
+      </p:sp>
+      <p:sp>
+        <p:nvSpPr>
+          <p:cNvPr id="115" name="Text 113"/>
+          <p:cNvSpPr txBox="1"/>
+          <p:nvPr/>
+        </p:nvSpPr>
+        <p:spPr>
+          <a:xfrm>
+            <a:off x="6565392" y="1700784"/>
+            <a:ext cx="1783080" cy="248502"/>
           </a:xfrm>
           <a:prstGeom prst="rect">
             <a:avLst/>
@@ -20264,14 +20966,14 @@
       </p:sp>
       <p:sp>
         <p:nvSpPr>
-          <p:cNvPr id="98" name="Shape 96"/>
+          <p:cNvPr id="116" name="Shape 114"/>
           <p:cNvSpPr/>
           <p:nvPr/>
         </p:nvSpPr>
         <p:spPr>
           <a:xfrm>
-            <a:off x="8220456" y="1756697"/>
-            <a:ext cx="232057" cy="136676"/>
+            <a:off x="8421624" y="1756697"/>
+            <a:ext cx="187228" cy="136676"/>
           </a:xfrm>
           <a:prstGeom prst="rect">
             <a:avLst/>
@@ -20284,13 +20986,13 @@
       </p:sp>
       <p:sp>
         <p:nvSpPr>
-          <p:cNvPr id="99" name="Text 97"/>
-          <p:cNvSpPr txBox="1"/>
-          <p:nvPr/>
-        </p:nvSpPr>
-        <p:spPr>
-          <a:xfrm>
-            <a:off x="9079992" y="1700784"/>
+          <p:cNvPr id="117" name="Text 115"/>
+          <p:cNvSpPr txBox="1"/>
+          <p:nvPr/>
+        </p:nvSpPr>
+        <p:spPr>
+          <a:xfrm>
+            <a:off x="9125712" y="1700784"/>
             <a:ext cx="822960" cy="248502"/>
           </a:xfrm>
           <a:prstGeom prst="rect">
@@ -20323,13 +21025,13 @@
       </p:sp>
       <p:sp>
         <p:nvSpPr>
-          <p:cNvPr id="100" name="Text 98"/>
-          <p:cNvSpPr txBox="1"/>
-          <p:nvPr/>
-        </p:nvSpPr>
-        <p:spPr>
-          <a:xfrm>
-            <a:off x="9902952" y="1700784"/>
+          <p:cNvPr id="118" name="Text 116"/>
+          <p:cNvSpPr txBox="1"/>
+          <p:nvPr/>
+        </p:nvSpPr>
+        <p:spPr>
+          <a:xfrm>
+            <a:off x="9948672" y="1700784"/>
             <a:ext cx="786384" cy="248502"/>
           </a:xfrm>
           <a:prstGeom prst="rect">
@@ -20362,13 +21064,13 @@
       </p:sp>
       <p:sp>
         <p:nvSpPr>
-          <p:cNvPr id="101" name="Text 99"/>
-          <p:cNvSpPr txBox="1"/>
-          <p:nvPr/>
-        </p:nvSpPr>
-        <p:spPr>
-          <a:xfrm>
-            <a:off x="10689336" y="1700784"/>
+          <p:cNvPr id="119" name="Text 117"/>
+          <p:cNvSpPr txBox="1"/>
+          <p:nvPr/>
+        </p:nvSpPr>
+        <p:spPr>
+          <a:xfrm>
+            <a:off x="10735056" y="1700784"/>
             <a:ext cx="731520" cy="248502"/>
           </a:xfrm>
           <a:prstGeom prst="rect">
@@ -20401,14 +21103,53 @@
       </p:sp>
       <p:sp>
         <p:nvSpPr>
-          <p:cNvPr id="102" name="Text 100"/>
+          <p:cNvPr id="120" name="Text 118"/>
           <p:cNvSpPr txBox="1"/>
           <p:nvPr/>
         </p:nvSpPr>
         <p:spPr>
           <a:xfrm>
             <a:off x="6208776" y="1949286"/>
-            <a:ext cx="1938528" cy="248502"/>
+            <a:ext cx="310896" cy="248502"/>
+          </a:xfrm>
+          <a:prstGeom prst="rect">
+            <a:avLst/>
+          </a:prstGeom>
+          <a:noFill/>
+          <a:ln/>
+        </p:spPr>
+        <p:txBody>
+          <a:bodyPr wrap="square" lIns="0" tIns="0" rIns="0" bIns="0" rtlCol="0" anchor="ctr"/>
+          <a:lstStyle/>
+          <a:p>
+            <a:pPr algn="r" indent="0" marL="0">
+              <a:buNone/>
+            </a:pPr>
+            <a:r>
+              <a:rPr lang="en-US" sz="1200" dirty="0">
+                <a:solidFill>
+                  <a:srgbClr val="9AA3AD"/>
+                </a:solidFill>
+                <a:latin typeface="Inter" pitchFamily="34" charset="0"/>
+                <a:ea typeface="Inter" pitchFamily="34" charset="-122"/>
+                <a:cs typeface="Inter" pitchFamily="34" charset="-120"/>
+              </a:rPr>
+              <a:t>19</a:t>
+            </a:r>
+            <a:endParaRPr lang="en-US" sz="1200" dirty="0"/>
+          </a:p>
+        </p:txBody>
+      </p:sp>
+      <p:sp>
+        <p:nvSpPr>
+          <p:cNvPr id="121" name="Text 119"/>
+          <p:cNvSpPr txBox="1"/>
+          <p:nvPr/>
+        </p:nvSpPr>
+        <p:spPr>
+          <a:xfrm>
+            <a:off x="6565392" y="1949286"/>
+            <a:ext cx="1783080" cy="248502"/>
           </a:xfrm>
           <a:prstGeom prst="rect">
             <a:avLst/>
@@ -20440,14 +21181,14 @@
       </p:sp>
       <p:sp>
         <p:nvSpPr>
-          <p:cNvPr id="103" name="Shape 101"/>
+          <p:cNvPr id="122" name="Shape 120"/>
           <p:cNvSpPr/>
           <p:nvPr/>
         </p:nvSpPr>
         <p:spPr>
           <a:xfrm>
-            <a:off x="8220456" y="2005199"/>
-            <a:ext cx="227868" cy="136676"/>
+            <a:off x="8421624" y="2005199"/>
+            <a:ext cx="183848" cy="136676"/>
           </a:xfrm>
           <a:prstGeom prst="rect">
             <a:avLst/>
@@ -20460,13 +21201,13 @@
       </p:sp>
       <p:sp>
         <p:nvSpPr>
-          <p:cNvPr id="104" name="Text 102"/>
-          <p:cNvSpPr txBox="1"/>
-          <p:nvPr/>
-        </p:nvSpPr>
-        <p:spPr>
-          <a:xfrm>
-            <a:off x="9079992" y="1949286"/>
+          <p:cNvPr id="123" name="Text 121"/>
+          <p:cNvSpPr txBox="1"/>
+          <p:nvPr/>
+        </p:nvSpPr>
+        <p:spPr>
+          <a:xfrm>
+            <a:off x="9125712" y="1949286"/>
             <a:ext cx="822960" cy="248502"/>
           </a:xfrm>
           <a:prstGeom prst="rect">
@@ -20499,13 +21240,13 @@
       </p:sp>
       <p:sp>
         <p:nvSpPr>
-          <p:cNvPr id="105" name="Text 103"/>
-          <p:cNvSpPr txBox="1"/>
-          <p:nvPr/>
-        </p:nvSpPr>
-        <p:spPr>
-          <a:xfrm>
-            <a:off x="9902952" y="1949286"/>
+          <p:cNvPr id="124" name="Text 122"/>
+          <p:cNvSpPr txBox="1"/>
+          <p:nvPr/>
+        </p:nvSpPr>
+        <p:spPr>
+          <a:xfrm>
+            <a:off x="9948672" y="1949286"/>
             <a:ext cx="786384" cy="248502"/>
           </a:xfrm>
           <a:prstGeom prst="rect">
@@ -20538,13 +21279,13 @@
       </p:sp>
       <p:sp>
         <p:nvSpPr>
-          <p:cNvPr id="106" name="Text 104"/>
-          <p:cNvSpPr txBox="1"/>
-          <p:nvPr/>
-        </p:nvSpPr>
-        <p:spPr>
-          <a:xfrm>
-            <a:off x="10689336" y="1949286"/>
+          <p:cNvPr id="125" name="Text 123"/>
+          <p:cNvSpPr txBox="1"/>
+          <p:nvPr/>
+        </p:nvSpPr>
+        <p:spPr>
+          <a:xfrm>
+            <a:off x="10735056" y="1949286"/>
             <a:ext cx="731520" cy="248502"/>
           </a:xfrm>
           <a:prstGeom prst="rect">
@@ -20577,14 +21318,53 @@
       </p:sp>
       <p:sp>
         <p:nvSpPr>
-          <p:cNvPr id="107" name="Text 105"/>
+          <p:cNvPr id="126" name="Text 124"/>
           <p:cNvSpPr txBox="1"/>
           <p:nvPr/>
         </p:nvSpPr>
         <p:spPr>
           <a:xfrm>
             <a:off x="6208776" y="2197787"/>
-            <a:ext cx="1938528" cy="248502"/>
+            <a:ext cx="310896" cy="248502"/>
+          </a:xfrm>
+          <a:prstGeom prst="rect">
+            <a:avLst/>
+          </a:prstGeom>
+          <a:noFill/>
+          <a:ln/>
+        </p:spPr>
+        <p:txBody>
+          <a:bodyPr wrap="square" lIns="0" tIns="0" rIns="0" bIns="0" rtlCol="0" anchor="ctr"/>
+          <a:lstStyle/>
+          <a:p>
+            <a:pPr algn="r" indent="0" marL="0">
+              <a:buNone/>
+            </a:pPr>
+            <a:r>
+              <a:rPr lang="en-US" sz="1200" dirty="0">
+                <a:solidFill>
+                  <a:srgbClr val="9AA3AD"/>
+                </a:solidFill>
+                <a:latin typeface="Inter" pitchFamily="34" charset="0"/>
+                <a:ea typeface="Inter" pitchFamily="34" charset="-122"/>
+                <a:cs typeface="Inter" pitchFamily="34" charset="-120"/>
+              </a:rPr>
+              <a:t>20</a:t>
+            </a:r>
+            <a:endParaRPr lang="en-US" sz="1200" dirty="0"/>
+          </a:p>
+        </p:txBody>
+      </p:sp>
+      <p:sp>
+        <p:nvSpPr>
+          <p:cNvPr id="127" name="Text 125"/>
+          <p:cNvSpPr txBox="1"/>
+          <p:nvPr/>
+        </p:nvSpPr>
+        <p:spPr>
+          <a:xfrm>
+            <a:off x="6565392" y="2197787"/>
+            <a:ext cx="1783080" cy="248502"/>
           </a:xfrm>
           <a:prstGeom prst="rect">
             <a:avLst/>
@@ -20616,14 +21396,14 @@
       </p:sp>
       <p:sp>
         <p:nvSpPr>
-          <p:cNvPr id="108" name="Shape 106"/>
+          <p:cNvPr id="128" name="Shape 126"/>
           <p:cNvSpPr/>
           <p:nvPr/>
         </p:nvSpPr>
         <p:spPr>
           <a:xfrm>
-            <a:off x="8220456" y="2253700"/>
-            <a:ext cx="216710" cy="136676"/>
+            <a:off x="8421624" y="2253700"/>
+            <a:ext cx="174845" cy="136676"/>
           </a:xfrm>
           <a:prstGeom prst="rect">
             <a:avLst/>
@@ -20636,13 +21416,13 @@
       </p:sp>
       <p:sp>
         <p:nvSpPr>
-          <p:cNvPr id="109" name="Text 107"/>
-          <p:cNvSpPr txBox="1"/>
-          <p:nvPr/>
-        </p:nvSpPr>
-        <p:spPr>
-          <a:xfrm>
-            <a:off x="9079992" y="2197787"/>
+          <p:cNvPr id="129" name="Text 127"/>
+          <p:cNvSpPr txBox="1"/>
+          <p:nvPr/>
+        </p:nvSpPr>
+        <p:spPr>
+          <a:xfrm>
+            <a:off x="9125712" y="2197787"/>
             <a:ext cx="822960" cy="248502"/>
           </a:xfrm>
           <a:prstGeom prst="rect">
@@ -20675,13 +21455,13 @@
       </p:sp>
       <p:sp>
         <p:nvSpPr>
-          <p:cNvPr id="110" name="Text 108"/>
-          <p:cNvSpPr txBox="1"/>
-          <p:nvPr/>
-        </p:nvSpPr>
-        <p:spPr>
-          <a:xfrm>
-            <a:off x="9902952" y="2197787"/>
+          <p:cNvPr id="130" name="Text 128"/>
+          <p:cNvSpPr txBox="1"/>
+          <p:nvPr/>
+        </p:nvSpPr>
+        <p:spPr>
+          <a:xfrm>
+            <a:off x="9948672" y="2197787"/>
             <a:ext cx="786384" cy="248502"/>
           </a:xfrm>
           <a:prstGeom prst="rect">
@@ -20714,13 +21494,13 @@
       </p:sp>
       <p:sp>
         <p:nvSpPr>
-          <p:cNvPr id="111" name="Text 109"/>
-          <p:cNvSpPr txBox="1"/>
-          <p:nvPr/>
-        </p:nvSpPr>
-        <p:spPr>
-          <a:xfrm>
-            <a:off x="10689336" y="2197787"/>
+          <p:cNvPr id="131" name="Text 129"/>
+          <p:cNvSpPr txBox="1"/>
+          <p:nvPr/>
+        </p:nvSpPr>
+        <p:spPr>
+          <a:xfrm>
+            <a:off x="10735056" y="2197787"/>
             <a:ext cx="731520" cy="248502"/>
           </a:xfrm>
           <a:prstGeom prst="rect">
@@ -20753,14 +21533,53 @@
       </p:sp>
       <p:sp>
         <p:nvSpPr>
-          <p:cNvPr id="112" name="Text 110"/>
+          <p:cNvPr id="132" name="Text 130"/>
           <p:cNvSpPr txBox="1"/>
           <p:nvPr/>
         </p:nvSpPr>
         <p:spPr>
           <a:xfrm>
             <a:off x="6208776" y="2446289"/>
-            <a:ext cx="1938528" cy="248502"/>
+            <a:ext cx="310896" cy="248502"/>
+          </a:xfrm>
+          <a:prstGeom prst="rect">
+            <a:avLst/>
+          </a:prstGeom>
+          <a:noFill/>
+          <a:ln/>
+        </p:spPr>
+        <p:txBody>
+          <a:bodyPr wrap="square" lIns="0" tIns="0" rIns="0" bIns="0" rtlCol="0" anchor="ctr"/>
+          <a:lstStyle/>
+          <a:p>
+            <a:pPr algn="r" indent="0" marL="0">
+              <a:buNone/>
+            </a:pPr>
+            <a:r>
+              <a:rPr lang="en-US" sz="1200" dirty="0">
+                <a:solidFill>
+                  <a:srgbClr val="9AA3AD"/>
+                </a:solidFill>
+                <a:latin typeface="Inter" pitchFamily="34" charset="0"/>
+                <a:ea typeface="Inter" pitchFamily="34" charset="-122"/>
+                <a:cs typeface="Inter" pitchFamily="34" charset="-120"/>
+              </a:rPr>
+              <a:t>21</a:t>
+            </a:r>
+            <a:endParaRPr lang="en-US" sz="1200" dirty="0"/>
+          </a:p>
+        </p:txBody>
+      </p:sp>
+      <p:sp>
+        <p:nvSpPr>
+          <p:cNvPr id="133" name="Text 131"/>
+          <p:cNvSpPr txBox="1"/>
+          <p:nvPr/>
+        </p:nvSpPr>
+        <p:spPr>
+          <a:xfrm>
+            <a:off x="6565392" y="2446289"/>
+            <a:ext cx="1783080" cy="248502"/>
           </a:xfrm>
           <a:prstGeom prst="rect">
             <a:avLst/>
@@ -20792,14 +21611,14 @@
       </p:sp>
       <p:sp>
         <p:nvSpPr>
-          <p:cNvPr id="113" name="Shape 111"/>
+          <p:cNvPr id="134" name="Shape 132"/>
           <p:cNvSpPr/>
           <p:nvPr/>
         </p:nvSpPr>
         <p:spPr>
           <a:xfrm>
-            <a:off x="8220456" y="2502202"/>
-            <a:ext cx="213355" cy="136676"/>
+            <a:off x="8421624" y="2502202"/>
+            <a:ext cx="172138" cy="136676"/>
           </a:xfrm>
           <a:prstGeom prst="rect">
             <a:avLst/>
@@ -20812,13 +21631,13 @@
       </p:sp>
       <p:sp>
         <p:nvSpPr>
-          <p:cNvPr id="114" name="Text 112"/>
-          <p:cNvSpPr txBox="1"/>
-          <p:nvPr/>
-        </p:nvSpPr>
-        <p:spPr>
-          <a:xfrm>
-            <a:off x="9079992" y="2446289"/>
+          <p:cNvPr id="135" name="Text 133"/>
+          <p:cNvSpPr txBox="1"/>
+          <p:nvPr/>
+        </p:nvSpPr>
+        <p:spPr>
+          <a:xfrm>
+            <a:off x="9125712" y="2446289"/>
             <a:ext cx="822960" cy="248502"/>
           </a:xfrm>
           <a:prstGeom prst="rect">
@@ -20851,13 +21670,13 @@
       </p:sp>
       <p:sp>
         <p:nvSpPr>
-          <p:cNvPr id="115" name="Text 113"/>
-          <p:cNvSpPr txBox="1"/>
-          <p:nvPr/>
-        </p:nvSpPr>
-        <p:spPr>
-          <a:xfrm>
-            <a:off x="9902952" y="2446289"/>
+          <p:cNvPr id="136" name="Text 134"/>
+          <p:cNvSpPr txBox="1"/>
+          <p:nvPr/>
+        </p:nvSpPr>
+        <p:spPr>
+          <a:xfrm>
+            <a:off x="9948672" y="2446289"/>
             <a:ext cx="786384" cy="248502"/>
           </a:xfrm>
           <a:prstGeom prst="rect">
@@ -20890,13 +21709,13 @@
       </p:sp>
       <p:sp>
         <p:nvSpPr>
-          <p:cNvPr id="116" name="Text 114"/>
-          <p:cNvSpPr txBox="1"/>
-          <p:nvPr/>
-        </p:nvSpPr>
-        <p:spPr>
-          <a:xfrm>
-            <a:off x="10689336" y="2446289"/>
+          <p:cNvPr id="137" name="Text 135"/>
+          <p:cNvSpPr txBox="1"/>
+          <p:nvPr/>
+        </p:nvSpPr>
+        <p:spPr>
+          <a:xfrm>
+            <a:off x="10735056" y="2446289"/>
             <a:ext cx="731520" cy="248502"/>
           </a:xfrm>
           <a:prstGeom prst="rect">
@@ -20929,14 +21748,53 @@
       </p:sp>
       <p:sp>
         <p:nvSpPr>
-          <p:cNvPr id="117" name="Text 115"/>
+          <p:cNvPr id="138" name="Text 136"/>
           <p:cNvSpPr txBox="1"/>
           <p:nvPr/>
         </p:nvSpPr>
         <p:spPr>
           <a:xfrm>
             <a:off x="6208776" y="2694791"/>
-            <a:ext cx="1938528" cy="248502"/>
+            <a:ext cx="310896" cy="248502"/>
+          </a:xfrm>
+          <a:prstGeom prst="rect">
+            <a:avLst/>
+          </a:prstGeom>
+          <a:noFill/>
+          <a:ln/>
+        </p:spPr>
+        <p:txBody>
+          <a:bodyPr wrap="square" lIns="0" tIns="0" rIns="0" bIns="0" rtlCol="0" anchor="ctr"/>
+          <a:lstStyle/>
+          <a:p>
+            <a:pPr algn="r" indent="0" marL="0">
+              <a:buNone/>
+            </a:pPr>
+            <a:r>
+              <a:rPr lang="en-US" sz="1200" dirty="0">
+                <a:solidFill>
+                  <a:srgbClr val="9AA3AD"/>
+                </a:solidFill>
+                <a:latin typeface="Inter" pitchFamily="34" charset="0"/>
+                <a:ea typeface="Inter" pitchFamily="34" charset="-122"/>
+                <a:cs typeface="Inter" pitchFamily="34" charset="-120"/>
+              </a:rPr>
+              <a:t>22</a:t>
+            </a:r>
+            <a:endParaRPr lang="en-US" sz="1200" dirty="0"/>
+          </a:p>
+        </p:txBody>
+      </p:sp>
+      <p:sp>
+        <p:nvSpPr>
+          <p:cNvPr id="139" name="Text 137"/>
+          <p:cNvSpPr txBox="1"/>
+          <p:nvPr/>
+        </p:nvSpPr>
+        <p:spPr>
+          <a:xfrm>
+            <a:off x="6565392" y="2694791"/>
+            <a:ext cx="1783080" cy="248502"/>
           </a:xfrm>
           <a:prstGeom prst="rect">
             <a:avLst/>
@@ -20968,14 +21826,14 @@
       </p:sp>
       <p:sp>
         <p:nvSpPr>
-          <p:cNvPr id="118" name="Shape 116"/>
+          <p:cNvPr id="140" name="Shape 138"/>
           <p:cNvSpPr/>
           <p:nvPr/>
         </p:nvSpPr>
         <p:spPr>
           <a:xfrm>
-            <a:off x="8220456" y="2750703"/>
-            <a:ext cx="211393" cy="136676"/>
+            <a:off x="8421624" y="2750703"/>
+            <a:ext cx="170555" cy="136676"/>
           </a:xfrm>
           <a:prstGeom prst="rect">
             <a:avLst/>
@@ -20988,13 +21846,13 @@
       </p:sp>
       <p:sp>
         <p:nvSpPr>
-          <p:cNvPr id="119" name="Text 117"/>
-          <p:cNvSpPr txBox="1"/>
-          <p:nvPr/>
-        </p:nvSpPr>
-        <p:spPr>
-          <a:xfrm>
-            <a:off x="9079992" y="2694791"/>
+          <p:cNvPr id="141" name="Text 139"/>
+          <p:cNvSpPr txBox="1"/>
+          <p:nvPr/>
+        </p:nvSpPr>
+        <p:spPr>
+          <a:xfrm>
+            <a:off x="9125712" y="2694791"/>
             <a:ext cx="822960" cy="248502"/>
           </a:xfrm>
           <a:prstGeom prst="rect">
@@ -21027,13 +21885,13 @@
       </p:sp>
       <p:sp>
         <p:nvSpPr>
-          <p:cNvPr id="120" name="Text 118"/>
-          <p:cNvSpPr txBox="1"/>
-          <p:nvPr/>
-        </p:nvSpPr>
-        <p:spPr>
-          <a:xfrm>
-            <a:off x="9902952" y="2694791"/>
+          <p:cNvPr id="142" name="Text 140"/>
+          <p:cNvSpPr txBox="1"/>
+          <p:nvPr/>
+        </p:nvSpPr>
+        <p:spPr>
+          <a:xfrm>
+            <a:off x="9948672" y="2694791"/>
             <a:ext cx="786384" cy="248502"/>
           </a:xfrm>
           <a:prstGeom prst="rect">
@@ -21066,13 +21924,13 @@
       </p:sp>
       <p:sp>
         <p:nvSpPr>
-          <p:cNvPr id="121" name="Text 119"/>
-          <p:cNvSpPr txBox="1"/>
-          <p:nvPr/>
-        </p:nvSpPr>
-        <p:spPr>
-          <a:xfrm>
-            <a:off x="10689336" y="2694791"/>
+          <p:cNvPr id="143" name="Text 141"/>
+          <p:cNvSpPr txBox="1"/>
+          <p:nvPr/>
+        </p:nvSpPr>
+        <p:spPr>
+          <a:xfrm>
+            <a:off x="10735056" y="2694791"/>
             <a:ext cx="731520" cy="248502"/>
           </a:xfrm>
           <a:prstGeom prst="rect">
@@ -21105,14 +21963,53 @@
       </p:sp>
       <p:sp>
         <p:nvSpPr>
-          <p:cNvPr id="122" name="Text 120"/>
+          <p:cNvPr id="144" name="Text 142"/>
           <p:cNvSpPr txBox="1"/>
           <p:nvPr/>
         </p:nvSpPr>
         <p:spPr>
           <a:xfrm>
             <a:off x="6208776" y="2943292"/>
-            <a:ext cx="1938528" cy="248502"/>
+            <a:ext cx="310896" cy="248502"/>
+          </a:xfrm>
+          <a:prstGeom prst="rect">
+            <a:avLst/>
+          </a:prstGeom>
+          <a:noFill/>
+          <a:ln/>
+        </p:spPr>
+        <p:txBody>
+          <a:bodyPr wrap="square" lIns="0" tIns="0" rIns="0" bIns="0" rtlCol="0" anchor="ctr"/>
+          <a:lstStyle/>
+          <a:p>
+            <a:pPr algn="r" indent="0" marL="0">
+              <a:buNone/>
+            </a:pPr>
+            <a:r>
+              <a:rPr lang="en-US" sz="1200" dirty="0">
+                <a:solidFill>
+                  <a:srgbClr val="9AA3AD"/>
+                </a:solidFill>
+                <a:latin typeface="Inter" pitchFamily="34" charset="0"/>
+                <a:ea typeface="Inter" pitchFamily="34" charset="-122"/>
+                <a:cs typeface="Inter" pitchFamily="34" charset="-120"/>
+              </a:rPr>
+              <a:t>23</a:t>
+            </a:r>
+            <a:endParaRPr lang="en-US" sz="1200" dirty="0"/>
+          </a:p>
+        </p:txBody>
+      </p:sp>
+      <p:sp>
+        <p:nvSpPr>
+          <p:cNvPr id="145" name="Text 143"/>
+          <p:cNvSpPr txBox="1"/>
+          <p:nvPr/>
+        </p:nvSpPr>
+        <p:spPr>
+          <a:xfrm>
+            <a:off x="6565392" y="2943292"/>
+            <a:ext cx="1783080" cy="248502"/>
           </a:xfrm>
           <a:prstGeom prst="rect">
             <a:avLst/>
@@ -21144,14 +22041,14 @@
       </p:sp>
       <p:sp>
         <p:nvSpPr>
-          <p:cNvPr id="123" name="Shape 121"/>
+          <p:cNvPr id="146" name="Shape 144"/>
           <p:cNvSpPr/>
           <p:nvPr/>
         </p:nvSpPr>
         <p:spPr>
           <a:xfrm>
-            <a:off x="8220456" y="2999205"/>
-            <a:ext cx="201201" cy="136676"/>
+            <a:off x="8421624" y="2999205"/>
+            <a:ext cx="162333" cy="136676"/>
           </a:xfrm>
           <a:prstGeom prst="rect">
             <a:avLst/>
@@ -21164,13 +22061,13 @@
       </p:sp>
       <p:sp>
         <p:nvSpPr>
-          <p:cNvPr id="124" name="Text 122"/>
-          <p:cNvSpPr txBox="1"/>
-          <p:nvPr/>
-        </p:nvSpPr>
-        <p:spPr>
-          <a:xfrm>
-            <a:off x="9079992" y="2943292"/>
+          <p:cNvPr id="147" name="Text 145"/>
+          <p:cNvSpPr txBox="1"/>
+          <p:nvPr/>
+        </p:nvSpPr>
+        <p:spPr>
+          <a:xfrm>
+            <a:off x="9125712" y="2943292"/>
             <a:ext cx="822960" cy="248502"/>
           </a:xfrm>
           <a:prstGeom prst="rect">
@@ -21203,13 +22100,13 @@
       </p:sp>
       <p:sp>
         <p:nvSpPr>
-          <p:cNvPr id="125" name="Text 123"/>
-          <p:cNvSpPr txBox="1"/>
-          <p:nvPr/>
-        </p:nvSpPr>
-        <p:spPr>
-          <a:xfrm>
-            <a:off x="9902952" y="2943292"/>
+          <p:cNvPr id="148" name="Text 146"/>
+          <p:cNvSpPr txBox="1"/>
+          <p:nvPr/>
+        </p:nvSpPr>
+        <p:spPr>
+          <a:xfrm>
+            <a:off x="9948672" y="2943292"/>
             <a:ext cx="786384" cy="248502"/>
           </a:xfrm>
           <a:prstGeom prst="rect">
@@ -21242,13 +22139,13 @@
       </p:sp>
       <p:sp>
         <p:nvSpPr>
-          <p:cNvPr id="126" name="Text 124"/>
-          <p:cNvSpPr txBox="1"/>
-          <p:nvPr/>
-        </p:nvSpPr>
-        <p:spPr>
-          <a:xfrm>
-            <a:off x="10689336" y="2943292"/>
+          <p:cNvPr id="149" name="Text 147"/>
+          <p:cNvSpPr txBox="1"/>
+          <p:nvPr/>
+        </p:nvSpPr>
+        <p:spPr>
+          <a:xfrm>
+            <a:off x="10735056" y="2943292"/>
             <a:ext cx="731520" cy="248502"/>
           </a:xfrm>
           <a:prstGeom prst="rect">
@@ -21281,14 +22178,53 @@
       </p:sp>
       <p:sp>
         <p:nvSpPr>
-          <p:cNvPr id="127" name="Text 125"/>
+          <p:cNvPr id="150" name="Text 148"/>
           <p:cNvSpPr txBox="1"/>
           <p:nvPr/>
         </p:nvSpPr>
         <p:spPr>
           <a:xfrm>
             <a:off x="6208776" y="3191794"/>
-            <a:ext cx="1938528" cy="248502"/>
+            <a:ext cx="310896" cy="248502"/>
+          </a:xfrm>
+          <a:prstGeom prst="rect">
+            <a:avLst/>
+          </a:prstGeom>
+          <a:noFill/>
+          <a:ln/>
+        </p:spPr>
+        <p:txBody>
+          <a:bodyPr wrap="square" lIns="0" tIns="0" rIns="0" bIns="0" rtlCol="0" anchor="ctr"/>
+          <a:lstStyle/>
+          <a:p>
+            <a:pPr algn="r" indent="0" marL="0">
+              <a:buNone/>
+            </a:pPr>
+            <a:r>
+              <a:rPr lang="en-US" sz="1200" dirty="0">
+                <a:solidFill>
+                  <a:srgbClr val="9AA3AD"/>
+                </a:solidFill>
+                <a:latin typeface="Inter" pitchFamily="34" charset="0"/>
+                <a:ea typeface="Inter" pitchFamily="34" charset="-122"/>
+                <a:cs typeface="Inter" pitchFamily="34" charset="-120"/>
+              </a:rPr>
+              <a:t>24</a:t>
+            </a:r>
+            <a:endParaRPr lang="en-US" sz="1200" dirty="0"/>
+          </a:p>
+        </p:txBody>
+      </p:sp>
+      <p:sp>
+        <p:nvSpPr>
+          <p:cNvPr id="151" name="Text 149"/>
+          <p:cNvSpPr txBox="1"/>
+          <p:nvPr/>
+        </p:nvSpPr>
+        <p:spPr>
+          <a:xfrm>
+            <a:off x="6565392" y="3191794"/>
+            <a:ext cx="1783080" cy="248502"/>
           </a:xfrm>
           <a:prstGeom prst="rect">
             <a:avLst/>
@@ -21320,14 +22256,14 @@
       </p:sp>
       <p:sp>
         <p:nvSpPr>
-          <p:cNvPr id="128" name="Shape 126"/>
+          <p:cNvPr id="152" name="Shape 150"/>
           <p:cNvSpPr/>
           <p:nvPr/>
         </p:nvSpPr>
         <p:spPr>
           <a:xfrm>
-            <a:off x="8220456" y="3247707"/>
-            <a:ext cx="195251" cy="136676"/>
+            <a:off x="8421624" y="3247707"/>
+            <a:ext cx="157532" cy="136676"/>
           </a:xfrm>
           <a:prstGeom prst="rect">
             <a:avLst/>
@@ -21340,13 +22276,13 @@
       </p:sp>
       <p:sp>
         <p:nvSpPr>
-          <p:cNvPr id="129" name="Text 127"/>
-          <p:cNvSpPr txBox="1"/>
-          <p:nvPr/>
-        </p:nvSpPr>
-        <p:spPr>
-          <a:xfrm>
-            <a:off x="9079992" y="3191794"/>
+          <p:cNvPr id="153" name="Text 151"/>
+          <p:cNvSpPr txBox="1"/>
+          <p:nvPr/>
+        </p:nvSpPr>
+        <p:spPr>
+          <a:xfrm>
+            <a:off x="9125712" y="3191794"/>
             <a:ext cx="822960" cy="248502"/>
           </a:xfrm>
           <a:prstGeom prst="rect">
@@ -21379,13 +22315,13 @@
       </p:sp>
       <p:sp>
         <p:nvSpPr>
-          <p:cNvPr id="130" name="Text 128"/>
-          <p:cNvSpPr txBox="1"/>
-          <p:nvPr/>
-        </p:nvSpPr>
-        <p:spPr>
-          <a:xfrm>
-            <a:off x="9902952" y="3191794"/>
+          <p:cNvPr id="154" name="Text 152"/>
+          <p:cNvSpPr txBox="1"/>
+          <p:nvPr/>
+        </p:nvSpPr>
+        <p:spPr>
+          <a:xfrm>
+            <a:off x="9948672" y="3191794"/>
             <a:ext cx="786384" cy="248502"/>
           </a:xfrm>
           <a:prstGeom prst="rect">
@@ -21418,13 +22354,13 @@
       </p:sp>
       <p:sp>
         <p:nvSpPr>
-          <p:cNvPr id="131" name="Text 129"/>
-          <p:cNvSpPr txBox="1"/>
-          <p:nvPr/>
-        </p:nvSpPr>
-        <p:spPr>
-          <a:xfrm>
-            <a:off x="10689336" y="3191794"/>
+          <p:cNvPr id="155" name="Text 153"/>
+          <p:cNvSpPr txBox="1"/>
+          <p:nvPr/>
+        </p:nvSpPr>
+        <p:spPr>
+          <a:xfrm>
+            <a:off x="10735056" y="3191794"/>
             <a:ext cx="731520" cy="248502"/>
           </a:xfrm>
           <a:prstGeom prst="rect">
@@ -21457,14 +22393,53 @@
       </p:sp>
       <p:sp>
         <p:nvSpPr>
-          <p:cNvPr id="132" name="Text 130"/>
+          <p:cNvPr id="156" name="Text 154"/>
           <p:cNvSpPr txBox="1"/>
           <p:nvPr/>
         </p:nvSpPr>
         <p:spPr>
           <a:xfrm>
             <a:off x="6208776" y="3440296"/>
-            <a:ext cx="1938528" cy="248502"/>
+            <a:ext cx="310896" cy="248502"/>
+          </a:xfrm>
+          <a:prstGeom prst="rect">
+            <a:avLst/>
+          </a:prstGeom>
+          <a:noFill/>
+          <a:ln/>
+        </p:spPr>
+        <p:txBody>
+          <a:bodyPr wrap="square" lIns="0" tIns="0" rIns="0" bIns="0" rtlCol="0" anchor="ctr"/>
+          <a:lstStyle/>
+          <a:p>
+            <a:pPr algn="r" indent="0" marL="0">
+              <a:buNone/>
+            </a:pPr>
+            <a:r>
+              <a:rPr lang="en-US" sz="1200" dirty="0">
+                <a:solidFill>
+                  <a:srgbClr val="9AA3AD"/>
+                </a:solidFill>
+                <a:latin typeface="Inter" pitchFamily="34" charset="0"/>
+                <a:ea typeface="Inter" pitchFamily="34" charset="-122"/>
+                <a:cs typeface="Inter" pitchFamily="34" charset="-120"/>
+              </a:rPr>
+              <a:t>25</a:t>
+            </a:r>
+            <a:endParaRPr lang="en-US" sz="1200" dirty="0"/>
+          </a:p>
+        </p:txBody>
+      </p:sp>
+      <p:sp>
+        <p:nvSpPr>
+          <p:cNvPr id="157" name="Text 155"/>
+          <p:cNvSpPr txBox="1"/>
+          <p:nvPr/>
+        </p:nvSpPr>
+        <p:spPr>
+          <a:xfrm>
+            <a:off x="6565392" y="3440296"/>
+            <a:ext cx="1783080" cy="248502"/>
           </a:xfrm>
           <a:prstGeom prst="rect">
             <a:avLst/>
@@ -21496,14 +22471,14 @@
       </p:sp>
       <p:sp>
         <p:nvSpPr>
-          <p:cNvPr id="133" name="Shape 131"/>
+          <p:cNvPr id="158" name="Shape 156"/>
           <p:cNvSpPr/>
           <p:nvPr/>
         </p:nvSpPr>
         <p:spPr>
           <a:xfrm>
-            <a:off x="8220456" y="3496208"/>
-            <a:ext cx="193063" cy="136676"/>
+            <a:off x="8421624" y="3496208"/>
+            <a:ext cx="155767" cy="136676"/>
           </a:xfrm>
           <a:prstGeom prst="rect">
             <a:avLst/>
@@ -21516,13 +22491,13 @@
       </p:sp>
       <p:sp>
         <p:nvSpPr>
-          <p:cNvPr id="134" name="Text 132"/>
-          <p:cNvSpPr txBox="1"/>
-          <p:nvPr/>
-        </p:nvSpPr>
-        <p:spPr>
-          <a:xfrm>
-            <a:off x="9079992" y="3440296"/>
+          <p:cNvPr id="159" name="Text 157"/>
+          <p:cNvSpPr txBox="1"/>
+          <p:nvPr/>
+        </p:nvSpPr>
+        <p:spPr>
+          <a:xfrm>
+            <a:off x="9125712" y="3440296"/>
             <a:ext cx="822960" cy="248502"/>
           </a:xfrm>
           <a:prstGeom prst="rect">
@@ -21555,13 +22530,13 @@
       </p:sp>
       <p:sp>
         <p:nvSpPr>
-          <p:cNvPr id="135" name="Text 133"/>
-          <p:cNvSpPr txBox="1"/>
-          <p:nvPr/>
-        </p:nvSpPr>
-        <p:spPr>
-          <a:xfrm>
-            <a:off x="9902952" y="3440296"/>
+          <p:cNvPr id="160" name="Text 158"/>
+          <p:cNvSpPr txBox="1"/>
+          <p:nvPr/>
+        </p:nvSpPr>
+        <p:spPr>
+          <a:xfrm>
+            <a:off x="9948672" y="3440296"/>
             <a:ext cx="786384" cy="248502"/>
           </a:xfrm>
           <a:prstGeom prst="rect">
@@ -21594,13 +22569,13 @@
       </p:sp>
       <p:sp>
         <p:nvSpPr>
-          <p:cNvPr id="136" name="Text 134"/>
-          <p:cNvSpPr txBox="1"/>
-          <p:nvPr/>
-        </p:nvSpPr>
-        <p:spPr>
-          <a:xfrm>
-            <a:off x="10689336" y="3440296"/>
+          <p:cNvPr id="161" name="Text 159"/>
+          <p:cNvSpPr txBox="1"/>
+          <p:nvPr/>
+        </p:nvSpPr>
+        <p:spPr>
+          <a:xfrm>
+            <a:off x="10735056" y="3440296"/>
             <a:ext cx="731520" cy="248502"/>
           </a:xfrm>
           <a:prstGeom prst="rect">
@@ -21633,14 +22608,53 @@
       </p:sp>
       <p:sp>
         <p:nvSpPr>
-          <p:cNvPr id="137" name="Text 135"/>
+          <p:cNvPr id="162" name="Text 160"/>
           <p:cNvSpPr txBox="1"/>
           <p:nvPr/>
         </p:nvSpPr>
         <p:spPr>
           <a:xfrm>
             <a:off x="6208776" y="3688797"/>
-            <a:ext cx="1938528" cy="248502"/>
+            <a:ext cx="310896" cy="248502"/>
+          </a:xfrm>
+          <a:prstGeom prst="rect">
+            <a:avLst/>
+          </a:prstGeom>
+          <a:noFill/>
+          <a:ln/>
+        </p:spPr>
+        <p:txBody>
+          <a:bodyPr wrap="square" lIns="0" tIns="0" rIns="0" bIns="0" rtlCol="0" anchor="ctr"/>
+          <a:lstStyle/>
+          <a:p>
+            <a:pPr algn="r" indent="0" marL="0">
+              <a:buNone/>
+            </a:pPr>
+            <a:r>
+              <a:rPr lang="en-US" sz="1200" dirty="0">
+                <a:solidFill>
+                  <a:srgbClr val="9AA3AD"/>
+                </a:solidFill>
+                <a:latin typeface="Inter" pitchFamily="34" charset="0"/>
+                <a:ea typeface="Inter" pitchFamily="34" charset="-122"/>
+                <a:cs typeface="Inter" pitchFamily="34" charset="-120"/>
+              </a:rPr>
+              <a:t>26</a:t>
+            </a:r>
+            <a:endParaRPr lang="en-US" sz="1200" dirty="0"/>
+          </a:p>
+        </p:txBody>
+      </p:sp>
+      <p:sp>
+        <p:nvSpPr>
+          <p:cNvPr id="163" name="Text 161"/>
+          <p:cNvSpPr txBox="1"/>
+          <p:nvPr/>
+        </p:nvSpPr>
+        <p:spPr>
+          <a:xfrm>
+            <a:off x="6565392" y="3688797"/>
+            <a:ext cx="1783080" cy="248502"/>
           </a:xfrm>
           <a:prstGeom prst="rect">
             <a:avLst/>
@@ -21672,14 +22686,14 @@
       </p:sp>
       <p:sp>
         <p:nvSpPr>
-          <p:cNvPr id="138" name="Shape 136"/>
+          <p:cNvPr id="164" name="Shape 162"/>
           <p:cNvSpPr/>
           <p:nvPr/>
         </p:nvSpPr>
         <p:spPr>
           <a:xfrm>
-            <a:off x="8220456" y="3744710"/>
-            <a:ext cx="184766" cy="136676"/>
+            <a:off x="8421624" y="3744710"/>
+            <a:ext cx="149072" cy="136676"/>
           </a:xfrm>
           <a:prstGeom prst="rect">
             <a:avLst/>
@@ -21692,13 +22706,13 @@
       </p:sp>
       <p:sp>
         <p:nvSpPr>
-          <p:cNvPr id="139" name="Text 137"/>
-          <p:cNvSpPr txBox="1"/>
-          <p:nvPr/>
-        </p:nvSpPr>
-        <p:spPr>
-          <a:xfrm>
-            <a:off x="9079992" y="3688797"/>
+          <p:cNvPr id="165" name="Text 163"/>
+          <p:cNvSpPr txBox="1"/>
+          <p:nvPr/>
+        </p:nvSpPr>
+        <p:spPr>
+          <a:xfrm>
+            <a:off x="9125712" y="3688797"/>
             <a:ext cx="822960" cy="248502"/>
           </a:xfrm>
           <a:prstGeom prst="rect">
@@ -21731,13 +22745,13 @@
       </p:sp>
       <p:sp>
         <p:nvSpPr>
-          <p:cNvPr id="140" name="Text 138"/>
-          <p:cNvSpPr txBox="1"/>
-          <p:nvPr/>
-        </p:nvSpPr>
-        <p:spPr>
-          <a:xfrm>
-            <a:off x="9902952" y="3688797"/>
+          <p:cNvPr id="166" name="Text 164"/>
+          <p:cNvSpPr txBox="1"/>
+          <p:nvPr/>
+        </p:nvSpPr>
+        <p:spPr>
+          <a:xfrm>
+            <a:off x="9948672" y="3688797"/>
             <a:ext cx="786384" cy="248502"/>
           </a:xfrm>
           <a:prstGeom prst="rect">
@@ -21770,13 +22784,13 @@
       </p:sp>
       <p:sp>
         <p:nvSpPr>
-          <p:cNvPr id="141" name="Text 139"/>
-          <p:cNvSpPr txBox="1"/>
-          <p:nvPr/>
-        </p:nvSpPr>
-        <p:spPr>
-          <a:xfrm>
-            <a:off x="10689336" y="3688797"/>
+          <p:cNvPr id="167" name="Text 165"/>
+          <p:cNvSpPr txBox="1"/>
+          <p:nvPr/>
+        </p:nvSpPr>
+        <p:spPr>
+          <a:xfrm>
+            <a:off x="10735056" y="3688797"/>
             <a:ext cx="731520" cy="248502"/>
           </a:xfrm>
           <a:prstGeom prst="rect">
@@ -21809,14 +22823,53 @@
       </p:sp>
       <p:sp>
         <p:nvSpPr>
-          <p:cNvPr id="142" name="Text 140"/>
+          <p:cNvPr id="168" name="Text 166"/>
           <p:cNvSpPr txBox="1"/>
           <p:nvPr/>
         </p:nvSpPr>
         <p:spPr>
           <a:xfrm>
             <a:off x="6208776" y="3937299"/>
-            <a:ext cx="1938528" cy="248502"/>
+            <a:ext cx="310896" cy="248502"/>
+          </a:xfrm>
+          <a:prstGeom prst="rect">
+            <a:avLst/>
+          </a:prstGeom>
+          <a:noFill/>
+          <a:ln/>
+        </p:spPr>
+        <p:txBody>
+          <a:bodyPr wrap="square" lIns="0" tIns="0" rIns="0" bIns="0" rtlCol="0" anchor="ctr"/>
+          <a:lstStyle/>
+          <a:p>
+            <a:pPr algn="r" indent="0" marL="0">
+              <a:buNone/>
+            </a:pPr>
+            <a:r>
+              <a:rPr lang="en-US" sz="1200" dirty="0">
+                <a:solidFill>
+                  <a:srgbClr val="9AA3AD"/>
+                </a:solidFill>
+                <a:latin typeface="Inter" pitchFamily="34" charset="0"/>
+                <a:ea typeface="Inter" pitchFamily="34" charset="-122"/>
+                <a:cs typeface="Inter" pitchFamily="34" charset="-120"/>
+              </a:rPr>
+              <a:t>27</a:t>
+            </a:r>
+            <a:endParaRPr lang="en-US" sz="1200" dirty="0"/>
+          </a:p>
+        </p:txBody>
+      </p:sp>
+      <p:sp>
+        <p:nvSpPr>
+          <p:cNvPr id="169" name="Text 167"/>
+          <p:cNvSpPr txBox="1"/>
+          <p:nvPr/>
+        </p:nvSpPr>
+        <p:spPr>
+          <a:xfrm>
+            <a:off x="6565392" y="3937299"/>
+            <a:ext cx="1783080" cy="248502"/>
           </a:xfrm>
           <a:prstGeom prst="rect">
             <a:avLst/>
@@ -21848,14 +22901,14 @@
       </p:sp>
       <p:sp>
         <p:nvSpPr>
-          <p:cNvPr id="143" name="Shape 141"/>
+          <p:cNvPr id="170" name="Shape 168"/>
           <p:cNvSpPr/>
           <p:nvPr/>
         </p:nvSpPr>
         <p:spPr>
           <a:xfrm>
-            <a:off x="8220456" y="3993212"/>
-            <a:ext cx="166831" cy="136676"/>
+            <a:off x="8421624" y="3993212"/>
+            <a:ext cx="134602" cy="136676"/>
           </a:xfrm>
           <a:prstGeom prst="rect">
             <a:avLst/>
@@ -21868,13 +22921,13 @@
       </p:sp>
       <p:sp>
         <p:nvSpPr>
-          <p:cNvPr id="144" name="Text 142"/>
-          <p:cNvSpPr txBox="1"/>
-          <p:nvPr/>
-        </p:nvSpPr>
-        <p:spPr>
-          <a:xfrm>
-            <a:off x="9079992" y="3937299"/>
+          <p:cNvPr id="171" name="Text 169"/>
+          <p:cNvSpPr txBox="1"/>
+          <p:nvPr/>
+        </p:nvSpPr>
+        <p:spPr>
+          <a:xfrm>
+            <a:off x="9125712" y="3937299"/>
             <a:ext cx="822960" cy="248502"/>
           </a:xfrm>
           <a:prstGeom prst="rect">
@@ -21907,13 +22960,13 @@
       </p:sp>
       <p:sp>
         <p:nvSpPr>
-          <p:cNvPr id="145" name="Text 143"/>
-          <p:cNvSpPr txBox="1"/>
-          <p:nvPr/>
-        </p:nvSpPr>
-        <p:spPr>
-          <a:xfrm>
-            <a:off x="9902952" y="3937299"/>
+          <p:cNvPr id="172" name="Text 170"/>
+          <p:cNvSpPr txBox="1"/>
+          <p:nvPr/>
+        </p:nvSpPr>
+        <p:spPr>
+          <a:xfrm>
+            <a:off x="9948672" y="3937299"/>
             <a:ext cx="786384" cy="248502"/>
           </a:xfrm>
           <a:prstGeom prst="rect">
@@ -21946,13 +22999,13 @@
       </p:sp>
       <p:sp>
         <p:nvSpPr>
-          <p:cNvPr id="146" name="Text 144"/>
-          <p:cNvSpPr txBox="1"/>
-          <p:nvPr/>
-        </p:nvSpPr>
-        <p:spPr>
-          <a:xfrm>
-            <a:off x="10689336" y="3937299"/>
+          <p:cNvPr id="173" name="Text 171"/>
+          <p:cNvSpPr txBox="1"/>
+          <p:nvPr/>
+        </p:nvSpPr>
+        <p:spPr>
+          <a:xfrm>
+            <a:off x="10735056" y="3937299"/>
             <a:ext cx="731520" cy="248502"/>
           </a:xfrm>
           <a:prstGeom prst="rect">
@@ -21985,14 +23038,53 @@
       </p:sp>
       <p:sp>
         <p:nvSpPr>
-          <p:cNvPr id="147" name="Text 145"/>
+          <p:cNvPr id="174" name="Text 172"/>
           <p:cNvSpPr txBox="1"/>
           <p:nvPr/>
         </p:nvSpPr>
         <p:spPr>
           <a:xfrm>
             <a:off x="6208776" y="4185800"/>
-            <a:ext cx="1938528" cy="248502"/>
+            <a:ext cx="310896" cy="248502"/>
+          </a:xfrm>
+          <a:prstGeom prst="rect">
+            <a:avLst/>
+          </a:prstGeom>
+          <a:noFill/>
+          <a:ln/>
+        </p:spPr>
+        <p:txBody>
+          <a:bodyPr wrap="square" lIns="0" tIns="0" rIns="0" bIns="0" rtlCol="0" anchor="ctr"/>
+          <a:lstStyle/>
+          <a:p>
+            <a:pPr algn="r" indent="0" marL="0">
+              <a:buNone/>
+            </a:pPr>
+            <a:r>
+              <a:rPr lang="en-US" sz="1200" dirty="0">
+                <a:solidFill>
+                  <a:srgbClr val="9AA3AD"/>
+                </a:solidFill>
+                <a:latin typeface="Inter" pitchFamily="34" charset="0"/>
+                <a:ea typeface="Inter" pitchFamily="34" charset="-122"/>
+                <a:cs typeface="Inter" pitchFamily="34" charset="-120"/>
+              </a:rPr>
+              <a:t>28</a:t>
+            </a:r>
+            <a:endParaRPr lang="en-US" sz="1200" dirty="0"/>
+          </a:p>
+        </p:txBody>
+      </p:sp>
+      <p:sp>
+        <p:nvSpPr>
+          <p:cNvPr id="175" name="Text 173"/>
+          <p:cNvSpPr txBox="1"/>
+          <p:nvPr/>
+        </p:nvSpPr>
+        <p:spPr>
+          <a:xfrm>
+            <a:off x="6565392" y="4185800"/>
+            <a:ext cx="1783080" cy="248502"/>
           </a:xfrm>
           <a:prstGeom prst="rect">
             <a:avLst/>
@@ -22024,14 +23116,14 @@
       </p:sp>
       <p:sp>
         <p:nvSpPr>
-          <p:cNvPr id="148" name="Shape 146"/>
+          <p:cNvPr id="176" name="Shape 174"/>
           <p:cNvSpPr/>
           <p:nvPr/>
         </p:nvSpPr>
         <p:spPr>
           <a:xfrm>
-            <a:off x="8220456" y="4241713"/>
-            <a:ext cx="163399" cy="136676"/>
+            <a:off x="8421624" y="4241713"/>
+            <a:ext cx="131833" cy="136676"/>
           </a:xfrm>
           <a:prstGeom prst="rect">
             <a:avLst/>
@@ -22044,13 +23136,13 @@
       </p:sp>
       <p:sp>
         <p:nvSpPr>
-          <p:cNvPr id="149" name="Text 147"/>
-          <p:cNvSpPr txBox="1"/>
-          <p:nvPr/>
-        </p:nvSpPr>
-        <p:spPr>
-          <a:xfrm>
-            <a:off x="9079992" y="4185800"/>
+          <p:cNvPr id="177" name="Text 175"/>
+          <p:cNvSpPr txBox="1"/>
+          <p:nvPr/>
+        </p:nvSpPr>
+        <p:spPr>
+          <a:xfrm>
+            <a:off x="9125712" y="4185800"/>
             <a:ext cx="822960" cy="248502"/>
           </a:xfrm>
           <a:prstGeom prst="rect">
@@ -22083,13 +23175,13 @@
       </p:sp>
       <p:sp>
         <p:nvSpPr>
-          <p:cNvPr id="150" name="Text 148"/>
-          <p:cNvSpPr txBox="1"/>
-          <p:nvPr/>
-        </p:nvSpPr>
-        <p:spPr>
-          <a:xfrm>
-            <a:off x="9902952" y="4185800"/>
+          <p:cNvPr id="178" name="Text 176"/>
+          <p:cNvSpPr txBox="1"/>
+          <p:nvPr/>
+        </p:nvSpPr>
+        <p:spPr>
+          <a:xfrm>
+            <a:off x="9948672" y="4185800"/>
             <a:ext cx="786384" cy="248502"/>
           </a:xfrm>
           <a:prstGeom prst="rect">
@@ -22122,13 +23214,13 @@
       </p:sp>
       <p:sp>
         <p:nvSpPr>
-          <p:cNvPr id="151" name="Text 149"/>
-          <p:cNvSpPr txBox="1"/>
-          <p:nvPr/>
-        </p:nvSpPr>
-        <p:spPr>
-          <a:xfrm>
-            <a:off x="10689336" y="4185800"/>
+          <p:cNvPr id="179" name="Text 177"/>
+          <p:cNvSpPr txBox="1"/>
+          <p:nvPr/>
+        </p:nvSpPr>
+        <p:spPr>
+          <a:xfrm>
+            <a:off x="10735056" y="4185800"/>
             <a:ext cx="731520" cy="248502"/>
           </a:xfrm>
           <a:prstGeom prst="rect">
@@ -22161,14 +23253,53 @@
       </p:sp>
       <p:sp>
         <p:nvSpPr>
-          <p:cNvPr id="152" name="Text 150"/>
+          <p:cNvPr id="180" name="Text 178"/>
           <p:cNvSpPr txBox="1"/>
           <p:nvPr/>
         </p:nvSpPr>
         <p:spPr>
           <a:xfrm>
             <a:off x="6208776" y="4434302"/>
-            <a:ext cx="1938528" cy="248502"/>
+            <a:ext cx="310896" cy="248502"/>
+          </a:xfrm>
+          <a:prstGeom prst="rect">
+            <a:avLst/>
+          </a:prstGeom>
+          <a:noFill/>
+          <a:ln/>
+        </p:spPr>
+        <p:txBody>
+          <a:bodyPr wrap="square" lIns="0" tIns="0" rIns="0" bIns="0" rtlCol="0" anchor="ctr"/>
+          <a:lstStyle/>
+          <a:p>
+            <a:pPr algn="r" indent="0" marL="0">
+              <a:buNone/>
+            </a:pPr>
+            <a:r>
+              <a:rPr lang="en-US" sz="1200" dirty="0">
+                <a:solidFill>
+                  <a:srgbClr val="9AA3AD"/>
+                </a:solidFill>
+                <a:latin typeface="Inter" pitchFamily="34" charset="0"/>
+                <a:ea typeface="Inter" pitchFamily="34" charset="-122"/>
+                <a:cs typeface="Inter" pitchFamily="34" charset="-120"/>
+              </a:rPr>
+              <a:t>29</a:t>
+            </a:r>
+            <a:endParaRPr lang="en-US" sz="1200" dirty="0"/>
+          </a:p>
+        </p:txBody>
+      </p:sp>
+      <p:sp>
+        <p:nvSpPr>
+          <p:cNvPr id="181" name="Text 179"/>
+          <p:cNvSpPr txBox="1"/>
+          <p:nvPr/>
+        </p:nvSpPr>
+        <p:spPr>
+          <a:xfrm>
+            <a:off x="6565392" y="4434302"/>
+            <a:ext cx="1783080" cy="248502"/>
           </a:xfrm>
           <a:prstGeom prst="rect">
             <a:avLst/>
@@ -22200,14 +23331,14 @@
       </p:sp>
       <p:sp>
         <p:nvSpPr>
-          <p:cNvPr id="153" name="Shape 151"/>
+          <p:cNvPr id="182" name="Shape 180"/>
           <p:cNvSpPr/>
           <p:nvPr/>
         </p:nvSpPr>
         <p:spPr>
           <a:xfrm>
-            <a:off x="8220456" y="4490215"/>
-            <a:ext cx="163357" cy="136676"/>
+            <a:off x="8421624" y="4490215"/>
+            <a:ext cx="131799" cy="136676"/>
           </a:xfrm>
           <a:prstGeom prst="rect">
             <a:avLst/>
@@ -22220,13 +23351,13 @@
       </p:sp>
       <p:sp>
         <p:nvSpPr>
-          <p:cNvPr id="154" name="Text 152"/>
-          <p:cNvSpPr txBox="1"/>
-          <p:nvPr/>
-        </p:nvSpPr>
-        <p:spPr>
-          <a:xfrm>
-            <a:off x="9079992" y="4434302"/>
+          <p:cNvPr id="183" name="Text 181"/>
+          <p:cNvSpPr txBox="1"/>
+          <p:nvPr/>
+        </p:nvSpPr>
+        <p:spPr>
+          <a:xfrm>
+            <a:off x="9125712" y="4434302"/>
             <a:ext cx="822960" cy="248502"/>
           </a:xfrm>
           <a:prstGeom prst="rect">
@@ -22259,13 +23390,13 @@
       </p:sp>
       <p:sp>
         <p:nvSpPr>
-          <p:cNvPr id="155" name="Text 153"/>
-          <p:cNvSpPr txBox="1"/>
-          <p:nvPr/>
-        </p:nvSpPr>
-        <p:spPr>
-          <a:xfrm>
-            <a:off x="9902952" y="4434302"/>
+          <p:cNvPr id="184" name="Text 182"/>
+          <p:cNvSpPr txBox="1"/>
+          <p:nvPr/>
+        </p:nvSpPr>
+        <p:spPr>
+          <a:xfrm>
+            <a:off x="9948672" y="4434302"/>
             <a:ext cx="786384" cy="248502"/>
           </a:xfrm>
           <a:prstGeom prst="rect">
@@ -22298,13 +23429,13 @@
       </p:sp>
       <p:sp>
         <p:nvSpPr>
-          <p:cNvPr id="156" name="Text 154"/>
-          <p:cNvSpPr txBox="1"/>
-          <p:nvPr/>
-        </p:nvSpPr>
-        <p:spPr>
-          <a:xfrm>
-            <a:off x="10689336" y="4434302"/>
+          <p:cNvPr id="185" name="Text 183"/>
+          <p:cNvSpPr txBox="1"/>
+          <p:nvPr/>
+        </p:nvSpPr>
+        <p:spPr>
+          <a:xfrm>
+            <a:off x="10735056" y="4434302"/>
             <a:ext cx="731520" cy="248502"/>
           </a:xfrm>
           <a:prstGeom prst="rect">
@@ -22337,14 +23468,53 @@
       </p:sp>
       <p:sp>
         <p:nvSpPr>
-          <p:cNvPr id="157" name="Text 155"/>
+          <p:cNvPr id="186" name="Text 184"/>
           <p:cNvSpPr txBox="1"/>
           <p:nvPr/>
         </p:nvSpPr>
         <p:spPr>
           <a:xfrm>
             <a:off x="6208776" y="4682804"/>
-            <a:ext cx="1938528" cy="248502"/>
+            <a:ext cx="310896" cy="248502"/>
+          </a:xfrm>
+          <a:prstGeom prst="rect">
+            <a:avLst/>
+          </a:prstGeom>
+          <a:noFill/>
+          <a:ln/>
+        </p:spPr>
+        <p:txBody>
+          <a:bodyPr wrap="square" lIns="0" tIns="0" rIns="0" bIns="0" rtlCol="0" anchor="ctr"/>
+          <a:lstStyle/>
+          <a:p>
+            <a:pPr algn="r" indent="0" marL="0">
+              <a:buNone/>
+            </a:pPr>
+            <a:r>
+              <a:rPr lang="en-US" sz="1200" dirty="0">
+                <a:solidFill>
+                  <a:srgbClr val="9AA3AD"/>
+                </a:solidFill>
+                <a:latin typeface="Inter" pitchFamily="34" charset="0"/>
+                <a:ea typeface="Inter" pitchFamily="34" charset="-122"/>
+                <a:cs typeface="Inter" pitchFamily="34" charset="-120"/>
+              </a:rPr>
+              <a:t>30</a:t>
+            </a:r>
+            <a:endParaRPr lang="en-US" sz="1200" dirty="0"/>
+          </a:p>
+        </p:txBody>
+      </p:sp>
+      <p:sp>
+        <p:nvSpPr>
+          <p:cNvPr id="187" name="Text 185"/>
+          <p:cNvSpPr txBox="1"/>
+          <p:nvPr/>
+        </p:nvSpPr>
+        <p:spPr>
+          <a:xfrm>
+            <a:off x="6565392" y="4682804"/>
+            <a:ext cx="1783080" cy="248502"/>
           </a:xfrm>
           <a:prstGeom prst="rect">
             <a:avLst/>
@@ -22376,14 +23546,14 @@
       </p:sp>
       <p:sp>
         <p:nvSpPr>
-          <p:cNvPr id="158" name="Shape 156"/>
+          <p:cNvPr id="188" name="Shape 186"/>
           <p:cNvSpPr/>
           <p:nvPr/>
         </p:nvSpPr>
         <p:spPr>
           <a:xfrm>
-            <a:off x="8220456" y="4738717"/>
-            <a:ext cx="163282" cy="136676"/>
+            <a:off x="8421624" y="4738717"/>
+            <a:ext cx="131739" cy="136676"/>
           </a:xfrm>
           <a:prstGeom prst="rect">
             <a:avLst/>
@@ -22396,13 +23566,13 @@
       </p:sp>
       <p:sp>
         <p:nvSpPr>
-          <p:cNvPr id="159" name="Text 157"/>
-          <p:cNvSpPr txBox="1"/>
-          <p:nvPr/>
-        </p:nvSpPr>
-        <p:spPr>
-          <a:xfrm>
-            <a:off x="9079992" y="4682804"/>
+          <p:cNvPr id="189" name="Text 187"/>
+          <p:cNvSpPr txBox="1"/>
+          <p:nvPr/>
+        </p:nvSpPr>
+        <p:spPr>
+          <a:xfrm>
+            <a:off x="9125712" y="4682804"/>
             <a:ext cx="822960" cy="248502"/>
           </a:xfrm>
           <a:prstGeom prst="rect">
@@ -22435,13 +23605,13 @@
       </p:sp>
       <p:sp>
         <p:nvSpPr>
-          <p:cNvPr id="160" name="Text 158"/>
-          <p:cNvSpPr txBox="1"/>
-          <p:nvPr/>
-        </p:nvSpPr>
-        <p:spPr>
-          <a:xfrm>
-            <a:off x="9902952" y="4682804"/>
+          <p:cNvPr id="190" name="Text 188"/>
+          <p:cNvSpPr txBox="1"/>
+          <p:nvPr/>
+        </p:nvSpPr>
+        <p:spPr>
+          <a:xfrm>
+            <a:off x="9948672" y="4682804"/>
             <a:ext cx="786384" cy="248502"/>
           </a:xfrm>
           <a:prstGeom prst="rect">
@@ -22474,13 +23644,13 @@
       </p:sp>
       <p:sp>
         <p:nvSpPr>
-          <p:cNvPr id="161" name="Text 159"/>
-          <p:cNvSpPr txBox="1"/>
-          <p:nvPr/>
-        </p:nvSpPr>
-        <p:spPr>
-          <a:xfrm>
-            <a:off x="10689336" y="4682804"/>
+          <p:cNvPr id="191" name="Text 189"/>
+          <p:cNvSpPr txBox="1"/>
+          <p:nvPr/>
+        </p:nvSpPr>
+        <p:spPr>
+          <a:xfrm>
+            <a:off x="10735056" y="4682804"/>
             <a:ext cx="731520" cy="248502"/>
           </a:xfrm>
           <a:prstGeom prst="rect">
@@ -22513,14 +23683,53 @@
       </p:sp>
       <p:sp>
         <p:nvSpPr>
-          <p:cNvPr id="162" name="Text 160"/>
+          <p:cNvPr id="192" name="Text 190"/>
           <p:cNvSpPr txBox="1"/>
           <p:nvPr/>
         </p:nvSpPr>
         <p:spPr>
           <a:xfrm>
             <a:off x="6208776" y="4931305"/>
-            <a:ext cx="1938528" cy="248502"/>
+            <a:ext cx="310896" cy="248502"/>
+          </a:xfrm>
+          <a:prstGeom prst="rect">
+            <a:avLst/>
+          </a:prstGeom>
+          <a:noFill/>
+          <a:ln/>
+        </p:spPr>
+        <p:txBody>
+          <a:bodyPr wrap="square" lIns="0" tIns="0" rIns="0" bIns="0" rtlCol="0" anchor="ctr"/>
+          <a:lstStyle/>
+          <a:p>
+            <a:pPr algn="r" indent="0" marL="0">
+              <a:buNone/>
+            </a:pPr>
+            <a:r>
+              <a:rPr lang="en-US" sz="1200" dirty="0">
+                <a:solidFill>
+                  <a:srgbClr val="9AA3AD"/>
+                </a:solidFill>
+                <a:latin typeface="Inter" pitchFamily="34" charset="0"/>
+                <a:ea typeface="Inter" pitchFamily="34" charset="-122"/>
+                <a:cs typeface="Inter" pitchFamily="34" charset="-120"/>
+              </a:rPr>
+              <a:t>31</a:t>
+            </a:r>
+            <a:endParaRPr lang="en-US" sz="1200" dirty="0"/>
+          </a:p>
+        </p:txBody>
+      </p:sp>
+      <p:sp>
+        <p:nvSpPr>
+          <p:cNvPr id="193" name="Text 191"/>
+          <p:cNvSpPr txBox="1"/>
+          <p:nvPr/>
+        </p:nvSpPr>
+        <p:spPr>
+          <a:xfrm>
+            <a:off x="6565392" y="4931305"/>
+            <a:ext cx="1783080" cy="248502"/>
           </a:xfrm>
           <a:prstGeom prst="rect">
             <a:avLst/>
@@ -22552,14 +23761,14 @@
       </p:sp>
       <p:sp>
         <p:nvSpPr>
-          <p:cNvPr id="163" name="Shape 161"/>
+          <p:cNvPr id="194" name="Shape 192"/>
           <p:cNvSpPr/>
           <p:nvPr/>
         </p:nvSpPr>
         <p:spPr>
           <a:xfrm>
-            <a:off x="8220456" y="4987218"/>
-            <a:ext cx="151770" cy="136676"/>
+            <a:off x="8421624" y="4987218"/>
+            <a:ext cx="122451" cy="136676"/>
           </a:xfrm>
           <a:prstGeom prst="rect">
             <a:avLst/>
@@ -22572,13 +23781,13 @@
       </p:sp>
       <p:sp>
         <p:nvSpPr>
-          <p:cNvPr id="164" name="Text 162"/>
-          <p:cNvSpPr txBox="1"/>
-          <p:nvPr/>
-        </p:nvSpPr>
-        <p:spPr>
-          <a:xfrm>
-            <a:off x="9079992" y="4931305"/>
+          <p:cNvPr id="195" name="Text 193"/>
+          <p:cNvSpPr txBox="1"/>
+          <p:nvPr/>
+        </p:nvSpPr>
+        <p:spPr>
+          <a:xfrm>
+            <a:off x="9125712" y="4931305"/>
             <a:ext cx="822960" cy="248502"/>
           </a:xfrm>
           <a:prstGeom prst="rect">
@@ -22611,13 +23820,13 @@
       </p:sp>
       <p:sp>
         <p:nvSpPr>
-          <p:cNvPr id="165" name="Text 163"/>
-          <p:cNvSpPr txBox="1"/>
-          <p:nvPr/>
-        </p:nvSpPr>
-        <p:spPr>
-          <a:xfrm>
-            <a:off x="9902952" y="4931305"/>
+          <p:cNvPr id="196" name="Text 194"/>
+          <p:cNvSpPr txBox="1"/>
+          <p:nvPr/>
+        </p:nvSpPr>
+        <p:spPr>
+          <a:xfrm>
+            <a:off x="9948672" y="4931305"/>
             <a:ext cx="786384" cy="248502"/>
           </a:xfrm>
           <a:prstGeom prst="rect">
@@ -22650,13 +23859,13 @@
       </p:sp>
       <p:sp>
         <p:nvSpPr>
-          <p:cNvPr id="166" name="Text 164"/>
-          <p:cNvSpPr txBox="1"/>
-          <p:nvPr/>
-        </p:nvSpPr>
-        <p:spPr>
-          <a:xfrm>
-            <a:off x="10689336" y="4931305"/>
+          <p:cNvPr id="197" name="Text 195"/>
+          <p:cNvSpPr txBox="1"/>
+          <p:nvPr/>
+        </p:nvSpPr>
+        <p:spPr>
+          <a:xfrm>
+            <a:off x="10735056" y="4931305"/>
             <a:ext cx="731520" cy="248502"/>
           </a:xfrm>
           <a:prstGeom prst="rect">
@@ -22689,14 +23898,53 @@
       </p:sp>
       <p:sp>
         <p:nvSpPr>
-          <p:cNvPr id="167" name="Text 165"/>
+          <p:cNvPr id="198" name="Text 196"/>
           <p:cNvSpPr txBox="1"/>
           <p:nvPr/>
         </p:nvSpPr>
         <p:spPr>
           <a:xfrm>
             <a:off x="6208776" y="5179807"/>
-            <a:ext cx="1938528" cy="248502"/>
+            <a:ext cx="310896" cy="248502"/>
+          </a:xfrm>
+          <a:prstGeom prst="rect">
+            <a:avLst/>
+          </a:prstGeom>
+          <a:noFill/>
+          <a:ln/>
+        </p:spPr>
+        <p:txBody>
+          <a:bodyPr wrap="square" lIns="0" tIns="0" rIns="0" bIns="0" rtlCol="0" anchor="ctr"/>
+          <a:lstStyle/>
+          <a:p>
+            <a:pPr algn="r" indent="0" marL="0">
+              <a:buNone/>
+            </a:pPr>
+            <a:r>
+              <a:rPr lang="en-US" sz="1200" dirty="0">
+                <a:solidFill>
+                  <a:srgbClr val="9AA3AD"/>
+                </a:solidFill>
+                <a:latin typeface="Inter" pitchFamily="34" charset="0"/>
+                <a:ea typeface="Inter" pitchFamily="34" charset="-122"/>
+                <a:cs typeface="Inter" pitchFamily="34" charset="-120"/>
+              </a:rPr>
+              <a:t>32</a:t>
+            </a:r>
+            <a:endParaRPr lang="en-US" sz="1200" dirty="0"/>
+          </a:p>
+        </p:txBody>
+      </p:sp>
+      <p:sp>
+        <p:nvSpPr>
+          <p:cNvPr id="199" name="Text 197"/>
+          <p:cNvSpPr txBox="1"/>
+          <p:nvPr/>
+        </p:nvSpPr>
+        <p:spPr>
+          <a:xfrm>
+            <a:off x="6565392" y="5179807"/>
+            <a:ext cx="1783080" cy="248502"/>
           </a:xfrm>
           <a:prstGeom prst="rect">
             <a:avLst/>
@@ -22728,14 +23976,14 @@
       </p:sp>
       <p:sp>
         <p:nvSpPr>
-          <p:cNvPr id="168" name="Shape 166"/>
+          <p:cNvPr id="200" name="Shape 198"/>
           <p:cNvSpPr/>
           <p:nvPr/>
         </p:nvSpPr>
         <p:spPr>
           <a:xfrm>
-            <a:off x="8220456" y="5235720"/>
-            <a:ext cx="149543" cy="136676"/>
+            <a:off x="8421624" y="5235720"/>
+            <a:ext cx="120654" cy="136676"/>
           </a:xfrm>
           <a:prstGeom prst="rect">
             <a:avLst/>
@@ -22748,13 +23996,13 @@
       </p:sp>
       <p:sp>
         <p:nvSpPr>
-          <p:cNvPr id="169" name="Text 167"/>
-          <p:cNvSpPr txBox="1"/>
-          <p:nvPr/>
-        </p:nvSpPr>
-        <p:spPr>
-          <a:xfrm>
-            <a:off x="9079992" y="5179807"/>
+          <p:cNvPr id="201" name="Text 199"/>
+          <p:cNvSpPr txBox="1"/>
+          <p:nvPr/>
+        </p:nvSpPr>
+        <p:spPr>
+          <a:xfrm>
+            <a:off x="9125712" y="5179807"/>
             <a:ext cx="822960" cy="248502"/>
           </a:xfrm>
           <a:prstGeom prst="rect">
@@ -22787,13 +24035,13 @@
       </p:sp>
       <p:sp>
         <p:nvSpPr>
-          <p:cNvPr id="170" name="Text 168"/>
-          <p:cNvSpPr txBox="1"/>
-          <p:nvPr/>
-        </p:nvSpPr>
-        <p:spPr>
-          <a:xfrm>
-            <a:off x="9902952" y="5179807"/>
+          <p:cNvPr id="202" name="Text 200"/>
+          <p:cNvSpPr txBox="1"/>
+          <p:nvPr/>
+        </p:nvSpPr>
+        <p:spPr>
+          <a:xfrm>
+            <a:off x="9948672" y="5179807"/>
             <a:ext cx="786384" cy="248502"/>
           </a:xfrm>
           <a:prstGeom prst="rect">
@@ -22826,13 +24074,13 @@
       </p:sp>
       <p:sp>
         <p:nvSpPr>
-          <p:cNvPr id="171" name="Text 169"/>
-          <p:cNvSpPr txBox="1"/>
-          <p:nvPr/>
-        </p:nvSpPr>
-        <p:spPr>
-          <a:xfrm>
-            <a:off x="10689336" y="5179807"/>
+          <p:cNvPr id="203" name="Text 201"/>
+          <p:cNvSpPr txBox="1"/>
+          <p:nvPr/>
+        </p:nvSpPr>
+        <p:spPr>
+          <a:xfrm>
+            <a:off x="10735056" y="5179807"/>
             <a:ext cx="731520" cy="248502"/>
           </a:xfrm>
           <a:prstGeom prst="rect">
@@ -22865,14 +24113,53 @@
       </p:sp>
       <p:sp>
         <p:nvSpPr>
-          <p:cNvPr id="172" name="Text 170"/>
+          <p:cNvPr id="204" name="Text 202"/>
           <p:cNvSpPr txBox="1"/>
           <p:nvPr/>
         </p:nvSpPr>
         <p:spPr>
           <a:xfrm>
             <a:off x="6208776" y="5428309"/>
-            <a:ext cx="1938528" cy="248502"/>
+            <a:ext cx="310896" cy="248502"/>
+          </a:xfrm>
+          <a:prstGeom prst="rect">
+            <a:avLst/>
+          </a:prstGeom>
+          <a:noFill/>
+          <a:ln/>
+        </p:spPr>
+        <p:txBody>
+          <a:bodyPr wrap="square" lIns="0" tIns="0" rIns="0" bIns="0" rtlCol="0" anchor="ctr"/>
+          <a:lstStyle/>
+          <a:p>
+            <a:pPr algn="r" indent="0" marL="0">
+              <a:buNone/>
+            </a:pPr>
+            <a:r>
+              <a:rPr lang="en-US" sz="1200" dirty="0">
+                <a:solidFill>
+                  <a:srgbClr val="9AA3AD"/>
+                </a:solidFill>
+                <a:latin typeface="Inter" pitchFamily="34" charset="0"/>
+                <a:ea typeface="Inter" pitchFamily="34" charset="-122"/>
+                <a:cs typeface="Inter" pitchFamily="34" charset="-120"/>
+              </a:rPr>
+              <a:t>33</a:t>
+            </a:r>
+            <a:endParaRPr lang="en-US" sz="1200" dirty="0"/>
+          </a:p>
+        </p:txBody>
+      </p:sp>
+      <p:sp>
+        <p:nvSpPr>
+          <p:cNvPr id="205" name="Text 203"/>
+          <p:cNvSpPr txBox="1"/>
+          <p:nvPr/>
+        </p:nvSpPr>
+        <p:spPr>
+          <a:xfrm>
+            <a:off x="6565392" y="5428309"/>
+            <a:ext cx="1783080" cy="248502"/>
           </a:xfrm>
           <a:prstGeom prst="rect">
             <a:avLst/>
@@ -22904,14 +24191,14 @@
       </p:sp>
       <p:sp>
         <p:nvSpPr>
-          <p:cNvPr id="173" name="Shape 171"/>
+          <p:cNvPr id="206" name="Shape 204"/>
           <p:cNvSpPr/>
           <p:nvPr/>
         </p:nvSpPr>
         <p:spPr>
           <a:xfrm>
-            <a:off x="8220456" y="5484222"/>
-            <a:ext cx="147241" cy="136676"/>
+            <a:off x="8421624" y="5484222"/>
+            <a:ext cx="118797" cy="136676"/>
           </a:xfrm>
           <a:prstGeom prst="rect">
             <a:avLst/>
@@ -22924,13 +24211,13 @@
       </p:sp>
       <p:sp>
         <p:nvSpPr>
-          <p:cNvPr id="174" name="Text 172"/>
-          <p:cNvSpPr txBox="1"/>
-          <p:nvPr/>
-        </p:nvSpPr>
-        <p:spPr>
-          <a:xfrm>
-            <a:off x="9079992" y="5428309"/>
+          <p:cNvPr id="207" name="Text 205"/>
+          <p:cNvSpPr txBox="1"/>
+          <p:nvPr/>
+        </p:nvSpPr>
+        <p:spPr>
+          <a:xfrm>
+            <a:off x="9125712" y="5428309"/>
             <a:ext cx="822960" cy="248502"/>
           </a:xfrm>
           <a:prstGeom prst="rect">
@@ -22963,13 +24250,13 @@
       </p:sp>
       <p:sp>
         <p:nvSpPr>
-          <p:cNvPr id="175" name="Text 173"/>
-          <p:cNvSpPr txBox="1"/>
-          <p:nvPr/>
-        </p:nvSpPr>
-        <p:spPr>
-          <a:xfrm>
-            <a:off x="9902952" y="5428309"/>
+          <p:cNvPr id="208" name="Text 206"/>
+          <p:cNvSpPr txBox="1"/>
+          <p:nvPr/>
+        </p:nvSpPr>
+        <p:spPr>
+          <a:xfrm>
+            <a:off x="9948672" y="5428309"/>
             <a:ext cx="786384" cy="248502"/>
           </a:xfrm>
           <a:prstGeom prst="rect">
@@ -23002,13 +24289,13 @@
       </p:sp>
       <p:sp>
         <p:nvSpPr>
-          <p:cNvPr id="176" name="Text 174"/>
-          <p:cNvSpPr txBox="1"/>
-          <p:nvPr/>
-        </p:nvSpPr>
-        <p:spPr>
-          <a:xfrm>
-            <a:off x="10689336" y="5428309"/>
+          <p:cNvPr id="209" name="Text 207"/>
+          <p:cNvSpPr txBox="1"/>
+          <p:nvPr/>
+        </p:nvSpPr>
+        <p:spPr>
+          <a:xfrm>
+            <a:off x="10735056" y="5428309"/>
             <a:ext cx="731520" cy="248502"/>
           </a:xfrm>
           <a:prstGeom prst="rect">
@@ -23041,7 +24328,27 @@
       </p:sp>
       <p:sp>
         <p:nvSpPr>
-          <p:cNvPr id="177" name="Shape 175"/>
+          <p:cNvPr id="210" name="Shape 208"/>
+          <p:cNvSpPr/>
+          <p:nvPr/>
+        </p:nvSpPr>
+        <p:spPr>
+          <a:xfrm>
+            <a:off x="6085332" y="1700784"/>
+            <a:ext cx="10973" cy="4224528"/>
+          </a:xfrm>
+          <a:prstGeom prst="rect">
+            <a:avLst/>
+          </a:prstGeom>
+          <a:solidFill>
+            <a:srgbClr val="D9D9D9"/>
+          </a:solidFill>
+          <a:ln/>
+        </p:spPr>
+      </p:sp>
+      <p:sp>
+        <p:nvSpPr>
+          <p:cNvPr id="211" name="Shape 209"/>
           <p:cNvSpPr/>
           <p:nvPr/>
         </p:nvSpPr>
@@ -23061,7 +24368,7 @@
       </p:sp>
       <p:sp>
         <p:nvSpPr>
-          <p:cNvPr id="178" name="Text 176"/>
+          <p:cNvPr id="212" name="Text 210"/>
           <p:cNvSpPr txBox="1"/>
           <p:nvPr/>
         </p:nvSpPr>

</xml_diff>

<commit_message>
Day 2 deck: dollar-first gross change rankers with % marks, movers both-list bar, variance-from-benchmark titles, Why We Are Here draft; Best Techs to Open Decisions, How We Measured It back in flow
Co-Authored-By: Claude Opus 5.5 <noreply@anthropic.com>
Claude-Session: https://claude.ai/code/session_01Xa4nFVxuQGXmHARGph9WhS
</commit_message>
<xml_diff>
--- a/day2-deck/decks/CP Hours & RO a Day - Review.pptx
+++ b/day2-deck/decks/CP Hours & RO a Day - Review.pptx
@@ -2639,7 +2639,7 @@
           <a:p>
             <a:r>
               <a:rPr lang="en-US" dirty="0"/>
-              <a:t>Source: Qlik - Closed Repair Orders. Customer pay, Jan-Sep by close date. Same-store, INEOS excluded (opened 2026). GMC Prescott body shop labor types excluded. Total customer-pay labor hours sold, all CP ROs. Top and bottom five stores by change in customer-pay hours sold (percent, so store size does not drive the ranking), Jan-Sep 2026 vs 2025. Moving now: Jul-Sep 2026 vs Jan-Mar 2026, each store against itself (monthly averages); the group moved +5.5% on the same basis, so part of every store's change is seasonal.Conversation starter: each top store says one thing they started doing; each bottom store says what got in the way and what they would try. The room trades ideas. Moving now: ask the top three what they started this year.</a:t>
+              <a:t>Source: Qlik - Closed Repair Orders. Customer pay, Jan-Sep by close date. Same-store, INEOS excluded (opened 2026). GMC Prescott body shop labor types excluded. Total customer-pay labor hours sold, all CP ROs. Top and bottom five stores by change in customer-pay hours sold (percent, so store size does not drive the ranking), Jan-Sep 2026 vs 2025. Moving now: Jul-Sep 2026 vs Jan-Mar 2026, each store against itself (monthly averages); the group moved +5.5% on the same basis, so part of every store's change is seasonal. Green bar at the right of a row: the store is on both the top five vs last year and the top five moving now.Conversation starter: each top store says one thing they started doing; each bottom store says what got in the way and what they would try. The room trades ideas. Moving now: ask the top three what they started this year.</a:t>
             </a:r>
             <a:endParaRPr lang="en-US" dirty="0"/>
           </a:p>
@@ -9292,7 +9292,7 @@
               <a:buNone/>
             </a:pPr>
             <a:r>
-              <a:rPr lang="en-US" sz="1200" dirty="0">
+              <a:rPr lang="en-US" sz="1200" b="1" dirty="0">
                 <a:solidFill>
                   <a:srgbClr val="0B7A4A"/>
                 </a:solidFill>
@@ -9429,7 +9429,7 @@
               <a:buNone/>
             </a:pPr>
             <a:r>
-              <a:rPr lang="en-US" sz="1200" dirty="0">
+              <a:rPr lang="en-US" sz="1200" b="1" dirty="0">
                 <a:solidFill>
                   <a:srgbClr val="0B7A4A"/>
                 </a:solidFill>
@@ -9566,7 +9566,7 @@
               <a:buNone/>
             </a:pPr>
             <a:r>
-              <a:rPr lang="en-US" sz="1200" dirty="0">
+              <a:rPr lang="en-US" sz="1200" b="1" dirty="0">
                 <a:solidFill>
                   <a:srgbClr val="0B7A4A"/>
                 </a:solidFill>
@@ -9703,7 +9703,7 @@
               <a:buNone/>
             </a:pPr>
             <a:r>
-              <a:rPr lang="en-US" sz="1200" dirty="0">
+              <a:rPr lang="en-US" sz="1200" b="1" dirty="0">
                 <a:solidFill>
                   <a:srgbClr val="0B7A4A"/>
                 </a:solidFill>
@@ -9840,7 +9840,7 @@
               <a:buNone/>
             </a:pPr>
             <a:r>
-              <a:rPr lang="en-US" sz="1200" dirty="0">
+              <a:rPr lang="en-US" sz="1200" b="1" dirty="0">
                 <a:solidFill>
                   <a:srgbClr val="0B7A4A"/>
                 </a:solidFill>
@@ -9977,7 +9977,7 @@
               <a:buNone/>
             </a:pPr>
             <a:r>
-              <a:rPr lang="en-US" sz="1200" dirty="0">
+              <a:rPr lang="en-US" sz="1200" b="1" dirty="0">
                 <a:solidFill>
                   <a:srgbClr val="0B7A4A"/>
                 </a:solidFill>
@@ -10114,7 +10114,7 @@
               <a:buNone/>
             </a:pPr>
             <a:r>
-              <a:rPr lang="en-US" sz="1200" dirty="0">
+              <a:rPr lang="en-US" sz="1200" b="1" dirty="0">
                 <a:solidFill>
                   <a:srgbClr val="0B7A4A"/>
                 </a:solidFill>
@@ -10251,7 +10251,7 @@
               <a:buNone/>
             </a:pPr>
             <a:r>
-              <a:rPr lang="en-US" sz="1200" dirty="0">
+              <a:rPr lang="en-US" sz="1200" b="1" dirty="0">
                 <a:solidFill>
                   <a:srgbClr val="0B7A4A"/>
                 </a:solidFill>
@@ -10388,7 +10388,7 @@
               <a:buNone/>
             </a:pPr>
             <a:r>
-              <a:rPr lang="en-US" sz="1200" dirty="0">
+              <a:rPr lang="en-US" sz="1200" b="1" dirty="0">
                 <a:solidFill>
                   <a:srgbClr val="0B7A4A"/>
                 </a:solidFill>
@@ -10525,7 +10525,7 @@
               <a:buNone/>
             </a:pPr>
             <a:r>
-              <a:rPr lang="en-US" sz="1200" dirty="0">
+              <a:rPr lang="en-US" sz="1200" b="1" dirty="0">
                 <a:solidFill>
                   <a:srgbClr val="0B7A4A"/>
                 </a:solidFill>
@@ -10662,7 +10662,7 @@
               <a:buNone/>
             </a:pPr>
             <a:r>
-              <a:rPr lang="en-US" sz="1200" dirty="0">
+              <a:rPr lang="en-US" sz="1200" b="1" dirty="0">
                 <a:solidFill>
                   <a:srgbClr val="0B7A4A"/>
                 </a:solidFill>
@@ -10799,7 +10799,7 @@
               <a:buNone/>
             </a:pPr>
             <a:r>
-              <a:rPr lang="en-US" sz="1200" dirty="0">
+              <a:rPr lang="en-US" sz="1200" b="1" dirty="0">
                 <a:solidFill>
                   <a:srgbClr val="0B7A4A"/>
                 </a:solidFill>
@@ -10936,7 +10936,7 @@
               <a:buNone/>
             </a:pPr>
             <a:r>
-              <a:rPr lang="en-US" sz="1200" dirty="0">
+              <a:rPr lang="en-US" sz="1200" b="1" dirty="0">
                 <a:solidFill>
                   <a:srgbClr val="0B7A4A"/>
                 </a:solidFill>
@@ -11073,7 +11073,7 @@
               <a:buNone/>
             </a:pPr>
             <a:r>
-              <a:rPr lang="en-US" sz="1200" dirty="0">
+              <a:rPr lang="en-US" sz="1200" b="1" dirty="0">
                 <a:solidFill>
                   <a:srgbClr val="0B7A4A"/>
                 </a:solidFill>
@@ -11210,7 +11210,7 @@
               <a:buNone/>
             </a:pPr>
             <a:r>
-              <a:rPr lang="en-US" sz="1200" dirty="0">
+              <a:rPr lang="en-US" sz="1200" b="1" dirty="0">
                 <a:solidFill>
                   <a:srgbClr val="0B7A4A"/>
                 </a:solidFill>
@@ -11347,7 +11347,7 @@
               <a:buNone/>
             </a:pPr>
             <a:r>
-              <a:rPr lang="en-US" sz="1200" dirty="0">
+              <a:rPr lang="en-US" sz="1200" b="1" dirty="0">
                 <a:solidFill>
                   <a:srgbClr val="0B7A4A"/>
                 </a:solidFill>
@@ -11484,7 +11484,7 @@
               <a:buNone/>
             </a:pPr>
             <a:r>
-              <a:rPr lang="en-US" sz="1200" dirty="0">
+              <a:rPr lang="en-US" sz="1200" b="1" dirty="0">
                 <a:solidFill>
                   <a:srgbClr val="0B7A4A"/>
                 </a:solidFill>
@@ -11621,7 +11621,7 @@
               <a:buNone/>
             </a:pPr>
             <a:r>
-              <a:rPr lang="en-US" sz="1200" dirty="0">
+              <a:rPr lang="en-US" sz="1200" b="1" dirty="0">
                 <a:solidFill>
                   <a:srgbClr val="0B7A4A"/>
                 </a:solidFill>
@@ -11758,7 +11758,7 @@
               <a:buNone/>
             </a:pPr>
             <a:r>
-              <a:rPr lang="en-US" sz="1200" dirty="0">
+              <a:rPr lang="en-US" sz="1200" b="1" dirty="0">
                 <a:solidFill>
                   <a:srgbClr val="0B7A4A"/>
                 </a:solidFill>
@@ -11895,7 +11895,7 @@
               <a:buNone/>
             </a:pPr>
             <a:r>
-              <a:rPr lang="en-US" sz="1200" dirty="0">
+              <a:rPr lang="en-US" sz="1200" b="1" dirty="0">
                 <a:solidFill>
                   <a:srgbClr val="0B7A4A"/>
                 </a:solidFill>
@@ -12032,7 +12032,7 @@
               <a:buNone/>
             </a:pPr>
             <a:r>
-              <a:rPr lang="en-US" sz="1200" dirty="0">
+              <a:rPr lang="en-US" sz="1200" b="1" dirty="0">
                 <a:solidFill>
                   <a:srgbClr val="0B7A4A"/>
                 </a:solidFill>
@@ -12169,7 +12169,7 @@
               <a:buNone/>
             </a:pPr>
             <a:r>
-              <a:rPr lang="en-US" sz="1200" dirty="0">
+              <a:rPr lang="en-US" sz="1200" b="1" dirty="0">
                 <a:solidFill>
                   <a:srgbClr val="0B7A4A"/>
                 </a:solidFill>
@@ -12306,7 +12306,7 @@
               <a:buNone/>
             </a:pPr>
             <a:r>
-              <a:rPr lang="en-US" sz="1200" dirty="0">
+              <a:rPr lang="en-US" sz="1200" b="1" dirty="0">
                 <a:solidFill>
                   <a:srgbClr val="0B7A4A"/>
                 </a:solidFill>
@@ -12443,7 +12443,7 @@
               <a:buNone/>
             </a:pPr>
             <a:r>
-              <a:rPr lang="en-US" sz="1200" dirty="0">
+              <a:rPr lang="en-US" sz="1200" b="1" dirty="0">
                 <a:solidFill>
                   <a:srgbClr val="A82B26"/>
                 </a:solidFill>
@@ -12580,7 +12580,7 @@
               <a:buNone/>
             </a:pPr>
             <a:r>
-              <a:rPr lang="en-US" sz="1200" dirty="0">
+              <a:rPr lang="en-US" sz="1200" b="1" dirty="0">
                 <a:solidFill>
                   <a:srgbClr val="A82B26"/>
                 </a:solidFill>
@@ -12717,7 +12717,7 @@
               <a:buNone/>
             </a:pPr>
             <a:r>
-              <a:rPr lang="en-US" sz="1200" dirty="0">
+              <a:rPr lang="en-US" sz="1200" b="1" dirty="0">
                 <a:solidFill>
                   <a:srgbClr val="A82B26"/>
                 </a:solidFill>
@@ -12854,7 +12854,7 @@
               <a:buNone/>
             </a:pPr>
             <a:r>
-              <a:rPr lang="en-US" sz="1200" dirty="0">
+              <a:rPr lang="en-US" sz="1200" b="1" dirty="0">
                 <a:solidFill>
                   <a:srgbClr val="A82B26"/>
                 </a:solidFill>
@@ -12991,7 +12991,7 @@
               <a:buNone/>
             </a:pPr>
             <a:r>
-              <a:rPr lang="en-US" sz="1200" dirty="0">
+              <a:rPr lang="en-US" sz="1200" b="1" dirty="0">
                 <a:solidFill>
                   <a:srgbClr val="A82B26"/>
                 </a:solidFill>
@@ -13128,7 +13128,7 @@
               <a:buNone/>
             </a:pPr>
             <a:r>
-              <a:rPr lang="en-US" sz="1200" dirty="0">
+              <a:rPr lang="en-US" sz="1200" b="1" dirty="0">
                 <a:solidFill>
                   <a:srgbClr val="A82B26"/>
                 </a:solidFill>
@@ -13265,7 +13265,7 @@
               <a:buNone/>
             </a:pPr>
             <a:r>
-              <a:rPr lang="en-US" sz="1200" dirty="0">
+              <a:rPr lang="en-US" sz="1200" b="1" dirty="0">
                 <a:solidFill>
                   <a:srgbClr val="A82B26"/>
                 </a:solidFill>
@@ -13402,7 +13402,7 @@
               <a:buNone/>
             </a:pPr>
             <a:r>
-              <a:rPr lang="en-US" sz="1200" dirty="0">
+              <a:rPr lang="en-US" sz="1200" b="1" dirty="0">
                 <a:solidFill>
                   <a:srgbClr val="A82B26"/>
                 </a:solidFill>
@@ -13539,7 +13539,7 @@
               <a:buNone/>
             </a:pPr>
             <a:r>
-              <a:rPr lang="en-US" sz="1200" dirty="0">
+              <a:rPr lang="en-US" sz="1200" b="1" dirty="0">
                 <a:solidFill>
                   <a:srgbClr val="A82B26"/>
                 </a:solidFill>
@@ -13676,7 +13676,7 @@
               <a:buNone/>
             </a:pPr>
             <a:r>
-              <a:rPr lang="en-US" sz="1200" dirty="0">
+              <a:rPr lang="en-US" sz="1200" b="1" dirty="0">
                 <a:solidFill>
                   <a:srgbClr val="A82B26"/>
                 </a:solidFill>
@@ -14413,7 +14413,27 @@
       </p:sp>
       <p:sp>
         <p:nvSpPr>
-          <p:cNvPr id="17" name="Text 15"/>
+          <p:cNvPr id="17" name="Shape 15"/>
+          <p:cNvSpPr/>
+          <p:nvPr/>
+        </p:nvSpPr>
+        <p:spPr>
+          <a:xfrm>
+            <a:off x="4084320" y="3650285"/>
+            <a:ext cx="64008" cy="682142"/>
+          </a:xfrm>
+          <a:prstGeom prst="rect">
+            <a:avLst/>
+          </a:prstGeom>
+          <a:solidFill>
+            <a:srgbClr val="12A566"/>
+          </a:solidFill>
+          <a:ln/>
+        </p:spPr>
+      </p:sp>
+      <p:sp>
+        <p:nvSpPr>
+          <p:cNvPr id="18" name="Text 16"/>
           <p:cNvSpPr txBox="1"/>
           <p:nvPr/>
         </p:nvSpPr>
@@ -14452,7 +14472,7 @@
       </p:sp>
       <p:sp>
         <p:nvSpPr>
-          <p:cNvPr id="18" name="Text 16"/>
+          <p:cNvPr id="19" name="Text 17"/>
           <p:cNvSpPr txBox="1"/>
           <p:nvPr/>
         </p:nvSpPr>
@@ -14531,7 +14551,7 @@
       </p:sp>
       <p:sp>
         <p:nvSpPr>
-          <p:cNvPr id="19" name="Text 17"/>
+          <p:cNvPr id="20" name="Text 18"/>
           <p:cNvSpPr txBox="1"/>
           <p:nvPr/>
         </p:nvSpPr>
@@ -14570,7 +14590,7 @@
       </p:sp>
       <p:sp>
         <p:nvSpPr>
-          <p:cNvPr id="20" name="Text 18"/>
+          <p:cNvPr id="21" name="Text 19"/>
           <p:cNvSpPr txBox="1"/>
           <p:nvPr/>
         </p:nvSpPr>
@@ -14609,7 +14629,7 @@
       </p:sp>
       <p:sp>
         <p:nvSpPr>
-          <p:cNvPr id="21" name="Text 19"/>
+          <p:cNvPr id="22" name="Text 20"/>
           <p:cNvSpPr txBox="1"/>
           <p:nvPr/>
         </p:nvSpPr>
@@ -14688,7 +14708,7 @@
       </p:sp>
       <p:sp>
         <p:nvSpPr>
-          <p:cNvPr id="22" name="Text 20"/>
+          <p:cNvPr id="23" name="Text 21"/>
           <p:cNvSpPr txBox="1"/>
           <p:nvPr/>
         </p:nvSpPr>
@@ -14727,7 +14747,7 @@
       </p:sp>
       <p:sp>
         <p:nvSpPr>
-          <p:cNvPr id="23" name="Shape 21"/>
+          <p:cNvPr id="24" name="Shape 22"/>
           <p:cNvSpPr/>
           <p:nvPr/>
         </p:nvSpPr>
@@ -14747,7 +14767,7 @@
       </p:sp>
       <p:sp>
         <p:nvSpPr>
-          <p:cNvPr id="24" name="Text 22"/>
+          <p:cNvPr id="25" name="Text 23"/>
           <p:cNvSpPr txBox="1"/>
           <p:nvPr/>
         </p:nvSpPr>
@@ -14786,7 +14806,7 @@
       </p:sp>
       <p:sp>
         <p:nvSpPr>
-          <p:cNvPr id="25" name="Text 23"/>
+          <p:cNvPr id="26" name="Text 24"/>
           <p:cNvSpPr txBox="1"/>
           <p:nvPr/>
         </p:nvSpPr>
@@ -14865,7 +14885,7 @@
       </p:sp>
       <p:sp>
         <p:nvSpPr>
-          <p:cNvPr id="26" name="Text 24"/>
+          <p:cNvPr id="27" name="Text 25"/>
           <p:cNvSpPr txBox="1"/>
           <p:nvPr/>
         </p:nvSpPr>
@@ -14904,7 +14924,7 @@
       </p:sp>
       <p:sp>
         <p:nvSpPr>
-          <p:cNvPr id="27" name="Shape 25"/>
+          <p:cNvPr id="28" name="Shape 26"/>
           <p:cNvSpPr/>
           <p:nvPr/>
         </p:nvSpPr>
@@ -14924,7 +14944,7 @@
       </p:sp>
       <p:sp>
         <p:nvSpPr>
-          <p:cNvPr id="28" name="Text 26"/>
+          <p:cNvPr id="29" name="Text 27"/>
           <p:cNvSpPr txBox="1"/>
           <p:nvPr/>
         </p:nvSpPr>
@@ -14963,7 +14983,7 @@
       </p:sp>
       <p:sp>
         <p:nvSpPr>
-          <p:cNvPr id="29" name="Text 27"/>
+          <p:cNvPr id="30" name="Text 28"/>
           <p:cNvSpPr txBox="1"/>
           <p:nvPr/>
         </p:nvSpPr>
@@ -15002,7 +15022,7 @@
       </p:sp>
       <p:sp>
         <p:nvSpPr>
-          <p:cNvPr id="30" name="Shape 28"/>
+          <p:cNvPr id="31" name="Shape 29"/>
           <p:cNvSpPr/>
           <p:nvPr/>
         </p:nvSpPr>
@@ -15022,7 +15042,7 @@
       </p:sp>
       <p:sp>
         <p:nvSpPr>
-          <p:cNvPr id="31" name="Text 29"/>
+          <p:cNvPr id="32" name="Text 30"/>
           <p:cNvSpPr txBox="1"/>
           <p:nvPr/>
         </p:nvSpPr>
@@ -15061,7 +15081,7 @@
       </p:sp>
       <p:sp>
         <p:nvSpPr>
-          <p:cNvPr id="32" name="Text 30"/>
+          <p:cNvPr id="33" name="Text 31"/>
           <p:cNvSpPr txBox="1"/>
           <p:nvPr/>
         </p:nvSpPr>
@@ -15140,7 +15160,7 @@
       </p:sp>
       <p:sp>
         <p:nvSpPr>
-          <p:cNvPr id="33" name="Text 31"/>
+          <p:cNvPr id="34" name="Text 32"/>
           <p:cNvSpPr txBox="1"/>
           <p:nvPr/>
         </p:nvSpPr>
@@ -15179,7 +15199,7 @@
       </p:sp>
       <p:sp>
         <p:nvSpPr>
-          <p:cNvPr id="34" name="Text 32"/>
+          <p:cNvPr id="35" name="Text 33"/>
           <p:cNvSpPr txBox="1"/>
           <p:nvPr/>
         </p:nvSpPr>
@@ -15218,7 +15238,7 @@
       </p:sp>
       <p:sp>
         <p:nvSpPr>
-          <p:cNvPr id="35" name="Text 33"/>
+          <p:cNvPr id="36" name="Text 34"/>
           <p:cNvSpPr txBox="1"/>
           <p:nvPr/>
         </p:nvSpPr>
@@ -15297,7 +15317,7 @@
       </p:sp>
       <p:sp>
         <p:nvSpPr>
-          <p:cNvPr id="36" name="Text 34"/>
+          <p:cNvPr id="37" name="Text 35"/>
           <p:cNvSpPr txBox="1"/>
           <p:nvPr/>
         </p:nvSpPr>
@@ -15336,7 +15356,7 @@
       </p:sp>
       <p:sp>
         <p:nvSpPr>
-          <p:cNvPr id="37" name="Shape 35"/>
+          <p:cNvPr id="38" name="Shape 36"/>
           <p:cNvSpPr/>
           <p:nvPr/>
         </p:nvSpPr>
@@ -15356,7 +15376,7 @@
       </p:sp>
       <p:sp>
         <p:nvSpPr>
-          <p:cNvPr id="38" name="Text 36"/>
+          <p:cNvPr id="39" name="Text 37"/>
           <p:cNvSpPr txBox="1"/>
           <p:nvPr/>
         </p:nvSpPr>
@@ -15395,7 +15415,7 @@
       </p:sp>
       <p:sp>
         <p:nvSpPr>
-          <p:cNvPr id="39" name="Text 37"/>
+          <p:cNvPr id="40" name="Text 38"/>
           <p:cNvSpPr txBox="1"/>
           <p:nvPr/>
         </p:nvSpPr>
@@ -15474,7 +15494,7 @@
       </p:sp>
       <p:sp>
         <p:nvSpPr>
-          <p:cNvPr id="40" name="Text 38"/>
+          <p:cNvPr id="41" name="Text 39"/>
           <p:cNvSpPr txBox="1"/>
           <p:nvPr/>
         </p:nvSpPr>
@@ -15513,7 +15533,7 @@
       </p:sp>
       <p:sp>
         <p:nvSpPr>
-          <p:cNvPr id="41" name="Text 39"/>
+          <p:cNvPr id="42" name="Text 40"/>
           <p:cNvSpPr txBox="1"/>
           <p:nvPr/>
         </p:nvSpPr>
@@ -15552,7 +15572,7 @@
       </p:sp>
       <p:sp>
         <p:nvSpPr>
-          <p:cNvPr id="42" name="Text 40"/>
+          <p:cNvPr id="43" name="Text 41"/>
           <p:cNvSpPr txBox="1"/>
           <p:nvPr/>
         </p:nvSpPr>
@@ -15631,7 +15651,7 @@
       </p:sp>
       <p:sp>
         <p:nvSpPr>
-          <p:cNvPr id="43" name="Text 41"/>
+          <p:cNvPr id="44" name="Text 42"/>
           <p:cNvSpPr txBox="1"/>
           <p:nvPr/>
         </p:nvSpPr>
@@ -15670,7 +15690,7 @@
       </p:sp>
       <p:sp>
         <p:nvSpPr>
-          <p:cNvPr id="44" name="Shape 42"/>
+          <p:cNvPr id="45" name="Shape 43"/>
           <p:cNvSpPr/>
           <p:nvPr/>
         </p:nvSpPr>
@@ -15690,7 +15710,7 @@
       </p:sp>
       <p:sp>
         <p:nvSpPr>
-          <p:cNvPr id="45" name="Text 43"/>
+          <p:cNvPr id="46" name="Text 44"/>
           <p:cNvSpPr txBox="1"/>
           <p:nvPr/>
         </p:nvSpPr>
@@ -15729,7 +15749,7 @@
       </p:sp>
       <p:sp>
         <p:nvSpPr>
-          <p:cNvPr id="46" name="Text 44"/>
+          <p:cNvPr id="47" name="Text 45"/>
           <p:cNvSpPr txBox="1"/>
           <p:nvPr/>
         </p:nvSpPr>
@@ -15808,7 +15828,7 @@
       </p:sp>
       <p:sp>
         <p:nvSpPr>
-          <p:cNvPr id="47" name="Text 45"/>
+          <p:cNvPr id="48" name="Text 46"/>
           <p:cNvSpPr txBox="1"/>
           <p:nvPr/>
         </p:nvSpPr>
@@ -15847,7 +15867,7 @@
       </p:sp>
       <p:sp>
         <p:nvSpPr>
-          <p:cNvPr id="48" name="Shape 46"/>
+          <p:cNvPr id="49" name="Shape 47"/>
           <p:cNvSpPr/>
           <p:nvPr/>
         </p:nvSpPr>
@@ -15867,7 +15887,7 @@
       </p:sp>
       <p:sp>
         <p:nvSpPr>
-          <p:cNvPr id="49" name="Text 47"/>
+          <p:cNvPr id="50" name="Text 48"/>
           <p:cNvSpPr txBox="1"/>
           <p:nvPr/>
         </p:nvSpPr>
@@ -15906,7 +15926,7 @@
       </p:sp>
       <p:sp>
         <p:nvSpPr>
-          <p:cNvPr id="50" name="Text 48"/>
+          <p:cNvPr id="51" name="Text 49"/>
           <p:cNvSpPr txBox="1"/>
           <p:nvPr/>
         </p:nvSpPr>
@@ -15945,7 +15965,7 @@
       </p:sp>
       <p:sp>
         <p:nvSpPr>
-          <p:cNvPr id="51" name="Shape 49"/>
+          <p:cNvPr id="52" name="Shape 50"/>
           <p:cNvSpPr/>
           <p:nvPr/>
         </p:nvSpPr>
@@ -15965,7 +15985,7 @@
       </p:sp>
       <p:sp>
         <p:nvSpPr>
-          <p:cNvPr id="52" name="Text 50"/>
+          <p:cNvPr id="53" name="Text 51"/>
           <p:cNvSpPr txBox="1"/>
           <p:nvPr/>
         </p:nvSpPr>
@@ -16004,7 +16024,7 @@
       </p:sp>
       <p:sp>
         <p:nvSpPr>
-          <p:cNvPr id="53" name="Text 51"/>
+          <p:cNvPr id="54" name="Text 52"/>
           <p:cNvSpPr txBox="1"/>
           <p:nvPr/>
         </p:nvSpPr>
@@ -16083,7 +16103,7 @@
       </p:sp>
       <p:sp>
         <p:nvSpPr>
-          <p:cNvPr id="54" name="Text 52"/>
+          <p:cNvPr id="55" name="Text 53"/>
           <p:cNvSpPr txBox="1"/>
           <p:nvPr/>
         </p:nvSpPr>
@@ -16122,7 +16142,7 @@
       </p:sp>
       <p:sp>
         <p:nvSpPr>
-          <p:cNvPr id="55" name="Text 53"/>
+          <p:cNvPr id="56" name="Text 54"/>
           <p:cNvSpPr txBox="1"/>
           <p:nvPr/>
         </p:nvSpPr>
@@ -16161,7 +16181,7 @@
       </p:sp>
       <p:sp>
         <p:nvSpPr>
-          <p:cNvPr id="56" name="Text 54"/>
+          <p:cNvPr id="57" name="Text 55"/>
           <p:cNvSpPr txBox="1"/>
           <p:nvPr/>
         </p:nvSpPr>
@@ -16240,7 +16260,7 @@
       </p:sp>
       <p:sp>
         <p:nvSpPr>
-          <p:cNvPr id="57" name="Text 55"/>
+          <p:cNvPr id="58" name="Text 56"/>
           <p:cNvSpPr txBox="1"/>
           <p:nvPr/>
         </p:nvSpPr>
@@ -16279,7 +16299,7 @@
       </p:sp>
       <p:sp>
         <p:nvSpPr>
-          <p:cNvPr id="58" name="Shape 56"/>
+          <p:cNvPr id="59" name="Shape 57"/>
           <p:cNvSpPr/>
           <p:nvPr/>
         </p:nvSpPr>
@@ -16299,7 +16319,7 @@
       </p:sp>
       <p:sp>
         <p:nvSpPr>
-          <p:cNvPr id="59" name="Text 57"/>
+          <p:cNvPr id="60" name="Text 58"/>
           <p:cNvSpPr txBox="1"/>
           <p:nvPr/>
         </p:nvSpPr>
@@ -16338,7 +16358,7 @@
       </p:sp>
       <p:sp>
         <p:nvSpPr>
-          <p:cNvPr id="60" name="Text 58"/>
+          <p:cNvPr id="61" name="Text 59"/>
           <p:cNvSpPr txBox="1"/>
           <p:nvPr/>
         </p:nvSpPr>
@@ -16417,7 +16437,7 @@
       </p:sp>
       <p:sp>
         <p:nvSpPr>
-          <p:cNvPr id="61" name="Text 59"/>
+          <p:cNvPr id="62" name="Text 60"/>
           <p:cNvSpPr txBox="1"/>
           <p:nvPr/>
         </p:nvSpPr>
@@ -16456,7 +16476,7 @@
       </p:sp>
       <p:sp>
         <p:nvSpPr>
-          <p:cNvPr id="62" name="Text 60"/>
+          <p:cNvPr id="63" name="Text 61"/>
           <p:cNvSpPr txBox="1"/>
           <p:nvPr/>
         </p:nvSpPr>
@@ -16495,7 +16515,7 @@
       </p:sp>
       <p:sp>
         <p:nvSpPr>
-          <p:cNvPr id="63" name="Text 61"/>
+          <p:cNvPr id="64" name="Text 62"/>
           <p:cNvSpPr txBox="1"/>
           <p:nvPr/>
         </p:nvSpPr>
@@ -16574,7 +16594,7 @@
       </p:sp>
       <p:sp>
         <p:nvSpPr>
-          <p:cNvPr id="64" name="Text 62"/>
+          <p:cNvPr id="65" name="Text 63"/>
           <p:cNvSpPr txBox="1"/>
           <p:nvPr/>
         </p:nvSpPr>
@@ -16613,7 +16633,7 @@
       </p:sp>
       <p:sp>
         <p:nvSpPr>
-          <p:cNvPr id="65" name="Shape 63"/>
+          <p:cNvPr id="66" name="Shape 64"/>
           <p:cNvSpPr/>
           <p:nvPr/>
         </p:nvSpPr>
@@ -16633,7 +16653,27 @@
       </p:sp>
       <p:sp>
         <p:nvSpPr>
-          <p:cNvPr id="66" name="Text 64"/>
+          <p:cNvPr id="67" name="Shape 65"/>
+          <p:cNvSpPr/>
+          <p:nvPr/>
+        </p:nvSpPr>
+        <p:spPr>
+          <a:xfrm>
+            <a:off x="11466576" y="5160874"/>
+            <a:ext cx="64008" cy="682142"/>
+          </a:xfrm>
+          <a:prstGeom prst="rect">
+            <a:avLst/>
+          </a:prstGeom>
+          <a:solidFill>
+            <a:srgbClr val="12A566"/>
+          </a:solidFill>
+          <a:ln/>
+        </p:spPr>
+      </p:sp>
+      <p:sp>
+        <p:nvSpPr>
+          <p:cNvPr id="68" name="Text 66"/>
           <p:cNvSpPr txBox="1"/>
           <p:nvPr/>
         </p:nvSpPr>
@@ -16672,7 +16712,7 @@
       </p:sp>
       <p:sp>
         <p:nvSpPr>
-          <p:cNvPr id="67" name="Text 65"/>
+          <p:cNvPr id="69" name="Text 67"/>
           <p:cNvSpPr txBox="1"/>
           <p:nvPr/>
         </p:nvSpPr>
@@ -16751,7 +16791,7 @@
       </p:sp>
       <p:sp>
         <p:nvSpPr>
-          <p:cNvPr id="68" name="Text 66"/>
+          <p:cNvPr id="70" name="Text 68"/>
           <p:cNvSpPr txBox="1"/>
           <p:nvPr/>
         </p:nvSpPr>
@@ -16790,7 +16830,7 @@
       </p:sp>
       <p:sp>
         <p:nvSpPr>
-          <p:cNvPr id="69" name="Shape 67"/>
+          <p:cNvPr id="71" name="Shape 69"/>
           <p:cNvSpPr/>
           <p:nvPr/>
         </p:nvSpPr>
@@ -16810,7 +16850,7 @@
       </p:sp>
       <p:sp>
         <p:nvSpPr>
-          <p:cNvPr id="70" name="Text 68"/>
+          <p:cNvPr id="72" name="Text 70"/>
           <p:cNvSpPr txBox="1"/>
           <p:nvPr/>
         </p:nvSpPr>

</xml_diff>

<commit_message>
Day 2 deck: Oct 25 round (records in opening, Pay Yourself First, internal vs own CP, warranty gross profit, combined warranty rates, wording updates)
Co-Authored-By: Claude Opus 5.5 <noreply@anthropic.com>
Claude-Session: https://claude.ai/code/session_01Xa4nFVxuQGXmHARGph9WhS
</commit_message>
<xml_diff>
--- a/day2-deck/decks/CP Hours & RO a Day - Review.pptx
+++ b/day2-deck/decks/CP Hours & RO a Day - Review.pptx
@@ -17335,7 +17335,7 @@
               <a:buNone/>
             </a:pPr>
             <a:r>
-              <a:rPr lang="en-US" sz="1300" dirty="0">
+              <a:rPr lang="en-US" sz="1200" dirty="0">
                 <a:solidFill>
                   <a:srgbClr val="1A1A1A"/>
                 </a:solidFill>
@@ -17345,7 +17345,7 @@
               </a:rPr>
               <a:t>LR HENDERSON</a:t>
             </a:r>
-            <a:endParaRPr lang="en-US" sz="1300" dirty="0"/>
+            <a:endParaRPr lang="en-US" sz="1200" dirty="0"/>
           </a:p>
         </p:txBody>
       </p:sp>
@@ -17550,7 +17550,7 @@
               <a:buNone/>
             </a:pPr>
             <a:r>
-              <a:rPr lang="en-US" sz="1300" dirty="0">
+              <a:rPr lang="en-US" sz="1200" dirty="0">
                 <a:solidFill>
                   <a:srgbClr val="1A1A1A"/>
                 </a:solidFill>
@@ -17560,7 +17560,7 @@
               </a:rPr>
               <a:t>LR LV</a:t>
             </a:r>
-            <a:endParaRPr lang="en-US" sz="1300" dirty="0"/>
+            <a:endParaRPr lang="en-US" sz="1200" dirty="0"/>
           </a:p>
         </p:txBody>
       </p:sp>
@@ -17765,7 +17765,7 @@
               <a:buNone/>
             </a:pPr>
             <a:r>
-              <a:rPr lang="en-US" sz="1300" dirty="0">
+              <a:rPr lang="en-US" sz="1200" dirty="0">
                 <a:solidFill>
                   <a:srgbClr val="1A1A1A"/>
                 </a:solidFill>
@@ -17775,7 +17775,7 @@
               </a:rPr>
               <a:t>LR RENO</a:t>
             </a:r>
-            <a:endParaRPr lang="en-US" sz="1300" dirty="0"/>
+            <a:endParaRPr lang="en-US" sz="1200" dirty="0"/>
           </a:p>
         </p:txBody>
       </p:sp>
@@ -17980,7 +17980,7 @@
               <a:buNone/>
             </a:pPr>
             <a:r>
-              <a:rPr lang="en-US" sz="1300" dirty="0">
+              <a:rPr lang="en-US" sz="1200" dirty="0">
                 <a:solidFill>
                   <a:srgbClr val="1A1A1A"/>
                 </a:solidFill>
@@ -17990,7 +17990,7 @@
               </a:rPr>
               <a:t>AUDI HENDERSON</a:t>
             </a:r>
-            <a:endParaRPr lang="en-US" sz="1300" dirty="0"/>
+            <a:endParaRPr lang="en-US" sz="1200" dirty="0"/>
           </a:p>
         </p:txBody>
       </p:sp>
@@ -18195,7 +18195,7 @@
               <a:buNone/>
             </a:pPr>
             <a:r>
-              <a:rPr lang="en-US" sz="1300" dirty="0">
+              <a:rPr lang="en-US" sz="1200" dirty="0">
                 <a:solidFill>
                   <a:srgbClr val="1A1A1A"/>
                 </a:solidFill>
@@ -18205,7 +18205,7 @@
               </a:rPr>
               <a:t>AUDI RENO</a:t>
             </a:r>
-            <a:endParaRPr lang="en-US" sz="1300" dirty="0"/>
+            <a:endParaRPr lang="en-US" sz="1200" dirty="0"/>
           </a:p>
         </p:txBody>
       </p:sp>
@@ -18410,7 +18410,7 @@
               <a:buNone/>
             </a:pPr>
             <a:r>
-              <a:rPr lang="en-US" sz="1300" dirty="0">
+              <a:rPr lang="en-US" sz="1200" dirty="0">
                 <a:solidFill>
                   <a:srgbClr val="1A1A1A"/>
                 </a:solidFill>
@@ -18420,7 +18420,7 @@
               </a:rPr>
               <a:t>VOLVO</a:t>
             </a:r>
-            <a:endParaRPr lang="en-US" sz="1300" dirty="0"/>
+            <a:endParaRPr lang="en-US" sz="1200" dirty="0"/>
           </a:p>
         </p:txBody>
       </p:sp>
@@ -18625,7 +18625,7 @@
               <a:buNone/>
             </a:pPr>
             <a:r>
-              <a:rPr lang="en-US" sz="1300" dirty="0">
+              <a:rPr lang="en-US" sz="1200" dirty="0">
                 <a:solidFill>
                   <a:srgbClr val="1A1A1A"/>
                 </a:solidFill>
@@ -18635,7 +18635,7 @@
               </a:rPr>
               <a:t>CADILLAC</a:t>
             </a:r>
-            <a:endParaRPr lang="en-US" sz="1300" dirty="0"/>
+            <a:endParaRPr lang="en-US" sz="1200" dirty="0"/>
           </a:p>
         </p:txBody>
       </p:sp>
@@ -18840,7 +18840,7 @@
               <a:buNone/>
             </a:pPr>
             <a:r>
-              <a:rPr lang="en-US" sz="1300" dirty="0">
+              <a:rPr lang="en-US" sz="1200" dirty="0">
                 <a:solidFill>
                   <a:srgbClr val="1A1A1A"/>
                 </a:solidFill>
@@ -18850,7 +18850,7 @@
               </a:rPr>
               <a:t>LINCOLN</a:t>
             </a:r>
-            <a:endParaRPr lang="en-US" sz="1300" dirty="0"/>
+            <a:endParaRPr lang="en-US" sz="1200" dirty="0"/>
           </a:p>
         </p:txBody>
       </p:sp>
@@ -19055,7 +19055,7 @@
               <a:buNone/>
             </a:pPr>
             <a:r>
-              <a:rPr lang="en-US" sz="1300" dirty="0">
+              <a:rPr lang="en-US" sz="1200" dirty="0">
                 <a:solidFill>
                   <a:srgbClr val="1A1A1A"/>
                 </a:solidFill>
@@ -19065,7 +19065,7 @@
               </a:rPr>
               <a:t>LEXUS</a:t>
             </a:r>
-            <a:endParaRPr lang="en-US" sz="1300" dirty="0"/>
+            <a:endParaRPr lang="en-US" sz="1200" dirty="0"/>
           </a:p>
         </p:txBody>
       </p:sp>
@@ -19270,7 +19270,7 @@
               <a:buNone/>
             </a:pPr>
             <a:r>
-              <a:rPr lang="en-US" sz="1300" dirty="0">
+              <a:rPr lang="en-US" sz="1200" dirty="0">
                 <a:solidFill>
                   <a:srgbClr val="1A1A1A"/>
                 </a:solidFill>
@@ -19280,7 +19280,7 @@
               </a:rPr>
               <a:t>VW HENDERSON</a:t>
             </a:r>
-            <a:endParaRPr lang="en-US" sz="1300" dirty="0"/>
+            <a:endParaRPr lang="en-US" sz="1200" dirty="0"/>
           </a:p>
         </p:txBody>
       </p:sp>
@@ -19485,7 +19485,7 @@
               <a:buNone/>
             </a:pPr>
             <a:r>
-              <a:rPr lang="en-US" sz="1300" dirty="0">
+              <a:rPr lang="en-US" sz="1200" dirty="0">
                 <a:solidFill>
                   <a:srgbClr val="1A1A1A"/>
                 </a:solidFill>
@@ -19495,7 +19495,7 @@
               </a:rPr>
               <a:t>NISSAN</a:t>
             </a:r>
-            <a:endParaRPr lang="en-US" sz="1300" dirty="0"/>
+            <a:endParaRPr lang="en-US" sz="1200" dirty="0"/>
           </a:p>
         </p:txBody>
       </p:sp>
@@ -19700,7 +19700,7 @@
               <a:buNone/>
             </a:pPr>
             <a:r>
-              <a:rPr lang="en-US" sz="1300" dirty="0">
+              <a:rPr lang="en-US" sz="1200" dirty="0">
                 <a:solidFill>
                   <a:srgbClr val="1A1A1A"/>
                 </a:solidFill>
@@ -19710,7 +19710,7 @@
               </a:rPr>
               <a:t>CDJR POST FALLS</a:t>
             </a:r>
-            <a:endParaRPr lang="en-US" sz="1300" dirty="0"/>
+            <a:endParaRPr lang="en-US" sz="1200" dirty="0"/>
           </a:p>
         </p:txBody>
       </p:sp>
@@ -19915,7 +19915,7 @@
               <a:buNone/>
             </a:pPr>
             <a:r>
-              <a:rPr lang="en-US" sz="1300" dirty="0">
+              <a:rPr lang="en-US" sz="1200" dirty="0">
                 <a:solidFill>
                   <a:srgbClr val="1A1A1A"/>
                 </a:solidFill>
@@ -19925,7 +19925,7 @@
               </a:rPr>
               <a:t>CHEVY LV</a:t>
             </a:r>
-            <a:endParaRPr lang="en-US" sz="1300" dirty="0"/>
+            <a:endParaRPr lang="en-US" sz="1200" dirty="0"/>
           </a:p>
         </p:txBody>
       </p:sp>
@@ -20130,7 +20130,7 @@
               <a:buNone/>
             </a:pPr>
             <a:r>
-              <a:rPr lang="en-US" sz="1300" dirty="0">
+              <a:rPr lang="en-US" sz="1200" dirty="0">
                 <a:solidFill>
                   <a:srgbClr val="1A1A1A"/>
                 </a:solidFill>
@@ -20140,7 +20140,7 @@
               </a:rPr>
               <a:t>SUBARU ST GEORGE</a:t>
             </a:r>
-            <a:endParaRPr lang="en-US" sz="1300" dirty="0"/>
+            <a:endParaRPr lang="en-US" sz="1200" dirty="0"/>
           </a:p>
         </p:txBody>
       </p:sp>
@@ -20345,7 +20345,7 @@
               <a:buNone/>
             </a:pPr>
             <a:r>
-              <a:rPr lang="en-US" sz="1300" dirty="0">
+              <a:rPr lang="en-US" sz="1200" dirty="0">
                 <a:solidFill>
                   <a:srgbClr val="1A1A1A"/>
                 </a:solidFill>
@@ -20355,7 +20355,7 @@
               </a:rPr>
               <a:t>ACURA</a:t>
             </a:r>
-            <a:endParaRPr lang="en-US" sz="1300" dirty="0"/>
+            <a:endParaRPr lang="en-US" sz="1200" dirty="0"/>
           </a:p>
         </p:txBody>
       </p:sp>
@@ -20560,7 +20560,7 @@
               <a:buNone/>
             </a:pPr>
             <a:r>
-              <a:rPr lang="en-US" sz="1300" dirty="0">
+              <a:rPr lang="en-US" sz="1200" dirty="0">
                 <a:solidFill>
                   <a:srgbClr val="1A1A1A"/>
                 </a:solidFill>
@@ -20570,7 +20570,7 @@
               </a:rPr>
               <a:t>SUBARU LV</a:t>
             </a:r>
-            <a:endParaRPr lang="en-US" sz="1300" dirty="0"/>
+            <a:endParaRPr lang="en-US" sz="1200" dirty="0"/>
           </a:p>
         </p:txBody>
       </p:sp>
@@ -20775,7 +20775,7 @@
               <a:buNone/>
             </a:pPr>
             <a:r>
-              <a:rPr lang="en-US" sz="1300" dirty="0">
+              <a:rPr lang="en-US" sz="1200" dirty="0">
                 <a:solidFill>
                   <a:srgbClr val="1A1A1A"/>
                 </a:solidFill>
@@ -20785,7 +20785,7 @@
               </a:rPr>
               <a:t>HONDA NORTH</a:t>
             </a:r>
-            <a:endParaRPr lang="en-US" sz="1300" dirty="0"/>
+            <a:endParaRPr lang="en-US" sz="1200" dirty="0"/>
           </a:p>
         </p:txBody>
       </p:sp>
@@ -20990,7 +20990,7 @@
               <a:buNone/>
             </a:pPr>
             <a:r>
-              <a:rPr lang="en-US" sz="1300" dirty="0">
+              <a:rPr lang="en-US" sz="1200" dirty="0">
                 <a:solidFill>
                   <a:srgbClr val="1A1A1A"/>
                 </a:solidFill>
@@ -21000,7 +21000,7 @@
               </a:rPr>
               <a:t>HONDA HENDERSON</a:t>
             </a:r>
-            <a:endParaRPr lang="en-US" sz="1300" dirty="0"/>
+            <a:endParaRPr lang="en-US" sz="1200" dirty="0"/>
           </a:p>
         </p:txBody>
       </p:sp>
@@ -21205,7 +21205,7 @@
               <a:buNone/>
             </a:pPr>
             <a:r>
-              <a:rPr lang="en-US" sz="1300" dirty="0">
+              <a:rPr lang="en-US" sz="1200" dirty="0">
                 <a:solidFill>
                   <a:srgbClr val="1A1A1A"/>
                 </a:solidFill>
@@ -21215,7 +21215,7 @@
               </a:rPr>
               <a:t>HONDA SPOKANE</a:t>
             </a:r>
-            <a:endParaRPr lang="en-US" sz="1300" dirty="0"/>
+            <a:endParaRPr lang="en-US" sz="1200" dirty="0"/>
           </a:p>
         </p:txBody>
       </p:sp>
@@ -21420,7 +21420,7 @@
               <a:buNone/>
             </a:pPr>
             <a:r>
-              <a:rPr lang="en-US" sz="1300" dirty="0">
+              <a:rPr lang="en-US" sz="1200" dirty="0">
                 <a:solidFill>
                   <a:srgbClr val="1A1A1A"/>
                 </a:solidFill>
@@ -21430,7 +21430,7 @@
               </a:rPr>
               <a:t>CHEVY GMC BULLHEAD</a:t>
             </a:r>
-            <a:endParaRPr lang="en-US" sz="1300" dirty="0"/>
+            <a:endParaRPr lang="en-US" sz="1200" dirty="0"/>
           </a:p>
         </p:txBody>
       </p:sp>
@@ -21635,7 +21635,7 @@
               <a:buNone/>
             </a:pPr>
             <a:r>
-              <a:rPr lang="en-US" sz="1300" dirty="0">
+              <a:rPr lang="en-US" sz="1200" dirty="0">
                 <a:solidFill>
                   <a:srgbClr val="1A1A1A"/>
                 </a:solidFill>
@@ -21645,7 +21645,7 @@
               </a:rPr>
               <a:t>GMC PRESCOTT</a:t>
             </a:r>
-            <a:endParaRPr lang="en-US" sz="1300" dirty="0"/>
+            <a:endParaRPr lang="en-US" sz="1200" dirty="0"/>
           </a:p>
         </p:txBody>
       </p:sp>
@@ -21850,7 +21850,7 @@
               <a:buNone/>
             </a:pPr>
             <a:r>
-              <a:rPr lang="en-US" sz="1300" dirty="0">
+              <a:rPr lang="en-US" sz="1200" dirty="0">
                 <a:solidFill>
                   <a:srgbClr val="1A1A1A"/>
                 </a:solidFill>
@@ -21860,7 +21860,7 @@
               </a:rPr>
               <a:t>HONDA FLAGSTAFF</a:t>
             </a:r>
-            <a:endParaRPr lang="en-US" sz="1300" dirty="0"/>
+            <a:endParaRPr lang="en-US" sz="1200" dirty="0"/>
           </a:p>
         </p:txBody>
       </p:sp>
@@ -22065,7 +22065,7 @@
               <a:buNone/>
             </a:pPr>
             <a:r>
-              <a:rPr lang="en-US" sz="1300" dirty="0">
+              <a:rPr lang="en-US" sz="1200" dirty="0">
                 <a:solidFill>
                   <a:srgbClr val="1A1A1A"/>
                 </a:solidFill>
@@ -22075,7 +22075,7 @@
               </a:rPr>
               <a:t>VW ST GEORGE</a:t>
             </a:r>
-            <a:endParaRPr lang="en-US" sz="1300" dirty="0"/>
+            <a:endParaRPr lang="en-US" sz="1200" dirty="0"/>
           </a:p>
         </p:txBody>
       </p:sp>
@@ -22280,7 +22280,7 @@
               <a:buNone/>
             </a:pPr>
             <a:r>
-              <a:rPr lang="en-US" sz="1300" dirty="0">
+              <a:rPr lang="en-US" sz="1200" dirty="0">
                 <a:solidFill>
                   <a:srgbClr val="1A1A1A"/>
                 </a:solidFill>
@@ -22290,7 +22290,7 @@
               </a:rPr>
               <a:t>HYUNDAI ST GEORGE</a:t>
             </a:r>
-            <a:endParaRPr lang="en-US" sz="1300" dirty="0"/>
+            <a:endParaRPr lang="en-US" sz="1200" dirty="0"/>
           </a:p>
         </p:txBody>
       </p:sp>
@@ -22495,7 +22495,7 @@
               <a:buNone/>
             </a:pPr>
             <a:r>
-              <a:rPr lang="en-US" sz="1300" dirty="0">
+              <a:rPr lang="en-US" sz="1200" dirty="0">
                 <a:solidFill>
                   <a:srgbClr val="1A1A1A"/>
                 </a:solidFill>
@@ -22505,7 +22505,7 @@
               </a:rPr>
               <a:t>MAZDA</a:t>
             </a:r>
-            <a:endParaRPr lang="en-US" sz="1300" dirty="0"/>
+            <a:endParaRPr lang="en-US" sz="1200" dirty="0"/>
           </a:p>
         </p:txBody>
       </p:sp>
@@ -22710,7 +22710,7 @@
               <a:buNone/>
             </a:pPr>
             <a:r>
-              <a:rPr lang="en-US" sz="1300" dirty="0">
+              <a:rPr lang="en-US" sz="1200" dirty="0">
                 <a:solidFill>
                   <a:srgbClr val="1A1A1A"/>
                 </a:solidFill>
@@ -22720,7 +22720,7 @@
               </a:rPr>
               <a:t>KIA LV</a:t>
             </a:r>
-            <a:endParaRPr lang="en-US" sz="1300" dirty="0"/>
+            <a:endParaRPr lang="en-US" sz="1200" dirty="0"/>
           </a:p>
         </p:txBody>
       </p:sp>
@@ -22925,7 +22925,7 @@
               <a:buNone/>
             </a:pPr>
             <a:r>
-              <a:rPr lang="en-US" sz="1300" dirty="0">
+              <a:rPr lang="en-US" sz="1200" dirty="0">
                 <a:solidFill>
                   <a:srgbClr val="1A1A1A"/>
                 </a:solidFill>
@@ -22935,7 +22935,7 @@
               </a:rPr>
               <a:t>TOYOTA HENDERSON</a:t>
             </a:r>
-            <a:endParaRPr lang="en-US" sz="1300" dirty="0"/>
+            <a:endParaRPr lang="en-US" sz="1200" dirty="0"/>
           </a:p>
         </p:txBody>
       </p:sp>
@@ -23140,7 +23140,7 @@
               <a:buNone/>
             </a:pPr>
             <a:r>
-              <a:rPr lang="en-US" sz="1300" dirty="0">
+              <a:rPr lang="en-US" sz="1200" dirty="0">
                 <a:solidFill>
                   <a:srgbClr val="1A1A1A"/>
                 </a:solidFill>
@@ -23150,7 +23150,7 @@
               </a:rPr>
               <a:t>HYUNDAI PRESCOTT</a:t>
             </a:r>
-            <a:endParaRPr lang="en-US" sz="1300" dirty="0"/>
+            <a:endParaRPr lang="en-US" sz="1200" dirty="0"/>
           </a:p>
         </p:txBody>
       </p:sp>
@@ -23355,7 +23355,7 @@
               <a:buNone/>
             </a:pPr>
             <a:r>
-              <a:rPr lang="en-US" sz="1300" dirty="0">
+              <a:rPr lang="en-US" sz="1200" dirty="0">
                 <a:solidFill>
                   <a:srgbClr val="1A1A1A"/>
                 </a:solidFill>
@@ -23365,7 +23365,7 @@
               </a:rPr>
               <a:t>SUBARU PRESCOTT</a:t>
             </a:r>
-            <a:endParaRPr lang="en-US" sz="1300" dirty="0"/>
+            <a:endParaRPr lang="en-US" sz="1200" dirty="0"/>
           </a:p>
         </p:txBody>
       </p:sp>
@@ -23570,7 +23570,7 @@
               <a:buNone/>
             </a:pPr>
             <a:r>
-              <a:rPr lang="en-US" sz="1300" dirty="0">
+              <a:rPr lang="en-US" sz="1200" dirty="0">
                 <a:solidFill>
                   <a:srgbClr val="1A1A1A"/>
                 </a:solidFill>
@@ -23580,7 +23580,7 @@
               </a:rPr>
               <a:t>TOYOTA PRESCOTT</a:t>
             </a:r>
-            <a:endParaRPr lang="en-US" sz="1300" dirty="0"/>
+            <a:endParaRPr lang="en-US" sz="1200" dirty="0"/>
           </a:p>
         </p:txBody>
       </p:sp>
@@ -23785,7 +23785,7 @@
               <a:buNone/>
             </a:pPr>
             <a:r>
-              <a:rPr lang="en-US" sz="1300" dirty="0">
+              <a:rPr lang="en-US" sz="1200" dirty="0">
                 <a:solidFill>
                   <a:srgbClr val="1A1A1A"/>
                 </a:solidFill>
@@ -23795,7 +23795,7 @@
               </a:rPr>
               <a:t>KIA ST GEORGE</a:t>
             </a:r>
-            <a:endParaRPr lang="en-US" sz="1300" dirty="0"/>
+            <a:endParaRPr lang="en-US" sz="1200" dirty="0"/>
           </a:p>
         </p:txBody>
       </p:sp>
@@ -24000,7 +24000,7 @@
               <a:buNone/>
             </a:pPr>
             <a:r>
-              <a:rPr lang="en-US" sz="1300" dirty="0">
+              <a:rPr lang="en-US" sz="1200" dirty="0">
                 <a:solidFill>
                   <a:srgbClr val="1A1A1A"/>
                 </a:solidFill>
@@ -24010,7 +24010,7 @@
               </a:rPr>
               <a:t>TOYOTA SPOKANE</a:t>
             </a:r>
-            <a:endParaRPr lang="en-US" sz="1300" dirty="0"/>
+            <a:endParaRPr lang="en-US" sz="1200" dirty="0"/>
           </a:p>
         </p:txBody>
       </p:sp>
@@ -24215,7 +24215,7 @@
               <a:buNone/>
             </a:pPr>
             <a:r>
-              <a:rPr lang="en-US" sz="1300" dirty="0">
+              <a:rPr lang="en-US" sz="1200" dirty="0">
                 <a:solidFill>
                   <a:srgbClr val="1A1A1A"/>
                 </a:solidFill>
@@ -24225,7 +24225,7 @@
               </a:rPr>
               <a:t>TOYOTA FLAGSTAFF</a:t>
             </a:r>
-            <a:endParaRPr lang="en-US" sz="1300" dirty="0"/>
+            <a:endParaRPr lang="en-US" sz="1200" dirty="0"/>
           </a:p>
         </p:txBody>
       </p:sp>

</xml_diff>

<commit_message>
Day 2 deck: Oct 26 wording round; changed slides file and checklist
Co-Authored-By: Claude Opus 5.5 <noreply@anthropic.com>
Claude-Session: https://claude.ai/code/session_01Xa4nFVxuQGXmHARGph9WhS
</commit_message>
<xml_diff>
--- a/day2-deck/decks/CP Hours & RO a Day - Review.pptx
+++ b/day2-deck/decks/CP Hours & RO a Day - Review.pptx
@@ -14051,7 +14051,7 @@
                 <a:ea typeface="Inter" pitchFamily="34" charset="-122"/>
                 <a:cs typeface="Inter" pitchFamily="34" charset="-120"/>
               </a:rPr>
-              <a:t>Jan–Sep 2026 vs Jan–Sep 2025</a:t>
+              <a:t>Jan–Sep, this year vs last</a:t>
             </a:r>
             <a:endParaRPr lang="en-US" sz="1200" dirty="0"/>
           </a:p>
@@ -15014,7 +15014,7 @@
                 <a:ea typeface="Inter" pitchFamily="34" charset="-122"/>
                 <a:cs typeface="Inter" pitchFamily="34" charset="-120"/>
               </a:rPr>
-              <a:t>Jan–Sep 2026 vs Jan–Sep 2025</a:t>
+              <a:t>Jan–Sep, this year vs last</a:t>
             </a:r>
             <a:endParaRPr lang="en-US" sz="1200" dirty="0"/>
           </a:p>
@@ -15957,7 +15957,7 @@
                 <a:ea typeface="Inter" pitchFamily="34" charset="-122"/>
                 <a:cs typeface="Inter" pitchFamily="34" charset="-120"/>
               </a:rPr>
-              <a:t>Jul–Sep vs Jan–Mar 2026, per month</a:t>
+              <a:t>Jul–Sep vs Jan–Mar this year</a:t>
             </a:r>
             <a:endParaRPr lang="en-US" sz="1200" dirty="0"/>
           </a:p>

</xml_diff>

<commit_message>
Drop every takeaway band that names a store (sentence to speaker notes); rebuild all decks
Co-Authored-By: Claude Opus 5.5 <noreply@anthropic.com>
Claude-Session: https://claude.ai/code/session_01Xa4nFVxuQGXmHARGph9WhS
</commit_message>
<xml_diff>
--- a/day2-deck/decks/CP Hours & RO a Day - Review.pptx
+++ b/day2-deck/decks/CP Hours & RO a Day - Review.pptx
@@ -2463,7 +2463,7 @@
           <a:p>
             <a:r>
               <a:rPr lang="en-US" dirty="0"/>
-              <a:t>Source: Qlik - Closed Repair Orders. Customer pay, Jan-Sep by close date. Same-store, INEOS excluded (opened 2026). GMC Prescott body shop labor types excluded. Total customer-pay labor hours sold, all CP ROs. Jan-Sep 2026 YTD.</a:t>
+              <a:t>Takeaway (off the slide): Toyota Henderson leads at 78,123; VW St George is smallest at 3,276.Source: Qlik - Closed Repair Orders. Customer pay, Jan-Sep by close date. Same-store, INEOS excluded (opened 2026). GMC Prescott body shop labor types excluded. Total customer-pay labor hours sold, all CP ROs. Jan-Sep 2026 YTD.</a:t>
             </a:r>
             <a:endParaRPr lang="en-US" dirty="0"/>
           </a:p>
@@ -2551,7 +2551,7 @@
           <a:p>
             <a:r>
               <a:rPr lang="en-US" dirty="0"/>
-              <a:t>Source: Qlik - Closed Repair Orders. Customer pay, Jan-Sep by close date. Same-store, INEOS excluded (opened 2026). GMC Prescott body shop labor types excluded. Change in customer-pay hours sold (percent, so store size does not drive the ranking), Jan-Sep 2026 vs 2025, best first.</a:t>
+              <a:t>Takeaway (off the slide): 23 of 33 stores sold more CP hours, led by Subaru St George at +44.6% to 12,766. 10 declined; VW St George fell most at −25.4%.Source: Qlik - Closed Repair Orders. Customer pay, Jan-Sep by close date. Same-store, INEOS excluded (opened 2026). GMC Prescott body shop labor types excluded. Change in customer-pay hours sold (percent, so store size does not drive the ranking), Jan-Sep 2026 vs 2025, best first.</a:t>
             </a:r>
             <a:endParaRPr lang="en-US" dirty="0"/>
           </a:p>
@@ -2639,7 +2639,7 @@
           <a:p>
             <a:r>
               <a:rPr lang="en-US" dirty="0"/>
-              <a:t>Source: Qlik - Closed Repair Orders. Customer pay, Jan-Sep by close date. Same-store, INEOS excluded (opened 2026). GMC Prescott body shop labor types excluded. Total customer-pay labor hours sold, all CP ROs. Top and bottom five stores by change in customer-pay hours sold (percent, so store size does not drive the ranking), Jan-Sep 2026 vs 2025. Moving now: Jul-Sep 2026 vs Jan-Mar 2026, each store against itself (monthly averages); the group moved +5.5% on the same basis, so part of every store's change is seasonal. Green bar at the right of a row: the store is on both the top five vs last year and the top five moving now.Conversation starter: each top store says one thing they started doing; each bottom store says what got in the way and what they would try. The room trades ideas. Moving now: ask the top three what they started this year.</a:t>
+              <a:t>Takeaway (off the slide): Ask Subaru St George, Kia LV and Kia St George what changed. Ask VW St George, Audi Reno and Volvo what got in the way. Ask Mazda, CDJR Post Falls and Lexus what they started this year.Source: Qlik - Closed Repair Orders. Customer pay, Jan-Sep by close date. Same-store, INEOS excluded (opened 2026). GMC Prescott body shop labor types excluded. Total customer-pay labor hours sold, all CP ROs. Top and bottom five stores by change in customer-pay hours sold (percent, so store size does not drive the ranking), Jan-Sep 2026 vs 2025. Moving now: Jul-Sep 2026 vs Jan-Mar 2026, each store against itself (monthly averages); the group moved +5.5% on the same basis, so part of every store's change is seasonal. Green bar at the right of a row: the store is on both the top five vs last year and the top five moving now.Conversation starter: each top store says one thing they started doing; each bottom store says what got in the way and what they would try. The room trades ideas. Moving now: ask the top three what they started this year.</a:t>
             </a:r>
             <a:endParaRPr lang="en-US" dirty="0"/>
           </a:p>
@@ -4094,7 +4094,7 @@
         <p:spPr>
           <a:xfrm>
             <a:off x="457200" y="1207008"/>
-            <a:ext cx="11274552" cy="4782312"/>
+            <a:ext cx="11274552" cy="5148072"/>
           </a:xfrm>
           <a:prstGeom prst="rect">
             <a:avLst/>
@@ -4271,7 +4271,7 @@
         <p:spPr>
           <a:xfrm>
             <a:off x="658368" y="1847088"/>
-            <a:ext cx="310896" cy="239896"/>
+            <a:ext cx="310896" cy="261411"/>
           </a:xfrm>
           <a:prstGeom prst="rect">
             <a:avLst/>
@@ -4310,7 +4310,7 @@
         <p:spPr>
           <a:xfrm>
             <a:off x="1014984" y="1847088"/>
-            <a:ext cx="1920240" cy="239896"/>
+            <a:ext cx="1920240" cy="261411"/>
           </a:xfrm>
           <a:prstGeom prst="rect">
             <a:avLst/>
@@ -4348,8 +4348,8 @@
         </p:nvSpPr>
         <p:spPr>
           <a:xfrm>
-            <a:off x="2980944" y="1911860"/>
-            <a:ext cx="1828800" cy="110352"/>
+            <a:off x="2980944" y="1917669"/>
+            <a:ext cx="1828800" cy="120249"/>
           </a:xfrm>
           <a:prstGeom prst="rect">
             <a:avLst/>
@@ -4369,7 +4369,7 @@
         <p:spPr>
           <a:xfrm>
             <a:off x="4855464" y="1847088"/>
-            <a:ext cx="1097280" cy="239896"/>
+            <a:ext cx="1097280" cy="261411"/>
           </a:xfrm>
           <a:prstGeom prst="rect">
             <a:avLst/>
@@ -4407,8 +4407,8 @@
         </p:nvSpPr>
         <p:spPr>
           <a:xfrm>
-            <a:off x="658368" y="2086984"/>
-            <a:ext cx="310896" cy="239896"/>
+            <a:off x="658368" y="2108499"/>
+            <a:ext cx="310896" cy="261411"/>
           </a:xfrm>
           <a:prstGeom prst="rect">
             <a:avLst/>
@@ -4446,8 +4446,8 @@
         </p:nvSpPr>
         <p:spPr>
           <a:xfrm>
-            <a:off x="1014984" y="2086984"/>
-            <a:ext cx="1920240" cy="239896"/>
+            <a:off x="1014984" y="2108499"/>
+            <a:ext cx="1920240" cy="261411"/>
           </a:xfrm>
           <a:prstGeom prst="rect">
             <a:avLst/>
@@ -4485,8 +4485,8 @@
         </p:nvSpPr>
         <p:spPr>
           <a:xfrm>
-            <a:off x="2980944" y="2151755"/>
-            <a:ext cx="1050673" cy="110352"/>
+            <a:off x="2980944" y="2179080"/>
+            <a:ext cx="1050673" cy="120249"/>
           </a:xfrm>
           <a:prstGeom prst="rect">
             <a:avLst/>
@@ -4505,8 +4505,8 @@
         </p:nvSpPr>
         <p:spPr>
           <a:xfrm>
-            <a:off x="4855464" y="2086984"/>
-            <a:ext cx="1097280" cy="239896"/>
+            <a:off x="4855464" y="2108499"/>
+            <a:ext cx="1097280" cy="261411"/>
           </a:xfrm>
           <a:prstGeom prst="rect">
             <a:avLst/>
@@ -4544,8 +4544,8 @@
         </p:nvSpPr>
         <p:spPr>
           <a:xfrm>
-            <a:off x="658368" y="2326879"/>
-            <a:ext cx="310896" cy="239896"/>
+            <a:off x="658368" y="2369910"/>
+            <a:ext cx="310896" cy="261411"/>
           </a:xfrm>
           <a:prstGeom prst="rect">
             <a:avLst/>
@@ -4583,8 +4583,8 @@
         </p:nvSpPr>
         <p:spPr>
           <a:xfrm>
-            <a:off x="1014984" y="2326879"/>
-            <a:ext cx="1920240" cy="239896"/>
+            <a:off x="1014984" y="2369910"/>
+            <a:ext cx="1920240" cy="261411"/>
           </a:xfrm>
           <a:prstGeom prst="rect">
             <a:avLst/>
@@ -4622,8 +4622,8 @@
         </p:nvSpPr>
         <p:spPr>
           <a:xfrm>
-            <a:off x="2980944" y="2391651"/>
-            <a:ext cx="1038014" cy="110352"/>
+            <a:off x="2980944" y="2440491"/>
+            <a:ext cx="1038014" cy="120249"/>
           </a:xfrm>
           <a:prstGeom prst="rect">
             <a:avLst/>
@@ -4642,8 +4642,8 @@
         </p:nvSpPr>
         <p:spPr>
           <a:xfrm>
-            <a:off x="4855464" y="2326879"/>
-            <a:ext cx="1097280" cy="239896"/>
+            <a:off x="4855464" y="2369910"/>
+            <a:ext cx="1097280" cy="261411"/>
           </a:xfrm>
           <a:prstGeom prst="rect">
             <a:avLst/>
@@ -4681,8 +4681,8 @@
         </p:nvSpPr>
         <p:spPr>
           <a:xfrm>
-            <a:off x="658368" y="2566775"/>
-            <a:ext cx="310896" cy="239896"/>
+            <a:off x="658368" y="2631320"/>
+            <a:ext cx="310896" cy="261411"/>
           </a:xfrm>
           <a:prstGeom prst="rect">
             <a:avLst/>
@@ -4720,8 +4720,8 @@
         </p:nvSpPr>
         <p:spPr>
           <a:xfrm>
-            <a:off x="1014984" y="2566775"/>
-            <a:ext cx="1920240" cy="239896"/>
+            <a:off x="1014984" y="2631320"/>
+            <a:ext cx="1920240" cy="261411"/>
           </a:xfrm>
           <a:prstGeom prst="rect">
             <a:avLst/>
@@ -4759,8 +4759,8 @@
         </p:nvSpPr>
         <p:spPr>
           <a:xfrm>
-            <a:off x="2980944" y="2631546"/>
-            <a:ext cx="711662" cy="110352"/>
+            <a:off x="2980944" y="2701901"/>
+            <a:ext cx="711662" cy="120249"/>
           </a:xfrm>
           <a:prstGeom prst="rect">
             <a:avLst/>
@@ -4779,8 +4779,8 @@
         </p:nvSpPr>
         <p:spPr>
           <a:xfrm>
-            <a:off x="4855464" y="2566775"/>
-            <a:ext cx="1097280" cy="239896"/>
+            <a:off x="4855464" y="2631320"/>
+            <a:ext cx="1097280" cy="261411"/>
           </a:xfrm>
           <a:prstGeom prst="rect">
             <a:avLst/>
@@ -4818,8 +4818,8 @@
         </p:nvSpPr>
         <p:spPr>
           <a:xfrm>
-            <a:off x="658368" y="2806670"/>
-            <a:ext cx="310896" cy="239896"/>
+            <a:off x="658368" y="2892731"/>
+            <a:ext cx="310896" cy="261411"/>
           </a:xfrm>
           <a:prstGeom prst="rect">
             <a:avLst/>
@@ -4857,8 +4857,8 @@
         </p:nvSpPr>
         <p:spPr>
           <a:xfrm>
-            <a:off x="1014984" y="2806670"/>
-            <a:ext cx="1920240" cy="239896"/>
+            <a:off x="1014984" y="2892731"/>
+            <a:ext cx="1920240" cy="261411"/>
           </a:xfrm>
           <a:prstGeom prst="rect">
             <a:avLst/>
@@ -4896,8 +4896,8 @@
         </p:nvSpPr>
         <p:spPr>
           <a:xfrm>
-            <a:off x="2980944" y="2871442"/>
-            <a:ext cx="649509" cy="110352"/>
+            <a:off x="2980944" y="2963312"/>
+            <a:ext cx="649509" cy="120249"/>
           </a:xfrm>
           <a:prstGeom prst="rect">
             <a:avLst/>
@@ -4916,8 +4916,8 @@
         </p:nvSpPr>
         <p:spPr>
           <a:xfrm>
-            <a:off x="4855464" y="2806670"/>
-            <a:ext cx="1097280" cy="239896"/>
+            <a:off x="4855464" y="2892731"/>
+            <a:ext cx="1097280" cy="261411"/>
           </a:xfrm>
           <a:prstGeom prst="rect">
             <a:avLst/>
@@ -4955,8 +4955,8 @@
         </p:nvSpPr>
         <p:spPr>
           <a:xfrm>
-            <a:off x="658368" y="3046566"/>
-            <a:ext cx="310896" cy="239896"/>
+            <a:off x="658368" y="3154142"/>
+            <a:ext cx="310896" cy="261411"/>
           </a:xfrm>
           <a:prstGeom prst="rect">
             <a:avLst/>
@@ -4994,8 +4994,8 @@
         </p:nvSpPr>
         <p:spPr>
           <a:xfrm>
-            <a:off x="1014984" y="3046566"/>
-            <a:ext cx="1920240" cy="239896"/>
+            <a:off x="1014984" y="3154142"/>
+            <a:ext cx="1920240" cy="261411"/>
           </a:xfrm>
           <a:prstGeom prst="rect">
             <a:avLst/>
@@ -5033,8 +5033,8 @@
         </p:nvSpPr>
         <p:spPr>
           <a:xfrm>
-            <a:off x="2980944" y="3111337"/>
-            <a:ext cx="602764" cy="110352"/>
+            <a:off x="2980944" y="3224723"/>
+            <a:ext cx="602764" cy="120249"/>
           </a:xfrm>
           <a:prstGeom prst="rect">
             <a:avLst/>
@@ -5053,8 +5053,8 @@
         </p:nvSpPr>
         <p:spPr>
           <a:xfrm>
-            <a:off x="4855464" y="3046566"/>
-            <a:ext cx="1097280" cy="239896"/>
+            <a:off x="4855464" y="3154142"/>
+            <a:ext cx="1097280" cy="261411"/>
           </a:xfrm>
           <a:prstGeom prst="rect">
             <a:avLst/>
@@ -5092,8 +5092,8 @@
         </p:nvSpPr>
         <p:spPr>
           <a:xfrm>
-            <a:off x="658368" y="3286461"/>
-            <a:ext cx="310896" cy="239896"/>
+            <a:off x="658368" y="3415553"/>
+            <a:ext cx="310896" cy="261411"/>
           </a:xfrm>
           <a:prstGeom prst="rect">
             <a:avLst/>
@@ -5131,8 +5131,8 @@
         </p:nvSpPr>
         <p:spPr>
           <a:xfrm>
-            <a:off x="1014984" y="3286461"/>
-            <a:ext cx="1920240" cy="239896"/>
+            <a:off x="1014984" y="3415553"/>
+            <a:ext cx="1920240" cy="261411"/>
           </a:xfrm>
           <a:prstGeom prst="rect">
             <a:avLst/>
@@ -5170,8 +5170,8 @@
         </p:nvSpPr>
         <p:spPr>
           <a:xfrm>
-            <a:off x="2980944" y="3351233"/>
-            <a:ext cx="498059" cy="110352"/>
+            <a:off x="2980944" y="3486134"/>
+            <a:ext cx="498059" cy="120249"/>
           </a:xfrm>
           <a:prstGeom prst="rect">
             <a:avLst/>
@@ -5190,8 +5190,8 @@
         </p:nvSpPr>
         <p:spPr>
           <a:xfrm>
-            <a:off x="4855464" y="3286461"/>
-            <a:ext cx="1097280" cy="239896"/>
+            <a:off x="4855464" y="3415553"/>
+            <a:ext cx="1097280" cy="261411"/>
           </a:xfrm>
           <a:prstGeom prst="rect">
             <a:avLst/>
@@ -5229,8 +5229,8 @@
         </p:nvSpPr>
         <p:spPr>
           <a:xfrm>
-            <a:off x="658368" y="3526357"/>
-            <a:ext cx="310896" cy="239896"/>
+            <a:off x="658368" y="3676964"/>
+            <a:ext cx="310896" cy="261411"/>
           </a:xfrm>
           <a:prstGeom prst="rect">
             <a:avLst/>
@@ -5268,8 +5268,8 @@
         </p:nvSpPr>
         <p:spPr>
           <a:xfrm>
-            <a:off x="1014984" y="3526357"/>
-            <a:ext cx="1920240" cy="239896"/>
+            <a:off x="1014984" y="3676964"/>
+            <a:ext cx="1920240" cy="261411"/>
           </a:xfrm>
           <a:prstGeom prst="rect">
             <a:avLst/>
@@ -5307,8 +5307,8 @@
         </p:nvSpPr>
         <p:spPr>
           <a:xfrm>
-            <a:off x="2980944" y="3591128"/>
-            <a:ext cx="436748" cy="110352"/>
+            <a:off x="2980944" y="3747545"/>
+            <a:ext cx="436748" cy="120249"/>
           </a:xfrm>
           <a:prstGeom prst="rect">
             <a:avLst/>
@@ -5327,8 +5327,8 @@
         </p:nvSpPr>
         <p:spPr>
           <a:xfrm>
-            <a:off x="4855464" y="3526357"/>
-            <a:ext cx="1097280" cy="239896"/>
+            <a:off x="4855464" y="3676964"/>
+            <a:ext cx="1097280" cy="261411"/>
           </a:xfrm>
           <a:prstGeom prst="rect">
             <a:avLst/>
@@ -5366,8 +5366,8 @@
         </p:nvSpPr>
         <p:spPr>
           <a:xfrm>
-            <a:off x="658368" y="3766252"/>
-            <a:ext cx="310896" cy="239896"/>
+            <a:off x="658368" y="3938375"/>
+            <a:ext cx="310896" cy="261411"/>
           </a:xfrm>
           <a:prstGeom prst="rect">
             <a:avLst/>
@@ -5405,8 +5405,8 @@
         </p:nvSpPr>
         <p:spPr>
           <a:xfrm>
-            <a:off x="1014984" y="3766252"/>
-            <a:ext cx="1920240" cy="239896"/>
+            <a:off x="1014984" y="3938375"/>
+            <a:ext cx="1920240" cy="261411"/>
           </a:xfrm>
           <a:prstGeom prst="rect">
             <a:avLst/>
@@ -5444,8 +5444,8 @@
         </p:nvSpPr>
         <p:spPr>
           <a:xfrm>
-            <a:off x="2980944" y="3831024"/>
-            <a:ext cx="419629" cy="110352"/>
+            <a:off x="2980944" y="4008956"/>
+            <a:ext cx="419629" cy="120249"/>
           </a:xfrm>
           <a:prstGeom prst="rect">
             <a:avLst/>
@@ -5464,8 +5464,8 @@
         </p:nvSpPr>
         <p:spPr>
           <a:xfrm>
-            <a:off x="4855464" y="3766252"/>
-            <a:ext cx="1097280" cy="239896"/>
+            <a:off x="4855464" y="3938375"/>
+            <a:ext cx="1097280" cy="261411"/>
           </a:xfrm>
           <a:prstGeom prst="rect">
             <a:avLst/>
@@ -5503,8 +5503,8 @@
         </p:nvSpPr>
         <p:spPr>
           <a:xfrm>
-            <a:off x="658368" y="4006148"/>
-            <a:ext cx="310896" cy="239896"/>
+            <a:off x="658368" y="4199785"/>
+            <a:ext cx="310896" cy="261411"/>
           </a:xfrm>
           <a:prstGeom prst="rect">
             <a:avLst/>
@@ -5542,8 +5542,8 @@
         </p:nvSpPr>
         <p:spPr>
           <a:xfrm>
-            <a:off x="1014984" y="4006148"/>
-            <a:ext cx="1920240" cy="239896"/>
+            <a:off x="1014984" y="4199785"/>
+            <a:ext cx="1920240" cy="261411"/>
           </a:xfrm>
           <a:prstGeom prst="rect">
             <a:avLst/>
@@ -5581,8 +5581,8 @@
         </p:nvSpPr>
         <p:spPr>
           <a:xfrm>
-            <a:off x="2980944" y="4070920"/>
-            <a:ext cx="344483" cy="110352"/>
+            <a:off x="2980944" y="4270366"/>
+            <a:ext cx="344483" cy="120249"/>
           </a:xfrm>
           <a:prstGeom prst="rect">
             <a:avLst/>
@@ -5601,8 +5601,8 @@
         </p:nvSpPr>
         <p:spPr>
           <a:xfrm>
-            <a:off x="4855464" y="4006148"/>
-            <a:ext cx="1097280" cy="239896"/>
+            <a:off x="4855464" y="4199785"/>
+            <a:ext cx="1097280" cy="261411"/>
           </a:xfrm>
           <a:prstGeom prst="rect">
             <a:avLst/>
@@ -5640,8 +5640,8 @@
         </p:nvSpPr>
         <p:spPr>
           <a:xfrm>
-            <a:off x="658368" y="4246043"/>
-            <a:ext cx="310896" cy="239896"/>
+            <a:off x="658368" y="4461196"/>
+            <a:ext cx="310896" cy="261411"/>
           </a:xfrm>
           <a:prstGeom prst="rect">
             <a:avLst/>
@@ -5679,8 +5679,8 @@
         </p:nvSpPr>
         <p:spPr>
           <a:xfrm>
-            <a:off x="1014984" y="4246043"/>
-            <a:ext cx="1920240" cy="239896"/>
+            <a:off x="1014984" y="4461196"/>
+            <a:ext cx="1920240" cy="261411"/>
           </a:xfrm>
           <a:prstGeom prst="rect">
             <a:avLst/>
@@ -5718,8 +5718,8 @@
         </p:nvSpPr>
         <p:spPr>
           <a:xfrm>
-            <a:off x="2980944" y="4310815"/>
-            <a:ext cx="341580" cy="110352"/>
+            <a:off x="2980944" y="4531777"/>
+            <a:ext cx="341580" cy="120249"/>
           </a:xfrm>
           <a:prstGeom prst="rect">
             <a:avLst/>
@@ -5738,8 +5738,8 @@
         </p:nvSpPr>
         <p:spPr>
           <a:xfrm>
-            <a:off x="4855464" y="4246043"/>
-            <a:ext cx="1097280" cy="239896"/>
+            <a:off x="4855464" y="4461196"/>
+            <a:ext cx="1097280" cy="261411"/>
           </a:xfrm>
           <a:prstGeom prst="rect">
             <a:avLst/>
@@ -5777,8 +5777,8 @@
         </p:nvSpPr>
         <p:spPr>
           <a:xfrm>
-            <a:off x="658368" y="4485939"/>
-            <a:ext cx="310896" cy="239896"/>
+            <a:off x="658368" y="4722607"/>
+            <a:ext cx="310896" cy="261411"/>
           </a:xfrm>
           <a:prstGeom prst="rect">
             <a:avLst/>
@@ -5816,8 +5816,8 @@
         </p:nvSpPr>
         <p:spPr>
           <a:xfrm>
-            <a:off x="1014984" y="4485939"/>
-            <a:ext cx="1920240" cy="239896"/>
+            <a:off x="1014984" y="4722607"/>
+            <a:ext cx="1920240" cy="261411"/>
           </a:xfrm>
           <a:prstGeom prst="rect">
             <a:avLst/>
@@ -5855,8 +5855,8 @@
         </p:nvSpPr>
         <p:spPr>
           <a:xfrm>
-            <a:off x="2980944" y="4550711"/>
-            <a:ext cx="326318" cy="110352"/>
+            <a:off x="2980944" y="4793188"/>
+            <a:ext cx="326318" cy="120249"/>
           </a:xfrm>
           <a:prstGeom prst="rect">
             <a:avLst/>
@@ -5875,8 +5875,8 @@
         </p:nvSpPr>
         <p:spPr>
           <a:xfrm>
-            <a:off x="4855464" y="4485939"/>
-            <a:ext cx="1097280" cy="239896"/>
+            <a:off x="4855464" y="4722607"/>
+            <a:ext cx="1097280" cy="261411"/>
           </a:xfrm>
           <a:prstGeom prst="rect">
             <a:avLst/>
@@ -5914,8 +5914,8 @@
         </p:nvSpPr>
         <p:spPr>
           <a:xfrm>
-            <a:off x="658368" y="4725834"/>
-            <a:ext cx="310896" cy="239896"/>
+            <a:off x="658368" y="4984018"/>
+            <a:ext cx="310896" cy="261411"/>
           </a:xfrm>
           <a:prstGeom prst="rect">
             <a:avLst/>
@@ -5953,8 +5953,8 @@
         </p:nvSpPr>
         <p:spPr>
           <a:xfrm>
-            <a:off x="1014984" y="4725834"/>
-            <a:ext cx="1920240" cy="239896"/>
+            <a:off x="1014984" y="4984018"/>
+            <a:ext cx="1920240" cy="261411"/>
           </a:xfrm>
           <a:prstGeom prst="rect">
             <a:avLst/>
@@ -5992,8 +5992,8 @@
         </p:nvSpPr>
         <p:spPr>
           <a:xfrm>
-            <a:off x="2980944" y="4790606"/>
-            <a:ext cx="308206" cy="110352"/>
+            <a:off x="2980944" y="5054599"/>
+            <a:ext cx="308206" cy="120249"/>
           </a:xfrm>
           <a:prstGeom prst="rect">
             <a:avLst/>
@@ -6012,8 +6012,8 @@
         </p:nvSpPr>
         <p:spPr>
           <a:xfrm>
-            <a:off x="4855464" y="4725834"/>
-            <a:ext cx="1097280" cy="239896"/>
+            <a:off x="4855464" y="4984018"/>
+            <a:ext cx="1097280" cy="261411"/>
           </a:xfrm>
           <a:prstGeom prst="rect">
             <a:avLst/>
@@ -6051,8 +6051,8 @@
         </p:nvSpPr>
         <p:spPr>
           <a:xfrm>
-            <a:off x="658368" y="4965730"/>
-            <a:ext cx="310896" cy="239896"/>
+            <a:off x="658368" y="5245429"/>
+            <a:ext cx="310896" cy="261411"/>
           </a:xfrm>
           <a:prstGeom prst="rect">
             <a:avLst/>
@@ -6090,8 +6090,8 @@
         </p:nvSpPr>
         <p:spPr>
           <a:xfrm>
-            <a:off x="1014984" y="4965730"/>
-            <a:ext cx="1920240" cy="239896"/>
+            <a:off x="1014984" y="5245429"/>
+            <a:ext cx="1920240" cy="261411"/>
           </a:xfrm>
           <a:prstGeom prst="rect">
             <a:avLst/>
@@ -6129,8 +6129,8 @@
         </p:nvSpPr>
         <p:spPr>
           <a:xfrm>
-            <a:off x="2980944" y="5030502"/>
-            <a:ext cx="299995" cy="110352"/>
+            <a:off x="2980944" y="5316010"/>
+            <a:ext cx="299995" cy="120249"/>
           </a:xfrm>
           <a:prstGeom prst="rect">
             <a:avLst/>
@@ -6149,8 +6149,8 @@
         </p:nvSpPr>
         <p:spPr>
           <a:xfrm>
-            <a:off x="4855464" y="4965730"/>
-            <a:ext cx="1097280" cy="239896"/>
+            <a:off x="4855464" y="5245429"/>
+            <a:ext cx="1097280" cy="261411"/>
           </a:xfrm>
           <a:prstGeom prst="rect">
             <a:avLst/>
@@ -6188,8 +6188,8 @@
         </p:nvSpPr>
         <p:spPr>
           <a:xfrm>
-            <a:off x="658368" y="5205625"/>
-            <a:ext cx="310896" cy="239896"/>
+            <a:off x="658368" y="5506840"/>
+            <a:ext cx="310896" cy="261411"/>
           </a:xfrm>
           <a:prstGeom prst="rect">
             <a:avLst/>
@@ -6227,8 +6227,8 @@
         </p:nvSpPr>
         <p:spPr>
           <a:xfrm>
-            <a:off x="1014984" y="5205625"/>
-            <a:ext cx="1920240" cy="239896"/>
+            <a:off x="1014984" y="5506840"/>
+            <a:ext cx="1920240" cy="261411"/>
           </a:xfrm>
           <a:prstGeom prst="rect">
             <a:avLst/>
@@ -6266,8 +6266,8 @@
         </p:nvSpPr>
         <p:spPr>
           <a:xfrm>
-            <a:off x="2980944" y="5270397"/>
-            <a:ext cx="298846" cy="110352"/>
+            <a:off x="2980944" y="5577420"/>
+            <a:ext cx="298846" cy="120249"/>
           </a:xfrm>
           <a:prstGeom prst="rect">
             <a:avLst/>
@@ -6286,8 +6286,8 @@
         </p:nvSpPr>
         <p:spPr>
           <a:xfrm>
-            <a:off x="4855464" y="5205625"/>
-            <a:ext cx="1097280" cy="239896"/>
+            <a:off x="4855464" y="5506840"/>
+            <a:ext cx="1097280" cy="261411"/>
           </a:xfrm>
           <a:prstGeom prst="rect">
             <a:avLst/>
@@ -6325,8 +6325,8 @@
         </p:nvSpPr>
         <p:spPr>
           <a:xfrm>
-            <a:off x="658368" y="5445521"/>
-            <a:ext cx="310896" cy="239896"/>
+            <a:off x="658368" y="5768250"/>
+            <a:ext cx="310896" cy="261411"/>
           </a:xfrm>
           <a:prstGeom prst="rect">
             <a:avLst/>
@@ -6364,8 +6364,8 @@
         </p:nvSpPr>
         <p:spPr>
           <a:xfrm>
-            <a:off x="1014984" y="5445521"/>
-            <a:ext cx="1920240" cy="239896"/>
+            <a:off x="1014984" y="5768250"/>
+            <a:ext cx="1920240" cy="261411"/>
           </a:xfrm>
           <a:prstGeom prst="rect">
             <a:avLst/>
@@ -6403,8 +6403,8 @@
         </p:nvSpPr>
         <p:spPr>
           <a:xfrm>
-            <a:off x="2980944" y="5510293"/>
-            <a:ext cx="298644" cy="110352"/>
+            <a:off x="2980944" y="5838831"/>
+            <a:ext cx="298644" cy="120249"/>
           </a:xfrm>
           <a:prstGeom prst="rect">
             <a:avLst/>
@@ -6423,8 +6423,8 @@
         </p:nvSpPr>
         <p:spPr>
           <a:xfrm>
-            <a:off x="4855464" y="5445521"/>
-            <a:ext cx="1097280" cy="239896"/>
+            <a:off x="4855464" y="5768250"/>
+            <a:ext cx="1097280" cy="261411"/>
           </a:xfrm>
           <a:prstGeom prst="rect">
             <a:avLst/>
@@ -6462,8 +6462,8 @@
         </p:nvSpPr>
         <p:spPr>
           <a:xfrm>
-            <a:off x="658368" y="5685416"/>
-            <a:ext cx="310896" cy="239896"/>
+            <a:off x="658368" y="6029661"/>
+            <a:ext cx="310896" cy="261411"/>
           </a:xfrm>
           <a:prstGeom prst="rect">
             <a:avLst/>
@@ -6501,8 +6501,8 @@
         </p:nvSpPr>
         <p:spPr>
           <a:xfrm>
-            <a:off x="1014984" y="5685416"/>
-            <a:ext cx="1920240" cy="239896"/>
+            <a:off x="1014984" y="6029661"/>
+            <a:ext cx="1920240" cy="261411"/>
           </a:xfrm>
           <a:prstGeom prst="rect">
             <a:avLst/>
@@ -6540,8 +6540,8 @@
         </p:nvSpPr>
         <p:spPr>
           <a:xfrm>
-            <a:off x="2980944" y="5750188"/>
-            <a:ext cx="276102" cy="110352"/>
+            <a:off x="2980944" y="6100242"/>
+            <a:ext cx="276102" cy="120249"/>
           </a:xfrm>
           <a:prstGeom prst="rect">
             <a:avLst/>
@@ -6560,8 +6560,8 @@
         </p:nvSpPr>
         <p:spPr>
           <a:xfrm>
-            <a:off x="4855464" y="5685416"/>
-            <a:ext cx="1097280" cy="239896"/>
+            <a:off x="4855464" y="6029661"/>
+            <a:ext cx="1097280" cy="261411"/>
           </a:xfrm>
           <a:prstGeom prst="rect">
             <a:avLst/>
@@ -6600,7 +6600,7 @@
         <p:spPr>
           <a:xfrm>
             <a:off x="6208776" y="1847088"/>
-            <a:ext cx="310896" cy="239896"/>
+            <a:ext cx="310896" cy="261411"/>
           </a:xfrm>
           <a:prstGeom prst="rect">
             <a:avLst/>
@@ -6639,7 +6639,7 @@
         <p:spPr>
           <a:xfrm>
             <a:off x="6565392" y="1847088"/>
-            <a:ext cx="1920240" cy="239896"/>
+            <a:ext cx="1920240" cy="261411"/>
           </a:xfrm>
           <a:prstGeom prst="rect">
             <a:avLst/>
@@ -6677,8 +6677,8 @@
         </p:nvSpPr>
         <p:spPr>
           <a:xfrm>
-            <a:off x="8531352" y="1911860"/>
-            <a:ext cx="257333" cy="110352"/>
+            <a:off x="8531352" y="1917669"/>
+            <a:ext cx="257333" cy="120249"/>
           </a:xfrm>
           <a:prstGeom prst="rect">
             <a:avLst/>
@@ -6698,7 +6698,7 @@
         <p:spPr>
           <a:xfrm>
             <a:off x="10405872" y="1847088"/>
-            <a:ext cx="1097280" cy="239896"/>
+            <a:ext cx="1097280" cy="261411"/>
           </a:xfrm>
           <a:prstGeom prst="rect">
             <a:avLst/>
@@ -6736,8 +6736,8 @@
         </p:nvSpPr>
         <p:spPr>
           <a:xfrm>
-            <a:off x="6208776" y="2086984"/>
-            <a:ext cx="310896" cy="239896"/>
+            <a:off x="6208776" y="2108499"/>
+            <a:ext cx="310896" cy="261411"/>
           </a:xfrm>
           <a:prstGeom prst="rect">
             <a:avLst/>
@@ -6775,8 +6775,8 @@
         </p:nvSpPr>
         <p:spPr>
           <a:xfrm>
-            <a:off x="6565392" y="2086984"/>
-            <a:ext cx="1920240" cy="239896"/>
+            <a:off x="6565392" y="2108499"/>
+            <a:ext cx="1920240" cy="261411"/>
           </a:xfrm>
           <a:prstGeom prst="rect">
             <a:avLst/>
@@ -6814,8 +6814,8 @@
         </p:nvSpPr>
         <p:spPr>
           <a:xfrm>
-            <a:off x="8531352" y="2151755"/>
-            <a:ext cx="250095" cy="110352"/>
+            <a:off x="8531352" y="2179080"/>
+            <a:ext cx="250095" cy="120249"/>
           </a:xfrm>
           <a:prstGeom prst="rect">
             <a:avLst/>
@@ -6834,8 +6834,8 @@
         </p:nvSpPr>
         <p:spPr>
           <a:xfrm>
-            <a:off x="10405872" y="2086984"/>
-            <a:ext cx="1097280" cy="239896"/>
+            <a:off x="10405872" y="2108499"/>
+            <a:ext cx="1097280" cy="261411"/>
           </a:xfrm>
           <a:prstGeom prst="rect">
             <a:avLst/>
@@ -6873,8 +6873,8 @@
         </p:nvSpPr>
         <p:spPr>
           <a:xfrm>
-            <a:off x="6208776" y="2326879"/>
-            <a:ext cx="310896" cy="239896"/>
+            <a:off x="6208776" y="2369910"/>
+            <a:ext cx="310896" cy="261411"/>
           </a:xfrm>
           <a:prstGeom prst="rect">
             <a:avLst/>
@@ -6912,8 +6912,8 @@
         </p:nvSpPr>
         <p:spPr>
           <a:xfrm>
-            <a:off x="6565392" y="2326879"/>
-            <a:ext cx="1920240" cy="239896"/>
+            <a:off x="6565392" y="2369910"/>
+            <a:ext cx="1920240" cy="261411"/>
           </a:xfrm>
           <a:prstGeom prst="rect">
             <a:avLst/>
@@ -6951,8 +6951,8 @@
         </p:nvSpPr>
         <p:spPr>
           <a:xfrm>
-            <a:off x="8531352" y="2391651"/>
-            <a:ext cx="222717" cy="110352"/>
+            <a:off x="8531352" y="2440491"/>
+            <a:ext cx="222717" cy="120249"/>
           </a:xfrm>
           <a:prstGeom prst="rect">
             <a:avLst/>
@@ -6971,8 +6971,8 @@
         </p:nvSpPr>
         <p:spPr>
           <a:xfrm>
-            <a:off x="10405872" y="2326879"/>
-            <a:ext cx="1097280" cy="239896"/>
+            <a:off x="10405872" y="2369910"/>
+            <a:ext cx="1097280" cy="261411"/>
           </a:xfrm>
           <a:prstGeom prst="rect">
             <a:avLst/>
@@ -7010,8 +7010,8 @@
         </p:nvSpPr>
         <p:spPr>
           <a:xfrm>
-            <a:off x="6208776" y="2566775"/>
-            <a:ext cx="310896" cy="239896"/>
+            <a:off x="6208776" y="2631320"/>
+            <a:ext cx="310896" cy="261411"/>
           </a:xfrm>
           <a:prstGeom prst="rect">
             <a:avLst/>
@@ -7049,8 +7049,8 @@
         </p:nvSpPr>
         <p:spPr>
           <a:xfrm>
-            <a:off x="6565392" y="2566775"/>
-            <a:ext cx="1920240" cy="239896"/>
+            <a:off x="6565392" y="2631320"/>
+            <a:ext cx="1920240" cy="261411"/>
           </a:xfrm>
           <a:prstGeom prst="rect">
             <a:avLst/>
@@ -7088,8 +7088,8 @@
         </p:nvSpPr>
         <p:spPr>
           <a:xfrm>
-            <a:off x="8531352" y="2631546"/>
-            <a:ext cx="194260" cy="110352"/>
+            <a:off x="8531352" y="2701901"/>
+            <a:ext cx="194260" cy="120249"/>
           </a:xfrm>
           <a:prstGeom prst="rect">
             <a:avLst/>
@@ -7108,8 +7108,8 @@
         </p:nvSpPr>
         <p:spPr>
           <a:xfrm>
-            <a:off x="10405872" y="2566775"/>
-            <a:ext cx="1097280" cy="239896"/>
+            <a:off x="10405872" y="2631320"/>
+            <a:ext cx="1097280" cy="261411"/>
           </a:xfrm>
           <a:prstGeom prst="rect">
             <a:avLst/>
@@ -7147,8 +7147,8 @@
         </p:nvSpPr>
         <p:spPr>
           <a:xfrm>
-            <a:off x="6208776" y="2806670"/>
-            <a:ext cx="310896" cy="239896"/>
+            <a:off x="6208776" y="2892731"/>
+            <a:ext cx="310896" cy="261411"/>
           </a:xfrm>
           <a:prstGeom prst="rect">
             <a:avLst/>
@@ -7186,8 +7186,8 @@
         </p:nvSpPr>
         <p:spPr>
           <a:xfrm>
-            <a:off x="6565392" y="2806670"/>
-            <a:ext cx="1920240" cy="239896"/>
+            <a:off x="6565392" y="2892731"/>
+            <a:ext cx="1920240" cy="261411"/>
           </a:xfrm>
           <a:prstGeom prst="rect">
             <a:avLst/>
@@ -7225,8 +7225,8 @@
         </p:nvSpPr>
         <p:spPr>
           <a:xfrm>
-            <a:off x="8531352" y="2871442"/>
-            <a:ext cx="190890" cy="110352"/>
+            <a:off x="8531352" y="2963312"/>
+            <a:ext cx="190890" cy="120249"/>
           </a:xfrm>
           <a:prstGeom prst="rect">
             <a:avLst/>
@@ -7245,8 +7245,8 @@
         </p:nvSpPr>
         <p:spPr>
           <a:xfrm>
-            <a:off x="10405872" y="2806670"/>
-            <a:ext cx="1097280" cy="239896"/>
+            <a:off x="10405872" y="2892731"/>
+            <a:ext cx="1097280" cy="261411"/>
           </a:xfrm>
           <a:prstGeom prst="rect">
             <a:avLst/>
@@ -7284,8 +7284,8 @@
         </p:nvSpPr>
         <p:spPr>
           <a:xfrm>
-            <a:off x="6208776" y="3046566"/>
-            <a:ext cx="310896" cy="239896"/>
+            <a:off x="6208776" y="3154142"/>
+            <a:ext cx="310896" cy="261411"/>
           </a:xfrm>
           <a:prstGeom prst="rect">
             <a:avLst/>
@@ -7323,8 +7323,8 @@
         </p:nvSpPr>
         <p:spPr>
           <a:xfrm>
-            <a:off x="6565392" y="3046566"/>
-            <a:ext cx="1920240" cy="239896"/>
+            <a:off x="6565392" y="3154142"/>
+            <a:ext cx="1920240" cy="261411"/>
           </a:xfrm>
           <a:prstGeom prst="rect">
             <a:avLst/>
@@ -7362,8 +7362,8 @@
         </p:nvSpPr>
         <p:spPr>
           <a:xfrm>
-            <a:off x="8531352" y="3111337"/>
-            <a:ext cx="181408" cy="110352"/>
+            <a:off x="8531352" y="3224723"/>
+            <a:ext cx="181408" cy="120249"/>
           </a:xfrm>
           <a:prstGeom prst="rect">
             <a:avLst/>
@@ -7382,8 +7382,8 @@
         </p:nvSpPr>
         <p:spPr>
           <a:xfrm>
-            <a:off x="10405872" y="3046566"/>
-            <a:ext cx="1097280" cy="239896"/>
+            <a:off x="10405872" y="3154142"/>
+            <a:ext cx="1097280" cy="261411"/>
           </a:xfrm>
           <a:prstGeom prst="rect">
             <a:avLst/>
@@ -7421,8 +7421,8 @@
         </p:nvSpPr>
         <p:spPr>
           <a:xfrm>
-            <a:off x="6208776" y="3286461"/>
-            <a:ext cx="310896" cy="239896"/>
+            <a:off x="6208776" y="3415553"/>
+            <a:ext cx="310896" cy="261411"/>
           </a:xfrm>
           <a:prstGeom prst="rect">
             <a:avLst/>
@@ -7460,8 +7460,8 @@
         </p:nvSpPr>
         <p:spPr>
           <a:xfrm>
-            <a:off x="6565392" y="3286461"/>
-            <a:ext cx="1920240" cy="239896"/>
+            <a:off x="6565392" y="3415553"/>
+            <a:ext cx="1920240" cy="261411"/>
           </a:xfrm>
           <a:prstGeom prst="rect">
             <a:avLst/>
@@ -7499,8 +7499,8 @@
         </p:nvSpPr>
         <p:spPr>
           <a:xfrm>
-            <a:off x="8531352" y="3351233"/>
-            <a:ext cx="157098" cy="110352"/>
+            <a:off x="8531352" y="3486134"/>
+            <a:ext cx="157098" cy="120249"/>
           </a:xfrm>
           <a:prstGeom prst="rect">
             <a:avLst/>
@@ -7519,8 +7519,8 @@
         </p:nvSpPr>
         <p:spPr>
           <a:xfrm>
-            <a:off x="10405872" y="3286461"/>
-            <a:ext cx="1097280" cy="239896"/>
+            <a:off x="10405872" y="3415553"/>
+            <a:ext cx="1097280" cy="261411"/>
           </a:xfrm>
           <a:prstGeom prst="rect">
             <a:avLst/>
@@ -7558,8 +7558,8 @@
         </p:nvSpPr>
         <p:spPr>
           <a:xfrm>
-            <a:off x="6208776" y="3526357"/>
-            <a:ext cx="310896" cy="239896"/>
+            <a:off x="6208776" y="3676964"/>
+            <a:ext cx="310896" cy="261411"/>
           </a:xfrm>
           <a:prstGeom prst="rect">
             <a:avLst/>
@@ -7597,8 +7597,8 @@
         </p:nvSpPr>
         <p:spPr>
           <a:xfrm>
-            <a:off x="6565392" y="3526357"/>
-            <a:ext cx="1920240" cy="239896"/>
+            <a:off x="6565392" y="3676964"/>
+            <a:ext cx="1920240" cy="261411"/>
           </a:xfrm>
           <a:prstGeom prst="rect">
             <a:avLst/>
@@ -7636,8 +7636,8 @@
         </p:nvSpPr>
         <p:spPr>
           <a:xfrm>
-            <a:off x="8531352" y="3591128"/>
-            <a:ext cx="152958" cy="110352"/>
+            <a:off x="8531352" y="3747545"/>
+            <a:ext cx="152958" cy="120249"/>
           </a:xfrm>
           <a:prstGeom prst="rect">
             <a:avLst/>
@@ -7656,8 +7656,8 @@
         </p:nvSpPr>
         <p:spPr>
           <a:xfrm>
-            <a:off x="10405872" y="3526357"/>
-            <a:ext cx="1097280" cy="239896"/>
+            <a:off x="10405872" y="3676964"/>
+            <a:ext cx="1097280" cy="261411"/>
           </a:xfrm>
           <a:prstGeom prst="rect">
             <a:avLst/>
@@ -7695,8 +7695,8 @@
         </p:nvSpPr>
         <p:spPr>
           <a:xfrm>
-            <a:off x="6208776" y="3766252"/>
-            <a:ext cx="310896" cy="239896"/>
+            <a:off x="6208776" y="3938375"/>
+            <a:ext cx="310896" cy="261411"/>
           </a:xfrm>
           <a:prstGeom prst="rect">
             <a:avLst/>
@@ -7734,8 +7734,8 @@
         </p:nvSpPr>
         <p:spPr>
           <a:xfrm>
-            <a:off x="6565392" y="3766252"/>
-            <a:ext cx="1920240" cy="239896"/>
+            <a:off x="6565392" y="3938375"/>
+            <a:ext cx="1920240" cy="261411"/>
           </a:xfrm>
           <a:prstGeom prst="rect">
             <a:avLst/>
@@ -7773,8 +7773,8 @@
         </p:nvSpPr>
         <p:spPr>
           <a:xfrm>
-            <a:off x="8531352" y="3831024"/>
-            <a:ext cx="145645" cy="110352"/>
+            <a:off x="8531352" y="4008956"/>
+            <a:ext cx="145645" cy="120249"/>
           </a:xfrm>
           <a:prstGeom prst="rect">
             <a:avLst/>
@@ -7793,8 +7793,8 @@
         </p:nvSpPr>
         <p:spPr>
           <a:xfrm>
-            <a:off x="10405872" y="3766252"/>
-            <a:ext cx="1097280" cy="239896"/>
+            <a:off x="10405872" y="3938375"/>
+            <a:ext cx="1097280" cy="261411"/>
           </a:xfrm>
           <a:prstGeom prst="rect">
             <a:avLst/>
@@ -7832,8 +7832,8 @@
         </p:nvSpPr>
         <p:spPr>
           <a:xfrm>
-            <a:off x="6208776" y="4006148"/>
-            <a:ext cx="310896" cy="239896"/>
+            <a:off x="6208776" y="4199785"/>
+            <a:ext cx="310896" cy="261411"/>
           </a:xfrm>
           <a:prstGeom prst="rect">
             <a:avLst/>
@@ -7871,8 +7871,8 @@
         </p:nvSpPr>
         <p:spPr>
           <a:xfrm>
-            <a:off x="6565392" y="4006148"/>
-            <a:ext cx="1920240" cy="239896"/>
+            <a:off x="6565392" y="4199785"/>
+            <a:ext cx="1920240" cy="261411"/>
           </a:xfrm>
           <a:prstGeom prst="rect">
             <a:avLst/>
@@ -7910,8 +7910,8 @@
         </p:nvSpPr>
         <p:spPr>
           <a:xfrm>
-            <a:off x="8531352" y="4070920"/>
-            <a:ext cx="142349" cy="110352"/>
+            <a:off x="8531352" y="4270366"/>
+            <a:ext cx="142349" cy="120249"/>
           </a:xfrm>
           <a:prstGeom prst="rect">
             <a:avLst/>
@@ -7930,8 +7930,8 @@
         </p:nvSpPr>
         <p:spPr>
           <a:xfrm>
-            <a:off x="10405872" y="4006148"/>
-            <a:ext cx="1097280" cy="239896"/>
+            <a:off x="10405872" y="4199785"/>
+            <a:ext cx="1097280" cy="261411"/>
           </a:xfrm>
           <a:prstGeom prst="rect">
             <a:avLst/>
@@ -7969,8 +7969,8 @@
         </p:nvSpPr>
         <p:spPr>
           <a:xfrm>
-            <a:off x="6208776" y="4246043"/>
-            <a:ext cx="310896" cy="239896"/>
+            <a:off x="6208776" y="4461196"/>
+            <a:ext cx="310896" cy="261411"/>
           </a:xfrm>
           <a:prstGeom prst="rect">
             <a:avLst/>
@@ -8008,8 +8008,8 @@
         </p:nvSpPr>
         <p:spPr>
           <a:xfrm>
-            <a:off x="6565392" y="4246043"/>
-            <a:ext cx="1920240" cy="239896"/>
+            <a:off x="6565392" y="4461196"/>
+            <a:ext cx="1920240" cy="261411"/>
           </a:xfrm>
           <a:prstGeom prst="rect">
             <a:avLst/>
@@ -8047,8 +8047,8 @@
         </p:nvSpPr>
         <p:spPr>
           <a:xfrm>
-            <a:off x="8531352" y="4310815"/>
-            <a:ext cx="122032" cy="110352"/>
+            <a:off x="8531352" y="4531777"/>
+            <a:ext cx="122032" cy="120249"/>
           </a:xfrm>
           <a:prstGeom prst="rect">
             <a:avLst/>
@@ -8067,8 +8067,8 @@
         </p:nvSpPr>
         <p:spPr>
           <a:xfrm>
-            <a:off x="10405872" y="4246043"/>
-            <a:ext cx="1097280" cy="239896"/>
+            <a:off x="10405872" y="4461196"/>
+            <a:ext cx="1097280" cy="261411"/>
           </a:xfrm>
           <a:prstGeom prst="rect">
             <a:avLst/>
@@ -8106,8 +8106,8 @@
         </p:nvSpPr>
         <p:spPr>
           <a:xfrm>
-            <a:off x="6208776" y="4485939"/>
-            <a:ext cx="310896" cy="239896"/>
+            <a:off x="6208776" y="4722607"/>
+            <a:ext cx="310896" cy="261411"/>
           </a:xfrm>
           <a:prstGeom prst="rect">
             <a:avLst/>
@@ -8145,8 +8145,8 @@
         </p:nvSpPr>
         <p:spPr>
           <a:xfrm>
-            <a:off x="6565392" y="4485939"/>
-            <a:ext cx="1920240" cy="239896"/>
+            <a:off x="6565392" y="4722607"/>
+            <a:ext cx="1920240" cy="261411"/>
           </a:xfrm>
           <a:prstGeom prst="rect">
             <a:avLst/>
@@ -8184,8 +8184,8 @@
         </p:nvSpPr>
         <p:spPr>
           <a:xfrm>
-            <a:off x="8531352" y="4550711"/>
-            <a:ext cx="118093" cy="110352"/>
+            <a:off x="8531352" y="4793188"/>
+            <a:ext cx="118093" cy="120249"/>
           </a:xfrm>
           <a:prstGeom prst="rect">
             <a:avLst/>
@@ -8204,8 +8204,8 @@
         </p:nvSpPr>
         <p:spPr>
           <a:xfrm>
-            <a:off x="10405872" y="4485939"/>
-            <a:ext cx="1097280" cy="239896"/>
+            <a:off x="10405872" y="4722607"/>
+            <a:ext cx="1097280" cy="261411"/>
           </a:xfrm>
           <a:prstGeom prst="rect">
             <a:avLst/>
@@ -8243,8 +8243,8 @@
         </p:nvSpPr>
         <p:spPr>
           <a:xfrm>
-            <a:off x="6208776" y="4725834"/>
-            <a:ext cx="310896" cy="239896"/>
+            <a:off x="6208776" y="4984018"/>
+            <a:ext cx="310896" cy="261411"/>
           </a:xfrm>
           <a:prstGeom prst="rect">
             <a:avLst/>
@@ -8282,8 +8282,8 @@
         </p:nvSpPr>
         <p:spPr>
           <a:xfrm>
-            <a:off x="6565392" y="4725834"/>
-            <a:ext cx="1920240" cy="239896"/>
+            <a:off x="6565392" y="4984018"/>
+            <a:ext cx="1920240" cy="261411"/>
           </a:xfrm>
           <a:prstGeom prst="rect">
             <a:avLst/>
@@ -8321,8 +8321,8 @@
         </p:nvSpPr>
         <p:spPr>
           <a:xfrm>
-            <a:off x="8531352" y="4790606"/>
-            <a:ext cx="115857" cy="110352"/>
+            <a:off x="8531352" y="5054599"/>
+            <a:ext cx="115857" cy="120249"/>
           </a:xfrm>
           <a:prstGeom prst="rect">
             <a:avLst/>
@@ -8341,8 +8341,8 @@
         </p:nvSpPr>
         <p:spPr>
           <a:xfrm>
-            <a:off x="10405872" y="4725834"/>
-            <a:ext cx="1097280" cy="239896"/>
+            <a:off x="10405872" y="4984018"/>
+            <a:ext cx="1097280" cy="261411"/>
           </a:xfrm>
           <a:prstGeom prst="rect">
             <a:avLst/>
@@ -8380,8 +8380,8 @@
         </p:nvSpPr>
         <p:spPr>
           <a:xfrm>
-            <a:off x="6208776" y="4965730"/>
-            <a:ext cx="310896" cy="239896"/>
+            <a:off x="6208776" y="5245429"/>
+            <a:ext cx="310896" cy="261411"/>
           </a:xfrm>
           <a:prstGeom prst="rect">
             <a:avLst/>
@@ -8419,8 +8419,8 @@
         </p:nvSpPr>
         <p:spPr>
           <a:xfrm>
-            <a:off x="6565392" y="4965730"/>
-            <a:ext cx="1920240" cy="239896"/>
+            <a:off x="6565392" y="5245429"/>
+            <a:ext cx="1920240" cy="261411"/>
           </a:xfrm>
           <a:prstGeom prst="rect">
             <a:avLst/>
@@ -8458,8 +8458,8 @@
         </p:nvSpPr>
         <p:spPr>
           <a:xfrm>
-            <a:off x="8531352" y="5030502"/>
-            <a:ext cx="111992" cy="110352"/>
+            <a:off x="8531352" y="5316010"/>
+            <a:ext cx="111992" cy="120249"/>
           </a:xfrm>
           <a:prstGeom prst="rect">
             <a:avLst/>
@@ -8478,8 +8478,8 @@
         </p:nvSpPr>
         <p:spPr>
           <a:xfrm>
-            <a:off x="10405872" y="4965730"/>
-            <a:ext cx="1097280" cy="239896"/>
+            <a:off x="10405872" y="5245429"/>
+            <a:ext cx="1097280" cy="261411"/>
           </a:xfrm>
           <a:prstGeom prst="rect">
             <a:avLst/>
@@ -8517,8 +8517,8 @@
         </p:nvSpPr>
         <p:spPr>
           <a:xfrm>
-            <a:off x="6208776" y="5205625"/>
-            <a:ext cx="310896" cy="239896"/>
+            <a:off x="6208776" y="5506840"/>
+            <a:ext cx="310896" cy="261411"/>
           </a:xfrm>
           <a:prstGeom prst="rect">
             <a:avLst/>
@@ -8556,8 +8556,8 @@
         </p:nvSpPr>
         <p:spPr>
           <a:xfrm>
-            <a:off x="6565392" y="5205625"/>
-            <a:ext cx="1920240" cy="239896"/>
+            <a:off x="6565392" y="5506840"/>
+            <a:ext cx="1920240" cy="261411"/>
           </a:xfrm>
           <a:prstGeom prst="rect">
             <a:avLst/>
@@ -8595,8 +8595,8 @@
         </p:nvSpPr>
         <p:spPr>
           <a:xfrm>
-            <a:off x="8531352" y="5270397"/>
-            <a:ext cx="76952" cy="110352"/>
+            <a:off x="8531352" y="5577420"/>
+            <a:ext cx="76952" cy="120249"/>
           </a:xfrm>
           <a:prstGeom prst="rect">
             <a:avLst/>
@@ -8615,8 +8615,8 @@
         </p:nvSpPr>
         <p:spPr>
           <a:xfrm>
-            <a:off x="10405872" y="5205625"/>
-            <a:ext cx="1097280" cy="239896"/>
+            <a:off x="10405872" y="5506840"/>
+            <a:ext cx="1097280" cy="261411"/>
           </a:xfrm>
           <a:prstGeom prst="rect">
             <a:avLst/>
@@ -8654,8 +8654,8 @@
         </p:nvSpPr>
         <p:spPr>
           <a:xfrm>
-            <a:off x="6208776" y="5445521"/>
-            <a:ext cx="310896" cy="239896"/>
+            <a:off x="6208776" y="5768250"/>
+            <a:ext cx="310896" cy="261411"/>
           </a:xfrm>
           <a:prstGeom prst="rect">
             <a:avLst/>
@@ -8693,8 +8693,8 @@
         </p:nvSpPr>
         <p:spPr>
           <a:xfrm>
-            <a:off x="6565392" y="5445521"/>
-            <a:ext cx="1920240" cy="239896"/>
+            <a:off x="6565392" y="5768250"/>
+            <a:ext cx="1920240" cy="261411"/>
           </a:xfrm>
           <a:prstGeom prst="rect">
             <a:avLst/>
@@ -8732,8 +8732,8 @@
         </p:nvSpPr>
         <p:spPr>
           <a:xfrm>
-            <a:off x="8531352" y="5510293"/>
-            <a:ext cx="76698" cy="110352"/>
+            <a:off x="8531352" y="5838831"/>
+            <a:ext cx="76698" cy="120249"/>
           </a:xfrm>
           <a:prstGeom prst="rect">
             <a:avLst/>
@@ -8752,8 +8752,8 @@
         </p:nvSpPr>
         <p:spPr>
           <a:xfrm>
-            <a:off x="10405872" y="5445521"/>
-            <a:ext cx="1097280" cy="239896"/>
+            <a:off x="10405872" y="5768250"/>
+            <a:ext cx="1097280" cy="261411"/>
           </a:xfrm>
           <a:prstGeom prst="rect">
             <a:avLst/>
@@ -8792,7 +8792,7 @@
         <p:spPr>
           <a:xfrm>
             <a:off x="6085332" y="1847088"/>
-            <a:ext cx="10973" cy="4078224"/>
+            <a:ext cx="10973" cy="4443984"/>
           </a:xfrm>
           <a:prstGeom prst="rect">
             <a:avLst/>
@@ -8802,65 +8802,6 @@
           </a:solidFill>
           <a:ln/>
         </p:spPr>
-      </p:sp>
-      <p:sp>
-        <p:nvSpPr>
-          <p:cNvPr id="144" name="Shape 142"/>
-          <p:cNvSpPr/>
-          <p:nvPr/>
-        </p:nvSpPr>
-        <p:spPr>
-          <a:xfrm>
-            <a:off x="457200" y="6126480"/>
-            <a:ext cx="11274552" cy="371856"/>
-          </a:xfrm>
-          <a:prstGeom prst="rect">
-            <a:avLst/>
-          </a:prstGeom>
-          <a:solidFill>
-            <a:srgbClr val="EDF4FA"/>
-          </a:solidFill>
-          <a:ln/>
-        </p:spPr>
-      </p:sp>
-      <p:sp>
-        <p:nvSpPr>
-          <p:cNvPr id="145" name="Text 143"/>
-          <p:cNvSpPr txBox="1"/>
-          <p:nvPr/>
-        </p:nvSpPr>
-        <p:spPr>
-          <a:xfrm>
-            <a:off x="658368" y="6144768"/>
-            <a:ext cx="10927080" cy="335280"/>
-          </a:xfrm>
-          <a:prstGeom prst="rect">
-            <a:avLst/>
-          </a:prstGeom>
-          <a:noFill/>
-          <a:ln/>
-        </p:spPr>
-        <p:txBody>
-          <a:bodyPr wrap="square" lIns="0" tIns="0" rIns="0" bIns="0" rtlCol="0" anchor="ctr"/>
-          <a:lstStyle/>
-          <a:p>
-            <a:pPr indent="0" marL="0">
-              <a:buNone/>
-            </a:pPr>
-            <a:r>
-              <a:rPr lang="en-US" sz="1600" b="1" dirty="0">
-                <a:solidFill>
-                  <a:srgbClr val="0B2C4A"/>
-                </a:solidFill>
-                <a:latin typeface="Inter" pitchFamily="34" charset="0"/>
-                <a:ea typeface="Inter" pitchFamily="34" charset="-122"/>
-                <a:cs typeface="Inter" pitchFamily="34" charset="-120"/>
-              </a:rPr>
-              <a:t>Toyota Henderson leads at 78,123; VW St George is smallest at 3,276.</a:t>
-            </a:r>
-            <a:endParaRPr lang="en-US" sz="1600" dirty="0"/>
-          </a:p>
-        </p:txBody>
       </p:sp>
     </p:spTree>
   </p:cSld>
@@ -9001,7 +8942,7 @@
         <p:spPr>
           <a:xfrm>
             <a:off x="457200" y="1207008"/>
-            <a:ext cx="11274552" cy="4782312"/>
+            <a:ext cx="11274552" cy="5148072"/>
           </a:xfrm>
           <a:prstGeom prst="rect">
             <a:avLst/>
@@ -9178,7 +9119,7 @@
         <p:spPr>
           <a:xfrm>
             <a:off x="658368" y="1847088"/>
-            <a:ext cx="310896" cy="239896"/>
+            <a:ext cx="310896" cy="261411"/>
           </a:xfrm>
           <a:prstGeom prst="rect">
             <a:avLst/>
@@ -9217,7 +9158,7 @@
         <p:spPr>
           <a:xfrm>
             <a:off x="1014984" y="1847088"/>
-            <a:ext cx="1920240" cy="239896"/>
+            <a:ext cx="1920240" cy="261411"/>
           </a:xfrm>
           <a:prstGeom prst="rect">
             <a:avLst/>
@@ -9255,8 +9196,8 @@
         </p:nvSpPr>
         <p:spPr>
           <a:xfrm>
-            <a:off x="3785616" y="1911860"/>
-            <a:ext cx="777240" cy="110352"/>
+            <a:off x="3785616" y="1917669"/>
+            <a:ext cx="777240" cy="120249"/>
           </a:xfrm>
           <a:prstGeom prst="rect">
             <a:avLst/>
@@ -9276,7 +9217,7 @@
         <p:spPr>
           <a:xfrm>
             <a:off x="4617720" y="1847088"/>
-            <a:ext cx="1234440" cy="239896"/>
+            <a:ext cx="1234440" cy="261411"/>
           </a:xfrm>
           <a:prstGeom prst="rect">
             <a:avLst/>
@@ -9314,8 +9255,8 @@
         </p:nvSpPr>
         <p:spPr>
           <a:xfrm>
-            <a:off x="658368" y="2086984"/>
-            <a:ext cx="310896" cy="239896"/>
+            <a:off x="658368" y="2108499"/>
+            <a:ext cx="310896" cy="261411"/>
           </a:xfrm>
           <a:prstGeom prst="rect">
             <a:avLst/>
@@ -9353,8 +9294,8 @@
         </p:nvSpPr>
         <p:spPr>
           <a:xfrm>
-            <a:off x="1014984" y="2086984"/>
-            <a:ext cx="1920240" cy="239896"/>
+            <a:off x="1014984" y="2108499"/>
+            <a:ext cx="1920240" cy="261411"/>
           </a:xfrm>
           <a:prstGeom prst="rect">
             <a:avLst/>
@@ -9392,8 +9333,8 @@
         </p:nvSpPr>
         <p:spPr>
           <a:xfrm>
-            <a:off x="3785616" y="2151755"/>
-            <a:ext cx="608749" cy="110352"/>
+            <a:off x="3785616" y="2179080"/>
+            <a:ext cx="608749" cy="120249"/>
           </a:xfrm>
           <a:prstGeom prst="rect">
             <a:avLst/>
@@ -9412,8 +9353,8 @@
         </p:nvSpPr>
         <p:spPr>
           <a:xfrm>
-            <a:off x="4617720" y="2086984"/>
-            <a:ext cx="1234440" cy="239896"/>
+            <a:off x="4617720" y="2108499"/>
+            <a:ext cx="1234440" cy="261411"/>
           </a:xfrm>
           <a:prstGeom prst="rect">
             <a:avLst/>
@@ -9451,8 +9392,8 @@
         </p:nvSpPr>
         <p:spPr>
           <a:xfrm>
-            <a:off x="658368" y="2326879"/>
-            <a:ext cx="310896" cy="239896"/>
+            <a:off x="658368" y="2369910"/>
+            <a:ext cx="310896" cy="261411"/>
           </a:xfrm>
           <a:prstGeom prst="rect">
             <a:avLst/>
@@ -9490,8 +9431,8 @@
         </p:nvSpPr>
         <p:spPr>
           <a:xfrm>
-            <a:off x="1014984" y="2326879"/>
-            <a:ext cx="1920240" cy="239896"/>
+            <a:off x="1014984" y="2369910"/>
+            <a:ext cx="1920240" cy="261411"/>
           </a:xfrm>
           <a:prstGeom prst="rect">
             <a:avLst/>
@@ -9529,8 +9470,8 @@
         </p:nvSpPr>
         <p:spPr>
           <a:xfrm>
-            <a:off x="3785616" y="2391651"/>
-            <a:ext cx="589865" cy="110352"/>
+            <a:off x="3785616" y="2440491"/>
+            <a:ext cx="589865" cy="120249"/>
           </a:xfrm>
           <a:prstGeom prst="rect">
             <a:avLst/>
@@ -9549,8 +9490,8 @@
         </p:nvSpPr>
         <p:spPr>
           <a:xfrm>
-            <a:off x="4617720" y="2326879"/>
-            <a:ext cx="1234440" cy="239896"/>
+            <a:off x="4617720" y="2369910"/>
+            <a:ext cx="1234440" cy="261411"/>
           </a:xfrm>
           <a:prstGeom prst="rect">
             <a:avLst/>
@@ -9588,8 +9529,8 @@
         </p:nvSpPr>
         <p:spPr>
           <a:xfrm>
-            <a:off x="658368" y="2566775"/>
-            <a:ext cx="310896" cy="239896"/>
+            <a:off x="658368" y="2631320"/>
+            <a:ext cx="310896" cy="261411"/>
           </a:xfrm>
           <a:prstGeom prst="rect">
             <a:avLst/>
@@ -9627,8 +9568,8 @@
         </p:nvSpPr>
         <p:spPr>
           <a:xfrm>
-            <a:off x="1014984" y="2566775"/>
-            <a:ext cx="1920240" cy="239896"/>
+            <a:off x="1014984" y="2631320"/>
+            <a:ext cx="1920240" cy="261411"/>
           </a:xfrm>
           <a:prstGeom prst="rect">
             <a:avLst/>
@@ -9666,8 +9607,8 @@
         </p:nvSpPr>
         <p:spPr>
           <a:xfrm>
-            <a:off x="3785616" y="2631546"/>
-            <a:ext cx="502608" cy="110352"/>
+            <a:off x="3785616" y="2701901"/>
+            <a:ext cx="502608" cy="120249"/>
           </a:xfrm>
           <a:prstGeom prst="rect">
             <a:avLst/>
@@ -9686,8 +9627,8 @@
         </p:nvSpPr>
         <p:spPr>
           <a:xfrm>
-            <a:off x="4617720" y="2566775"/>
-            <a:ext cx="1234440" cy="239896"/>
+            <a:off x="4617720" y="2631320"/>
+            <a:ext cx="1234440" cy="261411"/>
           </a:xfrm>
           <a:prstGeom prst="rect">
             <a:avLst/>
@@ -9725,8 +9666,8 @@
         </p:nvSpPr>
         <p:spPr>
           <a:xfrm>
-            <a:off x="658368" y="2806670"/>
-            <a:ext cx="310896" cy="239896"/>
+            <a:off x="658368" y="2892731"/>
+            <a:ext cx="310896" cy="261411"/>
           </a:xfrm>
           <a:prstGeom prst="rect">
             <a:avLst/>
@@ -9764,8 +9705,8 @@
         </p:nvSpPr>
         <p:spPr>
           <a:xfrm>
-            <a:off x="1014984" y="2806670"/>
-            <a:ext cx="1920240" cy="239896"/>
+            <a:off x="1014984" y="2892731"/>
+            <a:ext cx="1920240" cy="261411"/>
           </a:xfrm>
           <a:prstGeom prst="rect">
             <a:avLst/>
@@ -9803,8 +9744,8 @@
         </p:nvSpPr>
         <p:spPr>
           <a:xfrm>
-            <a:off x="3785616" y="2871442"/>
-            <a:ext cx="489520" cy="110352"/>
+            <a:off x="3785616" y="2963312"/>
+            <a:ext cx="489520" cy="120249"/>
           </a:xfrm>
           <a:prstGeom prst="rect">
             <a:avLst/>
@@ -9823,8 +9764,8 @@
         </p:nvSpPr>
         <p:spPr>
           <a:xfrm>
-            <a:off x="4617720" y="2806670"/>
-            <a:ext cx="1234440" cy="239896"/>
+            <a:off x="4617720" y="2892731"/>
+            <a:ext cx="1234440" cy="261411"/>
           </a:xfrm>
           <a:prstGeom prst="rect">
             <a:avLst/>
@@ -9862,8 +9803,8 @@
         </p:nvSpPr>
         <p:spPr>
           <a:xfrm>
-            <a:off x="658368" y="3046566"/>
-            <a:ext cx="310896" cy="239896"/>
+            <a:off x="658368" y="3154142"/>
+            <a:ext cx="310896" cy="261411"/>
           </a:xfrm>
           <a:prstGeom prst="rect">
             <a:avLst/>
@@ -9901,8 +9842,8 @@
         </p:nvSpPr>
         <p:spPr>
           <a:xfrm>
-            <a:off x="1014984" y="3046566"/>
-            <a:ext cx="1920240" cy="239896"/>
+            <a:off x="1014984" y="3154142"/>
+            <a:ext cx="1920240" cy="261411"/>
           </a:xfrm>
           <a:prstGeom prst="rect">
             <a:avLst/>
@@ -9940,8 +9881,8 @@
         </p:nvSpPr>
         <p:spPr>
           <a:xfrm>
-            <a:off x="3785616" y="3111337"/>
-            <a:ext cx="475887" cy="110352"/>
+            <a:off x="3785616" y="3224723"/>
+            <a:ext cx="475887" cy="120249"/>
           </a:xfrm>
           <a:prstGeom prst="rect">
             <a:avLst/>
@@ -9960,8 +9901,8 @@
         </p:nvSpPr>
         <p:spPr>
           <a:xfrm>
-            <a:off x="4617720" y="3046566"/>
-            <a:ext cx="1234440" cy="239896"/>
+            <a:off x="4617720" y="3154142"/>
+            <a:ext cx="1234440" cy="261411"/>
           </a:xfrm>
           <a:prstGeom prst="rect">
             <a:avLst/>
@@ -9999,8 +9940,8 @@
         </p:nvSpPr>
         <p:spPr>
           <a:xfrm>
-            <a:off x="658368" y="3286461"/>
-            <a:ext cx="310896" cy="239896"/>
+            <a:off x="658368" y="3415553"/>
+            <a:ext cx="310896" cy="261411"/>
           </a:xfrm>
           <a:prstGeom prst="rect">
             <a:avLst/>
@@ -10038,8 +9979,8 @@
         </p:nvSpPr>
         <p:spPr>
           <a:xfrm>
-            <a:off x="1014984" y="3286461"/>
-            <a:ext cx="1920240" cy="239896"/>
+            <a:off x="1014984" y="3415553"/>
+            <a:ext cx="1920240" cy="261411"/>
           </a:xfrm>
           <a:prstGeom prst="rect">
             <a:avLst/>
@@ -10077,8 +10018,8 @@
         </p:nvSpPr>
         <p:spPr>
           <a:xfrm>
-            <a:off x="3785616" y="3351233"/>
-            <a:ext cx="403394" cy="110352"/>
+            <a:off x="3785616" y="3486134"/>
+            <a:ext cx="403394" cy="120249"/>
           </a:xfrm>
           <a:prstGeom prst="rect">
             <a:avLst/>
@@ -10097,8 +10038,8 @@
         </p:nvSpPr>
         <p:spPr>
           <a:xfrm>
-            <a:off x="4617720" y="3286461"/>
-            <a:ext cx="1234440" cy="239896"/>
+            <a:off x="4617720" y="3415553"/>
+            <a:ext cx="1234440" cy="261411"/>
           </a:xfrm>
           <a:prstGeom prst="rect">
             <a:avLst/>
@@ -10136,8 +10077,8 @@
         </p:nvSpPr>
         <p:spPr>
           <a:xfrm>
-            <a:off x="658368" y="3526357"/>
-            <a:ext cx="310896" cy="239896"/>
+            <a:off x="658368" y="3676964"/>
+            <a:ext cx="310896" cy="261411"/>
           </a:xfrm>
           <a:prstGeom prst="rect">
             <a:avLst/>
@@ -10175,8 +10116,8 @@
         </p:nvSpPr>
         <p:spPr>
           <a:xfrm>
-            <a:off x="1014984" y="3526357"/>
-            <a:ext cx="1920240" cy="239896"/>
+            <a:off x="1014984" y="3676964"/>
+            <a:ext cx="1920240" cy="261411"/>
           </a:xfrm>
           <a:prstGeom prst="rect">
             <a:avLst/>
@@ -10214,8 +10155,8 @@
         </p:nvSpPr>
         <p:spPr>
           <a:xfrm>
-            <a:off x="3785616" y="3591128"/>
-            <a:ext cx="320015" cy="110352"/>
+            <a:off x="3785616" y="3747545"/>
+            <a:ext cx="320015" cy="120249"/>
           </a:xfrm>
           <a:prstGeom prst="rect">
             <a:avLst/>
@@ -10234,8 +10175,8 @@
         </p:nvSpPr>
         <p:spPr>
           <a:xfrm>
-            <a:off x="4617720" y="3526357"/>
-            <a:ext cx="1234440" cy="239896"/>
+            <a:off x="4617720" y="3676964"/>
+            <a:ext cx="1234440" cy="261411"/>
           </a:xfrm>
           <a:prstGeom prst="rect">
             <a:avLst/>
@@ -10273,8 +10214,8 @@
         </p:nvSpPr>
         <p:spPr>
           <a:xfrm>
-            <a:off x="658368" y="3766252"/>
-            <a:ext cx="310896" cy="239896"/>
+            <a:off x="658368" y="3938375"/>
+            <a:ext cx="310896" cy="261411"/>
           </a:xfrm>
           <a:prstGeom prst="rect">
             <a:avLst/>
@@ -10312,8 +10253,8 @@
         </p:nvSpPr>
         <p:spPr>
           <a:xfrm>
-            <a:off x="1014984" y="3766252"/>
-            <a:ext cx="1920240" cy="239896"/>
+            <a:off x="1014984" y="3938375"/>
+            <a:ext cx="1920240" cy="261411"/>
           </a:xfrm>
           <a:prstGeom prst="rect">
             <a:avLst/>
@@ -10351,8 +10292,8 @@
         </p:nvSpPr>
         <p:spPr>
           <a:xfrm>
-            <a:off x="3785616" y="3831024"/>
-            <a:ext cx="319802" cy="110352"/>
+            <a:off x="3785616" y="4008956"/>
+            <a:ext cx="319802" cy="120249"/>
           </a:xfrm>
           <a:prstGeom prst="rect">
             <a:avLst/>
@@ -10371,8 +10312,8 @@
         </p:nvSpPr>
         <p:spPr>
           <a:xfrm>
-            <a:off x="4617720" y="3766252"/>
-            <a:ext cx="1234440" cy="239896"/>
+            <a:off x="4617720" y="3938375"/>
+            <a:ext cx="1234440" cy="261411"/>
           </a:xfrm>
           <a:prstGeom prst="rect">
             <a:avLst/>
@@ -10410,8 +10351,8 @@
         </p:nvSpPr>
         <p:spPr>
           <a:xfrm>
-            <a:off x="658368" y="4006148"/>
-            <a:ext cx="310896" cy="239896"/>
+            <a:off x="658368" y="4199785"/>
+            <a:ext cx="310896" cy="261411"/>
           </a:xfrm>
           <a:prstGeom prst="rect">
             <a:avLst/>
@@ -10449,8 +10390,8 @@
         </p:nvSpPr>
         <p:spPr>
           <a:xfrm>
-            <a:off x="1014984" y="4006148"/>
-            <a:ext cx="1920240" cy="239896"/>
+            <a:off x="1014984" y="4199785"/>
+            <a:ext cx="1920240" cy="261411"/>
           </a:xfrm>
           <a:prstGeom prst="rect">
             <a:avLst/>
@@ -10488,8 +10429,8 @@
         </p:nvSpPr>
         <p:spPr>
           <a:xfrm>
-            <a:off x="3785616" y="4070920"/>
-            <a:ext cx="304780" cy="110352"/>
+            <a:off x="3785616" y="4270366"/>
+            <a:ext cx="304780" cy="120249"/>
           </a:xfrm>
           <a:prstGeom prst="rect">
             <a:avLst/>
@@ -10508,8 +10449,8 @@
         </p:nvSpPr>
         <p:spPr>
           <a:xfrm>
-            <a:off x="4617720" y="4006148"/>
-            <a:ext cx="1234440" cy="239896"/>
+            <a:off x="4617720" y="4199785"/>
+            <a:ext cx="1234440" cy="261411"/>
           </a:xfrm>
           <a:prstGeom prst="rect">
             <a:avLst/>
@@ -10547,8 +10488,8 @@
         </p:nvSpPr>
         <p:spPr>
           <a:xfrm>
-            <a:off x="658368" y="4246043"/>
-            <a:ext cx="310896" cy="239896"/>
+            <a:off x="658368" y="4461196"/>
+            <a:ext cx="310896" cy="261411"/>
           </a:xfrm>
           <a:prstGeom prst="rect">
             <a:avLst/>
@@ -10586,8 +10527,8 @@
         </p:nvSpPr>
         <p:spPr>
           <a:xfrm>
-            <a:off x="1014984" y="4246043"/>
-            <a:ext cx="1920240" cy="239896"/>
+            <a:off x="1014984" y="4461196"/>
+            <a:ext cx="1920240" cy="261411"/>
           </a:xfrm>
           <a:prstGeom prst="rect">
             <a:avLst/>
@@ -10625,8 +10566,8 @@
         </p:nvSpPr>
         <p:spPr>
           <a:xfrm>
-            <a:off x="3785616" y="4310815"/>
-            <a:ext cx="214987" cy="110352"/>
+            <a:off x="3785616" y="4531777"/>
+            <a:ext cx="214987" cy="120249"/>
           </a:xfrm>
           <a:prstGeom prst="rect">
             <a:avLst/>
@@ -10645,8 +10586,8 @@
         </p:nvSpPr>
         <p:spPr>
           <a:xfrm>
-            <a:off x="4617720" y="4246043"/>
-            <a:ext cx="1234440" cy="239896"/>
+            <a:off x="4617720" y="4461196"/>
+            <a:ext cx="1234440" cy="261411"/>
           </a:xfrm>
           <a:prstGeom prst="rect">
             <a:avLst/>
@@ -10684,8 +10625,8 @@
         </p:nvSpPr>
         <p:spPr>
           <a:xfrm>
-            <a:off x="658368" y="4485939"/>
-            <a:ext cx="310896" cy="239896"/>
+            <a:off x="658368" y="4722607"/>
+            <a:ext cx="310896" cy="261411"/>
           </a:xfrm>
           <a:prstGeom prst="rect">
             <a:avLst/>
@@ -10723,8 +10664,8 @@
         </p:nvSpPr>
         <p:spPr>
           <a:xfrm>
-            <a:off x="1014984" y="4485939"/>
-            <a:ext cx="1920240" cy="239896"/>
+            <a:off x="1014984" y="4722607"/>
+            <a:ext cx="1920240" cy="261411"/>
           </a:xfrm>
           <a:prstGeom prst="rect">
             <a:avLst/>
@@ -10762,8 +10703,8 @@
         </p:nvSpPr>
         <p:spPr>
           <a:xfrm>
-            <a:off x="3785616" y="4550711"/>
-            <a:ext cx="207215" cy="110352"/>
+            <a:off x="3785616" y="4793188"/>
+            <a:ext cx="207215" cy="120249"/>
           </a:xfrm>
           <a:prstGeom prst="rect">
             <a:avLst/>
@@ -10782,8 +10723,8 @@
         </p:nvSpPr>
         <p:spPr>
           <a:xfrm>
-            <a:off x="4617720" y="4485939"/>
-            <a:ext cx="1234440" cy="239896"/>
+            <a:off x="4617720" y="4722607"/>
+            <a:ext cx="1234440" cy="261411"/>
           </a:xfrm>
           <a:prstGeom prst="rect">
             <a:avLst/>
@@ -10821,8 +10762,8 @@
         </p:nvSpPr>
         <p:spPr>
           <a:xfrm>
-            <a:off x="658368" y="4725834"/>
-            <a:ext cx="310896" cy="239896"/>
+            <a:off x="658368" y="4984018"/>
+            <a:ext cx="310896" cy="261411"/>
           </a:xfrm>
           <a:prstGeom prst="rect">
             <a:avLst/>
@@ -10860,8 +10801,8 @@
         </p:nvSpPr>
         <p:spPr>
           <a:xfrm>
-            <a:off x="1014984" y="4725834"/>
-            <a:ext cx="1920240" cy="239896"/>
+            <a:off x="1014984" y="4984018"/>
+            <a:ext cx="1920240" cy="261411"/>
           </a:xfrm>
           <a:prstGeom prst="rect">
             <a:avLst/>
@@ -10899,8 +10840,8 @@
         </p:nvSpPr>
         <p:spPr>
           <a:xfrm>
-            <a:off x="3785616" y="4790606"/>
-            <a:ext cx="187159" cy="110352"/>
+            <a:off x="3785616" y="5054599"/>
+            <a:ext cx="187159" cy="120249"/>
           </a:xfrm>
           <a:prstGeom prst="rect">
             <a:avLst/>
@@ -10919,8 +10860,8 @@
         </p:nvSpPr>
         <p:spPr>
           <a:xfrm>
-            <a:off x="4617720" y="4725834"/>
-            <a:ext cx="1234440" cy="239896"/>
+            <a:off x="4617720" y="4984018"/>
+            <a:ext cx="1234440" cy="261411"/>
           </a:xfrm>
           <a:prstGeom prst="rect">
             <a:avLst/>
@@ -10958,8 +10899,8 @@
         </p:nvSpPr>
         <p:spPr>
           <a:xfrm>
-            <a:off x="658368" y="4965730"/>
-            <a:ext cx="310896" cy="239896"/>
+            <a:off x="658368" y="5245429"/>
+            <a:ext cx="310896" cy="261411"/>
           </a:xfrm>
           <a:prstGeom prst="rect">
             <a:avLst/>
@@ -10997,8 +10938,8 @@
         </p:nvSpPr>
         <p:spPr>
           <a:xfrm>
-            <a:off x="1014984" y="4965730"/>
-            <a:ext cx="1920240" cy="239896"/>
+            <a:off x="1014984" y="5245429"/>
+            <a:ext cx="1920240" cy="261411"/>
           </a:xfrm>
           <a:prstGeom prst="rect">
             <a:avLst/>
@@ -11036,8 +10977,8 @@
         </p:nvSpPr>
         <p:spPr>
           <a:xfrm>
-            <a:off x="3785616" y="5030502"/>
-            <a:ext cx="172129" cy="110352"/>
+            <a:off x="3785616" y="5316010"/>
+            <a:ext cx="172129" cy="120249"/>
           </a:xfrm>
           <a:prstGeom prst="rect">
             <a:avLst/>
@@ -11056,8 +10997,8 @@
         </p:nvSpPr>
         <p:spPr>
           <a:xfrm>
-            <a:off x="4617720" y="4965730"/>
-            <a:ext cx="1234440" cy="239896"/>
+            <a:off x="4617720" y="5245429"/>
+            <a:ext cx="1234440" cy="261411"/>
           </a:xfrm>
           <a:prstGeom prst="rect">
             <a:avLst/>
@@ -11095,8 +11036,8 @@
         </p:nvSpPr>
         <p:spPr>
           <a:xfrm>
-            <a:off x="658368" y="5205625"/>
-            <a:ext cx="310896" cy="239896"/>
+            <a:off x="658368" y="5506840"/>
+            <a:ext cx="310896" cy="261411"/>
           </a:xfrm>
           <a:prstGeom prst="rect">
             <a:avLst/>
@@ -11134,8 +11075,8 @@
         </p:nvSpPr>
         <p:spPr>
           <a:xfrm>
-            <a:off x="1014984" y="5205625"/>
-            <a:ext cx="1920240" cy="239896"/>
+            <a:off x="1014984" y="5506840"/>
+            <a:ext cx="1920240" cy="261411"/>
           </a:xfrm>
           <a:prstGeom prst="rect">
             <a:avLst/>
@@ -11173,8 +11114,8 @@
         </p:nvSpPr>
         <p:spPr>
           <a:xfrm>
-            <a:off x="3785616" y="5270397"/>
-            <a:ext cx="116744" cy="110352"/>
+            <a:off x="3785616" y="5577420"/>
+            <a:ext cx="116744" cy="120249"/>
           </a:xfrm>
           <a:prstGeom prst="rect">
             <a:avLst/>
@@ -11193,8 +11134,8 @@
         </p:nvSpPr>
         <p:spPr>
           <a:xfrm>
-            <a:off x="4617720" y="5205625"/>
-            <a:ext cx="1234440" cy="239896"/>
+            <a:off x="4617720" y="5506840"/>
+            <a:ext cx="1234440" cy="261411"/>
           </a:xfrm>
           <a:prstGeom prst="rect">
             <a:avLst/>
@@ -11232,8 +11173,8 @@
         </p:nvSpPr>
         <p:spPr>
           <a:xfrm>
-            <a:off x="658368" y="5445521"/>
-            <a:ext cx="310896" cy="239896"/>
+            <a:off x="658368" y="5768250"/>
+            <a:ext cx="310896" cy="261411"/>
           </a:xfrm>
           <a:prstGeom prst="rect">
             <a:avLst/>
@@ -11271,8 +11212,8 @@
         </p:nvSpPr>
         <p:spPr>
           <a:xfrm>
-            <a:off x="1014984" y="5445521"/>
-            <a:ext cx="1920240" cy="239896"/>
+            <a:off x="1014984" y="5768250"/>
+            <a:ext cx="1920240" cy="261411"/>
           </a:xfrm>
           <a:prstGeom prst="rect">
             <a:avLst/>
@@ -11310,8 +11251,8 @@
         </p:nvSpPr>
         <p:spPr>
           <a:xfrm>
-            <a:off x="3785616" y="5510293"/>
-            <a:ext cx="116682" cy="110352"/>
+            <a:off x="3785616" y="5838831"/>
+            <a:ext cx="116682" cy="120249"/>
           </a:xfrm>
           <a:prstGeom prst="rect">
             <a:avLst/>
@@ -11330,8 +11271,8 @@
         </p:nvSpPr>
         <p:spPr>
           <a:xfrm>
-            <a:off x="4617720" y="5445521"/>
-            <a:ext cx="1234440" cy="239896"/>
+            <a:off x="4617720" y="5768250"/>
+            <a:ext cx="1234440" cy="261411"/>
           </a:xfrm>
           <a:prstGeom prst="rect">
             <a:avLst/>
@@ -11369,8 +11310,8 @@
         </p:nvSpPr>
         <p:spPr>
           <a:xfrm>
-            <a:off x="658368" y="5685416"/>
-            <a:ext cx="310896" cy="239896"/>
+            <a:off x="658368" y="6029661"/>
+            <a:ext cx="310896" cy="261411"/>
           </a:xfrm>
           <a:prstGeom prst="rect">
             <a:avLst/>
@@ -11408,8 +11349,8 @@
         </p:nvSpPr>
         <p:spPr>
           <a:xfrm>
-            <a:off x="1014984" y="5685416"/>
-            <a:ext cx="1920240" cy="239896"/>
+            <a:off x="1014984" y="6029661"/>
+            <a:ext cx="1920240" cy="261411"/>
           </a:xfrm>
           <a:prstGeom prst="rect">
             <a:avLst/>
@@ -11447,8 +11388,8 @@
         </p:nvSpPr>
         <p:spPr>
           <a:xfrm>
-            <a:off x="3785616" y="5750188"/>
-            <a:ext cx="116417" cy="110352"/>
+            <a:off x="3785616" y="6100242"/>
+            <a:ext cx="116417" cy="120249"/>
           </a:xfrm>
           <a:prstGeom prst="rect">
             <a:avLst/>
@@ -11467,8 +11408,8 @@
         </p:nvSpPr>
         <p:spPr>
           <a:xfrm>
-            <a:off x="4617720" y="5685416"/>
-            <a:ext cx="1234440" cy="239896"/>
+            <a:off x="4617720" y="6029661"/>
+            <a:ext cx="1234440" cy="261411"/>
           </a:xfrm>
           <a:prstGeom prst="rect">
             <a:avLst/>
@@ -11507,7 +11448,7 @@
         <p:spPr>
           <a:xfrm>
             <a:off x="6208776" y="1847088"/>
-            <a:ext cx="310896" cy="239896"/>
+            <a:ext cx="310896" cy="261411"/>
           </a:xfrm>
           <a:prstGeom prst="rect">
             <a:avLst/>
@@ -11546,7 +11487,7 @@
         <p:spPr>
           <a:xfrm>
             <a:off x="6565392" y="1847088"/>
-            <a:ext cx="1920240" cy="239896"/>
+            <a:ext cx="1920240" cy="261411"/>
           </a:xfrm>
           <a:prstGeom prst="rect">
             <a:avLst/>
@@ -11584,8 +11525,8 @@
         </p:nvSpPr>
         <p:spPr>
           <a:xfrm>
-            <a:off x="9336024" y="1911860"/>
-            <a:ext cx="106340" cy="110352"/>
+            <a:off x="9336024" y="1917669"/>
+            <a:ext cx="106340" cy="120249"/>
           </a:xfrm>
           <a:prstGeom prst="rect">
             <a:avLst/>
@@ -11605,7 +11546,7 @@
         <p:spPr>
           <a:xfrm>
             <a:off x="10168128" y="1847088"/>
-            <a:ext cx="1234440" cy="239896"/>
+            <a:ext cx="1234440" cy="261411"/>
           </a:xfrm>
           <a:prstGeom prst="rect">
             <a:avLst/>
@@ -11643,8 +11584,8 @@
         </p:nvSpPr>
         <p:spPr>
           <a:xfrm>
-            <a:off x="6208776" y="2086984"/>
-            <a:ext cx="310896" cy="239896"/>
+            <a:off x="6208776" y="2108499"/>
+            <a:ext cx="310896" cy="261411"/>
           </a:xfrm>
           <a:prstGeom prst="rect">
             <a:avLst/>
@@ -11682,8 +11623,8 @@
         </p:nvSpPr>
         <p:spPr>
           <a:xfrm>
-            <a:off x="6565392" y="2086984"/>
-            <a:ext cx="1920240" cy="239896"/>
+            <a:off x="6565392" y="2108499"/>
+            <a:ext cx="1920240" cy="261411"/>
           </a:xfrm>
           <a:prstGeom prst="rect">
             <a:avLst/>
@@ -11721,8 +11662,8 @@
         </p:nvSpPr>
         <p:spPr>
           <a:xfrm>
-            <a:off x="9336024" y="2151755"/>
-            <a:ext cx="99982" cy="110352"/>
+            <a:off x="9336024" y="2179080"/>
+            <a:ext cx="99982" cy="120249"/>
           </a:xfrm>
           <a:prstGeom prst="rect">
             <a:avLst/>
@@ -11741,8 +11682,8 @@
         </p:nvSpPr>
         <p:spPr>
           <a:xfrm>
-            <a:off x="10168128" y="2086984"/>
-            <a:ext cx="1234440" cy="239896"/>
+            <a:off x="10168128" y="2108499"/>
+            <a:ext cx="1234440" cy="261411"/>
           </a:xfrm>
           <a:prstGeom prst="rect">
             <a:avLst/>
@@ -11780,8 +11721,8 @@
         </p:nvSpPr>
         <p:spPr>
           <a:xfrm>
-            <a:off x="6208776" y="2326879"/>
-            <a:ext cx="310896" cy="239896"/>
+            <a:off x="6208776" y="2369910"/>
+            <a:ext cx="310896" cy="261411"/>
           </a:xfrm>
           <a:prstGeom prst="rect">
             <a:avLst/>
@@ -11819,8 +11760,8 @@
         </p:nvSpPr>
         <p:spPr>
           <a:xfrm>
-            <a:off x="6565392" y="2326879"/>
-            <a:ext cx="1920240" cy="239896"/>
+            <a:off x="6565392" y="2369910"/>
+            <a:ext cx="1920240" cy="261411"/>
           </a:xfrm>
           <a:prstGeom prst="rect">
             <a:avLst/>
@@ -11858,8 +11799,8 @@
         </p:nvSpPr>
         <p:spPr>
           <a:xfrm>
-            <a:off x="9336024" y="2391651"/>
-            <a:ext cx="89045" cy="110352"/>
+            <a:off x="9336024" y="2440491"/>
+            <a:ext cx="89045" cy="120249"/>
           </a:xfrm>
           <a:prstGeom prst="rect">
             <a:avLst/>
@@ -11878,8 +11819,8 @@
         </p:nvSpPr>
         <p:spPr>
           <a:xfrm>
-            <a:off x="10168128" y="2326879"/>
-            <a:ext cx="1234440" cy="239896"/>
+            <a:off x="10168128" y="2369910"/>
+            <a:ext cx="1234440" cy="261411"/>
           </a:xfrm>
           <a:prstGeom prst="rect">
             <a:avLst/>
@@ -11917,8 +11858,8 @@
         </p:nvSpPr>
         <p:spPr>
           <a:xfrm>
-            <a:off x="6208776" y="2566775"/>
-            <a:ext cx="310896" cy="239896"/>
+            <a:off x="6208776" y="2631320"/>
+            <a:ext cx="310896" cy="261411"/>
           </a:xfrm>
           <a:prstGeom prst="rect">
             <a:avLst/>
@@ -11956,8 +11897,8 @@
         </p:nvSpPr>
         <p:spPr>
           <a:xfrm>
-            <a:off x="6565392" y="2566775"/>
-            <a:ext cx="1920240" cy="239896"/>
+            <a:off x="6565392" y="2631320"/>
+            <a:ext cx="1920240" cy="261411"/>
           </a:xfrm>
           <a:prstGeom prst="rect">
             <a:avLst/>
@@ -11995,8 +11936,8 @@
         </p:nvSpPr>
         <p:spPr>
           <a:xfrm>
-            <a:off x="9336024" y="2631546"/>
-            <a:ext cx="88806" cy="110352"/>
+            <a:off x="9336024" y="2701901"/>
+            <a:ext cx="88806" cy="120249"/>
           </a:xfrm>
           <a:prstGeom prst="rect">
             <a:avLst/>
@@ -12015,8 +11956,8 @@
         </p:nvSpPr>
         <p:spPr>
           <a:xfrm>
-            <a:off x="10168128" y="2566775"/>
-            <a:ext cx="1234440" cy="239896"/>
+            <a:off x="10168128" y="2631320"/>
+            <a:ext cx="1234440" cy="261411"/>
           </a:xfrm>
           <a:prstGeom prst="rect">
             <a:avLst/>
@@ -12054,8 +11995,8 @@
         </p:nvSpPr>
         <p:spPr>
           <a:xfrm>
-            <a:off x="6208776" y="2806670"/>
-            <a:ext cx="310896" cy="239896"/>
+            <a:off x="6208776" y="2892731"/>
+            <a:ext cx="310896" cy="261411"/>
           </a:xfrm>
           <a:prstGeom prst="rect">
             <a:avLst/>
@@ -12093,8 +12034,8 @@
         </p:nvSpPr>
         <p:spPr>
           <a:xfrm>
-            <a:off x="6565392" y="2806670"/>
-            <a:ext cx="1920240" cy="239896"/>
+            <a:off x="6565392" y="2892731"/>
+            <a:ext cx="1920240" cy="261411"/>
           </a:xfrm>
           <a:prstGeom prst="rect">
             <a:avLst/>
@@ -12132,8 +12073,8 @@
         </p:nvSpPr>
         <p:spPr>
           <a:xfrm>
-            <a:off x="9336024" y="2871442"/>
-            <a:ext cx="12802" cy="110352"/>
+            <a:off x="9336024" y="2963312"/>
+            <a:ext cx="12802" cy="120249"/>
           </a:xfrm>
           <a:prstGeom prst="rect">
             <a:avLst/>
@@ -12152,8 +12093,8 @@
         </p:nvSpPr>
         <p:spPr>
           <a:xfrm>
-            <a:off x="10168128" y="2806670"/>
-            <a:ext cx="1234440" cy="239896"/>
+            <a:off x="10168128" y="2892731"/>
+            <a:ext cx="1234440" cy="261411"/>
           </a:xfrm>
           <a:prstGeom prst="rect">
             <a:avLst/>
@@ -12191,8 +12132,8 @@
         </p:nvSpPr>
         <p:spPr>
           <a:xfrm>
-            <a:off x="6208776" y="3046566"/>
-            <a:ext cx="310896" cy="239896"/>
+            <a:off x="6208776" y="3154142"/>
+            <a:ext cx="310896" cy="261411"/>
           </a:xfrm>
           <a:prstGeom prst="rect">
             <a:avLst/>
@@ -12230,8 +12171,8 @@
         </p:nvSpPr>
         <p:spPr>
           <a:xfrm>
-            <a:off x="6565392" y="3046566"/>
-            <a:ext cx="1920240" cy="239896"/>
+            <a:off x="6565392" y="3154142"/>
+            <a:ext cx="1920240" cy="261411"/>
           </a:xfrm>
           <a:prstGeom prst="rect">
             <a:avLst/>
@@ -12269,8 +12210,8 @@
         </p:nvSpPr>
         <p:spPr>
           <a:xfrm>
-            <a:off x="9336024" y="3111337"/>
-            <a:ext cx="12802" cy="110352"/>
+            <a:off x="9336024" y="3224723"/>
+            <a:ext cx="12802" cy="120249"/>
           </a:xfrm>
           <a:prstGeom prst="rect">
             <a:avLst/>
@@ -12289,8 +12230,8 @@
         </p:nvSpPr>
         <p:spPr>
           <a:xfrm>
-            <a:off x="10168128" y="3046566"/>
-            <a:ext cx="1234440" cy="239896"/>
+            <a:off x="10168128" y="3154142"/>
+            <a:ext cx="1234440" cy="261411"/>
           </a:xfrm>
           <a:prstGeom prst="rect">
             <a:avLst/>
@@ -12328,8 +12269,8 @@
         </p:nvSpPr>
         <p:spPr>
           <a:xfrm>
-            <a:off x="6208776" y="3286461"/>
-            <a:ext cx="310896" cy="239896"/>
+            <a:off x="6208776" y="3415553"/>
+            <a:ext cx="310896" cy="261411"/>
           </a:xfrm>
           <a:prstGeom prst="rect">
             <a:avLst/>
@@ -12367,8 +12308,8 @@
         </p:nvSpPr>
         <p:spPr>
           <a:xfrm>
-            <a:off x="6565392" y="3286461"/>
-            <a:ext cx="1920240" cy="239896"/>
+            <a:off x="6565392" y="3415553"/>
+            <a:ext cx="1920240" cy="261411"/>
           </a:xfrm>
           <a:prstGeom prst="rect">
             <a:avLst/>
@@ -12406,8 +12347,8 @@
         </p:nvSpPr>
         <p:spPr>
           <a:xfrm>
-            <a:off x="9306237" y="3351233"/>
-            <a:ext cx="29787" cy="110352"/>
+            <a:off x="9306237" y="3486134"/>
+            <a:ext cx="29787" cy="120249"/>
           </a:xfrm>
           <a:prstGeom prst="rect">
             <a:avLst/>
@@ -12426,8 +12367,8 @@
         </p:nvSpPr>
         <p:spPr>
           <a:xfrm>
-            <a:off x="10168128" y="3286461"/>
-            <a:ext cx="1234440" cy="239896"/>
+            <a:off x="10168128" y="3415553"/>
+            <a:ext cx="1234440" cy="261411"/>
           </a:xfrm>
           <a:prstGeom prst="rect">
             <a:avLst/>
@@ -12465,8 +12406,8 @@
         </p:nvSpPr>
         <p:spPr>
           <a:xfrm>
-            <a:off x="6208776" y="3526357"/>
-            <a:ext cx="310896" cy="239896"/>
+            <a:off x="6208776" y="3676964"/>
+            <a:ext cx="310896" cy="261411"/>
           </a:xfrm>
           <a:prstGeom prst="rect">
             <a:avLst/>
@@ -12504,8 +12445,8 @@
         </p:nvSpPr>
         <p:spPr>
           <a:xfrm>
-            <a:off x="6565392" y="3526357"/>
-            <a:ext cx="1920240" cy="239896"/>
+            <a:off x="6565392" y="3676964"/>
+            <a:ext cx="1920240" cy="261411"/>
           </a:xfrm>
           <a:prstGeom prst="rect">
             <a:avLst/>
@@ -12543,8 +12484,8 @@
         </p:nvSpPr>
         <p:spPr>
           <a:xfrm>
-            <a:off x="9291402" y="3591128"/>
-            <a:ext cx="44622" cy="110352"/>
+            <a:off x="9291402" y="3747545"/>
+            <a:ext cx="44622" cy="120249"/>
           </a:xfrm>
           <a:prstGeom prst="rect">
             <a:avLst/>
@@ -12563,8 +12504,8 @@
         </p:nvSpPr>
         <p:spPr>
           <a:xfrm>
-            <a:off x="10168128" y="3526357"/>
-            <a:ext cx="1234440" cy="239896"/>
+            <a:off x="10168128" y="3676964"/>
+            <a:ext cx="1234440" cy="261411"/>
           </a:xfrm>
           <a:prstGeom prst="rect">
             <a:avLst/>
@@ -12602,8 +12543,8 @@
         </p:nvSpPr>
         <p:spPr>
           <a:xfrm>
-            <a:off x="6208776" y="3766252"/>
-            <a:ext cx="310896" cy="239896"/>
+            <a:off x="6208776" y="3938375"/>
+            <a:ext cx="310896" cy="261411"/>
           </a:xfrm>
           <a:prstGeom prst="rect">
             <a:avLst/>
@@ -12641,8 +12582,8 @@
         </p:nvSpPr>
         <p:spPr>
           <a:xfrm>
-            <a:off x="6565392" y="3766252"/>
-            <a:ext cx="1920240" cy="239896"/>
+            <a:off x="6565392" y="3938375"/>
+            <a:ext cx="1920240" cy="261411"/>
           </a:xfrm>
           <a:prstGeom prst="rect">
             <a:avLst/>
@@ -12680,8 +12621,8 @@
         </p:nvSpPr>
         <p:spPr>
           <a:xfrm>
-            <a:off x="9285327" y="3831024"/>
-            <a:ext cx="50697" cy="110352"/>
+            <a:off x="9285327" y="4008956"/>
+            <a:ext cx="50697" cy="120249"/>
           </a:xfrm>
           <a:prstGeom prst="rect">
             <a:avLst/>
@@ -12700,8 +12641,8 @@
         </p:nvSpPr>
         <p:spPr>
           <a:xfrm>
-            <a:off x="10168128" y="3766252"/>
-            <a:ext cx="1234440" cy="239896"/>
+            <a:off x="10168128" y="3938375"/>
+            <a:ext cx="1234440" cy="261411"/>
           </a:xfrm>
           <a:prstGeom prst="rect">
             <a:avLst/>
@@ -12739,8 +12680,8 @@
         </p:nvSpPr>
         <p:spPr>
           <a:xfrm>
-            <a:off x="6208776" y="4006148"/>
-            <a:ext cx="310896" cy="239896"/>
+            <a:off x="6208776" y="4199785"/>
+            <a:ext cx="310896" cy="261411"/>
           </a:xfrm>
           <a:prstGeom prst="rect">
             <a:avLst/>
@@ -12778,8 +12719,8 @@
         </p:nvSpPr>
         <p:spPr>
           <a:xfrm>
-            <a:off x="6565392" y="4006148"/>
-            <a:ext cx="1920240" cy="239896"/>
+            <a:off x="6565392" y="4199785"/>
+            <a:ext cx="1920240" cy="261411"/>
           </a:xfrm>
           <a:prstGeom prst="rect">
             <a:avLst/>
@@ -12817,8 +12758,8 @@
         </p:nvSpPr>
         <p:spPr>
           <a:xfrm>
-            <a:off x="9275488" y="4070920"/>
-            <a:ext cx="60536" cy="110352"/>
+            <a:off x="9275488" y="4270366"/>
+            <a:ext cx="60536" cy="120249"/>
           </a:xfrm>
           <a:prstGeom prst="rect">
             <a:avLst/>
@@ -12837,8 +12778,8 @@
         </p:nvSpPr>
         <p:spPr>
           <a:xfrm>
-            <a:off x="10168128" y="4006148"/>
-            <a:ext cx="1234440" cy="239896"/>
+            <a:off x="10168128" y="4199785"/>
+            <a:ext cx="1234440" cy="261411"/>
           </a:xfrm>
           <a:prstGeom prst="rect">
             <a:avLst/>
@@ -12876,8 +12817,8 @@
         </p:nvSpPr>
         <p:spPr>
           <a:xfrm>
-            <a:off x="6208776" y="4246043"/>
-            <a:ext cx="310896" cy="239896"/>
+            <a:off x="6208776" y="4461196"/>
+            <a:ext cx="310896" cy="261411"/>
           </a:xfrm>
           <a:prstGeom prst="rect">
             <a:avLst/>
@@ -12915,8 +12856,8 @@
         </p:nvSpPr>
         <p:spPr>
           <a:xfrm>
-            <a:off x="6565392" y="4246043"/>
-            <a:ext cx="1920240" cy="239896"/>
+            <a:off x="6565392" y="4461196"/>
+            <a:ext cx="1920240" cy="261411"/>
           </a:xfrm>
           <a:prstGeom prst="rect">
             <a:avLst/>
@@ -12954,8 +12895,8 @@
         </p:nvSpPr>
         <p:spPr>
           <a:xfrm>
-            <a:off x="9233370" y="4310815"/>
-            <a:ext cx="102654" cy="110352"/>
+            <a:off x="9233370" y="4531777"/>
+            <a:ext cx="102654" cy="120249"/>
           </a:xfrm>
           <a:prstGeom prst="rect">
             <a:avLst/>
@@ -12974,8 +12915,8 @@
         </p:nvSpPr>
         <p:spPr>
           <a:xfrm>
-            <a:off x="10168128" y="4246043"/>
-            <a:ext cx="1234440" cy="239896"/>
+            <a:off x="10168128" y="4461196"/>
+            <a:ext cx="1234440" cy="261411"/>
           </a:xfrm>
           <a:prstGeom prst="rect">
             <a:avLst/>
@@ -13013,8 +12954,8 @@
         </p:nvSpPr>
         <p:spPr>
           <a:xfrm>
-            <a:off x="6208776" y="4485939"/>
-            <a:ext cx="310896" cy="239896"/>
+            <a:off x="6208776" y="4722607"/>
+            <a:ext cx="310896" cy="261411"/>
           </a:xfrm>
           <a:prstGeom prst="rect">
             <a:avLst/>
@@ -13052,8 +12993,8 @@
         </p:nvSpPr>
         <p:spPr>
           <a:xfrm>
-            <a:off x="6565392" y="4485939"/>
-            <a:ext cx="1920240" cy="239896"/>
+            <a:off x="6565392" y="4722607"/>
+            <a:ext cx="1920240" cy="261411"/>
           </a:xfrm>
           <a:prstGeom prst="rect">
             <a:avLst/>
@@ -13091,8 +13032,8 @@
         </p:nvSpPr>
         <p:spPr>
           <a:xfrm>
-            <a:off x="9206595" y="4550711"/>
-            <a:ext cx="129429" cy="110352"/>
+            <a:off x="9206595" y="4793188"/>
+            <a:ext cx="129429" cy="120249"/>
           </a:xfrm>
           <a:prstGeom prst="rect">
             <a:avLst/>
@@ -13111,8 +13052,8 @@
         </p:nvSpPr>
         <p:spPr>
           <a:xfrm>
-            <a:off x="10168128" y="4485939"/>
-            <a:ext cx="1234440" cy="239896"/>
+            <a:off x="10168128" y="4722607"/>
+            <a:ext cx="1234440" cy="261411"/>
           </a:xfrm>
           <a:prstGeom prst="rect">
             <a:avLst/>
@@ -13150,8 +13091,8 @@
         </p:nvSpPr>
         <p:spPr>
           <a:xfrm>
-            <a:off x="6208776" y="4725834"/>
-            <a:ext cx="310896" cy="239896"/>
+            <a:off x="6208776" y="4984018"/>
+            <a:ext cx="310896" cy="261411"/>
           </a:xfrm>
           <a:prstGeom prst="rect">
             <a:avLst/>
@@ -13189,8 +13130,8 @@
         </p:nvSpPr>
         <p:spPr>
           <a:xfrm>
-            <a:off x="6565392" y="4725834"/>
-            <a:ext cx="1920240" cy="239896"/>
+            <a:off x="6565392" y="4984018"/>
+            <a:ext cx="1920240" cy="261411"/>
           </a:xfrm>
           <a:prstGeom prst="rect">
             <a:avLst/>
@@ -13228,8 +13169,8 @@
         </p:nvSpPr>
         <p:spPr>
           <a:xfrm>
-            <a:off x="9193818" y="4790606"/>
-            <a:ext cx="142206" cy="110352"/>
+            <a:off x="9193818" y="5054599"/>
+            <a:ext cx="142206" cy="120249"/>
           </a:xfrm>
           <a:prstGeom prst="rect">
             <a:avLst/>
@@ -13248,8 +13189,8 @@
         </p:nvSpPr>
         <p:spPr>
           <a:xfrm>
-            <a:off x="10168128" y="4725834"/>
-            <a:ext cx="1234440" cy="239896"/>
+            <a:off x="10168128" y="4984018"/>
+            <a:ext cx="1234440" cy="261411"/>
           </a:xfrm>
           <a:prstGeom prst="rect">
             <a:avLst/>
@@ -13287,8 +13228,8 @@
         </p:nvSpPr>
         <p:spPr>
           <a:xfrm>
-            <a:off x="6208776" y="4965730"/>
-            <a:ext cx="310896" cy="239896"/>
+            <a:off x="6208776" y="5245429"/>
+            <a:ext cx="310896" cy="261411"/>
           </a:xfrm>
           <a:prstGeom prst="rect">
             <a:avLst/>
@@ -13326,8 +13267,8 @@
         </p:nvSpPr>
         <p:spPr>
           <a:xfrm>
-            <a:off x="6565392" y="4965730"/>
-            <a:ext cx="1920240" cy="239896"/>
+            <a:off x="6565392" y="5245429"/>
+            <a:ext cx="1920240" cy="261411"/>
           </a:xfrm>
           <a:prstGeom prst="rect">
             <a:avLst/>
@@ -13365,8 +13306,8 @@
         </p:nvSpPr>
         <p:spPr>
           <a:xfrm>
-            <a:off x="9153034" y="5030502"/>
-            <a:ext cx="182990" cy="110352"/>
+            <a:off x="9153034" y="5316010"/>
+            <a:ext cx="182990" cy="120249"/>
           </a:xfrm>
           <a:prstGeom prst="rect">
             <a:avLst/>
@@ -13385,8 +13326,8 @@
         </p:nvSpPr>
         <p:spPr>
           <a:xfrm>
-            <a:off x="10168128" y="4965730"/>
-            <a:ext cx="1234440" cy="239896"/>
+            <a:off x="10168128" y="5245429"/>
+            <a:ext cx="1234440" cy="261411"/>
           </a:xfrm>
           <a:prstGeom prst="rect">
             <a:avLst/>
@@ -13424,8 +13365,8 @@
         </p:nvSpPr>
         <p:spPr>
           <a:xfrm>
-            <a:off x="6208776" y="5205625"/>
-            <a:ext cx="310896" cy="239896"/>
+            <a:off x="6208776" y="5506840"/>
+            <a:ext cx="310896" cy="261411"/>
           </a:xfrm>
           <a:prstGeom prst="rect">
             <a:avLst/>
@@ -13463,8 +13404,8 @@
         </p:nvSpPr>
         <p:spPr>
           <a:xfrm>
-            <a:off x="6565392" y="5205625"/>
-            <a:ext cx="1920240" cy="239896"/>
+            <a:off x="6565392" y="5506840"/>
+            <a:ext cx="1920240" cy="261411"/>
           </a:xfrm>
           <a:prstGeom prst="rect">
             <a:avLst/>
@@ -13502,8 +13443,8 @@
         </p:nvSpPr>
         <p:spPr>
           <a:xfrm>
-            <a:off x="9069849" y="5270397"/>
-            <a:ext cx="266175" cy="110352"/>
+            <a:off x="9069849" y="5577420"/>
+            <a:ext cx="266175" cy="120249"/>
           </a:xfrm>
           <a:prstGeom prst="rect">
             <a:avLst/>
@@ -13522,8 +13463,8 @@
         </p:nvSpPr>
         <p:spPr>
           <a:xfrm>
-            <a:off x="10168128" y="5205625"/>
-            <a:ext cx="1234440" cy="239896"/>
+            <a:off x="10168128" y="5506840"/>
+            <a:ext cx="1234440" cy="261411"/>
           </a:xfrm>
           <a:prstGeom prst="rect">
             <a:avLst/>
@@ -13561,8 +13502,8 @@
         </p:nvSpPr>
         <p:spPr>
           <a:xfrm>
-            <a:off x="6208776" y="5445521"/>
-            <a:ext cx="310896" cy="239896"/>
+            <a:off x="6208776" y="5768250"/>
+            <a:ext cx="310896" cy="261411"/>
           </a:xfrm>
           <a:prstGeom prst="rect">
             <a:avLst/>
@@ -13600,8 +13541,8 @@
         </p:nvSpPr>
         <p:spPr>
           <a:xfrm>
-            <a:off x="6565392" y="5445521"/>
-            <a:ext cx="1920240" cy="239896"/>
+            <a:off x="6565392" y="5768250"/>
+            <a:ext cx="1920240" cy="261411"/>
           </a:xfrm>
           <a:prstGeom prst="rect">
             <a:avLst/>
@@ -13639,8 +13580,8 @@
         </p:nvSpPr>
         <p:spPr>
           <a:xfrm>
-            <a:off x="8892903" y="5510293"/>
-            <a:ext cx="443121" cy="110352"/>
+            <a:off x="8892903" y="5838831"/>
+            <a:ext cx="443121" cy="120249"/>
           </a:xfrm>
           <a:prstGeom prst="rect">
             <a:avLst/>
@@ -13659,8 +13600,8 @@
         </p:nvSpPr>
         <p:spPr>
           <a:xfrm>
-            <a:off x="10168128" y="5445521"/>
-            <a:ext cx="1234440" cy="239896"/>
+            <a:off x="10168128" y="5768250"/>
+            <a:ext cx="1234440" cy="261411"/>
           </a:xfrm>
           <a:prstGeom prst="rect">
             <a:avLst/>
@@ -13699,7 +13640,7 @@
         <p:spPr>
           <a:xfrm>
             <a:off x="3780130" y="1847088"/>
-            <a:ext cx="10973" cy="4078224"/>
+            <a:ext cx="10973" cy="4443984"/>
           </a:xfrm>
           <a:prstGeom prst="rect">
             <a:avLst/>
@@ -13719,7 +13660,7 @@
         <p:spPr>
           <a:xfrm>
             <a:off x="9330538" y="1847088"/>
-            <a:ext cx="10973" cy="4078224"/>
+            <a:ext cx="10973" cy="4443984"/>
           </a:xfrm>
           <a:prstGeom prst="rect">
             <a:avLst/>
@@ -13739,7 +13680,7 @@
         <p:spPr>
           <a:xfrm>
             <a:off x="6085332" y="1847088"/>
-            <a:ext cx="10973" cy="4078224"/>
+            <a:ext cx="10973" cy="4443984"/>
           </a:xfrm>
           <a:prstGeom prst="rect">
             <a:avLst/>
@@ -13749,65 +13690,6 @@
           </a:solidFill>
           <a:ln/>
         </p:spPr>
-      </p:sp>
-      <p:sp>
-        <p:nvSpPr>
-          <p:cNvPr id="146" name="Shape 144"/>
-          <p:cNvSpPr/>
-          <p:nvPr/>
-        </p:nvSpPr>
-        <p:spPr>
-          <a:xfrm>
-            <a:off x="457200" y="6126480"/>
-            <a:ext cx="11274552" cy="615696"/>
-          </a:xfrm>
-          <a:prstGeom prst="rect">
-            <a:avLst/>
-          </a:prstGeom>
-          <a:solidFill>
-            <a:srgbClr val="E6F6EE"/>
-          </a:solidFill>
-          <a:ln/>
-        </p:spPr>
-      </p:sp>
-      <p:sp>
-        <p:nvSpPr>
-          <p:cNvPr id="147" name="Text 145"/>
-          <p:cNvSpPr txBox="1"/>
-          <p:nvPr/>
-        </p:nvSpPr>
-        <p:spPr>
-          <a:xfrm>
-            <a:off x="658368" y="6144768"/>
-            <a:ext cx="10927080" cy="579120"/>
-          </a:xfrm>
-          <a:prstGeom prst="rect">
-            <a:avLst/>
-          </a:prstGeom>
-          <a:noFill/>
-          <a:ln/>
-        </p:spPr>
-        <p:txBody>
-          <a:bodyPr wrap="square" lIns="0" tIns="0" rIns="0" bIns="0" rtlCol="0" anchor="ctr"/>
-          <a:lstStyle/>
-          <a:p>
-            <a:pPr indent="0" marL="0">
-              <a:buNone/>
-            </a:pPr>
-            <a:r>
-              <a:rPr lang="en-US" sz="1600" b="1" dirty="0">
-                <a:solidFill>
-                  <a:srgbClr val="0B7A4A"/>
-                </a:solidFill>
-                <a:latin typeface="Inter" pitchFamily="34" charset="0"/>
-                <a:ea typeface="Inter" pitchFamily="34" charset="-122"/>
-                <a:cs typeface="Inter" pitchFamily="34" charset="-120"/>
-              </a:rPr>
-              <a:t>23 of 33 stores sold more CP hours, led by Subaru St George at +44.6% to 12,766. 10 declined; VW St George fell most at −25.4%.</a:t>
-            </a:r>
-            <a:endParaRPr lang="en-US" sz="1600" dirty="0"/>
-          </a:p>
-        </p:txBody>
       </p:sp>
     </p:spTree>
   </p:cSld>
@@ -13948,7 +13830,7 @@
         <p:spPr>
           <a:xfrm>
             <a:off x="457200" y="1207008"/>
-            <a:ext cx="11274552" cy="4782312"/>
+            <a:ext cx="11274552" cy="5148072"/>
           </a:xfrm>
           <a:prstGeom prst="rect">
             <a:avLst/>
@@ -14066,7 +13948,7 @@
         <p:spPr>
           <a:xfrm>
             <a:off x="658368" y="2103120"/>
-            <a:ext cx="3489960" cy="755294"/>
+            <a:ext cx="3489960" cy="828446"/>
           </a:xfrm>
           <a:prstGeom prst="rect">
             <a:avLst/>
@@ -14086,7 +13968,7 @@
         <p:spPr>
           <a:xfrm>
             <a:off x="749808" y="2103120"/>
-            <a:ext cx="365760" cy="755294"/>
+            <a:ext cx="365760" cy="828446"/>
           </a:xfrm>
           <a:prstGeom prst="rect">
             <a:avLst/>
@@ -14125,7 +14007,7 @@
         <p:spPr>
           <a:xfrm>
             <a:off x="1097280" y="2103120"/>
-            <a:ext cx="1825752" cy="755294"/>
+            <a:ext cx="1825752" cy="828446"/>
           </a:xfrm>
           <a:prstGeom prst="rect">
             <a:avLst/>
@@ -14204,7 +14086,7 @@
         <p:spPr>
           <a:xfrm>
             <a:off x="2941320" y="2103120"/>
-            <a:ext cx="1115568" cy="755294"/>
+            <a:ext cx="1115568" cy="828446"/>
           </a:xfrm>
           <a:prstGeom prst="rect">
             <a:avLst/>
@@ -14242,8 +14124,8 @@
         </p:nvSpPr>
         <p:spPr>
           <a:xfrm>
-            <a:off x="749808" y="2858414"/>
-            <a:ext cx="365760" cy="755294"/>
+            <a:off x="749808" y="2931566"/>
+            <a:ext cx="365760" cy="828446"/>
           </a:xfrm>
           <a:prstGeom prst="rect">
             <a:avLst/>
@@ -14281,8 +14163,8 @@
         </p:nvSpPr>
         <p:spPr>
           <a:xfrm>
-            <a:off x="1097280" y="2858414"/>
-            <a:ext cx="1825752" cy="755294"/>
+            <a:off x="1097280" y="2931566"/>
+            <a:ext cx="1825752" cy="828446"/>
           </a:xfrm>
           <a:prstGeom prst="rect">
             <a:avLst/>
@@ -14360,8 +14242,8 @@
         </p:nvSpPr>
         <p:spPr>
           <a:xfrm>
-            <a:off x="2941320" y="2858414"/>
-            <a:ext cx="1115568" cy="755294"/>
+            <a:off x="2941320" y="2931566"/>
+            <a:ext cx="1115568" cy="828446"/>
           </a:xfrm>
           <a:prstGeom prst="rect">
             <a:avLst/>
@@ -14399,8 +14281,8 @@
         </p:nvSpPr>
         <p:spPr>
           <a:xfrm>
-            <a:off x="658368" y="3613709"/>
-            <a:ext cx="3489960" cy="755294"/>
+            <a:off x="658368" y="3760013"/>
+            <a:ext cx="3489960" cy="828446"/>
           </a:xfrm>
           <a:prstGeom prst="rect">
             <a:avLst/>
@@ -14419,8 +14301,8 @@
         </p:nvSpPr>
         <p:spPr>
           <a:xfrm>
-            <a:off x="4084320" y="3650285"/>
-            <a:ext cx="64008" cy="682142"/>
+            <a:off x="4084320" y="3796589"/>
+            <a:ext cx="64008" cy="755294"/>
           </a:xfrm>
           <a:prstGeom prst="rect">
             <a:avLst/>
@@ -14439,8 +14321,8 @@
         </p:nvSpPr>
         <p:spPr>
           <a:xfrm>
-            <a:off x="749808" y="3613709"/>
-            <a:ext cx="365760" cy="755294"/>
+            <a:off x="749808" y="3760013"/>
+            <a:ext cx="365760" cy="828446"/>
           </a:xfrm>
           <a:prstGeom prst="rect">
             <a:avLst/>
@@ -14478,8 +14360,8 @@
         </p:nvSpPr>
         <p:spPr>
           <a:xfrm>
-            <a:off x="1097280" y="3613709"/>
-            <a:ext cx="1825752" cy="755294"/>
+            <a:off x="1097280" y="3760013"/>
+            <a:ext cx="1825752" cy="828446"/>
           </a:xfrm>
           <a:prstGeom prst="rect">
             <a:avLst/>
@@ -14557,8 +14439,8 @@
         </p:nvSpPr>
         <p:spPr>
           <a:xfrm>
-            <a:off x="2941320" y="3613709"/>
-            <a:ext cx="1115568" cy="755294"/>
+            <a:off x="2941320" y="3760013"/>
+            <a:ext cx="1115568" cy="828446"/>
           </a:xfrm>
           <a:prstGeom prst="rect">
             <a:avLst/>
@@ -14596,8 +14478,8 @@
         </p:nvSpPr>
         <p:spPr>
           <a:xfrm>
-            <a:off x="749808" y="4369003"/>
-            <a:ext cx="365760" cy="755294"/>
+            <a:off x="749808" y="4588459"/>
+            <a:ext cx="365760" cy="828446"/>
           </a:xfrm>
           <a:prstGeom prst="rect">
             <a:avLst/>
@@ -14635,8 +14517,8 @@
         </p:nvSpPr>
         <p:spPr>
           <a:xfrm>
-            <a:off x="1097280" y="4369003"/>
-            <a:ext cx="1825752" cy="755294"/>
+            <a:off x="1097280" y="4588459"/>
+            <a:ext cx="1825752" cy="828446"/>
           </a:xfrm>
           <a:prstGeom prst="rect">
             <a:avLst/>
@@ -14714,8 +14596,8 @@
         </p:nvSpPr>
         <p:spPr>
           <a:xfrm>
-            <a:off x="2941320" y="4369003"/>
-            <a:ext cx="1115568" cy="755294"/>
+            <a:off x="2941320" y="4588459"/>
+            <a:ext cx="1115568" cy="828446"/>
           </a:xfrm>
           <a:prstGeom prst="rect">
             <a:avLst/>
@@ -14753,8 +14635,8 @@
         </p:nvSpPr>
         <p:spPr>
           <a:xfrm>
-            <a:off x="658368" y="5124298"/>
-            <a:ext cx="3489960" cy="755294"/>
+            <a:off x="658368" y="5416906"/>
+            <a:ext cx="3489960" cy="828446"/>
           </a:xfrm>
           <a:prstGeom prst="rect">
             <a:avLst/>
@@ -14773,8 +14655,8 @@
         </p:nvSpPr>
         <p:spPr>
           <a:xfrm>
-            <a:off x="749808" y="5124298"/>
-            <a:ext cx="365760" cy="755294"/>
+            <a:off x="749808" y="5416906"/>
+            <a:ext cx="365760" cy="828446"/>
           </a:xfrm>
           <a:prstGeom prst="rect">
             <a:avLst/>
@@ -14812,8 +14694,8 @@
         </p:nvSpPr>
         <p:spPr>
           <a:xfrm>
-            <a:off x="1097280" y="5124298"/>
-            <a:ext cx="1825752" cy="755294"/>
+            <a:off x="1097280" y="5416906"/>
+            <a:ext cx="1825752" cy="828446"/>
           </a:xfrm>
           <a:prstGeom prst="rect">
             <a:avLst/>
@@ -14891,8 +14773,8 @@
         </p:nvSpPr>
         <p:spPr>
           <a:xfrm>
-            <a:off x="2941320" y="5124298"/>
-            <a:ext cx="1115568" cy="755294"/>
+            <a:off x="2941320" y="5416906"/>
+            <a:ext cx="1115568" cy="828446"/>
           </a:xfrm>
           <a:prstGeom prst="rect">
             <a:avLst/>
@@ -15029,7 +14911,7 @@
         <p:spPr>
           <a:xfrm>
             <a:off x="4349496" y="2103120"/>
-            <a:ext cx="3489960" cy="755294"/>
+            <a:ext cx="3489960" cy="828446"/>
           </a:xfrm>
           <a:prstGeom prst="rect">
             <a:avLst/>
@@ -15049,7 +14931,7 @@
         <p:spPr>
           <a:xfrm>
             <a:off x="4440936" y="2103120"/>
-            <a:ext cx="365760" cy="755294"/>
+            <a:ext cx="365760" cy="828446"/>
           </a:xfrm>
           <a:prstGeom prst="rect">
             <a:avLst/>
@@ -15088,7 +14970,7 @@
         <p:spPr>
           <a:xfrm>
             <a:off x="4788408" y="2103120"/>
-            <a:ext cx="1825752" cy="755294"/>
+            <a:ext cx="1825752" cy="828446"/>
           </a:xfrm>
           <a:prstGeom prst="rect">
             <a:avLst/>
@@ -15167,7 +15049,7 @@
         <p:spPr>
           <a:xfrm>
             <a:off x="6632448" y="2103120"/>
-            <a:ext cx="1115568" cy="755294"/>
+            <a:ext cx="1115568" cy="828446"/>
           </a:xfrm>
           <a:prstGeom prst="rect">
             <a:avLst/>
@@ -15205,8 +15087,8 @@
         </p:nvSpPr>
         <p:spPr>
           <a:xfrm>
-            <a:off x="4440936" y="2858414"/>
-            <a:ext cx="365760" cy="755294"/>
+            <a:off x="4440936" y="2931566"/>
+            <a:ext cx="365760" cy="828446"/>
           </a:xfrm>
           <a:prstGeom prst="rect">
             <a:avLst/>
@@ -15244,8 +15126,8 @@
         </p:nvSpPr>
         <p:spPr>
           <a:xfrm>
-            <a:off x="4788408" y="2858414"/>
-            <a:ext cx="1825752" cy="755294"/>
+            <a:off x="4788408" y="2931566"/>
+            <a:ext cx="1825752" cy="828446"/>
           </a:xfrm>
           <a:prstGeom prst="rect">
             <a:avLst/>
@@ -15323,8 +15205,8 @@
         </p:nvSpPr>
         <p:spPr>
           <a:xfrm>
-            <a:off x="6632448" y="2858414"/>
-            <a:ext cx="1115568" cy="755294"/>
+            <a:off x="6632448" y="2931566"/>
+            <a:ext cx="1115568" cy="828446"/>
           </a:xfrm>
           <a:prstGeom prst="rect">
             <a:avLst/>
@@ -15362,8 +15244,8 @@
         </p:nvSpPr>
         <p:spPr>
           <a:xfrm>
-            <a:off x="4349496" y="3613709"/>
-            <a:ext cx="3489960" cy="755294"/>
+            <a:off x="4349496" y="3760013"/>
+            <a:ext cx="3489960" cy="828446"/>
           </a:xfrm>
           <a:prstGeom prst="rect">
             <a:avLst/>
@@ -15382,8 +15264,8 @@
         </p:nvSpPr>
         <p:spPr>
           <a:xfrm>
-            <a:off x="4440936" y="3613709"/>
-            <a:ext cx="365760" cy="755294"/>
+            <a:off x="4440936" y="3760013"/>
+            <a:ext cx="365760" cy="828446"/>
           </a:xfrm>
           <a:prstGeom prst="rect">
             <a:avLst/>
@@ -15421,8 +15303,8 @@
         </p:nvSpPr>
         <p:spPr>
           <a:xfrm>
-            <a:off x="4788408" y="3613709"/>
-            <a:ext cx="1825752" cy="755294"/>
+            <a:off x="4788408" y="3760013"/>
+            <a:ext cx="1825752" cy="828446"/>
           </a:xfrm>
           <a:prstGeom prst="rect">
             <a:avLst/>
@@ -15500,8 +15382,8 @@
         </p:nvSpPr>
         <p:spPr>
           <a:xfrm>
-            <a:off x="6632448" y="3613709"/>
-            <a:ext cx="1115568" cy="755294"/>
+            <a:off x="6632448" y="3760013"/>
+            <a:ext cx="1115568" cy="828446"/>
           </a:xfrm>
           <a:prstGeom prst="rect">
             <a:avLst/>
@@ -15539,8 +15421,8 @@
         </p:nvSpPr>
         <p:spPr>
           <a:xfrm>
-            <a:off x="4440936" y="4369003"/>
-            <a:ext cx="365760" cy="755294"/>
+            <a:off x="4440936" y="4588459"/>
+            <a:ext cx="365760" cy="828446"/>
           </a:xfrm>
           <a:prstGeom prst="rect">
             <a:avLst/>
@@ -15578,8 +15460,8 @@
         </p:nvSpPr>
         <p:spPr>
           <a:xfrm>
-            <a:off x="4788408" y="4369003"/>
-            <a:ext cx="1825752" cy="755294"/>
+            <a:off x="4788408" y="4588459"/>
+            <a:ext cx="1825752" cy="828446"/>
           </a:xfrm>
           <a:prstGeom prst="rect">
             <a:avLst/>
@@ -15657,8 +15539,8 @@
         </p:nvSpPr>
         <p:spPr>
           <a:xfrm>
-            <a:off x="6632448" y="4369003"/>
-            <a:ext cx="1115568" cy="755294"/>
+            <a:off x="6632448" y="4588459"/>
+            <a:ext cx="1115568" cy="828446"/>
           </a:xfrm>
           <a:prstGeom prst="rect">
             <a:avLst/>
@@ -15696,8 +15578,8 @@
         </p:nvSpPr>
         <p:spPr>
           <a:xfrm>
-            <a:off x="4349496" y="5124298"/>
-            <a:ext cx="3489960" cy="755294"/>
+            <a:off x="4349496" y="5416906"/>
+            <a:ext cx="3489960" cy="828446"/>
           </a:xfrm>
           <a:prstGeom prst="rect">
             <a:avLst/>
@@ -15716,8 +15598,8 @@
         </p:nvSpPr>
         <p:spPr>
           <a:xfrm>
-            <a:off x="4440936" y="5124298"/>
-            <a:ext cx="365760" cy="755294"/>
+            <a:off x="4440936" y="5416906"/>
+            <a:ext cx="365760" cy="828446"/>
           </a:xfrm>
           <a:prstGeom prst="rect">
             <a:avLst/>
@@ -15755,8 +15637,8 @@
         </p:nvSpPr>
         <p:spPr>
           <a:xfrm>
-            <a:off x="4788408" y="5124298"/>
-            <a:ext cx="1825752" cy="755294"/>
+            <a:off x="4788408" y="5416906"/>
+            <a:ext cx="1825752" cy="828446"/>
           </a:xfrm>
           <a:prstGeom prst="rect">
             <a:avLst/>
@@ -15834,8 +15716,8 @@
         </p:nvSpPr>
         <p:spPr>
           <a:xfrm>
-            <a:off x="6632448" y="5124298"/>
-            <a:ext cx="1115568" cy="755294"/>
+            <a:off x="6632448" y="5416906"/>
+            <a:ext cx="1115568" cy="828446"/>
           </a:xfrm>
           <a:prstGeom prst="rect">
             <a:avLst/>
@@ -15972,7 +15854,7 @@
         <p:spPr>
           <a:xfrm>
             <a:off x="8040624" y="2103120"/>
-            <a:ext cx="3489960" cy="755294"/>
+            <a:ext cx="3489960" cy="828446"/>
           </a:xfrm>
           <a:prstGeom prst="rect">
             <a:avLst/>
@@ -15992,7 +15874,7 @@
         <p:spPr>
           <a:xfrm>
             <a:off x="8132064" y="2103120"/>
-            <a:ext cx="365760" cy="755294"/>
+            <a:ext cx="365760" cy="828446"/>
           </a:xfrm>
           <a:prstGeom prst="rect">
             <a:avLst/>
@@ -16031,7 +15913,7 @@
         <p:spPr>
           <a:xfrm>
             <a:off x="8479536" y="2103120"/>
-            <a:ext cx="1825752" cy="755294"/>
+            <a:ext cx="1825752" cy="828446"/>
           </a:xfrm>
           <a:prstGeom prst="rect">
             <a:avLst/>
@@ -16110,7 +15992,7 @@
         <p:spPr>
           <a:xfrm>
             <a:off x="10323576" y="2103120"/>
-            <a:ext cx="1115568" cy="755294"/>
+            <a:ext cx="1115568" cy="828446"/>
           </a:xfrm>
           <a:prstGeom prst="rect">
             <a:avLst/>
@@ -16148,8 +16030,8 @@
         </p:nvSpPr>
         <p:spPr>
           <a:xfrm>
-            <a:off x="8132064" y="2858414"/>
-            <a:ext cx="365760" cy="755294"/>
+            <a:off x="8132064" y="2931566"/>
+            <a:ext cx="365760" cy="828446"/>
           </a:xfrm>
           <a:prstGeom prst="rect">
             <a:avLst/>
@@ -16187,8 +16069,8 @@
         </p:nvSpPr>
         <p:spPr>
           <a:xfrm>
-            <a:off x="8479536" y="2858414"/>
-            <a:ext cx="1825752" cy="755294"/>
+            <a:off x="8479536" y="2931566"/>
+            <a:ext cx="1825752" cy="828446"/>
           </a:xfrm>
           <a:prstGeom prst="rect">
             <a:avLst/>
@@ -16266,8 +16148,8 @@
         </p:nvSpPr>
         <p:spPr>
           <a:xfrm>
-            <a:off x="10323576" y="2858414"/>
-            <a:ext cx="1115568" cy="755294"/>
+            <a:off x="10323576" y="2931566"/>
+            <a:ext cx="1115568" cy="828446"/>
           </a:xfrm>
           <a:prstGeom prst="rect">
             <a:avLst/>
@@ -16305,8 +16187,8 @@
         </p:nvSpPr>
         <p:spPr>
           <a:xfrm>
-            <a:off x="8040624" y="3613709"/>
-            <a:ext cx="3489960" cy="755294"/>
+            <a:off x="8040624" y="3760013"/>
+            <a:ext cx="3489960" cy="828446"/>
           </a:xfrm>
           <a:prstGeom prst="rect">
             <a:avLst/>
@@ -16325,8 +16207,8 @@
         </p:nvSpPr>
         <p:spPr>
           <a:xfrm>
-            <a:off x="8132064" y="3613709"/>
-            <a:ext cx="365760" cy="755294"/>
+            <a:off x="8132064" y="3760013"/>
+            <a:ext cx="365760" cy="828446"/>
           </a:xfrm>
           <a:prstGeom prst="rect">
             <a:avLst/>
@@ -16364,8 +16246,8 @@
         </p:nvSpPr>
         <p:spPr>
           <a:xfrm>
-            <a:off x="8479536" y="3613709"/>
-            <a:ext cx="1825752" cy="755294"/>
+            <a:off x="8479536" y="3760013"/>
+            <a:ext cx="1825752" cy="828446"/>
           </a:xfrm>
           <a:prstGeom prst="rect">
             <a:avLst/>
@@ -16443,8 +16325,8 @@
         </p:nvSpPr>
         <p:spPr>
           <a:xfrm>
-            <a:off x="10323576" y="3613709"/>
-            <a:ext cx="1115568" cy="755294"/>
+            <a:off x="10323576" y="3760013"/>
+            <a:ext cx="1115568" cy="828446"/>
           </a:xfrm>
           <a:prstGeom prst="rect">
             <a:avLst/>
@@ -16482,8 +16364,8 @@
         </p:nvSpPr>
         <p:spPr>
           <a:xfrm>
-            <a:off x="8132064" y="4369003"/>
-            <a:ext cx="365760" cy="755294"/>
+            <a:off x="8132064" y="4588459"/>
+            <a:ext cx="365760" cy="828446"/>
           </a:xfrm>
           <a:prstGeom prst="rect">
             <a:avLst/>
@@ -16521,8 +16403,8 @@
         </p:nvSpPr>
         <p:spPr>
           <a:xfrm>
-            <a:off x="8479536" y="4369003"/>
-            <a:ext cx="1825752" cy="755294"/>
+            <a:off x="8479536" y="4588459"/>
+            <a:ext cx="1825752" cy="828446"/>
           </a:xfrm>
           <a:prstGeom prst="rect">
             <a:avLst/>
@@ -16600,8 +16482,8 @@
         </p:nvSpPr>
         <p:spPr>
           <a:xfrm>
-            <a:off x="10323576" y="4369003"/>
-            <a:ext cx="1115568" cy="755294"/>
+            <a:off x="10323576" y="4588459"/>
+            <a:ext cx="1115568" cy="828446"/>
           </a:xfrm>
           <a:prstGeom prst="rect">
             <a:avLst/>
@@ -16639,8 +16521,8 @@
         </p:nvSpPr>
         <p:spPr>
           <a:xfrm>
-            <a:off x="8040624" y="5124298"/>
-            <a:ext cx="3489960" cy="755294"/>
+            <a:off x="8040624" y="5416906"/>
+            <a:ext cx="3489960" cy="828446"/>
           </a:xfrm>
           <a:prstGeom prst="rect">
             <a:avLst/>
@@ -16659,8 +16541,8 @@
         </p:nvSpPr>
         <p:spPr>
           <a:xfrm>
-            <a:off x="11466576" y="5160874"/>
-            <a:ext cx="64008" cy="682142"/>
+            <a:off x="11466576" y="5453482"/>
+            <a:ext cx="64008" cy="755294"/>
           </a:xfrm>
           <a:prstGeom prst="rect">
             <a:avLst/>
@@ -16679,8 +16561,8 @@
         </p:nvSpPr>
         <p:spPr>
           <a:xfrm>
-            <a:off x="8132064" y="5124298"/>
-            <a:ext cx="365760" cy="755294"/>
+            <a:off x="8132064" y="5416906"/>
+            <a:ext cx="365760" cy="828446"/>
           </a:xfrm>
           <a:prstGeom prst="rect">
             <a:avLst/>
@@ -16718,8 +16600,8 @@
         </p:nvSpPr>
         <p:spPr>
           <a:xfrm>
-            <a:off x="8479536" y="5124298"/>
-            <a:ext cx="1825752" cy="755294"/>
+            <a:off x="8479536" y="5416906"/>
+            <a:ext cx="1825752" cy="828446"/>
           </a:xfrm>
           <a:prstGeom prst="rect">
             <a:avLst/>
@@ -16797,8 +16679,8 @@
         </p:nvSpPr>
         <p:spPr>
           <a:xfrm>
-            <a:off x="10323576" y="5124298"/>
-            <a:ext cx="1115568" cy="755294"/>
+            <a:off x="10323576" y="5416906"/>
+            <a:ext cx="1115568" cy="828446"/>
           </a:xfrm>
           <a:prstGeom prst="rect">
             <a:avLst/>
@@ -16823,65 +16705,6 @@
                 <a:cs typeface="Inter" pitchFamily="34" charset="-120"/>
               </a:rPr>
               <a:t>+23.1%</a:t>
-            </a:r>
-            <a:endParaRPr lang="en-US" sz="1600" dirty="0"/>
-          </a:p>
-        </p:txBody>
-      </p:sp>
-      <p:sp>
-        <p:nvSpPr>
-          <p:cNvPr id="71" name="Shape 69"/>
-          <p:cNvSpPr/>
-          <p:nvPr/>
-        </p:nvSpPr>
-        <p:spPr>
-          <a:xfrm>
-            <a:off x="457200" y="6126480"/>
-            <a:ext cx="11274552" cy="615696"/>
-          </a:xfrm>
-          <a:prstGeom prst="rect">
-            <a:avLst/>
-          </a:prstGeom>
-          <a:solidFill>
-            <a:srgbClr val="EDF4FA"/>
-          </a:solidFill>
-          <a:ln/>
-        </p:spPr>
-      </p:sp>
-      <p:sp>
-        <p:nvSpPr>
-          <p:cNvPr id="72" name="Text 70"/>
-          <p:cNvSpPr txBox="1"/>
-          <p:nvPr/>
-        </p:nvSpPr>
-        <p:spPr>
-          <a:xfrm>
-            <a:off x="658368" y="6144768"/>
-            <a:ext cx="10927080" cy="579120"/>
-          </a:xfrm>
-          <a:prstGeom prst="rect">
-            <a:avLst/>
-          </a:prstGeom>
-          <a:noFill/>
-          <a:ln/>
-        </p:spPr>
-        <p:txBody>
-          <a:bodyPr wrap="square" lIns="0" tIns="0" rIns="0" bIns="0" rtlCol="0" anchor="ctr"/>
-          <a:lstStyle/>
-          <a:p>
-            <a:pPr indent="0" marL="0">
-              <a:buNone/>
-            </a:pPr>
-            <a:r>
-              <a:rPr lang="en-US" sz="1600" b="1" dirty="0">
-                <a:solidFill>
-                  <a:srgbClr val="0B2C4A"/>
-                </a:solidFill>
-                <a:latin typeface="Inter" pitchFamily="34" charset="0"/>
-                <a:ea typeface="Inter" pitchFamily="34" charset="-122"/>
-                <a:cs typeface="Inter" pitchFamily="34" charset="-120"/>
-              </a:rPr>
-              <a:t>Ask Subaru St George, Kia LV and Kia St George what changed. Ask VW St George, Audi Reno and Volvo what got in the way. Ask Mazda, CDJR Post Falls and Lexus what they started this year.</a:t>
             </a:r>
             <a:endParaRPr lang="en-US" sz="1600" dirty="0"/>
           </a:p>

</xml_diff>

<commit_message>
Takeaways keep the group-level part, drop only store call-outs
Co-Authored-By: Claude Opus 5.5 <noreply@anthropic.com>
Claude-Session: https://claude.ai/code/session_01Xa4nFVxuQGXmHARGph9WhS
</commit_message>
<xml_diff>
--- a/day2-deck/decks/CP Hours & RO a Day - Review.pptx
+++ b/day2-deck/decks/CP Hours & RO a Day - Review.pptx
@@ -2463,7 +2463,7 @@
           <a:p>
             <a:r>
               <a:rPr lang="en-US" dirty="0"/>
-              <a:t>Takeaway (off the slide): Toyota Henderson leads at 78,123; VW St George is smallest at 3,276.Source: Qlik - Closed Repair Orders. Customer pay, Jan-Sep by close date. Same-store, INEOS excluded (opened 2026). GMC Prescott body shop labor types excluded. Total customer-pay labor hours sold, all CP ROs. Jan-Sep 2026 YTD.</a:t>
+              <a:t>Takeaway with the store call-outs (off the slide): Toyota Henderson leads at 78,123; VW St George is smallest at 3,276.Source: Qlik - Closed Repair Orders. Customer pay, Jan-Sep by close date. Same-store, INEOS excluded (opened 2026). GMC Prescott body shop labor types excluded. Total customer-pay labor hours sold, all CP ROs. Jan-Sep 2026 YTD.</a:t>
             </a:r>
             <a:endParaRPr lang="en-US" dirty="0"/>
           </a:p>
@@ -2551,7 +2551,7 @@
           <a:p>
             <a:r>
               <a:rPr lang="en-US" dirty="0"/>
-              <a:t>Takeaway (off the slide): 23 of 33 stores sold more CP hours, led by Subaru St George at +44.6% to 12,766. 10 declined; VW St George fell most at −25.4%.Source: Qlik - Closed Repair Orders. Customer pay, Jan-Sep by close date. Same-store, INEOS excluded (opened 2026). GMC Prescott body shop labor types excluded. Change in customer-pay hours sold (percent, so store size does not drive the ranking), Jan-Sep 2026 vs 2025, best first.</a:t>
+              <a:t>Takeaway with the store call-outs (off the slide): 23 of 33 stores sold more CP hours, led by Subaru St George at +44.6% to 12,766. 10 declined; VW St George fell most at −25.4%.Source: Qlik - Closed Repair Orders. Customer pay, Jan-Sep by close date. Same-store, INEOS excluded (opened 2026). GMC Prescott body shop labor types excluded. Change in customer-pay hours sold (percent, so store size does not drive the ranking), Jan-Sep 2026 vs 2025, best first.</a:t>
             </a:r>
             <a:endParaRPr lang="en-US" dirty="0"/>
           </a:p>
@@ -2639,7 +2639,7 @@
           <a:p>
             <a:r>
               <a:rPr lang="en-US" dirty="0"/>
-              <a:t>Takeaway (off the slide): Ask Subaru St George, Kia LV and Kia St George what changed. Ask VW St George, Audi Reno and Volvo what got in the way. Ask Mazda, CDJR Post Falls and Lexus what they started this year.Source: Qlik - Closed Repair Orders. Customer pay, Jan-Sep by close date. Same-store, INEOS excluded (opened 2026). GMC Prescott body shop labor types excluded. Total customer-pay labor hours sold, all CP ROs. Top and bottom five stores by change in customer-pay hours sold (percent, so store size does not drive the ranking), Jan-Sep 2026 vs 2025. Moving now: Jul-Sep 2026 vs Jan-Mar 2026, each store against itself (monthly averages); the group moved +5.5% on the same basis, so part of every store's change is seasonal. Green bar at the right of a row: the store is on both the top five vs last year and the top five moving now.Conversation starter: each top store says one thing they started doing; each bottom store says what got in the way and what they would try. The room trades ideas. Moving now: ask the top three what they started this year.</a:t>
+              <a:t>Takeaway with the store call-outs (off the slide): Ask Subaru St George, Kia LV and Kia St George what changed. Ask VW St George, Audi Reno and Volvo what got in the way. Ask Mazda, CDJR Post Falls and Lexus what they started this year.Source: Qlik - Closed Repair Orders. Customer pay, Jan-Sep by close date. Same-store, INEOS excluded (opened 2026). GMC Prescott body shop labor types excluded. Total customer-pay labor hours sold, all CP ROs. Top and bottom five stores by change in customer-pay hours sold (percent, so store size does not drive the ranking), Jan-Sep 2026 vs 2025. Moving now: Jul-Sep 2026 vs Jan-Mar 2026, each store against itself (monthly averages); the group moved +5.5% on the same basis, so part of every store's change is seasonal. Green bar at the right of a row: the store is on both the top five vs last year and the top five moving now.Conversation starter: each top store says one thing they started doing; each bottom store says what got in the way and what they would try. The room trades ideas. Moving now: ask the top three what they started this year.</a:t>
             </a:r>
             <a:endParaRPr lang="en-US" dirty="0"/>
           </a:p>
@@ -8942,7 +8942,7 @@
         <p:spPr>
           <a:xfrm>
             <a:off x="457200" y="1207008"/>
-            <a:ext cx="11274552" cy="5148072"/>
+            <a:ext cx="11274552" cy="4782312"/>
           </a:xfrm>
           <a:prstGeom prst="rect">
             <a:avLst/>
@@ -9119,7 +9119,7 @@
         <p:spPr>
           <a:xfrm>
             <a:off x="658368" y="1847088"/>
-            <a:ext cx="310896" cy="261411"/>
+            <a:ext cx="310896" cy="239896"/>
           </a:xfrm>
           <a:prstGeom prst="rect">
             <a:avLst/>
@@ -9158,7 +9158,7 @@
         <p:spPr>
           <a:xfrm>
             <a:off x="1014984" y="1847088"/>
-            <a:ext cx="1920240" cy="261411"/>
+            <a:ext cx="1920240" cy="239896"/>
           </a:xfrm>
           <a:prstGeom prst="rect">
             <a:avLst/>
@@ -9196,8 +9196,8 @@
         </p:nvSpPr>
         <p:spPr>
           <a:xfrm>
-            <a:off x="3785616" y="1917669"/>
-            <a:ext cx="777240" cy="120249"/>
+            <a:off x="3785616" y="1911860"/>
+            <a:ext cx="777240" cy="110352"/>
           </a:xfrm>
           <a:prstGeom prst="rect">
             <a:avLst/>
@@ -9217,7 +9217,7 @@
         <p:spPr>
           <a:xfrm>
             <a:off x="4617720" y="1847088"/>
-            <a:ext cx="1234440" cy="261411"/>
+            <a:ext cx="1234440" cy="239896"/>
           </a:xfrm>
           <a:prstGeom prst="rect">
             <a:avLst/>
@@ -9255,8 +9255,8 @@
         </p:nvSpPr>
         <p:spPr>
           <a:xfrm>
-            <a:off x="658368" y="2108499"/>
-            <a:ext cx="310896" cy="261411"/>
+            <a:off x="658368" y="2086984"/>
+            <a:ext cx="310896" cy="239896"/>
           </a:xfrm>
           <a:prstGeom prst="rect">
             <a:avLst/>
@@ -9294,8 +9294,8 @@
         </p:nvSpPr>
         <p:spPr>
           <a:xfrm>
-            <a:off x="1014984" y="2108499"/>
-            <a:ext cx="1920240" cy="261411"/>
+            <a:off x="1014984" y="2086984"/>
+            <a:ext cx="1920240" cy="239896"/>
           </a:xfrm>
           <a:prstGeom prst="rect">
             <a:avLst/>
@@ -9333,8 +9333,8 @@
         </p:nvSpPr>
         <p:spPr>
           <a:xfrm>
-            <a:off x="3785616" y="2179080"/>
-            <a:ext cx="608749" cy="120249"/>
+            <a:off x="3785616" y="2151755"/>
+            <a:ext cx="608749" cy="110352"/>
           </a:xfrm>
           <a:prstGeom prst="rect">
             <a:avLst/>
@@ -9353,8 +9353,8 @@
         </p:nvSpPr>
         <p:spPr>
           <a:xfrm>
-            <a:off x="4617720" y="2108499"/>
-            <a:ext cx="1234440" cy="261411"/>
+            <a:off x="4617720" y="2086984"/>
+            <a:ext cx="1234440" cy="239896"/>
           </a:xfrm>
           <a:prstGeom prst="rect">
             <a:avLst/>
@@ -9392,8 +9392,8 @@
         </p:nvSpPr>
         <p:spPr>
           <a:xfrm>
-            <a:off x="658368" y="2369910"/>
-            <a:ext cx="310896" cy="261411"/>
+            <a:off x="658368" y="2326879"/>
+            <a:ext cx="310896" cy="239896"/>
           </a:xfrm>
           <a:prstGeom prst="rect">
             <a:avLst/>
@@ -9431,8 +9431,8 @@
         </p:nvSpPr>
         <p:spPr>
           <a:xfrm>
-            <a:off x="1014984" y="2369910"/>
-            <a:ext cx="1920240" cy="261411"/>
+            <a:off x="1014984" y="2326879"/>
+            <a:ext cx="1920240" cy="239896"/>
           </a:xfrm>
           <a:prstGeom prst="rect">
             <a:avLst/>
@@ -9470,8 +9470,8 @@
         </p:nvSpPr>
         <p:spPr>
           <a:xfrm>
-            <a:off x="3785616" y="2440491"/>
-            <a:ext cx="589865" cy="120249"/>
+            <a:off x="3785616" y="2391651"/>
+            <a:ext cx="589865" cy="110352"/>
           </a:xfrm>
           <a:prstGeom prst="rect">
             <a:avLst/>
@@ -9490,8 +9490,8 @@
         </p:nvSpPr>
         <p:spPr>
           <a:xfrm>
-            <a:off x="4617720" y="2369910"/>
-            <a:ext cx="1234440" cy="261411"/>
+            <a:off x="4617720" y="2326879"/>
+            <a:ext cx="1234440" cy="239896"/>
           </a:xfrm>
           <a:prstGeom prst="rect">
             <a:avLst/>
@@ -9529,8 +9529,8 @@
         </p:nvSpPr>
         <p:spPr>
           <a:xfrm>
-            <a:off x="658368" y="2631320"/>
-            <a:ext cx="310896" cy="261411"/>
+            <a:off x="658368" y="2566775"/>
+            <a:ext cx="310896" cy="239896"/>
           </a:xfrm>
           <a:prstGeom prst="rect">
             <a:avLst/>
@@ -9568,8 +9568,8 @@
         </p:nvSpPr>
         <p:spPr>
           <a:xfrm>
-            <a:off x="1014984" y="2631320"/>
-            <a:ext cx="1920240" cy="261411"/>
+            <a:off x="1014984" y="2566775"/>
+            <a:ext cx="1920240" cy="239896"/>
           </a:xfrm>
           <a:prstGeom prst="rect">
             <a:avLst/>
@@ -9607,8 +9607,8 @@
         </p:nvSpPr>
         <p:spPr>
           <a:xfrm>
-            <a:off x="3785616" y="2701901"/>
-            <a:ext cx="502608" cy="120249"/>
+            <a:off x="3785616" y="2631546"/>
+            <a:ext cx="502608" cy="110352"/>
           </a:xfrm>
           <a:prstGeom prst="rect">
             <a:avLst/>
@@ -9627,8 +9627,8 @@
         </p:nvSpPr>
         <p:spPr>
           <a:xfrm>
-            <a:off x="4617720" y="2631320"/>
-            <a:ext cx="1234440" cy="261411"/>
+            <a:off x="4617720" y="2566775"/>
+            <a:ext cx="1234440" cy="239896"/>
           </a:xfrm>
           <a:prstGeom prst="rect">
             <a:avLst/>
@@ -9666,8 +9666,8 @@
         </p:nvSpPr>
         <p:spPr>
           <a:xfrm>
-            <a:off x="658368" y="2892731"/>
-            <a:ext cx="310896" cy="261411"/>
+            <a:off x="658368" y="2806670"/>
+            <a:ext cx="310896" cy="239896"/>
           </a:xfrm>
           <a:prstGeom prst="rect">
             <a:avLst/>
@@ -9705,8 +9705,8 @@
         </p:nvSpPr>
         <p:spPr>
           <a:xfrm>
-            <a:off x="1014984" y="2892731"/>
-            <a:ext cx="1920240" cy="261411"/>
+            <a:off x="1014984" y="2806670"/>
+            <a:ext cx="1920240" cy="239896"/>
           </a:xfrm>
           <a:prstGeom prst="rect">
             <a:avLst/>
@@ -9744,8 +9744,8 @@
         </p:nvSpPr>
         <p:spPr>
           <a:xfrm>
-            <a:off x="3785616" y="2963312"/>
-            <a:ext cx="489520" cy="120249"/>
+            <a:off x="3785616" y="2871442"/>
+            <a:ext cx="489520" cy="110352"/>
           </a:xfrm>
           <a:prstGeom prst="rect">
             <a:avLst/>
@@ -9764,8 +9764,8 @@
         </p:nvSpPr>
         <p:spPr>
           <a:xfrm>
-            <a:off x="4617720" y="2892731"/>
-            <a:ext cx="1234440" cy="261411"/>
+            <a:off x="4617720" y="2806670"/>
+            <a:ext cx="1234440" cy="239896"/>
           </a:xfrm>
           <a:prstGeom prst="rect">
             <a:avLst/>
@@ -9803,8 +9803,8 @@
         </p:nvSpPr>
         <p:spPr>
           <a:xfrm>
-            <a:off x="658368" y="3154142"/>
-            <a:ext cx="310896" cy="261411"/>
+            <a:off x="658368" y="3046566"/>
+            <a:ext cx="310896" cy="239896"/>
           </a:xfrm>
           <a:prstGeom prst="rect">
             <a:avLst/>
@@ -9842,8 +9842,8 @@
         </p:nvSpPr>
         <p:spPr>
           <a:xfrm>
-            <a:off x="1014984" y="3154142"/>
-            <a:ext cx="1920240" cy="261411"/>
+            <a:off x="1014984" y="3046566"/>
+            <a:ext cx="1920240" cy="239896"/>
           </a:xfrm>
           <a:prstGeom prst="rect">
             <a:avLst/>
@@ -9881,8 +9881,8 @@
         </p:nvSpPr>
         <p:spPr>
           <a:xfrm>
-            <a:off x="3785616" y="3224723"/>
-            <a:ext cx="475887" cy="120249"/>
+            <a:off x="3785616" y="3111337"/>
+            <a:ext cx="475887" cy="110352"/>
           </a:xfrm>
           <a:prstGeom prst="rect">
             <a:avLst/>
@@ -9901,8 +9901,8 @@
         </p:nvSpPr>
         <p:spPr>
           <a:xfrm>
-            <a:off x="4617720" y="3154142"/>
-            <a:ext cx="1234440" cy="261411"/>
+            <a:off x="4617720" y="3046566"/>
+            <a:ext cx="1234440" cy="239896"/>
           </a:xfrm>
           <a:prstGeom prst="rect">
             <a:avLst/>
@@ -9940,8 +9940,8 @@
         </p:nvSpPr>
         <p:spPr>
           <a:xfrm>
-            <a:off x="658368" y="3415553"/>
-            <a:ext cx="310896" cy="261411"/>
+            <a:off x="658368" y="3286461"/>
+            <a:ext cx="310896" cy="239896"/>
           </a:xfrm>
           <a:prstGeom prst="rect">
             <a:avLst/>
@@ -9979,8 +9979,8 @@
         </p:nvSpPr>
         <p:spPr>
           <a:xfrm>
-            <a:off x="1014984" y="3415553"/>
-            <a:ext cx="1920240" cy="261411"/>
+            <a:off x="1014984" y="3286461"/>
+            <a:ext cx="1920240" cy="239896"/>
           </a:xfrm>
           <a:prstGeom prst="rect">
             <a:avLst/>
@@ -10018,8 +10018,8 @@
         </p:nvSpPr>
         <p:spPr>
           <a:xfrm>
-            <a:off x="3785616" y="3486134"/>
-            <a:ext cx="403394" cy="120249"/>
+            <a:off x="3785616" y="3351233"/>
+            <a:ext cx="403394" cy="110352"/>
           </a:xfrm>
           <a:prstGeom prst="rect">
             <a:avLst/>
@@ -10038,8 +10038,8 @@
         </p:nvSpPr>
         <p:spPr>
           <a:xfrm>
-            <a:off x="4617720" y="3415553"/>
-            <a:ext cx="1234440" cy="261411"/>
+            <a:off x="4617720" y="3286461"/>
+            <a:ext cx="1234440" cy="239896"/>
           </a:xfrm>
           <a:prstGeom prst="rect">
             <a:avLst/>
@@ -10077,8 +10077,8 @@
         </p:nvSpPr>
         <p:spPr>
           <a:xfrm>
-            <a:off x="658368" y="3676964"/>
-            <a:ext cx="310896" cy="261411"/>
+            <a:off x="658368" y="3526357"/>
+            <a:ext cx="310896" cy="239896"/>
           </a:xfrm>
           <a:prstGeom prst="rect">
             <a:avLst/>
@@ -10116,8 +10116,8 @@
         </p:nvSpPr>
         <p:spPr>
           <a:xfrm>
-            <a:off x="1014984" y="3676964"/>
-            <a:ext cx="1920240" cy="261411"/>
+            <a:off x="1014984" y="3526357"/>
+            <a:ext cx="1920240" cy="239896"/>
           </a:xfrm>
           <a:prstGeom prst="rect">
             <a:avLst/>
@@ -10155,8 +10155,8 @@
         </p:nvSpPr>
         <p:spPr>
           <a:xfrm>
-            <a:off x="3785616" y="3747545"/>
-            <a:ext cx="320015" cy="120249"/>
+            <a:off x="3785616" y="3591128"/>
+            <a:ext cx="320015" cy="110352"/>
           </a:xfrm>
           <a:prstGeom prst="rect">
             <a:avLst/>
@@ -10175,8 +10175,8 @@
         </p:nvSpPr>
         <p:spPr>
           <a:xfrm>
-            <a:off x="4617720" y="3676964"/>
-            <a:ext cx="1234440" cy="261411"/>
+            <a:off x="4617720" y="3526357"/>
+            <a:ext cx="1234440" cy="239896"/>
           </a:xfrm>
           <a:prstGeom prst="rect">
             <a:avLst/>
@@ -10214,8 +10214,8 @@
         </p:nvSpPr>
         <p:spPr>
           <a:xfrm>
-            <a:off x="658368" y="3938375"/>
-            <a:ext cx="310896" cy="261411"/>
+            <a:off x="658368" y="3766252"/>
+            <a:ext cx="310896" cy="239896"/>
           </a:xfrm>
           <a:prstGeom prst="rect">
             <a:avLst/>
@@ -10253,8 +10253,8 @@
         </p:nvSpPr>
         <p:spPr>
           <a:xfrm>
-            <a:off x="1014984" y="3938375"/>
-            <a:ext cx="1920240" cy="261411"/>
+            <a:off x="1014984" y="3766252"/>
+            <a:ext cx="1920240" cy="239896"/>
           </a:xfrm>
           <a:prstGeom prst="rect">
             <a:avLst/>
@@ -10292,8 +10292,8 @@
         </p:nvSpPr>
         <p:spPr>
           <a:xfrm>
-            <a:off x="3785616" y="4008956"/>
-            <a:ext cx="319802" cy="120249"/>
+            <a:off x="3785616" y="3831024"/>
+            <a:ext cx="319802" cy="110352"/>
           </a:xfrm>
           <a:prstGeom prst="rect">
             <a:avLst/>
@@ -10312,8 +10312,8 @@
         </p:nvSpPr>
         <p:spPr>
           <a:xfrm>
-            <a:off x="4617720" y="3938375"/>
-            <a:ext cx="1234440" cy="261411"/>
+            <a:off x="4617720" y="3766252"/>
+            <a:ext cx="1234440" cy="239896"/>
           </a:xfrm>
           <a:prstGeom prst="rect">
             <a:avLst/>
@@ -10351,8 +10351,8 @@
         </p:nvSpPr>
         <p:spPr>
           <a:xfrm>
-            <a:off x="658368" y="4199785"/>
-            <a:ext cx="310896" cy="261411"/>
+            <a:off x="658368" y="4006148"/>
+            <a:ext cx="310896" cy="239896"/>
           </a:xfrm>
           <a:prstGeom prst="rect">
             <a:avLst/>
@@ -10390,8 +10390,8 @@
         </p:nvSpPr>
         <p:spPr>
           <a:xfrm>
-            <a:off x="1014984" y="4199785"/>
-            <a:ext cx="1920240" cy="261411"/>
+            <a:off x="1014984" y="4006148"/>
+            <a:ext cx="1920240" cy="239896"/>
           </a:xfrm>
           <a:prstGeom prst="rect">
             <a:avLst/>
@@ -10429,8 +10429,8 @@
         </p:nvSpPr>
         <p:spPr>
           <a:xfrm>
-            <a:off x="3785616" y="4270366"/>
-            <a:ext cx="304780" cy="120249"/>
+            <a:off x="3785616" y="4070920"/>
+            <a:ext cx="304780" cy="110352"/>
           </a:xfrm>
           <a:prstGeom prst="rect">
             <a:avLst/>
@@ -10449,8 +10449,8 @@
         </p:nvSpPr>
         <p:spPr>
           <a:xfrm>
-            <a:off x="4617720" y="4199785"/>
-            <a:ext cx="1234440" cy="261411"/>
+            <a:off x="4617720" y="4006148"/>
+            <a:ext cx="1234440" cy="239896"/>
           </a:xfrm>
           <a:prstGeom prst="rect">
             <a:avLst/>
@@ -10488,8 +10488,8 @@
         </p:nvSpPr>
         <p:spPr>
           <a:xfrm>
-            <a:off x="658368" y="4461196"/>
-            <a:ext cx="310896" cy="261411"/>
+            <a:off x="658368" y="4246043"/>
+            <a:ext cx="310896" cy="239896"/>
           </a:xfrm>
           <a:prstGeom prst="rect">
             <a:avLst/>
@@ -10527,8 +10527,8 @@
         </p:nvSpPr>
         <p:spPr>
           <a:xfrm>
-            <a:off x="1014984" y="4461196"/>
-            <a:ext cx="1920240" cy="261411"/>
+            <a:off x="1014984" y="4246043"/>
+            <a:ext cx="1920240" cy="239896"/>
           </a:xfrm>
           <a:prstGeom prst="rect">
             <a:avLst/>
@@ -10566,8 +10566,8 @@
         </p:nvSpPr>
         <p:spPr>
           <a:xfrm>
-            <a:off x="3785616" y="4531777"/>
-            <a:ext cx="214987" cy="120249"/>
+            <a:off x="3785616" y="4310815"/>
+            <a:ext cx="214987" cy="110352"/>
           </a:xfrm>
           <a:prstGeom prst="rect">
             <a:avLst/>
@@ -10586,8 +10586,8 @@
         </p:nvSpPr>
         <p:spPr>
           <a:xfrm>
-            <a:off x="4617720" y="4461196"/>
-            <a:ext cx="1234440" cy="261411"/>
+            <a:off x="4617720" y="4246043"/>
+            <a:ext cx="1234440" cy="239896"/>
           </a:xfrm>
           <a:prstGeom prst="rect">
             <a:avLst/>
@@ -10625,8 +10625,8 @@
         </p:nvSpPr>
         <p:spPr>
           <a:xfrm>
-            <a:off x="658368" y="4722607"/>
-            <a:ext cx="310896" cy="261411"/>
+            <a:off x="658368" y="4485939"/>
+            <a:ext cx="310896" cy="239896"/>
           </a:xfrm>
           <a:prstGeom prst="rect">
             <a:avLst/>
@@ -10664,8 +10664,8 @@
         </p:nvSpPr>
         <p:spPr>
           <a:xfrm>
-            <a:off x="1014984" y="4722607"/>
-            <a:ext cx="1920240" cy="261411"/>
+            <a:off x="1014984" y="4485939"/>
+            <a:ext cx="1920240" cy="239896"/>
           </a:xfrm>
           <a:prstGeom prst="rect">
             <a:avLst/>
@@ -10703,8 +10703,8 @@
         </p:nvSpPr>
         <p:spPr>
           <a:xfrm>
-            <a:off x="3785616" y="4793188"/>
-            <a:ext cx="207215" cy="120249"/>
+            <a:off x="3785616" y="4550711"/>
+            <a:ext cx="207215" cy="110352"/>
           </a:xfrm>
           <a:prstGeom prst="rect">
             <a:avLst/>
@@ -10723,8 +10723,8 @@
         </p:nvSpPr>
         <p:spPr>
           <a:xfrm>
-            <a:off x="4617720" y="4722607"/>
-            <a:ext cx="1234440" cy="261411"/>
+            <a:off x="4617720" y="4485939"/>
+            <a:ext cx="1234440" cy="239896"/>
           </a:xfrm>
           <a:prstGeom prst="rect">
             <a:avLst/>
@@ -10762,8 +10762,8 @@
         </p:nvSpPr>
         <p:spPr>
           <a:xfrm>
-            <a:off x="658368" y="4984018"/>
-            <a:ext cx="310896" cy="261411"/>
+            <a:off x="658368" y="4725834"/>
+            <a:ext cx="310896" cy="239896"/>
           </a:xfrm>
           <a:prstGeom prst="rect">
             <a:avLst/>
@@ -10801,8 +10801,8 @@
         </p:nvSpPr>
         <p:spPr>
           <a:xfrm>
-            <a:off x="1014984" y="4984018"/>
-            <a:ext cx="1920240" cy="261411"/>
+            <a:off x="1014984" y="4725834"/>
+            <a:ext cx="1920240" cy="239896"/>
           </a:xfrm>
           <a:prstGeom prst="rect">
             <a:avLst/>
@@ -10840,8 +10840,8 @@
         </p:nvSpPr>
         <p:spPr>
           <a:xfrm>
-            <a:off x="3785616" y="5054599"/>
-            <a:ext cx="187159" cy="120249"/>
+            <a:off x="3785616" y="4790606"/>
+            <a:ext cx="187159" cy="110352"/>
           </a:xfrm>
           <a:prstGeom prst="rect">
             <a:avLst/>
@@ -10860,8 +10860,8 @@
         </p:nvSpPr>
         <p:spPr>
           <a:xfrm>
-            <a:off x="4617720" y="4984018"/>
-            <a:ext cx="1234440" cy="261411"/>
+            <a:off x="4617720" y="4725834"/>
+            <a:ext cx="1234440" cy="239896"/>
           </a:xfrm>
           <a:prstGeom prst="rect">
             <a:avLst/>
@@ -10899,8 +10899,8 @@
         </p:nvSpPr>
         <p:spPr>
           <a:xfrm>
-            <a:off x="658368" y="5245429"/>
-            <a:ext cx="310896" cy="261411"/>
+            <a:off x="658368" y="4965730"/>
+            <a:ext cx="310896" cy="239896"/>
           </a:xfrm>
           <a:prstGeom prst="rect">
             <a:avLst/>
@@ -10938,8 +10938,8 @@
         </p:nvSpPr>
         <p:spPr>
           <a:xfrm>
-            <a:off x="1014984" y="5245429"/>
-            <a:ext cx="1920240" cy="261411"/>
+            <a:off x="1014984" y="4965730"/>
+            <a:ext cx="1920240" cy="239896"/>
           </a:xfrm>
           <a:prstGeom prst="rect">
             <a:avLst/>
@@ -10977,8 +10977,8 @@
         </p:nvSpPr>
         <p:spPr>
           <a:xfrm>
-            <a:off x="3785616" y="5316010"/>
-            <a:ext cx="172129" cy="120249"/>
+            <a:off x="3785616" y="5030502"/>
+            <a:ext cx="172129" cy="110352"/>
           </a:xfrm>
           <a:prstGeom prst="rect">
             <a:avLst/>
@@ -10997,8 +10997,8 @@
         </p:nvSpPr>
         <p:spPr>
           <a:xfrm>
-            <a:off x="4617720" y="5245429"/>
-            <a:ext cx="1234440" cy="261411"/>
+            <a:off x="4617720" y="4965730"/>
+            <a:ext cx="1234440" cy="239896"/>
           </a:xfrm>
           <a:prstGeom prst="rect">
             <a:avLst/>
@@ -11036,8 +11036,8 @@
         </p:nvSpPr>
         <p:spPr>
           <a:xfrm>
-            <a:off x="658368" y="5506840"/>
-            <a:ext cx="310896" cy="261411"/>
+            <a:off x="658368" y="5205625"/>
+            <a:ext cx="310896" cy="239896"/>
           </a:xfrm>
           <a:prstGeom prst="rect">
             <a:avLst/>
@@ -11075,8 +11075,8 @@
         </p:nvSpPr>
         <p:spPr>
           <a:xfrm>
-            <a:off x="1014984" y="5506840"/>
-            <a:ext cx="1920240" cy="261411"/>
+            <a:off x="1014984" y="5205625"/>
+            <a:ext cx="1920240" cy="239896"/>
           </a:xfrm>
           <a:prstGeom prst="rect">
             <a:avLst/>
@@ -11114,8 +11114,8 @@
         </p:nvSpPr>
         <p:spPr>
           <a:xfrm>
-            <a:off x="3785616" y="5577420"/>
-            <a:ext cx="116744" cy="120249"/>
+            <a:off x="3785616" y="5270397"/>
+            <a:ext cx="116744" cy="110352"/>
           </a:xfrm>
           <a:prstGeom prst="rect">
             <a:avLst/>
@@ -11134,8 +11134,8 @@
         </p:nvSpPr>
         <p:spPr>
           <a:xfrm>
-            <a:off x="4617720" y="5506840"/>
-            <a:ext cx="1234440" cy="261411"/>
+            <a:off x="4617720" y="5205625"/>
+            <a:ext cx="1234440" cy="239896"/>
           </a:xfrm>
           <a:prstGeom prst="rect">
             <a:avLst/>
@@ -11173,8 +11173,8 @@
         </p:nvSpPr>
         <p:spPr>
           <a:xfrm>
-            <a:off x="658368" y="5768250"/>
-            <a:ext cx="310896" cy="261411"/>
+            <a:off x="658368" y="5445521"/>
+            <a:ext cx="310896" cy="239896"/>
           </a:xfrm>
           <a:prstGeom prst="rect">
             <a:avLst/>
@@ -11212,8 +11212,8 @@
         </p:nvSpPr>
         <p:spPr>
           <a:xfrm>
-            <a:off x="1014984" y="5768250"/>
-            <a:ext cx="1920240" cy="261411"/>
+            <a:off x="1014984" y="5445521"/>
+            <a:ext cx="1920240" cy="239896"/>
           </a:xfrm>
           <a:prstGeom prst="rect">
             <a:avLst/>
@@ -11251,8 +11251,8 @@
         </p:nvSpPr>
         <p:spPr>
           <a:xfrm>
-            <a:off x="3785616" y="5838831"/>
-            <a:ext cx="116682" cy="120249"/>
+            <a:off x="3785616" y="5510293"/>
+            <a:ext cx="116682" cy="110352"/>
           </a:xfrm>
           <a:prstGeom prst="rect">
             <a:avLst/>
@@ -11271,8 +11271,8 @@
         </p:nvSpPr>
         <p:spPr>
           <a:xfrm>
-            <a:off x="4617720" y="5768250"/>
-            <a:ext cx="1234440" cy="261411"/>
+            <a:off x="4617720" y="5445521"/>
+            <a:ext cx="1234440" cy="239896"/>
           </a:xfrm>
           <a:prstGeom prst="rect">
             <a:avLst/>
@@ -11310,8 +11310,8 @@
         </p:nvSpPr>
         <p:spPr>
           <a:xfrm>
-            <a:off x="658368" y="6029661"/>
-            <a:ext cx="310896" cy="261411"/>
+            <a:off x="658368" y="5685416"/>
+            <a:ext cx="310896" cy="239896"/>
           </a:xfrm>
           <a:prstGeom prst="rect">
             <a:avLst/>
@@ -11349,8 +11349,8 @@
         </p:nvSpPr>
         <p:spPr>
           <a:xfrm>
-            <a:off x="1014984" y="6029661"/>
-            <a:ext cx="1920240" cy="261411"/>
+            <a:off x="1014984" y="5685416"/>
+            <a:ext cx="1920240" cy="239896"/>
           </a:xfrm>
           <a:prstGeom prst="rect">
             <a:avLst/>
@@ -11388,8 +11388,8 @@
         </p:nvSpPr>
         <p:spPr>
           <a:xfrm>
-            <a:off x="3785616" y="6100242"/>
-            <a:ext cx="116417" cy="120249"/>
+            <a:off x="3785616" y="5750188"/>
+            <a:ext cx="116417" cy="110352"/>
           </a:xfrm>
           <a:prstGeom prst="rect">
             <a:avLst/>
@@ -11408,8 +11408,8 @@
         </p:nvSpPr>
         <p:spPr>
           <a:xfrm>
-            <a:off x="4617720" y="6029661"/>
-            <a:ext cx="1234440" cy="261411"/>
+            <a:off x="4617720" y="5685416"/>
+            <a:ext cx="1234440" cy="239896"/>
           </a:xfrm>
           <a:prstGeom prst="rect">
             <a:avLst/>
@@ -11448,7 +11448,7 @@
         <p:spPr>
           <a:xfrm>
             <a:off x="6208776" y="1847088"/>
-            <a:ext cx="310896" cy="261411"/>
+            <a:ext cx="310896" cy="239896"/>
           </a:xfrm>
           <a:prstGeom prst="rect">
             <a:avLst/>
@@ -11487,7 +11487,7 @@
         <p:spPr>
           <a:xfrm>
             <a:off x="6565392" y="1847088"/>
-            <a:ext cx="1920240" cy="261411"/>
+            <a:ext cx="1920240" cy="239896"/>
           </a:xfrm>
           <a:prstGeom prst="rect">
             <a:avLst/>
@@ -11525,8 +11525,8 @@
         </p:nvSpPr>
         <p:spPr>
           <a:xfrm>
-            <a:off x="9336024" y="1917669"/>
-            <a:ext cx="106340" cy="120249"/>
+            <a:off x="9336024" y="1911860"/>
+            <a:ext cx="106340" cy="110352"/>
           </a:xfrm>
           <a:prstGeom prst="rect">
             <a:avLst/>
@@ -11546,7 +11546,7 @@
         <p:spPr>
           <a:xfrm>
             <a:off x="10168128" y="1847088"/>
-            <a:ext cx="1234440" cy="261411"/>
+            <a:ext cx="1234440" cy="239896"/>
           </a:xfrm>
           <a:prstGeom prst="rect">
             <a:avLst/>
@@ -11584,8 +11584,8 @@
         </p:nvSpPr>
         <p:spPr>
           <a:xfrm>
-            <a:off x="6208776" y="2108499"/>
-            <a:ext cx="310896" cy="261411"/>
+            <a:off x="6208776" y="2086984"/>
+            <a:ext cx="310896" cy="239896"/>
           </a:xfrm>
           <a:prstGeom prst="rect">
             <a:avLst/>
@@ -11623,8 +11623,8 @@
         </p:nvSpPr>
         <p:spPr>
           <a:xfrm>
-            <a:off x="6565392" y="2108499"/>
-            <a:ext cx="1920240" cy="261411"/>
+            <a:off x="6565392" y="2086984"/>
+            <a:ext cx="1920240" cy="239896"/>
           </a:xfrm>
           <a:prstGeom prst="rect">
             <a:avLst/>
@@ -11662,8 +11662,8 @@
         </p:nvSpPr>
         <p:spPr>
           <a:xfrm>
-            <a:off x="9336024" y="2179080"/>
-            <a:ext cx="99982" cy="120249"/>
+            <a:off x="9336024" y="2151755"/>
+            <a:ext cx="99982" cy="110352"/>
           </a:xfrm>
           <a:prstGeom prst="rect">
             <a:avLst/>
@@ -11682,8 +11682,8 @@
         </p:nvSpPr>
         <p:spPr>
           <a:xfrm>
-            <a:off x="10168128" y="2108499"/>
-            <a:ext cx="1234440" cy="261411"/>
+            <a:off x="10168128" y="2086984"/>
+            <a:ext cx="1234440" cy="239896"/>
           </a:xfrm>
           <a:prstGeom prst="rect">
             <a:avLst/>
@@ -11721,8 +11721,8 @@
         </p:nvSpPr>
         <p:spPr>
           <a:xfrm>
-            <a:off x="6208776" y="2369910"/>
-            <a:ext cx="310896" cy="261411"/>
+            <a:off x="6208776" y="2326879"/>
+            <a:ext cx="310896" cy="239896"/>
           </a:xfrm>
           <a:prstGeom prst="rect">
             <a:avLst/>
@@ -11760,8 +11760,8 @@
         </p:nvSpPr>
         <p:spPr>
           <a:xfrm>
-            <a:off x="6565392" y="2369910"/>
-            <a:ext cx="1920240" cy="261411"/>
+            <a:off x="6565392" y="2326879"/>
+            <a:ext cx="1920240" cy="239896"/>
           </a:xfrm>
           <a:prstGeom prst="rect">
             <a:avLst/>
@@ -11799,8 +11799,8 @@
         </p:nvSpPr>
         <p:spPr>
           <a:xfrm>
-            <a:off x="9336024" y="2440491"/>
-            <a:ext cx="89045" cy="120249"/>
+            <a:off x="9336024" y="2391651"/>
+            <a:ext cx="89045" cy="110352"/>
           </a:xfrm>
           <a:prstGeom prst="rect">
             <a:avLst/>
@@ -11819,8 +11819,8 @@
         </p:nvSpPr>
         <p:spPr>
           <a:xfrm>
-            <a:off x="10168128" y="2369910"/>
-            <a:ext cx="1234440" cy="261411"/>
+            <a:off x="10168128" y="2326879"/>
+            <a:ext cx="1234440" cy="239896"/>
           </a:xfrm>
           <a:prstGeom prst="rect">
             <a:avLst/>
@@ -11858,8 +11858,8 @@
         </p:nvSpPr>
         <p:spPr>
           <a:xfrm>
-            <a:off x="6208776" y="2631320"/>
-            <a:ext cx="310896" cy="261411"/>
+            <a:off x="6208776" y="2566775"/>
+            <a:ext cx="310896" cy="239896"/>
           </a:xfrm>
           <a:prstGeom prst="rect">
             <a:avLst/>
@@ -11897,8 +11897,8 @@
         </p:nvSpPr>
         <p:spPr>
           <a:xfrm>
-            <a:off x="6565392" y="2631320"/>
-            <a:ext cx="1920240" cy="261411"/>
+            <a:off x="6565392" y="2566775"/>
+            <a:ext cx="1920240" cy="239896"/>
           </a:xfrm>
           <a:prstGeom prst="rect">
             <a:avLst/>
@@ -11936,8 +11936,8 @@
         </p:nvSpPr>
         <p:spPr>
           <a:xfrm>
-            <a:off x="9336024" y="2701901"/>
-            <a:ext cx="88806" cy="120249"/>
+            <a:off x="9336024" y="2631546"/>
+            <a:ext cx="88806" cy="110352"/>
           </a:xfrm>
           <a:prstGeom prst="rect">
             <a:avLst/>
@@ -11956,8 +11956,8 @@
         </p:nvSpPr>
         <p:spPr>
           <a:xfrm>
-            <a:off x="10168128" y="2631320"/>
-            <a:ext cx="1234440" cy="261411"/>
+            <a:off x="10168128" y="2566775"/>
+            <a:ext cx="1234440" cy="239896"/>
           </a:xfrm>
           <a:prstGeom prst="rect">
             <a:avLst/>
@@ -11995,8 +11995,8 @@
         </p:nvSpPr>
         <p:spPr>
           <a:xfrm>
-            <a:off x="6208776" y="2892731"/>
-            <a:ext cx="310896" cy="261411"/>
+            <a:off x="6208776" y="2806670"/>
+            <a:ext cx="310896" cy="239896"/>
           </a:xfrm>
           <a:prstGeom prst="rect">
             <a:avLst/>
@@ -12034,8 +12034,8 @@
         </p:nvSpPr>
         <p:spPr>
           <a:xfrm>
-            <a:off x="6565392" y="2892731"/>
-            <a:ext cx="1920240" cy="261411"/>
+            <a:off x="6565392" y="2806670"/>
+            <a:ext cx="1920240" cy="239896"/>
           </a:xfrm>
           <a:prstGeom prst="rect">
             <a:avLst/>
@@ -12073,8 +12073,8 @@
         </p:nvSpPr>
         <p:spPr>
           <a:xfrm>
-            <a:off x="9336024" y="2963312"/>
-            <a:ext cx="12802" cy="120249"/>
+            <a:off x="9336024" y="2871442"/>
+            <a:ext cx="12802" cy="110352"/>
           </a:xfrm>
           <a:prstGeom prst="rect">
             <a:avLst/>
@@ -12093,8 +12093,8 @@
         </p:nvSpPr>
         <p:spPr>
           <a:xfrm>
-            <a:off x="10168128" y="2892731"/>
-            <a:ext cx="1234440" cy="261411"/>
+            <a:off x="10168128" y="2806670"/>
+            <a:ext cx="1234440" cy="239896"/>
           </a:xfrm>
           <a:prstGeom prst="rect">
             <a:avLst/>
@@ -12132,8 +12132,8 @@
         </p:nvSpPr>
         <p:spPr>
           <a:xfrm>
-            <a:off x="6208776" y="3154142"/>
-            <a:ext cx="310896" cy="261411"/>
+            <a:off x="6208776" y="3046566"/>
+            <a:ext cx="310896" cy="239896"/>
           </a:xfrm>
           <a:prstGeom prst="rect">
             <a:avLst/>
@@ -12171,8 +12171,8 @@
         </p:nvSpPr>
         <p:spPr>
           <a:xfrm>
-            <a:off x="6565392" y="3154142"/>
-            <a:ext cx="1920240" cy="261411"/>
+            <a:off x="6565392" y="3046566"/>
+            <a:ext cx="1920240" cy="239896"/>
           </a:xfrm>
           <a:prstGeom prst="rect">
             <a:avLst/>
@@ -12210,8 +12210,8 @@
         </p:nvSpPr>
         <p:spPr>
           <a:xfrm>
-            <a:off x="9336024" y="3224723"/>
-            <a:ext cx="12802" cy="120249"/>
+            <a:off x="9336024" y="3111337"/>
+            <a:ext cx="12802" cy="110352"/>
           </a:xfrm>
           <a:prstGeom prst="rect">
             <a:avLst/>
@@ -12230,8 +12230,8 @@
         </p:nvSpPr>
         <p:spPr>
           <a:xfrm>
-            <a:off x="10168128" y="3154142"/>
-            <a:ext cx="1234440" cy="261411"/>
+            <a:off x="10168128" y="3046566"/>
+            <a:ext cx="1234440" cy="239896"/>
           </a:xfrm>
           <a:prstGeom prst="rect">
             <a:avLst/>
@@ -12269,8 +12269,8 @@
         </p:nvSpPr>
         <p:spPr>
           <a:xfrm>
-            <a:off x="6208776" y="3415553"/>
-            <a:ext cx="310896" cy="261411"/>
+            <a:off x="6208776" y="3286461"/>
+            <a:ext cx="310896" cy="239896"/>
           </a:xfrm>
           <a:prstGeom prst="rect">
             <a:avLst/>
@@ -12308,8 +12308,8 @@
         </p:nvSpPr>
         <p:spPr>
           <a:xfrm>
-            <a:off x="6565392" y="3415553"/>
-            <a:ext cx="1920240" cy="261411"/>
+            <a:off x="6565392" y="3286461"/>
+            <a:ext cx="1920240" cy="239896"/>
           </a:xfrm>
           <a:prstGeom prst="rect">
             <a:avLst/>
@@ -12347,8 +12347,8 @@
         </p:nvSpPr>
         <p:spPr>
           <a:xfrm>
-            <a:off x="9306237" y="3486134"/>
-            <a:ext cx="29787" cy="120249"/>
+            <a:off x="9306237" y="3351233"/>
+            <a:ext cx="29787" cy="110352"/>
           </a:xfrm>
           <a:prstGeom prst="rect">
             <a:avLst/>
@@ -12367,8 +12367,8 @@
         </p:nvSpPr>
         <p:spPr>
           <a:xfrm>
-            <a:off x="10168128" y="3415553"/>
-            <a:ext cx="1234440" cy="261411"/>
+            <a:off x="10168128" y="3286461"/>
+            <a:ext cx="1234440" cy="239896"/>
           </a:xfrm>
           <a:prstGeom prst="rect">
             <a:avLst/>
@@ -12406,8 +12406,8 @@
         </p:nvSpPr>
         <p:spPr>
           <a:xfrm>
-            <a:off x="6208776" y="3676964"/>
-            <a:ext cx="310896" cy="261411"/>
+            <a:off x="6208776" y="3526357"/>
+            <a:ext cx="310896" cy="239896"/>
           </a:xfrm>
           <a:prstGeom prst="rect">
             <a:avLst/>
@@ -12445,8 +12445,8 @@
         </p:nvSpPr>
         <p:spPr>
           <a:xfrm>
-            <a:off x="6565392" y="3676964"/>
-            <a:ext cx="1920240" cy="261411"/>
+            <a:off x="6565392" y="3526357"/>
+            <a:ext cx="1920240" cy="239896"/>
           </a:xfrm>
           <a:prstGeom prst="rect">
             <a:avLst/>
@@ -12484,8 +12484,8 @@
         </p:nvSpPr>
         <p:spPr>
           <a:xfrm>
-            <a:off x="9291402" y="3747545"/>
-            <a:ext cx="44622" cy="120249"/>
+            <a:off x="9291402" y="3591128"/>
+            <a:ext cx="44622" cy="110352"/>
           </a:xfrm>
           <a:prstGeom prst="rect">
             <a:avLst/>
@@ -12504,8 +12504,8 @@
         </p:nvSpPr>
         <p:spPr>
           <a:xfrm>
-            <a:off x="10168128" y="3676964"/>
-            <a:ext cx="1234440" cy="261411"/>
+            <a:off x="10168128" y="3526357"/>
+            <a:ext cx="1234440" cy="239896"/>
           </a:xfrm>
           <a:prstGeom prst="rect">
             <a:avLst/>
@@ -12543,8 +12543,8 @@
         </p:nvSpPr>
         <p:spPr>
           <a:xfrm>
-            <a:off x="6208776" y="3938375"/>
-            <a:ext cx="310896" cy="261411"/>
+            <a:off x="6208776" y="3766252"/>
+            <a:ext cx="310896" cy="239896"/>
           </a:xfrm>
           <a:prstGeom prst="rect">
             <a:avLst/>
@@ -12582,8 +12582,8 @@
         </p:nvSpPr>
         <p:spPr>
           <a:xfrm>
-            <a:off x="6565392" y="3938375"/>
-            <a:ext cx="1920240" cy="261411"/>
+            <a:off x="6565392" y="3766252"/>
+            <a:ext cx="1920240" cy="239896"/>
           </a:xfrm>
           <a:prstGeom prst="rect">
             <a:avLst/>
@@ -12621,8 +12621,8 @@
         </p:nvSpPr>
         <p:spPr>
           <a:xfrm>
-            <a:off x="9285327" y="4008956"/>
-            <a:ext cx="50697" cy="120249"/>
+            <a:off x="9285327" y="3831024"/>
+            <a:ext cx="50697" cy="110352"/>
           </a:xfrm>
           <a:prstGeom prst="rect">
             <a:avLst/>
@@ -12641,8 +12641,8 @@
         </p:nvSpPr>
         <p:spPr>
           <a:xfrm>
-            <a:off x="10168128" y="3938375"/>
-            <a:ext cx="1234440" cy="261411"/>
+            <a:off x="10168128" y="3766252"/>
+            <a:ext cx="1234440" cy="239896"/>
           </a:xfrm>
           <a:prstGeom prst="rect">
             <a:avLst/>
@@ -12680,8 +12680,8 @@
         </p:nvSpPr>
         <p:spPr>
           <a:xfrm>
-            <a:off x="6208776" y="4199785"/>
-            <a:ext cx="310896" cy="261411"/>
+            <a:off x="6208776" y="4006148"/>
+            <a:ext cx="310896" cy="239896"/>
           </a:xfrm>
           <a:prstGeom prst="rect">
             <a:avLst/>
@@ -12719,8 +12719,8 @@
         </p:nvSpPr>
         <p:spPr>
           <a:xfrm>
-            <a:off x="6565392" y="4199785"/>
-            <a:ext cx="1920240" cy="261411"/>
+            <a:off x="6565392" y="4006148"/>
+            <a:ext cx="1920240" cy="239896"/>
           </a:xfrm>
           <a:prstGeom prst="rect">
             <a:avLst/>
@@ -12758,8 +12758,8 @@
         </p:nvSpPr>
         <p:spPr>
           <a:xfrm>
-            <a:off x="9275488" y="4270366"/>
-            <a:ext cx="60536" cy="120249"/>
+            <a:off x="9275488" y="4070920"/>
+            <a:ext cx="60536" cy="110352"/>
           </a:xfrm>
           <a:prstGeom prst="rect">
             <a:avLst/>
@@ -12778,8 +12778,8 @@
         </p:nvSpPr>
         <p:spPr>
           <a:xfrm>
-            <a:off x="10168128" y="4199785"/>
-            <a:ext cx="1234440" cy="261411"/>
+            <a:off x="10168128" y="4006148"/>
+            <a:ext cx="1234440" cy="239896"/>
           </a:xfrm>
           <a:prstGeom prst="rect">
             <a:avLst/>
@@ -12817,8 +12817,8 @@
         </p:nvSpPr>
         <p:spPr>
           <a:xfrm>
-            <a:off x="6208776" y="4461196"/>
-            <a:ext cx="310896" cy="261411"/>
+            <a:off x="6208776" y="4246043"/>
+            <a:ext cx="310896" cy="239896"/>
           </a:xfrm>
           <a:prstGeom prst="rect">
             <a:avLst/>
@@ -12856,8 +12856,8 @@
         </p:nvSpPr>
         <p:spPr>
           <a:xfrm>
-            <a:off x="6565392" y="4461196"/>
-            <a:ext cx="1920240" cy="261411"/>
+            <a:off x="6565392" y="4246043"/>
+            <a:ext cx="1920240" cy="239896"/>
           </a:xfrm>
           <a:prstGeom prst="rect">
             <a:avLst/>
@@ -12895,8 +12895,8 @@
         </p:nvSpPr>
         <p:spPr>
           <a:xfrm>
-            <a:off x="9233370" y="4531777"/>
-            <a:ext cx="102654" cy="120249"/>
+            <a:off x="9233370" y="4310815"/>
+            <a:ext cx="102654" cy="110352"/>
           </a:xfrm>
           <a:prstGeom prst="rect">
             <a:avLst/>
@@ -12915,8 +12915,8 @@
         </p:nvSpPr>
         <p:spPr>
           <a:xfrm>
-            <a:off x="10168128" y="4461196"/>
-            <a:ext cx="1234440" cy="261411"/>
+            <a:off x="10168128" y="4246043"/>
+            <a:ext cx="1234440" cy="239896"/>
           </a:xfrm>
           <a:prstGeom prst="rect">
             <a:avLst/>
@@ -12954,8 +12954,8 @@
         </p:nvSpPr>
         <p:spPr>
           <a:xfrm>
-            <a:off x="6208776" y="4722607"/>
-            <a:ext cx="310896" cy="261411"/>
+            <a:off x="6208776" y="4485939"/>
+            <a:ext cx="310896" cy="239896"/>
           </a:xfrm>
           <a:prstGeom prst="rect">
             <a:avLst/>
@@ -12993,8 +12993,8 @@
         </p:nvSpPr>
         <p:spPr>
           <a:xfrm>
-            <a:off x="6565392" y="4722607"/>
-            <a:ext cx="1920240" cy="261411"/>
+            <a:off x="6565392" y="4485939"/>
+            <a:ext cx="1920240" cy="239896"/>
           </a:xfrm>
           <a:prstGeom prst="rect">
             <a:avLst/>
@@ -13032,8 +13032,8 @@
         </p:nvSpPr>
         <p:spPr>
           <a:xfrm>
-            <a:off x="9206595" y="4793188"/>
-            <a:ext cx="129429" cy="120249"/>
+            <a:off x="9206595" y="4550711"/>
+            <a:ext cx="129429" cy="110352"/>
           </a:xfrm>
           <a:prstGeom prst="rect">
             <a:avLst/>
@@ -13052,8 +13052,8 @@
         </p:nvSpPr>
         <p:spPr>
           <a:xfrm>
-            <a:off x="10168128" y="4722607"/>
-            <a:ext cx="1234440" cy="261411"/>
+            <a:off x="10168128" y="4485939"/>
+            <a:ext cx="1234440" cy="239896"/>
           </a:xfrm>
           <a:prstGeom prst="rect">
             <a:avLst/>
@@ -13091,8 +13091,8 @@
         </p:nvSpPr>
         <p:spPr>
           <a:xfrm>
-            <a:off x="6208776" y="4984018"/>
-            <a:ext cx="310896" cy="261411"/>
+            <a:off x="6208776" y="4725834"/>
+            <a:ext cx="310896" cy="239896"/>
           </a:xfrm>
           <a:prstGeom prst="rect">
             <a:avLst/>
@@ -13130,8 +13130,8 @@
         </p:nvSpPr>
         <p:spPr>
           <a:xfrm>
-            <a:off x="6565392" y="4984018"/>
-            <a:ext cx="1920240" cy="261411"/>
+            <a:off x="6565392" y="4725834"/>
+            <a:ext cx="1920240" cy="239896"/>
           </a:xfrm>
           <a:prstGeom prst="rect">
             <a:avLst/>
@@ -13169,8 +13169,8 @@
         </p:nvSpPr>
         <p:spPr>
           <a:xfrm>
-            <a:off x="9193818" y="5054599"/>
-            <a:ext cx="142206" cy="120249"/>
+            <a:off x="9193818" y="4790606"/>
+            <a:ext cx="142206" cy="110352"/>
           </a:xfrm>
           <a:prstGeom prst="rect">
             <a:avLst/>
@@ -13189,8 +13189,8 @@
         </p:nvSpPr>
         <p:spPr>
           <a:xfrm>
-            <a:off x="10168128" y="4984018"/>
-            <a:ext cx="1234440" cy="261411"/>
+            <a:off x="10168128" y="4725834"/>
+            <a:ext cx="1234440" cy="239896"/>
           </a:xfrm>
           <a:prstGeom prst="rect">
             <a:avLst/>
@@ -13228,8 +13228,8 @@
         </p:nvSpPr>
         <p:spPr>
           <a:xfrm>
-            <a:off x="6208776" y="5245429"/>
-            <a:ext cx="310896" cy="261411"/>
+            <a:off x="6208776" y="4965730"/>
+            <a:ext cx="310896" cy="239896"/>
           </a:xfrm>
           <a:prstGeom prst="rect">
             <a:avLst/>
@@ -13267,8 +13267,8 @@
         </p:nvSpPr>
         <p:spPr>
           <a:xfrm>
-            <a:off x="6565392" y="5245429"/>
-            <a:ext cx="1920240" cy="261411"/>
+            <a:off x="6565392" y="4965730"/>
+            <a:ext cx="1920240" cy="239896"/>
           </a:xfrm>
           <a:prstGeom prst="rect">
             <a:avLst/>
@@ -13306,8 +13306,8 @@
         </p:nvSpPr>
         <p:spPr>
           <a:xfrm>
-            <a:off x="9153034" y="5316010"/>
-            <a:ext cx="182990" cy="120249"/>
+            <a:off x="9153034" y="5030502"/>
+            <a:ext cx="182990" cy="110352"/>
           </a:xfrm>
           <a:prstGeom prst="rect">
             <a:avLst/>
@@ -13326,8 +13326,8 @@
         </p:nvSpPr>
         <p:spPr>
           <a:xfrm>
-            <a:off x="10168128" y="5245429"/>
-            <a:ext cx="1234440" cy="261411"/>
+            <a:off x="10168128" y="4965730"/>
+            <a:ext cx="1234440" cy="239896"/>
           </a:xfrm>
           <a:prstGeom prst="rect">
             <a:avLst/>
@@ -13365,8 +13365,8 @@
         </p:nvSpPr>
         <p:spPr>
           <a:xfrm>
-            <a:off x="6208776" y="5506840"/>
-            <a:ext cx="310896" cy="261411"/>
+            <a:off x="6208776" y="5205625"/>
+            <a:ext cx="310896" cy="239896"/>
           </a:xfrm>
           <a:prstGeom prst="rect">
             <a:avLst/>
@@ -13404,8 +13404,8 @@
         </p:nvSpPr>
         <p:spPr>
           <a:xfrm>
-            <a:off x="6565392" y="5506840"/>
-            <a:ext cx="1920240" cy="261411"/>
+            <a:off x="6565392" y="5205625"/>
+            <a:ext cx="1920240" cy="239896"/>
           </a:xfrm>
           <a:prstGeom prst="rect">
             <a:avLst/>
@@ -13443,8 +13443,8 @@
         </p:nvSpPr>
         <p:spPr>
           <a:xfrm>
-            <a:off x="9069849" y="5577420"/>
-            <a:ext cx="266175" cy="120249"/>
+            <a:off x="9069849" y="5270397"/>
+            <a:ext cx="266175" cy="110352"/>
           </a:xfrm>
           <a:prstGeom prst="rect">
             <a:avLst/>
@@ -13463,8 +13463,8 @@
         </p:nvSpPr>
         <p:spPr>
           <a:xfrm>
-            <a:off x="10168128" y="5506840"/>
-            <a:ext cx="1234440" cy="261411"/>
+            <a:off x="10168128" y="5205625"/>
+            <a:ext cx="1234440" cy="239896"/>
           </a:xfrm>
           <a:prstGeom prst="rect">
             <a:avLst/>
@@ -13502,8 +13502,8 @@
         </p:nvSpPr>
         <p:spPr>
           <a:xfrm>
-            <a:off x="6208776" y="5768250"/>
-            <a:ext cx="310896" cy="261411"/>
+            <a:off x="6208776" y="5445521"/>
+            <a:ext cx="310896" cy="239896"/>
           </a:xfrm>
           <a:prstGeom prst="rect">
             <a:avLst/>
@@ -13541,8 +13541,8 @@
         </p:nvSpPr>
         <p:spPr>
           <a:xfrm>
-            <a:off x="6565392" y="5768250"/>
-            <a:ext cx="1920240" cy="261411"/>
+            <a:off x="6565392" y="5445521"/>
+            <a:ext cx="1920240" cy="239896"/>
           </a:xfrm>
           <a:prstGeom prst="rect">
             <a:avLst/>
@@ -13580,8 +13580,8 @@
         </p:nvSpPr>
         <p:spPr>
           <a:xfrm>
-            <a:off x="8892903" y="5838831"/>
-            <a:ext cx="443121" cy="120249"/>
+            <a:off x="8892903" y="5510293"/>
+            <a:ext cx="443121" cy="110352"/>
           </a:xfrm>
           <a:prstGeom prst="rect">
             <a:avLst/>
@@ -13600,8 +13600,8 @@
         </p:nvSpPr>
         <p:spPr>
           <a:xfrm>
-            <a:off x="10168128" y="5768250"/>
-            <a:ext cx="1234440" cy="261411"/>
+            <a:off x="10168128" y="5445521"/>
+            <a:ext cx="1234440" cy="239896"/>
           </a:xfrm>
           <a:prstGeom prst="rect">
             <a:avLst/>
@@ -13640,7 +13640,7 @@
         <p:spPr>
           <a:xfrm>
             <a:off x="3780130" y="1847088"/>
-            <a:ext cx="10973" cy="4443984"/>
+            <a:ext cx="10973" cy="4078224"/>
           </a:xfrm>
           <a:prstGeom prst="rect">
             <a:avLst/>
@@ -13660,7 +13660,7 @@
         <p:spPr>
           <a:xfrm>
             <a:off x="9330538" y="1847088"/>
-            <a:ext cx="10973" cy="4443984"/>
+            <a:ext cx="10973" cy="4078224"/>
           </a:xfrm>
           <a:prstGeom prst="rect">
             <a:avLst/>
@@ -13680,7 +13680,7 @@
         <p:spPr>
           <a:xfrm>
             <a:off x="6085332" y="1847088"/>
-            <a:ext cx="10973" cy="4443984"/>
+            <a:ext cx="10973" cy="4078224"/>
           </a:xfrm>
           <a:prstGeom prst="rect">
             <a:avLst/>
@@ -13690,6 +13690,65 @@
           </a:solidFill>
           <a:ln/>
         </p:spPr>
+      </p:sp>
+      <p:sp>
+        <p:nvSpPr>
+          <p:cNvPr id="147" name="Shape 144"/>
+          <p:cNvSpPr/>
+          <p:nvPr/>
+        </p:nvSpPr>
+        <p:spPr>
+          <a:xfrm>
+            <a:off x="457200" y="6126480"/>
+            <a:ext cx="11274552" cy="371856"/>
+          </a:xfrm>
+          <a:prstGeom prst="rect">
+            <a:avLst/>
+          </a:prstGeom>
+          <a:solidFill>
+            <a:srgbClr val="E6F6EE"/>
+          </a:solidFill>
+          <a:ln/>
+        </p:spPr>
+      </p:sp>
+      <p:sp>
+        <p:nvSpPr>
+          <p:cNvPr id="148" name="Text 145"/>
+          <p:cNvSpPr txBox="1"/>
+          <p:nvPr/>
+        </p:nvSpPr>
+        <p:spPr>
+          <a:xfrm>
+            <a:off x="658368" y="6144768"/>
+            <a:ext cx="10927080" cy="335280"/>
+          </a:xfrm>
+          <a:prstGeom prst="rect">
+            <a:avLst/>
+          </a:prstGeom>
+          <a:noFill/>
+          <a:ln/>
+        </p:spPr>
+        <p:txBody>
+          <a:bodyPr wrap="square" lIns="0" tIns="0" rIns="0" bIns="0" rtlCol="0" anchor="ctr"/>
+          <a:lstStyle/>
+          <a:p>
+            <a:pPr indent="0" marL="0">
+              <a:buNone/>
+            </a:pPr>
+            <a:r>
+              <a:rPr lang="en-US" sz="1600" b="1" dirty="0">
+                <a:solidFill>
+                  <a:srgbClr val="0B7A4A"/>
+                </a:solidFill>
+                <a:latin typeface="Inter" pitchFamily="34" charset="0"/>
+                <a:ea typeface="Inter" pitchFamily="34" charset="-122"/>
+                <a:cs typeface="Inter" pitchFamily="34" charset="-120"/>
+              </a:rPr>
+              <a:t>23 of 33 stores sold more CP hours. 10 declined.</a:t>
+            </a:r>
+            <a:endParaRPr lang="en-US" sz="1600" dirty="0"/>
+          </a:p>
+        </p:txBody>
       </p:sp>
     </p:spTree>
   </p:cSld>

</xml_diff>